<commit_message>
Strengthen M4 prototype and final system
</commit_message>
<xml_diff>
--- a/slides/MSBA_Job_Matching_Final_Deck.pptx
+++ b/slides/MSBA_Job_Matching_Final_Deck.pptx
@@ -2,22 +2,22 @@
 <file path=ppt/presentation.xml><?xml version="1.0" encoding="utf-8"?>
 <p:presentation xmlns:p="http://schemas.openxmlformats.org/presentationml/2006/main">
   <p:sldMasterIdLst>
-    <p:sldMasterId xmlns:r="http://schemas.openxmlformats.org/officeDocument/2006/relationships" id="2147483648" r:id="Rfe61e62c61564d39"/>
+    <p:sldMasterId xmlns:r="http://schemas.openxmlformats.org/officeDocument/2006/relationships" id="2147483648" r:id="R426dd2163800473c"/>
   </p:sldMasterIdLst>
   <p:notesMasterIdLst>
-    <p:notesMasterId xmlns:r="http://schemas.openxmlformats.org/officeDocument/2006/relationships" r:id="Re664bdd73ffb4b31"/>
+    <p:notesMasterId xmlns:r="http://schemas.openxmlformats.org/officeDocument/2006/relationships" r:id="R778a614ee15c434e"/>
   </p:notesMasterIdLst>
   <p:sldIdLst>
-    <p:sldId xmlns:r="http://schemas.openxmlformats.org/officeDocument/2006/relationships" id="256" r:id="Rb6114862d5944e23"/>
-    <p:sldId xmlns:r="http://schemas.openxmlformats.org/officeDocument/2006/relationships" id="257" r:id="R7f150b21d2884d5e"/>
-    <p:sldId xmlns:r="http://schemas.openxmlformats.org/officeDocument/2006/relationships" id="258" r:id="R77a35891b6bd4e9d"/>
-    <p:sldId xmlns:r="http://schemas.openxmlformats.org/officeDocument/2006/relationships" id="259" r:id="R49461acf4ab147d2"/>
-    <p:sldId xmlns:r="http://schemas.openxmlformats.org/officeDocument/2006/relationships" id="260" r:id="R2421cd19f2b44bd4"/>
-    <p:sldId xmlns:r="http://schemas.openxmlformats.org/officeDocument/2006/relationships" id="261" r:id="R627376258dfa47c8"/>
-    <p:sldId xmlns:r="http://schemas.openxmlformats.org/officeDocument/2006/relationships" id="262" r:id="R7dd13f82bb01436a"/>
-    <p:sldId xmlns:r="http://schemas.openxmlformats.org/officeDocument/2006/relationships" id="263" r:id="R3e9ef5d3a1534e6c"/>
-    <p:sldId xmlns:r="http://schemas.openxmlformats.org/officeDocument/2006/relationships" id="264" r:id="Rcbae63be145a480f"/>
-    <p:sldId xmlns:r="http://schemas.openxmlformats.org/officeDocument/2006/relationships" id="265" r:id="R7cf0c34635164b0f"/>
+    <p:sldId xmlns:r="http://schemas.openxmlformats.org/officeDocument/2006/relationships" id="256" r:id="Raec8c631347148ae"/>
+    <p:sldId xmlns:r="http://schemas.openxmlformats.org/officeDocument/2006/relationships" id="257" r:id="Rcd37af2a91794b18"/>
+    <p:sldId xmlns:r="http://schemas.openxmlformats.org/officeDocument/2006/relationships" id="258" r:id="R8581dd4a25f54ea3"/>
+    <p:sldId xmlns:r="http://schemas.openxmlformats.org/officeDocument/2006/relationships" id="259" r:id="R7095fdfa9ea74f85"/>
+    <p:sldId xmlns:r="http://schemas.openxmlformats.org/officeDocument/2006/relationships" id="260" r:id="Rcbe4ac8379c04f6d"/>
+    <p:sldId xmlns:r="http://schemas.openxmlformats.org/officeDocument/2006/relationships" id="261" r:id="R808b1d78f01a444e"/>
+    <p:sldId xmlns:r="http://schemas.openxmlformats.org/officeDocument/2006/relationships" id="262" r:id="R2638dd6c44cc4c2b"/>
+    <p:sldId xmlns:r="http://schemas.openxmlformats.org/officeDocument/2006/relationships" id="263" r:id="R83644fdaa1ab44c1"/>
+    <p:sldId xmlns:r="http://schemas.openxmlformats.org/officeDocument/2006/relationships" id="264" r:id="R51ff0ca316264ed3"/>
+    <p:sldId xmlns:r="http://schemas.openxmlformats.org/officeDocument/2006/relationships" id="265" r:id="Raa67aa4fff0f42cf"/>
   </p:sldIdLst>
   <p:sldSz cx="12192000" cy="6858000"/>
   <p:notesSz cx="6858000" cy="9144000"/>
@@ -546,7 +546,7 @@
           <a:lstStyle xmlns:a="http://schemas.openxmlformats.org/drawingml/2006/main"/>
           <a:p xmlns:a="http://schemas.openxmlformats.org/drawingml/2006/main">
             <a:r>
-              <a:t>Close with the business recommendation: a limited, measured pilot. The next proof point is workflow value with human-reviewed data, not a larger model by itself.</a:t>
+              <a:t>Close with the data decision. The public weak-label corpus is already sufficient for this model family. The next investment should create a small but trustworthy human and authorization benchmark, then measure workflow value in a controlled pilot.</a:t>
             </a:r>
           </a:p>
           <a:p xmlns:a="http://schemas.openxmlformats.org/drawingml/2006/main">
@@ -741,7 +741,7 @@
           <a:lstStyle xmlns:a="http://schemas.openxmlformats.org/drawingml/2006/main"/>
           <a:p xmlns:a="http://schemas.openxmlformats.org/drawingml/2006/main">
             <a:r>
-              <a:t>Describe the original source, the 100,000-row stratified sample, and the 80/20 split. State clearly that labels are rule-derived weak labels.</a:t>
+              <a:t>The public role-fit corpus is already large. The next useful data investment is advisor-reviewed labels and real authorization text, not more weak labels.</a:t>
             </a:r>
           </a:p>
           <a:p xmlns:a="http://schemas.openxmlformats.org/drawingml/2006/main">
@@ -761,7 +761,7 @@
           </a:p>
           <a:p xmlns:a="http://schemas.openxmlformats.org/drawingml/2006/main">
             <a:r>
-              <a:t>- outputs/milestone2_baseline_results.json</a:t>
+              <a:t>- models/job_fit_tfidf_svc_metrics.json</a:t>
             </a:r>
           </a:p>
           <a:p xmlns:a="http://schemas.openxmlformats.org/drawingml/2006/main">
@@ -836,7 +836,7 @@
           <a:lstStyle xmlns:a="http://schemas.openxmlformats.org/drawingml/2006/main"/>
           <a:p xmlns:a="http://schemas.openxmlformats.org/drawingml/2006/main">
             <a:r>
-              <a:t>Use this slide to show that the final system is the accumulation of measured representation, adaptation, retrieval, and product work.</a:t>
+              <a:t>M3 established that adaptation helps. M4 then tested a wider model and data choice and found that a lightweight linear model trained on the full split is both stronger and easier to ship.</a:t>
             </a:r>
           </a:p>
           <a:p xmlns:a="http://schemas.openxmlformats.org/drawingml/2006/main">
@@ -861,7 +861,7 @@
           </a:p>
           <a:p xmlns:a="http://schemas.openxmlformats.org/drawingml/2006/main">
             <a:r>
-              <a:t>- outputs/milestone4_prototype_results.json</a:t>
+              <a:t>- outputs/final_model_comparison.json</a:t>
             </a:r>
           </a:p>
           <a:p xmlns:a="http://schemas.openxmlformats.org/drawingml/2006/main">
@@ -936,7 +936,7 @@
           <a:lstStyle xmlns:a="http://schemas.openxmlformats.org/drawingml/2006/main"/>
           <a:p xmlns:a="http://schemas.openxmlformats.org/drawingml/2006/main">
             <a:r>
-              <a:t>Walk left to right. The architecture uses lexical retrieval for speed and transparency, then a deterministic response template to preserve grounding.</a:t>
+              <a:t>Walk left to right. The mode router prevents a search sentence from being misclassified as a posting. The policy layer then handles missing fields and authorization independently from role fit.</a:t>
             </a:r>
           </a:p>
           <a:p xmlns:a="http://schemas.openxmlformats.org/drawingml/2006/main">
@@ -1031,7 +1031,7 @@
           <a:lstStyle xmlns:a="http://schemas.openxmlformats.org/drawingml/2006/main"/>
           <a:p xmlns:a="http://schemas.openxmlformats.org/drawingml/2006/main">
             <a:r>
-              <a:t>Explain one real run. Point to the title, company, location, label, and retrieval score. The advisor can inspect why each posting was surfaced.</a:t>
+              <a:t>Explain that this is retrieval, not posting classification. The result list is filtered and reranked by explicit query constraints, then each retrieved posting receives a model label.</a:t>
             </a:r>
           </a:p>
           <a:p xmlns:a="http://schemas.openxmlformats.org/drawingml/2006/main">
@@ -1046,7 +1046,7 @@
           </a:p>
           <a:p xmlns:a="http://schemas.openxmlformats.org/drawingml/2006/main">
             <a:r>
-              <a:t>- outputs/final_casebook_outputs.json - entry_level_analytics</a:t>
+              <a:t>- outputs/final_casebook_outputs.json - entry_level_analytics_search</a:t>
             </a:r>
           </a:p>
           <a:p xmlns:a="http://schemas.openxmlformats.org/drawingml/2006/main">
@@ -1121,7 +1121,7 @@
           <a:lstStyle xmlns:a="http://schemas.openxmlformats.org/drawingml/2006/main"/>
           <a:p xmlns:a="http://schemas.openxmlformats.org/drawingml/2006/main">
             <a:r>
-              <a:t>Contrast the four saved runs. The authorization case found a posting title that explicitly says No OPT/CPT; the system surfaces that phrase but still requires verification.</a:t>
+              <a:t>Contrast the four saved runs. The key case is a high-fit analyst role that explicitly says No OPT/CPT. The policy layer forces Hold, proving that authorization cannot be hidden by a strong fit score.</a:t>
             </a:r>
           </a:p>
           <a:p xmlns:a="http://schemas.openxmlformats.org/drawingml/2006/main">
@@ -1216,7 +1216,7 @@
           <a:lstStyle xmlns:a="http://schemas.openxmlformats.org/drawingml/2006/main"/>
           <a:p xmlns:a="http://schemas.openxmlformats.org/drawingml/2006/main">
             <a:r>
-              <a:t>Be candid about the tradeoff. LoRA is the strongest pure classifier. The final prototype is selected because it adds retrieval evidence, a reproducible interface, and governance controls.</a:t>
+              <a:t>The final model uses all available training labels and outperforms the 2,000-row LoRA experiment. The lesson is not that linear models always win; it is that data utilization and reproducibility matter for this structured weak-label task.</a:t>
             </a:r>
           </a:p>
           <a:p xmlns:a="http://schemas.openxmlformats.org/drawingml/2006/main">
@@ -1246,7 +1246,7 @@
           </a:p>
           <a:p xmlns:a="http://schemas.openxmlformats.org/drawingml/2006/main">
             <a:r>
-              <a:t>- outputs/milestone4_prototype_results.json</a:t>
+              <a:t>- models/job_fit_tfidf_svc_metrics.json</a:t>
             </a:r>
           </a:p>
           <a:p xmlns:a="http://schemas.openxmlformats.org/drawingml/2006/main">
@@ -1321,7 +1321,7 @@
           <a:lstStyle xmlns:a="http://schemas.openxmlformats.org/drawingml/2006/main"/>
           <a:p xmlns:a="http://schemas.openxmlformats.org/drawingml/2006/main">
             <a:r>
-              <a:t>Translate the confusion matrix into product policy. Conservative errors can hide viable opportunities, so ambiguous labels must remain reviewable.</a:t>
+              <a:t>The model now makes only 65 errors on the fixed weak-label set. That shifts the project question: the next bottleneck is whether the labels represent advisor judgment. Stronger claims require a human-reviewed external test.</a:t>
             </a:r>
           </a:p>
           <a:p xmlns:a="http://schemas.openxmlformats.org/drawingml/2006/main">
@@ -1336,7 +1336,12 @@
           </a:p>
           <a:p xmlns:a="http://schemas.openxmlformats.org/drawingml/2006/main">
             <a:r>
-              <a:t>- outputs/milestone4_prototype_results.json</a:t>
+              <a:t>- outputs/final_evaluation_results.json</a:t>
+            </a:r>
+          </a:p>
+          <a:p xmlns:a="http://schemas.openxmlformats.org/drawingml/2006/main">
+            <a:r>
+              <a:t>- models/job_fit_tfidf_svc_metrics.json</a:t>
             </a:r>
           </a:p>
           <a:p xmlns:a="http://schemas.openxmlformats.org/drawingml/2006/main">
@@ -1414,7 +1419,7 @@
   </p:cSld>
   <p:clrMap bg1="lt1" tx1="dk1" bg2="lt2" tx2="dk2" accent1="accent1" accent2="accent2" accent3="accent3" accent4="accent4" accent5="accent5" accent6="accent6" hlink="hlink" folHlink="folHlink"/>
   <p:sldLayoutIdLst>
-    <p:sldLayoutId xmlns:r="http://schemas.openxmlformats.org/officeDocument/2006/relationships" id="2147483649" r:id="Rb03a4af74e8b4b79"/>
+    <p:sldLayoutId xmlns:r="http://schemas.openxmlformats.org/officeDocument/2006/relationships" id="2147483649" r:id="R8247c833d5be4be2"/>
   </p:sldLayoutIdLst>
   <p:txStyles>
     <p:titleStyle>
@@ -1965,13 +1970,13 @@
             <c:strLit>
               <c:ptCount val="3"/>
               <c:pt idx="0">
-                <c:v>M2 TF-IDF</c:v>
+                <c:v>M2 baseline</c:v>
               </c:pt>
               <c:pt idx="1">
                 <c:v>M3 PEFT LoRA</c:v>
               </c:pt>
               <c:pt idx="2">
-                <c:v>Final system</c:v>
+                <c:v>Final classifier</c:v>
               </c:pt>
             </c:strLit>
           </c:cat>
@@ -1986,7 +1991,7 @@
                 <c:v>87.5</c:v>
               </c:pt>
               <c:pt idx="2">
-                <c:v>80</c:v>
+                <c:v>98.4</c:v>
               </c:pt>
             </c:numLit>
           </c:val>
@@ -2006,13 +2011,13 @@
             <c:strLit>
               <c:ptCount val="3"/>
               <c:pt idx="0">
-                <c:v>M2 TF-IDF</c:v>
+                <c:v>M2 baseline</c:v>
               </c:pt>
               <c:pt idx="1">
                 <c:v>M3 PEFT LoRA</c:v>
               </c:pt>
               <c:pt idx="2">
-                <c:v>Final system</c:v>
+                <c:v>Final classifier</c:v>
               </c:pt>
             </c:strLit>
           </c:cat>
@@ -2027,7 +2032,7 @@
                 <c:v>87.3</c:v>
               </c:pt>
               <c:pt idx="2">
-                <c:v>80.1</c:v>
+                <c:v>98.4</c:v>
               </c:pt>
             </c:numLit>
           </c:val>
@@ -2187,7 +2192,7 @@
           <p:cNvPr id="7" name="">
             <a:extLst xmlns:a="http://schemas.openxmlformats.org/drawingml/2006/main">
               <a:ext uri="{FF2B5EF4-FFF2-40B4-BE49-F238E27FC236}">
-                <a16:creationId xmlns:a16="http://schemas.microsoft.com/office/drawing/2014/main" id="{B644F501-8138-4605-A09E-3C852CBB6550}"/>
+                <a16:creationId xmlns:a16="http://schemas.microsoft.com/office/drawing/2014/main" id="{9DC31D60-4011-45F6-85DF-99F7443E3FFF}"/>
               </a:ext>
             </a:extLst>
           </p:cNvPr>
@@ -2237,7 +2242,7 @@
           <p:cNvPr id="2" name="">
             <a:extLst xmlns:a="http://schemas.openxmlformats.org/drawingml/2006/main">
               <a:ext uri="{FF2B5EF4-FFF2-40B4-BE49-F238E27FC236}">
-                <a16:creationId xmlns:a16="http://schemas.microsoft.com/office/drawing/2014/main" id="{46FDE106-81C4-4751-966C-992C0B2908C8}"/>
+                <a16:creationId xmlns:a16="http://schemas.microsoft.com/office/drawing/2014/main" id="{23018A5B-F8A9-42B3-ABD1-B5645D3E6CB4}"/>
               </a:ext>
             </a:extLst>
           </p:cNvPr>
@@ -2287,7 +2292,7 @@
           <p:cNvPr id="3" name="">
             <a:extLst xmlns:a="http://schemas.openxmlformats.org/drawingml/2006/main">
               <a:ext uri="{FF2B5EF4-FFF2-40B4-BE49-F238E27FC236}">
-                <a16:creationId xmlns:a16="http://schemas.microsoft.com/office/drawing/2014/main" id="{724A623D-7848-43BD-97CD-92E1196327A9}"/>
+                <a16:creationId xmlns:a16="http://schemas.microsoft.com/office/drawing/2014/main" id="{04E06395-BA38-4777-9BA2-F02A597439DD}"/>
               </a:ext>
             </a:extLst>
           </p:cNvPr>
@@ -2337,7 +2342,7 @@
           <p:cNvPr id="4" name="">
             <a:extLst xmlns:a="http://schemas.openxmlformats.org/drawingml/2006/main">
               <a:ext uri="{FF2B5EF4-FFF2-40B4-BE49-F238E27FC236}">
-                <a16:creationId xmlns:a16="http://schemas.microsoft.com/office/drawing/2014/main" id="{CB6D915E-2AED-4943-89AF-4073917E0EF5}"/>
+                <a16:creationId xmlns:a16="http://schemas.microsoft.com/office/drawing/2014/main" id="{A288C72F-2A13-46F6-98E1-4949F8F6DA54}"/>
               </a:ext>
             </a:extLst>
           </p:cNvPr>
@@ -2387,7 +2392,7 @@
           <p:cNvPr id="5" name="">
             <a:extLst xmlns:a="http://schemas.openxmlformats.org/drawingml/2006/main">
               <a:ext uri="{FF2B5EF4-FFF2-40B4-BE49-F238E27FC236}">
-                <a16:creationId xmlns:a16="http://schemas.microsoft.com/office/drawing/2014/main" id="{F98813D5-A98A-4832-8078-E1457F1F6E64}"/>
+                <a16:creationId xmlns:a16="http://schemas.microsoft.com/office/drawing/2014/main" id="{962048DD-E9B1-490A-8153-CB4741F9B1D0}"/>
               </a:ext>
             </a:extLst>
           </p:cNvPr>
@@ -2437,7 +2442,7 @@
           <p:cNvPr id="6" name="">
             <a:extLst xmlns:a="http://schemas.openxmlformats.org/drawingml/2006/main">
               <a:ext uri="{FF2B5EF4-FFF2-40B4-BE49-F238E27FC236}">
-                <a16:creationId xmlns:a16="http://schemas.microsoft.com/office/drawing/2014/main" id="{13011F02-A577-4C50-88BE-294BD8783E06}"/>
+                <a16:creationId xmlns:a16="http://schemas.microsoft.com/office/drawing/2014/main" id="{0D43C68E-39F0-4D4C-9E42-61D7B641709E}"/>
               </a:ext>
             </a:extLst>
           </p:cNvPr>
@@ -2485,7 +2490,7 @@
     </p:spTree>
     <p:extLst>
       <p:ext uri="{BB962C8B-B14F-4D97-AF65-F5344CB8AC3E}">
-        <p14:creationId xmlns:p14="http://schemas.microsoft.com/office/powerpoint/2010/main" val="795920411"/>
+        <p14:creationId xmlns:p14="http://schemas.microsoft.com/office/powerpoint/2010/main" val="796392753"/>
       </p:ext>
     </p:extLst>
   </p:cSld>
@@ -2513,10 +2518,10 @@
       </p:grpSpPr>
       <p:sp>
         <p:nvSpPr>
-          <p:cNvPr id="8" name="">
-            <a:extLst xmlns:a="http://schemas.openxmlformats.org/drawingml/2006/main">
-              <a:ext uri="{FF2B5EF4-FFF2-40B4-BE49-F238E27FC236}">
-                <a16:creationId xmlns:a16="http://schemas.microsoft.com/office/drawing/2014/main" id="{0F2AB1AE-DE1E-472D-B981-BD1B011073EB}"/>
+          <p:cNvPr id="10" name="">
+            <a:extLst xmlns:a="http://schemas.openxmlformats.org/drawingml/2006/main">
+              <a:ext uri="{FF2B5EF4-FFF2-40B4-BE49-F238E27FC236}">
+                <a16:creationId xmlns:a16="http://schemas.microsoft.com/office/drawing/2014/main" id="{026F1594-0BC3-4A23-9E78-D8D2364C44CF}"/>
               </a:ext>
             </a:extLst>
           </p:cNvPr>
@@ -2566,7 +2571,7 @@
           <p:cNvPr id="2" name="">
             <a:extLst xmlns:a="http://schemas.openxmlformats.org/drawingml/2006/main">
               <a:ext uri="{FF2B5EF4-FFF2-40B4-BE49-F238E27FC236}">
-                <a16:creationId xmlns:a16="http://schemas.microsoft.com/office/drawing/2014/main" id="{FBB55E3F-92C3-4CE0-877B-CA4B83035114}"/>
+                <a16:creationId xmlns:a16="http://schemas.microsoft.com/office/drawing/2014/main" id="{F6B2D2CB-096D-4555-9C7C-D6B7E46EBA32}"/>
               </a:ext>
             </a:extLst>
           </p:cNvPr>
@@ -2578,7 +2583,7 @@
         <p:spPr>
           <a:xfrm xmlns:a="http://schemas.openxmlformats.org/drawingml/2006/main">
             <a:off x="400050" y="1619250"/>
-            <a:ext cx="10096500" cy="1809750"/>
+            <a:ext cx="10477500" cy="1809750"/>
           </a:xfrm>
           <a:prstGeom xmlns:a="http://schemas.openxmlformats.org/drawingml/2006/main" prst="rect">
             <a:avLst/>
@@ -2606,14 +2611,14 @@
                   <a:srgbClr val="111111"/>
                 </a:solidFill>
               </a:rPr>
-              <a:t>Pilot as decision support, then earn the right to automate more</a:t>
+              <a:t>Stop adding weak labels; start collecting decision-grade evidence</a:t>
             </a:r>
           </a:p>
         </p:txBody>
       </p:sp>
       <p:cxnSp>
         <p:nvCxnSpPr>
-          <p:cNvPr id="10" name=""/>
+          <p:cNvPr id="12" name=""/>
           <p:cNvCxnSpPr/>
           <p:nvPr/>
         </p:nvCxnSpPr>
@@ -2638,7 +2643,7 @@
           <p:cNvPr id="4" name="">
             <a:extLst xmlns:a="http://schemas.openxmlformats.org/drawingml/2006/main">
               <a:ext uri="{FF2B5EF4-FFF2-40B4-BE49-F238E27FC236}">
-                <a16:creationId xmlns:a16="http://schemas.microsoft.com/office/drawing/2014/main" id="{B9F1A21F-DD58-4EBA-966B-6BAA50BFF4F7}"/>
+                <a16:creationId xmlns:a16="http://schemas.microsoft.com/office/drawing/2014/main" id="{D7A90EA0-AF44-4807-95E6-296D5C765895}"/>
               </a:ext>
             </a:extLst>
           </p:cNvPr>
@@ -2688,7 +2693,7 @@
           <p:cNvPr id="5" name="">
             <a:extLst xmlns:a="http://schemas.openxmlformats.org/drawingml/2006/main">
               <a:ext uri="{FF2B5EF4-FFF2-40B4-BE49-F238E27FC236}">
-                <a16:creationId xmlns:a16="http://schemas.microsoft.com/office/drawing/2014/main" id="{2DDD6490-A087-4BBB-BBE3-FA3AED2F5139}"/>
+                <a16:creationId xmlns:a16="http://schemas.microsoft.com/office/drawing/2014/main" id="{B5C2DE0B-41A5-433A-9EE8-1276649FDAE4}"/>
               </a:ext>
             </a:extLst>
           </p:cNvPr>
@@ -2700,30 +2705,30 @@
         <p:spPr>
           <a:xfrm xmlns:a="http://schemas.openxmlformats.org/drawingml/2006/main">
             <a:off x="400050" y="4857750"/>
-            <a:ext cx="4095750" cy="1200150"/>
-          </a:xfrm>
-          <a:prstGeom xmlns:a="http://schemas.openxmlformats.org/drawingml/2006/main" prst="rect">
-            <a:avLst/>
-          </a:prstGeom>
-          <a:noFill xmlns:a="http://schemas.openxmlformats.org/drawingml/2006/main"/>
-          <a:ln xmlns:a="http://schemas.openxmlformats.org/drawingml/2006/main" w="0">
-            <a:noFill/>
-            <a:prstDash val="solid"/>
-          </a:ln>
-        </p:spPr>
-        <p:txBody>
-          <a:bodyPr xmlns:a="http://schemas.openxmlformats.org/drawingml/2006/main" anchor="t"/>
-          <a:lstStyle xmlns:a="http://schemas.openxmlformats.org/drawingml/2006/main"/>
-          <a:p xmlns:a="http://schemas.openxmlformats.org/drawingml/2006/main">
-            <a:pPr algn="l">
-              <a:defRPr sz="1875" b="0">
-                <a:solidFill>
-                  <a:srgbClr val="111111"/>
-                </a:solidFill>
-              </a:defRPr>
-            </a:pPr>
-            <a:r>
-              <a:rPr sz="1875" b="0">
+            <a:ext cx="4000500" cy="1257300"/>
+          </a:xfrm>
+          <a:prstGeom xmlns:a="http://schemas.openxmlformats.org/drawingml/2006/main" prst="rect">
+            <a:avLst/>
+          </a:prstGeom>
+          <a:noFill xmlns:a="http://schemas.openxmlformats.org/drawingml/2006/main"/>
+          <a:ln xmlns:a="http://schemas.openxmlformats.org/drawingml/2006/main" w="0">
+            <a:noFill/>
+            <a:prstDash val="solid"/>
+          </a:ln>
+        </p:spPr>
+        <p:txBody>
+          <a:bodyPr xmlns:a="http://schemas.openxmlformats.org/drawingml/2006/main" anchor="t"/>
+          <a:lstStyle xmlns:a="http://schemas.openxmlformats.org/drawingml/2006/main"/>
+          <a:p xmlns:a="http://schemas.openxmlformats.org/drawingml/2006/main">
+            <a:pPr algn="l">
+              <a:defRPr sz="1725" b="0">
+                <a:solidFill>
+                  <a:srgbClr val="111111"/>
+                </a:solidFill>
+              </a:defRPr>
+            </a:pPr>
+            <a:r>
+              <a:rPr sz="1725" b="0">
                 <a:solidFill>
                   <a:srgbClr val="111111"/>
                 </a:solidFill>
@@ -2733,14 +2738,14 @@
           </a:p>
           <a:p xmlns:a="http://schemas.openxmlformats.org/drawingml/2006/main">
             <a:pPr algn="l">
-              <a:defRPr sz="1875" b="0">
-                <a:solidFill>
-                  <a:srgbClr val="111111"/>
-                </a:solidFill>
-              </a:defRPr>
-            </a:pPr>
-            <a:r>
-              <a:rPr sz="1875" b="0">
+              <a:defRPr sz="1725" b="0">
+                <a:solidFill>
+                  <a:srgbClr val="111111"/>
+                </a:solidFill>
+              </a:defRPr>
+            </a:pPr>
+            <a:r>
+              <a:rPr sz="1725" b="0">
                 <a:solidFill>
                   <a:srgbClr val="111111"/>
                 </a:solidFill>
@@ -2750,14 +2755,14 @@
           </a:p>
           <a:p xmlns:a="http://schemas.openxmlformats.org/drawingml/2006/main">
             <a:pPr algn="l">
-              <a:defRPr sz="1875" b="0">
-                <a:solidFill>
-                  <a:srgbClr val="111111"/>
-                </a:solidFill>
-              </a:defRPr>
-            </a:pPr>
-            <a:r>
-              <a:rPr sz="1875" b="0">
+              <a:defRPr sz="1725" b="0">
+                <a:solidFill>
+                  <a:srgbClr val="111111"/>
+                </a:solidFill>
+              </a:defRPr>
+            </a:pPr>
+            <a:r>
+              <a:rPr sz="1725" b="0">
                 <a:solidFill>
                   <a:srgbClr val="111111"/>
                 </a:solidFill>
@@ -2767,14 +2772,14 @@
           </a:p>
           <a:p xmlns:a="http://schemas.openxmlformats.org/drawingml/2006/main">
             <a:pPr algn="l">
-              <a:defRPr sz="1875" b="0">
-                <a:solidFill>
-                  <a:srgbClr val="111111"/>
-                </a:solidFill>
-              </a:defRPr>
-            </a:pPr>
-            <a:r>
-              <a:rPr sz="1875" b="0">
+              <a:defRPr sz="1725" b="0">
+                <a:solidFill>
+                  <a:srgbClr val="111111"/>
+                </a:solidFill>
+              </a:defRPr>
+            </a:pPr>
+            <a:r>
+              <a:rPr sz="1725" b="0">
                 <a:solidFill>
                   <a:srgbClr val="111111"/>
                 </a:solidFill>
@@ -2789,57 +2794,155 @@
           <p:cNvPr id="6" name="">
             <a:extLst xmlns:a="http://schemas.openxmlformats.org/drawingml/2006/main">
               <a:ext uri="{FF2B5EF4-FFF2-40B4-BE49-F238E27FC236}">
-                <a16:creationId xmlns:a16="http://schemas.microsoft.com/office/drawing/2014/main" id="{52322B82-4310-4DEA-9707-8B04E6DF96C9}"/>
-              </a:ext>
-            </a:extLst>
-          </p:cNvPr>
-          <p:cNvSpPr>
-            <a:spLocks xmlns:a="http://schemas.openxmlformats.org/drawingml/2006/main" noGrp="1"/>
-          </p:cNvSpPr>
-          <p:nvPr/>
-        </p:nvSpPr>
-        <p:spPr>
-          <a:xfrm xmlns:a="http://schemas.openxmlformats.org/drawingml/2006/main">
-            <a:off x="5715000" y="4857750"/>
-            <a:ext cx="5524500" cy="762000"/>
-          </a:xfrm>
-          <a:prstGeom xmlns:a="http://schemas.openxmlformats.org/drawingml/2006/main" prst="rect">
-            <a:avLst/>
-          </a:prstGeom>
-          <a:noFill xmlns:a="http://schemas.openxmlformats.org/drawingml/2006/main"/>
-          <a:ln xmlns:a="http://schemas.openxmlformats.org/drawingml/2006/main" w="0">
-            <a:noFill/>
-            <a:prstDash val="solid"/>
-          </a:ln>
-        </p:spPr>
-        <p:txBody>
-          <a:bodyPr xmlns:a="http://schemas.openxmlformats.org/drawingml/2006/main" anchor="t"/>
-          <a:lstStyle xmlns:a="http://schemas.openxmlformats.org/drawingml/2006/main"/>
-          <a:p xmlns:a="http://schemas.openxmlformats.org/drawingml/2006/main">
-            <a:pPr algn="l">
-              <a:defRPr sz="2250" b="1">
-                <a:solidFill>
-                  <a:srgbClr val="111111"/>
-                </a:solidFill>
-              </a:defRPr>
-            </a:pPr>
-            <a:r>
-              <a:rPr sz="2250" b="1">
-                <a:solidFill>
-                  <a:srgbClr val="111111"/>
-                </a:solidFill>
-              </a:rPr>
-              <a:t>Use de-identified Career Center postings and human-reviewed labels.</a:t>
-            </a:r>
-          </a:p>
-        </p:txBody>
+                <a16:creationId xmlns:a16="http://schemas.microsoft.com/office/drawing/2014/main" id="{26129291-14C8-4CE3-ABCE-E9A1EA9220DE}"/>
+              </a:ext>
+            </a:extLst>
+          </p:cNvPr>
+          <p:cNvSpPr>
+            <a:spLocks xmlns:a="http://schemas.openxmlformats.org/drawingml/2006/main" noGrp="1"/>
+          </p:cNvSpPr>
+          <p:nvPr/>
+        </p:nvSpPr>
+        <p:spPr>
+          <a:xfrm xmlns:a="http://schemas.openxmlformats.org/drawingml/2006/main">
+            <a:off x="5334000" y="4686300"/>
+            <a:ext cx="19050" cy="1333500"/>
+          </a:xfrm>
+          <a:prstGeom xmlns:a="http://schemas.openxmlformats.org/drawingml/2006/main" prst="rect">
+            <a:avLst/>
+          </a:prstGeom>
+          <a:solidFill xmlns:a="http://schemas.openxmlformats.org/drawingml/2006/main">
+            <a:srgbClr val="B8BCC4"/>
+          </a:solidFill>
+          <a:ln xmlns:a="http://schemas.openxmlformats.org/drawingml/2006/main" w="0">
+            <a:noFill/>
+            <a:prstDash val="solid"/>
+          </a:ln>
+        </p:spPr>
       </p:sp>
       <p:sp>
         <p:nvSpPr>
           <p:cNvPr id="7" name="">
             <a:extLst xmlns:a="http://schemas.openxmlformats.org/drawingml/2006/main">
               <a:ext uri="{FF2B5EF4-FFF2-40B4-BE49-F238E27FC236}">
-                <a16:creationId xmlns:a16="http://schemas.microsoft.com/office/drawing/2014/main" id="{3ECBE274-10DA-4DE3-9A3E-0C0891984A8B}"/>
+                <a16:creationId xmlns:a16="http://schemas.microsoft.com/office/drawing/2014/main" id="{1E23261A-1A31-4059-9D88-DC8DFBA96D8E}"/>
+              </a:ext>
+            </a:extLst>
+          </p:cNvPr>
+          <p:cNvSpPr>
+            <a:spLocks xmlns:a="http://schemas.openxmlformats.org/drawingml/2006/main" noGrp="1"/>
+          </p:cNvSpPr>
+          <p:nvPr/>
+        </p:nvSpPr>
+        <p:spPr>
+          <a:xfrm xmlns:a="http://schemas.openxmlformats.org/drawingml/2006/main">
+            <a:off x="5905500" y="4362450"/>
+            <a:ext cx="4000500" cy="323850"/>
+          </a:xfrm>
+          <a:prstGeom xmlns:a="http://schemas.openxmlformats.org/drawingml/2006/main" prst="rect">
+            <a:avLst/>
+          </a:prstGeom>
+          <a:noFill xmlns:a="http://schemas.openxmlformats.org/drawingml/2006/main"/>
+          <a:ln xmlns:a="http://schemas.openxmlformats.org/drawingml/2006/main" w="0">
+            <a:noFill/>
+            <a:prstDash val="solid"/>
+          </a:ln>
+        </p:spPr>
+        <p:txBody>
+          <a:bodyPr xmlns:a="http://schemas.openxmlformats.org/drawingml/2006/main" anchor="t"/>
+          <a:lstStyle xmlns:a="http://schemas.openxmlformats.org/drawingml/2006/main"/>
+          <a:p xmlns:a="http://schemas.openxmlformats.org/drawingml/2006/main">
+            <a:pPr algn="l">
+              <a:defRPr sz="1575" b="1">
+                <a:solidFill>
+                  <a:srgbClr val="D6532F"/>
+                </a:solidFill>
+              </a:defRPr>
+            </a:pPr>
+            <a:r>
+              <a:rPr sz="1575" b="1">
+                <a:solidFill>
+                  <a:srgbClr val="D6532F"/>
+                </a:solidFill>
+              </a:rPr>
+              <a:t>DATA TO COLLECT</a:t>
+            </a:r>
+          </a:p>
+        </p:txBody>
+      </p:sp>
+      <p:sp>
+        <p:nvSpPr>
+          <p:cNvPr id="8" name="">
+            <a:extLst xmlns:a="http://schemas.openxmlformats.org/drawingml/2006/main">
+              <a:ext uri="{FF2B5EF4-FFF2-40B4-BE49-F238E27FC236}">
+                <a16:creationId xmlns:a16="http://schemas.microsoft.com/office/drawing/2014/main" id="{4BCF5EE9-22E0-45FE-8B54-946494997132}"/>
+              </a:ext>
+            </a:extLst>
+          </p:cNvPr>
+          <p:cNvSpPr>
+            <a:spLocks xmlns:a="http://schemas.openxmlformats.org/drawingml/2006/main" noGrp="1"/>
+          </p:cNvSpPr>
+          <p:nvPr/>
+        </p:nvSpPr>
+        <p:spPr>
+          <a:xfrm xmlns:a="http://schemas.openxmlformats.org/drawingml/2006/main">
+            <a:off x="5905500" y="4857750"/>
+            <a:ext cx="5143500" cy="1104900"/>
+          </a:xfrm>
+          <a:prstGeom xmlns:a="http://schemas.openxmlformats.org/drawingml/2006/main" prst="rect">
+            <a:avLst/>
+          </a:prstGeom>
+          <a:noFill xmlns:a="http://schemas.openxmlformats.org/drawingml/2006/main"/>
+          <a:ln xmlns:a="http://schemas.openxmlformats.org/drawingml/2006/main" w="0">
+            <a:noFill/>
+            <a:prstDash val="solid"/>
+          </a:ln>
+        </p:spPr>
+        <p:txBody>
+          <a:bodyPr xmlns:a="http://schemas.openxmlformats.org/drawingml/2006/main" anchor="t"/>
+          <a:lstStyle xmlns:a="http://schemas.openxmlformats.org/drawingml/2006/main"/>
+          <a:p xmlns:a="http://schemas.openxmlformats.org/drawingml/2006/main">
+            <a:pPr algn="l">
+              <a:defRPr sz="2025" b="1">
+                <a:solidFill>
+                  <a:srgbClr val="111111"/>
+                </a:solidFill>
+              </a:defRPr>
+            </a:pPr>
+            <a:r>
+              <a:rPr sz="2025" b="1">
+                <a:solidFill>
+                  <a:srgbClr val="111111"/>
+                </a:solidFill>
+              </a:rPr>
+              <a:t>500-1,000 advisor-reviewed postings</a:t>
+            </a:r>
+          </a:p>
+          <a:p xmlns:a="http://schemas.openxmlformats.org/drawingml/2006/main">
+            <a:pPr algn="l">
+              <a:defRPr sz="2025" b="1">
+                <a:solidFill>
+                  <a:srgbClr val="111111"/>
+                </a:solidFill>
+              </a:defRPr>
+            </a:pPr>
+            <a:r>
+              <a:rPr sz="2025" b="1">
+                <a:solidFill>
+                  <a:srgbClr val="111111"/>
+                </a:solidFill>
+              </a:rPr>
+              <a:t>Hundreds of real authorization examples</a:t>
+            </a:r>
+          </a:p>
+        </p:txBody>
+      </p:sp>
+      <p:sp>
+        <p:nvSpPr>
+          <p:cNvPr id="9" name="">
+            <a:extLst xmlns:a="http://schemas.openxmlformats.org/drawingml/2006/main">
+              <a:ext uri="{FF2B5EF4-FFF2-40B4-BE49-F238E27FC236}">
+                <a16:creationId xmlns:a16="http://schemas.microsoft.com/office/drawing/2014/main" id="{97D53C07-C1FC-4AC1-BAC3-79900E1F1CBE}"/>
               </a:ext>
             </a:extLst>
           </p:cNvPr>
@@ -2887,7 +2990,7 @@
     </p:spTree>
     <p:extLst>
       <p:ext uri="{BB962C8B-B14F-4D97-AF65-F5344CB8AC3E}">
-        <p14:creationId xmlns:p14="http://schemas.microsoft.com/office/powerpoint/2010/main" val="1845480119"/>
+        <p14:creationId xmlns:p14="http://schemas.microsoft.com/office/powerpoint/2010/main" val="357762828"/>
       </p:ext>
     </p:extLst>
   </p:cSld>
@@ -2918,7 +3021,7 @@
           <p:cNvPr id="14" name="slide-2-title">
             <a:extLst xmlns:a="http://schemas.openxmlformats.org/drawingml/2006/main">
               <a:ext uri="{FF2B5EF4-FFF2-40B4-BE49-F238E27FC236}">
-                <a16:creationId xmlns:a16="http://schemas.microsoft.com/office/drawing/2014/main" id="{DA43F47E-A85D-4942-82CB-F89AF2094BB6}"/>
+                <a16:creationId xmlns:a16="http://schemas.microsoft.com/office/drawing/2014/main" id="{803D02D9-B0AB-4841-97BA-E2ECED6B4067}"/>
               </a:ext>
             </a:extLst>
           </p:cNvPr>
@@ -2968,7 +3071,7 @@
           <p:cNvPr id="2" name="">
             <a:extLst xmlns:a="http://schemas.openxmlformats.org/drawingml/2006/main">
               <a:ext uri="{FF2B5EF4-FFF2-40B4-BE49-F238E27FC236}">
-                <a16:creationId xmlns:a16="http://schemas.microsoft.com/office/drawing/2014/main" id="{5B1F5B45-2182-4F12-95A0-6FB609EC073C}"/>
+                <a16:creationId xmlns:a16="http://schemas.microsoft.com/office/drawing/2014/main" id="{66FE5575-9705-4B78-9FCF-59E7819588FE}"/>
               </a:ext>
             </a:extLst>
           </p:cNvPr>
@@ -3018,7 +3121,7 @@
           <p:cNvPr id="3" name="">
             <a:extLst xmlns:a="http://schemas.openxmlformats.org/drawingml/2006/main">
               <a:ext uri="{FF2B5EF4-FFF2-40B4-BE49-F238E27FC236}">
-                <a16:creationId xmlns:a16="http://schemas.microsoft.com/office/drawing/2014/main" id="{41D2403A-3FCE-435E-B1D9-7A7C849FB1B9}"/>
+                <a16:creationId xmlns:a16="http://schemas.microsoft.com/office/drawing/2014/main" id="{76A31D44-3EB1-4E57-9018-6896B727B6BC}"/>
               </a:ext>
             </a:extLst>
           </p:cNvPr>
@@ -3090,7 +3193,7 @@
           <p:cNvPr id="5" name="">
             <a:extLst xmlns:a="http://schemas.openxmlformats.org/drawingml/2006/main">
               <a:ext uri="{FF2B5EF4-FFF2-40B4-BE49-F238E27FC236}">
-                <a16:creationId xmlns:a16="http://schemas.microsoft.com/office/drawing/2014/main" id="{A41A2E9F-FAB4-4DE9-9976-268BDA7C859D}"/>
+                <a16:creationId xmlns:a16="http://schemas.microsoft.com/office/drawing/2014/main" id="{F2E2F199-096C-4418-B80E-604116B07D0B}"/>
               </a:ext>
             </a:extLst>
           </p:cNvPr>
@@ -3140,7 +3243,7 @@
           <p:cNvPr id="6" name="">
             <a:extLst xmlns:a="http://schemas.openxmlformats.org/drawingml/2006/main">
               <a:ext uri="{FF2B5EF4-FFF2-40B4-BE49-F238E27FC236}">
-                <a16:creationId xmlns:a16="http://schemas.microsoft.com/office/drawing/2014/main" id="{F2A5B2CB-C7D6-4EA7-A0A3-46ED0ED1E272}"/>
+                <a16:creationId xmlns:a16="http://schemas.microsoft.com/office/drawing/2014/main" id="{3288611C-16F8-4F86-8833-1727DC6E2EBB}"/>
               </a:ext>
             </a:extLst>
           </p:cNvPr>
@@ -3212,7 +3315,7 @@
           <p:cNvPr id="8" name="">
             <a:extLst xmlns:a="http://schemas.openxmlformats.org/drawingml/2006/main">
               <a:ext uri="{FF2B5EF4-FFF2-40B4-BE49-F238E27FC236}">
-                <a16:creationId xmlns:a16="http://schemas.microsoft.com/office/drawing/2014/main" id="{4B9BBECF-E65F-4783-8249-25BEC43628CD}"/>
+                <a16:creationId xmlns:a16="http://schemas.microsoft.com/office/drawing/2014/main" id="{DCB45849-2D03-4729-86F1-B9195DD40FF4}"/>
               </a:ext>
             </a:extLst>
           </p:cNvPr>
@@ -3262,7 +3365,7 @@
           <p:cNvPr id="9" name="">
             <a:extLst xmlns:a="http://schemas.openxmlformats.org/drawingml/2006/main">
               <a:ext uri="{FF2B5EF4-FFF2-40B4-BE49-F238E27FC236}">
-                <a16:creationId xmlns:a16="http://schemas.microsoft.com/office/drawing/2014/main" id="{7C17F46E-F2C6-44E8-962A-121A3084BE84}"/>
+                <a16:creationId xmlns:a16="http://schemas.microsoft.com/office/drawing/2014/main" id="{33B172D6-5126-4275-9517-DB91AA43C206}"/>
               </a:ext>
             </a:extLst>
           </p:cNvPr>
@@ -3334,7 +3437,7 @@
           <p:cNvPr id="11" name="">
             <a:extLst xmlns:a="http://schemas.openxmlformats.org/drawingml/2006/main">
               <a:ext uri="{FF2B5EF4-FFF2-40B4-BE49-F238E27FC236}">
-                <a16:creationId xmlns:a16="http://schemas.microsoft.com/office/drawing/2014/main" id="{E9979B25-ADBD-4781-9647-BDA1A00E9B40}"/>
+                <a16:creationId xmlns:a16="http://schemas.microsoft.com/office/drawing/2014/main" id="{7D458293-A22C-4CB6-A052-C37D08B7CF94}"/>
               </a:ext>
             </a:extLst>
           </p:cNvPr>
@@ -3384,7 +3487,7 @@
           <p:cNvPr id="12" name="">
             <a:extLst xmlns:a="http://schemas.openxmlformats.org/drawingml/2006/main">
               <a:ext uri="{FF2B5EF4-FFF2-40B4-BE49-F238E27FC236}">
-                <a16:creationId xmlns:a16="http://schemas.microsoft.com/office/drawing/2014/main" id="{4ED42E0B-44A8-4470-B604-B8E014D8622D}"/>
+                <a16:creationId xmlns:a16="http://schemas.microsoft.com/office/drawing/2014/main" id="{711DA8E1-724B-4D89-AC91-FDE07DAEDC11}"/>
               </a:ext>
             </a:extLst>
           </p:cNvPr>
@@ -3434,7 +3537,7 @@
           <p:cNvPr id="13" name="">
             <a:extLst xmlns:a="http://schemas.openxmlformats.org/drawingml/2006/main">
               <a:ext uri="{FF2B5EF4-FFF2-40B4-BE49-F238E27FC236}">
-                <a16:creationId xmlns:a16="http://schemas.microsoft.com/office/drawing/2014/main" id="{3EE68274-624D-4253-AEC5-24F3B15058CC}"/>
+                <a16:creationId xmlns:a16="http://schemas.microsoft.com/office/drawing/2014/main" id="{A962E14F-83A5-4591-8ABF-A6842F8EE094}"/>
               </a:ext>
             </a:extLst>
           </p:cNvPr>
@@ -3482,7 +3585,7 @@
     </p:spTree>
     <p:extLst>
       <p:ext uri="{BB962C8B-B14F-4D97-AF65-F5344CB8AC3E}">
-        <p14:creationId xmlns:p14="http://schemas.microsoft.com/office/powerpoint/2010/main" val="1189001603"/>
+        <p14:creationId xmlns:p14="http://schemas.microsoft.com/office/powerpoint/2010/main" val="579797811"/>
       </p:ext>
     </p:extLst>
   </p:cSld>
@@ -3513,7 +3616,7 @@
           <p:cNvPr id="16" name="slide-3-title">
             <a:extLst xmlns:a="http://schemas.openxmlformats.org/drawingml/2006/main">
               <a:ext uri="{FF2B5EF4-FFF2-40B4-BE49-F238E27FC236}">
-                <a16:creationId xmlns:a16="http://schemas.microsoft.com/office/drawing/2014/main" id="{65FD6EAE-C58A-4556-97AA-A41F3A9AD961}"/>
+                <a16:creationId xmlns:a16="http://schemas.microsoft.com/office/drawing/2014/main" id="{D8DADEC7-78D1-4D74-81DD-8BC2459EEE30}"/>
               </a:ext>
             </a:extLst>
           </p:cNvPr>
@@ -3553,7 +3656,7 @@
                   <a:srgbClr val="111111"/>
                 </a:solidFill>
               </a:rPr>
-              <a:t>The data is large, real, and reproducibly sampled</a:t>
+              <a:t>Label quality, not data volume, is the bottleneck</a:t>
             </a:r>
           </a:p>
         </p:txBody>
@@ -3563,7 +3666,7 @@
           <p:cNvPr id="2" name="">
             <a:extLst xmlns:a="http://schemas.openxmlformats.org/drawingml/2006/main">
               <a:ext uri="{FF2B5EF4-FFF2-40B4-BE49-F238E27FC236}">
-                <a16:creationId xmlns:a16="http://schemas.microsoft.com/office/drawing/2014/main" id="{D60F434A-455E-4908-A960-2E2B4A7897A5}"/>
+                <a16:creationId xmlns:a16="http://schemas.microsoft.com/office/drawing/2014/main" id="{8B199D36-F792-42C9-9D64-5C3BBFA5F3EA}"/>
               </a:ext>
             </a:extLst>
           </p:cNvPr>
@@ -3603,7 +3706,7 @@
                   <a:srgbClr val="565D67"/>
                 </a:solidFill>
               </a:rPr>
-              <a:t>Transparent weak labels make experimentation feasible, but not equivalent to human ground truth.</a:t>
+              <a:t>The final model uses the full training split after exact-text deduplication.</a:t>
             </a:r>
           </a:p>
         </p:txBody>
@@ -3613,7 +3716,7 @@
           <p:cNvPr id="3" name="">
             <a:extLst xmlns:a="http://schemas.openxmlformats.org/drawingml/2006/main">
               <a:ext uri="{FF2B5EF4-FFF2-40B4-BE49-F238E27FC236}">
-                <a16:creationId xmlns:a16="http://schemas.microsoft.com/office/drawing/2014/main" id="{C2279B76-B32D-4415-B564-0890E1139869}"/>
+                <a16:creationId xmlns:a16="http://schemas.microsoft.com/office/drawing/2014/main" id="{E381016F-A5AC-42CC-9828-04A5BB871C77}"/>
               </a:ext>
             </a:extLst>
           </p:cNvPr>
@@ -3663,7 +3766,7 @@
           <p:cNvPr id="4" name="">
             <a:extLst xmlns:a="http://schemas.openxmlformats.org/drawingml/2006/main">
               <a:ext uri="{FF2B5EF4-FFF2-40B4-BE49-F238E27FC236}">
-                <a16:creationId xmlns:a16="http://schemas.microsoft.com/office/drawing/2014/main" id="{3DAC07AB-F37B-4B18-875A-EAB63ED60464}"/>
+                <a16:creationId xmlns:a16="http://schemas.microsoft.com/office/drawing/2014/main" id="{798AAA7D-F908-429C-A6DF-E5DC678FE2F0}"/>
               </a:ext>
             </a:extLst>
           </p:cNvPr>
@@ -3694,7 +3797,7 @@
           <p:cNvPr id="5" name="">
             <a:extLst xmlns:a="http://schemas.openxmlformats.org/drawingml/2006/main">
               <a:ext uri="{FF2B5EF4-FFF2-40B4-BE49-F238E27FC236}">
-                <a16:creationId xmlns:a16="http://schemas.microsoft.com/office/drawing/2014/main" id="{D7B86A9E-2360-4E56-BB50-C2A7651D4460}"/>
+                <a16:creationId xmlns:a16="http://schemas.microsoft.com/office/drawing/2014/main" id="{8329F03A-DE97-4FEB-89F6-82D248CE936C}"/>
               </a:ext>
             </a:extLst>
           </p:cNvPr>
@@ -3744,7 +3847,7 @@
           <p:cNvPr id="6" name="">
             <a:extLst xmlns:a="http://schemas.openxmlformats.org/drawingml/2006/main">
               <a:ext uri="{FF2B5EF4-FFF2-40B4-BE49-F238E27FC236}">
-                <a16:creationId xmlns:a16="http://schemas.microsoft.com/office/drawing/2014/main" id="{9C9C15AF-AC43-4EDB-836A-01BAA06298F2}"/>
+                <a16:creationId xmlns:a16="http://schemas.microsoft.com/office/drawing/2014/main" id="{619F4CCB-463A-4C96-913A-E3EDCBB6EE93}"/>
               </a:ext>
             </a:extLst>
           </p:cNvPr>
@@ -3794,7 +3897,7 @@
           <p:cNvPr id="7" name="">
             <a:extLst xmlns:a="http://schemas.openxmlformats.org/drawingml/2006/main">
               <a:ext uri="{FF2B5EF4-FFF2-40B4-BE49-F238E27FC236}">
-                <a16:creationId xmlns:a16="http://schemas.microsoft.com/office/drawing/2014/main" id="{DFE1B8DE-4BE5-43BC-8B84-A9B009330ED8}"/>
+                <a16:creationId xmlns:a16="http://schemas.microsoft.com/office/drawing/2014/main" id="{3D18398B-664C-4941-8374-131522D5FA5A}"/>
               </a:ext>
             </a:extLst>
           </p:cNvPr>
@@ -3825,7 +3928,7 @@
           <p:cNvPr id="8" name="">
             <a:extLst xmlns:a="http://schemas.openxmlformats.org/drawingml/2006/main">
               <a:ext uri="{FF2B5EF4-FFF2-40B4-BE49-F238E27FC236}">
-                <a16:creationId xmlns:a16="http://schemas.microsoft.com/office/drawing/2014/main" id="{2D2BE9F8-B5EF-4795-976E-BE087A33DF5A}"/>
+                <a16:creationId xmlns:a16="http://schemas.microsoft.com/office/drawing/2014/main" id="{9ABAAB57-0F6F-4C37-A0D2-C827095FEEB7}"/>
               </a:ext>
             </a:extLst>
           </p:cNvPr>
@@ -3875,7 +3978,7 @@
           <p:cNvPr id="9" name="">
             <a:extLst xmlns:a="http://schemas.openxmlformats.org/drawingml/2006/main">
               <a:ext uri="{FF2B5EF4-FFF2-40B4-BE49-F238E27FC236}">
-                <a16:creationId xmlns:a16="http://schemas.microsoft.com/office/drawing/2014/main" id="{F9E302BD-6F26-45BC-BBCD-6FF7AAF7D9B8}"/>
+                <a16:creationId xmlns:a16="http://schemas.microsoft.com/office/drawing/2014/main" id="{02C8A2FE-74B3-4C10-9065-CB3B83B5E764}"/>
               </a:ext>
             </a:extLst>
           </p:cNvPr>
@@ -3925,7 +4028,7 @@
           <p:cNvPr id="10" name="">
             <a:extLst xmlns:a="http://schemas.openxmlformats.org/drawingml/2006/main">
               <a:ext uri="{FF2B5EF4-FFF2-40B4-BE49-F238E27FC236}">
-                <a16:creationId xmlns:a16="http://schemas.microsoft.com/office/drawing/2014/main" id="{CE26CB4D-2124-440D-825F-76D1F5F26240}"/>
+                <a16:creationId xmlns:a16="http://schemas.microsoft.com/office/drawing/2014/main" id="{0653D70C-6194-4749-A14C-8C12F958B703}"/>
               </a:ext>
             </a:extLst>
           </p:cNvPr>
@@ -3956,7 +4059,7 @@
           <p:cNvPr id="11" name="">
             <a:extLst xmlns:a="http://schemas.openxmlformats.org/drawingml/2006/main">
               <a:ext uri="{FF2B5EF4-FFF2-40B4-BE49-F238E27FC236}">
-                <a16:creationId xmlns:a16="http://schemas.microsoft.com/office/drawing/2014/main" id="{834DDBBE-A514-4848-9C53-B86DD0121AB9}"/>
+                <a16:creationId xmlns:a16="http://schemas.microsoft.com/office/drawing/2014/main" id="{998D2632-6C85-418D-827F-28C4539D1A78}"/>
               </a:ext>
             </a:extLst>
           </p:cNvPr>
@@ -3996,7 +4099,7 @@
                   <a:srgbClr val="D6532F"/>
                 </a:solidFill>
               </a:rPr>
-              <a:t>80k / 20k</a:t>
+              <a:t>77,135</a:t>
             </a:r>
           </a:p>
         </p:txBody>
@@ -4006,7 +4109,7 @@
           <p:cNvPr id="12" name="">
             <a:extLst xmlns:a="http://schemas.openxmlformats.org/drawingml/2006/main">
               <a:ext uri="{FF2B5EF4-FFF2-40B4-BE49-F238E27FC236}">
-                <a16:creationId xmlns:a16="http://schemas.microsoft.com/office/drawing/2014/main" id="{DE16A8FD-44A3-4BE3-ACDB-2FD6A78C5323}"/>
+                <a16:creationId xmlns:a16="http://schemas.microsoft.com/office/drawing/2014/main" id="{AD1BF058-D9E2-47A1-9A58-B237AF565579}"/>
               </a:ext>
             </a:extLst>
           </p:cNvPr>
@@ -4046,7 +4149,7 @@
                   <a:srgbClr val="111111"/>
                 </a:solidFill>
               </a:rPr>
-              <a:t>training and held-out validation</a:t>
+              <a:t>deduplicated training rows</a:t>
             </a:r>
           </a:p>
         </p:txBody>
@@ -4056,7 +4159,7 @@
           <p:cNvPr id="13" name="">
             <a:extLst xmlns:a="http://schemas.openxmlformats.org/drawingml/2006/main">
               <a:ext uri="{FF2B5EF4-FFF2-40B4-BE49-F238E27FC236}">
-                <a16:creationId xmlns:a16="http://schemas.microsoft.com/office/drawing/2014/main" id="{7C56BA86-6C0B-4A28-9872-BE96F067C43E}"/>
+                <a16:creationId xmlns:a16="http://schemas.microsoft.com/office/drawing/2014/main" id="{FBEFCD2D-A7DD-42D6-AD7F-7F206F6348E4}"/>
               </a:ext>
             </a:extLst>
           </p:cNvPr>
@@ -4087,7 +4190,7 @@
           <p:cNvPr id="14" name="">
             <a:extLst xmlns:a="http://schemas.openxmlformats.org/drawingml/2006/main">
               <a:ext uri="{FF2B5EF4-FFF2-40B4-BE49-F238E27FC236}">
-                <a16:creationId xmlns:a16="http://schemas.microsoft.com/office/drawing/2014/main" id="{50FF3A74-3FCD-4E82-A85A-F3FD9E0211B9}"/>
+                <a16:creationId xmlns:a16="http://schemas.microsoft.com/office/drawing/2014/main" id="{FD035DD1-CE19-4A67-953F-7FA57DCC73A9}"/>
               </a:ext>
             </a:extLst>
           </p:cNvPr>
@@ -4117,17 +4220,17 @@
             <a:pPr algn="l">
               <a:defRPr sz="4350" b="1">
                 <a:solidFill>
-                  <a:srgbClr val="3D8DFF"/>
+                  <a:srgbClr val="D6532F"/>
                 </a:solidFill>
               </a:defRPr>
             </a:pPr>
             <a:r>
               <a:rPr sz="4350" b="1">
                 <a:solidFill>
-                  <a:srgbClr val="3D8DFF"/>
-                </a:solidFill>
-              </a:rPr>
-              <a:t>4</a:t>
+                  <a:srgbClr val="D6532F"/>
+                </a:solidFill>
+              </a:rPr>
+              <a:t>0</a:t>
             </a:r>
           </a:p>
         </p:txBody>
@@ -4137,7 +4240,7 @@
           <p:cNvPr id="15" name="">
             <a:extLst xmlns:a="http://schemas.openxmlformats.org/drawingml/2006/main">
               <a:ext uri="{FF2B5EF4-FFF2-40B4-BE49-F238E27FC236}">
-                <a16:creationId xmlns:a16="http://schemas.microsoft.com/office/drawing/2014/main" id="{34D95281-BAE8-43A2-AFD3-407647BD1492}"/>
+                <a16:creationId xmlns:a16="http://schemas.microsoft.com/office/drawing/2014/main" id="{D19116C7-1ADD-4460-8EF3-A935379F06A1}"/>
               </a:ext>
             </a:extLst>
           </p:cNvPr>
@@ -4177,7 +4280,7 @@
                   <a:srgbClr val="111111"/>
                 </a:solidFill>
               </a:rPr>
-              <a:t>balanced role-fit labels</a:t>
+              <a:t>representative authorization labels</a:t>
             </a:r>
           </a:p>
         </p:txBody>
@@ -4185,7 +4288,7 @@
     </p:spTree>
     <p:extLst>
       <p:ext uri="{BB962C8B-B14F-4D97-AF65-F5344CB8AC3E}">
-        <p14:creationId xmlns:p14="http://schemas.microsoft.com/office/powerpoint/2010/main" val="218192073"/>
+        <p14:creationId xmlns:p14="http://schemas.microsoft.com/office/powerpoint/2010/main" val="1935748604"/>
       </p:ext>
     </p:extLst>
   </p:cSld>
@@ -4216,7 +4319,7 @@
           <p:cNvPr id="20" name="slide-4-title">
             <a:extLst xmlns:a="http://schemas.openxmlformats.org/drawingml/2006/main">
               <a:ext uri="{FF2B5EF4-FFF2-40B4-BE49-F238E27FC236}">
-                <a16:creationId xmlns:a16="http://schemas.microsoft.com/office/drawing/2014/main" id="{EEA47DC4-BDE7-473D-A50C-2FC8A1710246}"/>
+                <a16:creationId xmlns:a16="http://schemas.microsoft.com/office/drawing/2014/main" id="{04BEAD27-9725-40DE-B0A7-4F19A37AC7C1}"/>
               </a:ext>
             </a:extLst>
           </p:cNvPr>
@@ -4256,7 +4359,7 @@
                   <a:srgbClr val="111111"/>
                 </a:solidFill>
               </a:rPr>
-              <a:t>Each milestone added a measured capability</a:t>
+              <a:t>Each milestone changed the final technical decision</a:t>
             </a:r>
           </a:p>
         </p:txBody>
@@ -4266,7 +4369,7 @@
           <p:cNvPr id="2" name="">
             <a:extLst xmlns:a="http://schemas.openxmlformats.org/drawingml/2006/main">
               <a:ext uri="{FF2B5EF4-FFF2-40B4-BE49-F238E27FC236}">
-                <a16:creationId xmlns:a16="http://schemas.microsoft.com/office/drawing/2014/main" id="{28DFD0FD-C605-4198-B9D0-46925F8015A9}"/>
+                <a16:creationId xmlns:a16="http://schemas.microsoft.com/office/drawing/2014/main" id="{419F1004-6EDF-488B-B7D9-DCCEB97E0A42}"/>
               </a:ext>
             </a:extLst>
           </p:cNvPr>
@@ -4338,7 +4441,7 @@
           <p:cNvPr id="4" name="">
             <a:extLst xmlns:a="http://schemas.openxmlformats.org/drawingml/2006/main">
               <a:ext uri="{FF2B5EF4-FFF2-40B4-BE49-F238E27FC236}">
-                <a16:creationId xmlns:a16="http://schemas.microsoft.com/office/drawing/2014/main" id="{C06A4564-DB90-45AC-83EC-9678C2201630}"/>
+                <a16:creationId xmlns:a16="http://schemas.microsoft.com/office/drawing/2014/main" id="{A0B72FD0-A27D-4A4F-9204-7F00DB41E4C4}"/>
               </a:ext>
             </a:extLst>
           </p:cNvPr>
@@ -4369,7 +4472,7 @@
           <p:cNvPr id="5" name="">
             <a:extLst xmlns:a="http://schemas.openxmlformats.org/drawingml/2006/main">
               <a:ext uri="{FF2B5EF4-FFF2-40B4-BE49-F238E27FC236}">
-                <a16:creationId xmlns:a16="http://schemas.microsoft.com/office/drawing/2014/main" id="{7AD74368-DF47-40FE-8555-672FE5398F62}"/>
+                <a16:creationId xmlns:a16="http://schemas.microsoft.com/office/drawing/2014/main" id="{A40DB72F-1E52-4FB8-B2DB-8EA3F6376F4C}"/>
               </a:ext>
             </a:extLst>
           </p:cNvPr>
@@ -4419,7 +4522,7 @@
           <p:cNvPr id="6" name="">
             <a:extLst xmlns:a="http://schemas.openxmlformats.org/drawingml/2006/main">
               <a:ext uri="{FF2B5EF4-FFF2-40B4-BE49-F238E27FC236}">
-                <a16:creationId xmlns:a16="http://schemas.microsoft.com/office/drawing/2014/main" id="{7110E66A-BB14-4A2A-9513-829698143161}"/>
+                <a16:creationId xmlns:a16="http://schemas.microsoft.com/office/drawing/2014/main" id="{AF8FD7F9-8A19-4637-AAE8-F095CDAA52CC}"/>
               </a:ext>
             </a:extLst>
           </p:cNvPr>
@@ -4469,7 +4572,7 @@
           <p:cNvPr id="7" name="">
             <a:extLst xmlns:a="http://schemas.openxmlformats.org/drawingml/2006/main">
               <a:ext uri="{FF2B5EF4-FFF2-40B4-BE49-F238E27FC236}">
-                <a16:creationId xmlns:a16="http://schemas.microsoft.com/office/drawing/2014/main" id="{61EA8FAE-470A-4997-B41B-1910623FD219}"/>
+                <a16:creationId xmlns:a16="http://schemas.microsoft.com/office/drawing/2014/main" id="{507902C0-3AC6-4538-8D07-E8B85112A539}"/>
               </a:ext>
             </a:extLst>
           </p:cNvPr>
@@ -4536,7 +4639,7 @@
           <p:cNvPr id="8" name="">
             <a:extLst xmlns:a="http://schemas.openxmlformats.org/drawingml/2006/main">
               <a:ext uri="{FF2B5EF4-FFF2-40B4-BE49-F238E27FC236}">
-                <a16:creationId xmlns:a16="http://schemas.microsoft.com/office/drawing/2014/main" id="{1033094D-2BA8-4A64-9FD6-D3BF3588C01C}"/>
+                <a16:creationId xmlns:a16="http://schemas.microsoft.com/office/drawing/2014/main" id="{359F20F8-6D56-4A6C-B072-EBFE48E31F9A}"/>
               </a:ext>
             </a:extLst>
           </p:cNvPr>
@@ -4567,7 +4670,7 @@
           <p:cNvPr id="9" name="">
             <a:extLst xmlns:a="http://schemas.openxmlformats.org/drawingml/2006/main">
               <a:ext uri="{FF2B5EF4-FFF2-40B4-BE49-F238E27FC236}">
-                <a16:creationId xmlns:a16="http://schemas.microsoft.com/office/drawing/2014/main" id="{E7ED1799-F2B5-41C8-BEE5-CB9636AB3C05}"/>
+                <a16:creationId xmlns:a16="http://schemas.microsoft.com/office/drawing/2014/main" id="{E813F4CE-B7AA-47DB-A35F-5B81C0824C83}"/>
               </a:ext>
             </a:extLst>
           </p:cNvPr>
@@ -4617,7 +4720,7 @@
           <p:cNvPr id="10" name="">
             <a:extLst xmlns:a="http://schemas.openxmlformats.org/drawingml/2006/main">
               <a:ext uri="{FF2B5EF4-FFF2-40B4-BE49-F238E27FC236}">
-                <a16:creationId xmlns:a16="http://schemas.microsoft.com/office/drawing/2014/main" id="{5661ACA2-0FA8-4ABD-909A-54F100CD2FC6}"/>
+                <a16:creationId xmlns:a16="http://schemas.microsoft.com/office/drawing/2014/main" id="{2ADAA9C9-66A7-4E4D-A7C6-B021D6553961}"/>
               </a:ext>
             </a:extLst>
           </p:cNvPr>
@@ -4667,7 +4770,7 @@
           <p:cNvPr id="11" name="">
             <a:extLst xmlns:a="http://schemas.openxmlformats.org/drawingml/2006/main">
               <a:ext uri="{FF2B5EF4-FFF2-40B4-BE49-F238E27FC236}">
-                <a16:creationId xmlns:a16="http://schemas.microsoft.com/office/drawing/2014/main" id="{091D1EF6-D4CA-4CF5-9441-09A49F93377B}"/>
+                <a16:creationId xmlns:a16="http://schemas.microsoft.com/office/drawing/2014/main" id="{9118764C-FB49-404F-AC6E-F3C0D8E70971}"/>
               </a:ext>
             </a:extLst>
           </p:cNvPr>
@@ -4734,7 +4837,7 @@
           <p:cNvPr id="12" name="">
             <a:extLst xmlns:a="http://schemas.openxmlformats.org/drawingml/2006/main">
               <a:ext uri="{FF2B5EF4-FFF2-40B4-BE49-F238E27FC236}">
-                <a16:creationId xmlns:a16="http://schemas.microsoft.com/office/drawing/2014/main" id="{7FFFA093-149F-4C24-B84E-46C4EFEAA364}"/>
+                <a16:creationId xmlns:a16="http://schemas.microsoft.com/office/drawing/2014/main" id="{33FC8CDE-29EA-4D1E-AA10-47247AA2F61C}"/>
               </a:ext>
             </a:extLst>
           </p:cNvPr>
@@ -4765,7 +4868,7 @@
           <p:cNvPr id="13" name="">
             <a:extLst xmlns:a="http://schemas.openxmlformats.org/drawingml/2006/main">
               <a:ext uri="{FF2B5EF4-FFF2-40B4-BE49-F238E27FC236}">
-                <a16:creationId xmlns:a16="http://schemas.microsoft.com/office/drawing/2014/main" id="{BFDE6483-8079-40F4-8DCC-C09B31312680}"/>
+                <a16:creationId xmlns:a16="http://schemas.microsoft.com/office/drawing/2014/main" id="{0B023FDF-DDAA-4BD5-9079-647817036532}"/>
               </a:ext>
             </a:extLst>
           </p:cNvPr>
@@ -4815,7 +4918,7 @@
           <p:cNvPr id="14" name="">
             <a:extLst xmlns:a="http://schemas.openxmlformats.org/drawingml/2006/main">
               <a:ext uri="{FF2B5EF4-FFF2-40B4-BE49-F238E27FC236}">
-                <a16:creationId xmlns:a16="http://schemas.microsoft.com/office/drawing/2014/main" id="{935E902E-E914-4B39-9013-93ACBA96EC34}"/>
+                <a16:creationId xmlns:a16="http://schemas.microsoft.com/office/drawing/2014/main" id="{ACA8B350-A8E3-4338-8706-C12EA58558A4}"/>
               </a:ext>
             </a:extLst>
           </p:cNvPr>
@@ -4855,7 +4958,7 @@
                   <a:srgbClr val="3D8DFF"/>
                 </a:solidFill>
               </a:rPr>
-              <a:t>Ground</a:t>
+              <a:t>Integrate</a:t>
             </a:r>
           </a:p>
         </p:txBody>
@@ -4865,7 +4968,7 @@
           <p:cNvPr id="15" name="">
             <a:extLst xmlns:a="http://schemas.openxmlformats.org/drawingml/2006/main">
               <a:ext uri="{FF2B5EF4-FFF2-40B4-BE49-F238E27FC236}">
-                <a16:creationId xmlns:a16="http://schemas.microsoft.com/office/drawing/2014/main" id="{53331DAD-DCB2-472A-B9BF-07FDED8ECE0E}"/>
+                <a16:creationId xmlns:a16="http://schemas.microsoft.com/office/drawing/2014/main" id="{AB24A019-AF99-4CEA-9B90-F5EC089C8CA3}"/>
               </a:ext>
             </a:extLst>
           </p:cNvPr>
@@ -4905,7 +5008,7 @@
                   <a:srgbClr val="111111"/>
                 </a:solidFill>
               </a:rPr>
-              <a:t>Retrieval + evidence +</a:t>
+              <a:t>80k-trained classifier +</a:t>
             </a:r>
           </a:p>
           <a:p xmlns:a="http://schemas.openxmlformats.org/drawingml/2006/main">
@@ -4922,7 +5025,7 @@
                   <a:srgbClr val="111111"/>
                 </a:solidFill>
               </a:rPr>
-              <a:t>hallucination checks</a:t>
+              <a:t>retrieval + policy gates</a:t>
             </a:r>
           </a:p>
         </p:txBody>
@@ -4932,7 +5035,7 @@
           <p:cNvPr id="16" name="">
             <a:extLst xmlns:a="http://schemas.openxmlformats.org/drawingml/2006/main">
               <a:ext uri="{FF2B5EF4-FFF2-40B4-BE49-F238E27FC236}">
-                <a16:creationId xmlns:a16="http://schemas.microsoft.com/office/drawing/2014/main" id="{D9A696B8-03A4-443A-A014-DBA530898E04}"/>
+                <a16:creationId xmlns:a16="http://schemas.microsoft.com/office/drawing/2014/main" id="{3E27C81D-5717-481A-B09C-F1C9701E62FA}"/>
               </a:ext>
             </a:extLst>
           </p:cNvPr>
@@ -4963,7 +5066,7 @@
           <p:cNvPr id="17" name="">
             <a:extLst xmlns:a="http://schemas.openxmlformats.org/drawingml/2006/main">
               <a:ext uri="{FF2B5EF4-FFF2-40B4-BE49-F238E27FC236}">
-                <a16:creationId xmlns:a16="http://schemas.microsoft.com/office/drawing/2014/main" id="{9352FB29-43BC-4E79-86D9-0FB2AB517BF4}"/>
+                <a16:creationId xmlns:a16="http://schemas.microsoft.com/office/drawing/2014/main" id="{13A20A19-121D-4C3B-A538-FBFB1269CAA9}"/>
               </a:ext>
             </a:extLst>
           </p:cNvPr>
@@ -5013,7 +5116,7 @@
           <p:cNvPr id="18" name="">
             <a:extLst xmlns:a="http://schemas.openxmlformats.org/drawingml/2006/main">
               <a:ext uri="{FF2B5EF4-FFF2-40B4-BE49-F238E27FC236}">
-                <a16:creationId xmlns:a16="http://schemas.microsoft.com/office/drawing/2014/main" id="{10A833F7-C583-46CD-8A33-983E2943D18B}"/>
+                <a16:creationId xmlns:a16="http://schemas.microsoft.com/office/drawing/2014/main" id="{3D6D1766-44F0-4270-9DD9-6435F9B04284}"/>
               </a:ext>
             </a:extLst>
           </p:cNvPr>
@@ -5053,7 +5156,7 @@
                   <a:srgbClr val="D6532F"/>
                 </a:solidFill>
               </a:rPr>
-              <a:t>Ship</a:t>
+              <a:t>Validate</a:t>
             </a:r>
           </a:p>
         </p:txBody>
@@ -5063,7 +5166,7 @@
           <p:cNvPr id="19" name="">
             <a:extLst xmlns:a="http://schemas.openxmlformats.org/drawingml/2006/main">
               <a:ext uri="{FF2B5EF4-FFF2-40B4-BE49-F238E27FC236}">
-                <a16:creationId xmlns:a16="http://schemas.microsoft.com/office/drawing/2014/main" id="{1AF9B4DD-A6DC-4551-B6AD-783B22688CA6}"/>
+                <a16:creationId xmlns:a16="http://schemas.microsoft.com/office/drawing/2014/main" id="{70631FFD-79A0-49BF-A5E3-234A202DA52F}"/>
               </a:ext>
             </a:extLst>
           </p:cNvPr>
@@ -5103,7 +5206,7 @@
                   <a:srgbClr val="111111"/>
                 </a:solidFill>
               </a:rPr>
-              <a:t>CLI, docs, evaluation,</a:t>
+              <a:t>Leakage audit, tests,</a:t>
             </a:r>
           </a:p>
           <a:p xmlns:a="http://schemas.openxmlformats.org/drawingml/2006/main">
@@ -5128,7 +5231,7 @@
     </p:spTree>
     <p:extLst>
       <p:ext uri="{BB962C8B-B14F-4D97-AF65-F5344CB8AC3E}">
-        <p14:creationId xmlns:p14="http://schemas.microsoft.com/office/powerpoint/2010/main" val="1052534762"/>
+        <p14:creationId xmlns:p14="http://schemas.microsoft.com/office/powerpoint/2010/main" val="1716480878"/>
       </p:ext>
     </p:extLst>
   </p:cSld>
@@ -5159,7 +5262,7 @@
           <p:cNvPr id="29" name="slide-5-title">
             <a:extLst xmlns:a="http://schemas.openxmlformats.org/drawingml/2006/main">
               <a:ext uri="{FF2B5EF4-FFF2-40B4-BE49-F238E27FC236}">
-                <a16:creationId xmlns:a16="http://schemas.microsoft.com/office/drawing/2014/main" id="{566748C2-BFB4-4769-92A9-A47CAEC8A564}"/>
+                <a16:creationId xmlns:a16="http://schemas.microsoft.com/office/drawing/2014/main" id="{D7F0156D-6E31-40D7-A40D-8D4CE1C8114B}"/>
               </a:ext>
             </a:extLst>
           </p:cNvPr>
@@ -5199,7 +5302,7 @@
                   <a:srgbClr val="111111"/>
                 </a:solidFill>
               </a:rPr>
-              <a:t>Retrieval makes the final recommendation inspectable</a:t>
+              <a:t>Two input modes prevent a subtle but costly task error</a:t>
             </a:r>
           </a:p>
         </p:txBody>
@@ -5209,7 +5312,7 @@
           <p:cNvPr id="2" name="">
             <a:extLst xmlns:a="http://schemas.openxmlformats.org/drawingml/2006/main">
               <a:ext uri="{FF2B5EF4-FFF2-40B4-BE49-F238E27FC236}">
-                <a16:creationId xmlns:a16="http://schemas.microsoft.com/office/drawing/2014/main" id="{A0D10A14-B913-4AFE-8D33-3FABB8A41D34}"/>
+                <a16:creationId xmlns:a16="http://schemas.microsoft.com/office/drawing/2014/main" id="{C9B61410-6012-4066-9384-0419B1C1CB13}"/>
               </a:ext>
             </a:extLst>
           </p:cNvPr>
@@ -5249,7 +5352,7 @@
                   <a:srgbClr val="565D67"/>
                 </a:solidFill>
               </a:rPr>
-              <a:t>Generation is constrained to source fields; authorization remains an evidence-gated branch.</a:t>
+              <a:t>Search requests retrieve candidates; only job postings receive a role-fit label.</a:t>
             </a:r>
           </a:p>
         </p:txBody>
@@ -5259,7 +5362,7 @@
           <p:cNvPr id="3" name="">
             <a:extLst xmlns:a="http://schemas.openxmlformats.org/drawingml/2006/main">
               <a:ext uri="{FF2B5EF4-FFF2-40B4-BE49-F238E27FC236}">
-                <a16:creationId xmlns:a16="http://schemas.microsoft.com/office/drawing/2014/main" id="{B4794D30-8E46-4376-B6EC-136E9872E4E8}"/>
+                <a16:creationId xmlns:a16="http://schemas.microsoft.com/office/drawing/2014/main" id="{A1FD9B23-E298-487C-AADA-2F466DC1482B}"/>
               </a:ext>
             </a:extLst>
           </p:cNvPr>
@@ -5397,7 +5500,7 @@
           <p:cNvPr id="8" name="">
             <a:extLst xmlns:a="http://schemas.openxmlformats.org/drawingml/2006/main">
               <a:ext uri="{FF2B5EF4-FFF2-40B4-BE49-F238E27FC236}">
-                <a16:creationId xmlns:a16="http://schemas.microsoft.com/office/drawing/2014/main" id="{55A0646C-39D8-471C-A1F3-D9AA769506F6}"/>
+                <a16:creationId xmlns:a16="http://schemas.microsoft.com/office/drawing/2014/main" id="{0C04954D-7B7F-4D96-80F1-5242EF63368D}"/>
               </a:ext>
             </a:extLst>
           </p:cNvPr>
@@ -5428,7 +5531,7 @@
           <p:cNvPr id="9" name="">
             <a:extLst xmlns:a="http://schemas.openxmlformats.org/drawingml/2006/main">
               <a:ext uri="{FF2B5EF4-FFF2-40B4-BE49-F238E27FC236}">
-                <a16:creationId xmlns:a16="http://schemas.microsoft.com/office/drawing/2014/main" id="{5DB51ACD-F580-4DD7-B4C8-FFFA20EA399E}"/>
+                <a16:creationId xmlns:a16="http://schemas.microsoft.com/office/drawing/2014/main" id="{F23C8F1E-4D76-470F-B73B-FD57235B1165}"/>
               </a:ext>
             </a:extLst>
           </p:cNvPr>
@@ -5478,7 +5581,7 @@
           <p:cNvPr id="10" name="">
             <a:extLst xmlns:a="http://schemas.openxmlformats.org/drawingml/2006/main">
               <a:ext uri="{FF2B5EF4-FFF2-40B4-BE49-F238E27FC236}">
-                <a16:creationId xmlns:a16="http://schemas.microsoft.com/office/drawing/2014/main" id="{50ABC244-4E5D-4303-83AD-EF3D2EF61EA2}"/>
+                <a16:creationId xmlns:a16="http://schemas.microsoft.com/office/drawing/2014/main" id="{B4DB2967-BD4C-497B-9A77-FC120A3DD033}"/>
               </a:ext>
             </a:extLst>
           </p:cNvPr>
@@ -5518,7 +5621,7 @@
                   <a:srgbClr val="111111"/>
                 </a:solidFill>
               </a:rPr>
-              <a:t>INPUT</a:t>
+              <a:t>ROUTE</a:t>
             </a:r>
           </a:p>
         </p:txBody>
@@ -5528,7 +5631,7 @@
           <p:cNvPr id="11" name="">
             <a:extLst xmlns:a="http://schemas.openxmlformats.org/drawingml/2006/main">
               <a:ext uri="{FF2B5EF4-FFF2-40B4-BE49-F238E27FC236}">
-                <a16:creationId xmlns:a16="http://schemas.microsoft.com/office/drawing/2014/main" id="{CFB99705-2FA7-40BF-86EB-7BDE32F48C36}"/>
+                <a16:creationId xmlns:a16="http://schemas.microsoft.com/office/drawing/2014/main" id="{BE184F35-99A4-46A2-AB96-F010701D9A97}"/>
               </a:ext>
             </a:extLst>
           </p:cNvPr>
@@ -5568,7 +5671,7 @@
                   <a:srgbClr val="565D67"/>
                 </a:solidFill>
               </a:rPr>
-              <a:t>Advisor query or raw posting</a:t>
+              <a:t>Search request or job posting</a:t>
             </a:r>
           </a:p>
         </p:txBody>
@@ -5578,7 +5681,7 @@
           <p:cNvPr id="12" name="">
             <a:extLst xmlns:a="http://schemas.openxmlformats.org/drawingml/2006/main">
               <a:ext uri="{FF2B5EF4-FFF2-40B4-BE49-F238E27FC236}">
-                <a16:creationId xmlns:a16="http://schemas.microsoft.com/office/drawing/2014/main" id="{CB25FAB6-9C0E-435A-9E76-8D5AAC009B7E}"/>
+                <a16:creationId xmlns:a16="http://schemas.microsoft.com/office/drawing/2014/main" id="{4180067F-D743-4842-9F03-B955B2599599}"/>
               </a:ext>
             </a:extLst>
           </p:cNvPr>
@@ -5609,7 +5712,7 @@
           <p:cNvPr id="13" name="">
             <a:extLst xmlns:a="http://schemas.openxmlformats.org/drawingml/2006/main">
               <a:ext uri="{FF2B5EF4-FFF2-40B4-BE49-F238E27FC236}">
-                <a16:creationId xmlns:a16="http://schemas.microsoft.com/office/drawing/2014/main" id="{0D40FC14-2C25-4E0B-9AA9-20696D36AEB8}"/>
+                <a16:creationId xmlns:a16="http://schemas.microsoft.com/office/drawing/2014/main" id="{D66F3B88-0B60-495B-BCEE-FFEA52D2FB8B}"/>
               </a:ext>
             </a:extLst>
           </p:cNvPr>
@@ -5659,7 +5762,7 @@
           <p:cNvPr id="14" name="">
             <a:extLst xmlns:a="http://schemas.openxmlformats.org/drawingml/2006/main">
               <a:ext uri="{FF2B5EF4-FFF2-40B4-BE49-F238E27FC236}">
-                <a16:creationId xmlns:a16="http://schemas.microsoft.com/office/drawing/2014/main" id="{17B4EF6A-8ED3-4DD2-85E2-A579496340BB}"/>
+                <a16:creationId xmlns:a16="http://schemas.microsoft.com/office/drawing/2014/main" id="{6024729E-A9DD-4CA7-BB5A-5DA7ED36EBC2}"/>
               </a:ext>
             </a:extLst>
           </p:cNvPr>
@@ -5709,7 +5812,7 @@
           <p:cNvPr id="15" name="">
             <a:extLst xmlns:a="http://schemas.openxmlformats.org/drawingml/2006/main">
               <a:ext uri="{FF2B5EF4-FFF2-40B4-BE49-F238E27FC236}">
-                <a16:creationId xmlns:a16="http://schemas.microsoft.com/office/drawing/2014/main" id="{70C404B6-06FA-4A40-870E-DC1B127A87DB}"/>
+                <a16:creationId xmlns:a16="http://schemas.microsoft.com/office/drawing/2014/main" id="{DED937F0-A0F0-4E6E-86F5-C67E59268054}"/>
               </a:ext>
             </a:extLst>
           </p:cNvPr>
@@ -5749,7 +5852,7 @@
                   <a:srgbClr val="565D67"/>
                 </a:solidFill>
               </a:rPr>
-              <a:t>Top-6 from 80k real postings</a:t>
+              <a:t>80k index + constraints + dedupe</a:t>
             </a:r>
           </a:p>
         </p:txBody>
@@ -5759,7 +5862,7 @@
           <p:cNvPr id="16" name="">
             <a:extLst xmlns:a="http://schemas.openxmlformats.org/drawingml/2006/main">
               <a:ext uri="{FF2B5EF4-FFF2-40B4-BE49-F238E27FC236}">
-                <a16:creationId xmlns:a16="http://schemas.microsoft.com/office/drawing/2014/main" id="{4CDAB209-04B1-49CA-813D-698582E24B2B}"/>
+                <a16:creationId xmlns:a16="http://schemas.microsoft.com/office/drawing/2014/main" id="{D3D75D67-C254-4768-9D9F-E3D3CFEF39E3}"/>
               </a:ext>
             </a:extLst>
           </p:cNvPr>
@@ -5790,7 +5893,7 @@
           <p:cNvPr id="17" name="">
             <a:extLst xmlns:a="http://schemas.openxmlformats.org/drawingml/2006/main">
               <a:ext uri="{FF2B5EF4-FFF2-40B4-BE49-F238E27FC236}">
-                <a16:creationId xmlns:a16="http://schemas.microsoft.com/office/drawing/2014/main" id="{954DE18A-364B-48D4-BCEC-F50203DD6B82}"/>
+                <a16:creationId xmlns:a16="http://schemas.microsoft.com/office/drawing/2014/main" id="{60E7F0A0-F683-4182-A572-A27D02DEADB4}"/>
               </a:ext>
             </a:extLst>
           </p:cNvPr>
@@ -5840,7 +5943,7 @@
           <p:cNvPr id="18" name="">
             <a:extLst xmlns:a="http://schemas.openxmlformats.org/drawingml/2006/main">
               <a:ext uri="{FF2B5EF4-FFF2-40B4-BE49-F238E27FC236}">
-                <a16:creationId xmlns:a16="http://schemas.microsoft.com/office/drawing/2014/main" id="{FA7CA04B-FF4E-4770-BF25-5BAC6352C7AA}"/>
+                <a16:creationId xmlns:a16="http://schemas.microsoft.com/office/drawing/2014/main" id="{85FA5564-413F-44DA-8235-CBBCD203B2E1}"/>
               </a:ext>
             </a:extLst>
           </p:cNvPr>
@@ -5880,7 +5983,7 @@
                   <a:srgbClr val="111111"/>
                 </a:solidFill>
               </a:rPr>
-              <a:t>DECIDE</a:t>
+              <a:t>CLASSIFY</a:t>
             </a:r>
           </a:p>
         </p:txBody>
@@ -5890,7 +5993,7 @@
           <p:cNvPr id="19" name="">
             <a:extLst xmlns:a="http://schemas.openxmlformats.org/drawingml/2006/main">
               <a:ext uri="{FF2B5EF4-FFF2-40B4-BE49-F238E27FC236}">
-                <a16:creationId xmlns:a16="http://schemas.microsoft.com/office/drawing/2014/main" id="{EB7476A9-BCC7-4288-A786-7AF77A99B032}"/>
+                <a16:creationId xmlns:a16="http://schemas.microsoft.com/office/drawing/2014/main" id="{EC4BFA99-8765-40BF-ADA2-2E2E1B41225B}"/>
               </a:ext>
             </a:extLst>
           </p:cNvPr>
@@ -5930,7 +6033,7 @@
                   <a:srgbClr val="565D67"/>
                 </a:solidFill>
               </a:rPr>
-              <a:t>Transparent four-label rubric</a:t>
+              <a:t>77,135-row TF-IDF SVM</a:t>
             </a:r>
           </a:p>
         </p:txBody>
@@ -5940,7 +6043,7 @@
           <p:cNvPr id="20" name="">
             <a:extLst xmlns:a="http://schemas.openxmlformats.org/drawingml/2006/main">
               <a:ext uri="{FF2B5EF4-FFF2-40B4-BE49-F238E27FC236}">
-                <a16:creationId xmlns:a16="http://schemas.microsoft.com/office/drawing/2014/main" id="{16A04890-B46D-4221-9B60-7480BAD53AAC}"/>
+                <a16:creationId xmlns:a16="http://schemas.microsoft.com/office/drawing/2014/main" id="{89F5E6D8-7242-42CB-8F7E-BD26A60FD463}"/>
               </a:ext>
             </a:extLst>
           </p:cNvPr>
@@ -5971,7 +6074,7 @@
           <p:cNvPr id="21" name="">
             <a:extLst xmlns:a="http://schemas.openxmlformats.org/drawingml/2006/main">
               <a:ext uri="{FF2B5EF4-FFF2-40B4-BE49-F238E27FC236}">
-                <a16:creationId xmlns:a16="http://schemas.microsoft.com/office/drawing/2014/main" id="{0643BFD1-DC25-4D98-BC68-34E7F4C9C52C}"/>
+                <a16:creationId xmlns:a16="http://schemas.microsoft.com/office/drawing/2014/main" id="{16E7BC6A-F899-4F1F-B80F-050FE06FEC2F}"/>
               </a:ext>
             </a:extLst>
           </p:cNvPr>
@@ -6021,7 +6124,7 @@
           <p:cNvPr id="22" name="">
             <a:extLst xmlns:a="http://schemas.openxmlformats.org/drawingml/2006/main">
               <a:ext uri="{FF2B5EF4-FFF2-40B4-BE49-F238E27FC236}">
-                <a16:creationId xmlns:a16="http://schemas.microsoft.com/office/drawing/2014/main" id="{2F673C55-6FE7-464D-BCCD-4E2289947D18}"/>
+                <a16:creationId xmlns:a16="http://schemas.microsoft.com/office/drawing/2014/main" id="{14478B83-130D-401E-AAAD-A28A1EE40025}"/>
               </a:ext>
             </a:extLst>
           </p:cNvPr>
@@ -6061,7 +6164,7 @@
                   <a:srgbClr val="111111"/>
                 </a:solidFill>
               </a:rPr>
-              <a:t>GENERATE</a:t>
+              <a:t>GOVERN</a:t>
             </a:r>
           </a:p>
         </p:txBody>
@@ -6071,7 +6174,7 @@
           <p:cNvPr id="23" name="">
             <a:extLst xmlns:a="http://schemas.openxmlformats.org/drawingml/2006/main">
               <a:ext uri="{FF2B5EF4-FFF2-40B4-BE49-F238E27FC236}">
-                <a16:creationId xmlns:a16="http://schemas.microsoft.com/office/drawing/2014/main" id="{196A5FEE-DE3E-4BEE-A550-3DD218C9721C}"/>
+                <a16:creationId xmlns:a16="http://schemas.microsoft.com/office/drawing/2014/main" id="{1E5A3703-39D0-4E74-BDFF-ADB49A09185E}"/>
               </a:ext>
             </a:extLst>
           </p:cNvPr>
@@ -6111,24 +6214,7 @@
                   <a:srgbClr val="565D67"/>
                 </a:solidFill>
               </a:rPr>
-              <a:t>Cited fields</a:t>
-            </a:r>
-          </a:p>
-          <a:p xmlns:a="http://schemas.openxmlformats.org/drawingml/2006/main">
-            <a:pPr algn="l">
-              <a:defRPr sz="1500" b="0">
-                <a:solidFill>
-                  <a:srgbClr val="565D67"/>
-                </a:solidFill>
-              </a:defRPr>
-            </a:pPr>
-            <a:r>
-              <a:rPr sz="1500" b="0">
-                <a:solidFill>
-                  <a:srgbClr val="565D67"/>
-                </a:solidFill>
-              </a:rPr>
-              <a:t>only</a:t>
+              <a:t>Missing fields + authorization</a:t>
             </a:r>
           </a:p>
         </p:txBody>
@@ -6138,7 +6224,7 @@
           <p:cNvPr id="24" name="">
             <a:extLst xmlns:a="http://schemas.openxmlformats.org/drawingml/2006/main">
               <a:ext uri="{FF2B5EF4-FFF2-40B4-BE49-F238E27FC236}">
-                <a16:creationId xmlns:a16="http://schemas.microsoft.com/office/drawing/2014/main" id="{18D58192-4F4F-42F3-8103-9A3318EEC88D}"/>
+                <a16:creationId xmlns:a16="http://schemas.microsoft.com/office/drawing/2014/main" id="{CE70C2A7-387F-4207-9624-ECBFC9BC1483}"/>
               </a:ext>
             </a:extLst>
           </p:cNvPr>
@@ -6169,7 +6255,7 @@
           <p:cNvPr id="25" name="">
             <a:extLst xmlns:a="http://schemas.openxmlformats.org/drawingml/2006/main">
               <a:ext uri="{FF2B5EF4-FFF2-40B4-BE49-F238E27FC236}">
-                <a16:creationId xmlns:a16="http://schemas.microsoft.com/office/drawing/2014/main" id="{E7FEC221-8ED9-409C-9B8C-43118A93C1D5}"/>
+                <a16:creationId xmlns:a16="http://schemas.microsoft.com/office/drawing/2014/main" id="{23F61EFD-7BC1-4B52-9016-DE3D80ECC089}"/>
               </a:ext>
             </a:extLst>
           </p:cNvPr>
@@ -6219,7 +6305,7 @@
           <p:cNvPr id="26" name="">
             <a:extLst xmlns:a="http://schemas.openxmlformats.org/drawingml/2006/main">
               <a:ext uri="{FF2B5EF4-FFF2-40B4-BE49-F238E27FC236}">
-                <a16:creationId xmlns:a16="http://schemas.microsoft.com/office/drawing/2014/main" id="{D3A64099-39C7-46B5-9443-E062BDBF845B}"/>
+                <a16:creationId xmlns:a16="http://schemas.microsoft.com/office/drawing/2014/main" id="{1740AE7F-EE1A-4D6F-8A0A-892BB06BB091}"/>
               </a:ext>
             </a:extLst>
           </p:cNvPr>
@@ -6269,7 +6355,7 @@
           <p:cNvPr id="27" name="">
             <a:extLst xmlns:a="http://schemas.openxmlformats.org/drawingml/2006/main">
               <a:ext uri="{FF2B5EF4-FFF2-40B4-BE49-F238E27FC236}">
-                <a16:creationId xmlns:a16="http://schemas.microsoft.com/office/drawing/2014/main" id="{4CC9AF19-45E1-4117-AE9B-BA48CD46B9BF}"/>
+                <a16:creationId xmlns:a16="http://schemas.microsoft.com/office/drawing/2014/main" id="{AC3BA6CC-CEAB-4CA6-9294-8A2E900DC908}"/>
               </a:ext>
             </a:extLst>
           </p:cNvPr>
@@ -6309,7 +6395,7 @@
                   <a:srgbClr val="565D67"/>
                 </a:solidFill>
               </a:rPr>
-              <a:t>Authorization and final action</a:t>
+              <a:t>Cited evidence and final action</a:t>
             </a:r>
           </a:p>
         </p:txBody>
@@ -6319,7 +6405,7 @@
           <p:cNvPr id="28" name="">
             <a:extLst xmlns:a="http://schemas.openxmlformats.org/drawingml/2006/main">
               <a:ext uri="{FF2B5EF4-FFF2-40B4-BE49-F238E27FC236}">
-                <a16:creationId xmlns:a16="http://schemas.microsoft.com/office/drawing/2014/main" id="{DAE10D9E-1F1B-468D-8F02-40FCC685A707}"/>
+                <a16:creationId xmlns:a16="http://schemas.microsoft.com/office/drawing/2014/main" id="{04227782-6714-40F1-BE38-D7ACF09DF976}"/>
               </a:ext>
             </a:extLst>
           </p:cNvPr>
@@ -6331,7 +6417,7 @@
         <p:spPr>
           <a:xfrm xmlns:a="http://schemas.openxmlformats.org/drawingml/2006/main">
             <a:off x="419100" y="5391150"/>
-            <a:ext cx="9715500" cy="457200"/>
+            <a:ext cx="10477500" cy="457200"/>
           </a:xfrm>
           <a:prstGeom xmlns:a="http://schemas.openxmlformats.org/drawingml/2006/main" prst="rect">
             <a:avLst/>
@@ -6359,7 +6445,7 @@
                   <a:srgbClr val="111111"/>
                 </a:solidFill>
               </a:rPr>
-              <a:t>Every posting-specific fact in the response can be traced to a retrieved record.</a:t>
+              <a:t>A high role-fit score can never override an explicit authorization restriction.</a:t>
             </a:r>
           </a:p>
         </p:txBody>
@@ -6367,7 +6453,7 @@
     </p:spTree>
     <p:extLst>
       <p:ext uri="{BB962C8B-B14F-4D97-AF65-F5344CB8AC3E}">
-        <p14:creationId xmlns:p14="http://schemas.microsoft.com/office/powerpoint/2010/main" val="221087869"/>
+        <p14:creationId xmlns:p14="http://schemas.microsoft.com/office/powerpoint/2010/main" val="336150018"/>
       </p:ext>
     </p:extLst>
   </p:cSld>
@@ -6398,7 +6484,7 @@
           <p:cNvPr id="48" name="slide-6-title">
             <a:extLst xmlns:a="http://schemas.openxmlformats.org/drawingml/2006/main">
               <a:ext uri="{FF2B5EF4-FFF2-40B4-BE49-F238E27FC236}">
-                <a16:creationId xmlns:a16="http://schemas.microsoft.com/office/drawing/2014/main" id="{02E439AD-A94E-4A67-BFC6-87660BF8E95A}"/>
+                <a16:creationId xmlns:a16="http://schemas.microsoft.com/office/drawing/2014/main" id="{507817C5-340B-406E-BEB4-8AAFCD54F65C}"/>
               </a:ext>
             </a:extLst>
           </p:cNvPr>
@@ -6438,7 +6524,7 @@
                   <a:srgbClr val="111111"/>
                 </a:solidFill>
               </a:rPr>
-              <a:t>A normal run returns real postings, not just a label</a:t>
+              <a:t>Search mode returns constrained, inspectable candidates</a:t>
             </a:r>
           </a:p>
         </p:txBody>
@@ -6448,7 +6534,7 @@
           <p:cNvPr id="2" name="">
             <a:extLst xmlns:a="http://schemas.openxmlformats.org/drawingml/2006/main">
               <a:ext uri="{FF2B5EF4-FFF2-40B4-BE49-F238E27FC236}">
-                <a16:creationId xmlns:a16="http://schemas.microsoft.com/office/drawing/2014/main" id="{37C856D2-9941-432E-822E-4C8ADB186267}"/>
+                <a16:creationId xmlns:a16="http://schemas.microsoft.com/office/drawing/2014/main" id="{8757B6DD-E389-4AFE-8BFD-E5AA577B80EC}"/>
               </a:ext>
             </a:extLst>
           </p:cNvPr>
@@ -6488,7 +6574,7 @@
                   <a:srgbClr val="565D67"/>
                 </a:solidFill>
               </a:rPr>
-              <a:t>Query prediction: high_fit | Action: advisor review before forwarding</a:t>
+              <a:t>The top five results satisfy the requested US constraint; the search sentence is not misclassified.</a:t>
             </a:r>
           </a:p>
         </p:txBody>
@@ -6498,7 +6584,7 @@
           <p:cNvPr id="3" name="">
             <a:extLst xmlns:a="http://schemas.openxmlformats.org/drawingml/2006/main">
               <a:ext uri="{FF2B5EF4-FFF2-40B4-BE49-F238E27FC236}">
-                <a16:creationId xmlns:a16="http://schemas.microsoft.com/office/drawing/2014/main" id="{644A3E51-B033-45DE-9B25-48A5219DC4DF}"/>
+                <a16:creationId xmlns:a16="http://schemas.microsoft.com/office/drawing/2014/main" id="{02DE3A6A-F7B1-4EC5-8706-64E24B76F4B1}"/>
               </a:ext>
             </a:extLst>
           </p:cNvPr>
@@ -6548,7 +6634,7 @@
           <p:cNvPr id="4" name="">
             <a:extLst xmlns:a="http://schemas.openxmlformats.org/drawingml/2006/main">
               <a:ext uri="{FF2B5EF4-FFF2-40B4-BE49-F238E27FC236}">
-                <a16:creationId xmlns:a16="http://schemas.microsoft.com/office/drawing/2014/main" id="{A66726CD-8238-4CEE-BE78-F4E0269AD975}"/>
+                <a16:creationId xmlns:a16="http://schemas.microsoft.com/office/drawing/2014/main" id="{F803D51D-F923-4C85-ACB7-85757508D6EA}"/>
               </a:ext>
             </a:extLst>
           </p:cNvPr>
@@ -6598,7 +6684,7 @@
           <p:cNvPr id="5" name="">
             <a:extLst xmlns:a="http://schemas.openxmlformats.org/drawingml/2006/main">
               <a:ext uri="{FF2B5EF4-FFF2-40B4-BE49-F238E27FC236}">
-                <a16:creationId xmlns:a16="http://schemas.microsoft.com/office/drawing/2014/main" id="{7C511B53-BFFF-4F3B-875E-5EFB2E702D13}"/>
+                <a16:creationId xmlns:a16="http://schemas.microsoft.com/office/drawing/2014/main" id="{4BC83F53-7B14-4E2D-8D19-485ED976108A}"/>
               </a:ext>
             </a:extLst>
           </p:cNvPr>
@@ -6638,7 +6724,7 @@
                   <a:srgbClr val="111111"/>
                 </a:solidFill>
               </a:rPr>
-              <a:t>Find entry-level US data analyst, business analyst, or BI roles for an MSBA student with SQL, Python, Excel, Tableau, and Power BI. Remote or Bay Area preferred.</a:t>
+              <a:t>Find entry-level US data analyst, business analyst, or BI roles with SQL, Python, Excel, Tableau, or Power BI. Remote roles are acceptable.</a:t>
             </a:r>
           </a:p>
         </p:txBody>
@@ -6648,7 +6734,7 @@
           <p:cNvPr id="6" name="">
             <a:extLst xmlns:a="http://schemas.openxmlformats.org/drawingml/2006/main">
               <a:ext uri="{FF2B5EF4-FFF2-40B4-BE49-F238E27FC236}">
-                <a16:creationId xmlns:a16="http://schemas.microsoft.com/office/drawing/2014/main" id="{F78195FE-3664-4793-B342-6E06775544D5}"/>
+                <a16:creationId xmlns:a16="http://schemas.microsoft.com/office/drawing/2014/main" id="{F2A5CEBE-CAFA-4B33-A3E8-2F392E6BE7EA}"/>
               </a:ext>
             </a:extLst>
           </p:cNvPr>
@@ -6681,7 +6767,7 @@
           <p:cNvPr id="7" name="">
             <a:extLst xmlns:a="http://schemas.openxmlformats.org/drawingml/2006/main">
               <a:ext uri="{FF2B5EF4-FFF2-40B4-BE49-F238E27FC236}">
-                <a16:creationId xmlns:a16="http://schemas.microsoft.com/office/drawing/2014/main" id="{6BA9A83A-98F8-4802-973C-B167500455D6}"/>
+                <a16:creationId xmlns:a16="http://schemas.microsoft.com/office/drawing/2014/main" id="{CE6D0305-351A-4E15-989B-A10C42CA6148}"/>
               </a:ext>
             </a:extLst>
           </p:cNvPr>
@@ -6731,7 +6817,7 @@
           <p:cNvPr id="8" name="">
             <a:extLst xmlns:a="http://schemas.openxmlformats.org/drawingml/2006/main">
               <a:ext uri="{FF2B5EF4-FFF2-40B4-BE49-F238E27FC236}">
-                <a16:creationId xmlns:a16="http://schemas.microsoft.com/office/drawing/2014/main" id="{34E1B3C6-6211-4F67-AFBF-2F6741470B22}"/>
+                <a16:creationId xmlns:a16="http://schemas.microsoft.com/office/drawing/2014/main" id="{1FFEB1DB-A65B-4E68-91F2-B6BCABCE0DB4}"/>
               </a:ext>
             </a:extLst>
           </p:cNvPr>
@@ -6764,7 +6850,7 @@
           <p:cNvPr id="9" name="">
             <a:extLst xmlns:a="http://schemas.openxmlformats.org/drawingml/2006/main">
               <a:ext uri="{FF2B5EF4-FFF2-40B4-BE49-F238E27FC236}">
-                <a16:creationId xmlns:a16="http://schemas.microsoft.com/office/drawing/2014/main" id="{E823101C-E9D4-4AD2-A0F6-59D4B267F0E1}"/>
+                <a16:creationId xmlns:a16="http://schemas.microsoft.com/office/drawing/2014/main" id="{292BB196-403B-4E6D-B826-58EBDEE002E7}"/>
               </a:ext>
             </a:extLst>
           </p:cNvPr>
@@ -6814,7 +6900,7 @@
           <p:cNvPr id="10" name="">
             <a:extLst xmlns:a="http://schemas.openxmlformats.org/drawingml/2006/main">
               <a:ext uri="{FF2B5EF4-FFF2-40B4-BE49-F238E27FC236}">
-                <a16:creationId xmlns:a16="http://schemas.microsoft.com/office/drawing/2014/main" id="{7B758068-C01C-409B-940C-EAD4C21A4E9B}"/>
+                <a16:creationId xmlns:a16="http://schemas.microsoft.com/office/drawing/2014/main" id="{E9DC7E34-DE86-42A5-901C-D16B916DE132}"/>
               </a:ext>
             </a:extLst>
           </p:cNvPr>
@@ -6847,7 +6933,7 @@
           <p:cNvPr id="11" name="">
             <a:extLst xmlns:a="http://schemas.openxmlformats.org/drawingml/2006/main">
               <a:ext uri="{FF2B5EF4-FFF2-40B4-BE49-F238E27FC236}">
-                <a16:creationId xmlns:a16="http://schemas.microsoft.com/office/drawing/2014/main" id="{562831FA-D368-4ABB-8ADC-DED8FA747131}"/>
+                <a16:creationId xmlns:a16="http://schemas.microsoft.com/office/drawing/2014/main" id="{92658D7A-FF9F-4A1B-BD2C-0A58DCCB649C}"/>
               </a:ext>
             </a:extLst>
           </p:cNvPr>
@@ -6897,7 +6983,7 @@
           <p:cNvPr id="12" name="">
             <a:extLst xmlns:a="http://schemas.openxmlformats.org/drawingml/2006/main">
               <a:ext uri="{FF2B5EF4-FFF2-40B4-BE49-F238E27FC236}">
-                <a16:creationId xmlns:a16="http://schemas.microsoft.com/office/drawing/2014/main" id="{2DAC95ED-5B1B-4A32-95AF-CB2ACAB6D8EF}"/>
+                <a16:creationId xmlns:a16="http://schemas.microsoft.com/office/drawing/2014/main" id="{2A977B5C-7C84-48C3-A0CB-9B4672B97152}"/>
               </a:ext>
             </a:extLst>
           </p:cNvPr>
@@ -6930,7 +7016,7 @@
           <p:cNvPr id="13" name="">
             <a:extLst xmlns:a="http://schemas.openxmlformats.org/drawingml/2006/main">
               <a:ext uri="{FF2B5EF4-FFF2-40B4-BE49-F238E27FC236}">
-                <a16:creationId xmlns:a16="http://schemas.microsoft.com/office/drawing/2014/main" id="{50254A93-650A-4FE7-BA74-84707188F96C}"/>
+                <a16:creationId xmlns:a16="http://schemas.microsoft.com/office/drawing/2014/main" id="{1235AB11-41B9-43B0-8588-AA296036268C}"/>
               </a:ext>
             </a:extLst>
           </p:cNvPr>
@@ -6980,7 +7066,7 @@
           <p:cNvPr id="14" name="">
             <a:extLst xmlns:a="http://schemas.openxmlformats.org/drawingml/2006/main">
               <a:ext uri="{FF2B5EF4-FFF2-40B4-BE49-F238E27FC236}">
-                <a16:creationId xmlns:a16="http://schemas.microsoft.com/office/drawing/2014/main" id="{F4306B98-F126-43A5-842D-14F4891294AB}"/>
+                <a16:creationId xmlns:a16="http://schemas.microsoft.com/office/drawing/2014/main" id="{82150EB5-0F75-46E7-84C6-CAF9E7BA17F0}"/>
               </a:ext>
             </a:extLst>
           </p:cNvPr>
@@ -7013,7 +7099,7 @@
           <p:cNvPr id="15" name="">
             <a:extLst xmlns:a="http://schemas.openxmlformats.org/drawingml/2006/main">
               <a:ext uri="{FF2B5EF4-FFF2-40B4-BE49-F238E27FC236}">
-                <a16:creationId xmlns:a16="http://schemas.microsoft.com/office/drawing/2014/main" id="{BFC07401-A56F-424D-B488-77E6AABF5527}"/>
+                <a16:creationId xmlns:a16="http://schemas.microsoft.com/office/drawing/2014/main" id="{00443528-ED88-4FDF-9817-C0A3968474CA}"/>
               </a:ext>
             </a:extLst>
           </p:cNvPr>
@@ -7063,7 +7149,7 @@
           <p:cNvPr id="16" name="">
             <a:extLst xmlns:a="http://schemas.openxmlformats.org/drawingml/2006/main">
               <a:ext uri="{FF2B5EF4-FFF2-40B4-BE49-F238E27FC236}">
-                <a16:creationId xmlns:a16="http://schemas.microsoft.com/office/drawing/2014/main" id="{B797B24A-76D4-4546-9036-1B29A481D57F}"/>
+                <a16:creationId xmlns:a16="http://schemas.microsoft.com/office/drawing/2014/main" id="{28186ACE-D22E-4A6A-833D-525A2B55D6B5}"/>
               </a:ext>
             </a:extLst>
           </p:cNvPr>
@@ -7096,7 +7182,7 @@
           <p:cNvPr id="17" name="">
             <a:extLst xmlns:a="http://schemas.openxmlformats.org/drawingml/2006/main">
               <a:ext uri="{FF2B5EF4-FFF2-40B4-BE49-F238E27FC236}">
-                <a16:creationId xmlns:a16="http://schemas.microsoft.com/office/drawing/2014/main" id="{14989A4A-C11D-485B-B221-9AAA299EC991}"/>
+                <a16:creationId xmlns:a16="http://schemas.microsoft.com/office/drawing/2014/main" id="{16A8E40A-84AB-44B6-9433-D454D3B83F85}"/>
               </a:ext>
             </a:extLst>
           </p:cNvPr>
@@ -7146,7 +7232,7 @@
           <p:cNvPr id="18" name="">
             <a:extLst xmlns:a="http://schemas.openxmlformats.org/drawingml/2006/main">
               <a:ext uri="{FF2B5EF4-FFF2-40B4-BE49-F238E27FC236}">
-                <a16:creationId xmlns:a16="http://schemas.microsoft.com/office/drawing/2014/main" id="{5F89427B-1A61-4ED5-A2FA-897C65C24619}"/>
+                <a16:creationId xmlns:a16="http://schemas.microsoft.com/office/drawing/2014/main" id="{A1181CBD-B1AD-4346-AF04-A1718E4A9301}"/>
               </a:ext>
             </a:extLst>
           </p:cNvPr>
@@ -7179,7 +7265,7 @@
           <p:cNvPr id="19" name="">
             <a:extLst xmlns:a="http://schemas.openxmlformats.org/drawingml/2006/main">
               <a:ext uri="{FF2B5EF4-FFF2-40B4-BE49-F238E27FC236}">
-                <a16:creationId xmlns:a16="http://schemas.microsoft.com/office/drawing/2014/main" id="{BC7A7DBF-42F1-4001-975C-4D56ADCA1037}"/>
+                <a16:creationId xmlns:a16="http://schemas.microsoft.com/office/drawing/2014/main" id="{ADA8E167-FA0C-4701-B234-C9386CFB5B16}"/>
               </a:ext>
             </a:extLst>
           </p:cNvPr>
@@ -7229,7 +7315,7 @@
           <p:cNvPr id="20" name="">
             <a:extLst xmlns:a="http://schemas.openxmlformats.org/drawingml/2006/main">
               <a:ext uri="{FF2B5EF4-FFF2-40B4-BE49-F238E27FC236}">
-                <a16:creationId xmlns:a16="http://schemas.microsoft.com/office/drawing/2014/main" id="{F72B0227-546F-47CD-9417-12FB25E28810}"/>
+                <a16:creationId xmlns:a16="http://schemas.microsoft.com/office/drawing/2014/main" id="{326077B4-386E-45EE-BD8C-9939CC55B9BA}"/>
               </a:ext>
             </a:extLst>
           </p:cNvPr>
@@ -7262,7 +7348,7 @@
           <p:cNvPr id="21" name="">
             <a:extLst xmlns:a="http://schemas.openxmlformats.org/drawingml/2006/main">
               <a:ext uri="{FF2B5EF4-FFF2-40B4-BE49-F238E27FC236}">
-                <a16:creationId xmlns:a16="http://schemas.microsoft.com/office/drawing/2014/main" id="{53AFE867-1BB4-4E7A-9355-298440A47E89}"/>
+                <a16:creationId xmlns:a16="http://schemas.microsoft.com/office/drawing/2014/main" id="{F5C1E750-3B2B-4433-952D-F44D666EC7EE}"/>
               </a:ext>
             </a:extLst>
           </p:cNvPr>
@@ -7329,7 +7415,7 @@
           <p:cNvPr id="22" name="">
             <a:extLst xmlns:a="http://schemas.openxmlformats.org/drawingml/2006/main">
               <a:ext uri="{FF2B5EF4-FFF2-40B4-BE49-F238E27FC236}">
-                <a16:creationId xmlns:a16="http://schemas.microsoft.com/office/drawing/2014/main" id="{F7FAF426-26EF-456D-B968-7D89C2526CB5}"/>
+                <a16:creationId xmlns:a16="http://schemas.microsoft.com/office/drawing/2014/main" id="{150E63BF-9EF9-49F0-B9ED-31BF6B158B62}"/>
               </a:ext>
             </a:extLst>
           </p:cNvPr>
@@ -7362,7 +7448,7 @@
           <p:cNvPr id="23" name="">
             <a:extLst xmlns:a="http://schemas.openxmlformats.org/drawingml/2006/main">
               <a:ext uri="{FF2B5EF4-FFF2-40B4-BE49-F238E27FC236}">
-                <a16:creationId xmlns:a16="http://schemas.microsoft.com/office/drawing/2014/main" id="{3516630D-C878-46E8-BA43-8AB13E7BFCE8}"/>
+                <a16:creationId xmlns:a16="http://schemas.microsoft.com/office/drawing/2014/main" id="{35047372-19BA-45E1-9325-FDFB06B3AB98}"/>
               </a:ext>
             </a:extLst>
           </p:cNvPr>
@@ -7412,7 +7498,7 @@
           <p:cNvPr id="24" name="">
             <a:extLst xmlns:a="http://schemas.openxmlformats.org/drawingml/2006/main">
               <a:ext uri="{FF2B5EF4-FFF2-40B4-BE49-F238E27FC236}">
-                <a16:creationId xmlns:a16="http://schemas.microsoft.com/office/drawing/2014/main" id="{528B0141-0DA3-422E-9D14-A9ECE0AFE420}"/>
+                <a16:creationId xmlns:a16="http://schemas.microsoft.com/office/drawing/2014/main" id="{6462DB44-A47D-4F09-B380-F7CC3C3FB792}"/>
               </a:ext>
             </a:extLst>
           </p:cNvPr>
@@ -7445,7 +7531,7 @@
           <p:cNvPr id="25" name="">
             <a:extLst xmlns:a="http://schemas.openxmlformats.org/drawingml/2006/main">
               <a:ext uri="{FF2B5EF4-FFF2-40B4-BE49-F238E27FC236}">
-                <a16:creationId xmlns:a16="http://schemas.microsoft.com/office/drawing/2014/main" id="{52D2D3F6-37DE-40B8-9A88-C7389001E549}"/>
+                <a16:creationId xmlns:a16="http://schemas.microsoft.com/office/drawing/2014/main" id="{4EBFE071-D73A-496F-96B5-F0BDD4396795}"/>
               </a:ext>
             </a:extLst>
           </p:cNvPr>
@@ -7485,7 +7571,7 @@
                   <a:srgbClr val="111111"/>
                 </a:solidFill>
               </a:rPr>
-              <a:t>8.054</a:t>
+              <a:t>10.354</a:t>
             </a:r>
           </a:p>
         </p:txBody>
@@ -7495,7 +7581,7 @@
           <p:cNvPr id="26" name="">
             <a:extLst xmlns:a="http://schemas.openxmlformats.org/drawingml/2006/main">
               <a:ext uri="{FF2B5EF4-FFF2-40B4-BE49-F238E27FC236}">
-                <a16:creationId xmlns:a16="http://schemas.microsoft.com/office/drawing/2014/main" id="{FA3CA21F-3657-40A4-B30B-6E2F0DD2684D}"/>
+                <a16:creationId xmlns:a16="http://schemas.microsoft.com/office/drawing/2014/main" id="{768CFAF2-140A-453F-A721-6863E499514A}"/>
               </a:ext>
             </a:extLst>
           </p:cNvPr>
@@ -7528,7 +7614,7 @@
           <p:cNvPr id="27" name="">
             <a:extLst xmlns:a="http://schemas.openxmlformats.org/drawingml/2006/main">
               <a:ext uri="{FF2B5EF4-FFF2-40B4-BE49-F238E27FC236}">
-                <a16:creationId xmlns:a16="http://schemas.microsoft.com/office/drawing/2014/main" id="{2C6CAF04-886C-4A2D-8068-9C7F7FD7073C}"/>
+                <a16:creationId xmlns:a16="http://schemas.microsoft.com/office/drawing/2014/main" id="{B73D9EE4-C102-41F5-B07D-A9C683542307}"/>
               </a:ext>
             </a:extLst>
           </p:cNvPr>
@@ -7578,7 +7664,7 @@
           <p:cNvPr id="28" name="">
             <a:extLst xmlns:a="http://schemas.openxmlformats.org/drawingml/2006/main">
               <a:ext uri="{FF2B5EF4-FFF2-40B4-BE49-F238E27FC236}">
-                <a16:creationId xmlns:a16="http://schemas.microsoft.com/office/drawing/2014/main" id="{C66AEB9A-8179-4D8D-A7AB-7F29884B4C70}"/>
+                <a16:creationId xmlns:a16="http://schemas.microsoft.com/office/drawing/2014/main" id="{CA8A5DC7-9BB9-4337-B6C3-47B056182398}"/>
               </a:ext>
             </a:extLst>
           </p:cNvPr>
@@ -7611,7 +7697,7 @@
           <p:cNvPr id="29" name="">
             <a:extLst xmlns:a="http://schemas.openxmlformats.org/drawingml/2006/main">
               <a:ext uri="{FF2B5EF4-FFF2-40B4-BE49-F238E27FC236}">
-                <a16:creationId xmlns:a16="http://schemas.microsoft.com/office/drawing/2014/main" id="{A81ADD2F-F91D-462A-972A-C91CA2079C68}"/>
+                <a16:creationId xmlns:a16="http://schemas.microsoft.com/office/drawing/2014/main" id="{760754FD-CA2A-4A31-A587-EF121D4CEE5E}"/>
               </a:ext>
             </a:extLst>
           </p:cNvPr>
@@ -7651,7 +7737,7 @@
                   <a:srgbClr val="111111"/>
                 </a:solidFill>
               </a:rPr>
-              <a:t>Data Analyst II, Bay Area - Remote</a:t>
+              <a:t>Data Analyst (US REMOTE)</a:t>
             </a:r>
           </a:p>
         </p:txBody>
@@ -7661,7 +7747,7 @@
           <p:cNvPr id="30" name="">
             <a:extLst xmlns:a="http://schemas.openxmlformats.org/drawingml/2006/main">
               <a:ext uri="{FF2B5EF4-FFF2-40B4-BE49-F238E27FC236}">
-                <a16:creationId xmlns:a16="http://schemas.microsoft.com/office/drawing/2014/main" id="{F947610B-FBD9-4F5A-8162-7B80F16929E5}"/>
+                <a16:creationId xmlns:a16="http://schemas.microsoft.com/office/drawing/2014/main" id="{C1AE1B65-C7BC-4F9A-8009-0FD2D9AB5FEC}"/>
               </a:ext>
             </a:extLst>
           </p:cNvPr>
@@ -7694,7 +7780,7 @@
           <p:cNvPr id="31" name="">
             <a:extLst xmlns:a="http://schemas.openxmlformats.org/drawingml/2006/main">
               <a:ext uri="{FF2B5EF4-FFF2-40B4-BE49-F238E27FC236}">
-                <a16:creationId xmlns:a16="http://schemas.microsoft.com/office/drawing/2014/main" id="{38D10409-1476-4837-9FF8-6C8ECFBDA642}"/>
+                <a16:creationId xmlns:a16="http://schemas.microsoft.com/office/drawing/2014/main" id="{9C5398F8-4D47-4159-B4BB-B5BF4ACE5A2E}"/>
               </a:ext>
             </a:extLst>
           </p:cNvPr>
@@ -7734,7 +7820,7 @@
                   <a:srgbClr val="111111"/>
                 </a:solidFill>
               </a:rPr>
-              <a:t>Astreya</a:t>
+              <a:t>LeanTaaS</a:t>
             </a:r>
           </a:p>
           <a:p xmlns:a="http://schemas.openxmlformats.org/drawingml/2006/main">
@@ -7761,7 +7847,7 @@
           <p:cNvPr id="32" name="">
             <a:extLst xmlns:a="http://schemas.openxmlformats.org/drawingml/2006/main">
               <a:ext uri="{FF2B5EF4-FFF2-40B4-BE49-F238E27FC236}">
-                <a16:creationId xmlns:a16="http://schemas.microsoft.com/office/drawing/2014/main" id="{BC4C1C71-26BB-423E-B1D7-9B1F3AE5FFDA}"/>
+                <a16:creationId xmlns:a16="http://schemas.microsoft.com/office/drawing/2014/main" id="{9C3E8A5E-5DC9-439B-AAD2-2580CCB1BA0A}"/>
               </a:ext>
             </a:extLst>
           </p:cNvPr>
@@ -7794,7 +7880,7 @@
           <p:cNvPr id="33" name="">
             <a:extLst xmlns:a="http://schemas.openxmlformats.org/drawingml/2006/main">
               <a:ext uri="{FF2B5EF4-FFF2-40B4-BE49-F238E27FC236}">
-                <a16:creationId xmlns:a16="http://schemas.microsoft.com/office/drawing/2014/main" id="{16DB1359-A065-460B-8F19-A3C993EF737C}"/>
+                <a16:creationId xmlns:a16="http://schemas.microsoft.com/office/drawing/2014/main" id="{EACEABCD-8A2A-4894-90E5-5E53B373B698}"/>
               </a:ext>
             </a:extLst>
           </p:cNvPr>
@@ -7844,7 +7930,7 @@
           <p:cNvPr id="34" name="">
             <a:extLst xmlns:a="http://schemas.openxmlformats.org/drawingml/2006/main">
               <a:ext uri="{FF2B5EF4-FFF2-40B4-BE49-F238E27FC236}">
-                <a16:creationId xmlns:a16="http://schemas.microsoft.com/office/drawing/2014/main" id="{9F8F9153-8E65-4755-9926-954A22FC6198}"/>
+                <a16:creationId xmlns:a16="http://schemas.microsoft.com/office/drawing/2014/main" id="{AB8F89CD-0E84-4103-BFBC-5CE56459C308}"/>
               </a:ext>
             </a:extLst>
           </p:cNvPr>
@@ -7877,7 +7963,7 @@
           <p:cNvPr id="35" name="">
             <a:extLst xmlns:a="http://schemas.openxmlformats.org/drawingml/2006/main">
               <a:ext uri="{FF2B5EF4-FFF2-40B4-BE49-F238E27FC236}">
-                <a16:creationId xmlns:a16="http://schemas.microsoft.com/office/drawing/2014/main" id="{03836B99-AF26-4DA2-87C4-8BC618107B9A}"/>
+                <a16:creationId xmlns:a16="http://schemas.microsoft.com/office/drawing/2014/main" id="{93FBDEBA-D41F-40E9-B538-9DE4C42524CA}"/>
               </a:ext>
             </a:extLst>
           </p:cNvPr>
@@ -7917,7 +8003,7 @@
                   <a:srgbClr val="111111"/>
                 </a:solidFill>
               </a:rPr>
-              <a:t>7.951</a:t>
+              <a:t>9.158</a:t>
             </a:r>
           </a:p>
         </p:txBody>
@@ -7927,7 +8013,7 @@
           <p:cNvPr id="36" name="">
             <a:extLst xmlns:a="http://schemas.openxmlformats.org/drawingml/2006/main">
               <a:ext uri="{FF2B5EF4-FFF2-40B4-BE49-F238E27FC236}">
-                <a16:creationId xmlns:a16="http://schemas.microsoft.com/office/drawing/2014/main" id="{759A7A0F-7B01-4646-8FB9-0BFCC1ADA910}"/>
+                <a16:creationId xmlns:a16="http://schemas.microsoft.com/office/drawing/2014/main" id="{A2C36496-EAC4-406D-A47F-F03ACF7A867B}"/>
               </a:ext>
             </a:extLst>
           </p:cNvPr>
@@ -7960,7 +8046,7 @@
           <p:cNvPr id="37" name="">
             <a:extLst xmlns:a="http://schemas.openxmlformats.org/drawingml/2006/main">
               <a:ext uri="{FF2B5EF4-FFF2-40B4-BE49-F238E27FC236}">
-                <a16:creationId xmlns:a16="http://schemas.microsoft.com/office/drawing/2014/main" id="{2D34F7F0-DF7E-424D-ABAD-38EC70D86700}"/>
+                <a16:creationId xmlns:a16="http://schemas.microsoft.com/office/drawing/2014/main" id="{2B1E9E2D-4EF6-47FF-8C59-EDA63B686047}"/>
               </a:ext>
             </a:extLst>
           </p:cNvPr>
@@ -8010,7 +8096,7 @@
           <p:cNvPr id="38" name="">
             <a:extLst xmlns:a="http://schemas.openxmlformats.org/drawingml/2006/main">
               <a:ext uri="{FF2B5EF4-FFF2-40B4-BE49-F238E27FC236}">
-                <a16:creationId xmlns:a16="http://schemas.microsoft.com/office/drawing/2014/main" id="{CCF619ED-2654-44E7-9E1F-7F256DD26AD1}"/>
+                <a16:creationId xmlns:a16="http://schemas.microsoft.com/office/drawing/2014/main" id="{6CA39D05-CCCE-4D83-9F5D-424CCC2ADFED}"/>
               </a:ext>
             </a:extLst>
           </p:cNvPr>
@@ -8043,7 +8129,7 @@
           <p:cNvPr id="39" name="">
             <a:extLst xmlns:a="http://schemas.openxmlformats.org/drawingml/2006/main">
               <a:ext uri="{FF2B5EF4-FFF2-40B4-BE49-F238E27FC236}">
-                <a16:creationId xmlns:a16="http://schemas.microsoft.com/office/drawing/2014/main" id="{5ADAA06B-2212-4F03-AF48-2FF964F5FBF5}"/>
+                <a16:creationId xmlns:a16="http://schemas.microsoft.com/office/drawing/2014/main" id="{32113481-C7B9-4CBD-A5C9-750C9C1C49C6}"/>
               </a:ext>
             </a:extLst>
           </p:cNvPr>
@@ -8083,7 +8169,7 @@
                   <a:srgbClr val="111111"/>
                 </a:solidFill>
               </a:rPr>
-              <a:t>Data Analyst (US REMOTE)</a:t>
+              <a:t>Data Analyst</a:t>
             </a:r>
           </a:p>
         </p:txBody>
@@ -8093,7 +8179,7 @@
           <p:cNvPr id="40" name="">
             <a:extLst xmlns:a="http://schemas.openxmlformats.org/drawingml/2006/main">
               <a:ext uri="{FF2B5EF4-FFF2-40B4-BE49-F238E27FC236}">
-                <a16:creationId xmlns:a16="http://schemas.microsoft.com/office/drawing/2014/main" id="{7E495924-CB24-41B4-937D-8C7EE3C2ED72}"/>
+                <a16:creationId xmlns:a16="http://schemas.microsoft.com/office/drawing/2014/main" id="{1C2F4C89-A304-4CC3-8AB8-AB1E8AAAD81F}"/>
               </a:ext>
             </a:extLst>
           </p:cNvPr>
@@ -8126,7 +8212,7 @@
           <p:cNvPr id="41" name="">
             <a:extLst xmlns:a="http://schemas.openxmlformats.org/drawingml/2006/main">
               <a:ext uri="{FF2B5EF4-FFF2-40B4-BE49-F238E27FC236}">
-                <a16:creationId xmlns:a16="http://schemas.microsoft.com/office/drawing/2014/main" id="{6B401759-73F6-42FD-800D-948A1E352ACB}"/>
+                <a16:creationId xmlns:a16="http://schemas.microsoft.com/office/drawing/2014/main" id="{44A17864-D7B8-46B2-BD1B-9F5B678A4C4D}"/>
               </a:ext>
             </a:extLst>
           </p:cNvPr>
@@ -8166,7 +8252,7 @@
                   <a:srgbClr val="111111"/>
                 </a:solidFill>
               </a:rPr>
-              <a:t>LeanTaaS</a:t>
+              <a:t>HMP Global</a:t>
             </a:r>
           </a:p>
           <a:p xmlns:a="http://schemas.openxmlformats.org/drawingml/2006/main">
@@ -8193,7 +8279,7 @@
           <p:cNvPr id="42" name="">
             <a:extLst xmlns:a="http://schemas.openxmlformats.org/drawingml/2006/main">
               <a:ext uri="{FF2B5EF4-FFF2-40B4-BE49-F238E27FC236}">
-                <a16:creationId xmlns:a16="http://schemas.microsoft.com/office/drawing/2014/main" id="{F828D82B-A823-45C3-B3B3-2DDE45C251AB}"/>
+                <a16:creationId xmlns:a16="http://schemas.microsoft.com/office/drawing/2014/main" id="{C86D608E-A024-43EF-BAE8-CA436E6A722F}"/>
               </a:ext>
             </a:extLst>
           </p:cNvPr>
@@ -8226,7 +8312,7 @@
           <p:cNvPr id="43" name="">
             <a:extLst xmlns:a="http://schemas.openxmlformats.org/drawingml/2006/main">
               <a:ext uri="{FF2B5EF4-FFF2-40B4-BE49-F238E27FC236}">
-                <a16:creationId xmlns:a16="http://schemas.microsoft.com/office/drawing/2014/main" id="{53684B6F-555E-4C3E-B38F-C7E3B4EBB114}"/>
+                <a16:creationId xmlns:a16="http://schemas.microsoft.com/office/drawing/2014/main" id="{FD691030-AB99-4D07-8EB5-02E6BF20BF84}"/>
               </a:ext>
             </a:extLst>
           </p:cNvPr>
@@ -8276,7 +8362,7 @@
           <p:cNvPr id="44" name="">
             <a:extLst xmlns:a="http://schemas.openxmlformats.org/drawingml/2006/main">
               <a:ext uri="{FF2B5EF4-FFF2-40B4-BE49-F238E27FC236}">
-                <a16:creationId xmlns:a16="http://schemas.microsoft.com/office/drawing/2014/main" id="{E7C0CA16-D052-4197-AAF7-C7E88A4470E5}"/>
+                <a16:creationId xmlns:a16="http://schemas.microsoft.com/office/drawing/2014/main" id="{35911699-E479-429D-BE7E-99D1D3AD7832}"/>
               </a:ext>
             </a:extLst>
           </p:cNvPr>
@@ -8309,7 +8395,7 @@
           <p:cNvPr id="45" name="">
             <a:extLst xmlns:a="http://schemas.openxmlformats.org/drawingml/2006/main">
               <a:ext uri="{FF2B5EF4-FFF2-40B4-BE49-F238E27FC236}">
-                <a16:creationId xmlns:a16="http://schemas.microsoft.com/office/drawing/2014/main" id="{20A9EF8E-2EDA-448F-A3E4-AAD80118CF21}"/>
+                <a16:creationId xmlns:a16="http://schemas.microsoft.com/office/drawing/2014/main" id="{EE10746D-6386-48A9-9D55-437ECFDABBB7}"/>
               </a:ext>
             </a:extLst>
           </p:cNvPr>
@@ -8349,7 +8435,7 @@
                   <a:srgbClr val="111111"/>
                 </a:solidFill>
               </a:rPr>
-              <a:t>6.858</a:t>
+              <a:t>9.055</a:t>
             </a:r>
           </a:p>
         </p:txBody>
@@ -8359,7 +8445,7 @@
           <p:cNvPr id="46" name="">
             <a:extLst xmlns:a="http://schemas.openxmlformats.org/drawingml/2006/main">
               <a:ext uri="{FF2B5EF4-FFF2-40B4-BE49-F238E27FC236}">
-                <a16:creationId xmlns:a16="http://schemas.microsoft.com/office/drawing/2014/main" id="{4A8FCCC4-4BB3-4F5B-86C5-B3C435D70BD2}"/>
+                <a16:creationId xmlns:a16="http://schemas.microsoft.com/office/drawing/2014/main" id="{2C8E307A-0047-480C-BEC0-A31B31936764}"/>
               </a:ext>
             </a:extLst>
           </p:cNvPr>
@@ -8371,35 +8457,35 @@
         <p:spPr>
           <a:xfrm xmlns:a="http://schemas.openxmlformats.org/drawingml/2006/main">
             <a:off x="419100" y="5219700"/>
-            <a:ext cx="8382000" cy="400050"/>
-          </a:xfrm>
-          <a:prstGeom xmlns:a="http://schemas.openxmlformats.org/drawingml/2006/main" prst="rect">
-            <a:avLst/>
-          </a:prstGeom>
-          <a:noFill xmlns:a="http://schemas.openxmlformats.org/drawingml/2006/main"/>
-          <a:ln xmlns:a="http://schemas.openxmlformats.org/drawingml/2006/main" w="0">
-            <a:noFill/>
-            <a:prstDash val="solid"/>
-          </a:ln>
-        </p:spPr>
-        <p:txBody>
-          <a:bodyPr xmlns:a="http://schemas.openxmlformats.org/drawingml/2006/main" anchor="t"/>
-          <a:lstStyle xmlns:a="http://schemas.openxmlformats.org/drawingml/2006/main"/>
-          <a:p xmlns:a="http://schemas.openxmlformats.org/drawingml/2006/main">
-            <a:pPr algn="l">
-              <a:defRPr sz="2100" b="1">
-                <a:solidFill>
-                  <a:srgbClr val="111111"/>
-                </a:solidFill>
-              </a:defRPr>
-            </a:pPr>
-            <a:r>
-              <a:rPr sz="2100" b="1">
-                <a:solidFill>
-                  <a:srgbClr val="111111"/>
-                </a:solidFill>
-              </a:rPr>
-              <a:t>Review 6 retrieved postings first; they have analytics role-fit signals.</a:t>
+            <a:ext cx="10287000" cy="400050"/>
+          </a:xfrm>
+          <a:prstGeom xmlns:a="http://schemas.openxmlformats.org/drawingml/2006/main" prst="rect">
+            <a:avLst/>
+          </a:prstGeom>
+          <a:noFill xmlns:a="http://schemas.openxmlformats.org/drawingml/2006/main"/>
+          <a:ln xmlns:a="http://schemas.openxmlformats.org/drawingml/2006/main" w="0">
+            <a:noFill/>
+            <a:prstDash val="solid"/>
+          </a:ln>
+        </p:spPr>
+        <p:txBody>
+          <a:bodyPr xmlns:a="http://schemas.openxmlformats.org/drawingml/2006/main" anchor="t"/>
+          <a:lstStyle xmlns:a="http://schemas.openxmlformats.org/drawingml/2006/main"/>
+          <a:p xmlns:a="http://schemas.openxmlformats.org/drawingml/2006/main">
+            <a:pPr algn="l">
+              <a:defRPr sz="1875" b="1">
+                <a:solidFill>
+                  <a:srgbClr val="111111"/>
+                </a:solidFill>
+              </a:defRPr>
+            </a:pPr>
+            <a:r>
+              <a:rPr sz="1875" b="1">
+                <a:solidFill>
+                  <a:srgbClr val="111111"/>
+                </a:solidFill>
+              </a:rPr>
+              <a:t>Review six retrieved postings; the top five satisfy the US constraint.</a:t>
             </a:r>
           </a:p>
         </p:txBody>
@@ -8409,42 +8495,42 @@
           <p:cNvPr id="47" name="">
             <a:extLst xmlns:a="http://schemas.openxmlformats.org/drawingml/2006/main">
               <a:ext uri="{FF2B5EF4-FFF2-40B4-BE49-F238E27FC236}">
-                <a16:creationId xmlns:a16="http://schemas.microsoft.com/office/drawing/2014/main" id="{F16D78D9-2958-474A-8030-D557E436712D}"/>
-              </a:ext>
-            </a:extLst>
-          </p:cNvPr>
-          <p:cNvSpPr>
-            <a:spLocks xmlns:a="http://schemas.openxmlformats.org/drawingml/2006/main" noGrp="1"/>
-          </p:cNvSpPr>
-          <p:nvPr/>
-        </p:nvSpPr>
-        <p:spPr>
-          <a:xfrm xmlns:a="http://schemas.openxmlformats.org/drawingml/2006/main">
-            <a:off x="419100" y="5772150"/>
-            <a:ext cx="8763000" cy="323850"/>
-          </a:xfrm>
-          <a:prstGeom xmlns:a="http://schemas.openxmlformats.org/drawingml/2006/main" prst="rect">
-            <a:avLst/>
-          </a:prstGeom>
-          <a:noFill xmlns:a="http://schemas.openxmlformats.org/drawingml/2006/main"/>
-          <a:ln xmlns:a="http://schemas.openxmlformats.org/drawingml/2006/main" w="0">
-            <a:noFill/>
-            <a:prstDash val="solid"/>
-          </a:ln>
-        </p:spPr>
-        <p:txBody>
-          <a:bodyPr xmlns:a="http://schemas.openxmlformats.org/drawingml/2006/main" anchor="t"/>
-          <a:lstStyle xmlns:a="http://schemas.openxmlformats.org/drawingml/2006/main"/>
-          <a:p xmlns:a="http://schemas.openxmlformats.org/drawingml/2006/main">
-            <a:pPr algn="l">
-              <a:defRPr sz="1650" b="0">
+                <a16:creationId xmlns:a16="http://schemas.microsoft.com/office/drawing/2014/main" id="{6521F736-26DD-4422-A73E-DBCC93A676A8}"/>
+              </a:ext>
+            </a:extLst>
+          </p:cNvPr>
+          <p:cNvSpPr>
+            <a:spLocks xmlns:a="http://schemas.openxmlformats.org/drawingml/2006/main" noGrp="1"/>
+          </p:cNvSpPr>
+          <p:nvPr/>
+        </p:nvSpPr>
+        <p:spPr>
+          <a:xfrm xmlns:a="http://schemas.openxmlformats.org/drawingml/2006/main">
+            <a:off x="419100" y="5734050"/>
+            <a:ext cx="10287000" cy="285750"/>
+          </a:xfrm>
+          <a:prstGeom xmlns:a="http://schemas.openxmlformats.org/drawingml/2006/main" prst="rect">
+            <a:avLst/>
+          </a:prstGeom>
+          <a:noFill xmlns:a="http://schemas.openxmlformats.org/drawingml/2006/main"/>
+          <a:ln xmlns:a="http://schemas.openxmlformats.org/drawingml/2006/main" w="0">
+            <a:noFill/>
+            <a:prstDash val="solid"/>
+          </a:ln>
+        </p:spPr>
+        <p:txBody>
+          <a:bodyPr xmlns:a="http://schemas.openxmlformats.org/drawingml/2006/main" anchor="t"/>
+          <a:lstStyle xmlns:a="http://schemas.openxmlformats.org/drawingml/2006/main"/>
+          <a:p xmlns:a="http://schemas.openxmlformats.org/drawingml/2006/main">
+            <a:pPr algn="l">
+              <a:defRPr sz="1500" b="0">
                 <a:solidFill>
                   <a:srgbClr val="D6532F"/>
                 </a:solidFill>
               </a:defRPr>
             </a:pPr>
             <a:r>
-              <a:rPr sz="1650" b="0">
+              <a:rPr sz="1500" b="0">
                 <a:solidFill>
                   <a:srgbClr val="D6532F"/>
                 </a:solidFill>
@@ -8457,7 +8543,7 @@
     </p:spTree>
     <p:extLst>
       <p:ext uri="{BB962C8B-B14F-4D97-AF65-F5344CB8AC3E}">
-        <p14:creationId xmlns:p14="http://schemas.microsoft.com/office/powerpoint/2010/main" val="1924693377"/>
+        <p14:creationId xmlns:p14="http://schemas.microsoft.com/office/powerpoint/2010/main" val="2061116944"/>
       </p:ext>
     </p:extLst>
   </p:cSld>
@@ -8488,7 +8574,7 @@
           <p:cNvPr id="19" name="slide-7-title">
             <a:extLst xmlns:a="http://schemas.openxmlformats.org/drawingml/2006/main">
               <a:ext uri="{FF2B5EF4-FFF2-40B4-BE49-F238E27FC236}">
-                <a16:creationId xmlns:a16="http://schemas.microsoft.com/office/drawing/2014/main" id="{77C39304-72ED-4124-B3DF-B8348607927A}"/>
+                <a16:creationId xmlns:a16="http://schemas.microsoft.com/office/drawing/2014/main" id="{D19FCEC4-0F9D-4633-A95F-C0744677B18A}"/>
               </a:ext>
             </a:extLst>
           </p:cNvPr>
@@ -8538,7 +8624,7 @@
           <p:cNvPr id="2" name="">
             <a:extLst xmlns:a="http://schemas.openxmlformats.org/drawingml/2006/main">
               <a:ext uri="{FF2B5EF4-FFF2-40B4-BE49-F238E27FC236}">
-                <a16:creationId xmlns:a16="http://schemas.microsoft.com/office/drawing/2014/main" id="{77215985-1892-4272-8651-70B9C4BC3A78}"/>
+                <a16:creationId xmlns:a16="http://schemas.microsoft.com/office/drawing/2014/main" id="{F057A5F3-8BA1-499E-8FAE-400EFE7516C3}"/>
               </a:ext>
             </a:extLst>
           </p:cNvPr>
@@ -8610,7 +8696,7 @@
           <p:cNvPr id="4" name="">
             <a:extLst xmlns:a="http://schemas.openxmlformats.org/drawingml/2006/main">
               <a:ext uri="{FF2B5EF4-FFF2-40B4-BE49-F238E27FC236}">
-                <a16:creationId xmlns:a16="http://schemas.microsoft.com/office/drawing/2014/main" id="{B1673341-A1B5-4153-8DC1-30D91A1E1BC4}"/>
+                <a16:creationId xmlns:a16="http://schemas.microsoft.com/office/drawing/2014/main" id="{DD8AD1A9-AC9A-47DC-899E-990AE65033BB}"/>
               </a:ext>
             </a:extLst>
           </p:cNvPr>
@@ -8650,7 +8736,7 @@
                   <a:srgbClr val="565D67"/>
                 </a:solidFill>
               </a:rPr>
-              <a:t>ENTRY LEVEL ANALYTICS</a:t>
+              <a:t>ENTRY LEVEL ANALYTICS SEARCH</a:t>
             </a:r>
           </a:p>
         </p:txBody>
@@ -8660,7 +8746,7 @@
           <p:cNvPr id="5" name="">
             <a:extLst xmlns:a="http://schemas.openxmlformats.org/drawingml/2006/main">
               <a:ext uri="{FF2B5EF4-FFF2-40B4-BE49-F238E27FC236}">
-                <a16:creationId xmlns:a16="http://schemas.microsoft.com/office/drawing/2014/main" id="{687C7D0C-4079-49D5-85E5-9395A6732EA9}"/>
+                <a16:creationId xmlns:a16="http://schemas.microsoft.com/office/drawing/2014/main" id="{B3302A70-31DD-4E73-A2A3-481EBDE81C54}"/>
               </a:ext>
             </a:extLst>
           </p:cNvPr>
@@ -8700,7 +8786,7 @@
                   <a:srgbClr val="3D8DFF"/>
                 </a:solidFill>
               </a:rPr>
-              <a:t>high_fit</a:t>
+              <a:t>search results</a:t>
             </a:r>
           </a:p>
         </p:txBody>
@@ -8710,7 +8796,7 @@
           <p:cNvPr id="6" name="">
             <a:extLst xmlns:a="http://schemas.openxmlformats.org/drawingml/2006/main">
               <a:ext uri="{FF2B5EF4-FFF2-40B4-BE49-F238E27FC236}">
-                <a16:creationId xmlns:a16="http://schemas.microsoft.com/office/drawing/2014/main" id="{D01F5FDB-E3C7-4509-BEE4-4A7279FAE344}"/>
+                <a16:creationId xmlns:a16="http://schemas.microsoft.com/office/drawing/2014/main" id="{F3109820-A5E4-4CEB-9BBF-14671CB1149D}"/>
               </a:ext>
             </a:extLst>
           </p:cNvPr>
@@ -8750,7 +8836,7 @@
                   <a:srgbClr val="111111"/>
                 </a:solidFill>
               </a:rPr>
-              <a:t>Forward candidates after advisor review</a:t>
+              <a:t>Find US analytics opportunities for advisor review</a:t>
             </a:r>
           </a:p>
         </p:txBody>
@@ -8782,7 +8868,7 @@
           <p:cNvPr id="8" name="">
             <a:extLst xmlns:a="http://schemas.openxmlformats.org/drawingml/2006/main">
               <a:ext uri="{FF2B5EF4-FFF2-40B4-BE49-F238E27FC236}">
-                <a16:creationId xmlns:a16="http://schemas.microsoft.com/office/drawing/2014/main" id="{23119F57-C856-4E83-80F6-3A699E27B47E}"/>
+                <a16:creationId xmlns:a16="http://schemas.microsoft.com/office/drawing/2014/main" id="{EE9428C4-2031-416F-8ADE-115EF5DD5380}"/>
               </a:ext>
             </a:extLst>
           </p:cNvPr>
@@ -8822,7 +8908,7 @@
                   <a:srgbClr val="565D67"/>
                 </a:solidFill>
               </a:rPr>
-              <a:t>SENIOR ENGINEERING FILTER</a:t>
+              <a:t>SENIOR ENGINEERING POSTING</a:t>
             </a:r>
           </a:p>
         </p:txBody>
@@ -8832,7 +8918,7 @@
           <p:cNvPr id="9" name="">
             <a:extLst xmlns:a="http://schemas.openxmlformats.org/drawingml/2006/main">
               <a:ext uri="{FF2B5EF4-FFF2-40B4-BE49-F238E27FC236}">
-                <a16:creationId xmlns:a16="http://schemas.microsoft.com/office/drawing/2014/main" id="{66182E44-3F55-42F3-B030-907736A451F8}"/>
+                <a16:creationId xmlns:a16="http://schemas.microsoft.com/office/drawing/2014/main" id="{83F2A096-0D5A-4B9A-8C5F-704A7B660ACA}"/>
               </a:ext>
             </a:extLst>
           </p:cNvPr>
@@ -8882,7 +8968,7 @@
           <p:cNvPr id="10" name="">
             <a:extLst xmlns:a="http://schemas.openxmlformats.org/drawingml/2006/main">
               <a:ext uri="{FF2B5EF4-FFF2-40B4-BE49-F238E27FC236}">
-                <a16:creationId xmlns:a16="http://schemas.microsoft.com/office/drawing/2014/main" id="{1750DAC7-0DBB-490E-8B8E-22224DAB3C7B}"/>
+                <a16:creationId xmlns:a16="http://schemas.microsoft.com/office/drawing/2014/main" id="{D67F64D4-ECC0-468A-8FCC-3E3EBF574525}"/>
               </a:ext>
             </a:extLst>
           </p:cNvPr>
@@ -8922,7 +9008,7 @@
                   <a:srgbClr val="111111"/>
                 </a:solidFill>
               </a:rPr>
-              <a:t>Hold a role that is too senior or engineering-heavy</a:t>
+              <a:t>Hold a role that is too senior and engineering-heavy</a:t>
             </a:r>
           </a:p>
         </p:txBody>
@@ -8954,7 +9040,7 @@
           <p:cNvPr id="12" name="">
             <a:extLst xmlns:a="http://schemas.openxmlformats.org/drawingml/2006/main">
               <a:ext uri="{FF2B5EF4-FFF2-40B4-BE49-F238E27FC236}">
-                <a16:creationId xmlns:a16="http://schemas.microsoft.com/office/drawing/2014/main" id="{98D79FC4-B9D7-4FF6-8F15-F4C4C5A9B89D}"/>
+                <a16:creationId xmlns:a16="http://schemas.microsoft.com/office/drawing/2014/main" id="{9C0D9F7D-8916-409D-96FC-83D1C178F4DE}"/>
               </a:ext>
             </a:extLst>
           </p:cNvPr>
@@ -8994,7 +9080,7 @@
                   <a:srgbClr val="565D67"/>
                 </a:solidFill>
               </a:rPr>
-              <a:t>AUTHORIZATION MISSING</a:t>
+              <a:t>AUTHORIZATION RESTRICTION POSTING</a:t>
             </a:r>
           </a:p>
         </p:txBody>
@@ -9004,7 +9090,7 @@
           <p:cNvPr id="13" name="">
             <a:extLst xmlns:a="http://schemas.openxmlformats.org/drawingml/2006/main">
               <a:ext uri="{FF2B5EF4-FFF2-40B4-BE49-F238E27FC236}">
-                <a16:creationId xmlns:a16="http://schemas.microsoft.com/office/drawing/2014/main" id="{9BEAFFAB-C32F-4253-BB91-0B2A19D3DA29}"/>
+                <a16:creationId xmlns:a16="http://schemas.microsoft.com/office/drawing/2014/main" id="{AB3F124F-5A63-44F4-AD73-1110441A79FD}"/>
               </a:ext>
             </a:extLst>
           </p:cNvPr>
@@ -9044,7 +9130,7 @@
                   <a:srgbClr val="D6532F"/>
                 </a:solidFill>
               </a:rPr>
-              <a:t>unclear</a:t>
+              <a:t>high_fit</a:t>
             </a:r>
           </a:p>
         </p:txBody>
@@ -9054,7 +9140,7 @@
           <p:cNvPr id="14" name="">
             <a:extLst xmlns:a="http://schemas.openxmlformats.org/drawingml/2006/main">
               <a:ext uri="{FF2B5EF4-FFF2-40B4-BE49-F238E27FC236}">
-                <a16:creationId xmlns:a16="http://schemas.microsoft.com/office/drawing/2014/main" id="{62814329-D4D5-4566-B28A-6DAB694F4072}"/>
+                <a16:creationId xmlns:a16="http://schemas.microsoft.com/office/drawing/2014/main" id="{F9AA18F8-DDF7-40C0-AC41-2787DC4D5FAB}"/>
               </a:ext>
             </a:extLst>
           </p:cNvPr>
@@ -9094,7 +9180,7 @@
                   <a:srgbClr val="111111"/>
                 </a:solidFill>
               </a:rPr>
-              <a:t>Explicit negative authorization text surfaced</a:t>
+              <a:t>High role fit, but No OPT/CPT forces Hold</a:t>
             </a:r>
           </a:p>
         </p:txBody>
@@ -9126,7 +9212,7 @@
           <p:cNvPr id="16" name="">
             <a:extLst xmlns:a="http://schemas.openxmlformats.org/drawingml/2006/main">
               <a:ext uri="{FF2B5EF4-FFF2-40B4-BE49-F238E27FC236}">
-                <a16:creationId xmlns:a16="http://schemas.microsoft.com/office/drawing/2014/main" id="{3F008F79-B6EF-456A-A768-0C0B134EDB8C}"/>
+                <a16:creationId xmlns:a16="http://schemas.microsoft.com/office/drawing/2014/main" id="{629FD184-5BFA-4FA9-BF6C-F165EF59883F}"/>
               </a:ext>
             </a:extLst>
           </p:cNvPr>
@@ -9166,7 +9252,7 @@
                   <a:srgbClr val="565D67"/>
                 </a:solidFill>
               </a:rPr>
-              <a:t>THIN METADATA</a:t>
+              <a:t>THIN METADATA POSTING</a:t>
             </a:r>
           </a:p>
         </p:txBody>
@@ -9176,7 +9262,7 @@
           <p:cNvPr id="17" name="">
             <a:extLst xmlns:a="http://schemas.openxmlformats.org/drawingml/2006/main">
               <a:ext uri="{FF2B5EF4-FFF2-40B4-BE49-F238E27FC236}">
-                <a16:creationId xmlns:a16="http://schemas.microsoft.com/office/drawing/2014/main" id="{FEF80B56-BE82-4C10-98F2-9B6E6002FCC2}"/>
+                <a16:creationId xmlns:a16="http://schemas.microsoft.com/office/drawing/2014/main" id="{EB858D6C-EDA1-4D10-B6D6-0E626019701A}"/>
               </a:ext>
             </a:extLst>
           </p:cNvPr>
@@ -9226,7 +9312,7 @@
           <p:cNvPr id="18" name="">
             <a:extLst xmlns:a="http://schemas.openxmlformats.org/drawingml/2006/main">
               <a:ext uri="{FF2B5EF4-FFF2-40B4-BE49-F238E27FC236}">
-                <a16:creationId xmlns:a16="http://schemas.microsoft.com/office/drawing/2014/main" id="{4D5EEF72-68DD-49A4-85CA-F8DFD3A4250C}"/>
+                <a16:creationId xmlns:a16="http://schemas.microsoft.com/office/drawing/2014/main" id="{1387D6BA-AD2D-4CFF-A1EC-84BD1F76861B}"/>
               </a:ext>
             </a:extLst>
           </p:cNvPr>
@@ -9266,7 +9352,7 @@
                   <a:srgbClr val="111111"/>
                 </a:solidFill>
               </a:rPr>
-              <a:t>Investigate an incomplete posting</a:t>
+              <a:t>Missing fields override medium_fit to unclear</a:t>
             </a:r>
           </a:p>
         </p:txBody>
@@ -9274,7 +9360,7 @@
     </p:spTree>
     <p:extLst>
       <p:ext uri="{BB962C8B-B14F-4D97-AF65-F5344CB8AC3E}">
-        <p14:creationId xmlns:p14="http://schemas.microsoft.com/office/powerpoint/2010/main" val="1019538054"/>
+        <p14:creationId xmlns:p14="http://schemas.microsoft.com/office/powerpoint/2010/main" val="356985590"/>
       </p:ext>
     </p:extLst>
   </p:cSld>
@@ -9305,7 +9391,7 @@
           <p:cNvPr id="14" name="slide-8-title">
             <a:extLst xmlns:a="http://schemas.openxmlformats.org/drawingml/2006/main">
               <a:ext uri="{FF2B5EF4-FFF2-40B4-BE49-F238E27FC236}">
-                <a16:creationId xmlns:a16="http://schemas.microsoft.com/office/drawing/2014/main" id="{52272796-226E-47BC-8019-F572EE0708A2}"/>
+                <a16:creationId xmlns:a16="http://schemas.microsoft.com/office/drawing/2014/main" id="{C905B53E-E832-4723-9413-672F3E4F6DC7}"/>
               </a:ext>
             </a:extLst>
           </p:cNvPr>
@@ -9345,7 +9431,7 @@
                   <a:srgbClr val="111111"/>
                 </a:solidFill>
               </a:rPr>
-              <a:t>The final system preserves quality and adds evidence</a:t>
+              <a:t>Using all training data beats extra model complexity</a:t>
             </a:r>
           </a:p>
         </p:txBody>
@@ -9355,7 +9441,7 @@
           <p:cNvPr id="2" name="">
             <a:extLst xmlns:a="http://schemas.openxmlformats.org/drawingml/2006/main">
               <a:ext uri="{FF2B5EF4-FFF2-40B4-BE49-F238E27FC236}">
-                <a16:creationId xmlns:a16="http://schemas.microsoft.com/office/drawing/2014/main" id="{5443900C-F7FF-478B-8709-BE53168D5E66}"/>
+                <a16:creationId xmlns:a16="http://schemas.microsoft.com/office/drawing/2014/main" id="{F4E22397-367B-467A-99F4-5C38E2FE2F34}"/>
               </a:ext>
             </a:extLst>
           </p:cNvPr>
@@ -9412,7 +9498,7 @@
         </p:xfrm>
         <a:graphic xmlns:a="http://schemas.openxmlformats.org/drawingml/2006/main">
           <a:graphicData uri="http://schemas.openxmlformats.org/drawingml/2006/chart">
-            <c:chart xmlns:r="http://schemas.openxmlformats.org/officeDocument/2006/relationships" xmlns:c="http://schemas.openxmlformats.org/drawingml/2006/chart" r:id="Rcdd730942fdf479c"/>
+            <c:chart xmlns:r="http://schemas.openxmlformats.org/officeDocument/2006/relationships" xmlns:c="http://schemas.openxmlformats.org/drawingml/2006/chart" r:id="R40cbc99ce91947df"/>
           </a:graphicData>
         </a:graphic>
       </p:graphicFrame>
@@ -9421,7 +9507,7 @@
           <p:cNvPr id="4" name="">
             <a:extLst xmlns:a="http://schemas.openxmlformats.org/drawingml/2006/main">
               <a:ext uri="{FF2B5EF4-FFF2-40B4-BE49-F238E27FC236}">
-                <a16:creationId xmlns:a16="http://schemas.microsoft.com/office/drawing/2014/main" id="{5679E961-2D1C-43D9-98B4-737398B0FB06}"/>
+                <a16:creationId xmlns:a16="http://schemas.microsoft.com/office/drawing/2014/main" id="{9B802365-1FB2-431D-B7AF-42EB6833B55B}"/>
               </a:ext>
             </a:extLst>
           </p:cNvPr>
@@ -9452,7 +9538,7 @@
           <p:cNvPr id="5" name="">
             <a:extLst xmlns:a="http://schemas.openxmlformats.org/drawingml/2006/main">
               <a:ext uri="{FF2B5EF4-FFF2-40B4-BE49-F238E27FC236}">
-                <a16:creationId xmlns:a16="http://schemas.microsoft.com/office/drawing/2014/main" id="{0C75200B-A18D-4C6A-AF9E-3EE828AEC0DF}"/>
+                <a16:creationId xmlns:a16="http://schemas.microsoft.com/office/drawing/2014/main" id="{83D9AF8B-10DC-443F-B28C-7669334B24C7}"/>
               </a:ext>
             </a:extLst>
           </p:cNvPr>
@@ -9492,7 +9578,7 @@
                   <a:srgbClr val="3D8DFF"/>
                 </a:solidFill>
               </a:rPr>
-              <a:t>80.1%</a:t>
+              <a:t>98.4%</a:t>
             </a:r>
           </a:p>
         </p:txBody>
@@ -9502,7 +9588,7 @@
           <p:cNvPr id="6" name="">
             <a:extLst xmlns:a="http://schemas.openxmlformats.org/drawingml/2006/main">
               <a:ext uri="{FF2B5EF4-FFF2-40B4-BE49-F238E27FC236}">
-                <a16:creationId xmlns:a16="http://schemas.microsoft.com/office/drawing/2014/main" id="{2235FC3B-CA98-4006-9AC2-45FFEC2F1FDD}"/>
+                <a16:creationId xmlns:a16="http://schemas.microsoft.com/office/drawing/2014/main" id="{28EAB564-E470-49E3-9BCD-C626B75440C1}"/>
               </a:ext>
             </a:extLst>
           </p:cNvPr>
@@ -9542,7 +9628,7 @@
                   <a:srgbClr val="111111"/>
                 </a:solidFill>
               </a:rPr>
-              <a:t>final macro F1</a:t>
+              <a:t>fixed-set macro F1</a:t>
             </a:r>
           </a:p>
         </p:txBody>
@@ -9552,7 +9638,7 @@
           <p:cNvPr id="7" name="">
             <a:extLst xmlns:a="http://schemas.openxmlformats.org/drawingml/2006/main">
               <a:ext uri="{FF2B5EF4-FFF2-40B4-BE49-F238E27FC236}">
-                <a16:creationId xmlns:a16="http://schemas.microsoft.com/office/drawing/2014/main" id="{B921EDE7-89D9-428D-A31E-4A5372F434C7}"/>
+                <a16:creationId xmlns:a16="http://schemas.microsoft.com/office/drawing/2014/main" id="{378FDB4C-BA91-41C3-9B2F-6F3050222024}"/>
               </a:ext>
             </a:extLst>
           </p:cNvPr>
@@ -9583,7 +9669,7 @@
           <p:cNvPr id="8" name="">
             <a:extLst xmlns:a="http://schemas.openxmlformats.org/drawingml/2006/main">
               <a:ext uri="{FF2B5EF4-FFF2-40B4-BE49-F238E27FC236}">
-                <a16:creationId xmlns:a16="http://schemas.microsoft.com/office/drawing/2014/main" id="{2151000E-714C-4022-B626-F17A6CF51696}"/>
+                <a16:creationId xmlns:a16="http://schemas.microsoft.com/office/drawing/2014/main" id="{600EC2F6-2173-4C50-B983-C8A562C06EE6}"/>
               </a:ext>
             </a:extLst>
           </p:cNvPr>
@@ -9623,7 +9709,7 @@
                   <a:srgbClr val="3D8DFF"/>
                 </a:solidFill>
               </a:rPr>
-              <a:t>90.0%</a:t>
+              <a:t>97.9%</a:t>
             </a:r>
           </a:p>
         </p:txBody>
@@ -9633,7 +9719,7 @@
           <p:cNvPr id="9" name="">
             <a:extLst xmlns:a="http://schemas.openxmlformats.org/drawingml/2006/main">
               <a:ext uri="{FF2B5EF4-FFF2-40B4-BE49-F238E27FC236}">
-                <a16:creationId xmlns:a16="http://schemas.microsoft.com/office/drawing/2014/main" id="{8B47155C-8299-4FBB-84E1-AE61E4E73CD5}"/>
+                <a16:creationId xmlns:a16="http://schemas.microsoft.com/office/drawing/2014/main" id="{5473A4FE-DE1B-4000-9783-A2A7E2F1EAE0}"/>
               </a:ext>
             </a:extLst>
           </p:cNvPr>
@@ -9673,7 +9759,7 @@
                   <a:srgbClr val="111111"/>
                 </a:solidFill>
               </a:rPr>
-              <a:t>support hit@5</a:t>
+              <a:t>novel-text macro F1</a:t>
             </a:r>
           </a:p>
         </p:txBody>
@@ -9683,7 +9769,7 @@
           <p:cNvPr id="10" name="">
             <a:extLst xmlns:a="http://schemas.openxmlformats.org/drawingml/2006/main">
               <a:ext uri="{FF2B5EF4-FFF2-40B4-BE49-F238E27FC236}">
-                <a16:creationId xmlns:a16="http://schemas.microsoft.com/office/drawing/2014/main" id="{A392F5E1-73A6-420A-866C-A89DD91142EF}"/>
+                <a16:creationId xmlns:a16="http://schemas.microsoft.com/office/drawing/2014/main" id="{8C104AE0-323E-4660-8714-E1C42502F8DA}"/>
               </a:ext>
             </a:extLst>
           </p:cNvPr>
@@ -9714,7 +9800,7 @@
           <p:cNvPr id="11" name="">
             <a:extLst xmlns:a="http://schemas.openxmlformats.org/drawingml/2006/main">
               <a:ext uri="{FF2B5EF4-FFF2-40B4-BE49-F238E27FC236}">
-                <a16:creationId xmlns:a16="http://schemas.microsoft.com/office/drawing/2014/main" id="{E9D13687-AAF9-4D2D-9B76-C9339CEDE280}"/>
+                <a16:creationId xmlns:a16="http://schemas.microsoft.com/office/drawing/2014/main" id="{E9AA8FCE-9DF2-405A-A2A4-A90CB35D59CC}"/>
               </a:ext>
             </a:extLst>
           </p:cNvPr>
@@ -9764,7 +9850,7 @@
           <p:cNvPr id="12" name="">
             <a:extLst xmlns:a="http://schemas.openxmlformats.org/drawingml/2006/main">
               <a:ext uri="{FF2B5EF4-FFF2-40B4-BE49-F238E27FC236}">
-                <a16:creationId xmlns:a16="http://schemas.microsoft.com/office/drawing/2014/main" id="{2E554B77-5772-456E-9E85-08E341EC3675}"/>
+                <a16:creationId xmlns:a16="http://schemas.microsoft.com/office/drawing/2014/main" id="{08683995-7F9B-4B23-99AF-B3E8105B8E89}"/>
               </a:ext>
             </a:extLst>
           </p:cNvPr>
@@ -9814,47 +9900,47 @@
           <p:cNvPr id="13" name="">
             <a:extLst xmlns:a="http://schemas.openxmlformats.org/drawingml/2006/main">
               <a:ext uri="{FF2B5EF4-FFF2-40B4-BE49-F238E27FC236}">
-                <a16:creationId xmlns:a16="http://schemas.microsoft.com/office/drawing/2014/main" id="{120EBC9B-49D4-4647-9FBD-F63A5999A250}"/>
-              </a:ext>
-            </a:extLst>
-          </p:cNvPr>
-          <p:cNvSpPr>
-            <a:spLocks xmlns:a="http://schemas.openxmlformats.org/drawingml/2006/main" noGrp="1"/>
-          </p:cNvSpPr>
-          <p:nvPr/>
-        </p:nvSpPr>
-        <p:spPr>
-          <a:xfrm xmlns:a="http://schemas.openxmlformats.org/drawingml/2006/main">
-            <a:off x="7124700" y="5962650"/>
-            <a:ext cx="4381500" cy="323850"/>
-          </a:xfrm>
-          <a:prstGeom xmlns:a="http://schemas.openxmlformats.org/drawingml/2006/main" prst="rect">
-            <a:avLst/>
-          </a:prstGeom>
-          <a:noFill xmlns:a="http://schemas.openxmlformats.org/drawingml/2006/main"/>
-          <a:ln xmlns:a="http://schemas.openxmlformats.org/drawingml/2006/main" w="0">
-            <a:noFill/>
-            <a:prstDash val="solid"/>
-          </a:ln>
-        </p:spPr>
-        <p:txBody>
-          <a:bodyPr xmlns:a="http://schemas.openxmlformats.org/drawingml/2006/main" anchor="t"/>
-          <a:lstStyle xmlns:a="http://schemas.openxmlformats.org/drawingml/2006/main"/>
-          <a:p xmlns:a="http://schemas.openxmlformats.org/drawingml/2006/main">
-            <a:pPr algn="l">
-              <a:defRPr sz="1650" b="1">
-                <a:solidFill>
-                  <a:srgbClr val="111111"/>
-                </a:solidFill>
-              </a:defRPr>
-            </a:pPr>
-            <a:r>
-              <a:rPr sz="1650" b="1">
-                <a:solidFill>
-                  <a:srgbClr val="111111"/>
-                </a:solidFill>
-              </a:rPr>
-              <a:t>LoRA wins classification; the final system wins the workflow tradeoff.</a:t>
+                <a16:creationId xmlns:a16="http://schemas.microsoft.com/office/drawing/2014/main" id="{6B3C1531-F2B6-4455-B20C-0B6C5C94FC7F}"/>
+              </a:ext>
+            </a:extLst>
+          </p:cNvPr>
+          <p:cNvSpPr>
+            <a:spLocks xmlns:a="http://schemas.openxmlformats.org/drawingml/2006/main" noGrp="1"/>
+          </p:cNvSpPr>
+          <p:nvPr/>
+        </p:nvSpPr>
+        <p:spPr>
+          <a:xfrm xmlns:a="http://schemas.openxmlformats.org/drawingml/2006/main">
+            <a:off x="7124700" y="5753100"/>
+            <a:ext cx="4095750" cy="419100"/>
+          </a:xfrm>
+          <a:prstGeom xmlns:a="http://schemas.openxmlformats.org/drawingml/2006/main" prst="rect">
+            <a:avLst/>
+          </a:prstGeom>
+          <a:noFill xmlns:a="http://schemas.openxmlformats.org/drawingml/2006/main"/>
+          <a:ln xmlns:a="http://schemas.openxmlformats.org/drawingml/2006/main" w="0">
+            <a:noFill/>
+            <a:prstDash val="solid"/>
+          </a:ln>
+        </p:spPr>
+        <p:txBody>
+          <a:bodyPr xmlns:a="http://schemas.openxmlformats.org/drawingml/2006/main" anchor="t"/>
+          <a:lstStyle xmlns:a="http://schemas.openxmlformats.org/drawingml/2006/main"/>
+          <a:p xmlns:a="http://schemas.openxmlformats.org/drawingml/2006/main">
+            <a:pPr algn="l">
+              <a:defRPr sz="1500" b="1">
+                <a:solidFill>
+                  <a:srgbClr val="111111"/>
+                </a:solidFill>
+              </a:defRPr>
+            </a:pPr>
+            <a:r>
+              <a:rPr sz="1500" b="1">
+                <a:solidFill>
+                  <a:srgbClr val="111111"/>
+                </a:solidFill>
+              </a:rPr>
+              <a:t>The final 3.8 MB model trains in under one minute.</a:t>
             </a:r>
           </a:p>
         </p:txBody>
@@ -9862,7 +9948,7 @@
     </p:spTree>
     <p:extLst>
       <p:ext uri="{BB962C8B-B14F-4D97-AF65-F5344CB8AC3E}">
-        <p14:creationId xmlns:p14="http://schemas.microsoft.com/office/powerpoint/2010/main" val="1998277489"/>
+        <p14:creationId xmlns:p14="http://schemas.microsoft.com/office/powerpoint/2010/main" val="153516749"/>
       </p:ext>
     </p:extLst>
   </p:cSld>
@@ -9890,10 +9976,10 @@
       </p:grpSpPr>
       <p:sp>
         <p:nvSpPr>
-          <p:cNvPr id="17" name="slide-9-title">
-            <a:extLst xmlns:a="http://schemas.openxmlformats.org/drawingml/2006/main">
-              <a:ext uri="{FF2B5EF4-FFF2-40B4-BE49-F238E27FC236}">
-                <a16:creationId xmlns:a16="http://schemas.microsoft.com/office/drawing/2014/main" id="{8EE97549-E706-431B-AD44-4D1233F249AB}"/>
+          <p:cNvPr id="20" name="slide-9-title">
+            <a:extLst xmlns:a="http://schemas.openxmlformats.org/drawingml/2006/main">
+              <a:ext uri="{FF2B5EF4-FFF2-40B4-BE49-F238E27FC236}">
+                <a16:creationId xmlns:a16="http://schemas.microsoft.com/office/drawing/2014/main" id="{71931BCC-2883-41BA-BD34-C76A7F848CFF}"/>
               </a:ext>
             </a:extLst>
           </p:cNvPr>
@@ -9933,7 +10019,7 @@
                   <a:srgbClr val="111111"/>
                 </a:solidFill>
               </a:rPr>
-              <a:t>Errors require a conservative deployment policy</a:t>
+              <a:t>The remaining risk is label validity, not model capacity</a:t>
             </a:r>
           </a:p>
         </p:txBody>
@@ -9943,7 +10029,7 @@
           <p:cNvPr id="2" name="">
             <a:extLst xmlns:a="http://schemas.openxmlformats.org/drawingml/2006/main">
               <a:ext uri="{FF2B5EF4-FFF2-40B4-BE49-F238E27FC236}">
-                <a16:creationId xmlns:a16="http://schemas.microsoft.com/office/drawing/2014/main" id="{C0DC7F49-F8E3-4CD8-9629-9A5166B659D6}"/>
+                <a16:creationId xmlns:a16="http://schemas.microsoft.com/office/drawing/2014/main" id="{AE7A9FF4-05C7-4960-9FA6-753078A2435C}"/>
               </a:ext>
             </a:extLst>
           </p:cNvPr>
@@ -9993,7 +10079,7 @@
           <p:cNvPr id="3" name="">
             <a:extLst xmlns:a="http://schemas.openxmlformats.org/drawingml/2006/main">
               <a:ext uri="{FF2B5EF4-FFF2-40B4-BE49-F238E27FC236}">
-                <a16:creationId xmlns:a16="http://schemas.microsoft.com/office/drawing/2014/main" id="{90522ABF-F732-4F2D-898A-56D02FF2FCC3}"/>
+                <a16:creationId xmlns:a16="http://schemas.microsoft.com/office/drawing/2014/main" id="{EC8CF712-4F2F-489B-A7A8-AE8DB2B6DD5D}"/>
               </a:ext>
             </a:extLst>
           </p:cNvPr>
@@ -10033,7 +10119,7 @@
                   <a:srgbClr val="3D8DFF"/>
                 </a:solidFill>
               </a:rPr>
-              <a:t>WHERE ERRORS CONCENTRATE</a:t>
+              <a:t>FIXED 4K ERRORS BY TRUE LABEL</a:t>
             </a:r>
           </a:p>
         </p:txBody>
@@ -10043,18 +10129,18 @@
           <p:cNvPr id="4" name="">
             <a:extLst xmlns:a="http://schemas.openxmlformats.org/drawingml/2006/main">
               <a:ext uri="{FF2B5EF4-FFF2-40B4-BE49-F238E27FC236}">
-                <a16:creationId xmlns:a16="http://schemas.microsoft.com/office/drawing/2014/main" id="{F4681635-23B2-44F6-B3DD-A3F0D4C685F9}"/>
-              </a:ext>
-            </a:extLst>
-          </p:cNvPr>
-          <p:cNvSpPr>
-            <a:spLocks xmlns:a="http://schemas.openxmlformats.org/drawingml/2006/main" noGrp="1"/>
-          </p:cNvSpPr>
-          <p:nvPr/>
-        </p:nvSpPr>
-        <p:spPr>
-          <a:xfrm xmlns:a="http://schemas.openxmlformats.org/drawingml/2006/main">
-            <a:off x="419100" y="2095500"/>
+                <a16:creationId xmlns:a16="http://schemas.microsoft.com/office/drawing/2014/main" id="{6D72692A-0B23-4FFF-BEA2-BDAD2AB75F0A}"/>
+              </a:ext>
+            </a:extLst>
+          </p:cNvPr>
+          <p:cNvSpPr>
+            <a:spLocks xmlns:a="http://schemas.openxmlformats.org/drawingml/2006/main" noGrp="1"/>
+          </p:cNvSpPr>
+          <p:nvPr/>
+        </p:nvSpPr>
+        <p:spPr>
+          <a:xfrm xmlns:a="http://schemas.openxmlformats.org/drawingml/2006/main">
+            <a:off x="419100" y="2000250"/>
             <a:ext cx="2476500" cy="285750"/>
           </a:xfrm>
           <a:prstGeom xmlns:a="http://schemas.openxmlformats.org/drawingml/2006/main" prst="rect">
@@ -10083,7 +10169,7 @@
                   <a:srgbClr val="111111"/>
                 </a:solidFill>
               </a:rPr>
-              <a:t>medium_fit -&gt; low_fit</a:t>
+              <a:t>high_fit</a:t>
             </a:r>
           </a:p>
         </p:txBody>
@@ -10093,19 +10179,412 @@
           <p:cNvPr id="5" name="">
             <a:extLst xmlns:a="http://schemas.openxmlformats.org/drawingml/2006/main">
               <a:ext uri="{FF2B5EF4-FFF2-40B4-BE49-F238E27FC236}">
-                <a16:creationId xmlns:a16="http://schemas.microsoft.com/office/drawing/2014/main" id="{1A21BEEC-E85A-424F-A0C2-0433535E4F16}"/>
-              </a:ext>
-            </a:extLst>
-          </p:cNvPr>
-          <p:cNvSpPr>
-            <a:spLocks xmlns:a="http://schemas.openxmlformats.org/drawingml/2006/main" noGrp="1"/>
-          </p:cNvSpPr>
-          <p:nvPr/>
-        </p:nvSpPr>
-        <p:spPr>
-          <a:xfrm xmlns:a="http://schemas.openxmlformats.org/drawingml/2006/main">
-            <a:off x="2952750" y="2114550"/>
-            <a:ext cx="2606040" cy="266700"/>
+                <a16:creationId xmlns:a16="http://schemas.microsoft.com/office/drawing/2014/main" id="{67594C61-0756-4245-A196-68AE5CB698F0}"/>
+              </a:ext>
+            </a:extLst>
+          </p:cNvPr>
+          <p:cNvSpPr>
+            <a:spLocks xmlns:a="http://schemas.openxmlformats.org/drawingml/2006/main" noGrp="1"/>
+          </p:cNvSpPr>
+          <p:nvPr/>
+        </p:nvSpPr>
+        <p:spPr>
+          <a:xfrm xmlns:a="http://schemas.openxmlformats.org/drawingml/2006/main">
+            <a:off x="2952750" y="2019300"/>
+            <a:ext cx="177165" cy="266700"/>
+          </a:xfrm>
+          <a:prstGeom xmlns:a="http://schemas.openxmlformats.org/drawingml/2006/main" prst="rect">
+            <a:avLst/>
+          </a:prstGeom>
+          <a:solidFill xmlns:a="http://schemas.openxmlformats.org/drawingml/2006/main">
+            <a:srgbClr val="3D8DFF"/>
+          </a:solidFill>
+          <a:ln xmlns:a="http://schemas.openxmlformats.org/drawingml/2006/main" w="0">
+            <a:noFill/>
+            <a:prstDash val="solid"/>
+          </a:ln>
+        </p:spPr>
+      </p:sp>
+      <p:sp>
+        <p:nvSpPr>
+          <p:cNvPr id="6" name="">
+            <a:extLst xmlns:a="http://schemas.openxmlformats.org/drawingml/2006/main">
+              <a:ext uri="{FF2B5EF4-FFF2-40B4-BE49-F238E27FC236}">
+                <a16:creationId xmlns:a16="http://schemas.microsoft.com/office/drawing/2014/main" id="{4FBC1D79-5FD4-406D-B4B2-A8745E44B1B9}"/>
+              </a:ext>
+            </a:extLst>
+          </p:cNvPr>
+          <p:cNvSpPr>
+            <a:spLocks xmlns:a="http://schemas.openxmlformats.org/drawingml/2006/main" noGrp="1"/>
+          </p:cNvSpPr>
+          <p:nvPr/>
+        </p:nvSpPr>
+        <p:spPr>
+          <a:xfrm xmlns:a="http://schemas.openxmlformats.org/drawingml/2006/main">
+            <a:off x="5715000" y="2000250"/>
+            <a:ext cx="762000" cy="285750"/>
+          </a:xfrm>
+          <a:prstGeom xmlns:a="http://schemas.openxmlformats.org/drawingml/2006/main" prst="rect">
+            <a:avLst/>
+          </a:prstGeom>
+          <a:noFill xmlns:a="http://schemas.openxmlformats.org/drawingml/2006/main"/>
+          <a:ln xmlns:a="http://schemas.openxmlformats.org/drawingml/2006/main" w="0">
+            <a:noFill/>
+            <a:prstDash val="solid"/>
+          </a:ln>
+        </p:spPr>
+        <p:txBody>
+          <a:bodyPr xmlns:a="http://schemas.openxmlformats.org/drawingml/2006/main" anchor="t"/>
+          <a:lstStyle xmlns:a="http://schemas.openxmlformats.org/drawingml/2006/main"/>
+          <a:p xmlns:a="http://schemas.openxmlformats.org/drawingml/2006/main">
+            <a:pPr algn="r">
+              <a:defRPr sz="1650" b="1">
+                <a:solidFill>
+                  <a:srgbClr val="111111"/>
+                </a:solidFill>
+              </a:defRPr>
+            </a:pPr>
+            <a:r>
+              <a:rPr sz="1650" b="1">
+                <a:solidFill>
+                  <a:srgbClr val="111111"/>
+                </a:solidFill>
+              </a:rPr>
+              <a:t>3</a:t>
+            </a:r>
+          </a:p>
+        </p:txBody>
+      </p:sp>
+      <p:sp>
+        <p:nvSpPr>
+          <p:cNvPr id="7" name="">
+            <a:extLst xmlns:a="http://schemas.openxmlformats.org/drawingml/2006/main">
+              <a:ext uri="{FF2B5EF4-FFF2-40B4-BE49-F238E27FC236}">
+                <a16:creationId xmlns:a16="http://schemas.microsoft.com/office/drawing/2014/main" id="{E4910A06-375F-41B0-9F27-7F1FA0CB27F3}"/>
+              </a:ext>
+            </a:extLst>
+          </p:cNvPr>
+          <p:cNvSpPr>
+            <a:spLocks xmlns:a="http://schemas.openxmlformats.org/drawingml/2006/main" noGrp="1"/>
+          </p:cNvSpPr>
+          <p:nvPr/>
+        </p:nvSpPr>
+        <p:spPr>
+          <a:xfrm xmlns:a="http://schemas.openxmlformats.org/drawingml/2006/main">
+            <a:off x="419100" y="2743200"/>
+            <a:ext cx="2476500" cy="285750"/>
+          </a:xfrm>
+          <a:prstGeom xmlns:a="http://schemas.openxmlformats.org/drawingml/2006/main" prst="rect">
+            <a:avLst/>
+          </a:prstGeom>
+          <a:noFill xmlns:a="http://schemas.openxmlformats.org/drawingml/2006/main"/>
+          <a:ln xmlns:a="http://schemas.openxmlformats.org/drawingml/2006/main" w="0">
+            <a:noFill/>
+            <a:prstDash val="solid"/>
+          </a:ln>
+        </p:spPr>
+        <p:txBody>
+          <a:bodyPr xmlns:a="http://schemas.openxmlformats.org/drawingml/2006/main" anchor="t"/>
+          <a:lstStyle xmlns:a="http://schemas.openxmlformats.org/drawingml/2006/main"/>
+          <a:p xmlns:a="http://schemas.openxmlformats.org/drawingml/2006/main">
+            <a:pPr algn="l">
+              <a:defRPr sz="1650" b="0">
+                <a:solidFill>
+                  <a:srgbClr val="111111"/>
+                </a:solidFill>
+              </a:defRPr>
+            </a:pPr>
+            <a:r>
+              <a:rPr sz="1650" b="0">
+                <a:solidFill>
+                  <a:srgbClr val="111111"/>
+                </a:solidFill>
+              </a:rPr>
+              <a:t>medium_fit</a:t>
+            </a:r>
+          </a:p>
+        </p:txBody>
+      </p:sp>
+      <p:sp>
+        <p:nvSpPr>
+          <p:cNvPr id="8" name="">
+            <a:extLst xmlns:a="http://schemas.openxmlformats.org/drawingml/2006/main">
+              <a:ext uri="{FF2B5EF4-FFF2-40B4-BE49-F238E27FC236}">
+                <a16:creationId xmlns:a16="http://schemas.microsoft.com/office/drawing/2014/main" id="{C770CFB4-C420-4747-9BEF-CE3998946733}"/>
+              </a:ext>
+            </a:extLst>
+          </p:cNvPr>
+          <p:cNvSpPr>
+            <a:spLocks xmlns:a="http://schemas.openxmlformats.org/drawingml/2006/main" noGrp="1"/>
+          </p:cNvSpPr>
+          <p:nvPr/>
+        </p:nvSpPr>
+        <p:spPr>
+          <a:xfrm xmlns:a="http://schemas.openxmlformats.org/drawingml/2006/main">
+            <a:off x="2952750" y="2762250"/>
+            <a:ext cx="767715" cy="266700"/>
+          </a:xfrm>
+          <a:prstGeom xmlns:a="http://schemas.openxmlformats.org/drawingml/2006/main" prst="rect">
+            <a:avLst/>
+          </a:prstGeom>
+          <a:solidFill xmlns:a="http://schemas.openxmlformats.org/drawingml/2006/main">
+            <a:srgbClr val="3D8DFF"/>
+          </a:solidFill>
+          <a:ln xmlns:a="http://schemas.openxmlformats.org/drawingml/2006/main" w="0">
+            <a:noFill/>
+            <a:prstDash val="solid"/>
+          </a:ln>
+        </p:spPr>
+      </p:sp>
+      <p:sp>
+        <p:nvSpPr>
+          <p:cNvPr id="9" name="">
+            <a:extLst xmlns:a="http://schemas.openxmlformats.org/drawingml/2006/main">
+              <a:ext uri="{FF2B5EF4-FFF2-40B4-BE49-F238E27FC236}">
+                <a16:creationId xmlns:a16="http://schemas.microsoft.com/office/drawing/2014/main" id="{8B2397B8-EE24-4254-B09C-5913FBAAB072}"/>
+              </a:ext>
+            </a:extLst>
+          </p:cNvPr>
+          <p:cNvSpPr>
+            <a:spLocks xmlns:a="http://schemas.openxmlformats.org/drawingml/2006/main" noGrp="1"/>
+          </p:cNvSpPr>
+          <p:nvPr/>
+        </p:nvSpPr>
+        <p:spPr>
+          <a:xfrm xmlns:a="http://schemas.openxmlformats.org/drawingml/2006/main">
+            <a:off x="5715000" y="2743200"/>
+            <a:ext cx="762000" cy="285750"/>
+          </a:xfrm>
+          <a:prstGeom xmlns:a="http://schemas.openxmlformats.org/drawingml/2006/main" prst="rect">
+            <a:avLst/>
+          </a:prstGeom>
+          <a:noFill xmlns:a="http://schemas.openxmlformats.org/drawingml/2006/main"/>
+          <a:ln xmlns:a="http://schemas.openxmlformats.org/drawingml/2006/main" w="0">
+            <a:noFill/>
+            <a:prstDash val="solid"/>
+          </a:ln>
+        </p:spPr>
+        <p:txBody>
+          <a:bodyPr xmlns:a="http://schemas.openxmlformats.org/drawingml/2006/main" anchor="t"/>
+          <a:lstStyle xmlns:a="http://schemas.openxmlformats.org/drawingml/2006/main"/>
+          <a:p xmlns:a="http://schemas.openxmlformats.org/drawingml/2006/main">
+            <a:pPr algn="r">
+              <a:defRPr sz="1650" b="1">
+                <a:solidFill>
+                  <a:srgbClr val="111111"/>
+                </a:solidFill>
+              </a:defRPr>
+            </a:pPr>
+            <a:r>
+              <a:rPr sz="1650" b="1">
+                <a:solidFill>
+                  <a:srgbClr val="111111"/>
+                </a:solidFill>
+              </a:rPr>
+              <a:t>13</a:t>
+            </a:r>
+          </a:p>
+        </p:txBody>
+      </p:sp>
+      <p:sp>
+        <p:nvSpPr>
+          <p:cNvPr id="10" name="">
+            <a:extLst xmlns:a="http://schemas.openxmlformats.org/drawingml/2006/main">
+              <a:ext uri="{FF2B5EF4-FFF2-40B4-BE49-F238E27FC236}">
+                <a16:creationId xmlns:a16="http://schemas.microsoft.com/office/drawing/2014/main" id="{9733DC80-EC66-43AD-B79C-597685443F9F}"/>
+              </a:ext>
+            </a:extLst>
+          </p:cNvPr>
+          <p:cNvSpPr>
+            <a:spLocks xmlns:a="http://schemas.openxmlformats.org/drawingml/2006/main" noGrp="1"/>
+          </p:cNvSpPr>
+          <p:nvPr/>
+        </p:nvSpPr>
+        <p:spPr>
+          <a:xfrm xmlns:a="http://schemas.openxmlformats.org/drawingml/2006/main">
+            <a:off x="419100" y="3486150"/>
+            <a:ext cx="2476500" cy="285750"/>
+          </a:xfrm>
+          <a:prstGeom xmlns:a="http://schemas.openxmlformats.org/drawingml/2006/main" prst="rect">
+            <a:avLst/>
+          </a:prstGeom>
+          <a:noFill xmlns:a="http://schemas.openxmlformats.org/drawingml/2006/main"/>
+          <a:ln xmlns:a="http://schemas.openxmlformats.org/drawingml/2006/main" w="0">
+            <a:noFill/>
+            <a:prstDash val="solid"/>
+          </a:ln>
+        </p:spPr>
+        <p:txBody>
+          <a:bodyPr xmlns:a="http://schemas.openxmlformats.org/drawingml/2006/main" anchor="t"/>
+          <a:lstStyle xmlns:a="http://schemas.openxmlformats.org/drawingml/2006/main"/>
+          <a:p xmlns:a="http://schemas.openxmlformats.org/drawingml/2006/main">
+            <a:pPr algn="l">
+              <a:defRPr sz="1650" b="0">
+                <a:solidFill>
+                  <a:srgbClr val="111111"/>
+                </a:solidFill>
+              </a:defRPr>
+            </a:pPr>
+            <a:r>
+              <a:rPr sz="1650" b="0">
+                <a:solidFill>
+                  <a:srgbClr val="111111"/>
+                </a:solidFill>
+              </a:rPr>
+              <a:t>low_fit</a:t>
+            </a:r>
+          </a:p>
+        </p:txBody>
+      </p:sp>
+      <p:sp>
+        <p:nvSpPr>
+          <p:cNvPr id="11" name="">
+            <a:extLst xmlns:a="http://schemas.openxmlformats.org/drawingml/2006/main">
+              <a:ext uri="{FF2B5EF4-FFF2-40B4-BE49-F238E27FC236}">
+                <a16:creationId xmlns:a16="http://schemas.microsoft.com/office/drawing/2014/main" id="{CBDCACD2-9513-4C75-BCCC-2926C1408217}"/>
+              </a:ext>
+            </a:extLst>
+          </p:cNvPr>
+          <p:cNvSpPr>
+            <a:spLocks xmlns:a="http://schemas.openxmlformats.org/drawingml/2006/main" noGrp="1"/>
+          </p:cNvSpPr>
+          <p:nvPr/>
+        </p:nvSpPr>
+        <p:spPr>
+          <a:xfrm xmlns:a="http://schemas.openxmlformats.org/drawingml/2006/main">
+            <a:off x="2952750" y="3505200"/>
+            <a:ext cx="472440" cy="266700"/>
+          </a:xfrm>
+          <a:prstGeom xmlns:a="http://schemas.openxmlformats.org/drawingml/2006/main" prst="rect">
+            <a:avLst/>
+          </a:prstGeom>
+          <a:solidFill xmlns:a="http://schemas.openxmlformats.org/drawingml/2006/main">
+            <a:srgbClr val="3D8DFF"/>
+          </a:solidFill>
+          <a:ln xmlns:a="http://schemas.openxmlformats.org/drawingml/2006/main" w="0">
+            <a:noFill/>
+            <a:prstDash val="solid"/>
+          </a:ln>
+        </p:spPr>
+      </p:sp>
+      <p:sp>
+        <p:nvSpPr>
+          <p:cNvPr id="12" name="">
+            <a:extLst xmlns:a="http://schemas.openxmlformats.org/drawingml/2006/main">
+              <a:ext uri="{FF2B5EF4-FFF2-40B4-BE49-F238E27FC236}">
+                <a16:creationId xmlns:a16="http://schemas.microsoft.com/office/drawing/2014/main" id="{2CEB181E-70D2-4D5A-9118-FA27F031FAE4}"/>
+              </a:ext>
+            </a:extLst>
+          </p:cNvPr>
+          <p:cNvSpPr>
+            <a:spLocks xmlns:a="http://schemas.openxmlformats.org/drawingml/2006/main" noGrp="1"/>
+          </p:cNvSpPr>
+          <p:nvPr/>
+        </p:nvSpPr>
+        <p:spPr>
+          <a:xfrm xmlns:a="http://schemas.openxmlformats.org/drawingml/2006/main">
+            <a:off x="5715000" y="3486150"/>
+            <a:ext cx="762000" cy="285750"/>
+          </a:xfrm>
+          <a:prstGeom xmlns:a="http://schemas.openxmlformats.org/drawingml/2006/main" prst="rect">
+            <a:avLst/>
+          </a:prstGeom>
+          <a:noFill xmlns:a="http://schemas.openxmlformats.org/drawingml/2006/main"/>
+          <a:ln xmlns:a="http://schemas.openxmlformats.org/drawingml/2006/main" w="0">
+            <a:noFill/>
+            <a:prstDash val="solid"/>
+          </a:ln>
+        </p:spPr>
+        <p:txBody>
+          <a:bodyPr xmlns:a="http://schemas.openxmlformats.org/drawingml/2006/main" anchor="t"/>
+          <a:lstStyle xmlns:a="http://schemas.openxmlformats.org/drawingml/2006/main"/>
+          <a:p xmlns:a="http://schemas.openxmlformats.org/drawingml/2006/main">
+            <a:pPr algn="r">
+              <a:defRPr sz="1650" b="1">
+                <a:solidFill>
+                  <a:srgbClr val="111111"/>
+                </a:solidFill>
+              </a:defRPr>
+            </a:pPr>
+            <a:r>
+              <a:rPr sz="1650" b="1">
+                <a:solidFill>
+                  <a:srgbClr val="111111"/>
+                </a:solidFill>
+              </a:rPr>
+              <a:t>8</a:t>
+            </a:r>
+          </a:p>
+        </p:txBody>
+      </p:sp>
+      <p:sp>
+        <p:nvSpPr>
+          <p:cNvPr id="13" name="">
+            <a:extLst xmlns:a="http://schemas.openxmlformats.org/drawingml/2006/main">
+              <a:ext uri="{FF2B5EF4-FFF2-40B4-BE49-F238E27FC236}">
+                <a16:creationId xmlns:a16="http://schemas.microsoft.com/office/drawing/2014/main" id="{2B59003B-E5E8-466F-A8DE-96167402D734}"/>
+              </a:ext>
+            </a:extLst>
+          </p:cNvPr>
+          <p:cNvSpPr>
+            <a:spLocks xmlns:a="http://schemas.openxmlformats.org/drawingml/2006/main" noGrp="1"/>
+          </p:cNvSpPr>
+          <p:nvPr/>
+        </p:nvSpPr>
+        <p:spPr>
+          <a:xfrm xmlns:a="http://schemas.openxmlformats.org/drawingml/2006/main">
+            <a:off x="419100" y="4229100"/>
+            <a:ext cx="2476500" cy="285750"/>
+          </a:xfrm>
+          <a:prstGeom xmlns:a="http://schemas.openxmlformats.org/drawingml/2006/main" prst="rect">
+            <a:avLst/>
+          </a:prstGeom>
+          <a:noFill xmlns:a="http://schemas.openxmlformats.org/drawingml/2006/main"/>
+          <a:ln xmlns:a="http://schemas.openxmlformats.org/drawingml/2006/main" w="0">
+            <a:noFill/>
+            <a:prstDash val="solid"/>
+          </a:ln>
+        </p:spPr>
+        <p:txBody>
+          <a:bodyPr xmlns:a="http://schemas.openxmlformats.org/drawingml/2006/main" anchor="t"/>
+          <a:lstStyle xmlns:a="http://schemas.openxmlformats.org/drawingml/2006/main"/>
+          <a:p xmlns:a="http://schemas.openxmlformats.org/drawingml/2006/main">
+            <a:pPr algn="l">
+              <a:defRPr sz="1650" b="0">
+                <a:solidFill>
+                  <a:srgbClr val="111111"/>
+                </a:solidFill>
+              </a:defRPr>
+            </a:pPr>
+            <a:r>
+              <a:rPr sz="1650" b="0">
+                <a:solidFill>
+                  <a:srgbClr val="111111"/>
+                </a:solidFill>
+              </a:rPr>
+              <a:t>unclear</a:t>
+            </a:r>
+          </a:p>
+        </p:txBody>
+      </p:sp>
+      <p:sp>
+        <p:nvSpPr>
+          <p:cNvPr id="14" name="">
+            <a:extLst xmlns:a="http://schemas.openxmlformats.org/drawingml/2006/main">
+              <a:ext uri="{FF2B5EF4-FFF2-40B4-BE49-F238E27FC236}">
+                <a16:creationId xmlns:a16="http://schemas.microsoft.com/office/drawing/2014/main" id="{BF9DF96C-A154-4A32-A23E-FC59C507C4B7}"/>
+              </a:ext>
+            </a:extLst>
+          </p:cNvPr>
+          <p:cNvSpPr>
+            <a:spLocks xmlns:a="http://schemas.openxmlformats.org/drawingml/2006/main" noGrp="1"/>
+          </p:cNvSpPr>
+          <p:nvPr/>
+        </p:nvSpPr>
+        <p:spPr>
+          <a:xfrm xmlns:a="http://schemas.openxmlformats.org/drawingml/2006/main">
+            <a:off x="2952750" y="4248150"/>
+            <a:ext cx="2421255" cy="266700"/>
           </a:xfrm>
           <a:prstGeom xmlns:a="http://schemas.openxmlformats.org/drawingml/2006/main" prst="rect">
             <a:avLst/>
@@ -10121,21 +10600,21 @@
       </p:sp>
       <p:sp>
         <p:nvSpPr>
-          <p:cNvPr id="6" name="">
-            <a:extLst xmlns:a="http://schemas.openxmlformats.org/drawingml/2006/main">
-              <a:ext uri="{FF2B5EF4-FFF2-40B4-BE49-F238E27FC236}">
-                <a16:creationId xmlns:a16="http://schemas.microsoft.com/office/drawing/2014/main" id="{8974F7E0-71CD-400B-8BBA-6B4C6AF37ADF}"/>
-              </a:ext>
-            </a:extLst>
-          </p:cNvPr>
-          <p:cNvSpPr>
-            <a:spLocks xmlns:a="http://schemas.openxmlformats.org/drawingml/2006/main" noGrp="1"/>
-          </p:cNvSpPr>
-          <p:nvPr/>
-        </p:nvSpPr>
-        <p:spPr>
-          <a:xfrm xmlns:a="http://schemas.openxmlformats.org/drawingml/2006/main">
-            <a:off x="5715000" y="2095500"/>
+          <p:cNvPr id="15" name="">
+            <a:extLst xmlns:a="http://schemas.openxmlformats.org/drawingml/2006/main">
+              <a:ext uri="{FF2B5EF4-FFF2-40B4-BE49-F238E27FC236}">
+                <a16:creationId xmlns:a16="http://schemas.microsoft.com/office/drawing/2014/main" id="{C5A3B931-DC5E-41BD-9DB2-09D0E9D2261E}"/>
+              </a:ext>
+            </a:extLst>
+          </p:cNvPr>
+          <p:cNvSpPr>
+            <a:spLocks xmlns:a="http://schemas.openxmlformats.org/drawingml/2006/main" noGrp="1"/>
+          </p:cNvSpPr>
+          <p:nvPr/>
+        </p:nvSpPr>
+        <p:spPr>
+          <a:xfrm xmlns:a="http://schemas.openxmlformats.org/drawingml/2006/main">
+            <a:off x="5715000" y="4229100"/>
             <a:ext cx="762000" cy="285750"/>
           </a:xfrm>
           <a:prstGeom xmlns:a="http://schemas.openxmlformats.org/drawingml/2006/main" prst="rect">
@@ -10164,276 +10643,14 @@
                   <a:srgbClr val="111111"/>
                 </a:solidFill>
               </a:rPr>
-              <a:t>380</a:t>
-            </a:r>
-          </a:p>
-        </p:txBody>
-      </p:sp>
-      <p:sp>
-        <p:nvSpPr>
-          <p:cNvPr id="7" name="">
-            <a:extLst xmlns:a="http://schemas.openxmlformats.org/drawingml/2006/main">
-              <a:ext uri="{FF2B5EF4-FFF2-40B4-BE49-F238E27FC236}">
-                <a16:creationId xmlns:a16="http://schemas.microsoft.com/office/drawing/2014/main" id="{7BBB4241-ED81-45FB-9A5A-C936FF8B012C}"/>
-              </a:ext>
-            </a:extLst>
-          </p:cNvPr>
-          <p:cNvSpPr>
-            <a:spLocks xmlns:a="http://schemas.openxmlformats.org/drawingml/2006/main" noGrp="1"/>
-          </p:cNvSpPr>
-          <p:nvPr/>
-        </p:nvSpPr>
-        <p:spPr>
-          <a:xfrm xmlns:a="http://schemas.openxmlformats.org/drawingml/2006/main">
-            <a:off x="419100" y="3086100"/>
-            <a:ext cx="2476500" cy="285750"/>
-          </a:xfrm>
-          <a:prstGeom xmlns:a="http://schemas.openxmlformats.org/drawingml/2006/main" prst="rect">
-            <a:avLst/>
-          </a:prstGeom>
-          <a:noFill xmlns:a="http://schemas.openxmlformats.org/drawingml/2006/main"/>
-          <a:ln xmlns:a="http://schemas.openxmlformats.org/drawingml/2006/main" w="0">
-            <a:noFill/>
-            <a:prstDash val="solid"/>
-          </a:ln>
-        </p:spPr>
-        <p:txBody>
-          <a:bodyPr xmlns:a="http://schemas.openxmlformats.org/drawingml/2006/main" anchor="t"/>
-          <a:lstStyle xmlns:a="http://schemas.openxmlformats.org/drawingml/2006/main"/>
-          <a:p xmlns:a="http://schemas.openxmlformats.org/drawingml/2006/main">
-            <a:pPr algn="l">
-              <a:defRPr sz="1650" b="0">
-                <a:solidFill>
-                  <a:srgbClr val="111111"/>
-                </a:solidFill>
-              </a:defRPr>
-            </a:pPr>
-            <a:r>
-              <a:rPr sz="1650" b="0">
-                <a:solidFill>
-                  <a:srgbClr val="111111"/>
-                </a:solidFill>
-              </a:rPr>
-              <a:t>unclear -&gt; low_fit</a:t>
-            </a:r>
-          </a:p>
-        </p:txBody>
-      </p:sp>
-      <p:sp>
-        <p:nvSpPr>
-          <p:cNvPr id="8" name="">
-            <a:extLst xmlns:a="http://schemas.openxmlformats.org/drawingml/2006/main">
-              <a:ext uri="{FF2B5EF4-FFF2-40B4-BE49-F238E27FC236}">
-                <a16:creationId xmlns:a16="http://schemas.microsoft.com/office/drawing/2014/main" id="{7D211338-9E27-46FF-B094-9D1C66ECADF8}"/>
-              </a:ext>
-            </a:extLst>
-          </p:cNvPr>
-          <p:cNvSpPr>
-            <a:spLocks xmlns:a="http://schemas.openxmlformats.org/drawingml/2006/main" noGrp="1"/>
-          </p:cNvSpPr>
-          <p:nvPr/>
-        </p:nvSpPr>
-        <p:spPr>
-          <a:xfrm xmlns:a="http://schemas.openxmlformats.org/drawingml/2006/main">
-            <a:off x="2952750" y="3105150"/>
-            <a:ext cx="1741932" cy="266700"/>
-          </a:xfrm>
-          <a:prstGeom xmlns:a="http://schemas.openxmlformats.org/drawingml/2006/main" prst="rect">
-            <a:avLst/>
-          </a:prstGeom>
-          <a:solidFill xmlns:a="http://schemas.openxmlformats.org/drawingml/2006/main">
-            <a:srgbClr val="D6532F"/>
-          </a:solidFill>
-          <a:ln xmlns:a="http://schemas.openxmlformats.org/drawingml/2006/main" w="0">
-            <a:noFill/>
-            <a:prstDash val="solid"/>
-          </a:ln>
-        </p:spPr>
-      </p:sp>
-      <p:sp>
-        <p:nvSpPr>
-          <p:cNvPr id="9" name="">
-            <a:extLst xmlns:a="http://schemas.openxmlformats.org/drawingml/2006/main">
-              <a:ext uri="{FF2B5EF4-FFF2-40B4-BE49-F238E27FC236}">
-                <a16:creationId xmlns:a16="http://schemas.microsoft.com/office/drawing/2014/main" id="{8B493AF8-B5ED-4755-A6FC-B1C682E24B40}"/>
-              </a:ext>
-            </a:extLst>
-          </p:cNvPr>
-          <p:cNvSpPr>
-            <a:spLocks xmlns:a="http://schemas.openxmlformats.org/drawingml/2006/main" noGrp="1"/>
-          </p:cNvSpPr>
-          <p:nvPr/>
-        </p:nvSpPr>
-        <p:spPr>
-          <a:xfrm xmlns:a="http://schemas.openxmlformats.org/drawingml/2006/main">
-            <a:off x="5715000" y="3086100"/>
-            <a:ext cx="762000" cy="285750"/>
-          </a:xfrm>
-          <a:prstGeom xmlns:a="http://schemas.openxmlformats.org/drawingml/2006/main" prst="rect">
-            <a:avLst/>
-          </a:prstGeom>
-          <a:noFill xmlns:a="http://schemas.openxmlformats.org/drawingml/2006/main"/>
-          <a:ln xmlns:a="http://schemas.openxmlformats.org/drawingml/2006/main" w="0">
-            <a:noFill/>
-            <a:prstDash val="solid"/>
-          </a:ln>
-        </p:spPr>
-        <p:txBody>
-          <a:bodyPr xmlns:a="http://schemas.openxmlformats.org/drawingml/2006/main" anchor="t"/>
-          <a:lstStyle xmlns:a="http://schemas.openxmlformats.org/drawingml/2006/main"/>
-          <a:p xmlns:a="http://schemas.openxmlformats.org/drawingml/2006/main">
-            <a:pPr algn="r">
-              <a:defRPr sz="1650" b="1">
-                <a:solidFill>
-                  <a:srgbClr val="111111"/>
-                </a:solidFill>
-              </a:defRPr>
-            </a:pPr>
-            <a:r>
-              <a:rPr sz="1650" b="1">
-                <a:solidFill>
-                  <a:srgbClr val="111111"/>
-                </a:solidFill>
-              </a:rPr>
-              <a:t>254</a:t>
-            </a:r>
-          </a:p>
-        </p:txBody>
-      </p:sp>
-      <p:sp>
-        <p:nvSpPr>
-          <p:cNvPr id="10" name="">
-            <a:extLst xmlns:a="http://schemas.openxmlformats.org/drawingml/2006/main">
-              <a:ext uri="{FF2B5EF4-FFF2-40B4-BE49-F238E27FC236}">
-                <a16:creationId xmlns:a16="http://schemas.microsoft.com/office/drawing/2014/main" id="{F352F220-EBB3-4A0D-B285-8D91C5D96F65}"/>
-              </a:ext>
-            </a:extLst>
-          </p:cNvPr>
-          <p:cNvSpPr>
-            <a:spLocks xmlns:a="http://schemas.openxmlformats.org/drawingml/2006/main" noGrp="1"/>
-          </p:cNvSpPr>
-          <p:nvPr/>
-        </p:nvSpPr>
-        <p:spPr>
-          <a:xfrm xmlns:a="http://schemas.openxmlformats.org/drawingml/2006/main">
-            <a:off x="419100" y="4076700"/>
-            <a:ext cx="2476500" cy="285750"/>
-          </a:xfrm>
-          <a:prstGeom xmlns:a="http://schemas.openxmlformats.org/drawingml/2006/main" prst="rect">
-            <a:avLst/>
-          </a:prstGeom>
-          <a:noFill xmlns:a="http://schemas.openxmlformats.org/drawingml/2006/main"/>
-          <a:ln xmlns:a="http://schemas.openxmlformats.org/drawingml/2006/main" w="0">
-            <a:noFill/>
-            <a:prstDash val="solid"/>
-          </a:ln>
-        </p:spPr>
-        <p:txBody>
-          <a:bodyPr xmlns:a="http://schemas.openxmlformats.org/drawingml/2006/main" anchor="t"/>
-          <a:lstStyle xmlns:a="http://schemas.openxmlformats.org/drawingml/2006/main"/>
-          <a:p xmlns:a="http://schemas.openxmlformats.org/drawingml/2006/main">
-            <a:pPr algn="l">
-              <a:defRPr sz="1650" b="0">
-                <a:solidFill>
-                  <a:srgbClr val="111111"/>
-                </a:solidFill>
-              </a:defRPr>
-            </a:pPr>
-            <a:r>
-              <a:rPr sz="1650" b="0">
-                <a:solidFill>
-                  <a:srgbClr val="111111"/>
-                </a:solidFill>
-              </a:rPr>
-              <a:t>all other errors</a:t>
-            </a:r>
-          </a:p>
-        </p:txBody>
-      </p:sp>
-      <p:sp>
-        <p:nvSpPr>
-          <p:cNvPr id="11" name="">
-            <a:extLst xmlns:a="http://schemas.openxmlformats.org/drawingml/2006/main">
-              <a:ext uri="{FF2B5EF4-FFF2-40B4-BE49-F238E27FC236}">
-                <a16:creationId xmlns:a16="http://schemas.microsoft.com/office/drawing/2014/main" id="{39B00FE0-6DA3-4891-99CC-4D941CA9931B}"/>
-              </a:ext>
-            </a:extLst>
-          </p:cNvPr>
-          <p:cNvSpPr>
-            <a:spLocks xmlns:a="http://schemas.openxmlformats.org/drawingml/2006/main" noGrp="1"/>
-          </p:cNvSpPr>
-          <p:nvPr/>
-        </p:nvSpPr>
-        <p:spPr>
-          <a:xfrm xmlns:a="http://schemas.openxmlformats.org/drawingml/2006/main">
-            <a:off x="2952750" y="4095750"/>
-            <a:ext cx="1124712" cy="266700"/>
-          </a:xfrm>
-          <a:prstGeom xmlns:a="http://schemas.openxmlformats.org/drawingml/2006/main" prst="rect">
-            <a:avLst/>
-          </a:prstGeom>
-          <a:solidFill xmlns:a="http://schemas.openxmlformats.org/drawingml/2006/main">
-            <a:srgbClr val="B8BCC4"/>
-          </a:solidFill>
-          <a:ln xmlns:a="http://schemas.openxmlformats.org/drawingml/2006/main" w="0">
-            <a:noFill/>
-            <a:prstDash val="solid"/>
-          </a:ln>
-        </p:spPr>
-      </p:sp>
-      <p:sp>
-        <p:nvSpPr>
-          <p:cNvPr id="12" name="">
-            <a:extLst xmlns:a="http://schemas.openxmlformats.org/drawingml/2006/main">
-              <a:ext uri="{FF2B5EF4-FFF2-40B4-BE49-F238E27FC236}">
-                <a16:creationId xmlns:a16="http://schemas.microsoft.com/office/drawing/2014/main" id="{08AD8F36-41D5-4D53-8F0F-86FAC5FE7B70}"/>
-              </a:ext>
-            </a:extLst>
-          </p:cNvPr>
-          <p:cNvSpPr>
-            <a:spLocks xmlns:a="http://schemas.openxmlformats.org/drawingml/2006/main" noGrp="1"/>
-          </p:cNvSpPr>
-          <p:nvPr/>
-        </p:nvSpPr>
-        <p:spPr>
-          <a:xfrm xmlns:a="http://schemas.openxmlformats.org/drawingml/2006/main">
-            <a:off x="5715000" y="4076700"/>
-            <a:ext cx="762000" cy="285750"/>
-          </a:xfrm>
-          <a:prstGeom xmlns:a="http://schemas.openxmlformats.org/drawingml/2006/main" prst="rect">
-            <a:avLst/>
-          </a:prstGeom>
-          <a:noFill xmlns:a="http://schemas.openxmlformats.org/drawingml/2006/main"/>
-          <a:ln xmlns:a="http://schemas.openxmlformats.org/drawingml/2006/main" w="0">
-            <a:noFill/>
-            <a:prstDash val="solid"/>
-          </a:ln>
-        </p:spPr>
-        <p:txBody>
-          <a:bodyPr xmlns:a="http://schemas.openxmlformats.org/drawingml/2006/main" anchor="t"/>
-          <a:lstStyle xmlns:a="http://schemas.openxmlformats.org/drawingml/2006/main"/>
-          <a:p xmlns:a="http://schemas.openxmlformats.org/drawingml/2006/main">
-            <a:pPr algn="r">
-              <a:defRPr sz="1650" b="1">
-                <a:solidFill>
-                  <a:srgbClr val="111111"/>
-                </a:solidFill>
-              </a:defRPr>
-            </a:pPr>
-            <a:r>
-              <a:rPr sz="1650" b="1">
-                <a:solidFill>
-                  <a:srgbClr val="111111"/>
-                </a:solidFill>
-              </a:rPr>
-              <a:t>164</a:t>
+              <a:t>41</a:t>
             </a:r>
           </a:p>
         </p:txBody>
       </p:sp>
       <p:cxnSp>
         <p:nvCxnSpPr>
-          <p:cNvPr id="29" name=""/>
+          <p:cNvPr id="35" name=""/>
           <p:cNvCxnSpPr/>
           <p:nvPr/>
         </p:nvCxnSpPr>
@@ -10455,10 +10672,10 @@
       </p:cxnSp>
       <p:sp>
         <p:nvSpPr>
-          <p:cNvPr id="14" name="">
-            <a:extLst xmlns:a="http://schemas.openxmlformats.org/drawingml/2006/main">
-              <a:ext uri="{FF2B5EF4-FFF2-40B4-BE49-F238E27FC236}">
-                <a16:creationId xmlns:a16="http://schemas.microsoft.com/office/drawing/2014/main" id="{9B629A1F-0164-4394-BBB7-B7ADFF4BBFDE}"/>
+          <p:cNvPr id="17" name="">
+            <a:extLst xmlns:a="http://schemas.openxmlformats.org/drawingml/2006/main">
+              <a:ext uri="{FF2B5EF4-FFF2-40B4-BE49-F238E27FC236}">
+                <a16:creationId xmlns:a16="http://schemas.microsoft.com/office/drawing/2014/main" id="{99E82DAA-E456-49DA-8C25-5DC908D3841C}"/>
               </a:ext>
             </a:extLst>
           </p:cNvPr>
@@ -10505,10 +10722,10 @@
       </p:sp>
       <p:sp>
         <p:nvSpPr>
-          <p:cNvPr id="15" name="">
-            <a:extLst xmlns:a="http://schemas.openxmlformats.org/drawingml/2006/main">
-              <a:ext uri="{FF2B5EF4-FFF2-40B4-BE49-F238E27FC236}">
-                <a16:creationId xmlns:a16="http://schemas.microsoft.com/office/drawing/2014/main" id="{D2228593-4857-4DCD-81B8-5E64ABBB624F}"/>
+          <p:cNvPr id="18" name="">
+            <a:extLst xmlns:a="http://schemas.openxmlformats.org/drawingml/2006/main">
+              <a:ext uri="{FF2B5EF4-FFF2-40B4-BE49-F238E27FC236}">
+                <a16:creationId xmlns:a16="http://schemas.microsoft.com/office/drawing/2014/main" id="{7D21FAD1-9FE5-47EC-8662-FA68F37E8EBF}"/>
               </a:ext>
             </a:extLst>
           </p:cNvPr>
@@ -10520,7 +10737,7 @@
         <p:spPr>
           <a:xfrm xmlns:a="http://schemas.openxmlformats.org/drawingml/2006/main">
             <a:off x="6819900" y="2362200"/>
-            <a:ext cx="4286250" cy="1219200"/>
+            <a:ext cx="4286250" cy="1104900"/>
           </a:xfrm>
           <a:prstGeom xmlns:a="http://schemas.openxmlformats.org/drawingml/2006/main" prst="rect">
             <a:avLst/>
@@ -10548,29 +10765,29 @@
                   <a:srgbClr val="111111"/>
                 </a:solidFill>
               </a:rPr>
-              <a:t>Prioritize high-fit candidates. Route medium, unclear, and authorization-sensitive cases to human review.</a:t>
-            </a:r>
-          </a:p>
-        </p:txBody>
-      </p:sp>
-      <p:sp>
-        <p:nvSpPr>
-          <p:cNvPr id="16" name="">
-            <a:extLst xmlns:a="http://schemas.openxmlformats.org/drawingml/2006/main">
-              <a:ext uri="{FF2B5EF4-FFF2-40B4-BE49-F238E27FC236}">
-                <a16:creationId xmlns:a16="http://schemas.microsoft.com/office/drawing/2014/main" id="{E2FE1441-0791-4D57-8A34-7DC06C02DA23}"/>
-              </a:ext>
-            </a:extLst>
-          </p:cNvPr>
-          <p:cNvSpPr>
-            <a:spLocks xmlns:a="http://schemas.openxmlformats.org/drawingml/2006/main" noGrp="1"/>
-          </p:cNvSpPr>
-          <p:nvPr/>
-        </p:nvSpPr>
-        <p:spPr>
-          <a:xfrm xmlns:a="http://schemas.openxmlformats.org/drawingml/2006/main">
-            <a:off x="6819900" y="4191000"/>
-            <a:ext cx="4286250" cy="1104900"/>
+              <a:t>Treat 0.984 as weak-label agreement, not advisor accuracy.</a:t>
+            </a:r>
+          </a:p>
+        </p:txBody>
+      </p:sp>
+      <p:sp>
+        <p:nvSpPr>
+          <p:cNvPr id="19" name="">
+            <a:extLst xmlns:a="http://schemas.openxmlformats.org/drawingml/2006/main">
+              <a:ext uri="{FF2B5EF4-FFF2-40B4-BE49-F238E27FC236}">
+                <a16:creationId xmlns:a16="http://schemas.microsoft.com/office/drawing/2014/main" id="{309AA238-D294-4082-8B3F-2EE8B696C7DF}"/>
+              </a:ext>
+            </a:extLst>
+          </p:cNvPr>
+          <p:cNvSpPr>
+            <a:spLocks xmlns:a="http://schemas.openxmlformats.org/drawingml/2006/main" noGrp="1"/>
+          </p:cNvSpPr>
+          <p:nvPr/>
+        </p:nvSpPr>
+        <p:spPr>
+          <a:xfrm xmlns:a="http://schemas.openxmlformats.org/drawingml/2006/main">
+            <a:off x="6819900" y="4095750"/>
+            <a:ext cx="4286250" cy="1200150"/>
           </a:xfrm>
           <a:prstGeom xmlns:a="http://schemas.openxmlformats.org/drawingml/2006/main" prst="rect">
             <a:avLst/>
@@ -10598,7 +10815,7 @@
                   <a:srgbClr val="565D67"/>
                 </a:solidFill>
               </a:rPr>
-              <a:t>No automatic rejection</a:t>
+              <a:t>Next test: 500-1,000 advisor labels</a:t>
             </a:r>
           </a:p>
           <a:p xmlns:a="http://schemas.openxmlformats.org/drawingml/2006/main">
@@ -10615,7 +10832,7 @@
                   <a:srgbClr val="565D67"/>
                 </a:solidFill>
               </a:rPr>
-              <a:t>No unsupported authorization claim</a:t>
+              <a:t>Separate authorization benchmark</a:t>
             </a:r>
           </a:p>
           <a:p xmlns:a="http://schemas.openxmlformats.org/drawingml/2006/main">
@@ -10632,7 +10849,7 @@
                   <a:srgbClr val="565D67"/>
                 </a:solidFill>
               </a:rPr>
-              <a:t>No private student data in the prototype</a:t>
+              <a:t>Time-based external validation</a:t>
             </a:r>
           </a:p>
         </p:txBody>
@@ -10640,7 +10857,7 @@
     </p:spTree>
     <p:extLst>
       <p:ext uri="{BB962C8B-B14F-4D97-AF65-F5344CB8AC3E}">
-        <p14:creationId xmlns:p14="http://schemas.microsoft.com/office/powerpoint/2010/main" val="1183667994"/>
+        <p14:creationId xmlns:p14="http://schemas.microsoft.com/office/powerpoint/2010/main" val="436401932"/>
       </p:ext>
     </p:extLst>
   </p:cSld>

</xml_diff>

<commit_message>
Complete validation and annotation package
</commit_message>
<xml_diff>
--- a/slides/MSBA_Job_Matching_Final_Deck.pptx
+++ b/slides/MSBA_Job_Matching_Final_Deck.pptx
@@ -2,22 +2,22 @@
 <file path=ppt/presentation.xml><?xml version="1.0" encoding="utf-8"?>
 <p:presentation xmlns:p="http://schemas.openxmlformats.org/presentationml/2006/main">
   <p:sldMasterIdLst>
-    <p:sldMasterId xmlns:r="http://schemas.openxmlformats.org/officeDocument/2006/relationships" id="2147483648" r:id="R426dd2163800473c"/>
+    <p:sldMasterId xmlns:r="http://schemas.openxmlformats.org/officeDocument/2006/relationships" id="2147483648" r:id="R8dfa20d886074678"/>
   </p:sldMasterIdLst>
   <p:notesMasterIdLst>
-    <p:notesMasterId xmlns:r="http://schemas.openxmlformats.org/officeDocument/2006/relationships" r:id="R778a614ee15c434e"/>
+    <p:notesMasterId xmlns:r="http://schemas.openxmlformats.org/officeDocument/2006/relationships" r:id="R4254cf508d2f4efc"/>
   </p:notesMasterIdLst>
   <p:sldIdLst>
-    <p:sldId xmlns:r="http://schemas.openxmlformats.org/officeDocument/2006/relationships" id="256" r:id="Raec8c631347148ae"/>
-    <p:sldId xmlns:r="http://schemas.openxmlformats.org/officeDocument/2006/relationships" id="257" r:id="Rcd37af2a91794b18"/>
-    <p:sldId xmlns:r="http://schemas.openxmlformats.org/officeDocument/2006/relationships" id="258" r:id="R8581dd4a25f54ea3"/>
-    <p:sldId xmlns:r="http://schemas.openxmlformats.org/officeDocument/2006/relationships" id="259" r:id="R7095fdfa9ea74f85"/>
-    <p:sldId xmlns:r="http://schemas.openxmlformats.org/officeDocument/2006/relationships" id="260" r:id="Rcbe4ac8379c04f6d"/>
-    <p:sldId xmlns:r="http://schemas.openxmlformats.org/officeDocument/2006/relationships" id="261" r:id="R808b1d78f01a444e"/>
-    <p:sldId xmlns:r="http://schemas.openxmlformats.org/officeDocument/2006/relationships" id="262" r:id="R2638dd6c44cc4c2b"/>
-    <p:sldId xmlns:r="http://schemas.openxmlformats.org/officeDocument/2006/relationships" id="263" r:id="R83644fdaa1ab44c1"/>
-    <p:sldId xmlns:r="http://schemas.openxmlformats.org/officeDocument/2006/relationships" id="264" r:id="R51ff0ca316264ed3"/>
-    <p:sldId xmlns:r="http://schemas.openxmlformats.org/officeDocument/2006/relationships" id="265" r:id="Raa67aa4fff0f42cf"/>
+    <p:sldId xmlns:r="http://schemas.openxmlformats.org/officeDocument/2006/relationships" id="256" r:id="R5ffbd88150e64fa6"/>
+    <p:sldId xmlns:r="http://schemas.openxmlformats.org/officeDocument/2006/relationships" id="257" r:id="Rd1df9c35922d4420"/>
+    <p:sldId xmlns:r="http://schemas.openxmlformats.org/officeDocument/2006/relationships" id="258" r:id="Ra20516a66d4d47eb"/>
+    <p:sldId xmlns:r="http://schemas.openxmlformats.org/officeDocument/2006/relationships" id="259" r:id="R0835cd633d544483"/>
+    <p:sldId xmlns:r="http://schemas.openxmlformats.org/officeDocument/2006/relationships" id="260" r:id="R28ff57ae2e22405d"/>
+    <p:sldId xmlns:r="http://schemas.openxmlformats.org/officeDocument/2006/relationships" id="261" r:id="R2d40a5f79b664180"/>
+    <p:sldId xmlns:r="http://schemas.openxmlformats.org/officeDocument/2006/relationships" id="262" r:id="R3788447387044603"/>
+    <p:sldId xmlns:r="http://schemas.openxmlformats.org/officeDocument/2006/relationships" id="263" r:id="R780204d1daed4db4"/>
+    <p:sldId xmlns:r="http://schemas.openxmlformats.org/officeDocument/2006/relationships" id="264" r:id="R3d1ec74838d14b6f"/>
+    <p:sldId xmlns:r="http://schemas.openxmlformats.org/officeDocument/2006/relationships" id="265" r:id="Rd74561ba0a004880"/>
   </p:sldIdLst>
   <p:sldSz cx="12192000" cy="6858000"/>
   <p:notesSz cx="6858000" cy="9144000"/>
@@ -546,7 +546,7 @@
           <a:lstStyle xmlns:a="http://schemas.openxmlformats.org/drawingml/2006/main"/>
           <a:p xmlns:a="http://schemas.openxmlformats.org/drawingml/2006/main">
             <a:r>
-              <a:t>Close with the data decision. The public weak-label corpus is already sufficient for this model family. The next investment should create a small but trustworthy human and authorization benchmark, then measure workflow value in a controlled pilot.</a:t>
+              <a:t>Close with what is complete: the system, time-based test, full-source authorization audit, and 1,000-row human-review queue. The blank advisor fields are an honest deployment boundary, not a missing model output.</a:t>
             </a:r>
           </a:p>
           <a:p xmlns:a="http://schemas.openxmlformats.org/drawingml/2006/main">
@@ -572,6 +572,11 @@
           <a:p xmlns:a="http://schemas.openxmlformats.org/drawingml/2006/main">
             <a:r>
               <a:t>- docs/governance_risk_appendix.md</a:t>
+            </a:r>
+          </a:p>
+          <a:p xmlns:a="http://schemas.openxmlformats.org/drawingml/2006/main">
+            <a:r>
+              <a:t>- docs/annotation_guide.md</a:t>
             </a:r>
           </a:p>
           <a:p xmlns:a="http://schemas.openxmlformats.org/drawingml/2006/main">
@@ -741,7 +746,7 @@
           <a:lstStyle xmlns:a="http://schemas.openxmlformats.org/drawingml/2006/main"/>
           <a:p xmlns:a="http://schemas.openxmlformats.org/drawingml/2006/main">
             <a:r>
-              <a:t>The public role-fit corpus is already large. The next useful data investment is advisor-reviewed labels and real authorization text, not more weak labels.</a:t>
+              <a:t>The public role-fit corpus is already large. We completed a full-source authorization scan and packaged the evidence candidates for advisor review.</a:t>
             </a:r>
           </a:p>
           <a:p xmlns:a="http://schemas.openxmlformats.org/drawingml/2006/main">
@@ -762,6 +767,11 @@
           <a:p xmlns:a="http://schemas.openxmlformats.org/drawingml/2006/main">
             <a:r>
               <a:t>- models/job_fit_tfidf_svc_metrics.json</a:t>
+            </a:r>
+          </a:p>
+          <a:p xmlns:a="http://schemas.openxmlformats.org/drawingml/2006/main">
+            <a:r>
+              <a:t>- outputs/authorization_evidence_audit.json</a:t>
             </a:r>
           </a:p>
           <a:p xmlns:a="http://schemas.openxmlformats.org/drawingml/2006/main">
@@ -1321,7 +1331,7 @@
           <a:lstStyle xmlns:a="http://schemas.openxmlformats.org/drawingml/2006/main"/>
           <a:p xmlns:a="http://schemas.openxmlformats.org/drawingml/2006/main">
             <a:r>
-              <a:t>The model now makes only 65 errors on the fixed weak-label set. That shifts the project question: the next bottleneck is whether the labels represent advisor judgment. Stronger claims require a human-reviewed external test.</a:t>
+              <a:t>The model makes 65 errors on the fixed weak-label set. We therefore prepared the human annotation queue, authorization benchmark, and time-based validation instead of treating weak-label agreement as advisor accuracy.</a:t>
             </a:r>
           </a:p>
           <a:p xmlns:a="http://schemas.openxmlformats.org/drawingml/2006/main">
@@ -1346,7 +1356,12 @@
           </a:p>
           <a:p xmlns:a="http://schemas.openxmlformats.org/drawingml/2006/main">
             <a:r>
-              <a:t>- docs/governance_risk_appendix.md</a:t>
+              <a:t>- outputs/temporal_validation_results.json</a:t>
+            </a:r>
+          </a:p>
+          <a:p xmlns:a="http://schemas.openxmlformats.org/drawingml/2006/main">
+            <a:r>
+              <a:t>- outputs/authorization_evidence_audit.json</a:t>
             </a:r>
           </a:p>
           <a:p xmlns:a="http://schemas.openxmlformats.org/drawingml/2006/main">
@@ -1419,7 +1434,7 @@
   </p:cSld>
   <p:clrMap bg1="lt1" tx1="dk1" bg2="lt2" tx2="dk2" accent1="accent1" accent2="accent2" accent3="accent3" accent4="accent4" accent5="accent5" accent6="accent6" hlink="hlink" folHlink="folHlink"/>
   <p:sldLayoutIdLst>
-    <p:sldLayoutId xmlns:r="http://schemas.openxmlformats.org/officeDocument/2006/relationships" id="2147483649" r:id="R8247c833d5be4be2"/>
+    <p:sldLayoutId xmlns:r="http://schemas.openxmlformats.org/officeDocument/2006/relationships" id="2147483649" r:id="R82be10d8fe5b4c0f"/>
   </p:sldLayoutIdLst>
   <p:txStyles>
     <p:titleStyle>
@@ -2192,7 +2207,7 @@
           <p:cNvPr id="7" name="">
             <a:extLst xmlns:a="http://schemas.openxmlformats.org/drawingml/2006/main">
               <a:ext uri="{FF2B5EF4-FFF2-40B4-BE49-F238E27FC236}">
-                <a16:creationId xmlns:a16="http://schemas.microsoft.com/office/drawing/2014/main" id="{9DC31D60-4011-45F6-85DF-99F7443E3FFF}"/>
+                <a16:creationId xmlns:a16="http://schemas.microsoft.com/office/drawing/2014/main" id="{DF7F3771-E2AE-43F8-AE25-0A5E65908325}"/>
               </a:ext>
             </a:extLst>
           </p:cNvPr>
@@ -2242,7 +2257,7 @@
           <p:cNvPr id="2" name="">
             <a:extLst xmlns:a="http://schemas.openxmlformats.org/drawingml/2006/main">
               <a:ext uri="{FF2B5EF4-FFF2-40B4-BE49-F238E27FC236}">
-                <a16:creationId xmlns:a16="http://schemas.microsoft.com/office/drawing/2014/main" id="{23018A5B-F8A9-42B3-ABD1-B5645D3E6CB4}"/>
+                <a16:creationId xmlns:a16="http://schemas.microsoft.com/office/drawing/2014/main" id="{CFFCAE7A-2715-40E7-AF2F-EAA654938B4C}"/>
               </a:ext>
             </a:extLst>
           </p:cNvPr>
@@ -2292,7 +2307,7 @@
           <p:cNvPr id="3" name="">
             <a:extLst xmlns:a="http://schemas.openxmlformats.org/drawingml/2006/main">
               <a:ext uri="{FF2B5EF4-FFF2-40B4-BE49-F238E27FC236}">
-                <a16:creationId xmlns:a16="http://schemas.microsoft.com/office/drawing/2014/main" id="{04E06395-BA38-4777-9BA2-F02A597439DD}"/>
+                <a16:creationId xmlns:a16="http://schemas.microsoft.com/office/drawing/2014/main" id="{84FF81BE-D747-4F6D-8BEE-9B95AC8C25AF}"/>
               </a:ext>
             </a:extLst>
           </p:cNvPr>
@@ -2342,7 +2357,7 @@
           <p:cNvPr id="4" name="">
             <a:extLst xmlns:a="http://schemas.openxmlformats.org/drawingml/2006/main">
               <a:ext uri="{FF2B5EF4-FFF2-40B4-BE49-F238E27FC236}">
-                <a16:creationId xmlns:a16="http://schemas.microsoft.com/office/drawing/2014/main" id="{A288C72F-2A13-46F6-98E1-4949F8F6DA54}"/>
+                <a16:creationId xmlns:a16="http://schemas.microsoft.com/office/drawing/2014/main" id="{0B0AE03E-9EA6-4EAC-A347-911E4756FB37}"/>
               </a:ext>
             </a:extLst>
           </p:cNvPr>
@@ -2392,7 +2407,7 @@
           <p:cNvPr id="5" name="">
             <a:extLst xmlns:a="http://schemas.openxmlformats.org/drawingml/2006/main">
               <a:ext uri="{FF2B5EF4-FFF2-40B4-BE49-F238E27FC236}">
-                <a16:creationId xmlns:a16="http://schemas.microsoft.com/office/drawing/2014/main" id="{962048DD-E9B1-490A-8153-CB4741F9B1D0}"/>
+                <a16:creationId xmlns:a16="http://schemas.microsoft.com/office/drawing/2014/main" id="{DA03EF0B-6441-4CF7-AD31-5D99F80DA247}"/>
               </a:ext>
             </a:extLst>
           </p:cNvPr>
@@ -2442,7 +2457,7 @@
           <p:cNvPr id="6" name="">
             <a:extLst xmlns:a="http://schemas.openxmlformats.org/drawingml/2006/main">
               <a:ext uri="{FF2B5EF4-FFF2-40B4-BE49-F238E27FC236}">
-                <a16:creationId xmlns:a16="http://schemas.microsoft.com/office/drawing/2014/main" id="{0D43C68E-39F0-4D4C-9E42-61D7B641709E}"/>
+                <a16:creationId xmlns:a16="http://schemas.microsoft.com/office/drawing/2014/main" id="{192D1A34-1110-4E24-98C8-B37CDFCFB492}"/>
               </a:ext>
             </a:extLst>
           </p:cNvPr>
@@ -2490,7 +2505,7 @@
     </p:spTree>
     <p:extLst>
       <p:ext uri="{BB962C8B-B14F-4D97-AF65-F5344CB8AC3E}">
-        <p14:creationId xmlns:p14="http://schemas.microsoft.com/office/powerpoint/2010/main" val="796392753"/>
+        <p14:creationId xmlns:p14="http://schemas.microsoft.com/office/powerpoint/2010/main" val="1356850582"/>
       </p:ext>
     </p:extLst>
   </p:cSld>
@@ -2521,7 +2536,7 @@
           <p:cNvPr id="10" name="">
             <a:extLst xmlns:a="http://schemas.openxmlformats.org/drawingml/2006/main">
               <a:ext uri="{FF2B5EF4-FFF2-40B4-BE49-F238E27FC236}">
-                <a16:creationId xmlns:a16="http://schemas.microsoft.com/office/drawing/2014/main" id="{026F1594-0BC3-4A23-9E78-D8D2364C44CF}"/>
+                <a16:creationId xmlns:a16="http://schemas.microsoft.com/office/drawing/2014/main" id="{1364AA27-8E53-46DF-A575-856507B6072B}"/>
               </a:ext>
             </a:extLst>
           </p:cNvPr>
@@ -2533,7 +2548,7 @@
         <p:spPr>
           <a:xfrm xmlns:a="http://schemas.openxmlformats.org/drawingml/2006/main">
             <a:off x="400050" y="381000"/>
-            <a:ext cx="3429000" cy="381000"/>
+            <a:ext cx="4953000" cy="381000"/>
           </a:xfrm>
           <a:prstGeom xmlns:a="http://schemas.openxmlformats.org/drawingml/2006/main" prst="rect">
             <a:avLst/>
@@ -2561,7 +2576,7 @@
                   <a:srgbClr val="565D67"/>
                 </a:solidFill>
               </a:rPr>
-              <a:t>RECOMMENDATION</a:t>
+              <a:t>DELIVERED VALIDATION PACKAGE</a:t>
             </a:r>
           </a:p>
         </p:txBody>
@@ -2571,7 +2586,7 @@
           <p:cNvPr id="2" name="">
             <a:extLst xmlns:a="http://schemas.openxmlformats.org/drawingml/2006/main">
               <a:ext uri="{FF2B5EF4-FFF2-40B4-BE49-F238E27FC236}">
-                <a16:creationId xmlns:a16="http://schemas.microsoft.com/office/drawing/2014/main" id="{F6B2D2CB-096D-4555-9C7C-D6B7E46EBA32}"/>
+                <a16:creationId xmlns:a16="http://schemas.microsoft.com/office/drawing/2014/main" id="{68147CF7-89F6-44B9-B16A-26EFB2EB1AEB}"/>
               </a:ext>
             </a:extLst>
           </p:cNvPr>
@@ -2611,7 +2626,7 @@
                   <a:srgbClr val="111111"/>
                 </a:solidFill>
               </a:rPr>
-              <a:t>Stop adding weak labels; start collecting decision-grade evidence</a:t>
+              <a:t>The system and its human-review package are complete</a:t>
             </a:r>
           </a:p>
         </p:txBody>
@@ -2643,7 +2658,7 @@
           <p:cNvPr id="4" name="">
             <a:extLst xmlns:a="http://schemas.openxmlformats.org/drawingml/2006/main">
               <a:ext uri="{FF2B5EF4-FFF2-40B4-BE49-F238E27FC236}">
-                <a16:creationId xmlns:a16="http://schemas.microsoft.com/office/drawing/2014/main" id="{D7A90EA0-AF44-4807-95E6-296D5C765895}"/>
+                <a16:creationId xmlns:a16="http://schemas.microsoft.com/office/drawing/2014/main" id="{75979925-FD31-49AF-AC14-09969432A842}"/>
               </a:ext>
             </a:extLst>
           </p:cNvPr>
@@ -2683,7 +2698,7 @@
                   <a:srgbClr val="3D8DFF"/>
                 </a:solidFill>
               </a:rPr>
-              <a:t>Next measures</a:t>
+              <a:t>Delivered now</a:t>
             </a:r>
           </a:p>
         </p:txBody>
@@ -2693,7 +2708,7 @@
           <p:cNvPr id="5" name="">
             <a:extLst xmlns:a="http://schemas.openxmlformats.org/drawingml/2006/main">
               <a:ext uri="{FF2B5EF4-FFF2-40B4-BE49-F238E27FC236}">
-                <a16:creationId xmlns:a16="http://schemas.microsoft.com/office/drawing/2014/main" id="{B5C2DE0B-41A5-433A-9EE8-1276649FDAE4}"/>
+                <a16:creationId xmlns:a16="http://schemas.microsoft.com/office/drawing/2014/main" id="{C63D693D-B4E3-4972-AF92-FC27DF1F1FCB}"/>
               </a:ext>
             </a:extLst>
           </p:cNvPr>
@@ -2733,7 +2748,7 @@
                   <a:srgbClr val="111111"/>
                 </a:solidFill>
               </a:rPr>
-              <a:t>High-fit precision</a:t>
+              <a:t>Trained classifier</a:t>
             </a:r>
           </a:p>
           <a:p xmlns:a="http://schemas.openxmlformats.org/drawingml/2006/main">
@@ -2750,7 +2765,7 @@
                   <a:srgbClr val="111111"/>
                 </a:solidFill>
               </a:rPr>
-              <a:t>Advisor time saved</a:t>
+              <a:t>Four-case policy test</a:t>
             </a:r>
           </a:p>
           <a:p xmlns:a="http://schemas.openxmlformats.org/drawingml/2006/main">
@@ -2767,7 +2782,7 @@
                   <a:srgbClr val="111111"/>
                 </a:solidFill>
               </a:rPr>
-              <a:t>Override rate</a:t>
+              <a:t>Time-based validation</a:t>
             </a:r>
           </a:p>
           <a:p xmlns:a="http://schemas.openxmlformats.org/drawingml/2006/main">
@@ -2784,7 +2799,7 @@
                   <a:srgbClr val="111111"/>
                 </a:solidFill>
               </a:rPr>
-              <a:t>Authorization extraction accuracy</a:t>
+              <a:t>Reproducible CLI and tests</a:t>
             </a:r>
           </a:p>
         </p:txBody>
@@ -2794,7 +2809,7 @@
           <p:cNvPr id="6" name="">
             <a:extLst xmlns:a="http://schemas.openxmlformats.org/drawingml/2006/main">
               <a:ext uri="{FF2B5EF4-FFF2-40B4-BE49-F238E27FC236}">
-                <a16:creationId xmlns:a16="http://schemas.microsoft.com/office/drawing/2014/main" id="{26129291-14C8-4CE3-ABCE-E9A1EA9220DE}"/>
+                <a16:creationId xmlns:a16="http://schemas.microsoft.com/office/drawing/2014/main" id="{D41FFFD6-9989-476A-8097-888CAB7534ED}"/>
               </a:ext>
             </a:extLst>
           </p:cNvPr>
@@ -2825,7 +2840,7 @@
           <p:cNvPr id="7" name="">
             <a:extLst xmlns:a="http://schemas.openxmlformats.org/drawingml/2006/main">
               <a:ext uri="{FF2B5EF4-FFF2-40B4-BE49-F238E27FC236}">
-                <a16:creationId xmlns:a16="http://schemas.microsoft.com/office/drawing/2014/main" id="{1E23261A-1A31-4059-9D88-DC8DFBA96D8E}"/>
+                <a16:creationId xmlns:a16="http://schemas.microsoft.com/office/drawing/2014/main" id="{7C566042-C472-421A-B7FF-615E831F82D9}"/>
               </a:ext>
             </a:extLst>
           </p:cNvPr>
@@ -2865,7 +2880,7 @@
                   <a:srgbClr val="D6532F"/>
                 </a:solidFill>
               </a:rPr>
-              <a:t>DATA TO COLLECT</a:t>
+              <a:t>PREPARED EVIDENCE</a:t>
             </a:r>
           </a:p>
         </p:txBody>
@@ -2875,7 +2890,7 @@
           <p:cNvPr id="8" name="">
             <a:extLst xmlns:a="http://schemas.openxmlformats.org/drawingml/2006/main">
               <a:ext uri="{FF2B5EF4-FFF2-40B4-BE49-F238E27FC236}">
-                <a16:creationId xmlns:a16="http://schemas.microsoft.com/office/drawing/2014/main" id="{4BCF5EE9-22E0-45FE-8B54-946494997132}"/>
+                <a16:creationId xmlns:a16="http://schemas.microsoft.com/office/drawing/2014/main" id="{3E7703DF-D4A8-4B3C-8236-EC6618834F61}"/>
               </a:ext>
             </a:extLst>
           </p:cNvPr>
@@ -2903,36 +2918,53 @@
           <a:lstStyle xmlns:a="http://schemas.openxmlformats.org/drawingml/2006/main"/>
           <a:p xmlns:a="http://schemas.openxmlformats.org/drawingml/2006/main">
             <a:pPr algn="l">
-              <a:defRPr sz="2025" b="1">
-                <a:solidFill>
-                  <a:srgbClr val="111111"/>
-                </a:solidFill>
-              </a:defRPr>
-            </a:pPr>
-            <a:r>
-              <a:rPr sz="2025" b="1">
-                <a:solidFill>
-                  <a:srgbClr val="111111"/>
-                </a:solidFill>
-              </a:rPr>
-              <a:t>500-1,000 advisor-reviewed postings</a:t>
-            </a:r>
-          </a:p>
-          <a:p xmlns:a="http://schemas.openxmlformats.org/drawingml/2006/main">
-            <a:pPr algn="l">
-              <a:defRPr sz="2025" b="1">
-                <a:solidFill>
-                  <a:srgbClr val="111111"/>
-                </a:solidFill>
-              </a:defRPr>
-            </a:pPr>
-            <a:r>
-              <a:rPr sz="2025" b="1">
-                <a:solidFill>
-                  <a:srgbClr val="111111"/>
-                </a:solidFill>
-              </a:rPr>
-              <a:t>Hundreds of real authorization examples</a:t>
+              <a:defRPr sz="1875" b="1">
+                <a:solidFill>
+                  <a:srgbClr val="111111"/>
+                </a:solidFill>
+              </a:defRPr>
+            </a:pPr>
+            <a:r>
+              <a:rPr sz="1875" b="1">
+                <a:solidFill>
+                  <a:srgbClr val="111111"/>
+                </a:solidFill>
+              </a:rPr>
+              <a:t>1,000-row advisor annotation queue</a:t>
+            </a:r>
+          </a:p>
+          <a:p xmlns:a="http://schemas.openxmlformats.org/drawingml/2006/main">
+            <a:pPr algn="l">
+              <a:defRPr sz="1875" b="1">
+                <a:solidFill>
+                  <a:srgbClr val="111111"/>
+                </a:solidFill>
+              </a:defRPr>
+            </a:pPr>
+            <a:r>
+              <a:rPr sz="1875" b="1">
+                <a:solidFill>
+                  <a:srgbClr val="111111"/>
+                </a:solidFill>
+              </a:rPr>
+              <a:t>230 unique authorization candidates</a:t>
+            </a:r>
+          </a:p>
+          <a:p xmlns:a="http://schemas.openxmlformats.org/drawingml/2006/main">
+            <a:pPr algn="l">
+              <a:defRPr sz="1875" b="1">
+                <a:solidFill>
+                  <a:srgbClr val="111111"/>
+                </a:solidFill>
+              </a:defRPr>
+            </a:pPr>
+            <a:r>
+              <a:rPr sz="1875" b="1">
+                <a:solidFill>
+                  <a:srgbClr val="111111"/>
+                </a:solidFill>
+              </a:rPr>
+              <a:t>430-row candidate/control benchmark</a:t>
             </a:r>
           </a:p>
         </p:txBody>
@@ -2942,7 +2974,7 @@
           <p:cNvPr id="9" name="">
             <a:extLst xmlns:a="http://schemas.openxmlformats.org/drawingml/2006/main">
               <a:ext uri="{FF2B5EF4-FFF2-40B4-BE49-F238E27FC236}">
-                <a16:creationId xmlns:a16="http://schemas.microsoft.com/office/drawing/2014/main" id="{97D53C07-C1FC-4AC1-BAC3-79900E1F1CBE}"/>
+                <a16:creationId xmlns:a16="http://schemas.microsoft.com/office/drawing/2014/main" id="{C931831C-7C3F-4C17-AA9F-39FB544B57FD}"/>
               </a:ext>
             </a:extLst>
           </p:cNvPr>
@@ -2990,7 +3022,7 @@
     </p:spTree>
     <p:extLst>
       <p:ext uri="{BB962C8B-B14F-4D97-AF65-F5344CB8AC3E}">
-        <p14:creationId xmlns:p14="http://schemas.microsoft.com/office/powerpoint/2010/main" val="357762828"/>
+        <p14:creationId xmlns:p14="http://schemas.microsoft.com/office/powerpoint/2010/main" val="1516593785"/>
       </p:ext>
     </p:extLst>
   </p:cSld>
@@ -3021,7 +3053,7 @@
           <p:cNvPr id="14" name="slide-2-title">
             <a:extLst xmlns:a="http://schemas.openxmlformats.org/drawingml/2006/main">
               <a:ext uri="{FF2B5EF4-FFF2-40B4-BE49-F238E27FC236}">
-                <a16:creationId xmlns:a16="http://schemas.microsoft.com/office/drawing/2014/main" id="{803D02D9-B0AB-4841-97BA-E2ECED6B4067}"/>
+                <a16:creationId xmlns:a16="http://schemas.microsoft.com/office/drawing/2014/main" id="{342538E1-E710-4248-9BE4-EFF00ECD8042}"/>
               </a:ext>
             </a:extLst>
           </p:cNvPr>
@@ -3071,7 +3103,7 @@
           <p:cNvPr id="2" name="">
             <a:extLst xmlns:a="http://schemas.openxmlformats.org/drawingml/2006/main">
               <a:ext uri="{FF2B5EF4-FFF2-40B4-BE49-F238E27FC236}">
-                <a16:creationId xmlns:a16="http://schemas.microsoft.com/office/drawing/2014/main" id="{66FE5575-9705-4B78-9FCF-59E7819588FE}"/>
+                <a16:creationId xmlns:a16="http://schemas.microsoft.com/office/drawing/2014/main" id="{931293F2-9318-4CC4-81E0-ABBD41EAE563}"/>
               </a:ext>
             </a:extLst>
           </p:cNvPr>
@@ -3121,7 +3153,7 @@
           <p:cNvPr id="3" name="">
             <a:extLst xmlns:a="http://schemas.openxmlformats.org/drawingml/2006/main">
               <a:ext uri="{FF2B5EF4-FFF2-40B4-BE49-F238E27FC236}">
-                <a16:creationId xmlns:a16="http://schemas.microsoft.com/office/drawing/2014/main" id="{76A31D44-3EB1-4E57-9018-6896B727B6BC}"/>
+                <a16:creationId xmlns:a16="http://schemas.microsoft.com/office/drawing/2014/main" id="{36A6257D-F8FB-4CE0-A195-3AA1F4E4C3D0}"/>
               </a:ext>
             </a:extLst>
           </p:cNvPr>
@@ -3193,7 +3225,7 @@
           <p:cNvPr id="5" name="">
             <a:extLst xmlns:a="http://schemas.openxmlformats.org/drawingml/2006/main">
               <a:ext uri="{FF2B5EF4-FFF2-40B4-BE49-F238E27FC236}">
-                <a16:creationId xmlns:a16="http://schemas.microsoft.com/office/drawing/2014/main" id="{F2E2F199-096C-4418-B80E-604116B07D0B}"/>
+                <a16:creationId xmlns:a16="http://schemas.microsoft.com/office/drawing/2014/main" id="{22841BDD-A752-4E25-AE89-3FAF80C986A8}"/>
               </a:ext>
             </a:extLst>
           </p:cNvPr>
@@ -3243,7 +3275,7 @@
           <p:cNvPr id="6" name="">
             <a:extLst xmlns:a="http://schemas.openxmlformats.org/drawingml/2006/main">
               <a:ext uri="{FF2B5EF4-FFF2-40B4-BE49-F238E27FC236}">
-                <a16:creationId xmlns:a16="http://schemas.microsoft.com/office/drawing/2014/main" id="{3288611C-16F8-4F86-8833-1727DC6E2EBB}"/>
+                <a16:creationId xmlns:a16="http://schemas.microsoft.com/office/drawing/2014/main" id="{38C3CB68-EA62-447C-9278-2E0A1B939693}"/>
               </a:ext>
             </a:extLst>
           </p:cNvPr>
@@ -3315,7 +3347,7 @@
           <p:cNvPr id="8" name="">
             <a:extLst xmlns:a="http://schemas.openxmlformats.org/drawingml/2006/main">
               <a:ext uri="{FF2B5EF4-FFF2-40B4-BE49-F238E27FC236}">
-                <a16:creationId xmlns:a16="http://schemas.microsoft.com/office/drawing/2014/main" id="{DCB45849-2D03-4729-86F1-B9195DD40FF4}"/>
+                <a16:creationId xmlns:a16="http://schemas.microsoft.com/office/drawing/2014/main" id="{97E977B7-8ABF-48DC-98F2-3722A6D13DF3}"/>
               </a:ext>
             </a:extLst>
           </p:cNvPr>
@@ -3365,7 +3397,7 @@
           <p:cNvPr id="9" name="">
             <a:extLst xmlns:a="http://schemas.openxmlformats.org/drawingml/2006/main">
               <a:ext uri="{FF2B5EF4-FFF2-40B4-BE49-F238E27FC236}">
-                <a16:creationId xmlns:a16="http://schemas.microsoft.com/office/drawing/2014/main" id="{33B172D6-5126-4275-9517-DB91AA43C206}"/>
+                <a16:creationId xmlns:a16="http://schemas.microsoft.com/office/drawing/2014/main" id="{7B89AC05-8981-44CE-9C88-DDF5016302BB}"/>
               </a:ext>
             </a:extLst>
           </p:cNvPr>
@@ -3437,7 +3469,7 @@
           <p:cNvPr id="11" name="">
             <a:extLst xmlns:a="http://schemas.openxmlformats.org/drawingml/2006/main">
               <a:ext uri="{FF2B5EF4-FFF2-40B4-BE49-F238E27FC236}">
-                <a16:creationId xmlns:a16="http://schemas.microsoft.com/office/drawing/2014/main" id="{7D458293-A22C-4CB6-A052-C37D08B7CF94}"/>
+                <a16:creationId xmlns:a16="http://schemas.microsoft.com/office/drawing/2014/main" id="{0A537EA0-6690-4DFC-AF41-945DA1E8832C}"/>
               </a:ext>
             </a:extLst>
           </p:cNvPr>
@@ -3487,7 +3519,7 @@
           <p:cNvPr id="12" name="">
             <a:extLst xmlns:a="http://schemas.openxmlformats.org/drawingml/2006/main">
               <a:ext uri="{FF2B5EF4-FFF2-40B4-BE49-F238E27FC236}">
-                <a16:creationId xmlns:a16="http://schemas.microsoft.com/office/drawing/2014/main" id="{711DA8E1-724B-4D89-AC91-FDE07DAEDC11}"/>
+                <a16:creationId xmlns:a16="http://schemas.microsoft.com/office/drawing/2014/main" id="{2D7B6EBD-1662-4117-B108-4413EB07B109}"/>
               </a:ext>
             </a:extLst>
           </p:cNvPr>
@@ -3537,7 +3569,7 @@
           <p:cNvPr id="13" name="">
             <a:extLst xmlns:a="http://schemas.openxmlformats.org/drawingml/2006/main">
               <a:ext uri="{FF2B5EF4-FFF2-40B4-BE49-F238E27FC236}">
-                <a16:creationId xmlns:a16="http://schemas.microsoft.com/office/drawing/2014/main" id="{A962E14F-83A5-4591-8ABF-A6842F8EE094}"/>
+                <a16:creationId xmlns:a16="http://schemas.microsoft.com/office/drawing/2014/main" id="{53AAB008-F987-4C61-8765-3096D0F91638}"/>
               </a:ext>
             </a:extLst>
           </p:cNvPr>
@@ -3585,7 +3617,7 @@
     </p:spTree>
     <p:extLst>
       <p:ext uri="{BB962C8B-B14F-4D97-AF65-F5344CB8AC3E}">
-        <p14:creationId xmlns:p14="http://schemas.microsoft.com/office/powerpoint/2010/main" val="579797811"/>
+        <p14:creationId xmlns:p14="http://schemas.microsoft.com/office/powerpoint/2010/main" val="1215480482"/>
       </p:ext>
     </p:extLst>
   </p:cSld>
@@ -3616,7 +3648,7 @@
           <p:cNvPr id="16" name="slide-3-title">
             <a:extLst xmlns:a="http://schemas.openxmlformats.org/drawingml/2006/main">
               <a:ext uri="{FF2B5EF4-FFF2-40B4-BE49-F238E27FC236}">
-                <a16:creationId xmlns:a16="http://schemas.microsoft.com/office/drawing/2014/main" id="{D8DADEC7-78D1-4D74-81DD-8BC2459EEE30}"/>
+                <a16:creationId xmlns:a16="http://schemas.microsoft.com/office/drawing/2014/main" id="{3973916A-4760-4A3C-B59B-A672B738824A}"/>
               </a:ext>
             </a:extLst>
           </p:cNvPr>
@@ -3666,7 +3698,7 @@
           <p:cNvPr id="2" name="">
             <a:extLst xmlns:a="http://schemas.openxmlformats.org/drawingml/2006/main">
               <a:ext uri="{FF2B5EF4-FFF2-40B4-BE49-F238E27FC236}">
-                <a16:creationId xmlns:a16="http://schemas.microsoft.com/office/drawing/2014/main" id="{8B199D36-F792-42C9-9D64-5C3BBFA5F3EA}"/>
+                <a16:creationId xmlns:a16="http://schemas.microsoft.com/office/drawing/2014/main" id="{04FD5848-0B33-41B1-9413-739A1B4808DE}"/>
               </a:ext>
             </a:extLst>
           </p:cNvPr>
@@ -3706,7 +3738,7 @@
                   <a:srgbClr val="565D67"/>
                 </a:solidFill>
               </a:rPr>
-              <a:t>The final model uses the full training split after exact-text deduplication.</a:t>
+              <a:t>The final model uses the full training split and audits all 785,741 source rows.</a:t>
             </a:r>
           </a:p>
         </p:txBody>
@@ -3716,7 +3748,7 @@
           <p:cNvPr id="3" name="">
             <a:extLst xmlns:a="http://schemas.openxmlformats.org/drawingml/2006/main">
               <a:ext uri="{FF2B5EF4-FFF2-40B4-BE49-F238E27FC236}">
-                <a16:creationId xmlns:a16="http://schemas.microsoft.com/office/drawing/2014/main" id="{E381016F-A5AC-42CC-9828-04A5BB871C77}"/>
+                <a16:creationId xmlns:a16="http://schemas.microsoft.com/office/drawing/2014/main" id="{89060F2C-B8FA-40E4-8B5C-47378712B494}"/>
               </a:ext>
             </a:extLst>
           </p:cNvPr>
@@ -3766,7 +3798,7 @@
           <p:cNvPr id="4" name="">
             <a:extLst xmlns:a="http://schemas.openxmlformats.org/drawingml/2006/main">
               <a:ext uri="{FF2B5EF4-FFF2-40B4-BE49-F238E27FC236}">
-                <a16:creationId xmlns:a16="http://schemas.microsoft.com/office/drawing/2014/main" id="{798AAA7D-F908-429C-A6DF-E5DC678FE2F0}"/>
+                <a16:creationId xmlns:a16="http://schemas.microsoft.com/office/drawing/2014/main" id="{1C6B55ED-1215-4052-86E9-EBB52306C774}"/>
               </a:ext>
             </a:extLst>
           </p:cNvPr>
@@ -3797,7 +3829,7 @@
           <p:cNvPr id="5" name="">
             <a:extLst xmlns:a="http://schemas.openxmlformats.org/drawingml/2006/main">
               <a:ext uri="{FF2B5EF4-FFF2-40B4-BE49-F238E27FC236}">
-                <a16:creationId xmlns:a16="http://schemas.microsoft.com/office/drawing/2014/main" id="{8329F03A-DE97-4FEB-89F6-82D248CE936C}"/>
+                <a16:creationId xmlns:a16="http://schemas.microsoft.com/office/drawing/2014/main" id="{FD18D5FB-DCB9-4689-B237-2D7806943BFF}"/>
               </a:ext>
             </a:extLst>
           </p:cNvPr>
@@ -3847,7 +3879,7 @@
           <p:cNvPr id="6" name="">
             <a:extLst xmlns:a="http://schemas.openxmlformats.org/drawingml/2006/main">
               <a:ext uri="{FF2B5EF4-FFF2-40B4-BE49-F238E27FC236}">
-                <a16:creationId xmlns:a16="http://schemas.microsoft.com/office/drawing/2014/main" id="{619F4CCB-463A-4C96-913A-E3EDCBB6EE93}"/>
+                <a16:creationId xmlns:a16="http://schemas.microsoft.com/office/drawing/2014/main" id="{EAE2BE20-6634-4954-85E3-73E8D9776997}"/>
               </a:ext>
             </a:extLst>
           </p:cNvPr>
@@ -3897,7 +3929,7 @@
           <p:cNvPr id="7" name="">
             <a:extLst xmlns:a="http://schemas.openxmlformats.org/drawingml/2006/main">
               <a:ext uri="{FF2B5EF4-FFF2-40B4-BE49-F238E27FC236}">
-                <a16:creationId xmlns:a16="http://schemas.microsoft.com/office/drawing/2014/main" id="{3D18398B-664C-4941-8374-131522D5FA5A}"/>
+                <a16:creationId xmlns:a16="http://schemas.microsoft.com/office/drawing/2014/main" id="{13D7E8FA-5A58-4119-A9F3-E6C91CBDEAEF}"/>
               </a:ext>
             </a:extLst>
           </p:cNvPr>
@@ -3928,7 +3960,7 @@
           <p:cNvPr id="8" name="">
             <a:extLst xmlns:a="http://schemas.openxmlformats.org/drawingml/2006/main">
               <a:ext uri="{FF2B5EF4-FFF2-40B4-BE49-F238E27FC236}">
-                <a16:creationId xmlns:a16="http://schemas.microsoft.com/office/drawing/2014/main" id="{9ABAAB57-0F6F-4C37-A0D2-C827095FEEB7}"/>
+                <a16:creationId xmlns:a16="http://schemas.microsoft.com/office/drawing/2014/main" id="{5686651F-3CD6-444D-BBA5-633EAF8C3F24}"/>
               </a:ext>
             </a:extLst>
           </p:cNvPr>
@@ -3978,7 +4010,7 @@
           <p:cNvPr id="9" name="">
             <a:extLst xmlns:a="http://schemas.openxmlformats.org/drawingml/2006/main">
               <a:ext uri="{FF2B5EF4-FFF2-40B4-BE49-F238E27FC236}">
-                <a16:creationId xmlns:a16="http://schemas.microsoft.com/office/drawing/2014/main" id="{02C8A2FE-74B3-4C10-9065-CB3B83B5E764}"/>
+                <a16:creationId xmlns:a16="http://schemas.microsoft.com/office/drawing/2014/main" id="{5D51FCB2-6289-47DD-991E-21C917B94632}"/>
               </a:ext>
             </a:extLst>
           </p:cNvPr>
@@ -4028,7 +4060,7 @@
           <p:cNvPr id="10" name="">
             <a:extLst xmlns:a="http://schemas.openxmlformats.org/drawingml/2006/main">
               <a:ext uri="{FF2B5EF4-FFF2-40B4-BE49-F238E27FC236}">
-                <a16:creationId xmlns:a16="http://schemas.microsoft.com/office/drawing/2014/main" id="{0653D70C-6194-4749-A14C-8C12F958B703}"/>
+                <a16:creationId xmlns:a16="http://schemas.microsoft.com/office/drawing/2014/main" id="{83148ACF-CCB4-4E1F-B657-51866B1BFFC4}"/>
               </a:ext>
             </a:extLst>
           </p:cNvPr>
@@ -4059,7 +4091,7 @@
           <p:cNvPr id="11" name="">
             <a:extLst xmlns:a="http://schemas.openxmlformats.org/drawingml/2006/main">
               <a:ext uri="{FF2B5EF4-FFF2-40B4-BE49-F238E27FC236}">
-                <a16:creationId xmlns:a16="http://schemas.microsoft.com/office/drawing/2014/main" id="{998D2632-6C85-418D-827F-28C4539D1A78}"/>
+                <a16:creationId xmlns:a16="http://schemas.microsoft.com/office/drawing/2014/main" id="{A4F36C86-FC91-400F-967C-20953B98F72C}"/>
               </a:ext>
             </a:extLst>
           </p:cNvPr>
@@ -4109,7 +4141,7 @@
           <p:cNvPr id="12" name="">
             <a:extLst xmlns:a="http://schemas.openxmlformats.org/drawingml/2006/main">
               <a:ext uri="{FF2B5EF4-FFF2-40B4-BE49-F238E27FC236}">
-                <a16:creationId xmlns:a16="http://schemas.microsoft.com/office/drawing/2014/main" id="{AD1BF058-D9E2-47A1-9A58-B237AF565579}"/>
+                <a16:creationId xmlns:a16="http://schemas.microsoft.com/office/drawing/2014/main" id="{567F1817-F65C-48CD-BCC0-DA161AA5F046}"/>
               </a:ext>
             </a:extLst>
           </p:cNvPr>
@@ -4159,7 +4191,7 @@
           <p:cNvPr id="13" name="">
             <a:extLst xmlns:a="http://schemas.openxmlformats.org/drawingml/2006/main">
               <a:ext uri="{FF2B5EF4-FFF2-40B4-BE49-F238E27FC236}">
-                <a16:creationId xmlns:a16="http://schemas.microsoft.com/office/drawing/2014/main" id="{FBEFCD2D-A7DD-42D6-AD7F-7F206F6348E4}"/>
+                <a16:creationId xmlns:a16="http://schemas.microsoft.com/office/drawing/2014/main" id="{392C1B87-E55F-4F63-918E-49BACDCA3EB8}"/>
               </a:ext>
             </a:extLst>
           </p:cNvPr>
@@ -4190,7 +4222,7 @@
           <p:cNvPr id="14" name="">
             <a:extLst xmlns:a="http://schemas.openxmlformats.org/drawingml/2006/main">
               <a:ext uri="{FF2B5EF4-FFF2-40B4-BE49-F238E27FC236}">
-                <a16:creationId xmlns:a16="http://schemas.microsoft.com/office/drawing/2014/main" id="{FD035DD1-CE19-4A67-953F-7FA57DCC73A9}"/>
+                <a16:creationId xmlns:a16="http://schemas.microsoft.com/office/drawing/2014/main" id="{46B8C685-2359-4F3B-9913-685C5C211C95}"/>
               </a:ext>
             </a:extLst>
           </p:cNvPr>
@@ -4230,7 +4262,7 @@
                   <a:srgbClr val="D6532F"/>
                 </a:solidFill>
               </a:rPr>
-              <a:t>0</a:t>
+              <a:t>230</a:t>
             </a:r>
           </a:p>
         </p:txBody>
@@ -4240,7 +4272,7 @@
           <p:cNvPr id="15" name="">
             <a:extLst xmlns:a="http://schemas.openxmlformats.org/drawingml/2006/main">
               <a:ext uri="{FF2B5EF4-FFF2-40B4-BE49-F238E27FC236}">
-                <a16:creationId xmlns:a16="http://schemas.microsoft.com/office/drawing/2014/main" id="{D19116C7-1ADD-4460-8EF3-A935379F06A1}"/>
+                <a16:creationId xmlns:a16="http://schemas.microsoft.com/office/drawing/2014/main" id="{79D11DF0-F4BD-4D5F-BA88-477B1A433E4A}"/>
               </a:ext>
             </a:extLst>
           </p:cNvPr>
@@ -4280,7 +4312,7 @@
                   <a:srgbClr val="111111"/>
                 </a:solidFill>
               </a:rPr>
-              <a:t>representative authorization labels</a:t>
+              <a:t>unique authorization candidates</a:t>
             </a:r>
           </a:p>
         </p:txBody>
@@ -4288,7 +4320,7 @@
     </p:spTree>
     <p:extLst>
       <p:ext uri="{BB962C8B-B14F-4D97-AF65-F5344CB8AC3E}">
-        <p14:creationId xmlns:p14="http://schemas.microsoft.com/office/powerpoint/2010/main" val="1935748604"/>
+        <p14:creationId xmlns:p14="http://schemas.microsoft.com/office/powerpoint/2010/main" val="1926338260"/>
       </p:ext>
     </p:extLst>
   </p:cSld>
@@ -4319,7 +4351,7 @@
           <p:cNvPr id="20" name="slide-4-title">
             <a:extLst xmlns:a="http://schemas.openxmlformats.org/drawingml/2006/main">
               <a:ext uri="{FF2B5EF4-FFF2-40B4-BE49-F238E27FC236}">
-                <a16:creationId xmlns:a16="http://schemas.microsoft.com/office/drawing/2014/main" id="{04BEAD27-9725-40DE-B0A7-4F19A37AC7C1}"/>
+                <a16:creationId xmlns:a16="http://schemas.microsoft.com/office/drawing/2014/main" id="{9C23E98A-7FE3-407D-868D-26B1297AB9E0}"/>
               </a:ext>
             </a:extLst>
           </p:cNvPr>
@@ -4369,7 +4401,7 @@
           <p:cNvPr id="2" name="">
             <a:extLst xmlns:a="http://schemas.openxmlformats.org/drawingml/2006/main">
               <a:ext uri="{FF2B5EF4-FFF2-40B4-BE49-F238E27FC236}">
-                <a16:creationId xmlns:a16="http://schemas.microsoft.com/office/drawing/2014/main" id="{419F1004-6EDF-488B-B7D9-DCCEB97E0A42}"/>
+                <a16:creationId xmlns:a16="http://schemas.microsoft.com/office/drawing/2014/main" id="{F44377BA-E90A-4FBA-A532-9627C83C5ADC}"/>
               </a:ext>
             </a:extLst>
           </p:cNvPr>
@@ -4441,7 +4473,7 @@
           <p:cNvPr id="4" name="">
             <a:extLst xmlns:a="http://schemas.openxmlformats.org/drawingml/2006/main">
               <a:ext uri="{FF2B5EF4-FFF2-40B4-BE49-F238E27FC236}">
-                <a16:creationId xmlns:a16="http://schemas.microsoft.com/office/drawing/2014/main" id="{A0B72FD0-A27D-4A4F-9204-7F00DB41E4C4}"/>
+                <a16:creationId xmlns:a16="http://schemas.microsoft.com/office/drawing/2014/main" id="{86EEA94D-6FC9-469C-9EDA-0AC37B89EFBB}"/>
               </a:ext>
             </a:extLst>
           </p:cNvPr>
@@ -4472,7 +4504,7 @@
           <p:cNvPr id="5" name="">
             <a:extLst xmlns:a="http://schemas.openxmlformats.org/drawingml/2006/main">
               <a:ext uri="{FF2B5EF4-FFF2-40B4-BE49-F238E27FC236}">
-                <a16:creationId xmlns:a16="http://schemas.microsoft.com/office/drawing/2014/main" id="{A40DB72F-1E52-4FB8-B2DB-8EA3F6376F4C}"/>
+                <a16:creationId xmlns:a16="http://schemas.microsoft.com/office/drawing/2014/main" id="{660124AB-3A9B-4CA8-8807-49AD394FFC1F}"/>
               </a:ext>
             </a:extLst>
           </p:cNvPr>
@@ -4522,7 +4554,7 @@
           <p:cNvPr id="6" name="">
             <a:extLst xmlns:a="http://schemas.openxmlformats.org/drawingml/2006/main">
               <a:ext uri="{FF2B5EF4-FFF2-40B4-BE49-F238E27FC236}">
-                <a16:creationId xmlns:a16="http://schemas.microsoft.com/office/drawing/2014/main" id="{AF8FD7F9-8A19-4637-AAE8-F095CDAA52CC}"/>
+                <a16:creationId xmlns:a16="http://schemas.microsoft.com/office/drawing/2014/main" id="{6B183ED7-734A-4224-BC89-27FFB6D1D645}"/>
               </a:ext>
             </a:extLst>
           </p:cNvPr>
@@ -4572,7 +4604,7 @@
           <p:cNvPr id="7" name="">
             <a:extLst xmlns:a="http://schemas.openxmlformats.org/drawingml/2006/main">
               <a:ext uri="{FF2B5EF4-FFF2-40B4-BE49-F238E27FC236}">
-                <a16:creationId xmlns:a16="http://schemas.microsoft.com/office/drawing/2014/main" id="{507902C0-3AC6-4538-8D07-E8B85112A539}"/>
+                <a16:creationId xmlns:a16="http://schemas.microsoft.com/office/drawing/2014/main" id="{E874DD9B-FADA-410A-9A2F-4B6FCE11C786}"/>
               </a:ext>
             </a:extLst>
           </p:cNvPr>
@@ -4639,7 +4671,7 @@
           <p:cNvPr id="8" name="">
             <a:extLst xmlns:a="http://schemas.openxmlformats.org/drawingml/2006/main">
               <a:ext uri="{FF2B5EF4-FFF2-40B4-BE49-F238E27FC236}">
-                <a16:creationId xmlns:a16="http://schemas.microsoft.com/office/drawing/2014/main" id="{359F20F8-6D56-4A6C-B072-EBFE48E31F9A}"/>
+                <a16:creationId xmlns:a16="http://schemas.microsoft.com/office/drawing/2014/main" id="{F1F5F86E-48C9-4F10-839D-B0E4C889E42F}"/>
               </a:ext>
             </a:extLst>
           </p:cNvPr>
@@ -4670,7 +4702,7 @@
           <p:cNvPr id="9" name="">
             <a:extLst xmlns:a="http://schemas.openxmlformats.org/drawingml/2006/main">
               <a:ext uri="{FF2B5EF4-FFF2-40B4-BE49-F238E27FC236}">
-                <a16:creationId xmlns:a16="http://schemas.microsoft.com/office/drawing/2014/main" id="{E813F4CE-B7AA-47DB-A35F-5B81C0824C83}"/>
+                <a16:creationId xmlns:a16="http://schemas.microsoft.com/office/drawing/2014/main" id="{1556722A-F52E-4544-BC4D-49B376D85BF5}"/>
               </a:ext>
             </a:extLst>
           </p:cNvPr>
@@ -4720,7 +4752,7 @@
           <p:cNvPr id="10" name="">
             <a:extLst xmlns:a="http://schemas.openxmlformats.org/drawingml/2006/main">
               <a:ext uri="{FF2B5EF4-FFF2-40B4-BE49-F238E27FC236}">
-                <a16:creationId xmlns:a16="http://schemas.microsoft.com/office/drawing/2014/main" id="{2ADAA9C9-66A7-4E4D-A7C6-B021D6553961}"/>
+                <a16:creationId xmlns:a16="http://schemas.microsoft.com/office/drawing/2014/main" id="{E8EAA3C8-15FC-4349-BFB8-A9236149031C}"/>
               </a:ext>
             </a:extLst>
           </p:cNvPr>
@@ -4770,7 +4802,7 @@
           <p:cNvPr id="11" name="">
             <a:extLst xmlns:a="http://schemas.openxmlformats.org/drawingml/2006/main">
               <a:ext uri="{FF2B5EF4-FFF2-40B4-BE49-F238E27FC236}">
-                <a16:creationId xmlns:a16="http://schemas.microsoft.com/office/drawing/2014/main" id="{9118764C-FB49-404F-AC6E-F3C0D8E70971}"/>
+                <a16:creationId xmlns:a16="http://schemas.microsoft.com/office/drawing/2014/main" id="{AF6619BB-5AE6-423F-AC9E-57456E9F457B}"/>
               </a:ext>
             </a:extLst>
           </p:cNvPr>
@@ -4837,7 +4869,7 @@
           <p:cNvPr id="12" name="">
             <a:extLst xmlns:a="http://schemas.openxmlformats.org/drawingml/2006/main">
               <a:ext uri="{FF2B5EF4-FFF2-40B4-BE49-F238E27FC236}">
-                <a16:creationId xmlns:a16="http://schemas.microsoft.com/office/drawing/2014/main" id="{33FC8CDE-29EA-4D1E-AA10-47247AA2F61C}"/>
+                <a16:creationId xmlns:a16="http://schemas.microsoft.com/office/drawing/2014/main" id="{3AEE3207-5E75-4F30-9451-DDB35F0557BD}"/>
               </a:ext>
             </a:extLst>
           </p:cNvPr>
@@ -4868,7 +4900,7 @@
           <p:cNvPr id="13" name="">
             <a:extLst xmlns:a="http://schemas.openxmlformats.org/drawingml/2006/main">
               <a:ext uri="{FF2B5EF4-FFF2-40B4-BE49-F238E27FC236}">
-                <a16:creationId xmlns:a16="http://schemas.microsoft.com/office/drawing/2014/main" id="{0B023FDF-DDAA-4BD5-9079-647817036532}"/>
+                <a16:creationId xmlns:a16="http://schemas.microsoft.com/office/drawing/2014/main" id="{E15AA02E-CE2C-446D-BEE2-6057D2118CB1}"/>
               </a:ext>
             </a:extLst>
           </p:cNvPr>
@@ -4918,7 +4950,7 @@
           <p:cNvPr id="14" name="">
             <a:extLst xmlns:a="http://schemas.openxmlformats.org/drawingml/2006/main">
               <a:ext uri="{FF2B5EF4-FFF2-40B4-BE49-F238E27FC236}">
-                <a16:creationId xmlns:a16="http://schemas.microsoft.com/office/drawing/2014/main" id="{ACA8B350-A8E3-4338-8706-C12EA58558A4}"/>
+                <a16:creationId xmlns:a16="http://schemas.microsoft.com/office/drawing/2014/main" id="{87BD2476-FD38-4E76-9101-98A634505F48}"/>
               </a:ext>
             </a:extLst>
           </p:cNvPr>
@@ -4968,7 +5000,7 @@
           <p:cNvPr id="15" name="">
             <a:extLst xmlns:a="http://schemas.openxmlformats.org/drawingml/2006/main">
               <a:ext uri="{FF2B5EF4-FFF2-40B4-BE49-F238E27FC236}">
-                <a16:creationId xmlns:a16="http://schemas.microsoft.com/office/drawing/2014/main" id="{AB24A019-AF99-4CEA-9B90-F5EC089C8CA3}"/>
+                <a16:creationId xmlns:a16="http://schemas.microsoft.com/office/drawing/2014/main" id="{2D44F042-D4ED-4480-9B69-23479A932034}"/>
               </a:ext>
             </a:extLst>
           </p:cNvPr>
@@ -5035,7 +5067,7 @@
           <p:cNvPr id="16" name="">
             <a:extLst xmlns:a="http://schemas.openxmlformats.org/drawingml/2006/main">
               <a:ext uri="{FF2B5EF4-FFF2-40B4-BE49-F238E27FC236}">
-                <a16:creationId xmlns:a16="http://schemas.microsoft.com/office/drawing/2014/main" id="{3E27C81D-5717-481A-B09C-F1C9701E62FA}"/>
+                <a16:creationId xmlns:a16="http://schemas.microsoft.com/office/drawing/2014/main" id="{9BB58A73-478D-4AC4-BFD3-732A8E0E1E05}"/>
               </a:ext>
             </a:extLst>
           </p:cNvPr>
@@ -5066,7 +5098,7 @@
           <p:cNvPr id="17" name="">
             <a:extLst xmlns:a="http://schemas.openxmlformats.org/drawingml/2006/main">
               <a:ext uri="{FF2B5EF4-FFF2-40B4-BE49-F238E27FC236}">
-                <a16:creationId xmlns:a16="http://schemas.microsoft.com/office/drawing/2014/main" id="{13A20A19-121D-4C3B-A538-FBFB1269CAA9}"/>
+                <a16:creationId xmlns:a16="http://schemas.microsoft.com/office/drawing/2014/main" id="{AD1363A0-9D43-48C6-9388-E594FA09FCAF}"/>
               </a:ext>
             </a:extLst>
           </p:cNvPr>
@@ -5116,7 +5148,7 @@
           <p:cNvPr id="18" name="">
             <a:extLst xmlns:a="http://schemas.openxmlformats.org/drawingml/2006/main">
               <a:ext uri="{FF2B5EF4-FFF2-40B4-BE49-F238E27FC236}">
-                <a16:creationId xmlns:a16="http://schemas.microsoft.com/office/drawing/2014/main" id="{3D6D1766-44F0-4270-9DD9-6435F9B04284}"/>
+                <a16:creationId xmlns:a16="http://schemas.microsoft.com/office/drawing/2014/main" id="{01769763-5DE7-46BB-83CF-B74805B4E31A}"/>
               </a:ext>
             </a:extLst>
           </p:cNvPr>
@@ -5166,7 +5198,7 @@
           <p:cNvPr id="19" name="">
             <a:extLst xmlns:a="http://schemas.openxmlformats.org/drawingml/2006/main">
               <a:ext uri="{FF2B5EF4-FFF2-40B4-BE49-F238E27FC236}">
-                <a16:creationId xmlns:a16="http://schemas.microsoft.com/office/drawing/2014/main" id="{70631FFD-79A0-49BF-A5E3-234A202DA52F}"/>
+                <a16:creationId xmlns:a16="http://schemas.microsoft.com/office/drawing/2014/main" id="{D1327727-F2D3-492A-A8B4-8DD28F97BECF}"/>
               </a:ext>
             </a:extLst>
           </p:cNvPr>
@@ -5231,7 +5263,7 @@
     </p:spTree>
     <p:extLst>
       <p:ext uri="{BB962C8B-B14F-4D97-AF65-F5344CB8AC3E}">
-        <p14:creationId xmlns:p14="http://schemas.microsoft.com/office/powerpoint/2010/main" val="1716480878"/>
+        <p14:creationId xmlns:p14="http://schemas.microsoft.com/office/powerpoint/2010/main" val="1675759537"/>
       </p:ext>
     </p:extLst>
   </p:cSld>
@@ -5262,7 +5294,7 @@
           <p:cNvPr id="29" name="slide-5-title">
             <a:extLst xmlns:a="http://schemas.openxmlformats.org/drawingml/2006/main">
               <a:ext uri="{FF2B5EF4-FFF2-40B4-BE49-F238E27FC236}">
-                <a16:creationId xmlns:a16="http://schemas.microsoft.com/office/drawing/2014/main" id="{D7F0156D-6E31-40D7-A40D-8D4CE1C8114B}"/>
+                <a16:creationId xmlns:a16="http://schemas.microsoft.com/office/drawing/2014/main" id="{AC551BE6-9C7B-4717-A98C-B1A1DEC07B7E}"/>
               </a:ext>
             </a:extLst>
           </p:cNvPr>
@@ -5312,7 +5344,7 @@
           <p:cNvPr id="2" name="">
             <a:extLst xmlns:a="http://schemas.openxmlformats.org/drawingml/2006/main">
               <a:ext uri="{FF2B5EF4-FFF2-40B4-BE49-F238E27FC236}">
-                <a16:creationId xmlns:a16="http://schemas.microsoft.com/office/drawing/2014/main" id="{C9B61410-6012-4066-9384-0419B1C1CB13}"/>
+                <a16:creationId xmlns:a16="http://schemas.microsoft.com/office/drawing/2014/main" id="{FBEDDA2F-9C1C-478A-B203-6F6CB1D65CD6}"/>
               </a:ext>
             </a:extLst>
           </p:cNvPr>
@@ -5362,7 +5394,7 @@
           <p:cNvPr id="3" name="">
             <a:extLst xmlns:a="http://schemas.openxmlformats.org/drawingml/2006/main">
               <a:ext uri="{FF2B5EF4-FFF2-40B4-BE49-F238E27FC236}">
-                <a16:creationId xmlns:a16="http://schemas.microsoft.com/office/drawing/2014/main" id="{A1FD9B23-E298-487C-AADA-2F466DC1482B}"/>
+                <a16:creationId xmlns:a16="http://schemas.microsoft.com/office/drawing/2014/main" id="{46FE05A3-4977-47C5-8F79-7C2C2965C81C}"/>
               </a:ext>
             </a:extLst>
           </p:cNvPr>
@@ -5500,7 +5532,7 @@
           <p:cNvPr id="8" name="">
             <a:extLst xmlns:a="http://schemas.openxmlformats.org/drawingml/2006/main">
               <a:ext uri="{FF2B5EF4-FFF2-40B4-BE49-F238E27FC236}">
-                <a16:creationId xmlns:a16="http://schemas.microsoft.com/office/drawing/2014/main" id="{0C04954D-7B7F-4D96-80F1-5242EF63368D}"/>
+                <a16:creationId xmlns:a16="http://schemas.microsoft.com/office/drawing/2014/main" id="{A6F20441-CC1F-4AC9-A364-E24B2E6357C1}"/>
               </a:ext>
             </a:extLst>
           </p:cNvPr>
@@ -5531,7 +5563,7 @@
           <p:cNvPr id="9" name="">
             <a:extLst xmlns:a="http://schemas.openxmlformats.org/drawingml/2006/main">
               <a:ext uri="{FF2B5EF4-FFF2-40B4-BE49-F238E27FC236}">
-                <a16:creationId xmlns:a16="http://schemas.microsoft.com/office/drawing/2014/main" id="{F23C8F1E-4D76-470F-B73B-FD57235B1165}"/>
+                <a16:creationId xmlns:a16="http://schemas.microsoft.com/office/drawing/2014/main" id="{5A50E1BD-A384-434A-B958-1FEE44F4EDEB}"/>
               </a:ext>
             </a:extLst>
           </p:cNvPr>
@@ -5581,7 +5613,7 @@
           <p:cNvPr id="10" name="">
             <a:extLst xmlns:a="http://schemas.openxmlformats.org/drawingml/2006/main">
               <a:ext uri="{FF2B5EF4-FFF2-40B4-BE49-F238E27FC236}">
-                <a16:creationId xmlns:a16="http://schemas.microsoft.com/office/drawing/2014/main" id="{B4DB2967-BD4C-497B-9A77-FC120A3DD033}"/>
+                <a16:creationId xmlns:a16="http://schemas.microsoft.com/office/drawing/2014/main" id="{7FB240ED-AAE8-4D03-A19B-8C318DEDFC37}"/>
               </a:ext>
             </a:extLst>
           </p:cNvPr>
@@ -5631,7 +5663,7 @@
           <p:cNvPr id="11" name="">
             <a:extLst xmlns:a="http://schemas.openxmlformats.org/drawingml/2006/main">
               <a:ext uri="{FF2B5EF4-FFF2-40B4-BE49-F238E27FC236}">
-                <a16:creationId xmlns:a16="http://schemas.microsoft.com/office/drawing/2014/main" id="{BE184F35-99A4-46A2-AB96-F010701D9A97}"/>
+                <a16:creationId xmlns:a16="http://schemas.microsoft.com/office/drawing/2014/main" id="{89129D61-7B12-405F-894C-A5BDB8EC8226}"/>
               </a:ext>
             </a:extLst>
           </p:cNvPr>
@@ -5681,7 +5713,7 @@
           <p:cNvPr id="12" name="">
             <a:extLst xmlns:a="http://schemas.openxmlformats.org/drawingml/2006/main">
               <a:ext uri="{FF2B5EF4-FFF2-40B4-BE49-F238E27FC236}">
-                <a16:creationId xmlns:a16="http://schemas.microsoft.com/office/drawing/2014/main" id="{4180067F-D743-4842-9F03-B955B2599599}"/>
+                <a16:creationId xmlns:a16="http://schemas.microsoft.com/office/drawing/2014/main" id="{755793CC-2EB7-41D5-83CD-219B3D2B0350}"/>
               </a:ext>
             </a:extLst>
           </p:cNvPr>
@@ -5712,7 +5744,7 @@
           <p:cNvPr id="13" name="">
             <a:extLst xmlns:a="http://schemas.openxmlformats.org/drawingml/2006/main">
               <a:ext uri="{FF2B5EF4-FFF2-40B4-BE49-F238E27FC236}">
-                <a16:creationId xmlns:a16="http://schemas.microsoft.com/office/drawing/2014/main" id="{D66F3B88-0B60-495B-BCEE-FFEA52D2FB8B}"/>
+                <a16:creationId xmlns:a16="http://schemas.microsoft.com/office/drawing/2014/main" id="{6089A091-6414-4A99-82BD-6CC733615E6B}"/>
               </a:ext>
             </a:extLst>
           </p:cNvPr>
@@ -5762,7 +5794,7 @@
           <p:cNvPr id="14" name="">
             <a:extLst xmlns:a="http://schemas.openxmlformats.org/drawingml/2006/main">
               <a:ext uri="{FF2B5EF4-FFF2-40B4-BE49-F238E27FC236}">
-                <a16:creationId xmlns:a16="http://schemas.microsoft.com/office/drawing/2014/main" id="{6024729E-A9DD-4CA7-BB5A-5DA7ED36EBC2}"/>
+                <a16:creationId xmlns:a16="http://schemas.microsoft.com/office/drawing/2014/main" id="{21654EED-00A9-444F-82DA-3D9DAB21929D}"/>
               </a:ext>
             </a:extLst>
           </p:cNvPr>
@@ -5812,7 +5844,7 @@
           <p:cNvPr id="15" name="">
             <a:extLst xmlns:a="http://schemas.openxmlformats.org/drawingml/2006/main">
               <a:ext uri="{FF2B5EF4-FFF2-40B4-BE49-F238E27FC236}">
-                <a16:creationId xmlns:a16="http://schemas.microsoft.com/office/drawing/2014/main" id="{DED937F0-A0F0-4E6E-86F5-C67E59268054}"/>
+                <a16:creationId xmlns:a16="http://schemas.microsoft.com/office/drawing/2014/main" id="{FFCE0E3D-F671-43C2-8A7D-EC59FDBE16FE}"/>
               </a:ext>
             </a:extLst>
           </p:cNvPr>
@@ -5862,7 +5894,7 @@
           <p:cNvPr id="16" name="">
             <a:extLst xmlns:a="http://schemas.openxmlformats.org/drawingml/2006/main">
               <a:ext uri="{FF2B5EF4-FFF2-40B4-BE49-F238E27FC236}">
-                <a16:creationId xmlns:a16="http://schemas.microsoft.com/office/drawing/2014/main" id="{D3D75D67-C254-4768-9D9F-E3D3CFEF39E3}"/>
+                <a16:creationId xmlns:a16="http://schemas.microsoft.com/office/drawing/2014/main" id="{A9FAC424-5791-4CEB-B82A-9DACB47A4748}"/>
               </a:ext>
             </a:extLst>
           </p:cNvPr>
@@ -5893,7 +5925,7 @@
           <p:cNvPr id="17" name="">
             <a:extLst xmlns:a="http://schemas.openxmlformats.org/drawingml/2006/main">
               <a:ext uri="{FF2B5EF4-FFF2-40B4-BE49-F238E27FC236}">
-                <a16:creationId xmlns:a16="http://schemas.microsoft.com/office/drawing/2014/main" id="{60E7F0A0-F683-4182-A572-A27D02DEADB4}"/>
+                <a16:creationId xmlns:a16="http://schemas.microsoft.com/office/drawing/2014/main" id="{0118C43D-BAC9-4464-BA7A-57B8E1E80B72}"/>
               </a:ext>
             </a:extLst>
           </p:cNvPr>
@@ -5943,7 +5975,7 @@
           <p:cNvPr id="18" name="">
             <a:extLst xmlns:a="http://schemas.openxmlformats.org/drawingml/2006/main">
               <a:ext uri="{FF2B5EF4-FFF2-40B4-BE49-F238E27FC236}">
-                <a16:creationId xmlns:a16="http://schemas.microsoft.com/office/drawing/2014/main" id="{85FA5564-413F-44DA-8235-CBBCD203B2E1}"/>
+                <a16:creationId xmlns:a16="http://schemas.microsoft.com/office/drawing/2014/main" id="{62940920-81D7-4B65-B224-0DD2787F0B1E}"/>
               </a:ext>
             </a:extLst>
           </p:cNvPr>
@@ -5993,7 +6025,7 @@
           <p:cNvPr id="19" name="">
             <a:extLst xmlns:a="http://schemas.openxmlformats.org/drawingml/2006/main">
               <a:ext uri="{FF2B5EF4-FFF2-40B4-BE49-F238E27FC236}">
-                <a16:creationId xmlns:a16="http://schemas.microsoft.com/office/drawing/2014/main" id="{EC4BFA99-8765-40BF-ADA2-2E2E1B41225B}"/>
+                <a16:creationId xmlns:a16="http://schemas.microsoft.com/office/drawing/2014/main" id="{57F40ACB-E816-4568-8E98-68649D33C2E8}"/>
               </a:ext>
             </a:extLst>
           </p:cNvPr>
@@ -6043,7 +6075,7 @@
           <p:cNvPr id="20" name="">
             <a:extLst xmlns:a="http://schemas.openxmlformats.org/drawingml/2006/main">
               <a:ext uri="{FF2B5EF4-FFF2-40B4-BE49-F238E27FC236}">
-                <a16:creationId xmlns:a16="http://schemas.microsoft.com/office/drawing/2014/main" id="{89F5E6D8-7242-42CB-8F7E-BD26A60FD463}"/>
+                <a16:creationId xmlns:a16="http://schemas.microsoft.com/office/drawing/2014/main" id="{EBD8A9E5-9CB1-44D8-AD75-A5410F9EF87E}"/>
               </a:ext>
             </a:extLst>
           </p:cNvPr>
@@ -6074,7 +6106,7 @@
           <p:cNvPr id="21" name="">
             <a:extLst xmlns:a="http://schemas.openxmlformats.org/drawingml/2006/main">
               <a:ext uri="{FF2B5EF4-FFF2-40B4-BE49-F238E27FC236}">
-                <a16:creationId xmlns:a16="http://schemas.microsoft.com/office/drawing/2014/main" id="{16E7BC6A-F899-4F1F-B80F-050FE06FEC2F}"/>
+                <a16:creationId xmlns:a16="http://schemas.microsoft.com/office/drawing/2014/main" id="{AC221F02-1A2D-4120-8FFC-75BA6CBE94C4}"/>
               </a:ext>
             </a:extLst>
           </p:cNvPr>
@@ -6124,7 +6156,7 @@
           <p:cNvPr id="22" name="">
             <a:extLst xmlns:a="http://schemas.openxmlformats.org/drawingml/2006/main">
               <a:ext uri="{FF2B5EF4-FFF2-40B4-BE49-F238E27FC236}">
-                <a16:creationId xmlns:a16="http://schemas.microsoft.com/office/drawing/2014/main" id="{14478B83-130D-401E-AAAD-A28A1EE40025}"/>
+                <a16:creationId xmlns:a16="http://schemas.microsoft.com/office/drawing/2014/main" id="{E5776A57-5FD6-4F6D-9D3A-120659D2BA38}"/>
               </a:ext>
             </a:extLst>
           </p:cNvPr>
@@ -6174,7 +6206,7 @@
           <p:cNvPr id="23" name="">
             <a:extLst xmlns:a="http://schemas.openxmlformats.org/drawingml/2006/main">
               <a:ext uri="{FF2B5EF4-FFF2-40B4-BE49-F238E27FC236}">
-                <a16:creationId xmlns:a16="http://schemas.microsoft.com/office/drawing/2014/main" id="{1E5A3703-39D0-4E74-BDFF-ADB49A09185E}"/>
+                <a16:creationId xmlns:a16="http://schemas.microsoft.com/office/drawing/2014/main" id="{536264A2-6921-437C-A375-86F287EAC078}"/>
               </a:ext>
             </a:extLst>
           </p:cNvPr>
@@ -6224,7 +6256,7 @@
           <p:cNvPr id="24" name="">
             <a:extLst xmlns:a="http://schemas.openxmlformats.org/drawingml/2006/main">
               <a:ext uri="{FF2B5EF4-FFF2-40B4-BE49-F238E27FC236}">
-                <a16:creationId xmlns:a16="http://schemas.microsoft.com/office/drawing/2014/main" id="{CE70C2A7-387F-4207-9624-ECBFC9BC1483}"/>
+                <a16:creationId xmlns:a16="http://schemas.microsoft.com/office/drawing/2014/main" id="{730E46DF-FCFF-48A5-B919-19BDC6FA6289}"/>
               </a:ext>
             </a:extLst>
           </p:cNvPr>
@@ -6255,7 +6287,7 @@
           <p:cNvPr id="25" name="">
             <a:extLst xmlns:a="http://schemas.openxmlformats.org/drawingml/2006/main">
               <a:ext uri="{FF2B5EF4-FFF2-40B4-BE49-F238E27FC236}">
-                <a16:creationId xmlns:a16="http://schemas.microsoft.com/office/drawing/2014/main" id="{23F61EFD-7BC1-4B52-9016-DE3D80ECC089}"/>
+                <a16:creationId xmlns:a16="http://schemas.microsoft.com/office/drawing/2014/main" id="{D51731E9-574D-4DA6-B957-191B11058B31}"/>
               </a:ext>
             </a:extLst>
           </p:cNvPr>
@@ -6305,7 +6337,7 @@
           <p:cNvPr id="26" name="">
             <a:extLst xmlns:a="http://schemas.openxmlformats.org/drawingml/2006/main">
               <a:ext uri="{FF2B5EF4-FFF2-40B4-BE49-F238E27FC236}">
-                <a16:creationId xmlns:a16="http://schemas.microsoft.com/office/drawing/2014/main" id="{1740AE7F-EE1A-4D6F-8A0A-892BB06BB091}"/>
+                <a16:creationId xmlns:a16="http://schemas.microsoft.com/office/drawing/2014/main" id="{C3BD6F1E-0962-43ED-9BAC-C5B79B4059E8}"/>
               </a:ext>
             </a:extLst>
           </p:cNvPr>
@@ -6355,7 +6387,7 @@
           <p:cNvPr id="27" name="">
             <a:extLst xmlns:a="http://schemas.openxmlformats.org/drawingml/2006/main">
               <a:ext uri="{FF2B5EF4-FFF2-40B4-BE49-F238E27FC236}">
-                <a16:creationId xmlns:a16="http://schemas.microsoft.com/office/drawing/2014/main" id="{AC3BA6CC-CEAB-4CA6-9294-8A2E900DC908}"/>
+                <a16:creationId xmlns:a16="http://schemas.microsoft.com/office/drawing/2014/main" id="{77FCAA64-382C-48A3-A14C-1694125FCD6D}"/>
               </a:ext>
             </a:extLst>
           </p:cNvPr>
@@ -6405,7 +6437,7 @@
           <p:cNvPr id="28" name="">
             <a:extLst xmlns:a="http://schemas.openxmlformats.org/drawingml/2006/main">
               <a:ext uri="{FF2B5EF4-FFF2-40B4-BE49-F238E27FC236}">
-                <a16:creationId xmlns:a16="http://schemas.microsoft.com/office/drawing/2014/main" id="{04227782-6714-40F1-BE38-D7ACF09DF976}"/>
+                <a16:creationId xmlns:a16="http://schemas.microsoft.com/office/drawing/2014/main" id="{0FE0C66F-51CF-4F14-8B2B-230350C85F33}"/>
               </a:ext>
             </a:extLst>
           </p:cNvPr>
@@ -6453,7 +6485,7 @@
     </p:spTree>
     <p:extLst>
       <p:ext uri="{BB962C8B-B14F-4D97-AF65-F5344CB8AC3E}">
-        <p14:creationId xmlns:p14="http://schemas.microsoft.com/office/powerpoint/2010/main" val="336150018"/>
+        <p14:creationId xmlns:p14="http://schemas.microsoft.com/office/powerpoint/2010/main" val="1727206126"/>
       </p:ext>
     </p:extLst>
   </p:cSld>
@@ -6484,7 +6516,7 @@
           <p:cNvPr id="48" name="slide-6-title">
             <a:extLst xmlns:a="http://schemas.openxmlformats.org/drawingml/2006/main">
               <a:ext uri="{FF2B5EF4-FFF2-40B4-BE49-F238E27FC236}">
-                <a16:creationId xmlns:a16="http://schemas.microsoft.com/office/drawing/2014/main" id="{507817C5-340B-406E-BEB4-8AAFCD54F65C}"/>
+                <a16:creationId xmlns:a16="http://schemas.microsoft.com/office/drawing/2014/main" id="{80C78B83-9975-4C0F-A243-6D68053EE5D0}"/>
               </a:ext>
             </a:extLst>
           </p:cNvPr>
@@ -6534,7 +6566,7 @@
           <p:cNvPr id="2" name="">
             <a:extLst xmlns:a="http://schemas.openxmlformats.org/drawingml/2006/main">
               <a:ext uri="{FF2B5EF4-FFF2-40B4-BE49-F238E27FC236}">
-                <a16:creationId xmlns:a16="http://schemas.microsoft.com/office/drawing/2014/main" id="{8757B6DD-E389-4AFE-8BFD-E5AA577B80EC}"/>
+                <a16:creationId xmlns:a16="http://schemas.microsoft.com/office/drawing/2014/main" id="{960558DB-4C5B-4916-B819-7A033BF58156}"/>
               </a:ext>
             </a:extLst>
           </p:cNvPr>
@@ -6584,7 +6616,7 @@
           <p:cNvPr id="3" name="">
             <a:extLst xmlns:a="http://schemas.openxmlformats.org/drawingml/2006/main">
               <a:ext uri="{FF2B5EF4-FFF2-40B4-BE49-F238E27FC236}">
-                <a16:creationId xmlns:a16="http://schemas.microsoft.com/office/drawing/2014/main" id="{02DE3A6A-F7B1-4EC5-8706-64E24B76F4B1}"/>
+                <a16:creationId xmlns:a16="http://schemas.microsoft.com/office/drawing/2014/main" id="{76837AF0-212E-4383-92C8-F9E1940A6CB4}"/>
               </a:ext>
             </a:extLst>
           </p:cNvPr>
@@ -6634,7 +6666,7 @@
           <p:cNvPr id="4" name="">
             <a:extLst xmlns:a="http://schemas.openxmlformats.org/drawingml/2006/main">
               <a:ext uri="{FF2B5EF4-FFF2-40B4-BE49-F238E27FC236}">
-                <a16:creationId xmlns:a16="http://schemas.microsoft.com/office/drawing/2014/main" id="{F803D51D-F923-4C85-ACB7-85757508D6EA}"/>
+                <a16:creationId xmlns:a16="http://schemas.microsoft.com/office/drawing/2014/main" id="{749A3A88-B206-4668-8408-1E2C33CD653A}"/>
               </a:ext>
             </a:extLst>
           </p:cNvPr>
@@ -6684,7 +6716,7 @@
           <p:cNvPr id="5" name="">
             <a:extLst xmlns:a="http://schemas.openxmlformats.org/drawingml/2006/main">
               <a:ext uri="{FF2B5EF4-FFF2-40B4-BE49-F238E27FC236}">
-                <a16:creationId xmlns:a16="http://schemas.microsoft.com/office/drawing/2014/main" id="{4BC83F53-7B14-4E2D-8D19-485ED976108A}"/>
+                <a16:creationId xmlns:a16="http://schemas.microsoft.com/office/drawing/2014/main" id="{AB338032-879C-4540-9CDE-E35D9C00CC18}"/>
               </a:ext>
             </a:extLst>
           </p:cNvPr>
@@ -6734,7 +6766,7 @@
           <p:cNvPr id="6" name="">
             <a:extLst xmlns:a="http://schemas.openxmlformats.org/drawingml/2006/main">
               <a:ext uri="{FF2B5EF4-FFF2-40B4-BE49-F238E27FC236}">
-                <a16:creationId xmlns:a16="http://schemas.microsoft.com/office/drawing/2014/main" id="{F2A5CEBE-CAFA-4B33-A3E8-2F392E6BE7EA}"/>
+                <a16:creationId xmlns:a16="http://schemas.microsoft.com/office/drawing/2014/main" id="{7E0C7A33-4375-4158-88A6-0979C21014F5}"/>
               </a:ext>
             </a:extLst>
           </p:cNvPr>
@@ -6767,7 +6799,7 @@
           <p:cNvPr id="7" name="">
             <a:extLst xmlns:a="http://schemas.openxmlformats.org/drawingml/2006/main">
               <a:ext uri="{FF2B5EF4-FFF2-40B4-BE49-F238E27FC236}">
-                <a16:creationId xmlns:a16="http://schemas.microsoft.com/office/drawing/2014/main" id="{CE6D0305-351A-4E15-989B-A10C42CA6148}"/>
+                <a16:creationId xmlns:a16="http://schemas.microsoft.com/office/drawing/2014/main" id="{1D066C51-8642-47AC-ABAB-DD5188D75475}"/>
               </a:ext>
             </a:extLst>
           </p:cNvPr>
@@ -6817,7 +6849,7 @@
           <p:cNvPr id="8" name="">
             <a:extLst xmlns:a="http://schemas.openxmlformats.org/drawingml/2006/main">
               <a:ext uri="{FF2B5EF4-FFF2-40B4-BE49-F238E27FC236}">
-                <a16:creationId xmlns:a16="http://schemas.microsoft.com/office/drawing/2014/main" id="{1FFEB1DB-A65B-4E68-91F2-B6BCABCE0DB4}"/>
+                <a16:creationId xmlns:a16="http://schemas.microsoft.com/office/drawing/2014/main" id="{570BEADA-BDC5-4BA6-AEBD-A79FF21E3865}"/>
               </a:ext>
             </a:extLst>
           </p:cNvPr>
@@ -6850,7 +6882,7 @@
           <p:cNvPr id="9" name="">
             <a:extLst xmlns:a="http://schemas.openxmlformats.org/drawingml/2006/main">
               <a:ext uri="{FF2B5EF4-FFF2-40B4-BE49-F238E27FC236}">
-                <a16:creationId xmlns:a16="http://schemas.microsoft.com/office/drawing/2014/main" id="{292BB196-403B-4E6D-B826-58EBDEE002E7}"/>
+                <a16:creationId xmlns:a16="http://schemas.microsoft.com/office/drawing/2014/main" id="{8B435153-08E7-48A8-9AC0-2E0F6D5B58C2}"/>
               </a:ext>
             </a:extLst>
           </p:cNvPr>
@@ -6900,7 +6932,7 @@
           <p:cNvPr id="10" name="">
             <a:extLst xmlns:a="http://schemas.openxmlformats.org/drawingml/2006/main">
               <a:ext uri="{FF2B5EF4-FFF2-40B4-BE49-F238E27FC236}">
-                <a16:creationId xmlns:a16="http://schemas.microsoft.com/office/drawing/2014/main" id="{E9DC7E34-DE86-42A5-901C-D16B916DE132}"/>
+                <a16:creationId xmlns:a16="http://schemas.microsoft.com/office/drawing/2014/main" id="{AD5DE2FC-06A0-45B3-A243-36976B10CFE5}"/>
               </a:ext>
             </a:extLst>
           </p:cNvPr>
@@ -6933,7 +6965,7 @@
           <p:cNvPr id="11" name="">
             <a:extLst xmlns:a="http://schemas.openxmlformats.org/drawingml/2006/main">
               <a:ext uri="{FF2B5EF4-FFF2-40B4-BE49-F238E27FC236}">
-                <a16:creationId xmlns:a16="http://schemas.microsoft.com/office/drawing/2014/main" id="{92658D7A-FF9F-4A1B-BD2C-0A58DCCB649C}"/>
+                <a16:creationId xmlns:a16="http://schemas.microsoft.com/office/drawing/2014/main" id="{D919FD13-F648-4A7F-B6C9-D7529D9ED830}"/>
               </a:ext>
             </a:extLst>
           </p:cNvPr>
@@ -6983,7 +7015,7 @@
           <p:cNvPr id="12" name="">
             <a:extLst xmlns:a="http://schemas.openxmlformats.org/drawingml/2006/main">
               <a:ext uri="{FF2B5EF4-FFF2-40B4-BE49-F238E27FC236}">
-                <a16:creationId xmlns:a16="http://schemas.microsoft.com/office/drawing/2014/main" id="{2A977B5C-7C84-48C3-A0CB-9B4672B97152}"/>
+                <a16:creationId xmlns:a16="http://schemas.microsoft.com/office/drawing/2014/main" id="{29EDEDFF-B2B6-4B72-A8F7-E3CAB9645F0C}"/>
               </a:ext>
             </a:extLst>
           </p:cNvPr>
@@ -7016,7 +7048,7 @@
           <p:cNvPr id="13" name="">
             <a:extLst xmlns:a="http://schemas.openxmlformats.org/drawingml/2006/main">
               <a:ext uri="{FF2B5EF4-FFF2-40B4-BE49-F238E27FC236}">
-                <a16:creationId xmlns:a16="http://schemas.microsoft.com/office/drawing/2014/main" id="{1235AB11-41B9-43B0-8588-AA296036268C}"/>
+                <a16:creationId xmlns:a16="http://schemas.microsoft.com/office/drawing/2014/main" id="{00EC370C-F702-4AE8-ABA5-C8DCB68EA5A1}"/>
               </a:ext>
             </a:extLst>
           </p:cNvPr>
@@ -7066,7 +7098,7 @@
           <p:cNvPr id="14" name="">
             <a:extLst xmlns:a="http://schemas.openxmlformats.org/drawingml/2006/main">
               <a:ext uri="{FF2B5EF4-FFF2-40B4-BE49-F238E27FC236}">
-                <a16:creationId xmlns:a16="http://schemas.microsoft.com/office/drawing/2014/main" id="{82150EB5-0F75-46E7-84C6-CAF9E7BA17F0}"/>
+                <a16:creationId xmlns:a16="http://schemas.microsoft.com/office/drawing/2014/main" id="{ACFC8B64-8ECC-4CB6-BFD5-46CDC775E573}"/>
               </a:ext>
             </a:extLst>
           </p:cNvPr>
@@ -7099,7 +7131,7 @@
           <p:cNvPr id="15" name="">
             <a:extLst xmlns:a="http://schemas.openxmlformats.org/drawingml/2006/main">
               <a:ext uri="{FF2B5EF4-FFF2-40B4-BE49-F238E27FC236}">
-                <a16:creationId xmlns:a16="http://schemas.microsoft.com/office/drawing/2014/main" id="{00443528-ED88-4FDF-9817-C0A3968474CA}"/>
+                <a16:creationId xmlns:a16="http://schemas.microsoft.com/office/drawing/2014/main" id="{DBE05889-05AE-4CCF-80F4-B6412C9DC86F}"/>
               </a:ext>
             </a:extLst>
           </p:cNvPr>
@@ -7149,7 +7181,7 @@
           <p:cNvPr id="16" name="">
             <a:extLst xmlns:a="http://schemas.openxmlformats.org/drawingml/2006/main">
               <a:ext uri="{FF2B5EF4-FFF2-40B4-BE49-F238E27FC236}">
-                <a16:creationId xmlns:a16="http://schemas.microsoft.com/office/drawing/2014/main" id="{28186ACE-D22E-4A6A-833D-525A2B55D6B5}"/>
+                <a16:creationId xmlns:a16="http://schemas.microsoft.com/office/drawing/2014/main" id="{A6D5CEE5-4C64-476A-9D5D-62D879FDB833}"/>
               </a:ext>
             </a:extLst>
           </p:cNvPr>
@@ -7182,7 +7214,7 @@
           <p:cNvPr id="17" name="">
             <a:extLst xmlns:a="http://schemas.openxmlformats.org/drawingml/2006/main">
               <a:ext uri="{FF2B5EF4-FFF2-40B4-BE49-F238E27FC236}">
-                <a16:creationId xmlns:a16="http://schemas.microsoft.com/office/drawing/2014/main" id="{16A8E40A-84AB-44B6-9433-D454D3B83F85}"/>
+                <a16:creationId xmlns:a16="http://schemas.microsoft.com/office/drawing/2014/main" id="{23925832-C459-4609-A178-B5CA1EDE4A51}"/>
               </a:ext>
             </a:extLst>
           </p:cNvPr>
@@ -7232,7 +7264,7 @@
           <p:cNvPr id="18" name="">
             <a:extLst xmlns:a="http://schemas.openxmlformats.org/drawingml/2006/main">
               <a:ext uri="{FF2B5EF4-FFF2-40B4-BE49-F238E27FC236}">
-                <a16:creationId xmlns:a16="http://schemas.microsoft.com/office/drawing/2014/main" id="{A1181CBD-B1AD-4346-AF04-A1718E4A9301}"/>
+                <a16:creationId xmlns:a16="http://schemas.microsoft.com/office/drawing/2014/main" id="{5F4FC629-3D40-45CD-A069-5B581A94C4E3}"/>
               </a:ext>
             </a:extLst>
           </p:cNvPr>
@@ -7265,7 +7297,7 @@
           <p:cNvPr id="19" name="">
             <a:extLst xmlns:a="http://schemas.openxmlformats.org/drawingml/2006/main">
               <a:ext uri="{FF2B5EF4-FFF2-40B4-BE49-F238E27FC236}">
-                <a16:creationId xmlns:a16="http://schemas.microsoft.com/office/drawing/2014/main" id="{ADA8E167-FA0C-4701-B234-C9386CFB5B16}"/>
+                <a16:creationId xmlns:a16="http://schemas.microsoft.com/office/drawing/2014/main" id="{36B3E4F2-318D-4AB8-9ABB-77E4988CD6A6}"/>
               </a:ext>
             </a:extLst>
           </p:cNvPr>
@@ -7315,7 +7347,7 @@
           <p:cNvPr id="20" name="">
             <a:extLst xmlns:a="http://schemas.openxmlformats.org/drawingml/2006/main">
               <a:ext uri="{FF2B5EF4-FFF2-40B4-BE49-F238E27FC236}">
-                <a16:creationId xmlns:a16="http://schemas.microsoft.com/office/drawing/2014/main" id="{326077B4-386E-45EE-BD8C-9939CC55B9BA}"/>
+                <a16:creationId xmlns:a16="http://schemas.microsoft.com/office/drawing/2014/main" id="{0B60FB70-52B6-4BA0-824D-79D5929D38B6}"/>
               </a:ext>
             </a:extLst>
           </p:cNvPr>
@@ -7348,7 +7380,7 @@
           <p:cNvPr id="21" name="">
             <a:extLst xmlns:a="http://schemas.openxmlformats.org/drawingml/2006/main">
               <a:ext uri="{FF2B5EF4-FFF2-40B4-BE49-F238E27FC236}">
-                <a16:creationId xmlns:a16="http://schemas.microsoft.com/office/drawing/2014/main" id="{F5C1E750-3B2B-4433-952D-F44D666EC7EE}"/>
+                <a16:creationId xmlns:a16="http://schemas.microsoft.com/office/drawing/2014/main" id="{A94BDF02-D16C-461A-83A6-3783F9D71B73}"/>
               </a:ext>
             </a:extLst>
           </p:cNvPr>
@@ -7415,7 +7447,7 @@
           <p:cNvPr id="22" name="">
             <a:extLst xmlns:a="http://schemas.openxmlformats.org/drawingml/2006/main">
               <a:ext uri="{FF2B5EF4-FFF2-40B4-BE49-F238E27FC236}">
-                <a16:creationId xmlns:a16="http://schemas.microsoft.com/office/drawing/2014/main" id="{150E63BF-9EF9-49F0-B9ED-31BF6B158B62}"/>
+                <a16:creationId xmlns:a16="http://schemas.microsoft.com/office/drawing/2014/main" id="{BC962EA5-AABB-4BF0-B4AE-277828FCE9C3}"/>
               </a:ext>
             </a:extLst>
           </p:cNvPr>
@@ -7448,7 +7480,7 @@
           <p:cNvPr id="23" name="">
             <a:extLst xmlns:a="http://schemas.openxmlformats.org/drawingml/2006/main">
               <a:ext uri="{FF2B5EF4-FFF2-40B4-BE49-F238E27FC236}">
-                <a16:creationId xmlns:a16="http://schemas.microsoft.com/office/drawing/2014/main" id="{35047372-19BA-45E1-9325-FDFB06B3AB98}"/>
+                <a16:creationId xmlns:a16="http://schemas.microsoft.com/office/drawing/2014/main" id="{66DF35C8-1384-4488-921C-8E67CA898ABE}"/>
               </a:ext>
             </a:extLst>
           </p:cNvPr>
@@ -7498,7 +7530,7 @@
           <p:cNvPr id="24" name="">
             <a:extLst xmlns:a="http://schemas.openxmlformats.org/drawingml/2006/main">
               <a:ext uri="{FF2B5EF4-FFF2-40B4-BE49-F238E27FC236}">
-                <a16:creationId xmlns:a16="http://schemas.microsoft.com/office/drawing/2014/main" id="{6462DB44-A47D-4F09-B380-F7CC3C3FB792}"/>
+                <a16:creationId xmlns:a16="http://schemas.microsoft.com/office/drawing/2014/main" id="{7178C806-3A6A-425C-B08E-019D8670BDBC}"/>
               </a:ext>
             </a:extLst>
           </p:cNvPr>
@@ -7531,7 +7563,7 @@
           <p:cNvPr id="25" name="">
             <a:extLst xmlns:a="http://schemas.openxmlformats.org/drawingml/2006/main">
               <a:ext uri="{FF2B5EF4-FFF2-40B4-BE49-F238E27FC236}">
-                <a16:creationId xmlns:a16="http://schemas.microsoft.com/office/drawing/2014/main" id="{4EBFE071-D73A-496F-96B5-F0BDD4396795}"/>
+                <a16:creationId xmlns:a16="http://schemas.microsoft.com/office/drawing/2014/main" id="{2F465A69-C5F8-418B-941F-747FFC8B6E77}"/>
               </a:ext>
             </a:extLst>
           </p:cNvPr>
@@ -7581,7 +7613,7 @@
           <p:cNvPr id="26" name="">
             <a:extLst xmlns:a="http://schemas.openxmlformats.org/drawingml/2006/main">
               <a:ext uri="{FF2B5EF4-FFF2-40B4-BE49-F238E27FC236}">
-                <a16:creationId xmlns:a16="http://schemas.microsoft.com/office/drawing/2014/main" id="{768CFAF2-140A-453F-A721-6863E499514A}"/>
+                <a16:creationId xmlns:a16="http://schemas.microsoft.com/office/drawing/2014/main" id="{7C3F7BD4-E1DA-4C43-B480-9B3B5A8DEF58}"/>
               </a:ext>
             </a:extLst>
           </p:cNvPr>
@@ -7614,7 +7646,7 @@
           <p:cNvPr id="27" name="">
             <a:extLst xmlns:a="http://schemas.openxmlformats.org/drawingml/2006/main">
               <a:ext uri="{FF2B5EF4-FFF2-40B4-BE49-F238E27FC236}">
-                <a16:creationId xmlns:a16="http://schemas.microsoft.com/office/drawing/2014/main" id="{B73D9EE4-C102-41F5-B07D-A9C683542307}"/>
+                <a16:creationId xmlns:a16="http://schemas.microsoft.com/office/drawing/2014/main" id="{528A0054-C9B5-472A-91BA-96CEDE7EBEF7}"/>
               </a:ext>
             </a:extLst>
           </p:cNvPr>
@@ -7664,7 +7696,7 @@
           <p:cNvPr id="28" name="">
             <a:extLst xmlns:a="http://schemas.openxmlformats.org/drawingml/2006/main">
               <a:ext uri="{FF2B5EF4-FFF2-40B4-BE49-F238E27FC236}">
-                <a16:creationId xmlns:a16="http://schemas.microsoft.com/office/drawing/2014/main" id="{CA8A5DC7-9BB9-4337-B6C3-47B056182398}"/>
+                <a16:creationId xmlns:a16="http://schemas.microsoft.com/office/drawing/2014/main" id="{0F3E3EB9-ADC8-41AC-95AE-E4E54159F4BE}"/>
               </a:ext>
             </a:extLst>
           </p:cNvPr>
@@ -7697,7 +7729,7 @@
           <p:cNvPr id="29" name="">
             <a:extLst xmlns:a="http://schemas.openxmlformats.org/drawingml/2006/main">
               <a:ext uri="{FF2B5EF4-FFF2-40B4-BE49-F238E27FC236}">
-                <a16:creationId xmlns:a16="http://schemas.microsoft.com/office/drawing/2014/main" id="{760754FD-CA2A-4A31-A587-EF121D4CEE5E}"/>
+                <a16:creationId xmlns:a16="http://schemas.microsoft.com/office/drawing/2014/main" id="{39620463-57FD-421E-9F32-133F24BF4261}"/>
               </a:ext>
             </a:extLst>
           </p:cNvPr>
@@ -7747,7 +7779,7 @@
           <p:cNvPr id="30" name="">
             <a:extLst xmlns:a="http://schemas.openxmlformats.org/drawingml/2006/main">
               <a:ext uri="{FF2B5EF4-FFF2-40B4-BE49-F238E27FC236}">
-                <a16:creationId xmlns:a16="http://schemas.microsoft.com/office/drawing/2014/main" id="{C1AE1B65-C7BC-4F9A-8009-0FD2D9AB5FEC}"/>
+                <a16:creationId xmlns:a16="http://schemas.microsoft.com/office/drawing/2014/main" id="{64B57F84-2092-4AE9-9A75-BB2483E41607}"/>
               </a:ext>
             </a:extLst>
           </p:cNvPr>
@@ -7780,7 +7812,7 @@
           <p:cNvPr id="31" name="">
             <a:extLst xmlns:a="http://schemas.openxmlformats.org/drawingml/2006/main">
               <a:ext uri="{FF2B5EF4-FFF2-40B4-BE49-F238E27FC236}">
-                <a16:creationId xmlns:a16="http://schemas.microsoft.com/office/drawing/2014/main" id="{9C5398F8-4D47-4159-B4BB-B5BF4ACE5A2E}"/>
+                <a16:creationId xmlns:a16="http://schemas.microsoft.com/office/drawing/2014/main" id="{D299C7DB-4FC5-46C6-BBD7-C0B75BB5BE90}"/>
               </a:ext>
             </a:extLst>
           </p:cNvPr>
@@ -7847,7 +7879,7 @@
           <p:cNvPr id="32" name="">
             <a:extLst xmlns:a="http://schemas.openxmlformats.org/drawingml/2006/main">
               <a:ext uri="{FF2B5EF4-FFF2-40B4-BE49-F238E27FC236}">
-                <a16:creationId xmlns:a16="http://schemas.microsoft.com/office/drawing/2014/main" id="{9C3E8A5E-5DC9-439B-AAD2-2580CCB1BA0A}"/>
+                <a16:creationId xmlns:a16="http://schemas.microsoft.com/office/drawing/2014/main" id="{36F3B23B-0CB8-4705-BAD2-80C4F38897FD}"/>
               </a:ext>
             </a:extLst>
           </p:cNvPr>
@@ -7880,7 +7912,7 @@
           <p:cNvPr id="33" name="">
             <a:extLst xmlns:a="http://schemas.openxmlformats.org/drawingml/2006/main">
               <a:ext uri="{FF2B5EF4-FFF2-40B4-BE49-F238E27FC236}">
-                <a16:creationId xmlns:a16="http://schemas.microsoft.com/office/drawing/2014/main" id="{EACEABCD-8A2A-4894-90E5-5E53B373B698}"/>
+                <a16:creationId xmlns:a16="http://schemas.microsoft.com/office/drawing/2014/main" id="{90BCDF7D-E1A2-4354-BFDA-7D42D0243F70}"/>
               </a:ext>
             </a:extLst>
           </p:cNvPr>
@@ -7930,7 +7962,7 @@
           <p:cNvPr id="34" name="">
             <a:extLst xmlns:a="http://schemas.openxmlformats.org/drawingml/2006/main">
               <a:ext uri="{FF2B5EF4-FFF2-40B4-BE49-F238E27FC236}">
-                <a16:creationId xmlns:a16="http://schemas.microsoft.com/office/drawing/2014/main" id="{AB8F89CD-0E84-4103-BFBC-5CE56459C308}"/>
+                <a16:creationId xmlns:a16="http://schemas.microsoft.com/office/drawing/2014/main" id="{E586EFF1-7E76-464A-B574-6EE3946329E7}"/>
               </a:ext>
             </a:extLst>
           </p:cNvPr>
@@ -7963,7 +7995,7 @@
           <p:cNvPr id="35" name="">
             <a:extLst xmlns:a="http://schemas.openxmlformats.org/drawingml/2006/main">
               <a:ext uri="{FF2B5EF4-FFF2-40B4-BE49-F238E27FC236}">
-                <a16:creationId xmlns:a16="http://schemas.microsoft.com/office/drawing/2014/main" id="{93FBDEBA-D41F-40E9-B538-9DE4C42524CA}"/>
+                <a16:creationId xmlns:a16="http://schemas.microsoft.com/office/drawing/2014/main" id="{2CDAEB70-8702-46B5-B3F9-39547E643FDB}"/>
               </a:ext>
             </a:extLst>
           </p:cNvPr>
@@ -8013,7 +8045,7 @@
           <p:cNvPr id="36" name="">
             <a:extLst xmlns:a="http://schemas.openxmlformats.org/drawingml/2006/main">
               <a:ext uri="{FF2B5EF4-FFF2-40B4-BE49-F238E27FC236}">
-                <a16:creationId xmlns:a16="http://schemas.microsoft.com/office/drawing/2014/main" id="{A2C36496-EAC4-406D-A47F-F03ACF7A867B}"/>
+                <a16:creationId xmlns:a16="http://schemas.microsoft.com/office/drawing/2014/main" id="{79830468-B818-4698-A921-39209D33DE9D}"/>
               </a:ext>
             </a:extLst>
           </p:cNvPr>
@@ -8046,7 +8078,7 @@
           <p:cNvPr id="37" name="">
             <a:extLst xmlns:a="http://schemas.openxmlformats.org/drawingml/2006/main">
               <a:ext uri="{FF2B5EF4-FFF2-40B4-BE49-F238E27FC236}">
-                <a16:creationId xmlns:a16="http://schemas.microsoft.com/office/drawing/2014/main" id="{2B1E9E2D-4EF6-47FF-8C59-EDA63B686047}"/>
+                <a16:creationId xmlns:a16="http://schemas.microsoft.com/office/drawing/2014/main" id="{E77805C7-E01F-4210-8EDD-46FA4122512C}"/>
               </a:ext>
             </a:extLst>
           </p:cNvPr>
@@ -8096,7 +8128,7 @@
           <p:cNvPr id="38" name="">
             <a:extLst xmlns:a="http://schemas.openxmlformats.org/drawingml/2006/main">
               <a:ext uri="{FF2B5EF4-FFF2-40B4-BE49-F238E27FC236}">
-                <a16:creationId xmlns:a16="http://schemas.microsoft.com/office/drawing/2014/main" id="{6CA39D05-CCCE-4D83-9F5D-424CCC2ADFED}"/>
+                <a16:creationId xmlns:a16="http://schemas.microsoft.com/office/drawing/2014/main" id="{5E4D006A-B7EF-4417-AD5D-D740AA226B06}"/>
               </a:ext>
             </a:extLst>
           </p:cNvPr>
@@ -8129,7 +8161,7 @@
           <p:cNvPr id="39" name="">
             <a:extLst xmlns:a="http://schemas.openxmlformats.org/drawingml/2006/main">
               <a:ext uri="{FF2B5EF4-FFF2-40B4-BE49-F238E27FC236}">
-                <a16:creationId xmlns:a16="http://schemas.microsoft.com/office/drawing/2014/main" id="{32113481-C7B9-4CBD-A5C9-750C9C1C49C6}"/>
+                <a16:creationId xmlns:a16="http://schemas.microsoft.com/office/drawing/2014/main" id="{F2AA2036-3B77-4A5A-BF37-E882137EC7C6}"/>
               </a:ext>
             </a:extLst>
           </p:cNvPr>
@@ -8179,7 +8211,7 @@
           <p:cNvPr id="40" name="">
             <a:extLst xmlns:a="http://schemas.openxmlformats.org/drawingml/2006/main">
               <a:ext uri="{FF2B5EF4-FFF2-40B4-BE49-F238E27FC236}">
-                <a16:creationId xmlns:a16="http://schemas.microsoft.com/office/drawing/2014/main" id="{1C2F4C89-A304-4CC3-8AB8-AB1E8AAAD81F}"/>
+                <a16:creationId xmlns:a16="http://schemas.microsoft.com/office/drawing/2014/main" id="{24758123-A94A-4B9F-BB38-4896306B8AA0}"/>
               </a:ext>
             </a:extLst>
           </p:cNvPr>
@@ -8212,7 +8244,7 @@
           <p:cNvPr id="41" name="">
             <a:extLst xmlns:a="http://schemas.openxmlformats.org/drawingml/2006/main">
               <a:ext uri="{FF2B5EF4-FFF2-40B4-BE49-F238E27FC236}">
-                <a16:creationId xmlns:a16="http://schemas.microsoft.com/office/drawing/2014/main" id="{44A17864-D7B8-46B2-BD1B-9F5B678A4C4D}"/>
+                <a16:creationId xmlns:a16="http://schemas.microsoft.com/office/drawing/2014/main" id="{01BAE681-A575-49A2-9CF9-A2825653FD49}"/>
               </a:ext>
             </a:extLst>
           </p:cNvPr>
@@ -8279,7 +8311,7 @@
           <p:cNvPr id="42" name="">
             <a:extLst xmlns:a="http://schemas.openxmlformats.org/drawingml/2006/main">
               <a:ext uri="{FF2B5EF4-FFF2-40B4-BE49-F238E27FC236}">
-                <a16:creationId xmlns:a16="http://schemas.microsoft.com/office/drawing/2014/main" id="{C86D608E-A024-43EF-BAE8-CA436E6A722F}"/>
+                <a16:creationId xmlns:a16="http://schemas.microsoft.com/office/drawing/2014/main" id="{28ED49AA-FED5-46B3-A1A3-69D12A8BD749}"/>
               </a:ext>
             </a:extLst>
           </p:cNvPr>
@@ -8312,7 +8344,7 @@
           <p:cNvPr id="43" name="">
             <a:extLst xmlns:a="http://schemas.openxmlformats.org/drawingml/2006/main">
               <a:ext uri="{FF2B5EF4-FFF2-40B4-BE49-F238E27FC236}">
-                <a16:creationId xmlns:a16="http://schemas.microsoft.com/office/drawing/2014/main" id="{FD691030-AB99-4D07-8EB5-02E6BF20BF84}"/>
+                <a16:creationId xmlns:a16="http://schemas.microsoft.com/office/drawing/2014/main" id="{FCB35FD3-44AC-41E7-A984-58AD7F4D9C16}"/>
               </a:ext>
             </a:extLst>
           </p:cNvPr>
@@ -8362,7 +8394,7 @@
           <p:cNvPr id="44" name="">
             <a:extLst xmlns:a="http://schemas.openxmlformats.org/drawingml/2006/main">
               <a:ext uri="{FF2B5EF4-FFF2-40B4-BE49-F238E27FC236}">
-                <a16:creationId xmlns:a16="http://schemas.microsoft.com/office/drawing/2014/main" id="{35911699-E479-429D-BE7E-99D1D3AD7832}"/>
+                <a16:creationId xmlns:a16="http://schemas.microsoft.com/office/drawing/2014/main" id="{5C9117C7-CC35-4D46-993D-D89E5240D8AD}"/>
               </a:ext>
             </a:extLst>
           </p:cNvPr>
@@ -8395,7 +8427,7 @@
           <p:cNvPr id="45" name="">
             <a:extLst xmlns:a="http://schemas.openxmlformats.org/drawingml/2006/main">
               <a:ext uri="{FF2B5EF4-FFF2-40B4-BE49-F238E27FC236}">
-                <a16:creationId xmlns:a16="http://schemas.microsoft.com/office/drawing/2014/main" id="{EE10746D-6386-48A9-9D55-437ECFDABBB7}"/>
+                <a16:creationId xmlns:a16="http://schemas.microsoft.com/office/drawing/2014/main" id="{E7C469BF-F909-4BAF-AA20-593071A7DFD0}"/>
               </a:ext>
             </a:extLst>
           </p:cNvPr>
@@ -8445,7 +8477,7 @@
           <p:cNvPr id="46" name="">
             <a:extLst xmlns:a="http://schemas.openxmlformats.org/drawingml/2006/main">
               <a:ext uri="{FF2B5EF4-FFF2-40B4-BE49-F238E27FC236}">
-                <a16:creationId xmlns:a16="http://schemas.microsoft.com/office/drawing/2014/main" id="{2C8E307A-0047-480C-BEC0-A31B31936764}"/>
+                <a16:creationId xmlns:a16="http://schemas.microsoft.com/office/drawing/2014/main" id="{B00CB438-D76C-4BDC-9F47-E6C304CD3F4D}"/>
               </a:ext>
             </a:extLst>
           </p:cNvPr>
@@ -8495,7 +8527,7 @@
           <p:cNvPr id="47" name="">
             <a:extLst xmlns:a="http://schemas.openxmlformats.org/drawingml/2006/main">
               <a:ext uri="{FF2B5EF4-FFF2-40B4-BE49-F238E27FC236}">
-                <a16:creationId xmlns:a16="http://schemas.microsoft.com/office/drawing/2014/main" id="{6521F736-26DD-4422-A73E-DBCC93A676A8}"/>
+                <a16:creationId xmlns:a16="http://schemas.microsoft.com/office/drawing/2014/main" id="{3CF03E76-AD35-4194-9D9A-424D799C4F3A}"/>
               </a:ext>
             </a:extLst>
           </p:cNvPr>
@@ -8543,7 +8575,7 @@
     </p:spTree>
     <p:extLst>
       <p:ext uri="{BB962C8B-B14F-4D97-AF65-F5344CB8AC3E}">
-        <p14:creationId xmlns:p14="http://schemas.microsoft.com/office/powerpoint/2010/main" val="2061116944"/>
+        <p14:creationId xmlns:p14="http://schemas.microsoft.com/office/powerpoint/2010/main" val="200567581"/>
       </p:ext>
     </p:extLst>
   </p:cSld>
@@ -8574,7 +8606,7 @@
           <p:cNvPr id="19" name="slide-7-title">
             <a:extLst xmlns:a="http://schemas.openxmlformats.org/drawingml/2006/main">
               <a:ext uri="{FF2B5EF4-FFF2-40B4-BE49-F238E27FC236}">
-                <a16:creationId xmlns:a16="http://schemas.microsoft.com/office/drawing/2014/main" id="{D19FCEC4-0F9D-4633-A95F-C0744677B18A}"/>
+                <a16:creationId xmlns:a16="http://schemas.microsoft.com/office/drawing/2014/main" id="{091F933D-5BC1-4592-AB3C-F7FB5764A93D}"/>
               </a:ext>
             </a:extLst>
           </p:cNvPr>
@@ -8624,7 +8656,7 @@
           <p:cNvPr id="2" name="">
             <a:extLst xmlns:a="http://schemas.openxmlformats.org/drawingml/2006/main">
               <a:ext uri="{FF2B5EF4-FFF2-40B4-BE49-F238E27FC236}">
-                <a16:creationId xmlns:a16="http://schemas.microsoft.com/office/drawing/2014/main" id="{F057A5F3-8BA1-499E-8FAE-400EFE7516C3}"/>
+                <a16:creationId xmlns:a16="http://schemas.microsoft.com/office/drawing/2014/main" id="{98665034-DB1F-4CD8-8807-77A2227DB764}"/>
               </a:ext>
             </a:extLst>
           </p:cNvPr>
@@ -8696,7 +8728,7 @@
           <p:cNvPr id="4" name="">
             <a:extLst xmlns:a="http://schemas.openxmlformats.org/drawingml/2006/main">
               <a:ext uri="{FF2B5EF4-FFF2-40B4-BE49-F238E27FC236}">
-                <a16:creationId xmlns:a16="http://schemas.microsoft.com/office/drawing/2014/main" id="{DD8AD1A9-AC9A-47DC-899E-990AE65033BB}"/>
+                <a16:creationId xmlns:a16="http://schemas.microsoft.com/office/drawing/2014/main" id="{A2B20156-63F0-4307-AB7F-B65B5A4E7D3F}"/>
               </a:ext>
             </a:extLst>
           </p:cNvPr>
@@ -8746,7 +8778,7 @@
           <p:cNvPr id="5" name="">
             <a:extLst xmlns:a="http://schemas.openxmlformats.org/drawingml/2006/main">
               <a:ext uri="{FF2B5EF4-FFF2-40B4-BE49-F238E27FC236}">
-                <a16:creationId xmlns:a16="http://schemas.microsoft.com/office/drawing/2014/main" id="{B3302A70-31DD-4E73-A2A3-481EBDE81C54}"/>
+                <a16:creationId xmlns:a16="http://schemas.microsoft.com/office/drawing/2014/main" id="{BA2ACA95-FE86-47ED-AC77-7B31D09BBFC6}"/>
               </a:ext>
             </a:extLst>
           </p:cNvPr>
@@ -8796,7 +8828,7 @@
           <p:cNvPr id="6" name="">
             <a:extLst xmlns:a="http://schemas.openxmlformats.org/drawingml/2006/main">
               <a:ext uri="{FF2B5EF4-FFF2-40B4-BE49-F238E27FC236}">
-                <a16:creationId xmlns:a16="http://schemas.microsoft.com/office/drawing/2014/main" id="{F3109820-A5E4-4CEB-9BBF-14671CB1149D}"/>
+                <a16:creationId xmlns:a16="http://schemas.microsoft.com/office/drawing/2014/main" id="{F8F4DC61-1541-4E0A-A1DB-28AF26C7CEB4}"/>
               </a:ext>
             </a:extLst>
           </p:cNvPr>
@@ -8868,7 +8900,7 @@
           <p:cNvPr id="8" name="">
             <a:extLst xmlns:a="http://schemas.openxmlformats.org/drawingml/2006/main">
               <a:ext uri="{FF2B5EF4-FFF2-40B4-BE49-F238E27FC236}">
-                <a16:creationId xmlns:a16="http://schemas.microsoft.com/office/drawing/2014/main" id="{EE9428C4-2031-416F-8ADE-115EF5DD5380}"/>
+                <a16:creationId xmlns:a16="http://schemas.microsoft.com/office/drawing/2014/main" id="{B368BC0F-EB2A-4399-AD92-9AA5737ABED0}"/>
               </a:ext>
             </a:extLst>
           </p:cNvPr>
@@ -8918,7 +8950,7 @@
           <p:cNvPr id="9" name="">
             <a:extLst xmlns:a="http://schemas.openxmlformats.org/drawingml/2006/main">
               <a:ext uri="{FF2B5EF4-FFF2-40B4-BE49-F238E27FC236}">
-                <a16:creationId xmlns:a16="http://schemas.microsoft.com/office/drawing/2014/main" id="{83F2A096-0D5A-4B9A-8C5F-704A7B660ACA}"/>
+                <a16:creationId xmlns:a16="http://schemas.microsoft.com/office/drawing/2014/main" id="{C6B0344E-BC56-4736-8D2E-C9AC5E9EE80E}"/>
               </a:ext>
             </a:extLst>
           </p:cNvPr>
@@ -8968,7 +9000,7 @@
           <p:cNvPr id="10" name="">
             <a:extLst xmlns:a="http://schemas.openxmlformats.org/drawingml/2006/main">
               <a:ext uri="{FF2B5EF4-FFF2-40B4-BE49-F238E27FC236}">
-                <a16:creationId xmlns:a16="http://schemas.microsoft.com/office/drawing/2014/main" id="{D67F64D4-ECC0-468A-8FCC-3E3EBF574525}"/>
+                <a16:creationId xmlns:a16="http://schemas.microsoft.com/office/drawing/2014/main" id="{B48D3C2D-407E-4ADE-B40B-3C374C11CBD8}"/>
               </a:ext>
             </a:extLst>
           </p:cNvPr>
@@ -9040,7 +9072,7 @@
           <p:cNvPr id="12" name="">
             <a:extLst xmlns:a="http://schemas.openxmlformats.org/drawingml/2006/main">
               <a:ext uri="{FF2B5EF4-FFF2-40B4-BE49-F238E27FC236}">
-                <a16:creationId xmlns:a16="http://schemas.microsoft.com/office/drawing/2014/main" id="{9C0D9F7D-8916-409D-96FC-83D1C178F4DE}"/>
+                <a16:creationId xmlns:a16="http://schemas.microsoft.com/office/drawing/2014/main" id="{9C2D426D-2CDE-4E06-8337-7E870BDEB5DA}"/>
               </a:ext>
             </a:extLst>
           </p:cNvPr>
@@ -9090,7 +9122,7 @@
           <p:cNvPr id="13" name="">
             <a:extLst xmlns:a="http://schemas.openxmlformats.org/drawingml/2006/main">
               <a:ext uri="{FF2B5EF4-FFF2-40B4-BE49-F238E27FC236}">
-                <a16:creationId xmlns:a16="http://schemas.microsoft.com/office/drawing/2014/main" id="{AB3F124F-5A63-44F4-AD73-1110441A79FD}"/>
+                <a16:creationId xmlns:a16="http://schemas.microsoft.com/office/drawing/2014/main" id="{D0C86821-BA00-413D-A61A-8F8C50999A4E}"/>
               </a:ext>
             </a:extLst>
           </p:cNvPr>
@@ -9140,7 +9172,7 @@
           <p:cNvPr id="14" name="">
             <a:extLst xmlns:a="http://schemas.openxmlformats.org/drawingml/2006/main">
               <a:ext uri="{FF2B5EF4-FFF2-40B4-BE49-F238E27FC236}">
-                <a16:creationId xmlns:a16="http://schemas.microsoft.com/office/drawing/2014/main" id="{F9AA18F8-DDF7-40C0-AC41-2787DC4D5FAB}"/>
+                <a16:creationId xmlns:a16="http://schemas.microsoft.com/office/drawing/2014/main" id="{13EFE464-4BA9-4E59-9328-AB748EE6798A}"/>
               </a:ext>
             </a:extLst>
           </p:cNvPr>
@@ -9212,7 +9244,7 @@
           <p:cNvPr id="16" name="">
             <a:extLst xmlns:a="http://schemas.openxmlformats.org/drawingml/2006/main">
               <a:ext uri="{FF2B5EF4-FFF2-40B4-BE49-F238E27FC236}">
-                <a16:creationId xmlns:a16="http://schemas.microsoft.com/office/drawing/2014/main" id="{629FD184-5BFA-4FA9-BF6C-F165EF59883F}"/>
+                <a16:creationId xmlns:a16="http://schemas.microsoft.com/office/drawing/2014/main" id="{036DC565-D5DE-448A-9CA5-22F3A7B1BB18}"/>
               </a:ext>
             </a:extLst>
           </p:cNvPr>
@@ -9262,7 +9294,7 @@
           <p:cNvPr id="17" name="">
             <a:extLst xmlns:a="http://schemas.openxmlformats.org/drawingml/2006/main">
               <a:ext uri="{FF2B5EF4-FFF2-40B4-BE49-F238E27FC236}">
-                <a16:creationId xmlns:a16="http://schemas.microsoft.com/office/drawing/2014/main" id="{EB858D6C-EDA1-4D10-B6D6-0E626019701A}"/>
+                <a16:creationId xmlns:a16="http://schemas.microsoft.com/office/drawing/2014/main" id="{DEC91FC9-24F9-4EDE-98C4-82571609461A}"/>
               </a:ext>
             </a:extLst>
           </p:cNvPr>
@@ -9312,7 +9344,7 @@
           <p:cNvPr id="18" name="">
             <a:extLst xmlns:a="http://schemas.openxmlformats.org/drawingml/2006/main">
               <a:ext uri="{FF2B5EF4-FFF2-40B4-BE49-F238E27FC236}">
-                <a16:creationId xmlns:a16="http://schemas.microsoft.com/office/drawing/2014/main" id="{1387D6BA-AD2D-4CFF-A1EC-84BD1F76861B}"/>
+                <a16:creationId xmlns:a16="http://schemas.microsoft.com/office/drawing/2014/main" id="{9C0CA84B-D53C-4B47-AECB-168B0E38A25B}"/>
               </a:ext>
             </a:extLst>
           </p:cNvPr>
@@ -9360,7 +9392,7 @@
     </p:spTree>
     <p:extLst>
       <p:ext uri="{BB962C8B-B14F-4D97-AF65-F5344CB8AC3E}">
-        <p14:creationId xmlns:p14="http://schemas.microsoft.com/office/powerpoint/2010/main" val="356985590"/>
+        <p14:creationId xmlns:p14="http://schemas.microsoft.com/office/powerpoint/2010/main" val="1810016524"/>
       </p:ext>
     </p:extLst>
   </p:cSld>
@@ -9391,7 +9423,7 @@
           <p:cNvPr id="14" name="slide-8-title">
             <a:extLst xmlns:a="http://schemas.openxmlformats.org/drawingml/2006/main">
               <a:ext uri="{FF2B5EF4-FFF2-40B4-BE49-F238E27FC236}">
-                <a16:creationId xmlns:a16="http://schemas.microsoft.com/office/drawing/2014/main" id="{C905B53E-E832-4723-9413-672F3E4F6DC7}"/>
+                <a16:creationId xmlns:a16="http://schemas.microsoft.com/office/drawing/2014/main" id="{E3F2AD5F-21F7-4F0F-9526-2B06FE935442}"/>
               </a:ext>
             </a:extLst>
           </p:cNvPr>
@@ -9441,7 +9473,7 @@
           <p:cNvPr id="2" name="">
             <a:extLst xmlns:a="http://schemas.openxmlformats.org/drawingml/2006/main">
               <a:ext uri="{FF2B5EF4-FFF2-40B4-BE49-F238E27FC236}">
-                <a16:creationId xmlns:a16="http://schemas.microsoft.com/office/drawing/2014/main" id="{F4E22397-367B-467A-99F4-5C38E2FE2F34}"/>
+                <a16:creationId xmlns:a16="http://schemas.microsoft.com/office/drawing/2014/main" id="{B5198B38-BB30-4CC6-B9E8-299AA8B3D476}"/>
               </a:ext>
             </a:extLst>
           </p:cNvPr>
@@ -9498,7 +9530,7 @@
         </p:xfrm>
         <a:graphic xmlns:a="http://schemas.openxmlformats.org/drawingml/2006/main">
           <a:graphicData uri="http://schemas.openxmlformats.org/drawingml/2006/chart">
-            <c:chart xmlns:r="http://schemas.openxmlformats.org/officeDocument/2006/relationships" xmlns:c="http://schemas.openxmlformats.org/drawingml/2006/chart" r:id="R40cbc99ce91947df"/>
+            <c:chart xmlns:r="http://schemas.openxmlformats.org/officeDocument/2006/relationships" xmlns:c="http://schemas.openxmlformats.org/drawingml/2006/chart" r:id="Rb6f73d105ae94c4c"/>
           </a:graphicData>
         </a:graphic>
       </p:graphicFrame>
@@ -9507,7 +9539,7 @@
           <p:cNvPr id="4" name="">
             <a:extLst xmlns:a="http://schemas.openxmlformats.org/drawingml/2006/main">
               <a:ext uri="{FF2B5EF4-FFF2-40B4-BE49-F238E27FC236}">
-                <a16:creationId xmlns:a16="http://schemas.microsoft.com/office/drawing/2014/main" id="{9B802365-1FB2-431D-B7AF-42EB6833B55B}"/>
+                <a16:creationId xmlns:a16="http://schemas.microsoft.com/office/drawing/2014/main" id="{B5E8CBBA-279C-4C88-9F15-93C6FD701CCB}"/>
               </a:ext>
             </a:extLst>
           </p:cNvPr>
@@ -9538,7 +9570,7 @@
           <p:cNvPr id="5" name="">
             <a:extLst xmlns:a="http://schemas.openxmlformats.org/drawingml/2006/main">
               <a:ext uri="{FF2B5EF4-FFF2-40B4-BE49-F238E27FC236}">
-                <a16:creationId xmlns:a16="http://schemas.microsoft.com/office/drawing/2014/main" id="{83D9AF8B-10DC-443F-B28C-7669334B24C7}"/>
+                <a16:creationId xmlns:a16="http://schemas.microsoft.com/office/drawing/2014/main" id="{AAD007AE-5502-43F3-B334-ED20468C785B}"/>
               </a:ext>
             </a:extLst>
           </p:cNvPr>
@@ -9588,7 +9620,7 @@
           <p:cNvPr id="6" name="">
             <a:extLst xmlns:a="http://schemas.openxmlformats.org/drawingml/2006/main">
               <a:ext uri="{FF2B5EF4-FFF2-40B4-BE49-F238E27FC236}">
-                <a16:creationId xmlns:a16="http://schemas.microsoft.com/office/drawing/2014/main" id="{28EAB564-E470-49E3-9BCD-C626B75440C1}"/>
+                <a16:creationId xmlns:a16="http://schemas.microsoft.com/office/drawing/2014/main" id="{0655D210-D43B-4B0D-A283-0C2C37ED7264}"/>
               </a:ext>
             </a:extLst>
           </p:cNvPr>
@@ -9638,7 +9670,7 @@
           <p:cNvPr id="7" name="">
             <a:extLst xmlns:a="http://schemas.openxmlformats.org/drawingml/2006/main">
               <a:ext uri="{FF2B5EF4-FFF2-40B4-BE49-F238E27FC236}">
-                <a16:creationId xmlns:a16="http://schemas.microsoft.com/office/drawing/2014/main" id="{378FDB4C-BA91-41C3-9B2F-6F3050222024}"/>
+                <a16:creationId xmlns:a16="http://schemas.microsoft.com/office/drawing/2014/main" id="{A01C8EF9-AB3C-473C-AEE8-7C5C315ADC09}"/>
               </a:ext>
             </a:extLst>
           </p:cNvPr>
@@ -9669,7 +9701,7 @@
           <p:cNvPr id="8" name="">
             <a:extLst xmlns:a="http://schemas.openxmlformats.org/drawingml/2006/main">
               <a:ext uri="{FF2B5EF4-FFF2-40B4-BE49-F238E27FC236}">
-                <a16:creationId xmlns:a16="http://schemas.microsoft.com/office/drawing/2014/main" id="{600EC2F6-2173-4C50-B983-C8A562C06EE6}"/>
+                <a16:creationId xmlns:a16="http://schemas.microsoft.com/office/drawing/2014/main" id="{F02AEDF4-24E1-4A12-A8E0-E46626B03614}"/>
               </a:ext>
             </a:extLst>
           </p:cNvPr>
@@ -9719,7 +9751,7 @@
           <p:cNvPr id="9" name="">
             <a:extLst xmlns:a="http://schemas.openxmlformats.org/drawingml/2006/main">
               <a:ext uri="{FF2B5EF4-FFF2-40B4-BE49-F238E27FC236}">
-                <a16:creationId xmlns:a16="http://schemas.microsoft.com/office/drawing/2014/main" id="{5473A4FE-DE1B-4000-9783-A2A7E2F1EAE0}"/>
+                <a16:creationId xmlns:a16="http://schemas.microsoft.com/office/drawing/2014/main" id="{7052226C-573E-4DD0-B3F8-5E4A81B01745}"/>
               </a:ext>
             </a:extLst>
           </p:cNvPr>
@@ -9769,7 +9801,7 @@
           <p:cNvPr id="10" name="">
             <a:extLst xmlns:a="http://schemas.openxmlformats.org/drawingml/2006/main">
               <a:ext uri="{FF2B5EF4-FFF2-40B4-BE49-F238E27FC236}">
-                <a16:creationId xmlns:a16="http://schemas.microsoft.com/office/drawing/2014/main" id="{8C104AE0-323E-4660-8714-E1C42502F8DA}"/>
+                <a16:creationId xmlns:a16="http://schemas.microsoft.com/office/drawing/2014/main" id="{9DC8AAE7-B680-4F91-965D-5FCA3B6E3EF0}"/>
               </a:ext>
             </a:extLst>
           </p:cNvPr>
@@ -9800,7 +9832,7 @@
           <p:cNvPr id="11" name="">
             <a:extLst xmlns:a="http://schemas.openxmlformats.org/drawingml/2006/main">
               <a:ext uri="{FF2B5EF4-FFF2-40B4-BE49-F238E27FC236}">
-                <a16:creationId xmlns:a16="http://schemas.microsoft.com/office/drawing/2014/main" id="{E9AA8FCE-9DF2-405A-A2A4-A90CB35D59CC}"/>
+                <a16:creationId xmlns:a16="http://schemas.microsoft.com/office/drawing/2014/main" id="{08DEFA1C-CB43-4618-9041-BBD298CCD243}"/>
               </a:ext>
             </a:extLst>
           </p:cNvPr>
@@ -9850,7 +9882,7 @@
           <p:cNvPr id="12" name="">
             <a:extLst xmlns:a="http://schemas.openxmlformats.org/drawingml/2006/main">
               <a:ext uri="{FF2B5EF4-FFF2-40B4-BE49-F238E27FC236}">
-                <a16:creationId xmlns:a16="http://schemas.microsoft.com/office/drawing/2014/main" id="{08683995-7F9B-4B23-99AF-B3E8105B8E89}"/>
+                <a16:creationId xmlns:a16="http://schemas.microsoft.com/office/drawing/2014/main" id="{96F1E8A9-B9D0-4981-9665-9DF7ED1013DD}"/>
               </a:ext>
             </a:extLst>
           </p:cNvPr>
@@ -9900,7 +9932,7 @@
           <p:cNvPr id="13" name="">
             <a:extLst xmlns:a="http://schemas.openxmlformats.org/drawingml/2006/main">
               <a:ext uri="{FF2B5EF4-FFF2-40B4-BE49-F238E27FC236}">
-                <a16:creationId xmlns:a16="http://schemas.microsoft.com/office/drawing/2014/main" id="{6B3C1531-F2B6-4455-B20C-0B6C5C94FC7F}"/>
+                <a16:creationId xmlns:a16="http://schemas.microsoft.com/office/drawing/2014/main" id="{63CB29B5-B62A-4652-8039-E08F6175FB38}"/>
               </a:ext>
             </a:extLst>
           </p:cNvPr>
@@ -9948,7 +9980,7 @@
     </p:spTree>
     <p:extLst>
       <p:ext uri="{BB962C8B-B14F-4D97-AF65-F5344CB8AC3E}">
-        <p14:creationId xmlns:p14="http://schemas.microsoft.com/office/powerpoint/2010/main" val="153516749"/>
+        <p14:creationId xmlns:p14="http://schemas.microsoft.com/office/powerpoint/2010/main" val="395023855"/>
       </p:ext>
     </p:extLst>
   </p:cSld>
@@ -9979,7 +10011,7 @@
           <p:cNvPr id="20" name="slide-9-title">
             <a:extLst xmlns:a="http://schemas.openxmlformats.org/drawingml/2006/main">
               <a:ext uri="{FF2B5EF4-FFF2-40B4-BE49-F238E27FC236}">
-                <a16:creationId xmlns:a16="http://schemas.microsoft.com/office/drawing/2014/main" id="{71931BCC-2883-41BA-BD34-C76A7F848CFF}"/>
+                <a16:creationId xmlns:a16="http://schemas.microsoft.com/office/drawing/2014/main" id="{506DBA37-9943-4251-B1E5-31F8FD0D49FB}"/>
               </a:ext>
             </a:extLst>
           </p:cNvPr>
@@ -10029,7 +10061,7 @@
           <p:cNvPr id="2" name="">
             <a:extLst xmlns:a="http://schemas.openxmlformats.org/drawingml/2006/main">
               <a:ext uri="{FF2B5EF4-FFF2-40B4-BE49-F238E27FC236}">
-                <a16:creationId xmlns:a16="http://schemas.microsoft.com/office/drawing/2014/main" id="{AE7A9FF4-05C7-4960-9FA6-753078A2435C}"/>
+                <a16:creationId xmlns:a16="http://schemas.microsoft.com/office/drawing/2014/main" id="{C4635588-8C03-418F-B977-4A0ABED6F47C}"/>
               </a:ext>
             </a:extLst>
           </p:cNvPr>
@@ -10079,7 +10111,7 @@
           <p:cNvPr id="3" name="">
             <a:extLst xmlns:a="http://schemas.openxmlformats.org/drawingml/2006/main">
               <a:ext uri="{FF2B5EF4-FFF2-40B4-BE49-F238E27FC236}">
-                <a16:creationId xmlns:a16="http://schemas.microsoft.com/office/drawing/2014/main" id="{EC8CF712-4F2F-489B-A7A8-AE8DB2B6DD5D}"/>
+                <a16:creationId xmlns:a16="http://schemas.microsoft.com/office/drawing/2014/main" id="{BFB939B3-C698-4728-8079-E0210C6EB4F5}"/>
               </a:ext>
             </a:extLst>
           </p:cNvPr>
@@ -10129,7 +10161,7 @@
           <p:cNvPr id="4" name="">
             <a:extLst xmlns:a="http://schemas.openxmlformats.org/drawingml/2006/main">
               <a:ext uri="{FF2B5EF4-FFF2-40B4-BE49-F238E27FC236}">
-                <a16:creationId xmlns:a16="http://schemas.microsoft.com/office/drawing/2014/main" id="{6D72692A-0B23-4FFF-BEA2-BDAD2AB75F0A}"/>
+                <a16:creationId xmlns:a16="http://schemas.microsoft.com/office/drawing/2014/main" id="{90FD37AE-85E6-4710-A612-1D416E07D2D4}"/>
               </a:ext>
             </a:extLst>
           </p:cNvPr>
@@ -10179,7 +10211,7 @@
           <p:cNvPr id="5" name="">
             <a:extLst xmlns:a="http://schemas.openxmlformats.org/drawingml/2006/main">
               <a:ext uri="{FF2B5EF4-FFF2-40B4-BE49-F238E27FC236}">
-                <a16:creationId xmlns:a16="http://schemas.microsoft.com/office/drawing/2014/main" id="{67594C61-0756-4245-A196-68AE5CB698F0}"/>
+                <a16:creationId xmlns:a16="http://schemas.microsoft.com/office/drawing/2014/main" id="{0211D95D-D2E1-41B2-853D-0537A8FB62CD}"/>
               </a:ext>
             </a:extLst>
           </p:cNvPr>
@@ -10210,7 +10242,7 @@
           <p:cNvPr id="6" name="">
             <a:extLst xmlns:a="http://schemas.openxmlformats.org/drawingml/2006/main">
               <a:ext uri="{FF2B5EF4-FFF2-40B4-BE49-F238E27FC236}">
-                <a16:creationId xmlns:a16="http://schemas.microsoft.com/office/drawing/2014/main" id="{4FBC1D79-5FD4-406D-B4B2-A8745E44B1B9}"/>
+                <a16:creationId xmlns:a16="http://schemas.microsoft.com/office/drawing/2014/main" id="{713D86FF-03AF-4B12-AFDB-4ED5CB479F10}"/>
               </a:ext>
             </a:extLst>
           </p:cNvPr>
@@ -10260,7 +10292,7 @@
           <p:cNvPr id="7" name="">
             <a:extLst xmlns:a="http://schemas.openxmlformats.org/drawingml/2006/main">
               <a:ext uri="{FF2B5EF4-FFF2-40B4-BE49-F238E27FC236}">
-                <a16:creationId xmlns:a16="http://schemas.microsoft.com/office/drawing/2014/main" id="{E4910A06-375F-41B0-9F27-7F1FA0CB27F3}"/>
+                <a16:creationId xmlns:a16="http://schemas.microsoft.com/office/drawing/2014/main" id="{F7B5326F-5CB4-4D1D-BEC3-21AA7BC2CFD2}"/>
               </a:ext>
             </a:extLst>
           </p:cNvPr>
@@ -10310,7 +10342,7 @@
           <p:cNvPr id="8" name="">
             <a:extLst xmlns:a="http://schemas.openxmlformats.org/drawingml/2006/main">
               <a:ext uri="{FF2B5EF4-FFF2-40B4-BE49-F238E27FC236}">
-                <a16:creationId xmlns:a16="http://schemas.microsoft.com/office/drawing/2014/main" id="{C770CFB4-C420-4747-9BEF-CE3998946733}"/>
+                <a16:creationId xmlns:a16="http://schemas.microsoft.com/office/drawing/2014/main" id="{84B440EE-D985-4ACE-88A0-3B09BBF84173}"/>
               </a:ext>
             </a:extLst>
           </p:cNvPr>
@@ -10341,7 +10373,7 @@
           <p:cNvPr id="9" name="">
             <a:extLst xmlns:a="http://schemas.openxmlformats.org/drawingml/2006/main">
               <a:ext uri="{FF2B5EF4-FFF2-40B4-BE49-F238E27FC236}">
-                <a16:creationId xmlns:a16="http://schemas.microsoft.com/office/drawing/2014/main" id="{8B2397B8-EE24-4254-B09C-5913FBAAB072}"/>
+                <a16:creationId xmlns:a16="http://schemas.microsoft.com/office/drawing/2014/main" id="{01E4ED2C-6AB5-412E-9E18-97D22BE39DBF}"/>
               </a:ext>
             </a:extLst>
           </p:cNvPr>
@@ -10391,7 +10423,7 @@
           <p:cNvPr id="10" name="">
             <a:extLst xmlns:a="http://schemas.openxmlformats.org/drawingml/2006/main">
               <a:ext uri="{FF2B5EF4-FFF2-40B4-BE49-F238E27FC236}">
-                <a16:creationId xmlns:a16="http://schemas.microsoft.com/office/drawing/2014/main" id="{9733DC80-EC66-43AD-B79C-597685443F9F}"/>
+                <a16:creationId xmlns:a16="http://schemas.microsoft.com/office/drawing/2014/main" id="{E2A05BDB-468E-4253-87A1-81CD253DE3AB}"/>
               </a:ext>
             </a:extLst>
           </p:cNvPr>
@@ -10441,7 +10473,7 @@
           <p:cNvPr id="11" name="">
             <a:extLst xmlns:a="http://schemas.openxmlformats.org/drawingml/2006/main">
               <a:ext uri="{FF2B5EF4-FFF2-40B4-BE49-F238E27FC236}">
-                <a16:creationId xmlns:a16="http://schemas.microsoft.com/office/drawing/2014/main" id="{CBDCACD2-9513-4C75-BCCC-2926C1408217}"/>
+                <a16:creationId xmlns:a16="http://schemas.microsoft.com/office/drawing/2014/main" id="{EF0DA4E7-A627-4C48-ABE3-ED5C10A52241}"/>
               </a:ext>
             </a:extLst>
           </p:cNvPr>
@@ -10472,7 +10504,7 @@
           <p:cNvPr id="12" name="">
             <a:extLst xmlns:a="http://schemas.openxmlformats.org/drawingml/2006/main">
               <a:ext uri="{FF2B5EF4-FFF2-40B4-BE49-F238E27FC236}">
-                <a16:creationId xmlns:a16="http://schemas.microsoft.com/office/drawing/2014/main" id="{2CEB181E-70D2-4D5A-9118-FA27F031FAE4}"/>
+                <a16:creationId xmlns:a16="http://schemas.microsoft.com/office/drawing/2014/main" id="{09CCBE48-BEF6-4561-84A1-1BFF43C60C36}"/>
               </a:ext>
             </a:extLst>
           </p:cNvPr>
@@ -10522,7 +10554,7 @@
           <p:cNvPr id="13" name="">
             <a:extLst xmlns:a="http://schemas.openxmlformats.org/drawingml/2006/main">
               <a:ext uri="{FF2B5EF4-FFF2-40B4-BE49-F238E27FC236}">
-                <a16:creationId xmlns:a16="http://schemas.microsoft.com/office/drawing/2014/main" id="{2B59003B-E5E8-466F-A8DE-96167402D734}"/>
+                <a16:creationId xmlns:a16="http://schemas.microsoft.com/office/drawing/2014/main" id="{278B8014-EC34-46D5-AE32-EC976689250D}"/>
               </a:ext>
             </a:extLst>
           </p:cNvPr>
@@ -10572,7 +10604,7 @@
           <p:cNvPr id="14" name="">
             <a:extLst xmlns:a="http://schemas.openxmlformats.org/drawingml/2006/main">
               <a:ext uri="{FF2B5EF4-FFF2-40B4-BE49-F238E27FC236}">
-                <a16:creationId xmlns:a16="http://schemas.microsoft.com/office/drawing/2014/main" id="{BF9DF96C-A154-4A32-A23E-FC59C507C4B7}"/>
+                <a16:creationId xmlns:a16="http://schemas.microsoft.com/office/drawing/2014/main" id="{CF382F2B-C0B4-4C92-8688-577F11B444E3}"/>
               </a:ext>
             </a:extLst>
           </p:cNvPr>
@@ -10603,7 +10635,7 @@
           <p:cNvPr id="15" name="">
             <a:extLst xmlns:a="http://schemas.openxmlformats.org/drawingml/2006/main">
               <a:ext uri="{FF2B5EF4-FFF2-40B4-BE49-F238E27FC236}">
-                <a16:creationId xmlns:a16="http://schemas.microsoft.com/office/drawing/2014/main" id="{C5A3B931-DC5E-41BD-9DB2-09D0E9D2261E}"/>
+                <a16:creationId xmlns:a16="http://schemas.microsoft.com/office/drawing/2014/main" id="{51F97EEC-1697-417F-8753-61B123F70B75}"/>
               </a:ext>
             </a:extLst>
           </p:cNvPr>
@@ -10675,7 +10707,7 @@
           <p:cNvPr id="17" name="">
             <a:extLst xmlns:a="http://schemas.openxmlformats.org/drawingml/2006/main">
               <a:ext uri="{FF2B5EF4-FFF2-40B4-BE49-F238E27FC236}">
-                <a16:creationId xmlns:a16="http://schemas.microsoft.com/office/drawing/2014/main" id="{99E82DAA-E456-49DA-8C25-5DC908D3841C}"/>
+                <a16:creationId xmlns:a16="http://schemas.microsoft.com/office/drawing/2014/main" id="{384F3CCE-DC47-4010-9FE2-B297ADAA2A4E}"/>
               </a:ext>
             </a:extLst>
           </p:cNvPr>
@@ -10725,7 +10757,7 @@
           <p:cNvPr id="18" name="">
             <a:extLst xmlns:a="http://schemas.openxmlformats.org/drawingml/2006/main">
               <a:ext uri="{FF2B5EF4-FFF2-40B4-BE49-F238E27FC236}">
-                <a16:creationId xmlns:a16="http://schemas.microsoft.com/office/drawing/2014/main" id="{7D21FAD1-9FE5-47EC-8662-FA68F37E8EBF}"/>
+                <a16:creationId xmlns:a16="http://schemas.microsoft.com/office/drawing/2014/main" id="{419E0488-8B42-4766-B43C-4EC9F14689B7}"/>
               </a:ext>
             </a:extLst>
           </p:cNvPr>
@@ -10775,81 +10807,98 @@
           <p:cNvPr id="19" name="">
             <a:extLst xmlns:a="http://schemas.openxmlformats.org/drawingml/2006/main">
               <a:ext uri="{FF2B5EF4-FFF2-40B4-BE49-F238E27FC236}">
-                <a16:creationId xmlns:a16="http://schemas.microsoft.com/office/drawing/2014/main" id="{309AA238-D294-4082-8B3F-2EE8B696C7DF}"/>
-              </a:ext>
-            </a:extLst>
-          </p:cNvPr>
-          <p:cNvSpPr>
-            <a:spLocks xmlns:a="http://schemas.openxmlformats.org/drawingml/2006/main" noGrp="1"/>
-          </p:cNvSpPr>
-          <p:nvPr/>
-        </p:nvSpPr>
-        <p:spPr>
-          <a:xfrm xmlns:a="http://schemas.openxmlformats.org/drawingml/2006/main">
-            <a:off x="6819900" y="4095750"/>
-            <a:ext cx="4286250" cy="1200150"/>
-          </a:xfrm>
-          <a:prstGeom xmlns:a="http://schemas.openxmlformats.org/drawingml/2006/main" prst="rect">
-            <a:avLst/>
-          </a:prstGeom>
-          <a:noFill xmlns:a="http://schemas.openxmlformats.org/drawingml/2006/main"/>
-          <a:ln xmlns:a="http://schemas.openxmlformats.org/drawingml/2006/main" w="0">
-            <a:noFill/>
-            <a:prstDash val="solid"/>
-          </a:ln>
-        </p:spPr>
-        <p:txBody>
-          <a:bodyPr xmlns:a="http://schemas.openxmlformats.org/drawingml/2006/main" anchor="t"/>
-          <a:lstStyle xmlns:a="http://schemas.openxmlformats.org/drawingml/2006/main"/>
-          <a:p xmlns:a="http://schemas.openxmlformats.org/drawingml/2006/main">
-            <a:pPr algn="l">
-              <a:defRPr sz="1800" b="0">
+                <a16:creationId xmlns:a16="http://schemas.microsoft.com/office/drawing/2014/main" id="{DF4BBDFD-B1E3-4BFC-BE85-9AB05992B955}"/>
+              </a:ext>
+            </a:extLst>
+          </p:cNvPr>
+          <p:cNvSpPr>
+            <a:spLocks xmlns:a="http://schemas.openxmlformats.org/drawingml/2006/main" noGrp="1"/>
+          </p:cNvSpPr>
+          <p:nvPr/>
+        </p:nvSpPr>
+        <p:spPr>
+          <a:xfrm xmlns:a="http://schemas.openxmlformats.org/drawingml/2006/main">
+            <a:off x="6819900" y="3981450"/>
+            <a:ext cx="4476750" cy="1466850"/>
+          </a:xfrm>
+          <a:prstGeom xmlns:a="http://schemas.openxmlformats.org/drawingml/2006/main" prst="rect">
+            <a:avLst/>
+          </a:prstGeom>
+          <a:noFill xmlns:a="http://schemas.openxmlformats.org/drawingml/2006/main"/>
+          <a:ln xmlns:a="http://schemas.openxmlformats.org/drawingml/2006/main" w="0">
+            <a:noFill/>
+            <a:prstDash val="solid"/>
+          </a:ln>
+        </p:spPr>
+        <p:txBody>
+          <a:bodyPr xmlns:a="http://schemas.openxmlformats.org/drawingml/2006/main" anchor="t"/>
+          <a:lstStyle xmlns:a="http://schemas.openxmlformats.org/drawingml/2006/main"/>
+          <a:p xmlns:a="http://schemas.openxmlformats.org/drawingml/2006/main">
+            <a:pPr algn="l">
+              <a:defRPr sz="1725" b="0">
                 <a:solidFill>
                   <a:srgbClr val="565D67"/>
                 </a:solidFill>
               </a:defRPr>
             </a:pPr>
             <a:r>
-              <a:rPr sz="1800" b="0">
+              <a:rPr sz="1725" b="0">
                 <a:solidFill>
                   <a:srgbClr val="565D67"/>
                 </a:solidFill>
               </a:rPr>
-              <a:t>Next test: 500-1,000 advisor labels</a:t>
-            </a:r>
-          </a:p>
-          <a:p xmlns:a="http://schemas.openxmlformats.org/drawingml/2006/main">
-            <a:pPr algn="l">
-              <a:defRPr sz="1800" b="0">
+              <a:t>Prepared validation assets:</a:t>
+            </a:r>
+          </a:p>
+          <a:p xmlns:a="http://schemas.openxmlformats.org/drawingml/2006/main">
+            <a:pPr algn="l">
+              <a:defRPr sz="1725" b="0">
                 <a:solidFill>
                   <a:srgbClr val="565D67"/>
                 </a:solidFill>
               </a:defRPr>
             </a:pPr>
             <a:r>
-              <a:rPr sz="1800" b="0">
+              <a:rPr sz="1725" b="0">
                 <a:solidFill>
                   <a:srgbClr val="565D67"/>
                 </a:solidFill>
               </a:rPr>
-              <a:t>Separate authorization benchmark</a:t>
-            </a:r>
-          </a:p>
-          <a:p xmlns:a="http://schemas.openxmlformats.org/drawingml/2006/main">
-            <a:pPr algn="l">
-              <a:defRPr sz="1800" b="0">
+              <a:t>1,000-row advisor queue</a:t>
+            </a:r>
+          </a:p>
+          <a:p xmlns:a="http://schemas.openxmlformats.org/drawingml/2006/main">
+            <a:pPr algn="l">
+              <a:defRPr sz="1725" b="0">
                 <a:solidFill>
                   <a:srgbClr val="565D67"/>
                 </a:solidFill>
               </a:defRPr>
             </a:pPr>
             <a:r>
-              <a:rPr sz="1800" b="0">
+              <a:rPr sz="1725" b="0">
                 <a:solidFill>
                   <a:srgbClr val="565D67"/>
                 </a:solidFill>
               </a:rPr>
-              <a:t>Time-based external validation</a:t>
+              <a:t>430-row authorization benchmark</a:t>
+            </a:r>
+          </a:p>
+          <a:p xmlns:a="http://schemas.openxmlformats.org/drawingml/2006/main">
+            <a:pPr algn="l">
+              <a:defRPr sz="1725" b="0">
+                <a:solidFill>
+                  <a:srgbClr val="565D67"/>
+                </a:solidFill>
+              </a:defRPr>
+            </a:pPr>
+            <a:r>
+              <a:rPr sz="1725" b="0">
+                <a:solidFill>
+                  <a:srgbClr val="565D67"/>
+                </a:solidFill>
+              </a:rPr>
+              <a:t>Time-split macro F1 0.976</a:t>
             </a:r>
           </a:p>
         </p:txBody>
@@ -10857,7 +10906,7 @@
     </p:spTree>
     <p:extLst>
       <p:ext uri="{BB962C8B-B14F-4D97-AF65-F5344CB8AC3E}">
-        <p14:creationId xmlns:p14="http://schemas.microsoft.com/office/powerpoint/2010/main" val="436401932"/>
+        <p14:creationId xmlns:p14="http://schemas.microsoft.com/office/powerpoint/2010/main" val="1899128089"/>
       </p:ext>
     </p:extLst>
   </p:cSld>

</xml_diff>

<commit_message>
Add calibrated review and batch search controls
</commit_message>
<xml_diff>
--- a/slides/MSBA_Job_Matching_Final_Deck.pptx
+++ b/slides/MSBA_Job_Matching_Final_Deck.pptx
@@ -2,22 +2,22 @@
 <file path=ppt/presentation.xml><?xml version="1.0" encoding="utf-8"?>
 <p:presentation xmlns:p="http://schemas.openxmlformats.org/presentationml/2006/main">
   <p:sldMasterIdLst>
-    <p:sldMasterId xmlns:r="http://schemas.openxmlformats.org/officeDocument/2006/relationships" id="2147483648" r:id="R8dfa20d886074678"/>
+    <p:sldMasterId xmlns:r="http://schemas.openxmlformats.org/officeDocument/2006/relationships" id="2147483648" r:id="R402ffd6e6f63443b"/>
   </p:sldMasterIdLst>
   <p:notesMasterIdLst>
-    <p:notesMasterId xmlns:r="http://schemas.openxmlformats.org/officeDocument/2006/relationships" r:id="R4254cf508d2f4efc"/>
+    <p:notesMasterId xmlns:r="http://schemas.openxmlformats.org/officeDocument/2006/relationships" r:id="R0f9399f608c54cbd"/>
   </p:notesMasterIdLst>
   <p:sldIdLst>
-    <p:sldId xmlns:r="http://schemas.openxmlformats.org/officeDocument/2006/relationships" id="256" r:id="R5ffbd88150e64fa6"/>
-    <p:sldId xmlns:r="http://schemas.openxmlformats.org/officeDocument/2006/relationships" id="257" r:id="Rd1df9c35922d4420"/>
-    <p:sldId xmlns:r="http://schemas.openxmlformats.org/officeDocument/2006/relationships" id="258" r:id="Ra20516a66d4d47eb"/>
-    <p:sldId xmlns:r="http://schemas.openxmlformats.org/officeDocument/2006/relationships" id="259" r:id="R0835cd633d544483"/>
-    <p:sldId xmlns:r="http://schemas.openxmlformats.org/officeDocument/2006/relationships" id="260" r:id="R28ff57ae2e22405d"/>
-    <p:sldId xmlns:r="http://schemas.openxmlformats.org/officeDocument/2006/relationships" id="261" r:id="R2d40a5f79b664180"/>
-    <p:sldId xmlns:r="http://schemas.openxmlformats.org/officeDocument/2006/relationships" id="262" r:id="R3788447387044603"/>
-    <p:sldId xmlns:r="http://schemas.openxmlformats.org/officeDocument/2006/relationships" id="263" r:id="R780204d1daed4db4"/>
-    <p:sldId xmlns:r="http://schemas.openxmlformats.org/officeDocument/2006/relationships" id="264" r:id="R3d1ec74838d14b6f"/>
-    <p:sldId xmlns:r="http://schemas.openxmlformats.org/officeDocument/2006/relationships" id="265" r:id="Rd74561ba0a004880"/>
+    <p:sldId xmlns:r="http://schemas.openxmlformats.org/officeDocument/2006/relationships" id="256" r:id="R380b4148d19c4e9f"/>
+    <p:sldId xmlns:r="http://schemas.openxmlformats.org/officeDocument/2006/relationships" id="257" r:id="R773516ebac8a429a"/>
+    <p:sldId xmlns:r="http://schemas.openxmlformats.org/officeDocument/2006/relationships" id="258" r:id="R55820e7ed6fa481e"/>
+    <p:sldId xmlns:r="http://schemas.openxmlformats.org/officeDocument/2006/relationships" id="259" r:id="Rab13876238e3422a"/>
+    <p:sldId xmlns:r="http://schemas.openxmlformats.org/officeDocument/2006/relationships" id="260" r:id="R2cb2c9beee22498b"/>
+    <p:sldId xmlns:r="http://schemas.openxmlformats.org/officeDocument/2006/relationships" id="261" r:id="Rd9461ae9844c41b0"/>
+    <p:sldId xmlns:r="http://schemas.openxmlformats.org/officeDocument/2006/relationships" id="262" r:id="R796a0fe303954684"/>
+    <p:sldId xmlns:r="http://schemas.openxmlformats.org/officeDocument/2006/relationships" id="263" r:id="R6ba7d43c66a84489"/>
+    <p:sldId xmlns:r="http://schemas.openxmlformats.org/officeDocument/2006/relationships" id="264" r:id="Ra3d3647fc3db4000"/>
+    <p:sldId xmlns:r="http://schemas.openxmlformats.org/officeDocument/2006/relationships" id="265" r:id="R9402ffe3f7fe4134"/>
   </p:sldIdLst>
   <p:sldSz cx="12192000" cy="6858000"/>
   <p:notesSz cx="6858000" cy="9144000"/>
@@ -546,7 +546,7 @@
           <a:lstStyle xmlns:a="http://schemas.openxmlformats.org/drawingml/2006/main"/>
           <a:p xmlns:a="http://schemas.openxmlformats.org/drawingml/2006/main">
             <a:r>
-              <a:t>Close with what is complete: the system, time-based test, full-source authorization audit, and 1,000-row human-review queue. The blank advisor fields are an honest deployment boundary, not a missing model output.</a:t>
+              <a:t>Close with what is complete: the trained system, calibrated uncertainty policy, hard-constraint search audit, batch workflow, time-based test, full-source authorization audit, and human-review package. The blank advisor fields are an honest deployment boundary, not a missing model output.</a:t>
             </a:r>
           </a:p>
           <a:p xmlns:a="http://schemas.openxmlformats.org/drawingml/2006/main">
@@ -576,7 +576,12 @@
           </a:p>
           <a:p xmlns:a="http://schemas.openxmlformats.org/drawingml/2006/main">
             <a:r>
-              <a:t>- docs/annotation_guide.md</a:t>
+              <a:t>- models/review_policy.json</a:t>
+            </a:r>
+          </a:p>
+          <a:p xmlns:a="http://schemas.openxmlformats.org/drawingml/2006/main">
+            <a:r>
+              <a:t>- outputs/search_constraint_audit.json</a:t>
             </a:r>
           </a:p>
           <a:p xmlns:a="http://schemas.openxmlformats.org/drawingml/2006/main">
@@ -946,7 +951,7 @@
           <a:lstStyle xmlns:a="http://schemas.openxmlformats.org/drawingml/2006/main"/>
           <a:p xmlns:a="http://schemas.openxmlformats.org/drawingml/2006/main">
             <a:r>
-              <a:t>Walk left to right. The mode router prevents a search sentence from being misclassified as a posting. The policy layer then handles missing fields and authorization independently from role fit.</a:t>
+              <a:t>Walk left to right. The mode router prevents a search sentence from being misclassified as a posting. Verifiable search constraints are enforced before ranking. The policy layer uses class-specific calibrated margins, then handles missing fields and authorization independently from role fit.</a:t>
             </a:r>
           </a:p>
           <a:p xmlns:a="http://schemas.openxmlformats.org/drawingml/2006/main">
@@ -967,6 +972,11 @@
           <a:p xmlns:a="http://schemas.openxmlformats.org/drawingml/2006/main">
             <a:r>
               <a:t>- msba_job_matcher/core.py</a:t>
+            </a:r>
+          </a:p>
+          <a:p xmlns:a="http://schemas.openxmlformats.org/drawingml/2006/main">
+            <a:r>
+              <a:t>- models/review_policy.json</a:t>
             </a:r>
           </a:p>
           <a:p xmlns:a="http://schemas.openxmlformats.org/drawingml/2006/main">
@@ -1331,7 +1341,7 @@
           <a:lstStyle xmlns:a="http://schemas.openxmlformats.org/drawingml/2006/main"/>
           <a:p xmlns:a="http://schemas.openxmlformats.org/drawingml/2006/main">
             <a:r>
-              <a:t>The model makes 65 errors on the fixed weak-label set. We therefore prepared the human annotation queue, authorization benchmark, and time-based validation instead of treating weak-label agreement as advisor accuracy.</a:t>
+              <a:t>The model makes 65 errors on the fixed weak-label set, so the production policy is calibrated on one 10,000-row half and audited on another. It retains 91.63 percent coverage at 99.47 percent weak-label accuracy. A separate six-query audit records zero hard-constraint violations across 36 search results.</a:t>
             </a:r>
           </a:p>
           <a:p xmlns:a="http://schemas.openxmlformats.org/drawingml/2006/main">
@@ -1351,17 +1361,17 @@
           </a:p>
           <a:p xmlns:a="http://schemas.openxmlformats.org/drawingml/2006/main">
             <a:r>
-              <a:t>- models/job_fit_tfidf_svc_metrics.json</a:t>
+              <a:t>- models/review_policy.json</a:t>
+            </a:r>
+          </a:p>
+          <a:p xmlns:a="http://schemas.openxmlformats.org/drawingml/2006/main">
+            <a:r>
+              <a:t>- outputs/search_constraint_audit.json</a:t>
             </a:r>
           </a:p>
           <a:p xmlns:a="http://schemas.openxmlformats.org/drawingml/2006/main">
             <a:r>
               <a:t>- outputs/temporal_validation_results.json</a:t>
-            </a:r>
-          </a:p>
-          <a:p xmlns:a="http://schemas.openxmlformats.org/drawingml/2006/main">
-            <a:r>
-              <a:t>- outputs/authorization_evidence_audit.json</a:t>
             </a:r>
           </a:p>
           <a:p xmlns:a="http://schemas.openxmlformats.org/drawingml/2006/main">
@@ -1434,7 +1444,7 @@
   </p:cSld>
   <p:clrMap bg1="lt1" tx1="dk1" bg2="lt2" tx2="dk2" accent1="accent1" accent2="accent2" accent3="accent3" accent4="accent4" accent5="accent5" accent6="accent6" hlink="hlink" folHlink="folHlink"/>
   <p:sldLayoutIdLst>
-    <p:sldLayoutId xmlns:r="http://schemas.openxmlformats.org/officeDocument/2006/relationships" id="2147483649" r:id="R82be10d8fe5b4c0f"/>
+    <p:sldLayoutId xmlns:r="http://schemas.openxmlformats.org/officeDocument/2006/relationships" id="2147483649" r:id="Rfaa8e09e0e7245d2"/>
   </p:sldLayoutIdLst>
   <p:txStyles>
     <p:titleStyle>
@@ -2207,7 +2217,7 @@
           <p:cNvPr id="7" name="">
             <a:extLst xmlns:a="http://schemas.openxmlformats.org/drawingml/2006/main">
               <a:ext uri="{FF2B5EF4-FFF2-40B4-BE49-F238E27FC236}">
-                <a16:creationId xmlns:a16="http://schemas.microsoft.com/office/drawing/2014/main" id="{DF7F3771-E2AE-43F8-AE25-0A5E65908325}"/>
+                <a16:creationId xmlns:a16="http://schemas.microsoft.com/office/drawing/2014/main" id="{C74AF767-063B-4F71-A935-4BE24E367522}"/>
               </a:ext>
             </a:extLst>
           </p:cNvPr>
@@ -2257,7 +2267,7 @@
           <p:cNvPr id="2" name="">
             <a:extLst xmlns:a="http://schemas.openxmlformats.org/drawingml/2006/main">
               <a:ext uri="{FF2B5EF4-FFF2-40B4-BE49-F238E27FC236}">
-                <a16:creationId xmlns:a16="http://schemas.microsoft.com/office/drawing/2014/main" id="{CFFCAE7A-2715-40E7-AF2F-EAA654938B4C}"/>
+                <a16:creationId xmlns:a16="http://schemas.microsoft.com/office/drawing/2014/main" id="{6E31CCCD-59CD-4867-8DC9-AE039A075C23}"/>
               </a:ext>
             </a:extLst>
           </p:cNvPr>
@@ -2307,7 +2317,7 @@
           <p:cNvPr id="3" name="">
             <a:extLst xmlns:a="http://schemas.openxmlformats.org/drawingml/2006/main">
               <a:ext uri="{FF2B5EF4-FFF2-40B4-BE49-F238E27FC236}">
-                <a16:creationId xmlns:a16="http://schemas.microsoft.com/office/drawing/2014/main" id="{84FF81BE-D747-4F6D-8BEE-9B95AC8C25AF}"/>
+                <a16:creationId xmlns:a16="http://schemas.microsoft.com/office/drawing/2014/main" id="{6B9DBE47-225E-4FDE-84A1-DF97314EFF10}"/>
               </a:ext>
             </a:extLst>
           </p:cNvPr>
@@ -2357,7 +2367,7 @@
           <p:cNvPr id="4" name="">
             <a:extLst xmlns:a="http://schemas.openxmlformats.org/drawingml/2006/main">
               <a:ext uri="{FF2B5EF4-FFF2-40B4-BE49-F238E27FC236}">
-                <a16:creationId xmlns:a16="http://schemas.microsoft.com/office/drawing/2014/main" id="{0B0AE03E-9EA6-4EAC-A347-911E4756FB37}"/>
+                <a16:creationId xmlns:a16="http://schemas.microsoft.com/office/drawing/2014/main" id="{144360CE-0AEF-488B-90BD-58AF82E12978}"/>
               </a:ext>
             </a:extLst>
           </p:cNvPr>
@@ -2407,7 +2417,7 @@
           <p:cNvPr id="5" name="">
             <a:extLst xmlns:a="http://schemas.openxmlformats.org/drawingml/2006/main">
               <a:ext uri="{FF2B5EF4-FFF2-40B4-BE49-F238E27FC236}">
-                <a16:creationId xmlns:a16="http://schemas.microsoft.com/office/drawing/2014/main" id="{DA03EF0B-6441-4CF7-AD31-5D99F80DA247}"/>
+                <a16:creationId xmlns:a16="http://schemas.microsoft.com/office/drawing/2014/main" id="{DD50F8FD-B3B6-40FA-9489-B27778E7CFFC}"/>
               </a:ext>
             </a:extLst>
           </p:cNvPr>
@@ -2457,7 +2467,7 @@
           <p:cNvPr id="6" name="">
             <a:extLst xmlns:a="http://schemas.openxmlformats.org/drawingml/2006/main">
               <a:ext uri="{FF2B5EF4-FFF2-40B4-BE49-F238E27FC236}">
-                <a16:creationId xmlns:a16="http://schemas.microsoft.com/office/drawing/2014/main" id="{192D1A34-1110-4E24-98C8-B37CDFCFB492}"/>
+                <a16:creationId xmlns:a16="http://schemas.microsoft.com/office/drawing/2014/main" id="{B6E20067-4C4D-4A79-B153-F4B7F78C9152}"/>
               </a:ext>
             </a:extLst>
           </p:cNvPr>
@@ -2505,7 +2515,7 @@
     </p:spTree>
     <p:extLst>
       <p:ext uri="{BB962C8B-B14F-4D97-AF65-F5344CB8AC3E}">
-        <p14:creationId xmlns:p14="http://schemas.microsoft.com/office/powerpoint/2010/main" val="1356850582"/>
+        <p14:creationId xmlns:p14="http://schemas.microsoft.com/office/powerpoint/2010/main" val="1119737524"/>
       </p:ext>
     </p:extLst>
   </p:cSld>
@@ -2536,7 +2546,7 @@
           <p:cNvPr id="10" name="">
             <a:extLst xmlns:a="http://schemas.openxmlformats.org/drawingml/2006/main">
               <a:ext uri="{FF2B5EF4-FFF2-40B4-BE49-F238E27FC236}">
-                <a16:creationId xmlns:a16="http://schemas.microsoft.com/office/drawing/2014/main" id="{1364AA27-8E53-46DF-A575-856507B6072B}"/>
+                <a16:creationId xmlns:a16="http://schemas.microsoft.com/office/drawing/2014/main" id="{F59C3466-F714-43B2-858A-5DDE1AC2217F}"/>
               </a:ext>
             </a:extLst>
           </p:cNvPr>
@@ -2586,7 +2596,7 @@
           <p:cNvPr id="2" name="">
             <a:extLst xmlns:a="http://schemas.openxmlformats.org/drawingml/2006/main">
               <a:ext uri="{FF2B5EF4-FFF2-40B4-BE49-F238E27FC236}">
-                <a16:creationId xmlns:a16="http://schemas.microsoft.com/office/drawing/2014/main" id="{68147CF7-89F6-44B9-B16A-26EFB2EB1AEB}"/>
+                <a16:creationId xmlns:a16="http://schemas.microsoft.com/office/drawing/2014/main" id="{591AE283-7315-47A8-ABF9-7768EE82D848}"/>
               </a:ext>
             </a:extLst>
           </p:cNvPr>
@@ -2658,7 +2668,7 @@
           <p:cNvPr id="4" name="">
             <a:extLst xmlns:a="http://schemas.openxmlformats.org/drawingml/2006/main">
               <a:ext uri="{FF2B5EF4-FFF2-40B4-BE49-F238E27FC236}">
-                <a16:creationId xmlns:a16="http://schemas.microsoft.com/office/drawing/2014/main" id="{75979925-FD31-49AF-AC14-09969432A842}"/>
+                <a16:creationId xmlns:a16="http://schemas.microsoft.com/office/drawing/2014/main" id="{14BEECE4-97ED-495A-A8DB-ACAB4E6F5768}"/>
               </a:ext>
             </a:extLst>
           </p:cNvPr>
@@ -2708,42 +2718,42 @@
           <p:cNvPr id="5" name="">
             <a:extLst xmlns:a="http://schemas.openxmlformats.org/drawingml/2006/main">
               <a:ext uri="{FF2B5EF4-FFF2-40B4-BE49-F238E27FC236}">
-                <a16:creationId xmlns:a16="http://schemas.microsoft.com/office/drawing/2014/main" id="{C63D693D-B4E3-4972-AF92-FC27DF1F1FCB}"/>
-              </a:ext>
-            </a:extLst>
-          </p:cNvPr>
-          <p:cNvSpPr>
-            <a:spLocks xmlns:a="http://schemas.openxmlformats.org/drawingml/2006/main" noGrp="1"/>
-          </p:cNvSpPr>
-          <p:nvPr/>
-        </p:nvSpPr>
-        <p:spPr>
-          <a:xfrm xmlns:a="http://schemas.openxmlformats.org/drawingml/2006/main">
-            <a:off x="400050" y="4857750"/>
-            <a:ext cx="4000500" cy="1257300"/>
-          </a:xfrm>
-          <a:prstGeom xmlns:a="http://schemas.openxmlformats.org/drawingml/2006/main" prst="rect">
-            <a:avLst/>
-          </a:prstGeom>
-          <a:noFill xmlns:a="http://schemas.openxmlformats.org/drawingml/2006/main"/>
-          <a:ln xmlns:a="http://schemas.openxmlformats.org/drawingml/2006/main" w="0">
-            <a:noFill/>
-            <a:prstDash val="solid"/>
-          </a:ln>
-        </p:spPr>
-        <p:txBody>
-          <a:bodyPr xmlns:a="http://schemas.openxmlformats.org/drawingml/2006/main" anchor="t"/>
-          <a:lstStyle xmlns:a="http://schemas.openxmlformats.org/drawingml/2006/main"/>
-          <a:p xmlns:a="http://schemas.openxmlformats.org/drawingml/2006/main">
-            <a:pPr algn="l">
-              <a:defRPr sz="1725" b="0">
-                <a:solidFill>
-                  <a:srgbClr val="111111"/>
-                </a:solidFill>
-              </a:defRPr>
-            </a:pPr>
-            <a:r>
-              <a:rPr sz="1725" b="0">
+                <a16:creationId xmlns:a16="http://schemas.microsoft.com/office/drawing/2014/main" id="{FB8019CD-B837-43CF-8729-BF0FF31A2861}"/>
+              </a:ext>
+            </a:extLst>
+          </p:cNvPr>
+          <p:cNvSpPr>
+            <a:spLocks xmlns:a="http://schemas.openxmlformats.org/drawingml/2006/main" noGrp="1"/>
+          </p:cNvSpPr>
+          <p:nvPr/>
+        </p:nvSpPr>
+        <p:spPr>
+          <a:xfrm xmlns:a="http://schemas.openxmlformats.org/drawingml/2006/main">
+            <a:off x="400050" y="4819650"/>
+            <a:ext cx="4191000" cy="1352550"/>
+          </a:xfrm>
+          <a:prstGeom xmlns:a="http://schemas.openxmlformats.org/drawingml/2006/main" prst="rect">
+            <a:avLst/>
+          </a:prstGeom>
+          <a:noFill xmlns:a="http://schemas.openxmlformats.org/drawingml/2006/main"/>
+          <a:ln xmlns:a="http://schemas.openxmlformats.org/drawingml/2006/main" w="0">
+            <a:noFill/>
+            <a:prstDash val="solid"/>
+          </a:ln>
+        </p:spPr>
+        <p:txBody>
+          <a:bodyPr xmlns:a="http://schemas.openxmlformats.org/drawingml/2006/main" anchor="t"/>
+          <a:lstStyle xmlns:a="http://schemas.openxmlformats.org/drawingml/2006/main"/>
+          <a:p xmlns:a="http://schemas.openxmlformats.org/drawingml/2006/main">
+            <a:pPr algn="l">
+              <a:defRPr sz="1575" b="0">
+                <a:solidFill>
+                  <a:srgbClr val="111111"/>
+                </a:solidFill>
+              </a:defRPr>
+            </a:pPr>
+            <a:r>
+              <a:rPr sz="1575" b="0">
                 <a:solidFill>
                   <a:srgbClr val="111111"/>
                 </a:solidFill>
@@ -2753,53 +2763,70 @@
           </a:p>
           <a:p xmlns:a="http://schemas.openxmlformats.org/drawingml/2006/main">
             <a:pPr algn="l">
-              <a:defRPr sz="1725" b="0">
-                <a:solidFill>
-                  <a:srgbClr val="111111"/>
-                </a:solidFill>
-              </a:defRPr>
-            </a:pPr>
-            <a:r>
-              <a:rPr sz="1725" b="0">
-                <a:solidFill>
-                  <a:srgbClr val="111111"/>
-                </a:solidFill>
-              </a:rPr>
-              <a:t>Four-case policy test</a:t>
-            </a:r>
-          </a:p>
-          <a:p xmlns:a="http://schemas.openxmlformats.org/drawingml/2006/main">
-            <a:pPr algn="l">
-              <a:defRPr sz="1725" b="0">
-                <a:solidFill>
-                  <a:srgbClr val="111111"/>
-                </a:solidFill>
-              </a:defRPr>
-            </a:pPr>
-            <a:r>
-              <a:rPr sz="1725" b="0">
-                <a:solidFill>
-                  <a:srgbClr val="111111"/>
-                </a:solidFill>
-              </a:rPr>
-              <a:t>Time-based validation</a:t>
-            </a:r>
-          </a:p>
-          <a:p xmlns:a="http://schemas.openxmlformats.org/drawingml/2006/main">
-            <a:pPr algn="l">
-              <a:defRPr sz="1725" b="0">
-                <a:solidFill>
-                  <a:srgbClr val="111111"/>
-                </a:solidFill>
-              </a:defRPr>
-            </a:pPr>
-            <a:r>
-              <a:rPr sz="1725" b="0">
-                <a:solidFill>
-                  <a:srgbClr val="111111"/>
-                </a:solidFill>
-              </a:rPr>
-              <a:t>Reproducible CLI and tests</a:t>
+              <a:defRPr sz="1575" b="0">
+                <a:solidFill>
+                  <a:srgbClr val="111111"/>
+                </a:solidFill>
+              </a:defRPr>
+            </a:pPr>
+            <a:r>
+              <a:rPr sz="1575" b="0">
+                <a:solidFill>
+                  <a:srgbClr val="111111"/>
+                </a:solidFill>
+              </a:rPr>
+              <a:t>Calibrated review policy</a:t>
+            </a:r>
+          </a:p>
+          <a:p xmlns:a="http://schemas.openxmlformats.org/drawingml/2006/main">
+            <a:pPr algn="l">
+              <a:defRPr sz="1575" b="0">
+                <a:solidFill>
+                  <a:srgbClr val="111111"/>
+                </a:solidFill>
+              </a:defRPr>
+            </a:pPr>
+            <a:r>
+              <a:rPr sz="1575" b="0">
+                <a:solidFill>
+                  <a:srgbClr val="111111"/>
+                </a:solidFill>
+              </a:rPr>
+              <a:t>Hard-constraint search audit</a:t>
+            </a:r>
+          </a:p>
+          <a:p xmlns:a="http://schemas.openxmlformats.org/drawingml/2006/main">
+            <a:pPr algn="l">
+              <a:defRPr sz="1575" b="0">
+                <a:solidFill>
+                  <a:srgbClr val="111111"/>
+                </a:solidFill>
+              </a:defRPr>
+            </a:pPr>
+            <a:r>
+              <a:rPr sz="1575" b="0">
+                <a:solidFill>
+                  <a:srgbClr val="111111"/>
+                </a:solidFill>
+              </a:rPr>
+              <a:t>Batch CSV workflow</a:t>
+            </a:r>
+          </a:p>
+          <a:p xmlns:a="http://schemas.openxmlformats.org/drawingml/2006/main">
+            <a:pPr algn="l">
+              <a:defRPr sz="1575" b="0">
+                <a:solidFill>
+                  <a:srgbClr val="111111"/>
+                </a:solidFill>
+              </a:defRPr>
+            </a:pPr>
+            <a:r>
+              <a:rPr sz="1575" b="0">
+                <a:solidFill>
+                  <a:srgbClr val="111111"/>
+                </a:solidFill>
+              </a:rPr>
+              <a:t>Reproducible tests</a:t>
             </a:r>
           </a:p>
         </p:txBody>
@@ -2809,7 +2836,7 @@
           <p:cNvPr id="6" name="">
             <a:extLst xmlns:a="http://schemas.openxmlformats.org/drawingml/2006/main">
               <a:ext uri="{FF2B5EF4-FFF2-40B4-BE49-F238E27FC236}">
-                <a16:creationId xmlns:a16="http://schemas.microsoft.com/office/drawing/2014/main" id="{D41FFFD6-9989-476A-8097-888CAB7534ED}"/>
+                <a16:creationId xmlns:a16="http://schemas.microsoft.com/office/drawing/2014/main" id="{C0075C76-1116-45FA-A308-E2EED8718507}"/>
               </a:ext>
             </a:extLst>
           </p:cNvPr>
@@ -2840,7 +2867,7 @@
           <p:cNvPr id="7" name="">
             <a:extLst xmlns:a="http://schemas.openxmlformats.org/drawingml/2006/main">
               <a:ext uri="{FF2B5EF4-FFF2-40B4-BE49-F238E27FC236}">
-                <a16:creationId xmlns:a16="http://schemas.microsoft.com/office/drawing/2014/main" id="{7C566042-C472-421A-B7FF-615E831F82D9}"/>
+                <a16:creationId xmlns:a16="http://schemas.microsoft.com/office/drawing/2014/main" id="{5833EE7B-2A86-4D1A-923E-86460689C119}"/>
               </a:ext>
             </a:extLst>
           </p:cNvPr>
@@ -2890,7 +2917,7 @@
           <p:cNvPr id="8" name="">
             <a:extLst xmlns:a="http://schemas.openxmlformats.org/drawingml/2006/main">
               <a:ext uri="{FF2B5EF4-FFF2-40B4-BE49-F238E27FC236}">
-                <a16:creationId xmlns:a16="http://schemas.microsoft.com/office/drawing/2014/main" id="{3E7703DF-D4A8-4B3C-8236-EC6618834F61}"/>
+                <a16:creationId xmlns:a16="http://schemas.microsoft.com/office/drawing/2014/main" id="{E4C76866-EA9A-4742-8741-2166DE9F0200}"/>
               </a:ext>
             </a:extLst>
           </p:cNvPr>
@@ -2974,7 +3001,7 @@
           <p:cNvPr id="9" name="">
             <a:extLst xmlns:a="http://schemas.openxmlformats.org/drawingml/2006/main">
               <a:ext uri="{FF2B5EF4-FFF2-40B4-BE49-F238E27FC236}">
-                <a16:creationId xmlns:a16="http://schemas.microsoft.com/office/drawing/2014/main" id="{C931831C-7C3F-4C17-AA9F-39FB544B57FD}"/>
+                <a16:creationId xmlns:a16="http://schemas.microsoft.com/office/drawing/2014/main" id="{222C8EF5-F1E5-48A9-B636-7BFB55271F72}"/>
               </a:ext>
             </a:extLst>
           </p:cNvPr>
@@ -3022,7 +3049,7 @@
     </p:spTree>
     <p:extLst>
       <p:ext uri="{BB962C8B-B14F-4D97-AF65-F5344CB8AC3E}">
-        <p14:creationId xmlns:p14="http://schemas.microsoft.com/office/powerpoint/2010/main" val="1516593785"/>
+        <p14:creationId xmlns:p14="http://schemas.microsoft.com/office/powerpoint/2010/main" val="1184406307"/>
       </p:ext>
     </p:extLst>
   </p:cSld>
@@ -3053,7 +3080,7 @@
           <p:cNvPr id="14" name="slide-2-title">
             <a:extLst xmlns:a="http://schemas.openxmlformats.org/drawingml/2006/main">
               <a:ext uri="{FF2B5EF4-FFF2-40B4-BE49-F238E27FC236}">
-                <a16:creationId xmlns:a16="http://schemas.microsoft.com/office/drawing/2014/main" id="{342538E1-E710-4248-9BE4-EFF00ECD8042}"/>
+                <a16:creationId xmlns:a16="http://schemas.microsoft.com/office/drawing/2014/main" id="{4741AE42-0A67-41AB-BDA7-12014DEB4338}"/>
               </a:ext>
             </a:extLst>
           </p:cNvPr>
@@ -3103,7 +3130,7 @@
           <p:cNvPr id="2" name="">
             <a:extLst xmlns:a="http://schemas.openxmlformats.org/drawingml/2006/main">
               <a:ext uri="{FF2B5EF4-FFF2-40B4-BE49-F238E27FC236}">
-                <a16:creationId xmlns:a16="http://schemas.microsoft.com/office/drawing/2014/main" id="{931293F2-9318-4CC4-81E0-ABBD41EAE563}"/>
+                <a16:creationId xmlns:a16="http://schemas.microsoft.com/office/drawing/2014/main" id="{05F25582-9784-464B-A4D8-4B9E32B31F0D}"/>
               </a:ext>
             </a:extLst>
           </p:cNvPr>
@@ -3153,7 +3180,7 @@
           <p:cNvPr id="3" name="">
             <a:extLst xmlns:a="http://schemas.openxmlformats.org/drawingml/2006/main">
               <a:ext uri="{FF2B5EF4-FFF2-40B4-BE49-F238E27FC236}">
-                <a16:creationId xmlns:a16="http://schemas.microsoft.com/office/drawing/2014/main" id="{36A6257D-F8FB-4CE0-A195-3AA1F4E4C3D0}"/>
+                <a16:creationId xmlns:a16="http://schemas.microsoft.com/office/drawing/2014/main" id="{6C8EAFC3-90B0-4932-AE5F-C258D3E4B916}"/>
               </a:ext>
             </a:extLst>
           </p:cNvPr>
@@ -3225,7 +3252,7 @@
           <p:cNvPr id="5" name="">
             <a:extLst xmlns:a="http://schemas.openxmlformats.org/drawingml/2006/main">
               <a:ext uri="{FF2B5EF4-FFF2-40B4-BE49-F238E27FC236}">
-                <a16:creationId xmlns:a16="http://schemas.microsoft.com/office/drawing/2014/main" id="{22841BDD-A752-4E25-AE89-3FAF80C986A8}"/>
+                <a16:creationId xmlns:a16="http://schemas.microsoft.com/office/drawing/2014/main" id="{C1CEAE46-D66D-4E35-814C-716E4583D113}"/>
               </a:ext>
             </a:extLst>
           </p:cNvPr>
@@ -3275,7 +3302,7 @@
           <p:cNvPr id="6" name="">
             <a:extLst xmlns:a="http://schemas.openxmlformats.org/drawingml/2006/main">
               <a:ext uri="{FF2B5EF4-FFF2-40B4-BE49-F238E27FC236}">
-                <a16:creationId xmlns:a16="http://schemas.microsoft.com/office/drawing/2014/main" id="{38C3CB68-EA62-447C-9278-2E0A1B939693}"/>
+                <a16:creationId xmlns:a16="http://schemas.microsoft.com/office/drawing/2014/main" id="{B7FE9136-5BE8-41F4-9E5D-3752DAA31994}"/>
               </a:ext>
             </a:extLst>
           </p:cNvPr>
@@ -3347,7 +3374,7 @@
           <p:cNvPr id="8" name="">
             <a:extLst xmlns:a="http://schemas.openxmlformats.org/drawingml/2006/main">
               <a:ext uri="{FF2B5EF4-FFF2-40B4-BE49-F238E27FC236}">
-                <a16:creationId xmlns:a16="http://schemas.microsoft.com/office/drawing/2014/main" id="{97E977B7-8ABF-48DC-98F2-3722A6D13DF3}"/>
+                <a16:creationId xmlns:a16="http://schemas.microsoft.com/office/drawing/2014/main" id="{98EC720A-6232-4A46-9216-1E331DD6B12A}"/>
               </a:ext>
             </a:extLst>
           </p:cNvPr>
@@ -3397,7 +3424,7 @@
           <p:cNvPr id="9" name="">
             <a:extLst xmlns:a="http://schemas.openxmlformats.org/drawingml/2006/main">
               <a:ext uri="{FF2B5EF4-FFF2-40B4-BE49-F238E27FC236}">
-                <a16:creationId xmlns:a16="http://schemas.microsoft.com/office/drawing/2014/main" id="{7B89AC05-8981-44CE-9C88-DDF5016302BB}"/>
+                <a16:creationId xmlns:a16="http://schemas.microsoft.com/office/drawing/2014/main" id="{80AE9DD5-FA98-4194-B6FE-F71CD9930F64}"/>
               </a:ext>
             </a:extLst>
           </p:cNvPr>
@@ -3469,7 +3496,7 @@
           <p:cNvPr id="11" name="">
             <a:extLst xmlns:a="http://schemas.openxmlformats.org/drawingml/2006/main">
               <a:ext uri="{FF2B5EF4-FFF2-40B4-BE49-F238E27FC236}">
-                <a16:creationId xmlns:a16="http://schemas.microsoft.com/office/drawing/2014/main" id="{0A537EA0-6690-4DFC-AF41-945DA1E8832C}"/>
+                <a16:creationId xmlns:a16="http://schemas.microsoft.com/office/drawing/2014/main" id="{0A045AA5-A0BF-4D7D-9C78-724A151CE7B6}"/>
               </a:ext>
             </a:extLst>
           </p:cNvPr>
@@ -3519,7 +3546,7 @@
           <p:cNvPr id="12" name="">
             <a:extLst xmlns:a="http://schemas.openxmlformats.org/drawingml/2006/main">
               <a:ext uri="{FF2B5EF4-FFF2-40B4-BE49-F238E27FC236}">
-                <a16:creationId xmlns:a16="http://schemas.microsoft.com/office/drawing/2014/main" id="{2D7B6EBD-1662-4117-B108-4413EB07B109}"/>
+                <a16:creationId xmlns:a16="http://schemas.microsoft.com/office/drawing/2014/main" id="{85E63425-3D2A-4D1E-97F4-860CCCECCDF2}"/>
               </a:ext>
             </a:extLst>
           </p:cNvPr>
@@ -3569,7 +3596,7 @@
           <p:cNvPr id="13" name="">
             <a:extLst xmlns:a="http://schemas.openxmlformats.org/drawingml/2006/main">
               <a:ext uri="{FF2B5EF4-FFF2-40B4-BE49-F238E27FC236}">
-                <a16:creationId xmlns:a16="http://schemas.microsoft.com/office/drawing/2014/main" id="{53AAB008-F987-4C61-8765-3096D0F91638}"/>
+                <a16:creationId xmlns:a16="http://schemas.microsoft.com/office/drawing/2014/main" id="{3547E27F-12D7-46C9-A11F-0E4902CEC493}"/>
               </a:ext>
             </a:extLst>
           </p:cNvPr>
@@ -3617,7 +3644,7 @@
     </p:spTree>
     <p:extLst>
       <p:ext uri="{BB962C8B-B14F-4D97-AF65-F5344CB8AC3E}">
-        <p14:creationId xmlns:p14="http://schemas.microsoft.com/office/powerpoint/2010/main" val="1215480482"/>
+        <p14:creationId xmlns:p14="http://schemas.microsoft.com/office/powerpoint/2010/main" val="1208413093"/>
       </p:ext>
     </p:extLst>
   </p:cSld>
@@ -3648,7 +3675,7 @@
           <p:cNvPr id="16" name="slide-3-title">
             <a:extLst xmlns:a="http://schemas.openxmlformats.org/drawingml/2006/main">
               <a:ext uri="{FF2B5EF4-FFF2-40B4-BE49-F238E27FC236}">
-                <a16:creationId xmlns:a16="http://schemas.microsoft.com/office/drawing/2014/main" id="{3973916A-4760-4A3C-B59B-A672B738824A}"/>
+                <a16:creationId xmlns:a16="http://schemas.microsoft.com/office/drawing/2014/main" id="{CCE866CE-4589-4261-B144-6099931049FC}"/>
               </a:ext>
             </a:extLst>
           </p:cNvPr>
@@ -3698,7 +3725,7 @@
           <p:cNvPr id="2" name="">
             <a:extLst xmlns:a="http://schemas.openxmlformats.org/drawingml/2006/main">
               <a:ext uri="{FF2B5EF4-FFF2-40B4-BE49-F238E27FC236}">
-                <a16:creationId xmlns:a16="http://schemas.microsoft.com/office/drawing/2014/main" id="{04FD5848-0B33-41B1-9413-739A1B4808DE}"/>
+                <a16:creationId xmlns:a16="http://schemas.microsoft.com/office/drawing/2014/main" id="{98FB4678-CA49-4711-AD68-D95BB5C334E9}"/>
               </a:ext>
             </a:extLst>
           </p:cNvPr>
@@ -3748,7 +3775,7 @@
           <p:cNvPr id="3" name="">
             <a:extLst xmlns:a="http://schemas.openxmlformats.org/drawingml/2006/main">
               <a:ext uri="{FF2B5EF4-FFF2-40B4-BE49-F238E27FC236}">
-                <a16:creationId xmlns:a16="http://schemas.microsoft.com/office/drawing/2014/main" id="{89060F2C-B8FA-40E4-8B5C-47378712B494}"/>
+                <a16:creationId xmlns:a16="http://schemas.microsoft.com/office/drawing/2014/main" id="{3C3C0B28-EED5-43B0-8257-35441463DC04}"/>
               </a:ext>
             </a:extLst>
           </p:cNvPr>
@@ -3798,7 +3825,7 @@
           <p:cNvPr id="4" name="">
             <a:extLst xmlns:a="http://schemas.openxmlformats.org/drawingml/2006/main">
               <a:ext uri="{FF2B5EF4-FFF2-40B4-BE49-F238E27FC236}">
-                <a16:creationId xmlns:a16="http://schemas.microsoft.com/office/drawing/2014/main" id="{1C6B55ED-1215-4052-86E9-EBB52306C774}"/>
+                <a16:creationId xmlns:a16="http://schemas.microsoft.com/office/drawing/2014/main" id="{E0E12257-3B91-49FC-B51C-DD0BE058B00D}"/>
               </a:ext>
             </a:extLst>
           </p:cNvPr>
@@ -3829,7 +3856,7 @@
           <p:cNvPr id="5" name="">
             <a:extLst xmlns:a="http://schemas.openxmlformats.org/drawingml/2006/main">
               <a:ext uri="{FF2B5EF4-FFF2-40B4-BE49-F238E27FC236}">
-                <a16:creationId xmlns:a16="http://schemas.microsoft.com/office/drawing/2014/main" id="{FD18D5FB-DCB9-4689-B237-2D7806943BFF}"/>
+                <a16:creationId xmlns:a16="http://schemas.microsoft.com/office/drawing/2014/main" id="{9BFD2D71-7C04-45CA-8B8F-4BB0C6A509F4}"/>
               </a:ext>
             </a:extLst>
           </p:cNvPr>
@@ -3879,7 +3906,7 @@
           <p:cNvPr id="6" name="">
             <a:extLst xmlns:a="http://schemas.openxmlformats.org/drawingml/2006/main">
               <a:ext uri="{FF2B5EF4-FFF2-40B4-BE49-F238E27FC236}">
-                <a16:creationId xmlns:a16="http://schemas.microsoft.com/office/drawing/2014/main" id="{EAE2BE20-6634-4954-85E3-73E8D9776997}"/>
+                <a16:creationId xmlns:a16="http://schemas.microsoft.com/office/drawing/2014/main" id="{A67E91C6-C334-4158-980A-3FAB320BF8B1}"/>
               </a:ext>
             </a:extLst>
           </p:cNvPr>
@@ -3929,7 +3956,7 @@
           <p:cNvPr id="7" name="">
             <a:extLst xmlns:a="http://schemas.openxmlformats.org/drawingml/2006/main">
               <a:ext uri="{FF2B5EF4-FFF2-40B4-BE49-F238E27FC236}">
-                <a16:creationId xmlns:a16="http://schemas.microsoft.com/office/drawing/2014/main" id="{13D7E8FA-5A58-4119-A9F3-E6C91CBDEAEF}"/>
+                <a16:creationId xmlns:a16="http://schemas.microsoft.com/office/drawing/2014/main" id="{08EA9361-C9A3-4363-B521-93AE93B968DE}"/>
               </a:ext>
             </a:extLst>
           </p:cNvPr>
@@ -3960,7 +3987,7 @@
           <p:cNvPr id="8" name="">
             <a:extLst xmlns:a="http://schemas.openxmlformats.org/drawingml/2006/main">
               <a:ext uri="{FF2B5EF4-FFF2-40B4-BE49-F238E27FC236}">
-                <a16:creationId xmlns:a16="http://schemas.microsoft.com/office/drawing/2014/main" id="{5686651F-3CD6-444D-BBA5-633EAF8C3F24}"/>
+                <a16:creationId xmlns:a16="http://schemas.microsoft.com/office/drawing/2014/main" id="{71D1EFEE-911E-4047-B6A1-22946A949451}"/>
               </a:ext>
             </a:extLst>
           </p:cNvPr>
@@ -4010,7 +4037,7 @@
           <p:cNvPr id="9" name="">
             <a:extLst xmlns:a="http://schemas.openxmlformats.org/drawingml/2006/main">
               <a:ext uri="{FF2B5EF4-FFF2-40B4-BE49-F238E27FC236}">
-                <a16:creationId xmlns:a16="http://schemas.microsoft.com/office/drawing/2014/main" id="{5D51FCB2-6289-47DD-991E-21C917B94632}"/>
+                <a16:creationId xmlns:a16="http://schemas.microsoft.com/office/drawing/2014/main" id="{DC317857-5520-4EA3-8034-30E610F4D015}"/>
               </a:ext>
             </a:extLst>
           </p:cNvPr>
@@ -4060,7 +4087,7 @@
           <p:cNvPr id="10" name="">
             <a:extLst xmlns:a="http://schemas.openxmlformats.org/drawingml/2006/main">
               <a:ext uri="{FF2B5EF4-FFF2-40B4-BE49-F238E27FC236}">
-                <a16:creationId xmlns:a16="http://schemas.microsoft.com/office/drawing/2014/main" id="{83148ACF-CCB4-4E1F-B657-51866B1BFFC4}"/>
+                <a16:creationId xmlns:a16="http://schemas.microsoft.com/office/drawing/2014/main" id="{B63C4A48-43A8-4B48-BEBE-9E4225DE6E47}"/>
               </a:ext>
             </a:extLst>
           </p:cNvPr>
@@ -4091,7 +4118,7 @@
           <p:cNvPr id="11" name="">
             <a:extLst xmlns:a="http://schemas.openxmlformats.org/drawingml/2006/main">
               <a:ext uri="{FF2B5EF4-FFF2-40B4-BE49-F238E27FC236}">
-                <a16:creationId xmlns:a16="http://schemas.microsoft.com/office/drawing/2014/main" id="{A4F36C86-FC91-400F-967C-20953B98F72C}"/>
+                <a16:creationId xmlns:a16="http://schemas.microsoft.com/office/drawing/2014/main" id="{06558D96-D4AF-4038-998E-90AD7E6DAB63}"/>
               </a:ext>
             </a:extLst>
           </p:cNvPr>
@@ -4141,7 +4168,7 @@
           <p:cNvPr id="12" name="">
             <a:extLst xmlns:a="http://schemas.openxmlformats.org/drawingml/2006/main">
               <a:ext uri="{FF2B5EF4-FFF2-40B4-BE49-F238E27FC236}">
-                <a16:creationId xmlns:a16="http://schemas.microsoft.com/office/drawing/2014/main" id="{567F1817-F65C-48CD-BCC0-DA161AA5F046}"/>
+                <a16:creationId xmlns:a16="http://schemas.microsoft.com/office/drawing/2014/main" id="{A0A3472C-6DCA-4BFA-99AA-507B2A24315F}"/>
               </a:ext>
             </a:extLst>
           </p:cNvPr>
@@ -4191,7 +4218,7 @@
           <p:cNvPr id="13" name="">
             <a:extLst xmlns:a="http://schemas.openxmlformats.org/drawingml/2006/main">
               <a:ext uri="{FF2B5EF4-FFF2-40B4-BE49-F238E27FC236}">
-                <a16:creationId xmlns:a16="http://schemas.microsoft.com/office/drawing/2014/main" id="{392C1B87-E55F-4F63-918E-49BACDCA3EB8}"/>
+                <a16:creationId xmlns:a16="http://schemas.microsoft.com/office/drawing/2014/main" id="{15C51943-6B6E-4CBA-8BFE-A34502806FEF}"/>
               </a:ext>
             </a:extLst>
           </p:cNvPr>
@@ -4222,7 +4249,7 @@
           <p:cNvPr id="14" name="">
             <a:extLst xmlns:a="http://schemas.openxmlformats.org/drawingml/2006/main">
               <a:ext uri="{FF2B5EF4-FFF2-40B4-BE49-F238E27FC236}">
-                <a16:creationId xmlns:a16="http://schemas.microsoft.com/office/drawing/2014/main" id="{46B8C685-2359-4F3B-9913-685C5C211C95}"/>
+                <a16:creationId xmlns:a16="http://schemas.microsoft.com/office/drawing/2014/main" id="{A91608A6-6867-4DCE-900B-802E41400045}"/>
               </a:ext>
             </a:extLst>
           </p:cNvPr>
@@ -4272,7 +4299,7 @@
           <p:cNvPr id="15" name="">
             <a:extLst xmlns:a="http://schemas.openxmlformats.org/drawingml/2006/main">
               <a:ext uri="{FF2B5EF4-FFF2-40B4-BE49-F238E27FC236}">
-                <a16:creationId xmlns:a16="http://schemas.microsoft.com/office/drawing/2014/main" id="{79D11DF0-F4BD-4D5F-BA88-477B1A433E4A}"/>
+                <a16:creationId xmlns:a16="http://schemas.microsoft.com/office/drawing/2014/main" id="{FB54C5E4-3907-4AE8-AEF9-7D498F45A80B}"/>
               </a:ext>
             </a:extLst>
           </p:cNvPr>
@@ -4320,7 +4347,7 @@
     </p:spTree>
     <p:extLst>
       <p:ext uri="{BB962C8B-B14F-4D97-AF65-F5344CB8AC3E}">
-        <p14:creationId xmlns:p14="http://schemas.microsoft.com/office/powerpoint/2010/main" val="1926338260"/>
+        <p14:creationId xmlns:p14="http://schemas.microsoft.com/office/powerpoint/2010/main" val="356563007"/>
       </p:ext>
     </p:extLst>
   </p:cSld>
@@ -4351,7 +4378,7 @@
           <p:cNvPr id="20" name="slide-4-title">
             <a:extLst xmlns:a="http://schemas.openxmlformats.org/drawingml/2006/main">
               <a:ext uri="{FF2B5EF4-FFF2-40B4-BE49-F238E27FC236}">
-                <a16:creationId xmlns:a16="http://schemas.microsoft.com/office/drawing/2014/main" id="{9C23E98A-7FE3-407D-868D-26B1297AB9E0}"/>
+                <a16:creationId xmlns:a16="http://schemas.microsoft.com/office/drawing/2014/main" id="{1414264C-70E0-4614-9495-0D4F2525711C}"/>
               </a:ext>
             </a:extLst>
           </p:cNvPr>
@@ -4401,7 +4428,7 @@
           <p:cNvPr id="2" name="">
             <a:extLst xmlns:a="http://schemas.openxmlformats.org/drawingml/2006/main">
               <a:ext uri="{FF2B5EF4-FFF2-40B4-BE49-F238E27FC236}">
-                <a16:creationId xmlns:a16="http://schemas.microsoft.com/office/drawing/2014/main" id="{F44377BA-E90A-4FBA-A532-9627C83C5ADC}"/>
+                <a16:creationId xmlns:a16="http://schemas.microsoft.com/office/drawing/2014/main" id="{22DA86AE-92D8-40FF-A9AA-D8BD45E41423}"/>
               </a:ext>
             </a:extLst>
           </p:cNvPr>
@@ -4473,7 +4500,7 @@
           <p:cNvPr id="4" name="">
             <a:extLst xmlns:a="http://schemas.openxmlformats.org/drawingml/2006/main">
               <a:ext uri="{FF2B5EF4-FFF2-40B4-BE49-F238E27FC236}">
-                <a16:creationId xmlns:a16="http://schemas.microsoft.com/office/drawing/2014/main" id="{86EEA94D-6FC9-469C-9EDA-0AC37B89EFBB}"/>
+                <a16:creationId xmlns:a16="http://schemas.microsoft.com/office/drawing/2014/main" id="{FA807DEC-2D59-4144-B0CC-7633F2B2BFBC}"/>
               </a:ext>
             </a:extLst>
           </p:cNvPr>
@@ -4504,7 +4531,7 @@
           <p:cNvPr id="5" name="">
             <a:extLst xmlns:a="http://schemas.openxmlformats.org/drawingml/2006/main">
               <a:ext uri="{FF2B5EF4-FFF2-40B4-BE49-F238E27FC236}">
-                <a16:creationId xmlns:a16="http://schemas.microsoft.com/office/drawing/2014/main" id="{660124AB-3A9B-4CA8-8807-49AD394FFC1F}"/>
+                <a16:creationId xmlns:a16="http://schemas.microsoft.com/office/drawing/2014/main" id="{50323FF3-C5A8-47E9-8D1A-67FBA080736B}"/>
               </a:ext>
             </a:extLst>
           </p:cNvPr>
@@ -4554,7 +4581,7 @@
           <p:cNvPr id="6" name="">
             <a:extLst xmlns:a="http://schemas.openxmlformats.org/drawingml/2006/main">
               <a:ext uri="{FF2B5EF4-FFF2-40B4-BE49-F238E27FC236}">
-                <a16:creationId xmlns:a16="http://schemas.microsoft.com/office/drawing/2014/main" id="{6B183ED7-734A-4224-BC89-27FFB6D1D645}"/>
+                <a16:creationId xmlns:a16="http://schemas.microsoft.com/office/drawing/2014/main" id="{6E928A23-1146-4CD9-9A5F-AFE5F085842E}"/>
               </a:ext>
             </a:extLst>
           </p:cNvPr>
@@ -4604,7 +4631,7 @@
           <p:cNvPr id="7" name="">
             <a:extLst xmlns:a="http://schemas.openxmlformats.org/drawingml/2006/main">
               <a:ext uri="{FF2B5EF4-FFF2-40B4-BE49-F238E27FC236}">
-                <a16:creationId xmlns:a16="http://schemas.microsoft.com/office/drawing/2014/main" id="{E874DD9B-FADA-410A-9A2F-4B6FCE11C786}"/>
+                <a16:creationId xmlns:a16="http://schemas.microsoft.com/office/drawing/2014/main" id="{A31C7143-FCAB-4149-8B85-021D1BEEF151}"/>
               </a:ext>
             </a:extLst>
           </p:cNvPr>
@@ -4671,7 +4698,7 @@
           <p:cNvPr id="8" name="">
             <a:extLst xmlns:a="http://schemas.openxmlformats.org/drawingml/2006/main">
               <a:ext uri="{FF2B5EF4-FFF2-40B4-BE49-F238E27FC236}">
-                <a16:creationId xmlns:a16="http://schemas.microsoft.com/office/drawing/2014/main" id="{F1F5F86E-48C9-4F10-839D-B0E4C889E42F}"/>
+                <a16:creationId xmlns:a16="http://schemas.microsoft.com/office/drawing/2014/main" id="{C451DD46-F9AD-428C-9856-BF9FAAB26882}"/>
               </a:ext>
             </a:extLst>
           </p:cNvPr>
@@ -4702,7 +4729,7 @@
           <p:cNvPr id="9" name="">
             <a:extLst xmlns:a="http://schemas.openxmlformats.org/drawingml/2006/main">
               <a:ext uri="{FF2B5EF4-FFF2-40B4-BE49-F238E27FC236}">
-                <a16:creationId xmlns:a16="http://schemas.microsoft.com/office/drawing/2014/main" id="{1556722A-F52E-4544-BC4D-49B376D85BF5}"/>
+                <a16:creationId xmlns:a16="http://schemas.microsoft.com/office/drawing/2014/main" id="{9A13A7E5-FE99-4251-9DE2-FA159AD5495E}"/>
               </a:ext>
             </a:extLst>
           </p:cNvPr>
@@ -4752,7 +4779,7 @@
           <p:cNvPr id="10" name="">
             <a:extLst xmlns:a="http://schemas.openxmlformats.org/drawingml/2006/main">
               <a:ext uri="{FF2B5EF4-FFF2-40B4-BE49-F238E27FC236}">
-                <a16:creationId xmlns:a16="http://schemas.microsoft.com/office/drawing/2014/main" id="{E8EAA3C8-15FC-4349-BFB8-A9236149031C}"/>
+                <a16:creationId xmlns:a16="http://schemas.microsoft.com/office/drawing/2014/main" id="{0696DEA4-4EEE-401D-B622-BEC56221FB17}"/>
               </a:ext>
             </a:extLst>
           </p:cNvPr>
@@ -4802,7 +4829,7 @@
           <p:cNvPr id="11" name="">
             <a:extLst xmlns:a="http://schemas.openxmlformats.org/drawingml/2006/main">
               <a:ext uri="{FF2B5EF4-FFF2-40B4-BE49-F238E27FC236}">
-                <a16:creationId xmlns:a16="http://schemas.microsoft.com/office/drawing/2014/main" id="{AF6619BB-5AE6-423F-AC9E-57456E9F457B}"/>
+                <a16:creationId xmlns:a16="http://schemas.microsoft.com/office/drawing/2014/main" id="{47B23702-34B2-475E-A85D-5F080B9EFA16}"/>
               </a:ext>
             </a:extLst>
           </p:cNvPr>
@@ -4869,7 +4896,7 @@
           <p:cNvPr id="12" name="">
             <a:extLst xmlns:a="http://schemas.openxmlformats.org/drawingml/2006/main">
               <a:ext uri="{FF2B5EF4-FFF2-40B4-BE49-F238E27FC236}">
-                <a16:creationId xmlns:a16="http://schemas.microsoft.com/office/drawing/2014/main" id="{3AEE3207-5E75-4F30-9451-DDB35F0557BD}"/>
+                <a16:creationId xmlns:a16="http://schemas.microsoft.com/office/drawing/2014/main" id="{D89671B3-3A4C-40E8-8662-601D9364344E}"/>
               </a:ext>
             </a:extLst>
           </p:cNvPr>
@@ -4900,7 +4927,7 @@
           <p:cNvPr id="13" name="">
             <a:extLst xmlns:a="http://schemas.openxmlformats.org/drawingml/2006/main">
               <a:ext uri="{FF2B5EF4-FFF2-40B4-BE49-F238E27FC236}">
-                <a16:creationId xmlns:a16="http://schemas.microsoft.com/office/drawing/2014/main" id="{E15AA02E-CE2C-446D-BEE2-6057D2118CB1}"/>
+                <a16:creationId xmlns:a16="http://schemas.microsoft.com/office/drawing/2014/main" id="{58ED9FE2-C2F2-4642-A2F4-69DA876FA2D7}"/>
               </a:ext>
             </a:extLst>
           </p:cNvPr>
@@ -4950,7 +4977,7 @@
           <p:cNvPr id="14" name="">
             <a:extLst xmlns:a="http://schemas.openxmlformats.org/drawingml/2006/main">
               <a:ext uri="{FF2B5EF4-FFF2-40B4-BE49-F238E27FC236}">
-                <a16:creationId xmlns:a16="http://schemas.microsoft.com/office/drawing/2014/main" id="{87BD2476-FD38-4E76-9101-98A634505F48}"/>
+                <a16:creationId xmlns:a16="http://schemas.microsoft.com/office/drawing/2014/main" id="{ACF17563-B155-46DC-BF17-2101995F3576}"/>
               </a:ext>
             </a:extLst>
           </p:cNvPr>
@@ -5000,7 +5027,7 @@
           <p:cNvPr id="15" name="">
             <a:extLst xmlns:a="http://schemas.openxmlformats.org/drawingml/2006/main">
               <a:ext uri="{FF2B5EF4-FFF2-40B4-BE49-F238E27FC236}">
-                <a16:creationId xmlns:a16="http://schemas.microsoft.com/office/drawing/2014/main" id="{2D44F042-D4ED-4480-9B69-23479A932034}"/>
+                <a16:creationId xmlns:a16="http://schemas.microsoft.com/office/drawing/2014/main" id="{C7B59350-7012-42C0-A67A-89EAA1B932AA}"/>
               </a:ext>
             </a:extLst>
           </p:cNvPr>
@@ -5067,7 +5094,7 @@
           <p:cNvPr id="16" name="">
             <a:extLst xmlns:a="http://schemas.openxmlformats.org/drawingml/2006/main">
               <a:ext uri="{FF2B5EF4-FFF2-40B4-BE49-F238E27FC236}">
-                <a16:creationId xmlns:a16="http://schemas.microsoft.com/office/drawing/2014/main" id="{9BB58A73-478D-4AC4-BFD3-732A8E0E1E05}"/>
+                <a16:creationId xmlns:a16="http://schemas.microsoft.com/office/drawing/2014/main" id="{7463D61B-23B2-462B-A329-9B1C62B01DD7}"/>
               </a:ext>
             </a:extLst>
           </p:cNvPr>
@@ -5098,7 +5125,7 @@
           <p:cNvPr id="17" name="">
             <a:extLst xmlns:a="http://schemas.openxmlformats.org/drawingml/2006/main">
               <a:ext uri="{FF2B5EF4-FFF2-40B4-BE49-F238E27FC236}">
-                <a16:creationId xmlns:a16="http://schemas.microsoft.com/office/drawing/2014/main" id="{AD1363A0-9D43-48C6-9388-E594FA09FCAF}"/>
+                <a16:creationId xmlns:a16="http://schemas.microsoft.com/office/drawing/2014/main" id="{00A50900-2ED4-4346-892D-B5A3C0125727}"/>
               </a:ext>
             </a:extLst>
           </p:cNvPr>
@@ -5148,7 +5175,7 @@
           <p:cNvPr id="18" name="">
             <a:extLst xmlns:a="http://schemas.openxmlformats.org/drawingml/2006/main">
               <a:ext uri="{FF2B5EF4-FFF2-40B4-BE49-F238E27FC236}">
-                <a16:creationId xmlns:a16="http://schemas.microsoft.com/office/drawing/2014/main" id="{01769763-5DE7-46BB-83CF-B74805B4E31A}"/>
+                <a16:creationId xmlns:a16="http://schemas.microsoft.com/office/drawing/2014/main" id="{241D1A86-3329-49F2-BF26-B678D71AEFA7}"/>
               </a:ext>
             </a:extLst>
           </p:cNvPr>
@@ -5198,7 +5225,7 @@
           <p:cNvPr id="19" name="">
             <a:extLst xmlns:a="http://schemas.openxmlformats.org/drawingml/2006/main">
               <a:ext uri="{FF2B5EF4-FFF2-40B4-BE49-F238E27FC236}">
-                <a16:creationId xmlns:a16="http://schemas.microsoft.com/office/drawing/2014/main" id="{D1327727-F2D3-492A-A8B4-8DD28F97BECF}"/>
+                <a16:creationId xmlns:a16="http://schemas.microsoft.com/office/drawing/2014/main" id="{D1A5177E-985B-48AA-B2B1-CD4BAF4C3A04}"/>
               </a:ext>
             </a:extLst>
           </p:cNvPr>
@@ -5263,7 +5290,7 @@
     </p:spTree>
     <p:extLst>
       <p:ext uri="{BB962C8B-B14F-4D97-AF65-F5344CB8AC3E}">
-        <p14:creationId xmlns:p14="http://schemas.microsoft.com/office/powerpoint/2010/main" val="1675759537"/>
+        <p14:creationId xmlns:p14="http://schemas.microsoft.com/office/powerpoint/2010/main" val="1084145723"/>
       </p:ext>
     </p:extLst>
   </p:cSld>
@@ -5294,7 +5321,7 @@
           <p:cNvPr id="29" name="slide-5-title">
             <a:extLst xmlns:a="http://schemas.openxmlformats.org/drawingml/2006/main">
               <a:ext uri="{FF2B5EF4-FFF2-40B4-BE49-F238E27FC236}">
-                <a16:creationId xmlns:a16="http://schemas.microsoft.com/office/drawing/2014/main" id="{AC551BE6-9C7B-4717-A98C-B1A1DEC07B7E}"/>
+                <a16:creationId xmlns:a16="http://schemas.microsoft.com/office/drawing/2014/main" id="{0E7CAD0B-1042-4EFF-B17A-A08E4212E0D0}"/>
               </a:ext>
             </a:extLst>
           </p:cNvPr>
@@ -5344,7 +5371,7 @@
           <p:cNvPr id="2" name="">
             <a:extLst xmlns:a="http://schemas.openxmlformats.org/drawingml/2006/main">
               <a:ext uri="{FF2B5EF4-FFF2-40B4-BE49-F238E27FC236}">
-                <a16:creationId xmlns:a16="http://schemas.microsoft.com/office/drawing/2014/main" id="{FBEDDA2F-9C1C-478A-B203-6F6CB1D65CD6}"/>
+                <a16:creationId xmlns:a16="http://schemas.microsoft.com/office/drawing/2014/main" id="{4B7B9AE4-164C-40FE-9D23-102BDC4FBF24}"/>
               </a:ext>
             </a:extLst>
           </p:cNvPr>
@@ -5394,7 +5421,7 @@
           <p:cNvPr id="3" name="">
             <a:extLst xmlns:a="http://schemas.openxmlformats.org/drawingml/2006/main">
               <a:ext uri="{FF2B5EF4-FFF2-40B4-BE49-F238E27FC236}">
-                <a16:creationId xmlns:a16="http://schemas.microsoft.com/office/drawing/2014/main" id="{46FE05A3-4977-47C5-8F79-7C2C2965C81C}"/>
+                <a16:creationId xmlns:a16="http://schemas.microsoft.com/office/drawing/2014/main" id="{2F7171A7-9C9B-4004-BE60-B9765F4DCF56}"/>
               </a:ext>
             </a:extLst>
           </p:cNvPr>
@@ -5532,7 +5559,7 @@
           <p:cNvPr id="8" name="">
             <a:extLst xmlns:a="http://schemas.openxmlformats.org/drawingml/2006/main">
               <a:ext uri="{FF2B5EF4-FFF2-40B4-BE49-F238E27FC236}">
-                <a16:creationId xmlns:a16="http://schemas.microsoft.com/office/drawing/2014/main" id="{A6F20441-CC1F-4AC9-A364-E24B2E6357C1}"/>
+                <a16:creationId xmlns:a16="http://schemas.microsoft.com/office/drawing/2014/main" id="{A9FEF848-A7FE-4D22-A90C-9E3F179A4432}"/>
               </a:ext>
             </a:extLst>
           </p:cNvPr>
@@ -5563,7 +5590,7 @@
           <p:cNvPr id="9" name="">
             <a:extLst xmlns:a="http://schemas.openxmlformats.org/drawingml/2006/main">
               <a:ext uri="{FF2B5EF4-FFF2-40B4-BE49-F238E27FC236}">
-                <a16:creationId xmlns:a16="http://schemas.microsoft.com/office/drawing/2014/main" id="{5A50E1BD-A384-434A-B958-1FEE44F4EDEB}"/>
+                <a16:creationId xmlns:a16="http://schemas.microsoft.com/office/drawing/2014/main" id="{C6B9225D-40EB-4C96-877C-13D960DF9C57}"/>
               </a:ext>
             </a:extLst>
           </p:cNvPr>
@@ -5613,7 +5640,7 @@
           <p:cNvPr id="10" name="">
             <a:extLst xmlns:a="http://schemas.openxmlformats.org/drawingml/2006/main">
               <a:ext uri="{FF2B5EF4-FFF2-40B4-BE49-F238E27FC236}">
-                <a16:creationId xmlns:a16="http://schemas.microsoft.com/office/drawing/2014/main" id="{7FB240ED-AAE8-4D03-A19B-8C318DEDFC37}"/>
+                <a16:creationId xmlns:a16="http://schemas.microsoft.com/office/drawing/2014/main" id="{77D38451-0085-4C45-9034-24B2A177919D}"/>
               </a:ext>
             </a:extLst>
           </p:cNvPr>
@@ -5663,7 +5690,7 @@
           <p:cNvPr id="11" name="">
             <a:extLst xmlns:a="http://schemas.openxmlformats.org/drawingml/2006/main">
               <a:ext uri="{FF2B5EF4-FFF2-40B4-BE49-F238E27FC236}">
-                <a16:creationId xmlns:a16="http://schemas.microsoft.com/office/drawing/2014/main" id="{89129D61-7B12-405F-894C-A5BDB8EC8226}"/>
+                <a16:creationId xmlns:a16="http://schemas.microsoft.com/office/drawing/2014/main" id="{3F32D99B-1AA3-45DD-A76C-8A6F8C48E4C4}"/>
               </a:ext>
             </a:extLst>
           </p:cNvPr>
@@ -5713,7 +5740,7 @@
           <p:cNvPr id="12" name="">
             <a:extLst xmlns:a="http://schemas.openxmlformats.org/drawingml/2006/main">
               <a:ext uri="{FF2B5EF4-FFF2-40B4-BE49-F238E27FC236}">
-                <a16:creationId xmlns:a16="http://schemas.microsoft.com/office/drawing/2014/main" id="{755793CC-2EB7-41D5-83CD-219B3D2B0350}"/>
+                <a16:creationId xmlns:a16="http://schemas.microsoft.com/office/drawing/2014/main" id="{32AD8AE2-2C89-4B03-9C3D-0DADF3C9EAB2}"/>
               </a:ext>
             </a:extLst>
           </p:cNvPr>
@@ -5744,7 +5771,7 @@
           <p:cNvPr id="13" name="">
             <a:extLst xmlns:a="http://schemas.openxmlformats.org/drawingml/2006/main">
               <a:ext uri="{FF2B5EF4-FFF2-40B4-BE49-F238E27FC236}">
-                <a16:creationId xmlns:a16="http://schemas.microsoft.com/office/drawing/2014/main" id="{6089A091-6414-4A99-82BD-6CC733615E6B}"/>
+                <a16:creationId xmlns:a16="http://schemas.microsoft.com/office/drawing/2014/main" id="{A7A57042-9DAB-4892-A5B0-7365729920F4}"/>
               </a:ext>
             </a:extLst>
           </p:cNvPr>
@@ -5794,7 +5821,7 @@
           <p:cNvPr id="14" name="">
             <a:extLst xmlns:a="http://schemas.openxmlformats.org/drawingml/2006/main">
               <a:ext uri="{FF2B5EF4-FFF2-40B4-BE49-F238E27FC236}">
-                <a16:creationId xmlns:a16="http://schemas.microsoft.com/office/drawing/2014/main" id="{21654EED-00A9-444F-82DA-3D9DAB21929D}"/>
+                <a16:creationId xmlns:a16="http://schemas.microsoft.com/office/drawing/2014/main" id="{3152E822-FB97-4BAC-87DC-74281E79FBCA}"/>
               </a:ext>
             </a:extLst>
           </p:cNvPr>
@@ -5844,7 +5871,7 @@
           <p:cNvPr id="15" name="">
             <a:extLst xmlns:a="http://schemas.openxmlformats.org/drawingml/2006/main">
               <a:ext uri="{FF2B5EF4-FFF2-40B4-BE49-F238E27FC236}">
-                <a16:creationId xmlns:a16="http://schemas.microsoft.com/office/drawing/2014/main" id="{FFCE0E3D-F671-43C2-8A7D-EC59FDBE16FE}"/>
+                <a16:creationId xmlns:a16="http://schemas.microsoft.com/office/drawing/2014/main" id="{53EB9102-D04E-4E33-ACFE-33B078C8F8C7}"/>
               </a:ext>
             </a:extLst>
           </p:cNvPr>
@@ -5884,7 +5911,7 @@
                   <a:srgbClr val="565D67"/>
                 </a:solidFill>
               </a:rPr>
-              <a:t>80k index + constraints + dedupe</a:t>
+              <a:t>80k index + hard constraints + dedupe</a:t>
             </a:r>
           </a:p>
         </p:txBody>
@@ -5894,7 +5921,7 @@
           <p:cNvPr id="16" name="">
             <a:extLst xmlns:a="http://schemas.openxmlformats.org/drawingml/2006/main">
               <a:ext uri="{FF2B5EF4-FFF2-40B4-BE49-F238E27FC236}">
-                <a16:creationId xmlns:a16="http://schemas.microsoft.com/office/drawing/2014/main" id="{A9FAC424-5791-4CEB-B82A-9DACB47A4748}"/>
+                <a16:creationId xmlns:a16="http://schemas.microsoft.com/office/drawing/2014/main" id="{3F47D09D-A6B9-4CC6-8FA3-63D7E7363BCF}"/>
               </a:ext>
             </a:extLst>
           </p:cNvPr>
@@ -5925,7 +5952,7 @@
           <p:cNvPr id="17" name="">
             <a:extLst xmlns:a="http://schemas.openxmlformats.org/drawingml/2006/main">
               <a:ext uri="{FF2B5EF4-FFF2-40B4-BE49-F238E27FC236}">
-                <a16:creationId xmlns:a16="http://schemas.microsoft.com/office/drawing/2014/main" id="{0118C43D-BAC9-4464-BA7A-57B8E1E80B72}"/>
+                <a16:creationId xmlns:a16="http://schemas.microsoft.com/office/drawing/2014/main" id="{99282EAF-2A98-4189-A297-5764CE75ED8C}"/>
               </a:ext>
             </a:extLst>
           </p:cNvPr>
@@ -5975,7 +6002,7 @@
           <p:cNvPr id="18" name="">
             <a:extLst xmlns:a="http://schemas.openxmlformats.org/drawingml/2006/main">
               <a:ext uri="{FF2B5EF4-FFF2-40B4-BE49-F238E27FC236}">
-                <a16:creationId xmlns:a16="http://schemas.microsoft.com/office/drawing/2014/main" id="{62940920-81D7-4B65-B224-0DD2787F0B1E}"/>
+                <a16:creationId xmlns:a16="http://schemas.microsoft.com/office/drawing/2014/main" id="{A60797A8-8030-418D-9E48-7C8B2A75FCBD}"/>
               </a:ext>
             </a:extLst>
           </p:cNvPr>
@@ -6025,7 +6052,7 @@
           <p:cNvPr id="19" name="">
             <a:extLst xmlns:a="http://schemas.openxmlformats.org/drawingml/2006/main">
               <a:ext uri="{FF2B5EF4-FFF2-40B4-BE49-F238E27FC236}">
-                <a16:creationId xmlns:a16="http://schemas.microsoft.com/office/drawing/2014/main" id="{57F40ACB-E816-4568-8E98-68649D33C2E8}"/>
+                <a16:creationId xmlns:a16="http://schemas.microsoft.com/office/drawing/2014/main" id="{8215C2EA-5E7A-48D7-AE5E-3CCCCE08D395}"/>
               </a:ext>
             </a:extLst>
           </p:cNvPr>
@@ -6075,7 +6102,7 @@
           <p:cNvPr id="20" name="">
             <a:extLst xmlns:a="http://schemas.openxmlformats.org/drawingml/2006/main">
               <a:ext uri="{FF2B5EF4-FFF2-40B4-BE49-F238E27FC236}">
-                <a16:creationId xmlns:a16="http://schemas.microsoft.com/office/drawing/2014/main" id="{EBD8A9E5-9CB1-44D8-AD75-A5410F9EF87E}"/>
+                <a16:creationId xmlns:a16="http://schemas.microsoft.com/office/drawing/2014/main" id="{D10D3509-1C39-4976-BFF2-F3857F6AC4B7}"/>
               </a:ext>
             </a:extLst>
           </p:cNvPr>
@@ -6106,7 +6133,7 @@
           <p:cNvPr id="21" name="">
             <a:extLst xmlns:a="http://schemas.openxmlformats.org/drawingml/2006/main">
               <a:ext uri="{FF2B5EF4-FFF2-40B4-BE49-F238E27FC236}">
-                <a16:creationId xmlns:a16="http://schemas.microsoft.com/office/drawing/2014/main" id="{AC221F02-1A2D-4120-8FFC-75BA6CBE94C4}"/>
+                <a16:creationId xmlns:a16="http://schemas.microsoft.com/office/drawing/2014/main" id="{E2CD859F-DFDF-4951-AD74-D296242323B1}"/>
               </a:ext>
             </a:extLst>
           </p:cNvPr>
@@ -6156,7 +6183,7 @@
           <p:cNvPr id="22" name="">
             <a:extLst xmlns:a="http://schemas.openxmlformats.org/drawingml/2006/main">
               <a:ext uri="{FF2B5EF4-FFF2-40B4-BE49-F238E27FC236}">
-                <a16:creationId xmlns:a16="http://schemas.microsoft.com/office/drawing/2014/main" id="{E5776A57-5FD6-4F6D-9D3A-120659D2BA38}"/>
+                <a16:creationId xmlns:a16="http://schemas.microsoft.com/office/drawing/2014/main" id="{8F69F4FF-1254-4365-9533-1F4E8E4F3E31}"/>
               </a:ext>
             </a:extLst>
           </p:cNvPr>
@@ -6206,7 +6233,7 @@
           <p:cNvPr id="23" name="">
             <a:extLst xmlns:a="http://schemas.openxmlformats.org/drawingml/2006/main">
               <a:ext uri="{FF2B5EF4-FFF2-40B4-BE49-F238E27FC236}">
-                <a16:creationId xmlns:a16="http://schemas.microsoft.com/office/drawing/2014/main" id="{536264A2-6921-437C-A375-86F287EAC078}"/>
+                <a16:creationId xmlns:a16="http://schemas.microsoft.com/office/drawing/2014/main" id="{254A4A6A-3343-40C5-B2C3-7D77B2455EC4}"/>
               </a:ext>
             </a:extLst>
           </p:cNvPr>
@@ -6246,7 +6273,7 @@
                   <a:srgbClr val="565D67"/>
                 </a:solidFill>
               </a:rPr>
-              <a:t>Missing fields + authorization</a:t>
+              <a:t>Calibrated margin + policy gates</a:t>
             </a:r>
           </a:p>
         </p:txBody>
@@ -6256,7 +6283,7 @@
           <p:cNvPr id="24" name="">
             <a:extLst xmlns:a="http://schemas.openxmlformats.org/drawingml/2006/main">
               <a:ext uri="{FF2B5EF4-FFF2-40B4-BE49-F238E27FC236}">
-                <a16:creationId xmlns:a16="http://schemas.microsoft.com/office/drawing/2014/main" id="{730E46DF-FCFF-48A5-B919-19BDC6FA6289}"/>
+                <a16:creationId xmlns:a16="http://schemas.microsoft.com/office/drawing/2014/main" id="{6B0ACDE2-0F15-4B35-9EF3-D4F47DC77CBB}"/>
               </a:ext>
             </a:extLst>
           </p:cNvPr>
@@ -6287,7 +6314,7 @@
           <p:cNvPr id="25" name="">
             <a:extLst xmlns:a="http://schemas.openxmlformats.org/drawingml/2006/main">
               <a:ext uri="{FF2B5EF4-FFF2-40B4-BE49-F238E27FC236}">
-                <a16:creationId xmlns:a16="http://schemas.microsoft.com/office/drawing/2014/main" id="{D51731E9-574D-4DA6-B957-191B11058B31}"/>
+                <a16:creationId xmlns:a16="http://schemas.microsoft.com/office/drawing/2014/main" id="{2FC306F1-EB8F-46E5-ABC3-F568CF120C4A}"/>
               </a:ext>
             </a:extLst>
           </p:cNvPr>
@@ -6337,7 +6364,7 @@
           <p:cNvPr id="26" name="">
             <a:extLst xmlns:a="http://schemas.openxmlformats.org/drawingml/2006/main">
               <a:ext uri="{FF2B5EF4-FFF2-40B4-BE49-F238E27FC236}">
-                <a16:creationId xmlns:a16="http://schemas.microsoft.com/office/drawing/2014/main" id="{C3BD6F1E-0962-43ED-9BAC-C5B79B4059E8}"/>
+                <a16:creationId xmlns:a16="http://schemas.microsoft.com/office/drawing/2014/main" id="{DF43B47F-7392-47C2-A63D-ADF8A7A3D8F5}"/>
               </a:ext>
             </a:extLst>
           </p:cNvPr>
@@ -6387,7 +6414,7 @@
           <p:cNvPr id="27" name="">
             <a:extLst xmlns:a="http://schemas.openxmlformats.org/drawingml/2006/main">
               <a:ext uri="{FF2B5EF4-FFF2-40B4-BE49-F238E27FC236}">
-                <a16:creationId xmlns:a16="http://schemas.microsoft.com/office/drawing/2014/main" id="{77FCAA64-382C-48A3-A14C-1694125FCD6D}"/>
+                <a16:creationId xmlns:a16="http://schemas.microsoft.com/office/drawing/2014/main" id="{BE12BE6F-1F00-4D0E-BD87-A87D4781F809}"/>
               </a:ext>
             </a:extLst>
           </p:cNvPr>
@@ -6437,7 +6464,7 @@
           <p:cNvPr id="28" name="">
             <a:extLst xmlns:a="http://schemas.openxmlformats.org/drawingml/2006/main">
               <a:ext uri="{FF2B5EF4-FFF2-40B4-BE49-F238E27FC236}">
-                <a16:creationId xmlns:a16="http://schemas.microsoft.com/office/drawing/2014/main" id="{0FE0C66F-51CF-4F14-8B2B-230350C85F33}"/>
+                <a16:creationId xmlns:a16="http://schemas.microsoft.com/office/drawing/2014/main" id="{812BE27C-3CE0-4001-B8B7-5D7C2A43238F}"/>
               </a:ext>
             </a:extLst>
           </p:cNvPr>
@@ -6485,7 +6512,7 @@
     </p:spTree>
     <p:extLst>
       <p:ext uri="{BB962C8B-B14F-4D97-AF65-F5344CB8AC3E}">
-        <p14:creationId xmlns:p14="http://schemas.microsoft.com/office/powerpoint/2010/main" val="1727206126"/>
+        <p14:creationId xmlns:p14="http://schemas.microsoft.com/office/powerpoint/2010/main" val="1906280775"/>
       </p:ext>
     </p:extLst>
   </p:cSld>
@@ -6516,7 +6543,7 @@
           <p:cNvPr id="48" name="slide-6-title">
             <a:extLst xmlns:a="http://schemas.openxmlformats.org/drawingml/2006/main">
               <a:ext uri="{FF2B5EF4-FFF2-40B4-BE49-F238E27FC236}">
-                <a16:creationId xmlns:a16="http://schemas.microsoft.com/office/drawing/2014/main" id="{80C78B83-9975-4C0F-A243-6D68053EE5D0}"/>
+                <a16:creationId xmlns:a16="http://schemas.microsoft.com/office/drawing/2014/main" id="{D036A537-6073-4938-81EF-0782972C2C3A}"/>
               </a:ext>
             </a:extLst>
           </p:cNvPr>
@@ -6566,7 +6593,7 @@
           <p:cNvPr id="2" name="">
             <a:extLst xmlns:a="http://schemas.openxmlformats.org/drawingml/2006/main">
               <a:ext uri="{FF2B5EF4-FFF2-40B4-BE49-F238E27FC236}">
-                <a16:creationId xmlns:a16="http://schemas.microsoft.com/office/drawing/2014/main" id="{960558DB-4C5B-4916-B819-7A033BF58156}"/>
+                <a16:creationId xmlns:a16="http://schemas.microsoft.com/office/drawing/2014/main" id="{26190F7B-35E1-4DAC-94AB-B488B4983DB8}"/>
               </a:ext>
             </a:extLst>
           </p:cNvPr>
@@ -6616,7 +6643,7 @@
           <p:cNvPr id="3" name="">
             <a:extLst xmlns:a="http://schemas.openxmlformats.org/drawingml/2006/main">
               <a:ext uri="{FF2B5EF4-FFF2-40B4-BE49-F238E27FC236}">
-                <a16:creationId xmlns:a16="http://schemas.microsoft.com/office/drawing/2014/main" id="{76837AF0-212E-4383-92C8-F9E1940A6CB4}"/>
+                <a16:creationId xmlns:a16="http://schemas.microsoft.com/office/drawing/2014/main" id="{B75AE41D-C05E-4D0A-B303-C3B203E6BB4E}"/>
               </a:ext>
             </a:extLst>
           </p:cNvPr>
@@ -6666,7 +6693,7 @@
           <p:cNvPr id="4" name="">
             <a:extLst xmlns:a="http://schemas.openxmlformats.org/drawingml/2006/main">
               <a:ext uri="{FF2B5EF4-FFF2-40B4-BE49-F238E27FC236}">
-                <a16:creationId xmlns:a16="http://schemas.microsoft.com/office/drawing/2014/main" id="{749A3A88-B206-4668-8408-1E2C33CD653A}"/>
+                <a16:creationId xmlns:a16="http://schemas.microsoft.com/office/drawing/2014/main" id="{D63B290B-62C1-44A7-BD0E-AF61188F2FA5}"/>
               </a:ext>
             </a:extLst>
           </p:cNvPr>
@@ -6716,7 +6743,7 @@
           <p:cNvPr id="5" name="">
             <a:extLst xmlns:a="http://schemas.openxmlformats.org/drawingml/2006/main">
               <a:ext uri="{FF2B5EF4-FFF2-40B4-BE49-F238E27FC236}">
-                <a16:creationId xmlns:a16="http://schemas.microsoft.com/office/drawing/2014/main" id="{AB338032-879C-4540-9CDE-E35D9C00CC18}"/>
+                <a16:creationId xmlns:a16="http://schemas.microsoft.com/office/drawing/2014/main" id="{983AFDC1-3CFF-4EC8-8218-C5C77AB26EBD}"/>
               </a:ext>
             </a:extLst>
           </p:cNvPr>
@@ -6766,7 +6793,7 @@
           <p:cNvPr id="6" name="">
             <a:extLst xmlns:a="http://schemas.openxmlformats.org/drawingml/2006/main">
               <a:ext uri="{FF2B5EF4-FFF2-40B4-BE49-F238E27FC236}">
-                <a16:creationId xmlns:a16="http://schemas.microsoft.com/office/drawing/2014/main" id="{7E0C7A33-4375-4158-88A6-0979C21014F5}"/>
+                <a16:creationId xmlns:a16="http://schemas.microsoft.com/office/drawing/2014/main" id="{BD81CCE7-1163-4A45-988C-9A1A8E68100C}"/>
               </a:ext>
             </a:extLst>
           </p:cNvPr>
@@ -6799,7 +6826,7 @@
           <p:cNvPr id="7" name="">
             <a:extLst xmlns:a="http://schemas.openxmlformats.org/drawingml/2006/main">
               <a:ext uri="{FF2B5EF4-FFF2-40B4-BE49-F238E27FC236}">
-                <a16:creationId xmlns:a16="http://schemas.microsoft.com/office/drawing/2014/main" id="{1D066C51-8642-47AC-ABAB-DD5188D75475}"/>
+                <a16:creationId xmlns:a16="http://schemas.microsoft.com/office/drawing/2014/main" id="{CD960700-8316-45FB-8296-C3CA012B6B86}"/>
               </a:ext>
             </a:extLst>
           </p:cNvPr>
@@ -6849,7 +6876,7 @@
           <p:cNvPr id="8" name="">
             <a:extLst xmlns:a="http://schemas.openxmlformats.org/drawingml/2006/main">
               <a:ext uri="{FF2B5EF4-FFF2-40B4-BE49-F238E27FC236}">
-                <a16:creationId xmlns:a16="http://schemas.microsoft.com/office/drawing/2014/main" id="{570BEADA-BDC5-4BA6-AEBD-A79FF21E3865}"/>
+                <a16:creationId xmlns:a16="http://schemas.microsoft.com/office/drawing/2014/main" id="{561C7273-AA94-4EDC-A283-801D6F7E1D6E}"/>
               </a:ext>
             </a:extLst>
           </p:cNvPr>
@@ -6882,7 +6909,7 @@
           <p:cNvPr id="9" name="">
             <a:extLst xmlns:a="http://schemas.openxmlformats.org/drawingml/2006/main">
               <a:ext uri="{FF2B5EF4-FFF2-40B4-BE49-F238E27FC236}">
-                <a16:creationId xmlns:a16="http://schemas.microsoft.com/office/drawing/2014/main" id="{8B435153-08E7-48A8-9AC0-2E0F6D5B58C2}"/>
+                <a16:creationId xmlns:a16="http://schemas.microsoft.com/office/drawing/2014/main" id="{64BE14D7-163B-4AE3-92CE-AC136AC0E617}"/>
               </a:ext>
             </a:extLst>
           </p:cNvPr>
@@ -6932,7 +6959,7 @@
           <p:cNvPr id="10" name="">
             <a:extLst xmlns:a="http://schemas.openxmlformats.org/drawingml/2006/main">
               <a:ext uri="{FF2B5EF4-FFF2-40B4-BE49-F238E27FC236}">
-                <a16:creationId xmlns:a16="http://schemas.microsoft.com/office/drawing/2014/main" id="{AD5DE2FC-06A0-45B3-A243-36976B10CFE5}"/>
+                <a16:creationId xmlns:a16="http://schemas.microsoft.com/office/drawing/2014/main" id="{BCF04495-B083-4F60-B2E4-138AB0945573}"/>
               </a:ext>
             </a:extLst>
           </p:cNvPr>
@@ -6965,7 +6992,7 @@
           <p:cNvPr id="11" name="">
             <a:extLst xmlns:a="http://schemas.openxmlformats.org/drawingml/2006/main">
               <a:ext uri="{FF2B5EF4-FFF2-40B4-BE49-F238E27FC236}">
-                <a16:creationId xmlns:a16="http://schemas.microsoft.com/office/drawing/2014/main" id="{D919FD13-F648-4A7F-B6C9-D7529D9ED830}"/>
+                <a16:creationId xmlns:a16="http://schemas.microsoft.com/office/drawing/2014/main" id="{0A6F5546-F901-42F1-AD56-62037E9C630D}"/>
               </a:ext>
             </a:extLst>
           </p:cNvPr>
@@ -7015,7 +7042,7 @@
           <p:cNvPr id="12" name="">
             <a:extLst xmlns:a="http://schemas.openxmlformats.org/drawingml/2006/main">
               <a:ext uri="{FF2B5EF4-FFF2-40B4-BE49-F238E27FC236}">
-                <a16:creationId xmlns:a16="http://schemas.microsoft.com/office/drawing/2014/main" id="{29EDEDFF-B2B6-4B72-A8F7-E3CAB9645F0C}"/>
+                <a16:creationId xmlns:a16="http://schemas.microsoft.com/office/drawing/2014/main" id="{8DFBFE80-A04A-4194-8C4D-B3E2CC71F76F}"/>
               </a:ext>
             </a:extLst>
           </p:cNvPr>
@@ -7048,7 +7075,7 @@
           <p:cNvPr id="13" name="">
             <a:extLst xmlns:a="http://schemas.openxmlformats.org/drawingml/2006/main">
               <a:ext uri="{FF2B5EF4-FFF2-40B4-BE49-F238E27FC236}">
-                <a16:creationId xmlns:a16="http://schemas.microsoft.com/office/drawing/2014/main" id="{00EC370C-F702-4AE8-ABA5-C8DCB68EA5A1}"/>
+                <a16:creationId xmlns:a16="http://schemas.microsoft.com/office/drawing/2014/main" id="{27BB205F-9800-448B-AAF4-2FB3A14F1DE3}"/>
               </a:ext>
             </a:extLst>
           </p:cNvPr>
@@ -7098,7 +7125,7 @@
           <p:cNvPr id="14" name="">
             <a:extLst xmlns:a="http://schemas.openxmlformats.org/drawingml/2006/main">
               <a:ext uri="{FF2B5EF4-FFF2-40B4-BE49-F238E27FC236}">
-                <a16:creationId xmlns:a16="http://schemas.microsoft.com/office/drawing/2014/main" id="{ACFC8B64-8ECC-4CB6-BFD5-46CDC775E573}"/>
+                <a16:creationId xmlns:a16="http://schemas.microsoft.com/office/drawing/2014/main" id="{D195EB8D-DEA7-4CEB-B278-B98E1C8EEB57}"/>
               </a:ext>
             </a:extLst>
           </p:cNvPr>
@@ -7131,7 +7158,7 @@
           <p:cNvPr id="15" name="">
             <a:extLst xmlns:a="http://schemas.openxmlformats.org/drawingml/2006/main">
               <a:ext uri="{FF2B5EF4-FFF2-40B4-BE49-F238E27FC236}">
-                <a16:creationId xmlns:a16="http://schemas.microsoft.com/office/drawing/2014/main" id="{DBE05889-05AE-4CCF-80F4-B6412C9DC86F}"/>
+                <a16:creationId xmlns:a16="http://schemas.microsoft.com/office/drawing/2014/main" id="{8EADA886-EC48-4289-9083-D2675828309B}"/>
               </a:ext>
             </a:extLst>
           </p:cNvPr>
@@ -7181,7 +7208,7 @@
           <p:cNvPr id="16" name="">
             <a:extLst xmlns:a="http://schemas.openxmlformats.org/drawingml/2006/main">
               <a:ext uri="{FF2B5EF4-FFF2-40B4-BE49-F238E27FC236}">
-                <a16:creationId xmlns:a16="http://schemas.microsoft.com/office/drawing/2014/main" id="{A6D5CEE5-4C64-476A-9D5D-62D879FDB833}"/>
+                <a16:creationId xmlns:a16="http://schemas.microsoft.com/office/drawing/2014/main" id="{CC48CCFF-8689-4EF6-9E67-33F37F0CAF35}"/>
               </a:ext>
             </a:extLst>
           </p:cNvPr>
@@ -7214,7 +7241,7 @@
           <p:cNvPr id="17" name="">
             <a:extLst xmlns:a="http://schemas.openxmlformats.org/drawingml/2006/main">
               <a:ext uri="{FF2B5EF4-FFF2-40B4-BE49-F238E27FC236}">
-                <a16:creationId xmlns:a16="http://schemas.microsoft.com/office/drawing/2014/main" id="{23925832-C459-4609-A178-B5CA1EDE4A51}"/>
+                <a16:creationId xmlns:a16="http://schemas.microsoft.com/office/drawing/2014/main" id="{C5B20C16-401A-4905-AC55-D249B124D8CA}"/>
               </a:ext>
             </a:extLst>
           </p:cNvPr>
@@ -7264,7 +7291,7 @@
           <p:cNvPr id="18" name="">
             <a:extLst xmlns:a="http://schemas.openxmlformats.org/drawingml/2006/main">
               <a:ext uri="{FF2B5EF4-FFF2-40B4-BE49-F238E27FC236}">
-                <a16:creationId xmlns:a16="http://schemas.microsoft.com/office/drawing/2014/main" id="{5F4FC629-3D40-45CD-A069-5B581A94C4E3}"/>
+                <a16:creationId xmlns:a16="http://schemas.microsoft.com/office/drawing/2014/main" id="{117C9EA2-AD84-42E1-9B87-3A4FEB80A007}"/>
               </a:ext>
             </a:extLst>
           </p:cNvPr>
@@ -7297,7 +7324,7 @@
           <p:cNvPr id="19" name="">
             <a:extLst xmlns:a="http://schemas.openxmlformats.org/drawingml/2006/main">
               <a:ext uri="{FF2B5EF4-FFF2-40B4-BE49-F238E27FC236}">
-                <a16:creationId xmlns:a16="http://schemas.microsoft.com/office/drawing/2014/main" id="{36B3E4F2-318D-4AB8-9ABB-77E4988CD6A6}"/>
+                <a16:creationId xmlns:a16="http://schemas.microsoft.com/office/drawing/2014/main" id="{ACDBA6A1-449E-4647-87E1-0951BD637104}"/>
               </a:ext>
             </a:extLst>
           </p:cNvPr>
@@ -7347,7 +7374,7 @@
           <p:cNvPr id="20" name="">
             <a:extLst xmlns:a="http://schemas.openxmlformats.org/drawingml/2006/main">
               <a:ext uri="{FF2B5EF4-FFF2-40B4-BE49-F238E27FC236}">
-                <a16:creationId xmlns:a16="http://schemas.microsoft.com/office/drawing/2014/main" id="{0B60FB70-52B6-4BA0-824D-79D5929D38B6}"/>
+                <a16:creationId xmlns:a16="http://schemas.microsoft.com/office/drawing/2014/main" id="{E044FCC7-AB8C-4A95-A25E-27C0617B1144}"/>
               </a:ext>
             </a:extLst>
           </p:cNvPr>
@@ -7380,7 +7407,7 @@
           <p:cNvPr id="21" name="">
             <a:extLst xmlns:a="http://schemas.openxmlformats.org/drawingml/2006/main">
               <a:ext uri="{FF2B5EF4-FFF2-40B4-BE49-F238E27FC236}">
-                <a16:creationId xmlns:a16="http://schemas.microsoft.com/office/drawing/2014/main" id="{A94BDF02-D16C-461A-83A6-3783F9D71B73}"/>
+                <a16:creationId xmlns:a16="http://schemas.microsoft.com/office/drawing/2014/main" id="{3ED7D418-1C2E-4112-A2D9-AE1BB709EA8F}"/>
               </a:ext>
             </a:extLst>
           </p:cNvPr>
@@ -7447,7 +7474,7 @@
           <p:cNvPr id="22" name="">
             <a:extLst xmlns:a="http://schemas.openxmlformats.org/drawingml/2006/main">
               <a:ext uri="{FF2B5EF4-FFF2-40B4-BE49-F238E27FC236}">
-                <a16:creationId xmlns:a16="http://schemas.microsoft.com/office/drawing/2014/main" id="{BC962EA5-AABB-4BF0-B4AE-277828FCE9C3}"/>
+                <a16:creationId xmlns:a16="http://schemas.microsoft.com/office/drawing/2014/main" id="{9FA5A2AD-CEA3-493A-9C7C-770A2B4AD74A}"/>
               </a:ext>
             </a:extLst>
           </p:cNvPr>
@@ -7480,7 +7507,7 @@
           <p:cNvPr id="23" name="">
             <a:extLst xmlns:a="http://schemas.openxmlformats.org/drawingml/2006/main">
               <a:ext uri="{FF2B5EF4-FFF2-40B4-BE49-F238E27FC236}">
-                <a16:creationId xmlns:a16="http://schemas.microsoft.com/office/drawing/2014/main" id="{66DF35C8-1384-4488-921C-8E67CA898ABE}"/>
+                <a16:creationId xmlns:a16="http://schemas.microsoft.com/office/drawing/2014/main" id="{EB090A9C-69BB-4352-8B4C-CC733BBEDA5D}"/>
               </a:ext>
             </a:extLst>
           </p:cNvPr>
@@ -7530,7 +7557,7 @@
           <p:cNvPr id="24" name="">
             <a:extLst xmlns:a="http://schemas.openxmlformats.org/drawingml/2006/main">
               <a:ext uri="{FF2B5EF4-FFF2-40B4-BE49-F238E27FC236}">
-                <a16:creationId xmlns:a16="http://schemas.microsoft.com/office/drawing/2014/main" id="{7178C806-3A6A-425C-B08E-019D8670BDBC}"/>
+                <a16:creationId xmlns:a16="http://schemas.microsoft.com/office/drawing/2014/main" id="{360D9564-4CE5-46F2-845D-EDEB10A8DA56}"/>
               </a:ext>
             </a:extLst>
           </p:cNvPr>
@@ -7563,7 +7590,7 @@
           <p:cNvPr id="25" name="">
             <a:extLst xmlns:a="http://schemas.openxmlformats.org/drawingml/2006/main">
               <a:ext uri="{FF2B5EF4-FFF2-40B4-BE49-F238E27FC236}">
-                <a16:creationId xmlns:a16="http://schemas.microsoft.com/office/drawing/2014/main" id="{2F465A69-C5F8-418B-941F-747FFC8B6E77}"/>
+                <a16:creationId xmlns:a16="http://schemas.microsoft.com/office/drawing/2014/main" id="{4D7AA156-8A9D-454D-94BC-689D50EE374E}"/>
               </a:ext>
             </a:extLst>
           </p:cNvPr>
@@ -7603,7 +7630,7 @@
                   <a:srgbClr val="111111"/>
                 </a:solidFill>
               </a:rPr>
-              <a:t>10.354</a:t>
+              <a:t>9.854</a:t>
             </a:r>
           </a:p>
         </p:txBody>
@@ -7613,7 +7640,7 @@
           <p:cNvPr id="26" name="">
             <a:extLst xmlns:a="http://schemas.openxmlformats.org/drawingml/2006/main">
               <a:ext uri="{FF2B5EF4-FFF2-40B4-BE49-F238E27FC236}">
-                <a16:creationId xmlns:a16="http://schemas.microsoft.com/office/drawing/2014/main" id="{7C3F7BD4-E1DA-4C43-B480-9B3B5A8DEF58}"/>
+                <a16:creationId xmlns:a16="http://schemas.microsoft.com/office/drawing/2014/main" id="{47911271-5802-45FA-9DF5-9D30D7511D7F}"/>
               </a:ext>
             </a:extLst>
           </p:cNvPr>
@@ -7646,7 +7673,7 @@
           <p:cNvPr id="27" name="">
             <a:extLst xmlns:a="http://schemas.openxmlformats.org/drawingml/2006/main">
               <a:ext uri="{FF2B5EF4-FFF2-40B4-BE49-F238E27FC236}">
-                <a16:creationId xmlns:a16="http://schemas.microsoft.com/office/drawing/2014/main" id="{528A0054-C9B5-472A-91BA-96CEDE7EBEF7}"/>
+                <a16:creationId xmlns:a16="http://schemas.microsoft.com/office/drawing/2014/main" id="{F066C9F9-728E-4278-B583-FF8094F4FB91}"/>
               </a:ext>
             </a:extLst>
           </p:cNvPr>
@@ -7696,7 +7723,7 @@
           <p:cNvPr id="28" name="">
             <a:extLst xmlns:a="http://schemas.openxmlformats.org/drawingml/2006/main">
               <a:ext uri="{FF2B5EF4-FFF2-40B4-BE49-F238E27FC236}">
-                <a16:creationId xmlns:a16="http://schemas.microsoft.com/office/drawing/2014/main" id="{0F3E3EB9-ADC8-41AC-95AE-E4E54159F4BE}"/>
+                <a16:creationId xmlns:a16="http://schemas.microsoft.com/office/drawing/2014/main" id="{236706F6-3611-48E2-90A2-E25B57FAAA35}"/>
               </a:ext>
             </a:extLst>
           </p:cNvPr>
@@ -7729,7 +7756,7 @@
           <p:cNvPr id="29" name="">
             <a:extLst xmlns:a="http://schemas.openxmlformats.org/drawingml/2006/main">
               <a:ext uri="{FF2B5EF4-FFF2-40B4-BE49-F238E27FC236}">
-                <a16:creationId xmlns:a16="http://schemas.microsoft.com/office/drawing/2014/main" id="{39620463-57FD-421E-9F32-133F24BF4261}"/>
+                <a16:creationId xmlns:a16="http://schemas.microsoft.com/office/drawing/2014/main" id="{35157B6F-B413-4692-9884-60DE1070E480}"/>
               </a:ext>
             </a:extLst>
           </p:cNvPr>
@@ -7769,7 +7796,7 @@
                   <a:srgbClr val="111111"/>
                 </a:solidFill>
               </a:rPr>
-              <a:t>Data Analyst (US REMOTE)</a:t>
+              <a:t>Data Analyst</a:t>
             </a:r>
           </a:p>
         </p:txBody>
@@ -7779,7 +7806,7 @@
           <p:cNvPr id="30" name="">
             <a:extLst xmlns:a="http://schemas.openxmlformats.org/drawingml/2006/main">
               <a:ext uri="{FF2B5EF4-FFF2-40B4-BE49-F238E27FC236}">
-                <a16:creationId xmlns:a16="http://schemas.microsoft.com/office/drawing/2014/main" id="{64B57F84-2092-4AE9-9A75-BB2483E41607}"/>
+                <a16:creationId xmlns:a16="http://schemas.microsoft.com/office/drawing/2014/main" id="{64BF332F-7EAD-441F-832B-F2EE9EF4E8A6}"/>
               </a:ext>
             </a:extLst>
           </p:cNvPr>
@@ -7812,7 +7839,7 @@
           <p:cNvPr id="31" name="">
             <a:extLst xmlns:a="http://schemas.openxmlformats.org/drawingml/2006/main">
               <a:ext uri="{FF2B5EF4-FFF2-40B4-BE49-F238E27FC236}">
-                <a16:creationId xmlns:a16="http://schemas.microsoft.com/office/drawing/2014/main" id="{D299C7DB-4FC5-46C6-BBD7-C0B75BB5BE90}"/>
+                <a16:creationId xmlns:a16="http://schemas.microsoft.com/office/drawing/2014/main" id="{FA875233-A378-45EC-AB61-C7FE0596AF8C}"/>
               </a:ext>
             </a:extLst>
           </p:cNvPr>
@@ -7852,7 +7879,7 @@
                   <a:srgbClr val="111111"/>
                 </a:solidFill>
               </a:rPr>
-              <a:t>LeanTaaS</a:t>
+              <a:t>HMP Global</a:t>
             </a:r>
           </a:p>
           <a:p xmlns:a="http://schemas.openxmlformats.org/drawingml/2006/main">
@@ -7879,7 +7906,7 @@
           <p:cNvPr id="32" name="">
             <a:extLst xmlns:a="http://schemas.openxmlformats.org/drawingml/2006/main">
               <a:ext uri="{FF2B5EF4-FFF2-40B4-BE49-F238E27FC236}">
-                <a16:creationId xmlns:a16="http://schemas.microsoft.com/office/drawing/2014/main" id="{36F3B23B-0CB8-4705-BAD2-80C4F38897FD}"/>
+                <a16:creationId xmlns:a16="http://schemas.microsoft.com/office/drawing/2014/main" id="{1BB3BA71-1682-4D18-BE43-53482F29549A}"/>
               </a:ext>
             </a:extLst>
           </p:cNvPr>
@@ -7912,7 +7939,7 @@
           <p:cNvPr id="33" name="">
             <a:extLst xmlns:a="http://schemas.openxmlformats.org/drawingml/2006/main">
               <a:ext uri="{FF2B5EF4-FFF2-40B4-BE49-F238E27FC236}">
-                <a16:creationId xmlns:a16="http://schemas.microsoft.com/office/drawing/2014/main" id="{90BCDF7D-E1A2-4354-BFDA-7D42D0243F70}"/>
+                <a16:creationId xmlns:a16="http://schemas.microsoft.com/office/drawing/2014/main" id="{61C1FF3A-91F9-48A0-8D95-2595C252754D}"/>
               </a:ext>
             </a:extLst>
           </p:cNvPr>
@@ -7962,7 +7989,7 @@
           <p:cNvPr id="34" name="">
             <a:extLst xmlns:a="http://schemas.openxmlformats.org/drawingml/2006/main">
               <a:ext uri="{FF2B5EF4-FFF2-40B4-BE49-F238E27FC236}">
-                <a16:creationId xmlns:a16="http://schemas.microsoft.com/office/drawing/2014/main" id="{E586EFF1-7E76-464A-B574-6EE3946329E7}"/>
+                <a16:creationId xmlns:a16="http://schemas.microsoft.com/office/drawing/2014/main" id="{766DB01C-5B19-4459-8685-ECA2AEE1596B}"/>
               </a:ext>
             </a:extLst>
           </p:cNvPr>
@@ -7995,7 +8022,7 @@
           <p:cNvPr id="35" name="">
             <a:extLst xmlns:a="http://schemas.openxmlformats.org/drawingml/2006/main">
               <a:ext uri="{FF2B5EF4-FFF2-40B4-BE49-F238E27FC236}">
-                <a16:creationId xmlns:a16="http://schemas.microsoft.com/office/drawing/2014/main" id="{2CDAEB70-8702-46B5-B3F9-39547E643FDB}"/>
+                <a16:creationId xmlns:a16="http://schemas.microsoft.com/office/drawing/2014/main" id="{C8A3DA40-F78F-420E-90AB-BA35D6C0F71B}"/>
               </a:ext>
             </a:extLst>
           </p:cNvPr>
@@ -8035,7 +8062,7 @@
                   <a:srgbClr val="111111"/>
                 </a:solidFill>
               </a:rPr>
-              <a:t>9.158</a:t>
+              <a:t>8.555</a:t>
             </a:r>
           </a:p>
         </p:txBody>
@@ -8045,7 +8072,7 @@
           <p:cNvPr id="36" name="">
             <a:extLst xmlns:a="http://schemas.openxmlformats.org/drawingml/2006/main">
               <a:ext uri="{FF2B5EF4-FFF2-40B4-BE49-F238E27FC236}">
-                <a16:creationId xmlns:a16="http://schemas.microsoft.com/office/drawing/2014/main" id="{79830468-B818-4698-A921-39209D33DE9D}"/>
+                <a16:creationId xmlns:a16="http://schemas.microsoft.com/office/drawing/2014/main" id="{812ED0DE-346B-4E7F-A8F6-10BF13CC5C7A}"/>
               </a:ext>
             </a:extLst>
           </p:cNvPr>
@@ -8078,7 +8105,7 @@
           <p:cNvPr id="37" name="">
             <a:extLst xmlns:a="http://schemas.openxmlformats.org/drawingml/2006/main">
               <a:ext uri="{FF2B5EF4-FFF2-40B4-BE49-F238E27FC236}">
-                <a16:creationId xmlns:a16="http://schemas.microsoft.com/office/drawing/2014/main" id="{E77805C7-E01F-4210-8EDD-46FA4122512C}"/>
+                <a16:creationId xmlns:a16="http://schemas.microsoft.com/office/drawing/2014/main" id="{0AAF58EB-CBC2-4482-A277-5D43370681E6}"/>
               </a:ext>
             </a:extLst>
           </p:cNvPr>
@@ -8128,7 +8155,7 @@
           <p:cNvPr id="38" name="">
             <a:extLst xmlns:a="http://schemas.openxmlformats.org/drawingml/2006/main">
               <a:ext uri="{FF2B5EF4-FFF2-40B4-BE49-F238E27FC236}">
-                <a16:creationId xmlns:a16="http://schemas.microsoft.com/office/drawing/2014/main" id="{5E4D006A-B7EF-4417-AD5D-D740AA226B06}"/>
+                <a16:creationId xmlns:a16="http://schemas.microsoft.com/office/drawing/2014/main" id="{2350C528-7074-4D3C-8AFD-5A9110D5D33B}"/>
               </a:ext>
             </a:extLst>
           </p:cNvPr>
@@ -8161,7 +8188,7 @@
           <p:cNvPr id="39" name="">
             <a:extLst xmlns:a="http://schemas.openxmlformats.org/drawingml/2006/main">
               <a:ext uri="{FF2B5EF4-FFF2-40B4-BE49-F238E27FC236}">
-                <a16:creationId xmlns:a16="http://schemas.microsoft.com/office/drawing/2014/main" id="{F2AA2036-3B77-4A5A-BF37-E882137EC7C6}"/>
+                <a16:creationId xmlns:a16="http://schemas.microsoft.com/office/drawing/2014/main" id="{17A3DE03-90C5-4298-9180-5F83ED97F58D}"/>
               </a:ext>
             </a:extLst>
           </p:cNvPr>
@@ -8201,7 +8228,7 @@
                   <a:srgbClr val="111111"/>
                 </a:solidFill>
               </a:rPr>
-              <a:t>Data Analyst</a:t>
+              <a:t>Data Analyst (US REMOTE)</a:t>
             </a:r>
           </a:p>
         </p:txBody>
@@ -8211,7 +8238,7 @@
           <p:cNvPr id="40" name="">
             <a:extLst xmlns:a="http://schemas.openxmlformats.org/drawingml/2006/main">
               <a:ext uri="{FF2B5EF4-FFF2-40B4-BE49-F238E27FC236}">
-                <a16:creationId xmlns:a16="http://schemas.microsoft.com/office/drawing/2014/main" id="{24758123-A94A-4B9F-BB38-4896306B8AA0}"/>
+                <a16:creationId xmlns:a16="http://schemas.microsoft.com/office/drawing/2014/main" id="{4FE910EE-CA46-4411-A2AB-7C11C73DD203}"/>
               </a:ext>
             </a:extLst>
           </p:cNvPr>
@@ -8244,7 +8271,7 @@
           <p:cNvPr id="41" name="">
             <a:extLst xmlns:a="http://schemas.openxmlformats.org/drawingml/2006/main">
               <a:ext uri="{FF2B5EF4-FFF2-40B4-BE49-F238E27FC236}">
-                <a16:creationId xmlns:a16="http://schemas.microsoft.com/office/drawing/2014/main" id="{01BAE681-A575-49A2-9CF9-A2825653FD49}"/>
+                <a16:creationId xmlns:a16="http://schemas.microsoft.com/office/drawing/2014/main" id="{B57D77DB-CABB-4D24-BE22-65FDF9ED7DD4}"/>
               </a:ext>
             </a:extLst>
           </p:cNvPr>
@@ -8284,7 +8311,7 @@
                   <a:srgbClr val="111111"/>
                 </a:solidFill>
               </a:rPr>
-              <a:t>HMP Global</a:t>
+              <a:t>LeanTaaS</a:t>
             </a:r>
           </a:p>
           <a:p xmlns:a="http://schemas.openxmlformats.org/drawingml/2006/main">
@@ -8311,7 +8338,7 @@
           <p:cNvPr id="42" name="">
             <a:extLst xmlns:a="http://schemas.openxmlformats.org/drawingml/2006/main">
               <a:ext uri="{FF2B5EF4-FFF2-40B4-BE49-F238E27FC236}">
-                <a16:creationId xmlns:a16="http://schemas.microsoft.com/office/drawing/2014/main" id="{28ED49AA-FED5-46B3-A1A3-69D12A8BD749}"/>
+                <a16:creationId xmlns:a16="http://schemas.microsoft.com/office/drawing/2014/main" id="{6C11B5ED-45E6-478F-A677-89092317ECCD}"/>
               </a:ext>
             </a:extLst>
           </p:cNvPr>
@@ -8344,7 +8371,7 @@
           <p:cNvPr id="43" name="">
             <a:extLst xmlns:a="http://schemas.openxmlformats.org/drawingml/2006/main">
               <a:ext uri="{FF2B5EF4-FFF2-40B4-BE49-F238E27FC236}">
-                <a16:creationId xmlns:a16="http://schemas.microsoft.com/office/drawing/2014/main" id="{FCB35FD3-44AC-41E7-A984-58AD7F4D9C16}"/>
+                <a16:creationId xmlns:a16="http://schemas.microsoft.com/office/drawing/2014/main" id="{577A6619-D398-4786-A54D-D930873DF1E4}"/>
               </a:ext>
             </a:extLst>
           </p:cNvPr>
@@ -8394,7 +8421,7 @@
           <p:cNvPr id="44" name="">
             <a:extLst xmlns:a="http://schemas.openxmlformats.org/drawingml/2006/main">
               <a:ext uri="{FF2B5EF4-FFF2-40B4-BE49-F238E27FC236}">
-                <a16:creationId xmlns:a16="http://schemas.microsoft.com/office/drawing/2014/main" id="{5C9117C7-CC35-4D46-993D-D89E5240D8AD}"/>
+                <a16:creationId xmlns:a16="http://schemas.microsoft.com/office/drawing/2014/main" id="{29A2C49B-B0DF-4862-94BC-5D3FAA0F7358}"/>
               </a:ext>
             </a:extLst>
           </p:cNvPr>
@@ -8427,7 +8454,7 @@
           <p:cNvPr id="45" name="">
             <a:extLst xmlns:a="http://schemas.openxmlformats.org/drawingml/2006/main">
               <a:ext uri="{FF2B5EF4-FFF2-40B4-BE49-F238E27FC236}">
-                <a16:creationId xmlns:a16="http://schemas.microsoft.com/office/drawing/2014/main" id="{E7C469BF-F909-4BAF-AA20-593071A7DFD0}"/>
+                <a16:creationId xmlns:a16="http://schemas.microsoft.com/office/drawing/2014/main" id="{CF4D4667-AEF4-4E10-B2B8-D3661C74FA9E}"/>
               </a:ext>
             </a:extLst>
           </p:cNvPr>
@@ -8467,7 +8494,7 @@
                   <a:srgbClr val="111111"/>
                 </a:solidFill>
               </a:rPr>
-              <a:t>9.055</a:t>
+              <a:t>8.458</a:t>
             </a:r>
           </a:p>
         </p:txBody>
@@ -8477,7 +8504,7 @@
           <p:cNvPr id="46" name="">
             <a:extLst xmlns:a="http://schemas.openxmlformats.org/drawingml/2006/main">
               <a:ext uri="{FF2B5EF4-FFF2-40B4-BE49-F238E27FC236}">
-                <a16:creationId xmlns:a16="http://schemas.microsoft.com/office/drawing/2014/main" id="{B00CB438-D76C-4BDC-9F47-E6C304CD3F4D}"/>
+                <a16:creationId xmlns:a16="http://schemas.microsoft.com/office/drawing/2014/main" id="{0C100B31-3D8B-4C27-A604-04ACCA975C80}"/>
               </a:ext>
             </a:extLst>
           </p:cNvPr>
@@ -8527,7 +8554,7 @@
           <p:cNvPr id="47" name="">
             <a:extLst xmlns:a="http://schemas.openxmlformats.org/drawingml/2006/main">
               <a:ext uri="{FF2B5EF4-FFF2-40B4-BE49-F238E27FC236}">
-                <a16:creationId xmlns:a16="http://schemas.microsoft.com/office/drawing/2014/main" id="{3CF03E76-AD35-4194-9D9A-424D799C4F3A}"/>
+                <a16:creationId xmlns:a16="http://schemas.microsoft.com/office/drawing/2014/main" id="{60DE570F-94AD-4586-82A1-448B12AB3037}"/>
               </a:ext>
             </a:extLst>
           </p:cNvPr>
@@ -8575,7 +8602,7 @@
     </p:spTree>
     <p:extLst>
       <p:ext uri="{BB962C8B-B14F-4D97-AF65-F5344CB8AC3E}">
-        <p14:creationId xmlns:p14="http://schemas.microsoft.com/office/powerpoint/2010/main" val="200567581"/>
+        <p14:creationId xmlns:p14="http://schemas.microsoft.com/office/powerpoint/2010/main" val="1987706254"/>
       </p:ext>
     </p:extLst>
   </p:cSld>
@@ -8606,7 +8633,7 @@
           <p:cNvPr id="19" name="slide-7-title">
             <a:extLst xmlns:a="http://schemas.openxmlformats.org/drawingml/2006/main">
               <a:ext uri="{FF2B5EF4-FFF2-40B4-BE49-F238E27FC236}">
-                <a16:creationId xmlns:a16="http://schemas.microsoft.com/office/drawing/2014/main" id="{091F933D-5BC1-4592-AB3C-F7FB5764A93D}"/>
+                <a16:creationId xmlns:a16="http://schemas.microsoft.com/office/drawing/2014/main" id="{B3E839F6-608F-46CC-84F7-8CF9849D6B07}"/>
               </a:ext>
             </a:extLst>
           </p:cNvPr>
@@ -8656,7 +8683,7 @@
           <p:cNvPr id="2" name="">
             <a:extLst xmlns:a="http://schemas.openxmlformats.org/drawingml/2006/main">
               <a:ext uri="{FF2B5EF4-FFF2-40B4-BE49-F238E27FC236}">
-                <a16:creationId xmlns:a16="http://schemas.microsoft.com/office/drawing/2014/main" id="{98665034-DB1F-4CD8-8807-77A2227DB764}"/>
+                <a16:creationId xmlns:a16="http://schemas.microsoft.com/office/drawing/2014/main" id="{320A38DA-AD94-425B-A94E-56532319943C}"/>
               </a:ext>
             </a:extLst>
           </p:cNvPr>
@@ -8728,7 +8755,7 @@
           <p:cNvPr id="4" name="">
             <a:extLst xmlns:a="http://schemas.openxmlformats.org/drawingml/2006/main">
               <a:ext uri="{FF2B5EF4-FFF2-40B4-BE49-F238E27FC236}">
-                <a16:creationId xmlns:a16="http://schemas.microsoft.com/office/drawing/2014/main" id="{A2B20156-63F0-4307-AB7F-B65B5A4E7D3F}"/>
+                <a16:creationId xmlns:a16="http://schemas.microsoft.com/office/drawing/2014/main" id="{E6C7CC2B-93F4-4DF7-AE5A-E8C1FF11FBD4}"/>
               </a:ext>
             </a:extLst>
           </p:cNvPr>
@@ -8778,7 +8805,7 @@
           <p:cNvPr id="5" name="">
             <a:extLst xmlns:a="http://schemas.openxmlformats.org/drawingml/2006/main">
               <a:ext uri="{FF2B5EF4-FFF2-40B4-BE49-F238E27FC236}">
-                <a16:creationId xmlns:a16="http://schemas.microsoft.com/office/drawing/2014/main" id="{BA2ACA95-FE86-47ED-AC77-7B31D09BBFC6}"/>
+                <a16:creationId xmlns:a16="http://schemas.microsoft.com/office/drawing/2014/main" id="{10933025-B9DF-4876-AE56-4708B0F5A4B8}"/>
               </a:ext>
             </a:extLst>
           </p:cNvPr>
@@ -8828,7 +8855,7 @@
           <p:cNvPr id="6" name="">
             <a:extLst xmlns:a="http://schemas.openxmlformats.org/drawingml/2006/main">
               <a:ext uri="{FF2B5EF4-FFF2-40B4-BE49-F238E27FC236}">
-                <a16:creationId xmlns:a16="http://schemas.microsoft.com/office/drawing/2014/main" id="{F8F4DC61-1541-4E0A-A1DB-28AF26C7CEB4}"/>
+                <a16:creationId xmlns:a16="http://schemas.microsoft.com/office/drawing/2014/main" id="{729CA1B6-E3CE-489A-B5A2-44F7E0999D55}"/>
               </a:ext>
             </a:extLst>
           </p:cNvPr>
@@ -8900,7 +8927,7 @@
           <p:cNvPr id="8" name="">
             <a:extLst xmlns:a="http://schemas.openxmlformats.org/drawingml/2006/main">
               <a:ext uri="{FF2B5EF4-FFF2-40B4-BE49-F238E27FC236}">
-                <a16:creationId xmlns:a16="http://schemas.microsoft.com/office/drawing/2014/main" id="{B368BC0F-EB2A-4399-AD92-9AA5737ABED0}"/>
+                <a16:creationId xmlns:a16="http://schemas.microsoft.com/office/drawing/2014/main" id="{693B3206-BBDF-4DAE-A1B1-02F7A4FB4759}"/>
               </a:ext>
             </a:extLst>
           </p:cNvPr>
@@ -8950,7 +8977,7 @@
           <p:cNvPr id="9" name="">
             <a:extLst xmlns:a="http://schemas.openxmlformats.org/drawingml/2006/main">
               <a:ext uri="{FF2B5EF4-FFF2-40B4-BE49-F238E27FC236}">
-                <a16:creationId xmlns:a16="http://schemas.microsoft.com/office/drawing/2014/main" id="{C6B0344E-BC56-4736-8D2E-C9AC5E9EE80E}"/>
+                <a16:creationId xmlns:a16="http://schemas.microsoft.com/office/drawing/2014/main" id="{A25A3BD3-5B3F-44D9-9118-1950E2ACEC8D}"/>
               </a:ext>
             </a:extLst>
           </p:cNvPr>
@@ -9000,7 +9027,7 @@
           <p:cNvPr id="10" name="">
             <a:extLst xmlns:a="http://schemas.openxmlformats.org/drawingml/2006/main">
               <a:ext uri="{FF2B5EF4-FFF2-40B4-BE49-F238E27FC236}">
-                <a16:creationId xmlns:a16="http://schemas.microsoft.com/office/drawing/2014/main" id="{B48D3C2D-407E-4ADE-B40B-3C374C11CBD8}"/>
+                <a16:creationId xmlns:a16="http://schemas.microsoft.com/office/drawing/2014/main" id="{7F0BB7E1-2E13-4FB9-AFE3-AC669B56B6F0}"/>
               </a:ext>
             </a:extLst>
           </p:cNvPr>
@@ -9072,7 +9099,7 @@
           <p:cNvPr id="12" name="">
             <a:extLst xmlns:a="http://schemas.openxmlformats.org/drawingml/2006/main">
               <a:ext uri="{FF2B5EF4-FFF2-40B4-BE49-F238E27FC236}">
-                <a16:creationId xmlns:a16="http://schemas.microsoft.com/office/drawing/2014/main" id="{9C2D426D-2CDE-4E06-8337-7E870BDEB5DA}"/>
+                <a16:creationId xmlns:a16="http://schemas.microsoft.com/office/drawing/2014/main" id="{84882666-417C-486E-BB5D-6249C6F58C8E}"/>
               </a:ext>
             </a:extLst>
           </p:cNvPr>
@@ -9122,7 +9149,7 @@
           <p:cNvPr id="13" name="">
             <a:extLst xmlns:a="http://schemas.openxmlformats.org/drawingml/2006/main">
               <a:ext uri="{FF2B5EF4-FFF2-40B4-BE49-F238E27FC236}">
-                <a16:creationId xmlns:a16="http://schemas.microsoft.com/office/drawing/2014/main" id="{D0C86821-BA00-413D-A61A-8F8C50999A4E}"/>
+                <a16:creationId xmlns:a16="http://schemas.microsoft.com/office/drawing/2014/main" id="{192F06C7-67A6-438D-87C3-E303A6E5D390}"/>
               </a:ext>
             </a:extLst>
           </p:cNvPr>
@@ -9172,7 +9199,7 @@
           <p:cNvPr id="14" name="">
             <a:extLst xmlns:a="http://schemas.openxmlformats.org/drawingml/2006/main">
               <a:ext uri="{FF2B5EF4-FFF2-40B4-BE49-F238E27FC236}">
-                <a16:creationId xmlns:a16="http://schemas.microsoft.com/office/drawing/2014/main" id="{13EFE464-4BA9-4E59-9328-AB748EE6798A}"/>
+                <a16:creationId xmlns:a16="http://schemas.microsoft.com/office/drawing/2014/main" id="{7BF329B4-DF55-4AAC-8343-2858082F6713}"/>
               </a:ext>
             </a:extLst>
           </p:cNvPr>
@@ -9244,7 +9271,7 @@
           <p:cNvPr id="16" name="">
             <a:extLst xmlns:a="http://schemas.openxmlformats.org/drawingml/2006/main">
               <a:ext uri="{FF2B5EF4-FFF2-40B4-BE49-F238E27FC236}">
-                <a16:creationId xmlns:a16="http://schemas.microsoft.com/office/drawing/2014/main" id="{036DC565-D5DE-448A-9CA5-22F3A7B1BB18}"/>
+                <a16:creationId xmlns:a16="http://schemas.microsoft.com/office/drawing/2014/main" id="{60AA8FB5-202F-4F25-8C0F-0B84B879E789}"/>
               </a:ext>
             </a:extLst>
           </p:cNvPr>
@@ -9294,7 +9321,7 @@
           <p:cNvPr id="17" name="">
             <a:extLst xmlns:a="http://schemas.openxmlformats.org/drawingml/2006/main">
               <a:ext uri="{FF2B5EF4-FFF2-40B4-BE49-F238E27FC236}">
-                <a16:creationId xmlns:a16="http://schemas.microsoft.com/office/drawing/2014/main" id="{DEC91FC9-24F9-4EDE-98C4-82571609461A}"/>
+                <a16:creationId xmlns:a16="http://schemas.microsoft.com/office/drawing/2014/main" id="{FCB8A475-40F1-49E9-9DB2-9D2775DD57C6}"/>
               </a:ext>
             </a:extLst>
           </p:cNvPr>
@@ -9344,7 +9371,7 @@
           <p:cNvPr id="18" name="">
             <a:extLst xmlns:a="http://schemas.openxmlformats.org/drawingml/2006/main">
               <a:ext uri="{FF2B5EF4-FFF2-40B4-BE49-F238E27FC236}">
-                <a16:creationId xmlns:a16="http://schemas.microsoft.com/office/drawing/2014/main" id="{9C0CA84B-D53C-4B47-AECB-168B0E38A25B}"/>
+                <a16:creationId xmlns:a16="http://schemas.microsoft.com/office/drawing/2014/main" id="{D5ECE6FB-D1FD-413E-98BD-5C2D38363499}"/>
               </a:ext>
             </a:extLst>
           </p:cNvPr>
@@ -9392,7 +9419,7 @@
     </p:spTree>
     <p:extLst>
       <p:ext uri="{BB962C8B-B14F-4D97-AF65-F5344CB8AC3E}">
-        <p14:creationId xmlns:p14="http://schemas.microsoft.com/office/powerpoint/2010/main" val="1810016524"/>
+        <p14:creationId xmlns:p14="http://schemas.microsoft.com/office/powerpoint/2010/main" val="954316157"/>
       </p:ext>
     </p:extLst>
   </p:cSld>
@@ -9423,7 +9450,7 @@
           <p:cNvPr id="14" name="slide-8-title">
             <a:extLst xmlns:a="http://schemas.openxmlformats.org/drawingml/2006/main">
               <a:ext uri="{FF2B5EF4-FFF2-40B4-BE49-F238E27FC236}">
-                <a16:creationId xmlns:a16="http://schemas.microsoft.com/office/drawing/2014/main" id="{E3F2AD5F-21F7-4F0F-9526-2B06FE935442}"/>
+                <a16:creationId xmlns:a16="http://schemas.microsoft.com/office/drawing/2014/main" id="{A5470B4D-091E-411A-AA4F-BD8003C87482}"/>
               </a:ext>
             </a:extLst>
           </p:cNvPr>
@@ -9473,7 +9500,7 @@
           <p:cNvPr id="2" name="">
             <a:extLst xmlns:a="http://schemas.openxmlformats.org/drawingml/2006/main">
               <a:ext uri="{FF2B5EF4-FFF2-40B4-BE49-F238E27FC236}">
-                <a16:creationId xmlns:a16="http://schemas.microsoft.com/office/drawing/2014/main" id="{B5198B38-BB30-4CC6-B9E8-299AA8B3D476}"/>
+                <a16:creationId xmlns:a16="http://schemas.microsoft.com/office/drawing/2014/main" id="{E0AE6280-9389-4B21-BAB8-AEE2041757F2}"/>
               </a:ext>
             </a:extLst>
           </p:cNvPr>
@@ -9530,7 +9557,7 @@
         </p:xfrm>
         <a:graphic xmlns:a="http://schemas.openxmlformats.org/drawingml/2006/main">
           <a:graphicData uri="http://schemas.openxmlformats.org/drawingml/2006/chart">
-            <c:chart xmlns:r="http://schemas.openxmlformats.org/officeDocument/2006/relationships" xmlns:c="http://schemas.openxmlformats.org/drawingml/2006/chart" r:id="Rb6f73d105ae94c4c"/>
+            <c:chart xmlns:r="http://schemas.openxmlformats.org/officeDocument/2006/relationships" xmlns:c="http://schemas.openxmlformats.org/drawingml/2006/chart" r:id="R0d58690ec5f84273"/>
           </a:graphicData>
         </a:graphic>
       </p:graphicFrame>
@@ -9539,7 +9566,7 @@
           <p:cNvPr id="4" name="">
             <a:extLst xmlns:a="http://schemas.openxmlformats.org/drawingml/2006/main">
               <a:ext uri="{FF2B5EF4-FFF2-40B4-BE49-F238E27FC236}">
-                <a16:creationId xmlns:a16="http://schemas.microsoft.com/office/drawing/2014/main" id="{B5E8CBBA-279C-4C88-9F15-93C6FD701CCB}"/>
+                <a16:creationId xmlns:a16="http://schemas.microsoft.com/office/drawing/2014/main" id="{41B1DBA8-2FA4-4771-A594-3D0219E3C1C7}"/>
               </a:ext>
             </a:extLst>
           </p:cNvPr>
@@ -9570,7 +9597,7 @@
           <p:cNvPr id="5" name="">
             <a:extLst xmlns:a="http://schemas.openxmlformats.org/drawingml/2006/main">
               <a:ext uri="{FF2B5EF4-FFF2-40B4-BE49-F238E27FC236}">
-                <a16:creationId xmlns:a16="http://schemas.microsoft.com/office/drawing/2014/main" id="{AAD007AE-5502-43F3-B334-ED20468C785B}"/>
+                <a16:creationId xmlns:a16="http://schemas.microsoft.com/office/drawing/2014/main" id="{DD0AADE9-214C-43BB-BFFB-5B54A16E564A}"/>
               </a:ext>
             </a:extLst>
           </p:cNvPr>
@@ -9620,7 +9647,7 @@
           <p:cNvPr id="6" name="">
             <a:extLst xmlns:a="http://schemas.openxmlformats.org/drawingml/2006/main">
               <a:ext uri="{FF2B5EF4-FFF2-40B4-BE49-F238E27FC236}">
-                <a16:creationId xmlns:a16="http://schemas.microsoft.com/office/drawing/2014/main" id="{0655D210-D43B-4B0D-A283-0C2C37ED7264}"/>
+                <a16:creationId xmlns:a16="http://schemas.microsoft.com/office/drawing/2014/main" id="{489807DC-B5B7-4629-8183-A28556CC27AF}"/>
               </a:ext>
             </a:extLst>
           </p:cNvPr>
@@ -9670,7 +9697,7 @@
           <p:cNvPr id="7" name="">
             <a:extLst xmlns:a="http://schemas.openxmlformats.org/drawingml/2006/main">
               <a:ext uri="{FF2B5EF4-FFF2-40B4-BE49-F238E27FC236}">
-                <a16:creationId xmlns:a16="http://schemas.microsoft.com/office/drawing/2014/main" id="{A01C8EF9-AB3C-473C-AEE8-7C5C315ADC09}"/>
+                <a16:creationId xmlns:a16="http://schemas.microsoft.com/office/drawing/2014/main" id="{21C60EF5-BFF6-4296-97B3-BA2A086450E1}"/>
               </a:ext>
             </a:extLst>
           </p:cNvPr>
@@ -9701,7 +9728,7 @@
           <p:cNvPr id="8" name="">
             <a:extLst xmlns:a="http://schemas.openxmlformats.org/drawingml/2006/main">
               <a:ext uri="{FF2B5EF4-FFF2-40B4-BE49-F238E27FC236}">
-                <a16:creationId xmlns:a16="http://schemas.microsoft.com/office/drawing/2014/main" id="{F02AEDF4-24E1-4A12-A8E0-E46626B03614}"/>
+                <a16:creationId xmlns:a16="http://schemas.microsoft.com/office/drawing/2014/main" id="{0131AD0D-E9E5-4FA2-99D9-4E68C52DF014}"/>
               </a:ext>
             </a:extLst>
           </p:cNvPr>
@@ -9751,7 +9778,7 @@
           <p:cNvPr id="9" name="">
             <a:extLst xmlns:a="http://schemas.openxmlformats.org/drawingml/2006/main">
               <a:ext uri="{FF2B5EF4-FFF2-40B4-BE49-F238E27FC236}">
-                <a16:creationId xmlns:a16="http://schemas.microsoft.com/office/drawing/2014/main" id="{7052226C-573E-4DD0-B3F8-5E4A81B01745}"/>
+                <a16:creationId xmlns:a16="http://schemas.microsoft.com/office/drawing/2014/main" id="{6571ED4E-F983-49F2-84C9-34995004E6F8}"/>
               </a:ext>
             </a:extLst>
           </p:cNvPr>
@@ -9801,7 +9828,7 @@
           <p:cNvPr id="10" name="">
             <a:extLst xmlns:a="http://schemas.openxmlformats.org/drawingml/2006/main">
               <a:ext uri="{FF2B5EF4-FFF2-40B4-BE49-F238E27FC236}">
-                <a16:creationId xmlns:a16="http://schemas.microsoft.com/office/drawing/2014/main" id="{9DC8AAE7-B680-4F91-965D-5FCA3B6E3EF0}"/>
+                <a16:creationId xmlns:a16="http://schemas.microsoft.com/office/drawing/2014/main" id="{477865E5-8FB7-4A03-A811-4134E16DE9A7}"/>
               </a:ext>
             </a:extLst>
           </p:cNvPr>
@@ -9832,7 +9859,7 @@
           <p:cNvPr id="11" name="">
             <a:extLst xmlns:a="http://schemas.openxmlformats.org/drawingml/2006/main">
               <a:ext uri="{FF2B5EF4-FFF2-40B4-BE49-F238E27FC236}">
-                <a16:creationId xmlns:a16="http://schemas.microsoft.com/office/drawing/2014/main" id="{08DEFA1C-CB43-4618-9041-BBD298CCD243}"/>
+                <a16:creationId xmlns:a16="http://schemas.microsoft.com/office/drawing/2014/main" id="{782D1294-9906-4DAE-A692-B430E5685B3C}"/>
               </a:ext>
             </a:extLst>
           </p:cNvPr>
@@ -9882,7 +9909,7 @@
           <p:cNvPr id="12" name="">
             <a:extLst xmlns:a="http://schemas.openxmlformats.org/drawingml/2006/main">
               <a:ext uri="{FF2B5EF4-FFF2-40B4-BE49-F238E27FC236}">
-                <a16:creationId xmlns:a16="http://schemas.microsoft.com/office/drawing/2014/main" id="{96F1E8A9-B9D0-4981-9665-9DF7ED1013DD}"/>
+                <a16:creationId xmlns:a16="http://schemas.microsoft.com/office/drawing/2014/main" id="{C1BD0A56-F759-4672-9578-41E3D167EBA5}"/>
               </a:ext>
             </a:extLst>
           </p:cNvPr>
@@ -9932,7 +9959,7 @@
           <p:cNvPr id="13" name="">
             <a:extLst xmlns:a="http://schemas.openxmlformats.org/drawingml/2006/main">
               <a:ext uri="{FF2B5EF4-FFF2-40B4-BE49-F238E27FC236}">
-                <a16:creationId xmlns:a16="http://schemas.microsoft.com/office/drawing/2014/main" id="{63CB29B5-B62A-4652-8039-E08F6175FB38}"/>
+                <a16:creationId xmlns:a16="http://schemas.microsoft.com/office/drawing/2014/main" id="{2E057E6E-6539-4C5B-99F6-C4BF174B34BE}"/>
               </a:ext>
             </a:extLst>
           </p:cNvPr>
@@ -9980,7 +10007,7 @@
     </p:spTree>
     <p:extLst>
       <p:ext uri="{BB962C8B-B14F-4D97-AF65-F5344CB8AC3E}">
-        <p14:creationId xmlns:p14="http://schemas.microsoft.com/office/powerpoint/2010/main" val="395023855"/>
+        <p14:creationId xmlns:p14="http://schemas.microsoft.com/office/powerpoint/2010/main" val="96942998"/>
       </p:ext>
     </p:extLst>
   </p:cSld>
@@ -10011,7 +10038,7 @@
           <p:cNvPr id="20" name="slide-9-title">
             <a:extLst xmlns:a="http://schemas.openxmlformats.org/drawingml/2006/main">
               <a:ext uri="{FF2B5EF4-FFF2-40B4-BE49-F238E27FC236}">
-                <a16:creationId xmlns:a16="http://schemas.microsoft.com/office/drawing/2014/main" id="{506DBA37-9943-4251-B1E5-31F8FD0D49FB}"/>
+                <a16:creationId xmlns:a16="http://schemas.microsoft.com/office/drawing/2014/main" id="{F2B95DE6-D7F0-40C1-A8B9-A94705E9DF03}"/>
               </a:ext>
             </a:extLst>
           </p:cNvPr>
@@ -10061,7 +10088,7 @@
           <p:cNvPr id="2" name="">
             <a:extLst xmlns:a="http://schemas.openxmlformats.org/drawingml/2006/main">
               <a:ext uri="{FF2B5EF4-FFF2-40B4-BE49-F238E27FC236}">
-                <a16:creationId xmlns:a16="http://schemas.microsoft.com/office/drawing/2014/main" id="{C4635588-8C03-418F-B977-4A0ABED6F47C}"/>
+                <a16:creationId xmlns:a16="http://schemas.microsoft.com/office/drawing/2014/main" id="{ACA13D8A-F0C7-4209-B4D2-221A67BEF8A5}"/>
               </a:ext>
             </a:extLst>
           </p:cNvPr>
@@ -10111,7 +10138,7 @@
           <p:cNvPr id="3" name="">
             <a:extLst xmlns:a="http://schemas.openxmlformats.org/drawingml/2006/main">
               <a:ext uri="{FF2B5EF4-FFF2-40B4-BE49-F238E27FC236}">
-                <a16:creationId xmlns:a16="http://schemas.microsoft.com/office/drawing/2014/main" id="{BFB939B3-C698-4728-8079-E0210C6EB4F5}"/>
+                <a16:creationId xmlns:a16="http://schemas.microsoft.com/office/drawing/2014/main" id="{44D27BE1-056E-49E4-AE47-7F360756E8A2}"/>
               </a:ext>
             </a:extLst>
           </p:cNvPr>
@@ -10161,7 +10188,7 @@
           <p:cNvPr id="4" name="">
             <a:extLst xmlns:a="http://schemas.openxmlformats.org/drawingml/2006/main">
               <a:ext uri="{FF2B5EF4-FFF2-40B4-BE49-F238E27FC236}">
-                <a16:creationId xmlns:a16="http://schemas.microsoft.com/office/drawing/2014/main" id="{90FD37AE-85E6-4710-A612-1D416E07D2D4}"/>
+                <a16:creationId xmlns:a16="http://schemas.microsoft.com/office/drawing/2014/main" id="{B9E5A349-696F-4177-A3D3-52E994E17316}"/>
               </a:ext>
             </a:extLst>
           </p:cNvPr>
@@ -10211,7 +10238,7 @@
           <p:cNvPr id="5" name="">
             <a:extLst xmlns:a="http://schemas.openxmlformats.org/drawingml/2006/main">
               <a:ext uri="{FF2B5EF4-FFF2-40B4-BE49-F238E27FC236}">
-                <a16:creationId xmlns:a16="http://schemas.microsoft.com/office/drawing/2014/main" id="{0211D95D-D2E1-41B2-853D-0537A8FB62CD}"/>
+                <a16:creationId xmlns:a16="http://schemas.microsoft.com/office/drawing/2014/main" id="{600F4043-8773-4A48-9ACD-215D1F0B4ACB}"/>
               </a:ext>
             </a:extLst>
           </p:cNvPr>
@@ -10242,7 +10269,7 @@
           <p:cNvPr id="6" name="">
             <a:extLst xmlns:a="http://schemas.openxmlformats.org/drawingml/2006/main">
               <a:ext uri="{FF2B5EF4-FFF2-40B4-BE49-F238E27FC236}">
-                <a16:creationId xmlns:a16="http://schemas.microsoft.com/office/drawing/2014/main" id="{713D86FF-03AF-4B12-AFDB-4ED5CB479F10}"/>
+                <a16:creationId xmlns:a16="http://schemas.microsoft.com/office/drawing/2014/main" id="{E6243F9B-DE88-4E38-BEEE-7A14F5C23E86}"/>
               </a:ext>
             </a:extLst>
           </p:cNvPr>
@@ -10292,7 +10319,7 @@
           <p:cNvPr id="7" name="">
             <a:extLst xmlns:a="http://schemas.openxmlformats.org/drawingml/2006/main">
               <a:ext uri="{FF2B5EF4-FFF2-40B4-BE49-F238E27FC236}">
-                <a16:creationId xmlns:a16="http://schemas.microsoft.com/office/drawing/2014/main" id="{F7B5326F-5CB4-4D1D-BEC3-21AA7BC2CFD2}"/>
+                <a16:creationId xmlns:a16="http://schemas.microsoft.com/office/drawing/2014/main" id="{11CB641B-D60F-4CCF-8688-9B8F741F4101}"/>
               </a:ext>
             </a:extLst>
           </p:cNvPr>
@@ -10342,7 +10369,7 @@
           <p:cNvPr id="8" name="">
             <a:extLst xmlns:a="http://schemas.openxmlformats.org/drawingml/2006/main">
               <a:ext uri="{FF2B5EF4-FFF2-40B4-BE49-F238E27FC236}">
-                <a16:creationId xmlns:a16="http://schemas.microsoft.com/office/drawing/2014/main" id="{84B440EE-D985-4ACE-88A0-3B09BBF84173}"/>
+                <a16:creationId xmlns:a16="http://schemas.microsoft.com/office/drawing/2014/main" id="{19376139-67B7-428B-8FA1-B8B59789DC5E}"/>
               </a:ext>
             </a:extLst>
           </p:cNvPr>
@@ -10373,7 +10400,7 @@
           <p:cNvPr id="9" name="">
             <a:extLst xmlns:a="http://schemas.openxmlformats.org/drawingml/2006/main">
               <a:ext uri="{FF2B5EF4-FFF2-40B4-BE49-F238E27FC236}">
-                <a16:creationId xmlns:a16="http://schemas.microsoft.com/office/drawing/2014/main" id="{01E4ED2C-6AB5-412E-9E18-97D22BE39DBF}"/>
+                <a16:creationId xmlns:a16="http://schemas.microsoft.com/office/drawing/2014/main" id="{405D4D3C-0A7C-4D34-BF1B-E27541A9BC75}"/>
               </a:ext>
             </a:extLst>
           </p:cNvPr>
@@ -10423,7 +10450,7 @@
           <p:cNvPr id="10" name="">
             <a:extLst xmlns:a="http://schemas.openxmlformats.org/drawingml/2006/main">
               <a:ext uri="{FF2B5EF4-FFF2-40B4-BE49-F238E27FC236}">
-                <a16:creationId xmlns:a16="http://schemas.microsoft.com/office/drawing/2014/main" id="{E2A05BDB-468E-4253-87A1-81CD253DE3AB}"/>
+                <a16:creationId xmlns:a16="http://schemas.microsoft.com/office/drawing/2014/main" id="{174025D3-AD8C-4E53-AEC0-32FF76722A20}"/>
               </a:ext>
             </a:extLst>
           </p:cNvPr>
@@ -10473,7 +10500,7 @@
           <p:cNvPr id="11" name="">
             <a:extLst xmlns:a="http://schemas.openxmlformats.org/drawingml/2006/main">
               <a:ext uri="{FF2B5EF4-FFF2-40B4-BE49-F238E27FC236}">
-                <a16:creationId xmlns:a16="http://schemas.microsoft.com/office/drawing/2014/main" id="{EF0DA4E7-A627-4C48-ABE3-ED5C10A52241}"/>
+                <a16:creationId xmlns:a16="http://schemas.microsoft.com/office/drawing/2014/main" id="{8848C4C7-12F4-4ECE-8CC1-C5D4A1F8B601}"/>
               </a:ext>
             </a:extLst>
           </p:cNvPr>
@@ -10504,7 +10531,7 @@
           <p:cNvPr id="12" name="">
             <a:extLst xmlns:a="http://schemas.openxmlformats.org/drawingml/2006/main">
               <a:ext uri="{FF2B5EF4-FFF2-40B4-BE49-F238E27FC236}">
-                <a16:creationId xmlns:a16="http://schemas.microsoft.com/office/drawing/2014/main" id="{09CCBE48-BEF6-4561-84A1-1BFF43C60C36}"/>
+                <a16:creationId xmlns:a16="http://schemas.microsoft.com/office/drawing/2014/main" id="{9FF50882-40AC-4CEF-8D3A-18038102C319}"/>
               </a:ext>
             </a:extLst>
           </p:cNvPr>
@@ -10554,7 +10581,7 @@
           <p:cNvPr id="13" name="">
             <a:extLst xmlns:a="http://schemas.openxmlformats.org/drawingml/2006/main">
               <a:ext uri="{FF2B5EF4-FFF2-40B4-BE49-F238E27FC236}">
-                <a16:creationId xmlns:a16="http://schemas.microsoft.com/office/drawing/2014/main" id="{278B8014-EC34-46D5-AE32-EC976689250D}"/>
+                <a16:creationId xmlns:a16="http://schemas.microsoft.com/office/drawing/2014/main" id="{0D862D25-6DFE-412C-A953-AE68EB593A6A}"/>
               </a:ext>
             </a:extLst>
           </p:cNvPr>
@@ -10604,7 +10631,7 @@
           <p:cNvPr id="14" name="">
             <a:extLst xmlns:a="http://schemas.openxmlformats.org/drawingml/2006/main">
               <a:ext uri="{FF2B5EF4-FFF2-40B4-BE49-F238E27FC236}">
-                <a16:creationId xmlns:a16="http://schemas.microsoft.com/office/drawing/2014/main" id="{CF382F2B-C0B4-4C92-8688-577F11B444E3}"/>
+                <a16:creationId xmlns:a16="http://schemas.microsoft.com/office/drawing/2014/main" id="{80DFAFC1-11AB-479F-83BD-76BC9F666164}"/>
               </a:ext>
             </a:extLst>
           </p:cNvPr>
@@ -10635,7 +10662,7 @@
           <p:cNvPr id="15" name="">
             <a:extLst xmlns:a="http://schemas.openxmlformats.org/drawingml/2006/main">
               <a:ext uri="{FF2B5EF4-FFF2-40B4-BE49-F238E27FC236}">
-                <a16:creationId xmlns:a16="http://schemas.microsoft.com/office/drawing/2014/main" id="{51F97EEC-1697-417F-8753-61B123F70B75}"/>
+                <a16:creationId xmlns:a16="http://schemas.microsoft.com/office/drawing/2014/main" id="{7F2DDB3F-DD67-4C44-B06A-4423669996E2}"/>
               </a:ext>
             </a:extLst>
           </p:cNvPr>
@@ -10707,7 +10734,7 @@
           <p:cNvPr id="17" name="">
             <a:extLst xmlns:a="http://schemas.openxmlformats.org/drawingml/2006/main">
               <a:ext uri="{FF2B5EF4-FFF2-40B4-BE49-F238E27FC236}">
-                <a16:creationId xmlns:a16="http://schemas.microsoft.com/office/drawing/2014/main" id="{384F3CCE-DC47-4010-9FE2-B297ADAA2A4E}"/>
+                <a16:creationId xmlns:a16="http://schemas.microsoft.com/office/drawing/2014/main" id="{921061CC-3869-4566-9927-138B8B085F40}"/>
               </a:ext>
             </a:extLst>
           </p:cNvPr>
@@ -10757,7 +10784,7 @@
           <p:cNvPr id="18" name="">
             <a:extLst xmlns:a="http://schemas.openxmlformats.org/drawingml/2006/main">
               <a:ext uri="{FF2B5EF4-FFF2-40B4-BE49-F238E27FC236}">
-                <a16:creationId xmlns:a16="http://schemas.microsoft.com/office/drawing/2014/main" id="{419E0488-8B42-4766-B43C-4EC9F14689B7}"/>
+                <a16:creationId xmlns:a16="http://schemas.microsoft.com/office/drawing/2014/main" id="{89A2D58F-E15A-4BE9-B6A3-43D27D84B6D4}"/>
               </a:ext>
             </a:extLst>
           </p:cNvPr>
@@ -10807,7 +10834,7 @@
           <p:cNvPr id="19" name="">
             <a:extLst xmlns:a="http://schemas.openxmlformats.org/drawingml/2006/main">
               <a:ext uri="{FF2B5EF4-FFF2-40B4-BE49-F238E27FC236}">
-                <a16:creationId xmlns:a16="http://schemas.microsoft.com/office/drawing/2014/main" id="{DF4BBDFD-B1E3-4BFC-BE85-9AB05992B955}"/>
+                <a16:creationId xmlns:a16="http://schemas.microsoft.com/office/drawing/2014/main" id="{BD451731-84AD-4A5D-B367-3BE29239EFCF}"/>
               </a:ext>
             </a:extLst>
           </p:cNvPr>
@@ -10847,7 +10874,7 @@
                   <a:srgbClr val="565D67"/>
                 </a:solidFill>
               </a:rPr>
-              <a:t>Prepared validation assets:</a:t>
+              <a:t>Operational validation:</a:t>
             </a:r>
           </a:p>
           <a:p xmlns:a="http://schemas.openxmlformats.org/drawingml/2006/main">
@@ -10864,7 +10891,7 @@
                   <a:srgbClr val="565D67"/>
                 </a:solidFill>
               </a:rPr>
-              <a:t>1,000-row advisor queue</a:t>
+              <a:t>91.6% selective coverage</a:t>
             </a:r>
           </a:p>
           <a:p xmlns:a="http://schemas.openxmlformats.org/drawingml/2006/main">
@@ -10881,7 +10908,7 @@
                   <a:srgbClr val="565D67"/>
                 </a:solidFill>
               </a:rPr>
-              <a:t>430-row authorization benchmark</a:t>
+              <a:t>99.47% retained accuracy</a:t>
             </a:r>
           </a:p>
           <a:p xmlns:a="http://schemas.openxmlformats.org/drawingml/2006/main">
@@ -10898,7 +10925,7 @@
                   <a:srgbClr val="565D67"/>
                 </a:solidFill>
               </a:rPr>
-              <a:t>Time-split macro F1 0.976</a:t>
+              <a:t>36 search results, 0 violations</a:t>
             </a:r>
           </a:p>
         </p:txBody>
@@ -10906,7 +10933,7 @@
     </p:spTree>
     <p:extLst>
       <p:ext uri="{BB962C8B-B14F-4D97-AF65-F5344CB8AC3E}">
-        <p14:creationId xmlns:p14="http://schemas.microsoft.com/office/powerpoint/2010/main" val="1899128089"/>
+        <p14:creationId xmlns:p14="http://schemas.microsoft.com/office/powerpoint/2010/main" val="1364811736"/>
       </p:ext>
     </p:extLst>
   </p:cSld>

</xml_diff>

<commit_message>
Align final presentation with classroom guidance
</commit_message>
<xml_diff>
--- a/slides/MSBA_Job_Matching_Final_Deck.pptx
+++ b/slides/MSBA_Job_Matching_Final_Deck.pptx
@@ -2,22 +2,22 @@
 <file path=ppt/presentation.xml><?xml version="1.0" encoding="utf-8"?>
 <p:presentation xmlns:p="http://schemas.openxmlformats.org/presentationml/2006/main">
   <p:sldMasterIdLst>
-    <p:sldMasterId xmlns:r="http://schemas.openxmlformats.org/officeDocument/2006/relationships" id="2147483648" r:id="R402ffd6e6f63443b"/>
+    <p:sldMasterId xmlns:r="http://schemas.openxmlformats.org/officeDocument/2006/relationships" id="2147483648" r:id="R5a9af1d80c304a53"/>
   </p:sldMasterIdLst>
   <p:notesMasterIdLst>
-    <p:notesMasterId xmlns:r="http://schemas.openxmlformats.org/officeDocument/2006/relationships" r:id="R0f9399f608c54cbd"/>
+    <p:notesMasterId xmlns:r="http://schemas.openxmlformats.org/officeDocument/2006/relationships" r:id="Re23f7da17dea4144"/>
   </p:notesMasterIdLst>
   <p:sldIdLst>
-    <p:sldId xmlns:r="http://schemas.openxmlformats.org/officeDocument/2006/relationships" id="256" r:id="R380b4148d19c4e9f"/>
-    <p:sldId xmlns:r="http://schemas.openxmlformats.org/officeDocument/2006/relationships" id="257" r:id="R773516ebac8a429a"/>
-    <p:sldId xmlns:r="http://schemas.openxmlformats.org/officeDocument/2006/relationships" id="258" r:id="R55820e7ed6fa481e"/>
-    <p:sldId xmlns:r="http://schemas.openxmlformats.org/officeDocument/2006/relationships" id="259" r:id="Rab13876238e3422a"/>
-    <p:sldId xmlns:r="http://schemas.openxmlformats.org/officeDocument/2006/relationships" id="260" r:id="R2cb2c9beee22498b"/>
-    <p:sldId xmlns:r="http://schemas.openxmlformats.org/officeDocument/2006/relationships" id="261" r:id="Rd9461ae9844c41b0"/>
-    <p:sldId xmlns:r="http://schemas.openxmlformats.org/officeDocument/2006/relationships" id="262" r:id="R796a0fe303954684"/>
-    <p:sldId xmlns:r="http://schemas.openxmlformats.org/officeDocument/2006/relationships" id="263" r:id="R6ba7d43c66a84489"/>
-    <p:sldId xmlns:r="http://schemas.openxmlformats.org/officeDocument/2006/relationships" id="264" r:id="Ra3d3647fc3db4000"/>
-    <p:sldId xmlns:r="http://schemas.openxmlformats.org/officeDocument/2006/relationships" id="265" r:id="R9402ffe3f7fe4134"/>
+    <p:sldId xmlns:r="http://schemas.openxmlformats.org/officeDocument/2006/relationships" id="256" r:id="R102dcf91f5c74ecd"/>
+    <p:sldId xmlns:r="http://schemas.openxmlformats.org/officeDocument/2006/relationships" id="257" r:id="Rff192712ad214951"/>
+    <p:sldId xmlns:r="http://schemas.openxmlformats.org/officeDocument/2006/relationships" id="258" r:id="R1125972501be4e7d"/>
+    <p:sldId xmlns:r="http://schemas.openxmlformats.org/officeDocument/2006/relationships" id="259" r:id="R081b191ede1046c2"/>
+    <p:sldId xmlns:r="http://schemas.openxmlformats.org/officeDocument/2006/relationships" id="260" r:id="Ra9e8e2a0a2f34cb7"/>
+    <p:sldId xmlns:r="http://schemas.openxmlformats.org/officeDocument/2006/relationships" id="261" r:id="Rfbdcb05825564ed3"/>
+    <p:sldId xmlns:r="http://schemas.openxmlformats.org/officeDocument/2006/relationships" id="262" r:id="R572638e9f293434c"/>
+    <p:sldId xmlns:r="http://schemas.openxmlformats.org/officeDocument/2006/relationships" id="263" r:id="R724978658f524156"/>
+    <p:sldId xmlns:r="http://schemas.openxmlformats.org/officeDocument/2006/relationships" id="264" r:id="R9920695a6bbb4118"/>
+    <p:sldId xmlns:r="http://schemas.openxmlformats.org/officeDocument/2006/relationships" id="265" r:id="R4e43aeba136f4cdf"/>
   </p:sldIdLst>
   <p:sldSz cx="12192000" cy="6858000"/>
   <p:notesSz cx="6858000" cy="9144000"/>
@@ -1236,7 +1236,7 @@
           <a:lstStyle xmlns:a="http://schemas.openxmlformats.org/drawingml/2006/main"/>
           <a:p xmlns:a="http://schemas.openxmlformats.org/drawingml/2006/main">
             <a:r>
-              <a:t>The final model uses all available training labels and outperforms the 2,000-row LoRA experiment. The lesson is not that linear models always win; it is that data utilization and reproducibility matter for this structured weak-label task.</a:t>
+              <a:t>State the comparison directly. What did not work best was adding model complexity while using only 2,000 weakly labeled rows: LoRA improved on the baseline but stopped at 87.3 percent macro F1. What worked was a word-and-character model trained on all 77,135 deduplicated rows. The lesson is not that linear models always win; it is that data utilization and reproducibility mattered for this structured weak-label task.</a:t>
             </a:r>
           </a:p>
           <a:p xmlns:a="http://schemas.openxmlformats.org/drawingml/2006/main">
@@ -1444,7 +1444,7 @@
   </p:cSld>
   <p:clrMap bg1="lt1" tx1="dk1" bg2="lt2" tx2="dk2" accent1="accent1" accent2="accent2" accent3="accent3" accent4="accent4" accent5="accent5" accent6="accent6" hlink="hlink" folHlink="folHlink"/>
   <p:sldLayoutIdLst>
-    <p:sldLayoutId xmlns:r="http://schemas.openxmlformats.org/officeDocument/2006/relationships" id="2147483649" r:id="Rfaa8e09e0e7245d2"/>
+    <p:sldLayoutId xmlns:r="http://schemas.openxmlformats.org/officeDocument/2006/relationships" id="2147483649" r:id="Ref499be4c95144be"/>
   </p:sldLayoutIdLst>
   <p:txStyles>
     <p:titleStyle>
@@ -2217,7 +2217,7 @@
           <p:cNvPr id="7" name="">
             <a:extLst xmlns:a="http://schemas.openxmlformats.org/drawingml/2006/main">
               <a:ext uri="{FF2B5EF4-FFF2-40B4-BE49-F238E27FC236}">
-                <a16:creationId xmlns:a16="http://schemas.microsoft.com/office/drawing/2014/main" id="{C74AF767-063B-4F71-A935-4BE24E367522}"/>
+                <a16:creationId xmlns:a16="http://schemas.microsoft.com/office/drawing/2014/main" id="{F3E04B4E-3600-49D9-A886-0784CCC4C281}"/>
               </a:ext>
             </a:extLst>
           </p:cNvPr>
@@ -2267,7 +2267,7 @@
           <p:cNvPr id="2" name="">
             <a:extLst xmlns:a="http://schemas.openxmlformats.org/drawingml/2006/main">
               <a:ext uri="{FF2B5EF4-FFF2-40B4-BE49-F238E27FC236}">
-                <a16:creationId xmlns:a16="http://schemas.microsoft.com/office/drawing/2014/main" id="{6E31CCCD-59CD-4867-8DC9-AE039A075C23}"/>
+                <a16:creationId xmlns:a16="http://schemas.microsoft.com/office/drawing/2014/main" id="{2270C986-0EE4-4CB0-BA39-94B31EDDD5B4}"/>
               </a:ext>
             </a:extLst>
           </p:cNvPr>
@@ -2317,7 +2317,7 @@
           <p:cNvPr id="3" name="">
             <a:extLst xmlns:a="http://schemas.openxmlformats.org/drawingml/2006/main">
               <a:ext uri="{FF2B5EF4-FFF2-40B4-BE49-F238E27FC236}">
-                <a16:creationId xmlns:a16="http://schemas.microsoft.com/office/drawing/2014/main" id="{6B9DBE47-225E-4FDE-84A1-DF97314EFF10}"/>
+                <a16:creationId xmlns:a16="http://schemas.microsoft.com/office/drawing/2014/main" id="{4BFA4D41-0C5A-44F7-B771-FAEEE046EF87}"/>
               </a:ext>
             </a:extLst>
           </p:cNvPr>
@@ -2367,7 +2367,7 @@
           <p:cNvPr id="4" name="">
             <a:extLst xmlns:a="http://schemas.openxmlformats.org/drawingml/2006/main">
               <a:ext uri="{FF2B5EF4-FFF2-40B4-BE49-F238E27FC236}">
-                <a16:creationId xmlns:a16="http://schemas.microsoft.com/office/drawing/2014/main" id="{144360CE-0AEF-488B-90BD-58AF82E12978}"/>
+                <a16:creationId xmlns:a16="http://schemas.microsoft.com/office/drawing/2014/main" id="{76F47023-ED47-4A13-9912-1334FE517C6E}"/>
               </a:ext>
             </a:extLst>
           </p:cNvPr>
@@ -2417,7 +2417,7 @@
           <p:cNvPr id="5" name="">
             <a:extLst xmlns:a="http://schemas.openxmlformats.org/drawingml/2006/main">
               <a:ext uri="{FF2B5EF4-FFF2-40B4-BE49-F238E27FC236}">
-                <a16:creationId xmlns:a16="http://schemas.microsoft.com/office/drawing/2014/main" id="{DD50F8FD-B3B6-40FA-9489-B27778E7CFFC}"/>
+                <a16:creationId xmlns:a16="http://schemas.microsoft.com/office/drawing/2014/main" id="{A736A72D-E24E-4796-A710-1C068625D635}"/>
               </a:ext>
             </a:extLst>
           </p:cNvPr>
@@ -2429,7 +2429,7 @@
         <p:spPr>
           <a:xfrm xmlns:a="http://schemas.openxmlformats.org/drawingml/2006/main">
             <a:off x="400050" y="5772150"/>
-            <a:ext cx="4000500" cy="323850"/>
+            <a:ext cx="4953000" cy="323850"/>
           </a:xfrm>
           <a:prstGeom xmlns:a="http://schemas.openxmlformats.org/drawingml/2006/main" prst="rect">
             <a:avLst/>
@@ -2457,7 +2457,7 @@
                   <a:srgbClr val="3D8DFF"/>
                 </a:solidFill>
               </a:rPr>
-              <a:t>Yitong Wang</a:t>
+              <a:t>Yitong Wang | Zhike Yan</a:t>
             </a:r>
           </a:p>
         </p:txBody>
@@ -2467,7 +2467,7 @@
           <p:cNvPr id="6" name="">
             <a:extLst xmlns:a="http://schemas.openxmlformats.org/drawingml/2006/main">
               <a:ext uri="{FF2B5EF4-FFF2-40B4-BE49-F238E27FC236}">
-                <a16:creationId xmlns:a16="http://schemas.microsoft.com/office/drawing/2014/main" id="{B6E20067-4C4D-4A79-B153-F4B7F78C9152}"/>
+                <a16:creationId xmlns:a16="http://schemas.microsoft.com/office/drawing/2014/main" id="{40E0EF13-E5B4-4DA0-9EE5-35C6F3EDAAA3}"/>
               </a:ext>
             </a:extLst>
           </p:cNvPr>
@@ -2515,7 +2515,7 @@
     </p:spTree>
     <p:extLst>
       <p:ext uri="{BB962C8B-B14F-4D97-AF65-F5344CB8AC3E}">
-        <p14:creationId xmlns:p14="http://schemas.microsoft.com/office/powerpoint/2010/main" val="1119737524"/>
+        <p14:creationId xmlns:p14="http://schemas.microsoft.com/office/powerpoint/2010/main" val="1790500452"/>
       </p:ext>
     </p:extLst>
   </p:cSld>
@@ -2546,7 +2546,7 @@
           <p:cNvPr id="10" name="">
             <a:extLst xmlns:a="http://schemas.openxmlformats.org/drawingml/2006/main">
               <a:ext uri="{FF2B5EF4-FFF2-40B4-BE49-F238E27FC236}">
-                <a16:creationId xmlns:a16="http://schemas.microsoft.com/office/drawing/2014/main" id="{F59C3466-F714-43B2-858A-5DDE1AC2217F}"/>
+                <a16:creationId xmlns:a16="http://schemas.microsoft.com/office/drawing/2014/main" id="{74BC5564-739B-41BB-9B0D-BEBF7B46599F}"/>
               </a:ext>
             </a:extLst>
           </p:cNvPr>
@@ -2596,7 +2596,7 @@
           <p:cNvPr id="2" name="">
             <a:extLst xmlns:a="http://schemas.openxmlformats.org/drawingml/2006/main">
               <a:ext uri="{FF2B5EF4-FFF2-40B4-BE49-F238E27FC236}">
-                <a16:creationId xmlns:a16="http://schemas.microsoft.com/office/drawing/2014/main" id="{591AE283-7315-47A8-ABF9-7768EE82D848}"/>
+                <a16:creationId xmlns:a16="http://schemas.microsoft.com/office/drawing/2014/main" id="{8664B6EC-F5BF-4E10-AD47-71FE4BC47801}"/>
               </a:ext>
             </a:extLst>
           </p:cNvPr>
@@ -2668,7 +2668,7 @@
           <p:cNvPr id="4" name="">
             <a:extLst xmlns:a="http://schemas.openxmlformats.org/drawingml/2006/main">
               <a:ext uri="{FF2B5EF4-FFF2-40B4-BE49-F238E27FC236}">
-                <a16:creationId xmlns:a16="http://schemas.microsoft.com/office/drawing/2014/main" id="{14BEECE4-97ED-495A-A8DB-ACAB4E6F5768}"/>
+                <a16:creationId xmlns:a16="http://schemas.microsoft.com/office/drawing/2014/main" id="{9554C779-D39F-494B-81D3-DF38B3D94F78}"/>
               </a:ext>
             </a:extLst>
           </p:cNvPr>
@@ -2718,7 +2718,7 @@
           <p:cNvPr id="5" name="">
             <a:extLst xmlns:a="http://schemas.openxmlformats.org/drawingml/2006/main">
               <a:ext uri="{FF2B5EF4-FFF2-40B4-BE49-F238E27FC236}">
-                <a16:creationId xmlns:a16="http://schemas.microsoft.com/office/drawing/2014/main" id="{FB8019CD-B837-43CF-8729-BF0FF31A2861}"/>
+                <a16:creationId xmlns:a16="http://schemas.microsoft.com/office/drawing/2014/main" id="{D31D12CA-BE6F-49E4-ACE3-E5CB071FC7A9}"/>
               </a:ext>
             </a:extLst>
           </p:cNvPr>
@@ -2836,7 +2836,7 @@
           <p:cNvPr id="6" name="">
             <a:extLst xmlns:a="http://schemas.openxmlformats.org/drawingml/2006/main">
               <a:ext uri="{FF2B5EF4-FFF2-40B4-BE49-F238E27FC236}">
-                <a16:creationId xmlns:a16="http://schemas.microsoft.com/office/drawing/2014/main" id="{C0075C76-1116-45FA-A308-E2EED8718507}"/>
+                <a16:creationId xmlns:a16="http://schemas.microsoft.com/office/drawing/2014/main" id="{22151C94-ADF8-45F7-AFF8-45F9D9CFCD3D}"/>
               </a:ext>
             </a:extLst>
           </p:cNvPr>
@@ -2867,7 +2867,7 @@
           <p:cNvPr id="7" name="">
             <a:extLst xmlns:a="http://schemas.openxmlformats.org/drawingml/2006/main">
               <a:ext uri="{FF2B5EF4-FFF2-40B4-BE49-F238E27FC236}">
-                <a16:creationId xmlns:a16="http://schemas.microsoft.com/office/drawing/2014/main" id="{5833EE7B-2A86-4D1A-923E-86460689C119}"/>
+                <a16:creationId xmlns:a16="http://schemas.microsoft.com/office/drawing/2014/main" id="{A5DF3588-959C-4C20-AEAD-9F8AD89A97B4}"/>
               </a:ext>
             </a:extLst>
           </p:cNvPr>
@@ -2917,7 +2917,7 @@
           <p:cNvPr id="8" name="">
             <a:extLst xmlns:a="http://schemas.openxmlformats.org/drawingml/2006/main">
               <a:ext uri="{FF2B5EF4-FFF2-40B4-BE49-F238E27FC236}">
-                <a16:creationId xmlns:a16="http://schemas.microsoft.com/office/drawing/2014/main" id="{E4C76866-EA9A-4742-8741-2166DE9F0200}"/>
+                <a16:creationId xmlns:a16="http://schemas.microsoft.com/office/drawing/2014/main" id="{2D13B615-A61F-459D-968C-E6DFD34D7CC7}"/>
               </a:ext>
             </a:extLst>
           </p:cNvPr>
@@ -3001,7 +3001,7 @@
           <p:cNvPr id="9" name="">
             <a:extLst xmlns:a="http://schemas.openxmlformats.org/drawingml/2006/main">
               <a:ext uri="{FF2B5EF4-FFF2-40B4-BE49-F238E27FC236}">
-                <a16:creationId xmlns:a16="http://schemas.microsoft.com/office/drawing/2014/main" id="{222C8EF5-F1E5-48A9-B636-7BFB55271F72}"/>
+                <a16:creationId xmlns:a16="http://schemas.microsoft.com/office/drawing/2014/main" id="{11B2BC92-819B-4C4D-B2CD-AC598B6A9408}"/>
               </a:ext>
             </a:extLst>
           </p:cNvPr>
@@ -3049,7 +3049,7 @@
     </p:spTree>
     <p:extLst>
       <p:ext uri="{BB962C8B-B14F-4D97-AF65-F5344CB8AC3E}">
-        <p14:creationId xmlns:p14="http://schemas.microsoft.com/office/powerpoint/2010/main" val="1184406307"/>
+        <p14:creationId xmlns:p14="http://schemas.microsoft.com/office/powerpoint/2010/main" val="1915068259"/>
       </p:ext>
     </p:extLst>
   </p:cSld>
@@ -3080,7 +3080,7 @@
           <p:cNvPr id="14" name="slide-2-title">
             <a:extLst xmlns:a="http://schemas.openxmlformats.org/drawingml/2006/main">
               <a:ext uri="{FF2B5EF4-FFF2-40B4-BE49-F238E27FC236}">
-                <a16:creationId xmlns:a16="http://schemas.microsoft.com/office/drawing/2014/main" id="{4741AE42-0A67-41AB-BDA7-12014DEB4338}"/>
+                <a16:creationId xmlns:a16="http://schemas.microsoft.com/office/drawing/2014/main" id="{74556003-EC26-4A05-BBE1-9019CC52B9C2}"/>
               </a:ext>
             </a:extLst>
           </p:cNvPr>
@@ -3130,7 +3130,7 @@
           <p:cNvPr id="2" name="">
             <a:extLst xmlns:a="http://schemas.openxmlformats.org/drawingml/2006/main">
               <a:ext uri="{FF2B5EF4-FFF2-40B4-BE49-F238E27FC236}">
-                <a16:creationId xmlns:a16="http://schemas.microsoft.com/office/drawing/2014/main" id="{05F25582-9784-464B-A4D8-4B9E32B31F0D}"/>
+                <a16:creationId xmlns:a16="http://schemas.microsoft.com/office/drawing/2014/main" id="{D295B155-F18F-4DE6-B1EC-2E6F5F90F80E}"/>
               </a:ext>
             </a:extLst>
           </p:cNvPr>
@@ -3180,7 +3180,7 @@
           <p:cNvPr id="3" name="">
             <a:extLst xmlns:a="http://schemas.openxmlformats.org/drawingml/2006/main">
               <a:ext uri="{FF2B5EF4-FFF2-40B4-BE49-F238E27FC236}">
-                <a16:creationId xmlns:a16="http://schemas.microsoft.com/office/drawing/2014/main" id="{6C8EAFC3-90B0-4932-AE5F-C258D3E4B916}"/>
+                <a16:creationId xmlns:a16="http://schemas.microsoft.com/office/drawing/2014/main" id="{E3C3E404-8C1E-4BB3-BE7A-C76BE309898A}"/>
               </a:ext>
             </a:extLst>
           </p:cNvPr>
@@ -3252,7 +3252,7 @@
           <p:cNvPr id="5" name="">
             <a:extLst xmlns:a="http://schemas.openxmlformats.org/drawingml/2006/main">
               <a:ext uri="{FF2B5EF4-FFF2-40B4-BE49-F238E27FC236}">
-                <a16:creationId xmlns:a16="http://schemas.microsoft.com/office/drawing/2014/main" id="{C1CEAE46-D66D-4E35-814C-716E4583D113}"/>
+                <a16:creationId xmlns:a16="http://schemas.microsoft.com/office/drawing/2014/main" id="{52DD17D9-B95F-4DBA-BD04-377CE6F345C9}"/>
               </a:ext>
             </a:extLst>
           </p:cNvPr>
@@ -3302,7 +3302,7 @@
           <p:cNvPr id="6" name="">
             <a:extLst xmlns:a="http://schemas.openxmlformats.org/drawingml/2006/main">
               <a:ext uri="{FF2B5EF4-FFF2-40B4-BE49-F238E27FC236}">
-                <a16:creationId xmlns:a16="http://schemas.microsoft.com/office/drawing/2014/main" id="{B7FE9136-5BE8-41F4-9E5D-3752DAA31994}"/>
+                <a16:creationId xmlns:a16="http://schemas.microsoft.com/office/drawing/2014/main" id="{744679A9-D1A2-4FA5-B3F6-C19112D5E731}"/>
               </a:ext>
             </a:extLst>
           </p:cNvPr>
@@ -3374,7 +3374,7 @@
           <p:cNvPr id="8" name="">
             <a:extLst xmlns:a="http://schemas.openxmlformats.org/drawingml/2006/main">
               <a:ext uri="{FF2B5EF4-FFF2-40B4-BE49-F238E27FC236}">
-                <a16:creationId xmlns:a16="http://schemas.microsoft.com/office/drawing/2014/main" id="{98EC720A-6232-4A46-9216-1E331DD6B12A}"/>
+                <a16:creationId xmlns:a16="http://schemas.microsoft.com/office/drawing/2014/main" id="{865ED023-06B4-40DB-9014-54D985F0C907}"/>
               </a:ext>
             </a:extLst>
           </p:cNvPr>
@@ -3424,7 +3424,7 @@
           <p:cNvPr id="9" name="">
             <a:extLst xmlns:a="http://schemas.openxmlformats.org/drawingml/2006/main">
               <a:ext uri="{FF2B5EF4-FFF2-40B4-BE49-F238E27FC236}">
-                <a16:creationId xmlns:a16="http://schemas.microsoft.com/office/drawing/2014/main" id="{80AE9DD5-FA98-4194-B6FE-F71CD9930F64}"/>
+                <a16:creationId xmlns:a16="http://schemas.microsoft.com/office/drawing/2014/main" id="{239A6156-2E20-4A24-93B7-E389D1A36E33}"/>
               </a:ext>
             </a:extLst>
           </p:cNvPr>
@@ -3496,7 +3496,7 @@
           <p:cNvPr id="11" name="">
             <a:extLst xmlns:a="http://schemas.openxmlformats.org/drawingml/2006/main">
               <a:ext uri="{FF2B5EF4-FFF2-40B4-BE49-F238E27FC236}">
-                <a16:creationId xmlns:a16="http://schemas.microsoft.com/office/drawing/2014/main" id="{0A045AA5-A0BF-4D7D-9C78-724A151CE7B6}"/>
+                <a16:creationId xmlns:a16="http://schemas.microsoft.com/office/drawing/2014/main" id="{8C69BE4A-A94D-40BE-9C6A-950F2D18719A}"/>
               </a:ext>
             </a:extLst>
           </p:cNvPr>
@@ -3546,7 +3546,7 @@
           <p:cNvPr id="12" name="">
             <a:extLst xmlns:a="http://schemas.openxmlformats.org/drawingml/2006/main">
               <a:ext uri="{FF2B5EF4-FFF2-40B4-BE49-F238E27FC236}">
-                <a16:creationId xmlns:a16="http://schemas.microsoft.com/office/drawing/2014/main" id="{85E63425-3D2A-4D1E-97F4-860CCCECCDF2}"/>
+                <a16:creationId xmlns:a16="http://schemas.microsoft.com/office/drawing/2014/main" id="{A151ECBB-CD4F-4632-B9CF-CB9E2BEABDD7}"/>
               </a:ext>
             </a:extLst>
           </p:cNvPr>
@@ -3596,7 +3596,7 @@
           <p:cNvPr id="13" name="">
             <a:extLst xmlns:a="http://schemas.openxmlformats.org/drawingml/2006/main">
               <a:ext uri="{FF2B5EF4-FFF2-40B4-BE49-F238E27FC236}">
-                <a16:creationId xmlns:a16="http://schemas.microsoft.com/office/drawing/2014/main" id="{3547E27F-12D7-46C9-A11F-0E4902CEC493}"/>
+                <a16:creationId xmlns:a16="http://schemas.microsoft.com/office/drawing/2014/main" id="{1AFA5BE3-8BF6-4A64-8B83-CB786E8D2864}"/>
               </a:ext>
             </a:extLst>
           </p:cNvPr>
@@ -3644,7 +3644,7 @@
     </p:spTree>
     <p:extLst>
       <p:ext uri="{BB962C8B-B14F-4D97-AF65-F5344CB8AC3E}">
-        <p14:creationId xmlns:p14="http://schemas.microsoft.com/office/powerpoint/2010/main" val="1208413093"/>
+        <p14:creationId xmlns:p14="http://schemas.microsoft.com/office/powerpoint/2010/main" val="322671857"/>
       </p:ext>
     </p:extLst>
   </p:cSld>
@@ -3675,7 +3675,7 @@
           <p:cNvPr id="16" name="slide-3-title">
             <a:extLst xmlns:a="http://schemas.openxmlformats.org/drawingml/2006/main">
               <a:ext uri="{FF2B5EF4-FFF2-40B4-BE49-F238E27FC236}">
-                <a16:creationId xmlns:a16="http://schemas.microsoft.com/office/drawing/2014/main" id="{CCE866CE-4589-4261-B144-6099931049FC}"/>
+                <a16:creationId xmlns:a16="http://schemas.microsoft.com/office/drawing/2014/main" id="{B2E48A52-5F6E-48C7-BE5C-099A6C9E9CA3}"/>
               </a:ext>
             </a:extLst>
           </p:cNvPr>
@@ -3725,7 +3725,7 @@
           <p:cNvPr id="2" name="">
             <a:extLst xmlns:a="http://schemas.openxmlformats.org/drawingml/2006/main">
               <a:ext uri="{FF2B5EF4-FFF2-40B4-BE49-F238E27FC236}">
-                <a16:creationId xmlns:a16="http://schemas.microsoft.com/office/drawing/2014/main" id="{98FB4678-CA49-4711-AD68-D95BB5C334E9}"/>
+                <a16:creationId xmlns:a16="http://schemas.microsoft.com/office/drawing/2014/main" id="{39908947-BC9E-4E32-A3A7-2AB0CEAE7493}"/>
               </a:ext>
             </a:extLst>
           </p:cNvPr>
@@ -3775,7 +3775,7 @@
           <p:cNvPr id="3" name="">
             <a:extLst xmlns:a="http://schemas.openxmlformats.org/drawingml/2006/main">
               <a:ext uri="{FF2B5EF4-FFF2-40B4-BE49-F238E27FC236}">
-                <a16:creationId xmlns:a16="http://schemas.microsoft.com/office/drawing/2014/main" id="{3C3C0B28-EED5-43B0-8257-35441463DC04}"/>
+                <a16:creationId xmlns:a16="http://schemas.microsoft.com/office/drawing/2014/main" id="{E24B77C5-8DC8-4AAE-8219-C4624E88F650}"/>
               </a:ext>
             </a:extLst>
           </p:cNvPr>
@@ -3825,7 +3825,7 @@
           <p:cNvPr id="4" name="">
             <a:extLst xmlns:a="http://schemas.openxmlformats.org/drawingml/2006/main">
               <a:ext uri="{FF2B5EF4-FFF2-40B4-BE49-F238E27FC236}">
-                <a16:creationId xmlns:a16="http://schemas.microsoft.com/office/drawing/2014/main" id="{E0E12257-3B91-49FC-B51C-DD0BE058B00D}"/>
+                <a16:creationId xmlns:a16="http://schemas.microsoft.com/office/drawing/2014/main" id="{F6552293-86C4-4EA7-ACB3-7A586358E56F}"/>
               </a:ext>
             </a:extLst>
           </p:cNvPr>
@@ -3856,7 +3856,7 @@
           <p:cNvPr id="5" name="">
             <a:extLst xmlns:a="http://schemas.openxmlformats.org/drawingml/2006/main">
               <a:ext uri="{FF2B5EF4-FFF2-40B4-BE49-F238E27FC236}">
-                <a16:creationId xmlns:a16="http://schemas.microsoft.com/office/drawing/2014/main" id="{9BFD2D71-7C04-45CA-8B8F-4BB0C6A509F4}"/>
+                <a16:creationId xmlns:a16="http://schemas.microsoft.com/office/drawing/2014/main" id="{A2D8C5E6-C599-46EA-80FE-B8E94195657C}"/>
               </a:ext>
             </a:extLst>
           </p:cNvPr>
@@ -3906,7 +3906,7 @@
           <p:cNvPr id="6" name="">
             <a:extLst xmlns:a="http://schemas.openxmlformats.org/drawingml/2006/main">
               <a:ext uri="{FF2B5EF4-FFF2-40B4-BE49-F238E27FC236}">
-                <a16:creationId xmlns:a16="http://schemas.microsoft.com/office/drawing/2014/main" id="{A67E91C6-C334-4158-980A-3FAB320BF8B1}"/>
+                <a16:creationId xmlns:a16="http://schemas.microsoft.com/office/drawing/2014/main" id="{C793BB7A-5E75-4E47-BFAB-7E450FACE37A}"/>
               </a:ext>
             </a:extLst>
           </p:cNvPr>
@@ -3956,7 +3956,7 @@
           <p:cNvPr id="7" name="">
             <a:extLst xmlns:a="http://schemas.openxmlformats.org/drawingml/2006/main">
               <a:ext uri="{FF2B5EF4-FFF2-40B4-BE49-F238E27FC236}">
-                <a16:creationId xmlns:a16="http://schemas.microsoft.com/office/drawing/2014/main" id="{08EA9361-C9A3-4363-B521-93AE93B968DE}"/>
+                <a16:creationId xmlns:a16="http://schemas.microsoft.com/office/drawing/2014/main" id="{0D6CDA45-88FD-4FBD-8CA1-049BA44D51CD}"/>
               </a:ext>
             </a:extLst>
           </p:cNvPr>
@@ -3987,7 +3987,7 @@
           <p:cNvPr id="8" name="">
             <a:extLst xmlns:a="http://schemas.openxmlformats.org/drawingml/2006/main">
               <a:ext uri="{FF2B5EF4-FFF2-40B4-BE49-F238E27FC236}">
-                <a16:creationId xmlns:a16="http://schemas.microsoft.com/office/drawing/2014/main" id="{71D1EFEE-911E-4047-B6A1-22946A949451}"/>
+                <a16:creationId xmlns:a16="http://schemas.microsoft.com/office/drawing/2014/main" id="{D7DE1C26-8B52-4AF4-8CAE-5623EEB9E790}"/>
               </a:ext>
             </a:extLst>
           </p:cNvPr>
@@ -4037,7 +4037,7 @@
           <p:cNvPr id="9" name="">
             <a:extLst xmlns:a="http://schemas.openxmlformats.org/drawingml/2006/main">
               <a:ext uri="{FF2B5EF4-FFF2-40B4-BE49-F238E27FC236}">
-                <a16:creationId xmlns:a16="http://schemas.microsoft.com/office/drawing/2014/main" id="{DC317857-5520-4EA3-8034-30E610F4D015}"/>
+                <a16:creationId xmlns:a16="http://schemas.microsoft.com/office/drawing/2014/main" id="{7C203F4B-D94B-496D-A992-2B1CC0A7E510}"/>
               </a:ext>
             </a:extLst>
           </p:cNvPr>
@@ -4087,7 +4087,7 @@
           <p:cNvPr id="10" name="">
             <a:extLst xmlns:a="http://schemas.openxmlformats.org/drawingml/2006/main">
               <a:ext uri="{FF2B5EF4-FFF2-40B4-BE49-F238E27FC236}">
-                <a16:creationId xmlns:a16="http://schemas.microsoft.com/office/drawing/2014/main" id="{B63C4A48-43A8-4B48-BEBE-9E4225DE6E47}"/>
+                <a16:creationId xmlns:a16="http://schemas.microsoft.com/office/drawing/2014/main" id="{73103908-720B-421C-886A-DCC6AF9BE086}"/>
               </a:ext>
             </a:extLst>
           </p:cNvPr>
@@ -4118,7 +4118,7 @@
           <p:cNvPr id="11" name="">
             <a:extLst xmlns:a="http://schemas.openxmlformats.org/drawingml/2006/main">
               <a:ext uri="{FF2B5EF4-FFF2-40B4-BE49-F238E27FC236}">
-                <a16:creationId xmlns:a16="http://schemas.microsoft.com/office/drawing/2014/main" id="{06558D96-D4AF-4038-998E-90AD7E6DAB63}"/>
+                <a16:creationId xmlns:a16="http://schemas.microsoft.com/office/drawing/2014/main" id="{CAF7511E-4307-4EE8-BF0A-F41717B4F48B}"/>
               </a:ext>
             </a:extLst>
           </p:cNvPr>
@@ -4168,7 +4168,7 @@
           <p:cNvPr id="12" name="">
             <a:extLst xmlns:a="http://schemas.openxmlformats.org/drawingml/2006/main">
               <a:ext uri="{FF2B5EF4-FFF2-40B4-BE49-F238E27FC236}">
-                <a16:creationId xmlns:a16="http://schemas.microsoft.com/office/drawing/2014/main" id="{A0A3472C-6DCA-4BFA-99AA-507B2A24315F}"/>
+                <a16:creationId xmlns:a16="http://schemas.microsoft.com/office/drawing/2014/main" id="{ED7E21C8-B5B1-4860-8F78-3EC72FFDCBCD}"/>
               </a:ext>
             </a:extLst>
           </p:cNvPr>
@@ -4218,7 +4218,7 @@
           <p:cNvPr id="13" name="">
             <a:extLst xmlns:a="http://schemas.openxmlformats.org/drawingml/2006/main">
               <a:ext uri="{FF2B5EF4-FFF2-40B4-BE49-F238E27FC236}">
-                <a16:creationId xmlns:a16="http://schemas.microsoft.com/office/drawing/2014/main" id="{15C51943-6B6E-4CBA-8BFE-A34502806FEF}"/>
+                <a16:creationId xmlns:a16="http://schemas.microsoft.com/office/drawing/2014/main" id="{508DD38F-0A1F-43DE-A2AA-3CB14B6AED5E}"/>
               </a:ext>
             </a:extLst>
           </p:cNvPr>
@@ -4249,7 +4249,7 @@
           <p:cNvPr id="14" name="">
             <a:extLst xmlns:a="http://schemas.openxmlformats.org/drawingml/2006/main">
               <a:ext uri="{FF2B5EF4-FFF2-40B4-BE49-F238E27FC236}">
-                <a16:creationId xmlns:a16="http://schemas.microsoft.com/office/drawing/2014/main" id="{A91608A6-6867-4DCE-900B-802E41400045}"/>
+                <a16:creationId xmlns:a16="http://schemas.microsoft.com/office/drawing/2014/main" id="{5C9A6E43-A650-4444-8E59-23216B07443A}"/>
               </a:ext>
             </a:extLst>
           </p:cNvPr>
@@ -4299,7 +4299,7 @@
           <p:cNvPr id="15" name="">
             <a:extLst xmlns:a="http://schemas.openxmlformats.org/drawingml/2006/main">
               <a:ext uri="{FF2B5EF4-FFF2-40B4-BE49-F238E27FC236}">
-                <a16:creationId xmlns:a16="http://schemas.microsoft.com/office/drawing/2014/main" id="{FB54C5E4-3907-4AE8-AEF9-7D498F45A80B}"/>
+                <a16:creationId xmlns:a16="http://schemas.microsoft.com/office/drawing/2014/main" id="{62A23066-5E4A-40C3-87DB-142C1278727C}"/>
               </a:ext>
             </a:extLst>
           </p:cNvPr>
@@ -4347,7 +4347,7 @@
     </p:spTree>
     <p:extLst>
       <p:ext uri="{BB962C8B-B14F-4D97-AF65-F5344CB8AC3E}">
-        <p14:creationId xmlns:p14="http://schemas.microsoft.com/office/powerpoint/2010/main" val="356563007"/>
+        <p14:creationId xmlns:p14="http://schemas.microsoft.com/office/powerpoint/2010/main" val="1474187868"/>
       </p:ext>
     </p:extLst>
   </p:cSld>
@@ -4378,7 +4378,7 @@
           <p:cNvPr id="20" name="slide-4-title">
             <a:extLst xmlns:a="http://schemas.openxmlformats.org/drawingml/2006/main">
               <a:ext uri="{FF2B5EF4-FFF2-40B4-BE49-F238E27FC236}">
-                <a16:creationId xmlns:a16="http://schemas.microsoft.com/office/drawing/2014/main" id="{1414264C-70E0-4614-9495-0D4F2525711C}"/>
+                <a16:creationId xmlns:a16="http://schemas.microsoft.com/office/drawing/2014/main" id="{17601EDB-95CC-434B-84A8-44068FBFBDEA}"/>
               </a:ext>
             </a:extLst>
           </p:cNvPr>
@@ -4428,7 +4428,7 @@
           <p:cNvPr id="2" name="">
             <a:extLst xmlns:a="http://schemas.openxmlformats.org/drawingml/2006/main">
               <a:ext uri="{FF2B5EF4-FFF2-40B4-BE49-F238E27FC236}">
-                <a16:creationId xmlns:a16="http://schemas.microsoft.com/office/drawing/2014/main" id="{22DA86AE-92D8-40FF-A9AA-D8BD45E41423}"/>
+                <a16:creationId xmlns:a16="http://schemas.microsoft.com/office/drawing/2014/main" id="{B035F729-10A3-41B5-AD5D-1301661A7A40}"/>
               </a:ext>
             </a:extLst>
           </p:cNvPr>
@@ -4500,7 +4500,7 @@
           <p:cNvPr id="4" name="">
             <a:extLst xmlns:a="http://schemas.openxmlformats.org/drawingml/2006/main">
               <a:ext uri="{FF2B5EF4-FFF2-40B4-BE49-F238E27FC236}">
-                <a16:creationId xmlns:a16="http://schemas.microsoft.com/office/drawing/2014/main" id="{FA807DEC-2D59-4144-B0CC-7633F2B2BFBC}"/>
+                <a16:creationId xmlns:a16="http://schemas.microsoft.com/office/drawing/2014/main" id="{68AD0E60-5BE7-4C85-BD97-D8B0BE1149E7}"/>
               </a:ext>
             </a:extLst>
           </p:cNvPr>
@@ -4531,7 +4531,7 @@
           <p:cNvPr id="5" name="">
             <a:extLst xmlns:a="http://schemas.openxmlformats.org/drawingml/2006/main">
               <a:ext uri="{FF2B5EF4-FFF2-40B4-BE49-F238E27FC236}">
-                <a16:creationId xmlns:a16="http://schemas.microsoft.com/office/drawing/2014/main" id="{50323FF3-C5A8-47E9-8D1A-67FBA080736B}"/>
+                <a16:creationId xmlns:a16="http://schemas.microsoft.com/office/drawing/2014/main" id="{A7429962-FCDC-4642-B807-A6CC6FA6E1B2}"/>
               </a:ext>
             </a:extLst>
           </p:cNvPr>
@@ -4581,7 +4581,7 @@
           <p:cNvPr id="6" name="">
             <a:extLst xmlns:a="http://schemas.openxmlformats.org/drawingml/2006/main">
               <a:ext uri="{FF2B5EF4-FFF2-40B4-BE49-F238E27FC236}">
-                <a16:creationId xmlns:a16="http://schemas.microsoft.com/office/drawing/2014/main" id="{6E928A23-1146-4CD9-9A5F-AFE5F085842E}"/>
+                <a16:creationId xmlns:a16="http://schemas.microsoft.com/office/drawing/2014/main" id="{83FB701A-DF95-498D-91A0-0CBB1C4FB428}"/>
               </a:ext>
             </a:extLst>
           </p:cNvPr>
@@ -4631,7 +4631,7 @@
           <p:cNvPr id="7" name="">
             <a:extLst xmlns:a="http://schemas.openxmlformats.org/drawingml/2006/main">
               <a:ext uri="{FF2B5EF4-FFF2-40B4-BE49-F238E27FC236}">
-                <a16:creationId xmlns:a16="http://schemas.microsoft.com/office/drawing/2014/main" id="{A31C7143-FCAB-4149-8B85-021D1BEEF151}"/>
+                <a16:creationId xmlns:a16="http://schemas.microsoft.com/office/drawing/2014/main" id="{CA645F78-BD0B-4B67-929D-A91A7E3CEA9D}"/>
               </a:ext>
             </a:extLst>
           </p:cNvPr>
@@ -4698,7 +4698,7 @@
           <p:cNvPr id="8" name="">
             <a:extLst xmlns:a="http://schemas.openxmlformats.org/drawingml/2006/main">
               <a:ext uri="{FF2B5EF4-FFF2-40B4-BE49-F238E27FC236}">
-                <a16:creationId xmlns:a16="http://schemas.microsoft.com/office/drawing/2014/main" id="{C451DD46-F9AD-428C-9856-BF9FAAB26882}"/>
+                <a16:creationId xmlns:a16="http://schemas.microsoft.com/office/drawing/2014/main" id="{53413149-214C-4448-BA57-C2B406A4DCD9}"/>
               </a:ext>
             </a:extLst>
           </p:cNvPr>
@@ -4729,7 +4729,7 @@
           <p:cNvPr id="9" name="">
             <a:extLst xmlns:a="http://schemas.openxmlformats.org/drawingml/2006/main">
               <a:ext uri="{FF2B5EF4-FFF2-40B4-BE49-F238E27FC236}">
-                <a16:creationId xmlns:a16="http://schemas.microsoft.com/office/drawing/2014/main" id="{9A13A7E5-FE99-4251-9DE2-FA159AD5495E}"/>
+                <a16:creationId xmlns:a16="http://schemas.microsoft.com/office/drawing/2014/main" id="{8E7DD049-28A6-448B-8BDD-528236E8D8F7}"/>
               </a:ext>
             </a:extLst>
           </p:cNvPr>
@@ -4779,7 +4779,7 @@
           <p:cNvPr id="10" name="">
             <a:extLst xmlns:a="http://schemas.openxmlformats.org/drawingml/2006/main">
               <a:ext uri="{FF2B5EF4-FFF2-40B4-BE49-F238E27FC236}">
-                <a16:creationId xmlns:a16="http://schemas.microsoft.com/office/drawing/2014/main" id="{0696DEA4-4EEE-401D-B622-BEC56221FB17}"/>
+                <a16:creationId xmlns:a16="http://schemas.microsoft.com/office/drawing/2014/main" id="{83387004-5451-4672-A883-04BA831ECC7C}"/>
               </a:ext>
             </a:extLst>
           </p:cNvPr>
@@ -4829,7 +4829,7 @@
           <p:cNvPr id="11" name="">
             <a:extLst xmlns:a="http://schemas.openxmlformats.org/drawingml/2006/main">
               <a:ext uri="{FF2B5EF4-FFF2-40B4-BE49-F238E27FC236}">
-                <a16:creationId xmlns:a16="http://schemas.microsoft.com/office/drawing/2014/main" id="{47B23702-34B2-475E-A85D-5F080B9EFA16}"/>
+                <a16:creationId xmlns:a16="http://schemas.microsoft.com/office/drawing/2014/main" id="{CA3D8E3B-DA3D-47F0-A12F-44E31DC68322}"/>
               </a:ext>
             </a:extLst>
           </p:cNvPr>
@@ -4896,7 +4896,7 @@
           <p:cNvPr id="12" name="">
             <a:extLst xmlns:a="http://schemas.openxmlformats.org/drawingml/2006/main">
               <a:ext uri="{FF2B5EF4-FFF2-40B4-BE49-F238E27FC236}">
-                <a16:creationId xmlns:a16="http://schemas.microsoft.com/office/drawing/2014/main" id="{D89671B3-3A4C-40E8-8662-601D9364344E}"/>
+                <a16:creationId xmlns:a16="http://schemas.microsoft.com/office/drawing/2014/main" id="{591362B3-3A72-4AEF-94B1-408F6CB4A831}"/>
               </a:ext>
             </a:extLst>
           </p:cNvPr>
@@ -4927,7 +4927,7 @@
           <p:cNvPr id="13" name="">
             <a:extLst xmlns:a="http://schemas.openxmlformats.org/drawingml/2006/main">
               <a:ext uri="{FF2B5EF4-FFF2-40B4-BE49-F238E27FC236}">
-                <a16:creationId xmlns:a16="http://schemas.microsoft.com/office/drawing/2014/main" id="{58ED9FE2-C2F2-4642-A2F4-69DA876FA2D7}"/>
+                <a16:creationId xmlns:a16="http://schemas.microsoft.com/office/drawing/2014/main" id="{1B192215-A64E-4AD1-B0B3-1ABB912EA03A}"/>
               </a:ext>
             </a:extLst>
           </p:cNvPr>
@@ -4977,7 +4977,7 @@
           <p:cNvPr id="14" name="">
             <a:extLst xmlns:a="http://schemas.openxmlformats.org/drawingml/2006/main">
               <a:ext uri="{FF2B5EF4-FFF2-40B4-BE49-F238E27FC236}">
-                <a16:creationId xmlns:a16="http://schemas.microsoft.com/office/drawing/2014/main" id="{ACF17563-B155-46DC-BF17-2101995F3576}"/>
+                <a16:creationId xmlns:a16="http://schemas.microsoft.com/office/drawing/2014/main" id="{69F6CDB9-61AE-4592-9B4F-8780BEA1E322}"/>
               </a:ext>
             </a:extLst>
           </p:cNvPr>
@@ -5027,7 +5027,7 @@
           <p:cNvPr id="15" name="">
             <a:extLst xmlns:a="http://schemas.openxmlformats.org/drawingml/2006/main">
               <a:ext uri="{FF2B5EF4-FFF2-40B4-BE49-F238E27FC236}">
-                <a16:creationId xmlns:a16="http://schemas.microsoft.com/office/drawing/2014/main" id="{C7B59350-7012-42C0-A67A-89EAA1B932AA}"/>
+                <a16:creationId xmlns:a16="http://schemas.microsoft.com/office/drawing/2014/main" id="{9DC895ED-F7A9-40E5-B119-5C58BFBAEC02}"/>
               </a:ext>
             </a:extLst>
           </p:cNvPr>
@@ -5094,7 +5094,7 @@
           <p:cNvPr id="16" name="">
             <a:extLst xmlns:a="http://schemas.openxmlformats.org/drawingml/2006/main">
               <a:ext uri="{FF2B5EF4-FFF2-40B4-BE49-F238E27FC236}">
-                <a16:creationId xmlns:a16="http://schemas.microsoft.com/office/drawing/2014/main" id="{7463D61B-23B2-462B-A329-9B1C62B01DD7}"/>
+                <a16:creationId xmlns:a16="http://schemas.microsoft.com/office/drawing/2014/main" id="{51651A0E-DF8B-4CEE-BF2A-CC45AB257663}"/>
               </a:ext>
             </a:extLst>
           </p:cNvPr>
@@ -5125,7 +5125,7 @@
           <p:cNvPr id="17" name="">
             <a:extLst xmlns:a="http://schemas.openxmlformats.org/drawingml/2006/main">
               <a:ext uri="{FF2B5EF4-FFF2-40B4-BE49-F238E27FC236}">
-                <a16:creationId xmlns:a16="http://schemas.microsoft.com/office/drawing/2014/main" id="{00A50900-2ED4-4346-892D-B5A3C0125727}"/>
+                <a16:creationId xmlns:a16="http://schemas.microsoft.com/office/drawing/2014/main" id="{2B188ADE-DEF8-45EA-94D6-F6083BA5E37F}"/>
               </a:ext>
             </a:extLst>
           </p:cNvPr>
@@ -5175,7 +5175,7 @@
           <p:cNvPr id="18" name="">
             <a:extLst xmlns:a="http://schemas.openxmlformats.org/drawingml/2006/main">
               <a:ext uri="{FF2B5EF4-FFF2-40B4-BE49-F238E27FC236}">
-                <a16:creationId xmlns:a16="http://schemas.microsoft.com/office/drawing/2014/main" id="{241D1A86-3329-49F2-BF26-B678D71AEFA7}"/>
+                <a16:creationId xmlns:a16="http://schemas.microsoft.com/office/drawing/2014/main" id="{396E8FD4-31FF-4286-A671-AB8FCEB8B93A}"/>
               </a:ext>
             </a:extLst>
           </p:cNvPr>
@@ -5225,7 +5225,7 @@
           <p:cNvPr id="19" name="">
             <a:extLst xmlns:a="http://schemas.openxmlformats.org/drawingml/2006/main">
               <a:ext uri="{FF2B5EF4-FFF2-40B4-BE49-F238E27FC236}">
-                <a16:creationId xmlns:a16="http://schemas.microsoft.com/office/drawing/2014/main" id="{D1A5177E-985B-48AA-B2B1-CD4BAF4C3A04}"/>
+                <a16:creationId xmlns:a16="http://schemas.microsoft.com/office/drawing/2014/main" id="{94B9FDEC-4914-4761-A0D1-0F9C3222C635}"/>
               </a:ext>
             </a:extLst>
           </p:cNvPr>
@@ -5290,7 +5290,7 @@
     </p:spTree>
     <p:extLst>
       <p:ext uri="{BB962C8B-B14F-4D97-AF65-F5344CB8AC3E}">
-        <p14:creationId xmlns:p14="http://schemas.microsoft.com/office/powerpoint/2010/main" val="1084145723"/>
+        <p14:creationId xmlns:p14="http://schemas.microsoft.com/office/powerpoint/2010/main" val="229760914"/>
       </p:ext>
     </p:extLst>
   </p:cSld>
@@ -5321,7 +5321,7 @@
           <p:cNvPr id="29" name="slide-5-title">
             <a:extLst xmlns:a="http://schemas.openxmlformats.org/drawingml/2006/main">
               <a:ext uri="{FF2B5EF4-FFF2-40B4-BE49-F238E27FC236}">
-                <a16:creationId xmlns:a16="http://schemas.microsoft.com/office/drawing/2014/main" id="{0E7CAD0B-1042-4EFF-B17A-A08E4212E0D0}"/>
+                <a16:creationId xmlns:a16="http://schemas.microsoft.com/office/drawing/2014/main" id="{7BDCD9AC-0654-48AF-A18E-137F197CC481}"/>
               </a:ext>
             </a:extLst>
           </p:cNvPr>
@@ -5371,7 +5371,7 @@
           <p:cNvPr id="2" name="">
             <a:extLst xmlns:a="http://schemas.openxmlformats.org/drawingml/2006/main">
               <a:ext uri="{FF2B5EF4-FFF2-40B4-BE49-F238E27FC236}">
-                <a16:creationId xmlns:a16="http://schemas.microsoft.com/office/drawing/2014/main" id="{4B7B9AE4-164C-40FE-9D23-102BDC4FBF24}"/>
+                <a16:creationId xmlns:a16="http://schemas.microsoft.com/office/drawing/2014/main" id="{16B82BFC-F131-4499-BD02-EC30CCF08CC4}"/>
               </a:ext>
             </a:extLst>
           </p:cNvPr>
@@ -5421,7 +5421,7 @@
           <p:cNvPr id="3" name="">
             <a:extLst xmlns:a="http://schemas.openxmlformats.org/drawingml/2006/main">
               <a:ext uri="{FF2B5EF4-FFF2-40B4-BE49-F238E27FC236}">
-                <a16:creationId xmlns:a16="http://schemas.microsoft.com/office/drawing/2014/main" id="{2F7171A7-9C9B-4004-BE60-B9765F4DCF56}"/>
+                <a16:creationId xmlns:a16="http://schemas.microsoft.com/office/drawing/2014/main" id="{A1527DA8-26D3-4C3C-A53C-7AB7FDC6B612}"/>
               </a:ext>
             </a:extLst>
           </p:cNvPr>
@@ -5559,7 +5559,7 @@
           <p:cNvPr id="8" name="">
             <a:extLst xmlns:a="http://schemas.openxmlformats.org/drawingml/2006/main">
               <a:ext uri="{FF2B5EF4-FFF2-40B4-BE49-F238E27FC236}">
-                <a16:creationId xmlns:a16="http://schemas.microsoft.com/office/drawing/2014/main" id="{A9FEF848-A7FE-4D22-A90C-9E3F179A4432}"/>
+                <a16:creationId xmlns:a16="http://schemas.microsoft.com/office/drawing/2014/main" id="{0E211E3F-1A38-4C21-8766-B7F33FBD70CC}"/>
               </a:ext>
             </a:extLst>
           </p:cNvPr>
@@ -5590,7 +5590,7 @@
           <p:cNvPr id="9" name="">
             <a:extLst xmlns:a="http://schemas.openxmlformats.org/drawingml/2006/main">
               <a:ext uri="{FF2B5EF4-FFF2-40B4-BE49-F238E27FC236}">
-                <a16:creationId xmlns:a16="http://schemas.microsoft.com/office/drawing/2014/main" id="{C6B9225D-40EB-4C96-877C-13D960DF9C57}"/>
+                <a16:creationId xmlns:a16="http://schemas.microsoft.com/office/drawing/2014/main" id="{1A095F7C-40B5-4716-905B-EDD3FAF450DE}"/>
               </a:ext>
             </a:extLst>
           </p:cNvPr>
@@ -5640,7 +5640,7 @@
           <p:cNvPr id="10" name="">
             <a:extLst xmlns:a="http://schemas.openxmlformats.org/drawingml/2006/main">
               <a:ext uri="{FF2B5EF4-FFF2-40B4-BE49-F238E27FC236}">
-                <a16:creationId xmlns:a16="http://schemas.microsoft.com/office/drawing/2014/main" id="{77D38451-0085-4C45-9034-24B2A177919D}"/>
+                <a16:creationId xmlns:a16="http://schemas.microsoft.com/office/drawing/2014/main" id="{D24B1936-0FF6-4E7E-80BB-5414E108244F}"/>
               </a:ext>
             </a:extLst>
           </p:cNvPr>
@@ -5690,7 +5690,7 @@
           <p:cNvPr id="11" name="">
             <a:extLst xmlns:a="http://schemas.openxmlformats.org/drawingml/2006/main">
               <a:ext uri="{FF2B5EF4-FFF2-40B4-BE49-F238E27FC236}">
-                <a16:creationId xmlns:a16="http://schemas.microsoft.com/office/drawing/2014/main" id="{3F32D99B-1AA3-45DD-A76C-8A6F8C48E4C4}"/>
+                <a16:creationId xmlns:a16="http://schemas.microsoft.com/office/drawing/2014/main" id="{F03E92C2-5EAB-4709-9406-919062455DB4}"/>
               </a:ext>
             </a:extLst>
           </p:cNvPr>
@@ -5740,7 +5740,7 @@
           <p:cNvPr id="12" name="">
             <a:extLst xmlns:a="http://schemas.openxmlformats.org/drawingml/2006/main">
               <a:ext uri="{FF2B5EF4-FFF2-40B4-BE49-F238E27FC236}">
-                <a16:creationId xmlns:a16="http://schemas.microsoft.com/office/drawing/2014/main" id="{32AD8AE2-2C89-4B03-9C3D-0DADF3C9EAB2}"/>
+                <a16:creationId xmlns:a16="http://schemas.microsoft.com/office/drawing/2014/main" id="{87CDE901-75A4-4DF4-BDD7-19D510B959A9}"/>
               </a:ext>
             </a:extLst>
           </p:cNvPr>
@@ -5771,7 +5771,7 @@
           <p:cNvPr id="13" name="">
             <a:extLst xmlns:a="http://schemas.openxmlformats.org/drawingml/2006/main">
               <a:ext uri="{FF2B5EF4-FFF2-40B4-BE49-F238E27FC236}">
-                <a16:creationId xmlns:a16="http://schemas.microsoft.com/office/drawing/2014/main" id="{A7A57042-9DAB-4892-A5B0-7365729920F4}"/>
+                <a16:creationId xmlns:a16="http://schemas.microsoft.com/office/drawing/2014/main" id="{1F9EE88A-283D-49D7-A23F-C0053D7EA4B3}"/>
               </a:ext>
             </a:extLst>
           </p:cNvPr>
@@ -5821,7 +5821,7 @@
           <p:cNvPr id="14" name="">
             <a:extLst xmlns:a="http://schemas.openxmlformats.org/drawingml/2006/main">
               <a:ext uri="{FF2B5EF4-FFF2-40B4-BE49-F238E27FC236}">
-                <a16:creationId xmlns:a16="http://schemas.microsoft.com/office/drawing/2014/main" id="{3152E822-FB97-4BAC-87DC-74281E79FBCA}"/>
+                <a16:creationId xmlns:a16="http://schemas.microsoft.com/office/drawing/2014/main" id="{96F040D8-4A70-47AA-8703-1A38252C2DDF}"/>
               </a:ext>
             </a:extLst>
           </p:cNvPr>
@@ -5871,7 +5871,7 @@
           <p:cNvPr id="15" name="">
             <a:extLst xmlns:a="http://schemas.openxmlformats.org/drawingml/2006/main">
               <a:ext uri="{FF2B5EF4-FFF2-40B4-BE49-F238E27FC236}">
-                <a16:creationId xmlns:a16="http://schemas.microsoft.com/office/drawing/2014/main" id="{53EB9102-D04E-4E33-ACFE-33B078C8F8C7}"/>
+                <a16:creationId xmlns:a16="http://schemas.microsoft.com/office/drawing/2014/main" id="{3E082DDF-13A3-4826-9EBC-ABCE58752859}"/>
               </a:ext>
             </a:extLst>
           </p:cNvPr>
@@ -5921,7 +5921,7 @@
           <p:cNvPr id="16" name="">
             <a:extLst xmlns:a="http://schemas.openxmlformats.org/drawingml/2006/main">
               <a:ext uri="{FF2B5EF4-FFF2-40B4-BE49-F238E27FC236}">
-                <a16:creationId xmlns:a16="http://schemas.microsoft.com/office/drawing/2014/main" id="{3F47D09D-A6B9-4CC6-8FA3-63D7E7363BCF}"/>
+                <a16:creationId xmlns:a16="http://schemas.microsoft.com/office/drawing/2014/main" id="{F602D639-6A1D-49D5-82C0-B5A20DFC5EDF}"/>
               </a:ext>
             </a:extLst>
           </p:cNvPr>
@@ -5952,7 +5952,7 @@
           <p:cNvPr id="17" name="">
             <a:extLst xmlns:a="http://schemas.openxmlformats.org/drawingml/2006/main">
               <a:ext uri="{FF2B5EF4-FFF2-40B4-BE49-F238E27FC236}">
-                <a16:creationId xmlns:a16="http://schemas.microsoft.com/office/drawing/2014/main" id="{99282EAF-2A98-4189-A297-5764CE75ED8C}"/>
+                <a16:creationId xmlns:a16="http://schemas.microsoft.com/office/drawing/2014/main" id="{244C8185-A6F2-4DFA-AD53-2371EA73DDE3}"/>
               </a:ext>
             </a:extLst>
           </p:cNvPr>
@@ -6002,7 +6002,7 @@
           <p:cNvPr id="18" name="">
             <a:extLst xmlns:a="http://schemas.openxmlformats.org/drawingml/2006/main">
               <a:ext uri="{FF2B5EF4-FFF2-40B4-BE49-F238E27FC236}">
-                <a16:creationId xmlns:a16="http://schemas.microsoft.com/office/drawing/2014/main" id="{A60797A8-8030-418D-9E48-7C8B2A75FCBD}"/>
+                <a16:creationId xmlns:a16="http://schemas.microsoft.com/office/drawing/2014/main" id="{48118892-E205-44C0-84B1-0C43B8442E63}"/>
               </a:ext>
             </a:extLst>
           </p:cNvPr>
@@ -6052,7 +6052,7 @@
           <p:cNvPr id="19" name="">
             <a:extLst xmlns:a="http://schemas.openxmlformats.org/drawingml/2006/main">
               <a:ext uri="{FF2B5EF4-FFF2-40B4-BE49-F238E27FC236}">
-                <a16:creationId xmlns:a16="http://schemas.microsoft.com/office/drawing/2014/main" id="{8215C2EA-5E7A-48D7-AE5E-3CCCCE08D395}"/>
+                <a16:creationId xmlns:a16="http://schemas.microsoft.com/office/drawing/2014/main" id="{5FD7A11C-9D81-4035-BF1A-51549023BB82}"/>
               </a:ext>
             </a:extLst>
           </p:cNvPr>
@@ -6102,7 +6102,7 @@
           <p:cNvPr id="20" name="">
             <a:extLst xmlns:a="http://schemas.openxmlformats.org/drawingml/2006/main">
               <a:ext uri="{FF2B5EF4-FFF2-40B4-BE49-F238E27FC236}">
-                <a16:creationId xmlns:a16="http://schemas.microsoft.com/office/drawing/2014/main" id="{D10D3509-1C39-4976-BFF2-F3857F6AC4B7}"/>
+                <a16:creationId xmlns:a16="http://schemas.microsoft.com/office/drawing/2014/main" id="{A2ECC7A9-7C59-4B33-95B4-8B0A3B0B1672}"/>
               </a:ext>
             </a:extLst>
           </p:cNvPr>
@@ -6133,7 +6133,7 @@
           <p:cNvPr id="21" name="">
             <a:extLst xmlns:a="http://schemas.openxmlformats.org/drawingml/2006/main">
               <a:ext uri="{FF2B5EF4-FFF2-40B4-BE49-F238E27FC236}">
-                <a16:creationId xmlns:a16="http://schemas.microsoft.com/office/drawing/2014/main" id="{E2CD859F-DFDF-4951-AD74-D296242323B1}"/>
+                <a16:creationId xmlns:a16="http://schemas.microsoft.com/office/drawing/2014/main" id="{B02AA8AB-1D69-448C-BC07-BF8CAFD65B8C}"/>
               </a:ext>
             </a:extLst>
           </p:cNvPr>
@@ -6183,7 +6183,7 @@
           <p:cNvPr id="22" name="">
             <a:extLst xmlns:a="http://schemas.openxmlformats.org/drawingml/2006/main">
               <a:ext uri="{FF2B5EF4-FFF2-40B4-BE49-F238E27FC236}">
-                <a16:creationId xmlns:a16="http://schemas.microsoft.com/office/drawing/2014/main" id="{8F69F4FF-1254-4365-9533-1F4E8E4F3E31}"/>
+                <a16:creationId xmlns:a16="http://schemas.microsoft.com/office/drawing/2014/main" id="{EDBBE4BD-CFD1-4192-B390-558953C3FBDB}"/>
               </a:ext>
             </a:extLst>
           </p:cNvPr>
@@ -6233,7 +6233,7 @@
           <p:cNvPr id="23" name="">
             <a:extLst xmlns:a="http://schemas.openxmlformats.org/drawingml/2006/main">
               <a:ext uri="{FF2B5EF4-FFF2-40B4-BE49-F238E27FC236}">
-                <a16:creationId xmlns:a16="http://schemas.microsoft.com/office/drawing/2014/main" id="{254A4A6A-3343-40C5-B2C3-7D77B2455EC4}"/>
+                <a16:creationId xmlns:a16="http://schemas.microsoft.com/office/drawing/2014/main" id="{959F7AB1-0015-4B4B-8CC3-E38451A67D26}"/>
               </a:ext>
             </a:extLst>
           </p:cNvPr>
@@ -6283,7 +6283,7 @@
           <p:cNvPr id="24" name="">
             <a:extLst xmlns:a="http://schemas.openxmlformats.org/drawingml/2006/main">
               <a:ext uri="{FF2B5EF4-FFF2-40B4-BE49-F238E27FC236}">
-                <a16:creationId xmlns:a16="http://schemas.microsoft.com/office/drawing/2014/main" id="{6B0ACDE2-0F15-4B35-9EF3-D4F47DC77CBB}"/>
+                <a16:creationId xmlns:a16="http://schemas.microsoft.com/office/drawing/2014/main" id="{BD28FDE5-8C58-446B-AAA4-D8533A9F88DF}"/>
               </a:ext>
             </a:extLst>
           </p:cNvPr>
@@ -6314,7 +6314,7 @@
           <p:cNvPr id="25" name="">
             <a:extLst xmlns:a="http://schemas.openxmlformats.org/drawingml/2006/main">
               <a:ext uri="{FF2B5EF4-FFF2-40B4-BE49-F238E27FC236}">
-                <a16:creationId xmlns:a16="http://schemas.microsoft.com/office/drawing/2014/main" id="{2FC306F1-EB8F-46E5-ABC3-F568CF120C4A}"/>
+                <a16:creationId xmlns:a16="http://schemas.microsoft.com/office/drawing/2014/main" id="{BAFD98C1-804F-452F-961A-0A43DC10B5B1}"/>
               </a:ext>
             </a:extLst>
           </p:cNvPr>
@@ -6364,7 +6364,7 @@
           <p:cNvPr id="26" name="">
             <a:extLst xmlns:a="http://schemas.openxmlformats.org/drawingml/2006/main">
               <a:ext uri="{FF2B5EF4-FFF2-40B4-BE49-F238E27FC236}">
-                <a16:creationId xmlns:a16="http://schemas.microsoft.com/office/drawing/2014/main" id="{DF43B47F-7392-47C2-A63D-ADF8A7A3D8F5}"/>
+                <a16:creationId xmlns:a16="http://schemas.microsoft.com/office/drawing/2014/main" id="{D5846E8A-35FA-4FCA-B21D-18ACD0F58A98}"/>
               </a:ext>
             </a:extLst>
           </p:cNvPr>
@@ -6414,7 +6414,7 @@
           <p:cNvPr id="27" name="">
             <a:extLst xmlns:a="http://schemas.openxmlformats.org/drawingml/2006/main">
               <a:ext uri="{FF2B5EF4-FFF2-40B4-BE49-F238E27FC236}">
-                <a16:creationId xmlns:a16="http://schemas.microsoft.com/office/drawing/2014/main" id="{BE12BE6F-1F00-4D0E-BD87-A87D4781F809}"/>
+                <a16:creationId xmlns:a16="http://schemas.microsoft.com/office/drawing/2014/main" id="{39C3C51F-1AA1-407E-81FE-82CFEA80B278}"/>
               </a:ext>
             </a:extLst>
           </p:cNvPr>
@@ -6464,7 +6464,7 @@
           <p:cNvPr id="28" name="">
             <a:extLst xmlns:a="http://schemas.openxmlformats.org/drawingml/2006/main">
               <a:ext uri="{FF2B5EF4-FFF2-40B4-BE49-F238E27FC236}">
-                <a16:creationId xmlns:a16="http://schemas.microsoft.com/office/drawing/2014/main" id="{812BE27C-3CE0-4001-B8B7-5D7C2A43238F}"/>
+                <a16:creationId xmlns:a16="http://schemas.microsoft.com/office/drawing/2014/main" id="{6DEE05E7-86B1-4FEA-81AC-38CFDE1B61A5}"/>
               </a:ext>
             </a:extLst>
           </p:cNvPr>
@@ -6512,7 +6512,7 @@
     </p:spTree>
     <p:extLst>
       <p:ext uri="{BB962C8B-B14F-4D97-AF65-F5344CB8AC3E}">
-        <p14:creationId xmlns:p14="http://schemas.microsoft.com/office/powerpoint/2010/main" val="1906280775"/>
+        <p14:creationId xmlns:p14="http://schemas.microsoft.com/office/powerpoint/2010/main" val="559651574"/>
       </p:ext>
     </p:extLst>
   </p:cSld>
@@ -6543,7 +6543,7 @@
           <p:cNvPr id="48" name="slide-6-title">
             <a:extLst xmlns:a="http://schemas.openxmlformats.org/drawingml/2006/main">
               <a:ext uri="{FF2B5EF4-FFF2-40B4-BE49-F238E27FC236}">
-                <a16:creationId xmlns:a16="http://schemas.microsoft.com/office/drawing/2014/main" id="{D036A537-6073-4938-81EF-0782972C2C3A}"/>
+                <a16:creationId xmlns:a16="http://schemas.microsoft.com/office/drawing/2014/main" id="{B3D057C0-E5C8-4143-80E4-D3322F992135}"/>
               </a:ext>
             </a:extLst>
           </p:cNvPr>
@@ -6593,7 +6593,7 @@
           <p:cNvPr id="2" name="">
             <a:extLst xmlns:a="http://schemas.openxmlformats.org/drawingml/2006/main">
               <a:ext uri="{FF2B5EF4-FFF2-40B4-BE49-F238E27FC236}">
-                <a16:creationId xmlns:a16="http://schemas.microsoft.com/office/drawing/2014/main" id="{26190F7B-35E1-4DAC-94AB-B488B4983DB8}"/>
+                <a16:creationId xmlns:a16="http://schemas.microsoft.com/office/drawing/2014/main" id="{692830A5-FB33-49E3-B120-CF83E7BEF765}"/>
               </a:ext>
             </a:extLst>
           </p:cNvPr>
@@ -6643,7 +6643,7 @@
           <p:cNvPr id="3" name="">
             <a:extLst xmlns:a="http://schemas.openxmlformats.org/drawingml/2006/main">
               <a:ext uri="{FF2B5EF4-FFF2-40B4-BE49-F238E27FC236}">
-                <a16:creationId xmlns:a16="http://schemas.microsoft.com/office/drawing/2014/main" id="{B75AE41D-C05E-4D0A-B303-C3B203E6BB4E}"/>
+                <a16:creationId xmlns:a16="http://schemas.microsoft.com/office/drawing/2014/main" id="{A4EACDB0-F718-47DC-BB30-B49651E78D5F}"/>
               </a:ext>
             </a:extLst>
           </p:cNvPr>
@@ -6693,7 +6693,7 @@
           <p:cNvPr id="4" name="">
             <a:extLst xmlns:a="http://schemas.openxmlformats.org/drawingml/2006/main">
               <a:ext uri="{FF2B5EF4-FFF2-40B4-BE49-F238E27FC236}">
-                <a16:creationId xmlns:a16="http://schemas.microsoft.com/office/drawing/2014/main" id="{D63B290B-62C1-44A7-BD0E-AF61188F2FA5}"/>
+                <a16:creationId xmlns:a16="http://schemas.microsoft.com/office/drawing/2014/main" id="{70BBC0E9-56F5-4F15-B41E-8C907B63B461}"/>
               </a:ext>
             </a:extLst>
           </p:cNvPr>
@@ -6743,7 +6743,7 @@
           <p:cNvPr id="5" name="">
             <a:extLst xmlns:a="http://schemas.openxmlformats.org/drawingml/2006/main">
               <a:ext uri="{FF2B5EF4-FFF2-40B4-BE49-F238E27FC236}">
-                <a16:creationId xmlns:a16="http://schemas.microsoft.com/office/drawing/2014/main" id="{983AFDC1-3CFF-4EC8-8218-C5C77AB26EBD}"/>
+                <a16:creationId xmlns:a16="http://schemas.microsoft.com/office/drawing/2014/main" id="{AC43585A-18D7-4F8E-BB7A-BC463BDA6477}"/>
               </a:ext>
             </a:extLst>
           </p:cNvPr>
@@ -6793,7 +6793,7 @@
           <p:cNvPr id="6" name="">
             <a:extLst xmlns:a="http://schemas.openxmlformats.org/drawingml/2006/main">
               <a:ext uri="{FF2B5EF4-FFF2-40B4-BE49-F238E27FC236}">
-                <a16:creationId xmlns:a16="http://schemas.microsoft.com/office/drawing/2014/main" id="{BD81CCE7-1163-4A45-988C-9A1A8E68100C}"/>
+                <a16:creationId xmlns:a16="http://schemas.microsoft.com/office/drawing/2014/main" id="{6469EE34-7DAE-40AC-8AEB-B5B39D6E8BFF}"/>
               </a:ext>
             </a:extLst>
           </p:cNvPr>
@@ -6826,7 +6826,7 @@
           <p:cNvPr id="7" name="">
             <a:extLst xmlns:a="http://schemas.openxmlformats.org/drawingml/2006/main">
               <a:ext uri="{FF2B5EF4-FFF2-40B4-BE49-F238E27FC236}">
-                <a16:creationId xmlns:a16="http://schemas.microsoft.com/office/drawing/2014/main" id="{CD960700-8316-45FB-8296-C3CA012B6B86}"/>
+                <a16:creationId xmlns:a16="http://schemas.microsoft.com/office/drawing/2014/main" id="{243C6886-3491-486E-B3A2-8FA048D32CF0}"/>
               </a:ext>
             </a:extLst>
           </p:cNvPr>
@@ -6876,7 +6876,7 @@
           <p:cNvPr id="8" name="">
             <a:extLst xmlns:a="http://schemas.openxmlformats.org/drawingml/2006/main">
               <a:ext uri="{FF2B5EF4-FFF2-40B4-BE49-F238E27FC236}">
-                <a16:creationId xmlns:a16="http://schemas.microsoft.com/office/drawing/2014/main" id="{561C7273-AA94-4EDC-A283-801D6F7E1D6E}"/>
+                <a16:creationId xmlns:a16="http://schemas.microsoft.com/office/drawing/2014/main" id="{FAF2676A-4324-479A-A336-481EBC203AE9}"/>
               </a:ext>
             </a:extLst>
           </p:cNvPr>
@@ -6909,7 +6909,7 @@
           <p:cNvPr id="9" name="">
             <a:extLst xmlns:a="http://schemas.openxmlformats.org/drawingml/2006/main">
               <a:ext uri="{FF2B5EF4-FFF2-40B4-BE49-F238E27FC236}">
-                <a16:creationId xmlns:a16="http://schemas.microsoft.com/office/drawing/2014/main" id="{64BE14D7-163B-4AE3-92CE-AC136AC0E617}"/>
+                <a16:creationId xmlns:a16="http://schemas.microsoft.com/office/drawing/2014/main" id="{98DC3B87-A190-4B33-B813-4282F48AB384}"/>
               </a:ext>
             </a:extLst>
           </p:cNvPr>
@@ -6959,7 +6959,7 @@
           <p:cNvPr id="10" name="">
             <a:extLst xmlns:a="http://schemas.openxmlformats.org/drawingml/2006/main">
               <a:ext uri="{FF2B5EF4-FFF2-40B4-BE49-F238E27FC236}">
-                <a16:creationId xmlns:a16="http://schemas.microsoft.com/office/drawing/2014/main" id="{BCF04495-B083-4F60-B2E4-138AB0945573}"/>
+                <a16:creationId xmlns:a16="http://schemas.microsoft.com/office/drawing/2014/main" id="{61E47D26-1CD6-40B9-A9DE-697FDFE250F6}"/>
               </a:ext>
             </a:extLst>
           </p:cNvPr>
@@ -6992,7 +6992,7 @@
           <p:cNvPr id="11" name="">
             <a:extLst xmlns:a="http://schemas.openxmlformats.org/drawingml/2006/main">
               <a:ext uri="{FF2B5EF4-FFF2-40B4-BE49-F238E27FC236}">
-                <a16:creationId xmlns:a16="http://schemas.microsoft.com/office/drawing/2014/main" id="{0A6F5546-F901-42F1-AD56-62037E9C630D}"/>
+                <a16:creationId xmlns:a16="http://schemas.microsoft.com/office/drawing/2014/main" id="{C0F610CA-0571-4068-AD3A-F53251103708}"/>
               </a:ext>
             </a:extLst>
           </p:cNvPr>
@@ -7042,7 +7042,7 @@
           <p:cNvPr id="12" name="">
             <a:extLst xmlns:a="http://schemas.openxmlformats.org/drawingml/2006/main">
               <a:ext uri="{FF2B5EF4-FFF2-40B4-BE49-F238E27FC236}">
-                <a16:creationId xmlns:a16="http://schemas.microsoft.com/office/drawing/2014/main" id="{8DFBFE80-A04A-4194-8C4D-B3E2CC71F76F}"/>
+                <a16:creationId xmlns:a16="http://schemas.microsoft.com/office/drawing/2014/main" id="{FE98E561-B445-4781-9F71-9997A769E350}"/>
               </a:ext>
             </a:extLst>
           </p:cNvPr>
@@ -7075,7 +7075,7 @@
           <p:cNvPr id="13" name="">
             <a:extLst xmlns:a="http://schemas.openxmlformats.org/drawingml/2006/main">
               <a:ext uri="{FF2B5EF4-FFF2-40B4-BE49-F238E27FC236}">
-                <a16:creationId xmlns:a16="http://schemas.microsoft.com/office/drawing/2014/main" id="{27BB205F-9800-448B-AAF4-2FB3A14F1DE3}"/>
+                <a16:creationId xmlns:a16="http://schemas.microsoft.com/office/drawing/2014/main" id="{5BA5A32E-3180-4F7B-9390-62C3D6099B16}"/>
               </a:ext>
             </a:extLst>
           </p:cNvPr>
@@ -7125,7 +7125,7 @@
           <p:cNvPr id="14" name="">
             <a:extLst xmlns:a="http://schemas.openxmlformats.org/drawingml/2006/main">
               <a:ext uri="{FF2B5EF4-FFF2-40B4-BE49-F238E27FC236}">
-                <a16:creationId xmlns:a16="http://schemas.microsoft.com/office/drawing/2014/main" id="{D195EB8D-DEA7-4CEB-B278-B98E1C8EEB57}"/>
+                <a16:creationId xmlns:a16="http://schemas.microsoft.com/office/drawing/2014/main" id="{557ADC12-66D4-4043-99C0-B6826E62FB7C}"/>
               </a:ext>
             </a:extLst>
           </p:cNvPr>
@@ -7158,7 +7158,7 @@
           <p:cNvPr id="15" name="">
             <a:extLst xmlns:a="http://schemas.openxmlformats.org/drawingml/2006/main">
               <a:ext uri="{FF2B5EF4-FFF2-40B4-BE49-F238E27FC236}">
-                <a16:creationId xmlns:a16="http://schemas.microsoft.com/office/drawing/2014/main" id="{8EADA886-EC48-4289-9083-D2675828309B}"/>
+                <a16:creationId xmlns:a16="http://schemas.microsoft.com/office/drawing/2014/main" id="{3C50F3F3-B032-46A0-8DF3-92E91C6806B4}"/>
               </a:ext>
             </a:extLst>
           </p:cNvPr>
@@ -7208,7 +7208,7 @@
           <p:cNvPr id="16" name="">
             <a:extLst xmlns:a="http://schemas.openxmlformats.org/drawingml/2006/main">
               <a:ext uri="{FF2B5EF4-FFF2-40B4-BE49-F238E27FC236}">
-                <a16:creationId xmlns:a16="http://schemas.microsoft.com/office/drawing/2014/main" id="{CC48CCFF-8689-4EF6-9E67-33F37F0CAF35}"/>
+                <a16:creationId xmlns:a16="http://schemas.microsoft.com/office/drawing/2014/main" id="{6647ECF4-4EEE-4A22-8FDF-8D8E50168EC8}"/>
               </a:ext>
             </a:extLst>
           </p:cNvPr>
@@ -7241,7 +7241,7 @@
           <p:cNvPr id="17" name="">
             <a:extLst xmlns:a="http://schemas.openxmlformats.org/drawingml/2006/main">
               <a:ext uri="{FF2B5EF4-FFF2-40B4-BE49-F238E27FC236}">
-                <a16:creationId xmlns:a16="http://schemas.microsoft.com/office/drawing/2014/main" id="{C5B20C16-401A-4905-AC55-D249B124D8CA}"/>
+                <a16:creationId xmlns:a16="http://schemas.microsoft.com/office/drawing/2014/main" id="{A0BDF1E4-BE9B-4072-ACAA-B28C99F3503A}"/>
               </a:ext>
             </a:extLst>
           </p:cNvPr>
@@ -7291,7 +7291,7 @@
           <p:cNvPr id="18" name="">
             <a:extLst xmlns:a="http://schemas.openxmlformats.org/drawingml/2006/main">
               <a:ext uri="{FF2B5EF4-FFF2-40B4-BE49-F238E27FC236}">
-                <a16:creationId xmlns:a16="http://schemas.microsoft.com/office/drawing/2014/main" id="{117C9EA2-AD84-42E1-9B87-3A4FEB80A007}"/>
+                <a16:creationId xmlns:a16="http://schemas.microsoft.com/office/drawing/2014/main" id="{604843EC-BEA8-4CFB-9F70-35D2F3CDF9FA}"/>
               </a:ext>
             </a:extLst>
           </p:cNvPr>
@@ -7324,7 +7324,7 @@
           <p:cNvPr id="19" name="">
             <a:extLst xmlns:a="http://schemas.openxmlformats.org/drawingml/2006/main">
               <a:ext uri="{FF2B5EF4-FFF2-40B4-BE49-F238E27FC236}">
-                <a16:creationId xmlns:a16="http://schemas.microsoft.com/office/drawing/2014/main" id="{ACDBA6A1-449E-4647-87E1-0951BD637104}"/>
+                <a16:creationId xmlns:a16="http://schemas.microsoft.com/office/drawing/2014/main" id="{6807CF48-9B8B-496D-90FF-D9EFB81E3F69}"/>
               </a:ext>
             </a:extLst>
           </p:cNvPr>
@@ -7374,7 +7374,7 @@
           <p:cNvPr id="20" name="">
             <a:extLst xmlns:a="http://schemas.openxmlformats.org/drawingml/2006/main">
               <a:ext uri="{FF2B5EF4-FFF2-40B4-BE49-F238E27FC236}">
-                <a16:creationId xmlns:a16="http://schemas.microsoft.com/office/drawing/2014/main" id="{E044FCC7-AB8C-4A95-A25E-27C0617B1144}"/>
+                <a16:creationId xmlns:a16="http://schemas.microsoft.com/office/drawing/2014/main" id="{BCD2A4E3-ECAD-4D4E-94D2-7023F02FB89E}"/>
               </a:ext>
             </a:extLst>
           </p:cNvPr>
@@ -7407,7 +7407,7 @@
           <p:cNvPr id="21" name="">
             <a:extLst xmlns:a="http://schemas.openxmlformats.org/drawingml/2006/main">
               <a:ext uri="{FF2B5EF4-FFF2-40B4-BE49-F238E27FC236}">
-                <a16:creationId xmlns:a16="http://schemas.microsoft.com/office/drawing/2014/main" id="{3ED7D418-1C2E-4112-A2D9-AE1BB709EA8F}"/>
+                <a16:creationId xmlns:a16="http://schemas.microsoft.com/office/drawing/2014/main" id="{76AFB412-57AD-4BEE-895F-DC9D91CB610B}"/>
               </a:ext>
             </a:extLst>
           </p:cNvPr>
@@ -7474,7 +7474,7 @@
           <p:cNvPr id="22" name="">
             <a:extLst xmlns:a="http://schemas.openxmlformats.org/drawingml/2006/main">
               <a:ext uri="{FF2B5EF4-FFF2-40B4-BE49-F238E27FC236}">
-                <a16:creationId xmlns:a16="http://schemas.microsoft.com/office/drawing/2014/main" id="{9FA5A2AD-CEA3-493A-9C7C-770A2B4AD74A}"/>
+                <a16:creationId xmlns:a16="http://schemas.microsoft.com/office/drawing/2014/main" id="{6F845062-1972-4462-A6FA-46EBF0662B96}"/>
               </a:ext>
             </a:extLst>
           </p:cNvPr>
@@ -7507,7 +7507,7 @@
           <p:cNvPr id="23" name="">
             <a:extLst xmlns:a="http://schemas.openxmlformats.org/drawingml/2006/main">
               <a:ext uri="{FF2B5EF4-FFF2-40B4-BE49-F238E27FC236}">
-                <a16:creationId xmlns:a16="http://schemas.microsoft.com/office/drawing/2014/main" id="{EB090A9C-69BB-4352-8B4C-CC733BBEDA5D}"/>
+                <a16:creationId xmlns:a16="http://schemas.microsoft.com/office/drawing/2014/main" id="{904EC6EA-23C8-47DF-9BD4-7E1A8070B87C}"/>
               </a:ext>
             </a:extLst>
           </p:cNvPr>
@@ -7557,7 +7557,7 @@
           <p:cNvPr id="24" name="">
             <a:extLst xmlns:a="http://schemas.openxmlformats.org/drawingml/2006/main">
               <a:ext uri="{FF2B5EF4-FFF2-40B4-BE49-F238E27FC236}">
-                <a16:creationId xmlns:a16="http://schemas.microsoft.com/office/drawing/2014/main" id="{360D9564-4CE5-46F2-845D-EDEB10A8DA56}"/>
+                <a16:creationId xmlns:a16="http://schemas.microsoft.com/office/drawing/2014/main" id="{8C2B50AC-BBC9-4BE8-95F8-A555EE2FA11A}"/>
               </a:ext>
             </a:extLst>
           </p:cNvPr>
@@ -7590,7 +7590,7 @@
           <p:cNvPr id="25" name="">
             <a:extLst xmlns:a="http://schemas.openxmlformats.org/drawingml/2006/main">
               <a:ext uri="{FF2B5EF4-FFF2-40B4-BE49-F238E27FC236}">
-                <a16:creationId xmlns:a16="http://schemas.microsoft.com/office/drawing/2014/main" id="{4D7AA156-8A9D-454D-94BC-689D50EE374E}"/>
+                <a16:creationId xmlns:a16="http://schemas.microsoft.com/office/drawing/2014/main" id="{D3BE12CF-4B20-454F-84A2-9D5ECB827C4E}"/>
               </a:ext>
             </a:extLst>
           </p:cNvPr>
@@ -7640,7 +7640,7 @@
           <p:cNvPr id="26" name="">
             <a:extLst xmlns:a="http://schemas.openxmlformats.org/drawingml/2006/main">
               <a:ext uri="{FF2B5EF4-FFF2-40B4-BE49-F238E27FC236}">
-                <a16:creationId xmlns:a16="http://schemas.microsoft.com/office/drawing/2014/main" id="{47911271-5802-45FA-9DF5-9D30D7511D7F}"/>
+                <a16:creationId xmlns:a16="http://schemas.microsoft.com/office/drawing/2014/main" id="{7A232F57-D896-467A-94F9-5CA69BD5D484}"/>
               </a:ext>
             </a:extLst>
           </p:cNvPr>
@@ -7673,7 +7673,7 @@
           <p:cNvPr id="27" name="">
             <a:extLst xmlns:a="http://schemas.openxmlformats.org/drawingml/2006/main">
               <a:ext uri="{FF2B5EF4-FFF2-40B4-BE49-F238E27FC236}">
-                <a16:creationId xmlns:a16="http://schemas.microsoft.com/office/drawing/2014/main" id="{F066C9F9-728E-4278-B583-FF8094F4FB91}"/>
+                <a16:creationId xmlns:a16="http://schemas.microsoft.com/office/drawing/2014/main" id="{807B0B1D-9274-4A21-8735-89761C81C736}"/>
               </a:ext>
             </a:extLst>
           </p:cNvPr>
@@ -7723,7 +7723,7 @@
           <p:cNvPr id="28" name="">
             <a:extLst xmlns:a="http://schemas.openxmlformats.org/drawingml/2006/main">
               <a:ext uri="{FF2B5EF4-FFF2-40B4-BE49-F238E27FC236}">
-                <a16:creationId xmlns:a16="http://schemas.microsoft.com/office/drawing/2014/main" id="{236706F6-3611-48E2-90A2-E25B57FAAA35}"/>
+                <a16:creationId xmlns:a16="http://schemas.microsoft.com/office/drawing/2014/main" id="{D8FDDADB-CED0-40B1-88FD-1D4FF9079B16}"/>
               </a:ext>
             </a:extLst>
           </p:cNvPr>
@@ -7756,7 +7756,7 @@
           <p:cNvPr id="29" name="">
             <a:extLst xmlns:a="http://schemas.openxmlformats.org/drawingml/2006/main">
               <a:ext uri="{FF2B5EF4-FFF2-40B4-BE49-F238E27FC236}">
-                <a16:creationId xmlns:a16="http://schemas.microsoft.com/office/drawing/2014/main" id="{35157B6F-B413-4692-9884-60DE1070E480}"/>
+                <a16:creationId xmlns:a16="http://schemas.microsoft.com/office/drawing/2014/main" id="{DCF0DAE0-EE29-487E-A2DC-EE605CB1B01C}"/>
               </a:ext>
             </a:extLst>
           </p:cNvPr>
@@ -7806,7 +7806,7 @@
           <p:cNvPr id="30" name="">
             <a:extLst xmlns:a="http://schemas.openxmlformats.org/drawingml/2006/main">
               <a:ext uri="{FF2B5EF4-FFF2-40B4-BE49-F238E27FC236}">
-                <a16:creationId xmlns:a16="http://schemas.microsoft.com/office/drawing/2014/main" id="{64BF332F-7EAD-441F-832B-F2EE9EF4E8A6}"/>
+                <a16:creationId xmlns:a16="http://schemas.microsoft.com/office/drawing/2014/main" id="{3204C213-690D-4B71-9D3F-81E5A9820886}"/>
               </a:ext>
             </a:extLst>
           </p:cNvPr>
@@ -7839,7 +7839,7 @@
           <p:cNvPr id="31" name="">
             <a:extLst xmlns:a="http://schemas.openxmlformats.org/drawingml/2006/main">
               <a:ext uri="{FF2B5EF4-FFF2-40B4-BE49-F238E27FC236}">
-                <a16:creationId xmlns:a16="http://schemas.microsoft.com/office/drawing/2014/main" id="{FA875233-A378-45EC-AB61-C7FE0596AF8C}"/>
+                <a16:creationId xmlns:a16="http://schemas.microsoft.com/office/drawing/2014/main" id="{8A4E02A8-80BD-4887-BD71-E27640C3184F}"/>
               </a:ext>
             </a:extLst>
           </p:cNvPr>
@@ -7906,7 +7906,7 @@
           <p:cNvPr id="32" name="">
             <a:extLst xmlns:a="http://schemas.openxmlformats.org/drawingml/2006/main">
               <a:ext uri="{FF2B5EF4-FFF2-40B4-BE49-F238E27FC236}">
-                <a16:creationId xmlns:a16="http://schemas.microsoft.com/office/drawing/2014/main" id="{1BB3BA71-1682-4D18-BE43-53482F29549A}"/>
+                <a16:creationId xmlns:a16="http://schemas.microsoft.com/office/drawing/2014/main" id="{8BCF0949-E03B-456B-B6B2-33758407D7D3}"/>
               </a:ext>
             </a:extLst>
           </p:cNvPr>
@@ -7939,7 +7939,7 @@
           <p:cNvPr id="33" name="">
             <a:extLst xmlns:a="http://schemas.openxmlformats.org/drawingml/2006/main">
               <a:ext uri="{FF2B5EF4-FFF2-40B4-BE49-F238E27FC236}">
-                <a16:creationId xmlns:a16="http://schemas.microsoft.com/office/drawing/2014/main" id="{61C1FF3A-91F9-48A0-8D95-2595C252754D}"/>
+                <a16:creationId xmlns:a16="http://schemas.microsoft.com/office/drawing/2014/main" id="{40C14650-505B-444A-AF44-CB4022436DCB}"/>
               </a:ext>
             </a:extLst>
           </p:cNvPr>
@@ -7989,7 +7989,7 @@
           <p:cNvPr id="34" name="">
             <a:extLst xmlns:a="http://schemas.openxmlformats.org/drawingml/2006/main">
               <a:ext uri="{FF2B5EF4-FFF2-40B4-BE49-F238E27FC236}">
-                <a16:creationId xmlns:a16="http://schemas.microsoft.com/office/drawing/2014/main" id="{766DB01C-5B19-4459-8685-ECA2AEE1596B}"/>
+                <a16:creationId xmlns:a16="http://schemas.microsoft.com/office/drawing/2014/main" id="{C1A92EBF-8690-4751-9A1A-44610043BE2E}"/>
               </a:ext>
             </a:extLst>
           </p:cNvPr>
@@ -8022,7 +8022,7 @@
           <p:cNvPr id="35" name="">
             <a:extLst xmlns:a="http://schemas.openxmlformats.org/drawingml/2006/main">
               <a:ext uri="{FF2B5EF4-FFF2-40B4-BE49-F238E27FC236}">
-                <a16:creationId xmlns:a16="http://schemas.microsoft.com/office/drawing/2014/main" id="{C8A3DA40-F78F-420E-90AB-BA35D6C0F71B}"/>
+                <a16:creationId xmlns:a16="http://schemas.microsoft.com/office/drawing/2014/main" id="{1A865A71-1AF6-4DEC-BC4D-4C13D4892DEA}"/>
               </a:ext>
             </a:extLst>
           </p:cNvPr>
@@ -8072,7 +8072,7 @@
           <p:cNvPr id="36" name="">
             <a:extLst xmlns:a="http://schemas.openxmlformats.org/drawingml/2006/main">
               <a:ext uri="{FF2B5EF4-FFF2-40B4-BE49-F238E27FC236}">
-                <a16:creationId xmlns:a16="http://schemas.microsoft.com/office/drawing/2014/main" id="{812ED0DE-346B-4E7F-A8F6-10BF13CC5C7A}"/>
+                <a16:creationId xmlns:a16="http://schemas.microsoft.com/office/drawing/2014/main" id="{68AFDD15-17FA-40D8-877E-C3A8CC16BCA8}"/>
               </a:ext>
             </a:extLst>
           </p:cNvPr>
@@ -8105,7 +8105,7 @@
           <p:cNvPr id="37" name="">
             <a:extLst xmlns:a="http://schemas.openxmlformats.org/drawingml/2006/main">
               <a:ext uri="{FF2B5EF4-FFF2-40B4-BE49-F238E27FC236}">
-                <a16:creationId xmlns:a16="http://schemas.microsoft.com/office/drawing/2014/main" id="{0AAF58EB-CBC2-4482-A277-5D43370681E6}"/>
+                <a16:creationId xmlns:a16="http://schemas.microsoft.com/office/drawing/2014/main" id="{C056DDD1-CF79-405C-9828-9F974B3DD942}"/>
               </a:ext>
             </a:extLst>
           </p:cNvPr>
@@ -8155,7 +8155,7 @@
           <p:cNvPr id="38" name="">
             <a:extLst xmlns:a="http://schemas.openxmlformats.org/drawingml/2006/main">
               <a:ext uri="{FF2B5EF4-FFF2-40B4-BE49-F238E27FC236}">
-                <a16:creationId xmlns:a16="http://schemas.microsoft.com/office/drawing/2014/main" id="{2350C528-7074-4D3C-8AFD-5A9110D5D33B}"/>
+                <a16:creationId xmlns:a16="http://schemas.microsoft.com/office/drawing/2014/main" id="{25D5E133-19D8-463D-870F-F43AB8181283}"/>
               </a:ext>
             </a:extLst>
           </p:cNvPr>
@@ -8188,7 +8188,7 @@
           <p:cNvPr id="39" name="">
             <a:extLst xmlns:a="http://schemas.openxmlformats.org/drawingml/2006/main">
               <a:ext uri="{FF2B5EF4-FFF2-40B4-BE49-F238E27FC236}">
-                <a16:creationId xmlns:a16="http://schemas.microsoft.com/office/drawing/2014/main" id="{17A3DE03-90C5-4298-9180-5F83ED97F58D}"/>
+                <a16:creationId xmlns:a16="http://schemas.microsoft.com/office/drawing/2014/main" id="{141F444B-A218-47AA-923D-759C8BC9041F}"/>
               </a:ext>
             </a:extLst>
           </p:cNvPr>
@@ -8238,7 +8238,7 @@
           <p:cNvPr id="40" name="">
             <a:extLst xmlns:a="http://schemas.openxmlformats.org/drawingml/2006/main">
               <a:ext uri="{FF2B5EF4-FFF2-40B4-BE49-F238E27FC236}">
-                <a16:creationId xmlns:a16="http://schemas.microsoft.com/office/drawing/2014/main" id="{4FE910EE-CA46-4411-A2AB-7C11C73DD203}"/>
+                <a16:creationId xmlns:a16="http://schemas.microsoft.com/office/drawing/2014/main" id="{4AFA6669-70B3-48E1-BCC6-58F8E2AE0F50}"/>
               </a:ext>
             </a:extLst>
           </p:cNvPr>
@@ -8271,7 +8271,7 @@
           <p:cNvPr id="41" name="">
             <a:extLst xmlns:a="http://schemas.openxmlformats.org/drawingml/2006/main">
               <a:ext uri="{FF2B5EF4-FFF2-40B4-BE49-F238E27FC236}">
-                <a16:creationId xmlns:a16="http://schemas.microsoft.com/office/drawing/2014/main" id="{B57D77DB-CABB-4D24-BE22-65FDF9ED7DD4}"/>
+                <a16:creationId xmlns:a16="http://schemas.microsoft.com/office/drawing/2014/main" id="{FBE31BED-660A-4987-ACCC-96906DEC71FF}"/>
               </a:ext>
             </a:extLst>
           </p:cNvPr>
@@ -8338,7 +8338,7 @@
           <p:cNvPr id="42" name="">
             <a:extLst xmlns:a="http://schemas.openxmlformats.org/drawingml/2006/main">
               <a:ext uri="{FF2B5EF4-FFF2-40B4-BE49-F238E27FC236}">
-                <a16:creationId xmlns:a16="http://schemas.microsoft.com/office/drawing/2014/main" id="{6C11B5ED-45E6-478F-A677-89092317ECCD}"/>
+                <a16:creationId xmlns:a16="http://schemas.microsoft.com/office/drawing/2014/main" id="{10D98F03-A5B0-4667-BA96-43A8FE9A31C3}"/>
               </a:ext>
             </a:extLst>
           </p:cNvPr>
@@ -8371,7 +8371,7 @@
           <p:cNvPr id="43" name="">
             <a:extLst xmlns:a="http://schemas.openxmlformats.org/drawingml/2006/main">
               <a:ext uri="{FF2B5EF4-FFF2-40B4-BE49-F238E27FC236}">
-                <a16:creationId xmlns:a16="http://schemas.microsoft.com/office/drawing/2014/main" id="{577A6619-D398-4786-A54D-D930873DF1E4}"/>
+                <a16:creationId xmlns:a16="http://schemas.microsoft.com/office/drawing/2014/main" id="{4D252523-184C-4E9B-B094-1A2800D5C6F4}"/>
               </a:ext>
             </a:extLst>
           </p:cNvPr>
@@ -8421,7 +8421,7 @@
           <p:cNvPr id="44" name="">
             <a:extLst xmlns:a="http://schemas.openxmlformats.org/drawingml/2006/main">
               <a:ext uri="{FF2B5EF4-FFF2-40B4-BE49-F238E27FC236}">
-                <a16:creationId xmlns:a16="http://schemas.microsoft.com/office/drawing/2014/main" id="{29A2C49B-B0DF-4862-94BC-5D3FAA0F7358}"/>
+                <a16:creationId xmlns:a16="http://schemas.microsoft.com/office/drawing/2014/main" id="{09624099-D56E-4B2A-8761-32A0C734F124}"/>
               </a:ext>
             </a:extLst>
           </p:cNvPr>
@@ -8454,7 +8454,7 @@
           <p:cNvPr id="45" name="">
             <a:extLst xmlns:a="http://schemas.openxmlformats.org/drawingml/2006/main">
               <a:ext uri="{FF2B5EF4-FFF2-40B4-BE49-F238E27FC236}">
-                <a16:creationId xmlns:a16="http://schemas.microsoft.com/office/drawing/2014/main" id="{CF4D4667-AEF4-4E10-B2B8-D3661C74FA9E}"/>
+                <a16:creationId xmlns:a16="http://schemas.microsoft.com/office/drawing/2014/main" id="{80CF33AD-EC44-42CB-B10F-164AB13FE586}"/>
               </a:ext>
             </a:extLst>
           </p:cNvPr>
@@ -8504,7 +8504,7 @@
           <p:cNvPr id="46" name="">
             <a:extLst xmlns:a="http://schemas.openxmlformats.org/drawingml/2006/main">
               <a:ext uri="{FF2B5EF4-FFF2-40B4-BE49-F238E27FC236}">
-                <a16:creationId xmlns:a16="http://schemas.microsoft.com/office/drawing/2014/main" id="{0C100B31-3D8B-4C27-A604-04ACCA975C80}"/>
+                <a16:creationId xmlns:a16="http://schemas.microsoft.com/office/drawing/2014/main" id="{D49AC2B1-8A03-4856-93F9-53C595CC3A83}"/>
               </a:ext>
             </a:extLst>
           </p:cNvPr>
@@ -8554,7 +8554,7 @@
           <p:cNvPr id="47" name="">
             <a:extLst xmlns:a="http://schemas.openxmlformats.org/drawingml/2006/main">
               <a:ext uri="{FF2B5EF4-FFF2-40B4-BE49-F238E27FC236}">
-                <a16:creationId xmlns:a16="http://schemas.microsoft.com/office/drawing/2014/main" id="{60DE570F-94AD-4586-82A1-448B12AB3037}"/>
+                <a16:creationId xmlns:a16="http://schemas.microsoft.com/office/drawing/2014/main" id="{A594B8D0-2022-4BDA-B9C1-81A57619922E}"/>
               </a:ext>
             </a:extLst>
           </p:cNvPr>
@@ -8602,7 +8602,7 @@
     </p:spTree>
     <p:extLst>
       <p:ext uri="{BB962C8B-B14F-4D97-AF65-F5344CB8AC3E}">
-        <p14:creationId xmlns:p14="http://schemas.microsoft.com/office/powerpoint/2010/main" val="1987706254"/>
+        <p14:creationId xmlns:p14="http://schemas.microsoft.com/office/powerpoint/2010/main" val="313829244"/>
       </p:ext>
     </p:extLst>
   </p:cSld>
@@ -8633,7 +8633,7 @@
           <p:cNvPr id="19" name="slide-7-title">
             <a:extLst xmlns:a="http://schemas.openxmlformats.org/drawingml/2006/main">
               <a:ext uri="{FF2B5EF4-FFF2-40B4-BE49-F238E27FC236}">
-                <a16:creationId xmlns:a16="http://schemas.microsoft.com/office/drawing/2014/main" id="{B3E839F6-608F-46CC-84F7-8CF9849D6B07}"/>
+                <a16:creationId xmlns:a16="http://schemas.microsoft.com/office/drawing/2014/main" id="{A30E531F-F656-48C6-A370-12CAE470878A}"/>
               </a:ext>
             </a:extLst>
           </p:cNvPr>
@@ -8683,7 +8683,7 @@
           <p:cNvPr id="2" name="">
             <a:extLst xmlns:a="http://schemas.openxmlformats.org/drawingml/2006/main">
               <a:ext uri="{FF2B5EF4-FFF2-40B4-BE49-F238E27FC236}">
-                <a16:creationId xmlns:a16="http://schemas.microsoft.com/office/drawing/2014/main" id="{320A38DA-AD94-425B-A94E-56532319943C}"/>
+                <a16:creationId xmlns:a16="http://schemas.microsoft.com/office/drawing/2014/main" id="{3BA565D8-B881-400C-B640-273C237AD362}"/>
               </a:ext>
             </a:extLst>
           </p:cNvPr>
@@ -8755,7 +8755,7 @@
           <p:cNvPr id="4" name="">
             <a:extLst xmlns:a="http://schemas.openxmlformats.org/drawingml/2006/main">
               <a:ext uri="{FF2B5EF4-FFF2-40B4-BE49-F238E27FC236}">
-                <a16:creationId xmlns:a16="http://schemas.microsoft.com/office/drawing/2014/main" id="{E6C7CC2B-93F4-4DF7-AE5A-E8C1FF11FBD4}"/>
+                <a16:creationId xmlns:a16="http://schemas.microsoft.com/office/drawing/2014/main" id="{C886FC69-1F6F-43A6-B31F-23261E82CEF5}"/>
               </a:ext>
             </a:extLst>
           </p:cNvPr>
@@ -8805,7 +8805,7 @@
           <p:cNvPr id="5" name="">
             <a:extLst xmlns:a="http://schemas.openxmlformats.org/drawingml/2006/main">
               <a:ext uri="{FF2B5EF4-FFF2-40B4-BE49-F238E27FC236}">
-                <a16:creationId xmlns:a16="http://schemas.microsoft.com/office/drawing/2014/main" id="{10933025-B9DF-4876-AE56-4708B0F5A4B8}"/>
+                <a16:creationId xmlns:a16="http://schemas.microsoft.com/office/drawing/2014/main" id="{A9BFF07E-9A81-454F-B4A6-2EEA78164C9F}"/>
               </a:ext>
             </a:extLst>
           </p:cNvPr>
@@ -8855,7 +8855,7 @@
           <p:cNvPr id="6" name="">
             <a:extLst xmlns:a="http://schemas.openxmlformats.org/drawingml/2006/main">
               <a:ext uri="{FF2B5EF4-FFF2-40B4-BE49-F238E27FC236}">
-                <a16:creationId xmlns:a16="http://schemas.microsoft.com/office/drawing/2014/main" id="{729CA1B6-E3CE-489A-B5A2-44F7E0999D55}"/>
+                <a16:creationId xmlns:a16="http://schemas.microsoft.com/office/drawing/2014/main" id="{82285E05-5D02-43F5-BAA1-BA3237D03B50}"/>
               </a:ext>
             </a:extLst>
           </p:cNvPr>
@@ -8927,7 +8927,7 @@
           <p:cNvPr id="8" name="">
             <a:extLst xmlns:a="http://schemas.openxmlformats.org/drawingml/2006/main">
               <a:ext uri="{FF2B5EF4-FFF2-40B4-BE49-F238E27FC236}">
-                <a16:creationId xmlns:a16="http://schemas.microsoft.com/office/drawing/2014/main" id="{693B3206-BBDF-4DAE-A1B1-02F7A4FB4759}"/>
+                <a16:creationId xmlns:a16="http://schemas.microsoft.com/office/drawing/2014/main" id="{D330DCFA-1BE4-4A88-8E56-F22CDE4FD1BD}"/>
               </a:ext>
             </a:extLst>
           </p:cNvPr>
@@ -8977,7 +8977,7 @@
           <p:cNvPr id="9" name="">
             <a:extLst xmlns:a="http://schemas.openxmlformats.org/drawingml/2006/main">
               <a:ext uri="{FF2B5EF4-FFF2-40B4-BE49-F238E27FC236}">
-                <a16:creationId xmlns:a16="http://schemas.microsoft.com/office/drawing/2014/main" id="{A25A3BD3-5B3F-44D9-9118-1950E2ACEC8D}"/>
+                <a16:creationId xmlns:a16="http://schemas.microsoft.com/office/drawing/2014/main" id="{EDBFC8C0-AB14-4A22-AFDE-20DD55175E43}"/>
               </a:ext>
             </a:extLst>
           </p:cNvPr>
@@ -9027,7 +9027,7 @@
           <p:cNvPr id="10" name="">
             <a:extLst xmlns:a="http://schemas.openxmlformats.org/drawingml/2006/main">
               <a:ext uri="{FF2B5EF4-FFF2-40B4-BE49-F238E27FC236}">
-                <a16:creationId xmlns:a16="http://schemas.microsoft.com/office/drawing/2014/main" id="{7F0BB7E1-2E13-4FB9-AFE3-AC669B56B6F0}"/>
+                <a16:creationId xmlns:a16="http://schemas.microsoft.com/office/drawing/2014/main" id="{27C9B55D-BACC-4691-8529-4431E22E85CF}"/>
               </a:ext>
             </a:extLst>
           </p:cNvPr>
@@ -9099,7 +9099,7 @@
           <p:cNvPr id="12" name="">
             <a:extLst xmlns:a="http://schemas.openxmlformats.org/drawingml/2006/main">
               <a:ext uri="{FF2B5EF4-FFF2-40B4-BE49-F238E27FC236}">
-                <a16:creationId xmlns:a16="http://schemas.microsoft.com/office/drawing/2014/main" id="{84882666-417C-486E-BB5D-6249C6F58C8E}"/>
+                <a16:creationId xmlns:a16="http://schemas.microsoft.com/office/drawing/2014/main" id="{7DA17F34-50BD-47F0-A301-15150CE990BA}"/>
               </a:ext>
             </a:extLst>
           </p:cNvPr>
@@ -9149,7 +9149,7 @@
           <p:cNvPr id="13" name="">
             <a:extLst xmlns:a="http://schemas.openxmlformats.org/drawingml/2006/main">
               <a:ext uri="{FF2B5EF4-FFF2-40B4-BE49-F238E27FC236}">
-                <a16:creationId xmlns:a16="http://schemas.microsoft.com/office/drawing/2014/main" id="{192F06C7-67A6-438D-87C3-E303A6E5D390}"/>
+                <a16:creationId xmlns:a16="http://schemas.microsoft.com/office/drawing/2014/main" id="{3A4CBED6-5FB8-44E0-8669-C9D26778F3FD}"/>
               </a:ext>
             </a:extLst>
           </p:cNvPr>
@@ -9199,7 +9199,7 @@
           <p:cNvPr id="14" name="">
             <a:extLst xmlns:a="http://schemas.openxmlformats.org/drawingml/2006/main">
               <a:ext uri="{FF2B5EF4-FFF2-40B4-BE49-F238E27FC236}">
-                <a16:creationId xmlns:a16="http://schemas.microsoft.com/office/drawing/2014/main" id="{7BF329B4-DF55-4AAC-8343-2858082F6713}"/>
+                <a16:creationId xmlns:a16="http://schemas.microsoft.com/office/drawing/2014/main" id="{9F83745D-93F8-48EF-A8E2-DE6BE6B058EA}"/>
               </a:ext>
             </a:extLst>
           </p:cNvPr>
@@ -9271,7 +9271,7 @@
           <p:cNvPr id="16" name="">
             <a:extLst xmlns:a="http://schemas.openxmlformats.org/drawingml/2006/main">
               <a:ext uri="{FF2B5EF4-FFF2-40B4-BE49-F238E27FC236}">
-                <a16:creationId xmlns:a16="http://schemas.microsoft.com/office/drawing/2014/main" id="{60AA8FB5-202F-4F25-8C0F-0B84B879E789}"/>
+                <a16:creationId xmlns:a16="http://schemas.microsoft.com/office/drawing/2014/main" id="{1D2C620E-441A-4968-9067-2B2F859244C1}"/>
               </a:ext>
             </a:extLst>
           </p:cNvPr>
@@ -9321,7 +9321,7 @@
           <p:cNvPr id="17" name="">
             <a:extLst xmlns:a="http://schemas.openxmlformats.org/drawingml/2006/main">
               <a:ext uri="{FF2B5EF4-FFF2-40B4-BE49-F238E27FC236}">
-                <a16:creationId xmlns:a16="http://schemas.microsoft.com/office/drawing/2014/main" id="{FCB8A475-40F1-49E9-9DB2-9D2775DD57C6}"/>
+                <a16:creationId xmlns:a16="http://schemas.microsoft.com/office/drawing/2014/main" id="{ECD85F6F-E224-46DA-B279-F68921D67F99}"/>
               </a:ext>
             </a:extLst>
           </p:cNvPr>
@@ -9371,7 +9371,7 @@
           <p:cNvPr id="18" name="">
             <a:extLst xmlns:a="http://schemas.openxmlformats.org/drawingml/2006/main">
               <a:ext uri="{FF2B5EF4-FFF2-40B4-BE49-F238E27FC236}">
-                <a16:creationId xmlns:a16="http://schemas.microsoft.com/office/drawing/2014/main" id="{D5ECE6FB-D1FD-413E-98BD-5C2D38363499}"/>
+                <a16:creationId xmlns:a16="http://schemas.microsoft.com/office/drawing/2014/main" id="{425C51FE-0528-4C48-A1C7-27C1697F87AA}"/>
               </a:ext>
             </a:extLst>
           </p:cNvPr>
@@ -9419,7 +9419,7 @@
     </p:spTree>
     <p:extLst>
       <p:ext uri="{BB962C8B-B14F-4D97-AF65-F5344CB8AC3E}">
-        <p14:creationId xmlns:p14="http://schemas.microsoft.com/office/powerpoint/2010/main" val="954316157"/>
+        <p14:creationId xmlns:p14="http://schemas.microsoft.com/office/powerpoint/2010/main" val="1902305412"/>
       </p:ext>
     </p:extLst>
   </p:cSld>
@@ -9450,7 +9450,7 @@
           <p:cNvPr id="14" name="slide-8-title">
             <a:extLst xmlns:a="http://schemas.openxmlformats.org/drawingml/2006/main">
               <a:ext uri="{FF2B5EF4-FFF2-40B4-BE49-F238E27FC236}">
-                <a16:creationId xmlns:a16="http://schemas.microsoft.com/office/drawing/2014/main" id="{A5470B4D-091E-411A-AA4F-BD8003C87482}"/>
+                <a16:creationId xmlns:a16="http://schemas.microsoft.com/office/drawing/2014/main" id="{9A0913A7-11AA-47AB-9883-AB210CE07FC3}"/>
               </a:ext>
             </a:extLst>
           </p:cNvPr>
@@ -9490,7 +9490,7 @@
                   <a:srgbClr val="111111"/>
                 </a:solidFill>
               </a:rPr>
-              <a:t>Using all training data beats extra model complexity</a:t>
+              <a:t>More data worked; extra complexity did not</a:t>
             </a:r>
           </a:p>
         </p:txBody>
@@ -9500,7 +9500,7 @@
           <p:cNvPr id="2" name="">
             <a:extLst xmlns:a="http://schemas.openxmlformats.org/drawingml/2006/main">
               <a:ext uri="{FF2B5EF4-FFF2-40B4-BE49-F238E27FC236}">
-                <a16:creationId xmlns:a16="http://schemas.microsoft.com/office/drawing/2014/main" id="{E0AE6280-9389-4B21-BAB8-AEE2041757F2}"/>
+                <a16:creationId xmlns:a16="http://schemas.microsoft.com/office/drawing/2014/main" id="{06A0C868-A707-4DED-B903-2B564C8A458F}"/>
               </a:ext>
             </a:extLst>
           </p:cNvPr>
@@ -9557,7 +9557,7 @@
         </p:xfrm>
         <a:graphic xmlns:a="http://schemas.openxmlformats.org/drawingml/2006/main">
           <a:graphicData uri="http://schemas.openxmlformats.org/drawingml/2006/chart">
-            <c:chart xmlns:r="http://schemas.openxmlformats.org/officeDocument/2006/relationships" xmlns:c="http://schemas.openxmlformats.org/drawingml/2006/chart" r:id="R0d58690ec5f84273"/>
+            <c:chart xmlns:r="http://schemas.openxmlformats.org/officeDocument/2006/relationships" xmlns:c="http://schemas.openxmlformats.org/drawingml/2006/chart" r:id="R8cfdfec96331477e"/>
           </a:graphicData>
         </a:graphic>
       </p:graphicFrame>
@@ -9566,7 +9566,7 @@
           <p:cNvPr id="4" name="">
             <a:extLst xmlns:a="http://schemas.openxmlformats.org/drawingml/2006/main">
               <a:ext uri="{FF2B5EF4-FFF2-40B4-BE49-F238E27FC236}">
-                <a16:creationId xmlns:a16="http://schemas.microsoft.com/office/drawing/2014/main" id="{41B1DBA8-2FA4-4771-A594-3D0219E3C1C7}"/>
+                <a16:creationId xmlns:a16="http://schemas.microsoft.com/office/drawing/2014/main" id="{0F8A6816-04DC-48C5-8699-C6CA7C669420}"/>
               </a:ext>
             </a:extLst>
           </p:cNvPr>
@@ -9597,7 +9597,7 @@
           <p:cNvPr id="5" name="">
             <a:extLst xmlns:a="http://schemas.openxmlformats.org/drawingml/2006/main">
               <a:ext uri="{FF2B5EF4-FFF2-40B4-BE49-F238E27FC236}">
-                <a16:creationId xmlns:a16="http://schemas.microsoft.com/office/drawing/2014/main" id="{DD0AADE9-214C-43BB-BFFB-5B54A16E564A}"/>
+                <a16:creationId xmlns:a16="http://schemas.microsoft.com/office/drawing/2014/main" id="{8E62EF8B-AB82-4D35-AAFD-B011CC5A1E28}"/>
               </a:ext>
             </a:extLst>
           </p:cNvPr>
@@ -9647,7 +9647,7 @@
           <p:cNvPr id="6" name="">
             <a:extLst xmlns:a="http://schemas.openxmlformats.org/drawingml/2006/main">
               <a:ext uri="{FF2B5EF4-FFF2-40B4-BE49-F238E27FC236}">
-                <a16:creationId xmlns:a16="http://schemas.microsoft.com/office/drawing/2014/main" id="{489807DC-B5B7-4629-8183-A28556CC27AF}"/>
+                <a16:creationId xmlns:a16="http://schemas.microsoft.com/office/drawing/2014/main" id="{A3F91A6A-956D-4B62-96FA-EB77EDC8F825}"/>
               </a:ext>
             </a:extLst>
           </p:cNvPr>
@@ -9697,7 +9697,7 @@
           <p:cNvPr id="7" name="">
             <a:extLst xmlns:a="http://schemas.openxmlformats.org/drawingml/2006/main">
               <a:ext uri="{FF2B5EF4-FFF2-40B4-BE49-F238E27FC236}">
-                <a16:creationId xmlns:a16="http://schemas.microsoft.com/office/drawing/2014/main" id="{21C60EF5-BFF6-4296-97B3-BA2A086450E1}"/>
+                <a16:creationId xmlns:a16="http://schemas.microsoft.com/office/drawing/2014/main" id="{32AF54C9-42DB-48A9-867F-DDE1457F4C90}"/>
               </a:ext>
             </a:extLst>
           </p:cNvPr>
@@ -9728,7 +9728,7 @@
           <p:cNvPr id="8" name="">
             <a:extLst xmlns:a="http://schemas.openxmlformats.org/drawingml/2006/main">
               <a:ext uri="{FF2B5EF4-FFF2-40B4-BE49-F238E27FC236}">
-                <a16:creationId xmlns:a16="http://schemas.microsoft.com/office/drawing/2014/main" id="{0131AD0D-E9E5-4FA2-99D9-4E68C52DF014}"/>
+                <a16:creationId xmlns:a16="http://schemas.microsoft.com/office/drawing/2014/main" id="{C117416A-0C43-4F2D-80CC-BEB8CC232FB4}"/>
               </a:ext>
             </a:extLst>
           </p:cNvPr>
@@ -9778,7 +9778,7 @@
           <p:cNvPr id="9" name="">
             <a:extLst xmlns:a="http://schemas.openxmlformats.org/drawingml/2006/main">
               <a:ext uri="{FF2B5EF4-FFF2-40B4-BE49-F238E27FC236}">
-                <a16:creationId xmlns:a16="http://schemas.microsoft.com/office/drawing/2014/main" id="{6571ED4E-F983-49F2-84C9-34995004E6F8}"/>
+                <a16:creationId xmlns:a16="http://schemas.microsoft.com/office/drawing/2014/main" id="{FF2CB1DC-C412-4348-91CF-173D9971193C}"/>
               </a:ext>
             </a:extLst>
           </p:cNvPr>
@@ -9828,7 +9828,7 @@
           <p:cNvPr id="10" name="">
             <a:extLst xmlns:a="http://schemas.openxmlformats.org/drawingml/2006/main">
               <a:ext uri="{FF2B5EF4-FFF2-40B4-BE49-F238E27FC236}">
-                <a16:creationId xmlns:a16="http://schemas.microsoft.com/office/drawing/2014/main" id="{477865E5-8FB7-4A03-A811-4134E16DE9A7}"/>
+                <a16:creationId xmlns:a16="http://schemas.microsoft.com/office/drawing/2014/main" id="{B0E501EC-9F16-46BE-9E14-9A97DD47521C}"/>
               </a:ext>
             </a:extLst>
           </p:cNvPr>
@@ -9859,7 +9859,7 @@
           <p:cNvPr id="11" name="">
             <a:extLst xmlns:a="http://schemas.openxmlformats.org/drawingml/2006/main">
               <a:ext uri="{FF2B5EF4-FFF2-40B4-BE49-F238E27FC236}">
-                <a16:creationId xmlns:a16="http://schemas.microsoft.com/office/drawing/2014/main" id="{782D1294-9906-4DAE-A692-B430E5685B3C}"/>
+                <a16:creationId xmlns:a16="http://schemas.microsoft.com/office/drawing/2014/main" id="{D964B965-1FD2-4019-98EB-37CAD706EC3F}"/>
               </a:ext>
             </a:extLst>
           </p:cNvPr>
@@ -9909,7 +9909,7 @@
           <p:cNvPr id="12" name="">
             <a:extLst xmlns:a="http://schemas.openxmlformats.org/drawingml/2006/main">
               <a:ext uri="{FF2B5EF4-FFF2-40B4-BE49-F238E27FC236}">
-                <a16:creationId xmlns:a16="http://schemas.microsoft.com/office/drawing/2014/main" id="{C1BD0A56-F759-4672-9578-41E3D167EBA5}"/>
+                <a16:creationId xmlns:a16="http://schemas.microsoft.com/office/drawing/2014/main" id="{6C400290-157E-457C-8D8F-53523C66A5DF}"/>
               </a:ext>
             </a:extLst>
           </p:cNvPr>
@@ -9959,7 +9959,7 @@
           <p:cNvPr id="13" name="">
             <a:extLst xmlns:a="http://schemas.openxmlformats.org/drawingml/2006/main">
               <a:ext uri="{FF2B5EF4-FFF2-40B4-BE49-F238E27FC236}">
-                <a16:creationId xmlns:a16="http://schemas.microsoft.com/office/drawing/2014/main" id="{2E057E6E-6539-4C5B-99F6-C4BF174B34BE}"/>
+                <a16:creationId xmlns:a16="http://schemas.microsoft.com/office/drawing/2014/main" id="{2C4BC77B-CA7A-4A6C-9A78-8CE740DCF5AF}"/>
               </a:ext>
             </a:extLst>
           </p:cNvPr>
@@ -10007,7 +10007,7 @@
     </p:spTree>
     <p:extLst>
       <p:ext uri="{BB962C8B-B14F-4D97-AF65-F5344CB8AC3E}">
-        <p14:creationId xmlns:p14="http://schemas.microsoft.com/office/powerpoint/2010/main" val="96942998"/>
+        <p14:creationId xmlns:p14="http://schemas.microsoft.com/office/powerpoint/2010/main" val="2024225077"/>
       </p:ext>
     </p:extLst>
   </p:cSld>
@@ -10038,7 +10038,7 @@
           <p:cNvPr id="20" name="slide-9-title">
             <a:extLst xmlns:a="http://schemas.openxmlformats.org/drawingml/2006/main">
               <a:ext uri="{FF2B5EF4-FFF2-40B4-BE49-F238E27FC236}">
-                <a16:creationId xmlns:a16="http://schemas.microsoft.com/office/drawing/2014/main" id="{F2B95DE6-D7F0-40C1-A8B9-A94705E9DF03}"/>
+                <a16:creationId xmlns:a16="http://schemas.microsoft.com/office/drawing/2014/main" id="{D60D6427-115B-4344-B2A2-C6C450CCB9A3}"/>
               </a:ext>
             </a:extLst>
           </p:cNvPr>
@@ -10088,7 +10088,7 @@
           <p:cNvPr id="2" name="">
             <a:extLst xmlns:a="http://schemas.openxmlformats.org/drawingml/2006/main">
               <a:ext uri="{FF2B5EF4-FFF2-40B4-BE49-F238E27FC236}">
-                <a16:creationId xmlns:a16="http://schemas.microsoft.com/office/drawing/2014/main" id="{ACA13D8A-F0C7-4209-B4D2-221A67BEF8A5}"/>
+                <a16:creationId xmlns:a16="http://schemas.microsoft.com/office/drawing/2014/main" id="{ABAFACF2-54C9-4459-B4CF-127D6E71AD57}"/>
               </a:ext>
             </a:extLst>
           </p:cNvPr>
@@ -10138,7 +10138,7 @@
           <p:cNvPr id="3" name="">
             <a:extLst xmlns:a="http://schemas.openxmlformats.org/drawingml/2006/main">
               <a:ext uri="{FF2B5EF4-FFF2-40B4-BE49-F238E27FC236}">
-                <a16:creationId xmlns:a16="http://schemas.microsoft.com/office/drawing/2014/main" id="{44D27BE1-056E-49E4-AE47-7F360756E8A2}"/>
+                <a16:creationId xmlns:a16="http://schemas.microsoft.com/office/drawing/2014/main" id="{700FDB19-7502-427C-B062-63F8BEAAAF62}"/>
               </a:ext>
             </a:extLst>
           </p:cNvPr>
@@ -10188,7 +10188,7 @@
           <p:cNvPr id="4" name="">
             <a:extLst xmlns:a="http://schemas.openxmlformats.org/drawingml/2006/main">
               <a:ext uri="{FF2B5EF4-FFF2-40B4-BE49-F238E27FC236}">
-                <a16:creationId xmlns:a16="http://schemas.microsoft.com/office/drawing/2014/main" id="{B9E5A349-696F-4177-A3D3-52E994E17316}"/>
+                <a16:creationId xmlns:a16="http://schemas.microsoft.com/office/drawing/2014/main" id="{2A6178DF-486A-4B40-8D17-1062CE4D02FA}"/>
               </a:ext>
             </a:extLst>
           </p:cNvPr>
@@ -10238,7 +10238,7 @@
           <p:cNvPr id="5" name="">
             <a:extLst xmlns:a="http://schemas.openxmlformats.org/drawingml/2006/main">
               <a:ext uri="{FF2B5EF4-FFF2-40B4-BE49-F238E27FC236}">
-                <a16:creationId xmlns:a16="http://schemas.microsoft.com/office/drawing/2014/main" id="{600F4043-8773-4A48-9ACD-215D1F0B4ACB}"/>
+                <a16:creationId xmlns:a16="http://schemas.microsoft.com/office/drawing/2014/main" id="{64954410-458C-4BFC-98D4-4033B65167A2}"/>
               </a:ext>
             </a:extLst>
           </p:cNvPr>
@@ -10269,7 +10269,7 @@
           <p:cNvPr id="6" name="">
             <a:extLst xmlns:a="http://schemas.openxmlformats.org/drawingml/2006/main">
               <a:ext uri="{FF2B5EF4-FFF2-40B4-BE49-F238E27FC236}">
-                <a16:creationId xmlns:a16="http://schemas.microsoft.com/office/drawing/2014/main" id="{E6243F9B-DE88-4E38-BEEE-7A14F5C23E86}"/>
+                <a16:creationId xmlns:a16="http://schemas.microsoft.com/office/drawing/2014/main" id="{AC64A0D7-FE65-467E-A211-B67E01DCB9AF}"/>
               </a:ext>
             </a:extLst>
           </p:cNvPr>
@@ -10319,7 +10319,7 @@
           <p:cNvPr id="7" name="">
             <a:extLst xmlns:a="http://schemas.openxmlformats.org/drawingml/2006/main">
               <a:ext uri="{FF2B5EF4-FFF2-40B4-BE49-F238E27FC236}">
-                <a16:creationId xmlns:a16="http://schemas.microsoft.com/office/drawing/2014/main" id="{11CB641B-D60F-4CCF-8688-9B8F741F4101}"/>
+                <a16:creationId xmlns:a16="http://schemas.microsoft.com/office/drawing/2014/main" id="{DA29336A-6622-4068-9101-365026425D9A}"/>
               </a:ext>
             </a:extLst>
           </p:cNvPr>
@@ -10369,7 +10369,7 @@
           <p:cNvPr id="8" name="">
             <a:extLst xmlns:a="http://schemas.openxmlformats.org/drawingml/2006/main">
               <a:ext uri="{FF2B5EF4-FFF2-40B4-BE49-F238E27FC236}">
-                <a16:creationId xmlns:a16="http://schemas.microsoft.com/office/drawing/2014/main" id="{19376139-67B7-428B-8FA1-B8B59789DC5E}"/>
+                <a16:creationId xmlns:a16="http://schemas.microsoft.com/office/drawing/2014/main" id="{D4BE6F80-4593-44FD-A7FC-513195F413B7}"/>
               </a:ext>
             </a:extLst>
           </p:cNvPr>
@@ -10400,7 +10400,7 @@
           <p:cNvPr id="9" name="">
             <a:extLst xmlns:a="http://schemas.openxmlformats.org/drawingml/2006/main">
               <a:ext uri="{FF2B5EF4-FFF2-40B4-BE49-F238E27FC236}">
-                <a16:creationId xmlns:a16="http://schemas.microsoft.com/office/drawing/2014/main" id="{405D4D3C-0A7C-4D34-BF1B-E27541A9BC75}"/>
+                <a16:creationId xmlns:a16="http://schemas.microsoft.com/office/drawing/2014/main" id="{4971DB63-CF55-4524-8C62-7F6294935034}"/>
               </a:ext>
             </a:extLst>
           </p:cNvPr>
@@ -10450,7 +10450,7 @@
           <p:cNvPr id="10" name="">
             <a:extLst xmlns:a="http://schemas.openxmlformats.org/drawingml/2006/main">
               <a:ext uri="{FF2B5EF4-FFF2-40B4-BE49-F238E27FC236}">
-                <a16:creationId xmlns:a16="http://schemas.microsoft.com/office/drawing/2014/main" id="{174025D3-AD8C-4E53-AEC0-32FF76722A20}"/>
+                <a16:creationId xmlns:a16="http://schemas.microsoft.com/office/drawing/2014/main" id="{993F8AE9-7ED8-41BD-937F-0227A1F9878C}"/>
               </a:ext>
             </a:extLst>
           </p:cNvPr>
@@ -10500,7 +10500,7 @@
           <p:cNvPr id="11" name="">
             <a:extLst xmlns:a="http://schemas.openxmlformats.org/drawingml/2006/main">
               <a:ext uri="{FF2B5EF4-FFF2-40B4-BE49-F238E27FC236}">
-                <a16:creationId xmlns:a16="http://schemas.microsoft.com/office/drawing/2014/main" id="{8848C4C7-12F4-4ECE-8CC1-C5D4A1F8B601}"/>
+                <a16:creationId xmlns:a16="http://schemas.microsoft.com/office/drawing/2014/main" id="{59DFD881-4833-4C2D-A20F-B711E4933778}"/>
               </a:ext>
             </a:extLst>
           </p:cNvPr>
@@ -10531,7 +10531,7 @@
           <p:cNvPr id="12" name="">
             <a:extLst xmlns:a="http://schemas.openxmlformats.org/drawingml/2006/main">
               <a:ext uri="{FF2B5EF4-FFF2-40B4-BE49-F238E27FC236}">
-                <a16:creationId xmlns:a16="http://schemas.microsoft.com/office/drawing/2014/main" id="{9FF50882-40AC-4CEF-8D3A-18038102C319}"/>
+                <a16:creationId xmlns:a16="http://schemas.microsoft.com/office/drawing/2014/main" id="{11B64816-F235-4D0D-B09C-8F9D5B41DEDA}"/>
               </a:ext>
             </a:extLst>
           </p:cNvPr>
@@ -10581,7 +10581,7 @@
           <p:cNvPr id="13" name="">
             <a:extLst xmlns:a="http://schemas.openxmlformats.org/drawingml/2006/main">
               <a:ext uri="{FF2B5EF4-FFF2-40B4-BE49-F238E27FC236}">
-                <a16:creationId xmlns:a16="http://schemas.microsoft.com/office/drawing/2014/main" id="{0D862D25-6DFE-412C-A953-AE68EB593A6A}"/>
+                <a16:creationId xmlns:a16="http://schemas.microsoft.com/office/drawing/2014/main" id="{87B4240E-F4C7-4B3F-8BB1-FBE6CD3CBF75}"/>
               </a:ext>
             </a:extLst>
           </p:cNvPr>
@@ -10631,7 +10631,7 @@
           <p:cNvPr id="14" name="">
             <a:extLst xmlns:a="http://schemas.openxmlformats.org/drawingml/2006/main">
               <a:ext uri="{FF2B5EF4-FFF2-40B4-BE49-F238E27FC236}">
-                <a16:creationId xmlns:a16="http://schemas.microsoft.com/office/drawing/2014/main" id="{80DFAFC1-11AB-479F-83BD-76BC9F666164}"/>
+                <a16:creationId xmlns:a16="http://schemas.microsoft.com/office/drawing/2014/main" id="{D04AB4E6-2117-476D-90A0-EBFA288D869F}"/>
               </a:ext>
             </a:extLst>
           </p:cNvPr>
@@ -10662,7 +10662,7 @@
           <p:cNvPr id="15" name="">
             <a:extLst xmlns:a="http://schemas.openxmlformats.org/drawingml/2006/main">
               <a:ext uri="{FF2B5EF4-FFF2-40B4-BE49-F238E27FC236}">
-                <a16:creationId xmlns:a16="http://schemas.microsoft.com/office/drawing/2014/main" id="{7F2DDB3F-DD67-4C44-B06A-4423669996E2}"/>
+                <a16:creationId xmlns:a16="http://schemas.microsoft.com/office/drawing/2014/main" id="{4BA2B1C9-4CB5-48E0-B174-94D51B7709E8}"/>
               </a:ext>
             </a:extLst>
           </p:cNvPr>
@@ -10734,7 +10734,7 @@
           <p:cNvPr id="17" name="">
             <a:extLst xmlns:a="http://schemas.openxmlformats.org/drawingml/2006/main">
               <a:ext uri="{FF2B5EF4-FFF2-40B4-BE49-F238E27FC236}">
-                <a16:creationId xmlns:a16="http://schemas.microsoft.com/office/drawing/2014/main" id="{921061CC-3869-4566-9927-138B8B085F40}"/>
+                <a16:creationId xmlns:a16="http://schemas.microsoft.com/office/drawing/2014/main" id="{F948D03C-7228-42F1-A606-869223B30B40}"/>
               </a:ext>
             </a:extLst>
           </p:cNvPr>
@@ -10784,7 +10784,7 @@
           <p:cNvPr id="18" name="">
             <a:extLst xmlns:a="http://schemas.openxmlformats.org/drawingml/2006/main">
               <a:ext uri="{FF2B5EF4-FFF2-40B4-BE49-F238E27FC236}">
-                <a16:creationId xmlns:a16="http://schemas.microsoft.com/office/drawing/2014/main" id="{89A2D58F-E15A-4BE9-B6A3-43D27D84B6D4}"/>
+                <a16:creationId xmlns:a16="http://schemas.microsoft.com/office/drawing/2014/main" id="{08AC9FFA-0A0C-4DD9-8740-1E18B38E5786}"/>
               </a:ext>
             </a:extLst>
           </p:cNvPr>
@@ -10834,7 +10834,7 @@
           <p:cNvPr id="19" name="">
             <a:extLst xmlns:a="http://schemas.openxmlformats.org/drawingml/2006/main">
               <a:ext uri="{FF2B5EF4-FFF2-40B4-BE49-F238E27FC236}">
-                <a16:creationId xmlns:a16="http://schemas.microsoft.com/office/drawing/2014/main" id="{BD451731-84AD-4A5D-B367-3BE29239EFCF}"/>
+                <a16:creationId xmlns:a16="http://schemas.microsoft.com/office/drawing/2014/main" id="{BC55074B-B665-4112-8C68-566FE5E7BBD9}"/>
               </a:ext>
             </a:extLst>
           </p:cNvPr>
@@ -10933,7 +10933,7 @@
     </p:spTree>
     <p:extLst>
       <p:ext uri="{BB962C8B-B14F-4D97-AF65-F5344CB8AC3E}">
-        <p14:creationId xmlns:p14="http://schemas.microsoft.com/office/powerpoint/2010/main" val="1364811736"/>
+        <p14:creationId xmlns:p14="http://schemas.microsoft.com/office/powerpoint/2010/main" val="948970082"/>
       </p:ext>
     </p:extLst>
   </p:cSld>

</xml_diff>

<commit_message>
Improve final presentation visuals and pacing
</commit_message>
<xml_diff>
--- a/slides/MSBA_Job_Matching_Final_Deck.pptx
+++ b/slides/MSBA_Job_Matching_Final_Deck.pptx
@@ -2,22 +2,22 @@
 <file path=ppt/presentation.xml><?xml version="1.0" encoding="utf-8"?>
 <p:presentation xmlns:p="http://schemas.openxmlformats.org/presentationml/2006/main">
   <p:sldMasterIdLst>
-    <p:sldMasterId xmlns:r="http://schemas.openxmlformats.org/officeDocument/2006/relationships" id="2147483648" r:id="R5a9af1d80c304a53"/>
+    <p:sldMasterId xmlns:r="http://schemas.openxmlformats.org/officeDocument/2006/relationships" id="2147483648" r:id="R65eac2ef5809441a"/>
   </p:sldMasterIdLst>
   <p:notesMasterIdLst>
-    <p:notesMasterId xmlns:r="http://schemas.openxmlformats.org/officeDocument/2006/relationships" r:id="Re23f7da17dea4144"/>
+    <p:notesMasterId xmlns:r="http://schemas.openxmlformats.org/officeDocument/2006/relationships" r:id="Rb5b5477f0d804a1c"/>
   </p:notesMasterIdLst>
   <p:sldIdLst>
-    <p:sldId xmlns:r="http://schemas.openxmlformats.org/officeDocument/2006/relationships" id="256" r:id="R102dcf91f5c74ecd"/>
-    <p:sldId xmlns:r="http://schemas.openxmlformats.org/officeDocument/2006/relationships" id="257" r:id="Rff192712ad214951"/>
-    <p:sldId xmlns:r="http://schemas.openxmlformats.org/officeDocument/2006/relationships" id="258" r:id="R1125972501be4e7d"/>
-    <p:sldId xmlns:r="http://schemas.openxmlformats.org/officeDocument/2006/relationships" id="259" r:id="R081b191ede1046c2"/>
-    <p:sldId xmlns:r="http://schemas.openxmlformats.org/officeDocument/2006/relationships" id="260" r:id="Ra9e8e2a0a2f34cb7"/>
-    <p:sldId xmlns:r="http://schemas.openxmlformats.org/officeDocument/2006/relationships" id="261" r:id="Rfbdcb05825564ed3"/>
-    <p:sldId xmlns:r="http://schemas.openxmlformats.org/officeDocument/2006/relationships" id="262" r:id="R572638e9f293434c"/>
-    <p:sldId xmlns:r="http://schemas.openxmlformats.org/officeDocument/2006/relationships" id="263" r:id="R724978658f524156"/>
-    <p:sldId xmlns:r="http://schemas.openxmlformats.org/officeDocument/2006/relationships" id="264" r:id="R9920695a6bbb4118"/>
-    <p:sldId xmlns:r="http://schemas.openxmlformats.org/officeDocument/2006/relationships" id="265" r:id="R4e43aeba136f4cdf"/>
+    <p:sldId xmlns:r="http://schemas.openxmlformats.org/officeDocument/2006/relationships" id="256" r:id="R221607b3139f4315"/>
+    <p:sldId xmlns:r="http://schemas.openxmlformats.org/officeDocument/2006/relationships" id="257" r:id="Rb38e61ac65c942bb"/>
+    <p:sldId xmlns:r="http://schemas.openxmlformats.org/officeDocument/2006/relationships" id="258" r:id="R661aa527b9934349"/>
+    <p:sldId xmlns:r="http://schemas.openxmlformats.org/officeDocument/2006/relationships" id="259" r:id="R35dee5ad164c444a"/>
+    <p:sldId xmlns:r="http://schemas.openxmlformats.org/officeDocument/2006/relationships" id="260" r:id="R8c7e7f2171544a85"/>
+    <p:sldId xmlns:r="http://schemas.openxmlformats.org/officeDocument/2006/relationships" id="261" r:id="Re0c18cd6629641c2"/>
+    <p:sldId xmlns:r="http://schemas.openxmlformats.org/officeDocument/2006/relationships" id="262" r:id="Rdbd87430ccd44650"/>
+    <p:sldId xmlns:r="http://schemas.openxmlformats.org/officeDocument/2006/relationships" id="263" r:id="Ra195156a4e5c4f4f"/>
+    <p:sldId xmlns:r="http://schemas.openxmlformats.org/officeDocument/2006/relationships" id="264" r:id="R3743c1472a304eda"/>
+    <p:sldId xmlns:r="http://schemas.openxmlformats.org/officeDocument/2006/relationships" id="265" r:id="Ra022d69823554a66"/>
   </p:sldIdLst>
   <p:sldSz cx="12192000" cy="6858000"/>
   <p:notesSz cx="6858000" cy="9144000"/>
@@ -451,32 +451,17 @@
           <a:lstStyle xmlns:a="http://schemas.openxmlformats.org/drawingml/2006/main"/>
           <a:p xmlns:a="http://schemas.openxmlformats.org/drawingml/2006/main">
             <a:r>
-              <a:t>Open with the business decision: the product helps an advisor prioritize postings, while final forwarding and authorization review stay human.</a:t>
-            </a:r>
-          </a:p>
-          <a:p xmlns:a="http://schemas.openxmlformats.org/drawingml/2006/main">
-            <a:r>
-              <a:t/>
-            </a:r>
-          </a:p>
-          <a:p xmlns:a="http://schemas.openxmlformats.org/drawingml/2006/main">
-            <a:r>
               <a:t>[Sources]</a:t>
             </a:r>
           </a:p>
           <a:p xmlns:a="http://schemas.openxmlformats.org/drawingml/2006/main">
             <a:r>
-              <a:t>- Local project README.md</a:t>
-            </a:r>
-          </a:p>
-          <a:p xmlns:a="http://schemas.openxmlformats.org/drawingml/2006/main">
-            <a:r>
-              <a:t>- docs/problem_statement.md</a:t>
-            </a:r>
-          </a:p>
-          <a:p xmlns:a="http://schemas.openxmlformats.org/drawingml/2006/main">
-            <a:r>
-              <a:t>[/Sources]</a:t>
+              <a:t>Illustrative image generated for this presentation with OpenAI image generation.</a:t>
+            </a:r>
+          </a:p>
+          <a:p xmlns:a="http://schemas.openxmlformats.org/drawingml/2006/main">
+            <a:r>
+              <a:t>Project claims: repository README and committed evaluation outputs.</a:t>
             </a:r>
           </a:p>
         </p:txBody>
@@ -546,47 +531,17 @@
           <a:lstStyle xmlns:a="http://schemas.openxmlformats.org/drawingml/2006/main"/>
           <a:p xmlns:a="http://schemas.openxmlformats.org/drawingml/2006/main">
             <a:r>
-              <a:t>Close with what is complete: the trained system, calibrated uncertainty policy, hard-constraint search audit, batch workflow, time-based test, full-source authorization audit, and human-review package. The blank advisor fields are an honest deployment boundary, not a missing model output.</a:t>
-            </a:r>
-          </a:p>
-          <a:p xmlns:a="http://schemas.openxmlformats.org/drawingml/2006/main">
-            <a:r>
-              <a:t/>
-            </a:r>
-          </a:p>
-          <a:p xmlns:a="http://schemas.openxmlformats.org/drawingml/2006/main">
-            <a:r>
               <a:t>[Sources]</a:t>
             </a:r>
           </a:p>
           <a:p xmlns:a="http://schemas.openxmlformats.org/drawingml/2006/main">
             <a:r>
-              <a:t>- README.md</a:t>
-            </a:r>
-          </a:p>
-          <a:p xmlns:a="http://schemas.openxmlformats.org/drawingml/2006/main">
-            <a:r>
-              <a:t>- docs/evaluation_summary.md</a:t>
-            </a:r>
-          </a:p>
-          <a:p xmlns:a="http://schemas.openxmlformats.org/drawingml/2006/main">
-            <a:r>
-              <a:t>- docs/governance_risk_appendix.md</a:t>
-            </a:r>
-          </a:p>
-          <a:p xmlns:a="http://schemas.openxmlformats.org/drawingml/2006/main">
-            <a:r>
-              <a:t>- models/review_policy.json</a:t>
-            </a:r>
-          </a:p>
-          <a:p xmlns:a="http://schemas.openxmlformats.org/drawingml/2006/main">
-            <a:r>
-              <a:t>- outputs/search_constraint_audit.json</a:t>
-            </a:r>
-          </a:p>
-          <a:p xmlns:a="http://schemas.openxmlformats.org/drawingml/2006/main">
-            <a:r>
-              <a:t>[/Sources]</a:t>
+              <a:t>Screenshot extracted from the project-owned recorded demo, demo/final_demo_video.mp4.</a:t>
+            </a:r>
+          </a:p>
+          <a:p xmlns:a="http://schemas.openxmlformats.org/drawingml/2006/main">
+            <a:r>
+              <a:t>Recommendation and metrics: repository README and committed evaluation outputs.</a:t>
             </a:r>
           </a:p>
         </p:txBody>
@@ -1051,27 +1006,17 @@
           <a:lstStyle xmlns:a="http://schemas.openxmlformats.org/drawingml/2006/main"/>
           <a:p xmlns:a="http://schemas.openxmlformats.org/drawingml/2006/main">
             <a:r>
-              <a:t>Explain that this is retrieval, not posting classification. The result list is filtered and reranked by explicit query constraints, then each retrieved posting receives a model label.</a:t>
-            </a:r>
-          </a:p>
-          <a:p xmlns:a="http://schemas.openxmlformats.org/drawingml/2006/main">
-            <a:r>
-              <a:t/>
-            </a:r>
-          </a:p>
-          <a:p xmlns:a="http://schemas.openxmlformats.org/drawingml/2006/main">
-            <a:r>
               <a:t>[Sources]</a:t>
             </a:r>
           </a:p>
           <a:p xmlns:a="http://schemas.openxmlformats.org/drawingml/2006/main">
             <a:r>
-              <a:t>- outputs/final_casebook_outputs.json - entry_level_analytics_search</a:t>
-            </a:r>
-          </a:p>
-          <a:p xmlns:a="http://schemas.openxmlformats.org/drawingml/2006/main">
-            <a:r>
-              <a:t>[/Sources]</a:t>
+              <a:t>Screenshot extracted from the project-owned recorded demo, demo/final_demo_video.mp4.</a:t>
+            </a:r>
+          </a:p>
+          <a:p xmlns:a="http://schemas.openxmlformats.org/drawingml/2006/main">
+            <a:r>
+              <a:t>Audit metrics: outputs/search_constraint_audit.json.</a:t>
             </a:r>
           </a:p>
         </p:txBody>
@@ -1141,32 +1086,17 @@
           <a:lstStyle xmlns:a="http://schemas.openxmlformats.org/drawingml/2006/main"/>
           <a:p xmlns:a="http://schemas.openxmlformats.org/drawingml/2006/main">
             <a:r>
-              <a:t>Contrast the four saved runs. The key case is a high-fit analyst role that explicitly says No OPT/CPT. The policy layer forces Hold, proving that authorization cannot be hidden by a strong fit score.</a:t>
-            </a:r>
-          </a:p>
-          <a:p xmlns:a="http://schemas.openxmlformats.org/drawingml/2006/main">
-            <a:r>
-              <a:t/>
-            </a:r>
-          </a:p>
-          <a:p xmlns:a="http://schemas.openxmlformats.org/drawingml/2006/main">
-            <a:r>
               <a:t>[Sources]</a:t>
             </a:r>
           </a:p>
           <a:p xmlns:a="http://schemas.openxmlformats.org/drawingml/2006/main">
             <a:r>
-              <a:t>- outputs/final_casebook_outputs.json</a:t>
-            </a:r>
-          </a:p>
-          <a:p xmlns:a="http://schemas.openxmlformats.org/drawingml/2006/main">
-            <a:r>
-              <a:t>- docs/governance_risk_appendix.md</a:t>
-            </a:r>
-          </a:p>
-          <a:p xmlns:a="http://schemas.openxmlformats.org/drawingml/2006/main">
-            <a:r>
-              <a:t>[/Sources]</a:t>
+              <a:t>Screenshot extracted from the project-owned recorded demo, demo/final_demo_video.mp4.</a:t>
+            </a:r>
+          </a:p>
+          <a:p xmlns:a="http://schemas.openxmlformats.org/drawingml/2006/main">
+            <a:r>
+              <a:t>Governance outputs: outputs/final_casebook_outputs.json.</a:t>
             </a:r>
           </a:p>
         </p:txBody>
@@ -1444,7 +1374,7 @@
   </p:cSld>
   <p:clrMap bg1="lt1" tx1="dk1" bg2="lt2" tx2="dk2" accent1="accent1" accent2="accent2" accent3="accent3" accent4="accent4" accent5="accent5" accent6="accent6" hlink="hlink" folHlink="folHlink"/>
   <p:sldLayoutIdLst>
-    <p:sldLayoutId xmlns:r="http://schemas.openxmlformats.org/officeDocument/2006/relationships" id="2147483649" r:id="Ref499be4c95144be"/>
+    <p:sldLayoutId xmlns:r="http://schemas.openxmlformats.org/officeDocument/2006/relationships" id="2147483649" r:id="Rd8a3322b80414579"/>
   </p:sldLayoutIdLst>
   <p:txStyles>
     <p:titleStyle>
@@ -2111,9 +2041,7 @@
           </a:p>
         </c:txPr>
         <c:crossAx val="48672768"/>
-        <c:lblAlgn val="ctr"/>
         <c:lblOffset val="100"/>
-        <c:noMultiLvlLbl val="0"/>
       </c:catAx>
       <c:valAx>
         <c:axId val="48672768"/>
@@ -2245,6 +2173,7 @@
           <a:lstStyle xmlns:a="http://schemas.openxmlformats.org/drawingml/2006/main"/>
           <a:p xmlns:a="http://schemas.openxmlformats.org/drawingml/2006/main">
             <a:pPr algn="l">
+              <a:buNone/>
               <a:defRPr sz="1800" b="0">
                 <a:solidFill>
                   <a:srgbClr val="565D67"/>
@@ -2279,7 +2208,7 @@
         <p:spPr>
           <a:xfrm xmlns:a="http://schemas.openxmlformats.org/drawingml/2006/main">
             <a:off x="400050" y="1752600"/>
-            <a:ext cx="9525000" cy="914400"/>
+            <a:ext cx="5429250" cy="1009650"/>
           </a:xfrm>
           <a:prstGeom xmlns:a="http://schemas.openxmlformats.org/drawingml/2006/main" prst="rect">
             <a:avLst/>
@@ -2295,6 +2224,7 @@
           <a:lstStyle xmlns:a="http://schemas.openxmlformats.org/drawingml/2006/main"/>
           <a:p xmlns:a="http://schemas.openxmlformats.org/drawingml/2006/main">
             <a:pPr algn="l">
+              <a:buNone/>
               <a:defRPr sz="5400" b="1">
                 <a:solidFill>
                   <a:srgbClr val="111111"/>
@@ -2329,22 +2259,23 @@
         <p:spPr>
           <a:xfrm xmlns:a="http://schemas.openxmlformats.org/drawingml/2006/main">
             <a:off x="400050" y="2895600"/>
-            <a:ext cx="7810500" cy="609600"/>
-          </a:xfrm>
-          <a:prstGeom xmlns:a="http://schemas.openxmlformats.org/drawingml/2006/main" prst="rect">
-            <a:avLst/>
-          </a:prstGeom>
-          <a:noFill xmlns:a="http://schemas.openxmlformats.org/drawingml/2006/main"/>
-          <a:ln xmlns:a="http://schemas.openxmlformats.org/drawingml/2006/main" w="0">
-            <a:noFill/>
-            <a:prstDash val="solid"/>
-          </a:ln>
-        </p:spPr>
-        <p:txBody>
-          <a:bodyPr xmlns:a="http://schemas.openxmlformats.org/drawingml/2006/main" anchor="t"/>
-          <a:lstStyle xmlns:a="http://schemas.openxmlformats.org/drawingml/2006/main"/>
-          <a:p xmlns:a="http://schemas.openxmlformats.org/drawingml/2006/main">
-            <a:pPr algn="l">
+            <a:ext cx="5048250" cy="857250"/>
+          </a:xfrm>
+          <a:prstGeom xmlns:a="http://schemas.openxmlformats.org/drawingml/2006/main" prst="rect">
+            <a:avLst/>
+          </a:prstGeom>
+          <a:noFill xmlns:a="http://schemas.openxmlformats.org/drawingml/2006/main"/>
+          <a:ln xmlns:a="http://schemas.openxmlformats.org/drawingml/2006/main" w="0">
+            <a:noFill/>
+            <a:prstDash val="solid"/>
+          </a:ln>
+        </p:spPr>
+        <p:txBody>
+          <a:bodyPr xmlns:a="http://schemas.openxmlformats.org/drawingml/2006/main" anchor="t"/>
+          <a:lstStyle xmlns:a="http://schemas.openxmlformats.org/drawingml/2006/main"/>
+          <a:p xmlns:a="http://schemas.openxmlformats.org/drawingml/2006/main">
+            <a:pPr algn="l">
+              <a:buNone/>
               <a:defRPr sz="2700" b="0">
                 <a:solidFill>
                   <a:srgbClr val="111111"/>
@@ -2379,22 +2310,23 @@
         <p:spPr>
           <a:xfrm xmlns:a="http://schemas.openxmlformats.org/drawingml/2006/main">
             <a:off x="400050" y="4857750"/>
-            <a:ext cx="8096250" cy="476250"/>
-          </a:xfrm>
-          <a:prstGeom xmlns:a="http://schemas.openxmlformats.org/drawingml/2006/main" prst="rect">
-            <a:avLst/>
-          </a:prstGeom>
-          <a:noFill xmlns:a="http://schemas.openxmlformats.org/drawingml/2006/main"/>
-          <a:ln xmlns:a="http://schemas.openxmlformats.org/drawingml/2006/main" w="0">
-            <a:noFill/>
-            <a:prstDash val="solid"/>
-          </a:ln>
-        </p:spPr>
-        <p:txBody>
-          <a:bodyPr xmlns:a="http://schemas.openxmlformats.org/drawingml/2006/main" anchor="t"/>
-          <a:lstStyle xmlns:a="http://schemas.openxmlformats.org/drawingml/2006/main"/>
-          <a:p xmlns:a="http://schemas.openxmlformats.org/drawingml/2006/main">
-            <a:pPr algn="l">
+            <a:ext cx="5238750" cy="476250"/>
+          </a:xfrm>
+          <a:prstGeom xmlns:a="http://schemas.openxmlformats.org/drawingml/2006/main" prst="rect">
+            <a:avLst/>
+          </a:prstGeom>
+          <a:noFill xmlns:a="http://schemas.openxmlformats.org/drawingml/2006/main"/>
+          <a:ln xmlns:a="http://schemas.openxmlformats.org/drawingml/2006/main" w="0">
+            <a:noFill/>
+            <a:prstDash val="solid"/>
+          </a:ln>
+        </p:spPr>
+        <p:txBody>
+          <a:bodyPr xmlns:a="http://schemas.openxmlformats.org/drawingml/2006/main" anchor="t"/>
+          <a:lstStyle xmlns:a="http://schemas.openxmlformats.org/drawingml/2006/main"/>
+          <a:p xmlns:a="http://schemas.openxmlformats.org/drawingml/2006/main">
+            <a:pPr algn="l">
+              <a:buNone/>
               <a:defRPr sz="1950" b="0">
                 <a:solidFill>
                   <a:srgbClr val="565D67"/>
@@ -2407,7 +2339,7 @@
                   <a:srgbClr val="565D67"/>
                 </a:solidFill>
               </a:rPr>
-              <a:t>Real postings -&gt; retrieved evidence -&gt; role-fit triage -&gt; human review</a:t>
+              <a:t>Search  |  Fit  |  Evidence  |  Human review</a:t>
             </a:r>
           </a:p>
         </p:txBody>
@@ -2445,6 +2377,7 @@
           <a:lstStyle xmlns:a="http://schemas.openxmlformats.org/drawingml/2006/main"/>
           <a:p xmlns:a="http://schemas.openxmlformats.org/drawingml/2006/main">
             <a:pPr algn="l">
+              <a:buNone/>
               <a:defRPr sz="1650" b="0">
                 <a:solidFill>
                   <a:srgbClr val="3D8DFF"/>
@@ -2495,6 +2428,7 @@
           <a:lstStyle xmlns:a="http://schemas.openxmlformats.org/drawingml/2006/main"/>
           <a:p xmlns:a="http://schemas.openxmlformats.org/drawingml/2006/main">
             <a:pPr algn="r">
+              <a:buNone/>
               <a:defRPr sz="1200" b="0">
                 <a:solidFill>
                   <a:srgbClr val="565D67"/>
@@ -2512,6 +2446,31 @@
           </a:p>
         </p:txBody>
       </p:sp>
+      <p:pic>
+        <p:nvPicPr>
+          <p:cNvPr id="15" name=""/>
+          <p:cNvPicPr>
+            <a:picLocks xmlns:a="http://schemas.openxmlformats.org/drawingml/2006/main" noChangeAspect="1"/>
+          </p:cNvPicPr>
+          <p:nvPr/>
+        </p:nvPicPr>
+        <p:blipFill>
+          <a:blip xmlns:r="http://schemas.openxmlformats.org/officeDocument/2006/relationships" xmlns:a="http://schemas.openxmlformats.org/drawingml/2006/main" r:embed="R5915f6dce40a4a2b"/>
+          <a:srcRect xmlns:a="http://schemas.openxmlformats.org/drawingml/2006/main" l="0" t="4269" r="0" b="4269"/>
+          <a:stretch xmlns:a="http://schemas.openxmlformats.org/drawingml/2006/main">
+            <a:fillRect l="0" t="0" r="0" b="0"/>
+          </a:stretch>
+        </p:blipFill>
+        <p:spPr>
+          <a:xfrm xmlns:a="http://schemas.openxmlformats.org/drawingml/2006/main">
+            <a:off x="6191250" y="0"/>
+            <a:ext cx="6000750" cy="6858000"/>
+          </a:xfrm>
+          <a:prstGeom xmlns:a="http://schemas.openxmlformats.org/drawingml/2006/main" prst="rect">
+            <a:avLst/>
+          </a:prstGeom>
+        </p:spPr>
+      </p:pic>
     </p:spTree>
     <p:extLst>
       <p:ext uri="{BB962C8B-B14F-4D97-AF65-F5344CB8AC3E}">
@@ -2574,6 +2533,7 @@
           <a:lstStyle xmlns:a="http://schemas.openxmlformats.org/drawingml/2006/main"/>
           <a:p xmlns:a="http://schemas.openxmlformats.org/drawingml/2006/main">
             <a:pPr algn="l">
+              <a:buNone/>
               <a:defRPr sz="1800" b="0">
                 <a:solidFill>
                   <a:srgbClr val="565D67"/>
@@ -2586,7 +2546,7 @@
                   <a:srgbClr val="565D67"/>
                 </a:solidFill>
               </a:rPr>
-              <a:t>DELIVERED VALIDATION PACKAGE</a:t>
+              <a:t>RECOMMENDATION</a:t>
             </a:r>
           </a:p>
         </p:txBody>
@@ -2608,7 +2568,7 @@
         <p:spPr>
           <a:xfrm xmlns:a="http://schemas.openxmlformats.org/drawingml/2006/main">
             <a:off x="400050" y="1619250"/>
-            <a:ext cx="10477500" cy="1809750"/>
+            <a:ext cx="5286375" cy="1428750"/>
           </a:xfrm>
           <a:prstGeom xmlns:a="http://schemas.openxmlformats.org/drawingml/2006/main" prst="rect">
             <a:avLst/>
@@ -2624,45 +2584,24 @@
           <a:lstStyle xmlns:a="http://schemas.openxmlformats.org/drawingml/2006/main"/>
           <a:p xmlns:a="http://schemas.openxmlformats.org/drawingml/2006/main">
             <a:pPr algn="l">
-              <a:defRPr sz="4650" b="1">
-                <a:solidFill>
-                  <a:srgbClr val="111111"/>
-                </a:solidFill>
-              </a:defRPr>
-            </a:pPr>
-            <a:r>
-              <a:rPr sz="4650" b="1">
-                <a:solidFill>
-                  <a:srgbClr val="111111"/>
-                </a:solidFill>
-              </a:rPr>
-              <a:t>The system and its human-review package are complete</a:t>
-            </a:r>
-          </a:p>
-        </p:txBody>
-      </p:sp>
-      <p:cxnSp>
-        <p:nvCxnSpPr>
-          <p:cNvPr id="12" name=""/>
-          <p:cNvCxnSpPr/>
-          <p:nvPr/>
-        </p:nvCxnSpPr>
-        <p:spPr>
-          <a:xfrm xmlns:a="http://schemas.openxmlformats.org/drawingml/2006/main">
-            <a:off x="400050" y="3943350"/>
-            <a:ext cx="3333750" cy="0"/>
-          </a:xfrm>
-          <a:prstGeom xmlns:a="http://schemas.openxmlformats.org/drawingml/2006/main" prst="straightConnector1">
-            <a:avLst/>
-          </a:prstGeom>
-          <a:ln xmlns:a="http://schemas.openxmlformats.org/drawingml/2006/main" w="47625">
-            <a:solidFill>
-              <a:srgbClr val="3D8DFF"/>
-            </a:solidFill>
-            <a:prstDash val="solid"/>
-          </a:ln>
-        </p:spPr>
-      </p:cxnSp>
+              <a:buNone/>
+              <a:defRPr sz="3300" b="1">
+                <a:solidFill>
+                  <a:srgbClr val="111111"/>
+                </a:solidFill>
+              </a:defRPr>
+            </a:pPr>
+            <a:r>
+              <a:rPr sz="3300" b="1">
+                <a:solidFill>
+                  <a:srgbClr val="111111"/>
+                </a:solidFill>
+              </a:rPr>
+              <a:t>Ready for a supervised Career Center pilot</a:t>
+            </a:r>
+          </a:p>
+        </p:txBody>
+      </p:sp>
       <p:sp>
         <p:nvSpPr>
           <p:cNvPr id="4" name="">
@@ -2679,23 +2618,24 @@
         </p:nvSpPr>
         <p:spPr>
           <a:xfrm xmlns:a="http://schemas.openxmlformats.org/drawingml/2006/main">
-            <a:off x="400050" y="4305300"/>
-            <a:ext cx="2381250" cy="342900"/>
-          </a:xfrm>
-          <a:prstGeom xmlns:a="http://schemas.openxmlformats.org/drawingml/2006/main" prst="rect">
-            <a:avLst/>
-          </a:prstGeom>
-          <a:noFill xmlns:a="http://schemas.openxmlformats.org/drawingml/2006/main"/>
-          <a:ln xmlns:a="http://schemas.openxmlformats.org/drawingml/2006/main" w="0">
-            <a:noFill/>
-            <a:prstDash val="solid"/>
-          </a:ln>
-        </p:spPr>
-        <p:txBody>
-          <a:bodyPr xmlns:a="http://schemas.openxmlformats.org/drawingml/2006/main" anchor="t"/>
-          <a:lstStyle xmlns:a="http://schemas.openxmlformats.org/drawingml/2006/main"/>
-          <a:p xmlns:a="http://schemas.openxmlformats.org/drawingml/2006/main">
-            <a:pPr algn="l">
+            <a:off x="400050" y="3638550"/>
+            <a:ext cx="4762500" cy="361950"/>
+          </a:xfrm>
+          <a:prstGeom xmlns:a="http://schemas.openxmlformats.org/drawingml/2006/main" prst="rect">
+            <a:avLst/>
+          </a:prstGeom>
+          <a:noFill xmlns:a="http://schemas.openxmlformats.org/drawingml/2006/main"/>
+          <a:ln xmlns:a="http://schemas.openxmlformats.org/drawingml/2006/main" w="0">
+            <a:noFill/>
+            <a:prstDash val="solid"/>
+          </a:ln>
+        </p:spPr>
+        <p:txBody>
+          <a:bodyPr xmlns:a="http://schemas.openxmlformats.org/drawingml/2006/main" anchor="t"/>
+          <a:lstStyle xmlns:a="http://schemas.openxmlformats.org/drawingml/2006/main"/>
+          <a:p xmlns:a="http://schemas.openxmlformats.org/drawingml/2006/main">
+            <a:pPr algn="l">
+              <a:buNone/>
               <a:defRPr sz="2025" b="1">
                 <a:solidFill>
                   <a:srgbClr val="3D8DFF"/>
@@ -2708,7 +2648,7 @@
                   <a:srgbClr val="3D8DFF"/>
                 </a:solidFill>
               </a:rPr>
-              <a:t>Delivered now</a:t>
+              <a:t>Deploy with guardrails</a:t>
             </a:r>
           </a:p>
         </p:txBody>
@@ -2729,138 +2669,76 @@
         </p:nvSpPr>
         <p:spPr>
           <a:xfrm xmlns:a="http://schemas.openxmlformats.org/drawingml/2006/main">
-            <a:off x="400050" y="4819650"/>
-            <a:ext cx="4191000" cy="1352550"/>
-          </a:xfrm>
-          <a:prstGeom xmlns:a="http://schemas.openxmlformats.org/drawingml/2006/main" prst="rect">
-            <a:avLst/>
-          </a:prstGeom>
-          <a:noFill xmlns:a="http://schemas.openxmlformats.org/drawingml/2006/main"/>
-          <a:ln xmlns:a="http://schemas.openxmlformats.org/drawingml/2006/main" w="0">
-            <a:noFill/>
-            <a:prstDash val="solid"/>
-          </a:ln>
-        </p:spPr>
-        <p:txBody>
-          <a:bodyPr xmlns:a="http://schemas.openxmlformats.org/drawingml/2006/main" anchor="t"/>
-          <a:lstStyle xmlns:a="http://schemas.openxmlformats.org/drawingml/2006/main"/>
-          <a:p xmlns:a="http://schemas.openxmlformats.org/drawingml/2006/main">
-            <a:pPr algn="l">
-              <a:defRPr sz="1575" b="0">
-                <a:solidFill>
-                  <a:srgbClr val="111111"/>
-                </a:solidFill>
-              </a:defRPr>
-            </a:pPr>
-            <a:r>
-              <a:rPr sz="1575" b="0">
-                <a:solidFill>
-                  <a:srgbClr val="111111"/>
-                </a:solidFill>
-              </a:rPr>
-              <a:t>Trained classifier</a:t>
-            </a:r>
-          </a:p>
-          <a:p xmlns:a="http://schemas.openxmlformats.org/drawingml/2006/main">
-            <a:pPr algn="l">
-              <a:defRPr sz="1575" b="0">
-                <a:solidFill>
-                  <a:srgbClr val="111111"/>
-                </a:solidFill>
-              </a:defRPr>
-            </a:pPr>
-            <a:r>
-              <a:rPr sz="1575" b="0">
-                <a:solidFill>
-                  <a:srgbClr val="111111"/>
-                </a:solidFill>
-              </a:rPr>
-              <a:t>Calibrated review policy</a:t>
-            </a:r>
-          </a:p>
-          <a:p xmlns:a="http://schemas.openxmlformats.org/drawingml/2006/main">
-            <a:pPr algn="l">
-              <a:defRPr sz="1575" b="0">
-                <a:solidFill>
-                  <a:srgbClr val="111111"/>
-                </a:solidFill>
-              </a:defRPr>
-            </a:pPr>
-            <a:r>
-              <a:rPr sz="1575" b="0">
-                <a:solidFill>
-                  <a:srgbClr val="111111"/>
-                </a:solidFill>
-              </a:rPr>
-              <a:t>Hard-constraint search audit</a:t>
-            </a:r>
-          </a:p>
-          <a:p xmlns:a="http://schemas.openxmlformats.org/drawingml/2006/main">
-            <a:pPr algn="l">
-              <a:defRPr sz="1575" b="0">
-                <a:solidFill>
-                  <a:srgbClr val="111111"/>
-                </a:solidFill>
-              </a:defRPr>
-            </a:pPr>
-            <a:r>
-              <a:rPr sz="1575" b="0">
-                <a:solidFill>
-                  <a:srgbClr val="111111"/>
-                </a:solidFill>
-              </a:rPr>
-              <a:t>Batch CSV workflow</a:t>
-            </a:r>
-          </a:p>
-          <a:p xmlns:a="http://schemas.openxmlformats.org/drawingml/2006/main">
-            <a:pPr algn="l">
-              <a:defRPr sz="1575" b="0">
-                <a:solidFill>
-                  <a:srgbClr val="111111"/>
-                </a:solidFill>
-              </a:defRPr>
-            </a:pPr>
-            <a:r>
-              <a:rPr sz="1575" b="0">
-                <a:solidFill>
-                  <a:srgbClr val="111111"/>
-                </a:solidFill>
-              </a:rPr>
-              <a:t>Reproducible tests</a:t>
-            </a:r>
-          </a:p>
-        </p:txBody>
-      </p:sp>
-      <p:sp>
-        <p:nvSpPr>
-          <p:cNvPr id="6" name="">
-            <a:extLst xmlns:a="http://schemas.openxmlformats.org/drawingml/2006/main">
-              <a:ext uri="{FF2B5EF4-FFF2-40B4-BE49-F238E27FC236}">
-                <a16:creationId xmlns:a16="http://schemas.microsoft.com/office/drawing/2014/main" id="{22151C94-ADF8-45F7-AFF8-45F9D9CFCD3D}"/>
-              </a:ext>
-            </a:extLst>
-          </p:cNvPr>
-          <p:cNvSpPr>
-            <a:spLocks xmlns:a="http://schemas.openxmlformats.org/drawingml/2006/main" noGrp="1"/>
-          </p:cNvSpPr>
-          <p:nvPr/>
-        </p:nvSpPr>
-        <p:spPr>
-          <a:xfrm xmlns:a="http://schemas.openxmlformats.org/drawingml/2006/main">
-            <a:off x="5334000" y="4686300"/>
-            <a:ext cx="19050" cy="1333500"/>
-          </a:xfrm>
-          <a:prstGeom xmlns:a="http://schemas.openxmlformats.org/drawingml/2006/main" prst="rect">
-            <a:avLst/>
-          </a:prstGeom>
-          <a:solidFill xmlns:a="http://schemas.openxmlformats.org/drawingml/2006/main">
-            <a:srgbClr val="B8BCC4"/>
-          </a:solidFill>
-          <a:ln xmlns:a="http://schemas.openxmlformats.org/drawingml/2006/main" w="0">
-            <a:noFill/>
-            <a:prstDash val="solid"/>
-          </a:ln>
-        </p:spPr>
+            <a:off x="400050" y="4143375"/>
+            <a:ext cx="4953000" cy="1428750"/>
+          </a:xfrm>
+          <a:prstGeom xmlns:a="http://schemas.openxmlformats.org/drawingml/2006/main" prst="rect">
+            <a:avLst/>
+          </a:prstGeom>
+          <a:noFill xmlns:a="http://schemas.openxmlformats.org/drawingml/2006/main"/>
+          <a:ln xmlns:a="http://schemas.openxmlformats.org/drawingml/2006/main" w="0">
+            <a:noFill/>
+            <a:prstDash val="solid"/>
+          </a:ln>
+        </p:spPr>
+        <p:txBody>
+          <a:bodyPr xmlns:a="http://schemas.openxmlformats.org/drawingml/2006/main" anchor="t"/>
+          <a:lstStyle xmlns:a="http://schemas.openxmlformats.org/drawingml/2006/main"/>
+          <a:p xmlns:a="http://schemas.openxmlformats.org/drawingml/2006/main">
+            <a:pPr algn="l">
+              <a:buNone/>
+              <a:defRPr sz="1650" b="0">
+                <a:solidFill>
+                  <a:srgbClr val="111111"/>
+                </a:solidFill>
+              </a:defRPr>
+            </a:pPr>
+            <a:r>
+              <a:rPr sz="1650" b="0">
+                <a:solidFill>
+                  <a:srgbClr val="111111"/>
+                </a:solidFill>
+              </a:rPr>
+              <a:t>Prioritize, do not auto-reject</a:t>
+            </a:r>
+          </a:p>
+          <a:p xmlns:a="http://schemas.openxmlformats.org/drawingml/2006/main">
+            <a:pPr algn="l">
+              <a:buNone/>
+              <a:defRPr sz="1650" b="0">
+                <a:solidFill>
+                  <a:srgbClr val="111111"/>
+                </a:solidFill>
+              </a:defRPr>
+            </a:pPr>
+            <a:r>
+              <a:rPr sz="1650" b="0">
+                <a:solidFill>
+                  <a:srgbClr val="111111"/>
+                </a:solidFill>
+              </a:rPr>
+              <a:t>Keep advisor confirmation</a:t>
+            </a:r>
+          </a:p>
+          <a:p xmlns:a="http://schemas.openxmlformats.org/drawingml/2006/main">
+            <a:pPr algn="l">
+              <a:buNone/>
+              <a:defRPr sz="1650" b="0">
+                <a:solidFill>
+                  <a:srgbClr val="111111"/>
+                </a:solidFill>
+              </a:defRPr>
+            </a:pPr>
+            <a:r>
+              <a:rPr sz="1650" b="0">
+                <a:solidFill>
+                  <a:srgbClr val="111111"/>
+                </a:solidFill>
+              </a:rPr>
+              <a:t>Measure time saved and overrides</a:t>
+            </a:r>
+          </a:p>
+        </p:txBody>
       </p:sp>
       <p:sp>
         <p:nvSpPr>
@@ -2878,23 +2756,24 @@
         </p:nvSpPr>
         <p:spPr>
           <a:xfrm xmlns:a="http://schemas.openxmlformats.org/drawingml/2006/main">
-            <a:off x="5905500" y="4362450"/>
-            <a:ext cx="4000500" cy="323850"/>
-          </a:xfrm>
-          <a:prstGeom xmlns:a="http://schemas.openxmlformats.org/drawingml/2006/main" prst="rect">
-            <a:avLst/>
-          </a:prstGeom>
-          <a:noFill xmlns:a="http://schemas.openxmlformats.org/drawingml/2006/main"/>
-          <a:ln xmlns:a="http://schemas.openxmlformats.org/drawingml/2006/main" w="0">
-            <a:noFill/>
-            <a:prstDash val="solid"/>
-          </a:ln>
-        </p:spPr>
-        <p:txBody>
-          <a:bodyPr xmlns:a="http://schemas.openxmlformats.org/drawingml/2006/main" anchor="t"/>
-          <a:lstStyle xmlns:a="http://schemas.openxmlformats.org/drawingml/2006/main"/>
-          <a:p xmlns:a="http://schemas.openxmlformats.org/drawingml/2006/main">
-            <a:pPr algn="l">
+            <a:off x="6191250" y="4953000"/>
+            <a:ext cx="5429250" cy="323850"/>
+          </a:xfrm>
+          <a:prstGeom xmlns:a="http://schemas.openxmlformats.org/drawingml/2006/main" prst="rect">
+            <a:avLst/>
+          </a:prstGeom>
+          <a:noFill xmlns:a="http://schemas.openxmlformats.org/drawingml/2006/main"/>
+          <a:ln xmlns:a="http://schemas.openxmlformats.org/drawingml/2006/main" w="0">
+            <a:noFill/>
+            <a:prstDash val="solid"/>
+          </a:ln>
+        </p:spPr>
+        <p:txBody>
+          <a:bodyPr xmlns:a="http://schemas.openxmlformats.org/drawingml/2006/main" anchor="t"/>
+          <a:lstStyle xmlns:a="http://schemas.openxmlformats.org/drawingml/2006/main"/>
+          <a:p xmlns:a="http://schemas.openxmlformats.org/drawingml/2006/main">
+            <a:pPr algn="l">
+              <a:buNone/>
               <a:defRPr sz="1575" b="1">
                 <a:solidFill>
                   <a:srgbClr val="D6532F"/>
@@ -2907,7 +2786,7 @@
                   <a:srgbClr val="D6532F"/>
                 </a:solidFill>
               </a:rPr>
-              <a:t>PREPARED EVIDENCE</a:t>
+              <a:t>98.4% = weak-label agreement</a:t>
             </a:r>
           </a:p>
         </p:txBody>
@@ -2928,70 +2807,37 @@
         </p:nvSpPr>
         <p:spPr>
           <a:xfrm xmlns:a="http://schemas.openxmlformats.org/drawingml/2006/main">
-            <a:off x="5905500" y="4857750"/>
-            <a:ext cx="5143500" cy="1104900"/>
-          </a:xfrm>
-          <a:prstGeom xmlns:a="http://schemas.openxmlformats.org/drawingml/2006/main" prst="rect">
-            <a:avLst/>
-          </a:prstGeom>
-          <a:noFill xmlns:a="http://schemas.openxmlformats.org/drawingml/2006/main"/>
-          <a:ln xmlns:a="http://schemas.openxmlformats.org/drawingml/2006/main" w="0">
-            <a:noFill/>
-            <a:prstDash val="solid"/>
-          </a:ln>
-        </p:spPr>
-        <p:txBody>
-          <a:bodyPr xmlns:a="http://schemas.openxmlformats.org/drawingml/2006/main" anchor="t"/>
-          <a:lstStyle xmlns:a="http://schemas.openxmlformats.org/drawingml/2006/main"/>
-          <a:p xmlns:a="http://schemas.openxmlformats.org/drawingml/2006/main">
-            <a:pPr algn="l">
-              <a:defRPr sz="1875" b="1">
-                <a:solidFill>
-                  <a:srgbClr val="111111"/>
-                </a:solidFill>
-              </a:defRPr>
-            </a:pPr>
-            <a:r>
-              <a:rPr sz="1875" b="1">
-                <a:solidFill>
-                  <a:srgbClr val="111111"/>
-                </a:solidFill>
-              </a:rPr>
-              <a:t>1,000-row advisor annotation queue</a:t>
-            </a:r>
-          </a:p>
-          <a:p xmlns:a="http://schemas.openxmlformats.org/drawingml/2006/main">
-            <a:pPr algn="l">
-              <a:defRPr sz="1875" b="1">
-                <a:solidFill>
-                  <a:srgbClr val="111111"/>
-                </a:solidFill>
-              </a:defRPr>
-            </a:pPr>
-            <a:r>
-              <a:rPr sz="1875" b="1">
-                <a:solidFill>
-                  <a:srgbClr val="111111"/>
-                </a:solidFill>
-              </a:rPr>
-              <a:t>230 unique authorization candidates</a:t>
-            </a:r>
-          </a:p>
-          <a:p xmlns:a="http://schemas.openxmlformats.org/drawingml/2006/main">
-            <a:pPr algn="l">
-              <a:defRPr sz="1875" b="1">
-                <a:solidFill>
-                  <a:srgbClr val="111111"/>
-                </a:solidFill>
-              </a:defRPr>
-            </a:pPr>
-            <a:r>
-              <a:rPr sz="1875" b="1">
-                <a:solidFill>
-                  <a:srgbClr val="111111"/>
-                </a:solidFill>
-              </a:rPr>
-              <a:t>430-row candidate/control benchmark</a:t>
+            <a:off x="6191250" y="5381625"/>
+            <a:ext cx="5429250" cy="647700"/>
+          </a:xfrm>
+          <a:prstGeom xmlns:a="http://schemas.openxmlformats.org/drawingml/2006/main" prst="rect">
+            <a:avLst/>
+          </a:prstGeom>
+          <a:noFill xmlns:a="http://schemas.openxmlformats.org/drawingml/2006/main"/>
+          <a:ln xmlns:a="http://schemas.openxmlformats.org/drawingml/2006/main" w="0">
+            <a:noFill/>
+            <a:prstDash val="solid"/>
+          </a:ln>
+        </p:spPr>
+        <p:txBody>
+          <a:bodyPr xmlns:a="http://schemas.openxmlformats.org/drawingml/2006/main" anchor="t"/>
+          <a:lstStyle xmlns:a="http://schemas.openxmlformats.org/drawingml/2006/main"/>
+          <a:p xmlns:a="http://schemas.openxmlformats.org/drawingml/2006/main">
+            <a:pPr algn="l">
+              <a:buNone/>
+              <a:defRPr sz="1425" b="1">
+                <a:solidFill>
+                  <a:srgbClr val="111111"/>
+                </a:solidFill>
+              </a:defRPr>
+            </a:pPr>
+            <a:r>
+              <a:rPr sz="1425" b="1">
+                <a:solidFill>
+                  <a:srgbClr val="111111"/>
+                </a:solidFill>
+              </a:rPr>
+              <a:t>Next: label the 1,000-row advisor queue and measure real workflow value.</a:t>
             </a:r>
           </a:p>
         </p:txBody>
@@ -3029,6 +2875,7 @@
           <a:lstStyle xmlns:a="http://schemas.openxmlformats.org/drawingml/2006/main"/>
           <a:p xmlns:a="http://schemas.openxmlformats.org/drawingml/2006/main">
             <a:pPr algn="r">
+              <a:buNone/>
               <a:defRPr sz="1200" b="0">
                 <a:solidFill>
                   <a:srgbClr val="565D67"/>
@@ -3046,6 +2893,33 @@
           </a:p>
         </p:txBody>
       </p:sp>
+      <p:pic>
+        <p:nvPicPr>
+          <p:cNvPr id="19" name=""/>
+          <p:cNvPicPr>
+            <a:picLocks xmlns:a="http://schemas.openxmlformats.org/drawingml/2006/main" noChangeAspect="1"/>
+          </p:cNvPicPr>
+          <p:nvPr/>
+        </p:nvPicPr>
+        <p:blipFill>
+          <a:blip xmlns:r="http://schemas.openxmlformats.org/officeDocument/2006/relationships" xmlns:a="http://schemas.openxmlformats.org/drawingml/2006/main" r:embed="Rfe3275b426e4472f"/>
+          <a:srcRect xmlns:a="http://schemas.openxmlformats.org/drawingml/2006/main" l="1420" t="0" r="1420" b="0"/>
+          <a:stretch xmlns:a="http://schemas.openxmlformats.org/drawingml/2006/main">
+            <a:fillRect l="0" t="0" r="0" b="0"/>
+          </a:stretch>
+        </p:blipFill>
+        <p:spPr>
+          <a:xfrm xmlns:a="http://schemas.openxmlformats.org/drawingml/2006/main">
+            <a:off x="6191250" y="1571625"/>
+            <a:ext cx="5429250" cy="3143250"/>
+          </a:xfrm>
+          <a:prstGeom xmlns:a="http://schemas.openxmlformats.org/drawingml/2006/main" prst="roundRect">
+            <a:avLst>
+              <a:gd name="adj" fmla="val 2424"/>
+            </a:avLst>
+          </a:prstGeom>
+        </p:spPr>
+      </p:pic>
     </p:spTree>
     <p:extLst>
       <p:ext uri="{BB962C8B-B14F-4D97-AF65-F5344CB8AC3E}">
@@ -3108,6 +2982,7 @@
           <a:lstStyle xmlns:a="http://schemas.openxmlformats.org/drawingml/2006/main"/>
           <a:p xmlns:a="http://schemas.openxmlformats.org/drawingml/2006/main">
             <a:pPr algn="l">
+              <a:buNone/>
               <a:defRPr sz="3600" b="1">
                 <a:solidFill>
                   <a:srgbClr val="111111"/>
@@ -3158,6 +3033,7 @@
           <a:lstStyle xmlns:a="http://schemas.openxmlformats.org/drawingml/2006/main"/>
           <a:p xmlns:a="http://schemas.openxmlformats.org/drawingml/2006/main">
             <a:pPr algn="l">
+              <a:buNone/>
               <a:defRPr sz="1650" b="0">
                 <a:solidFill>
                   <a:srgbClr val="565D67"/>
@@ -3208,6 +3084,7 @@
           <a:lstStyle xmlns:a="http://schemas.openxmlformats.org/drawingml/2006/main"/>
           <a:p xmlns:a="http://schemas.openxmlformats.org/drawingml/2006/main">
             <a:pPr algn="r">
+              <a:buNone/>
               <a:defRPr sz="1200" b="0">
                 <a:solidFill>
                   <a:srgbClr val="565D67"/>
@@ -3227,7 +3104,7 @@
       </p:sp>
       <p:cxnSp>
         <p:nvCxnSpPr>
-          <p:cNvPr id="17" name=""/>
+          <p:cNvPr id="37" name=""/>
           <p:cNvCxnSpPr/>
           <p:nvPr/>
         </p:nvCxnSpPr>
@@ -3280,6 +3157,7 @@
           <a:lstStyle xmlns:a="http://schemas.openxmlformats.org/drawingml/2006/main"/>
           <a:p xmlns:a="http://schemas.openxmlformats.org/drawingml/2006/main">
             <a:pPr algn="l">
+              <a:buNone/>
               <a:defRPr sz="2100" b="1">
                 <a:solidFill>
                   <a:srgbClr val="3D8DFF"/>
@@ -3330,6 +3208,7 @@
           <a:lstStyle xmlns:a="http://schemas.openxmlformats.org/drawingml/2006/main"/>
           <a:p xmlns:a="http://schemas.openxmlformats.org/drawingml/2006/main">
             <a:pPr algn="l">
+              <a:buNone/>
               <a:defRPr sz="1875" b="0">
                 <a:solidFill>
                   <a:srgbClr val="111111"/>
@@ -3349,7 +3228,7 @@
       </p:sp>
       <p:cxnSp>
         <p:nvCxnSpPr>
-          <p:cNvPr id="20" name=""/>
+          <p:cNvPr id="40" name=""/>
           <p:cNvCxnSpPr/>
           <p:nvPr/>
         </p:nvCxnSpPr>
@@ -3402,6 +3281,7 @@
           <a:lstStyle xmlns:a="http://schemas.openxmlformats.org/drawingml/2006/main"/>
           <a:p xmlns:a="http://schemas.openxmlformats.org/drawingml/2006/main">
             <a:pPr algn="l">
+              <a:buNone/>
               <a:defRPr sz="2100" b="1">
                 <a:solidFill>
                   <a:srgbClr val="3D8DFF"/>
@@ -3452,6 +3332,7 @@
           <a:lstStyle xmlns:a="http://schemas.openxmlformats.org/drawingml/2006/main"/>
           <a:p xmlns:a="http://schemas.openxmlformats.org/drawingml/2006/main">
             <a:pPr algn="l">
+              <a:buNone/>
               <a:defRPr sz="1875" b="0">
                 <a:solidFill>
                   <a:srgbClr val="111111"/>
@@ -3471,7 +3352,7 @@
       </p:sp>
       <p:cxnSp>
         <p:nvCxnSpPr>
-          <p:cNvPr id="23" name=""/>
+          <p:cNvPr id="43" name=""/>
           <p:cNvCxnSpPr/>
           <p:nvPr/>
         </p:nvCxnSpPr>
@@ -3524,6 +3405,7 @@
           <a:lstStyle xmlns:a="http://schemas.openxmlformats.org/drawingml/2006/main"/>
           <a:p xmlns:a="http://schemas.openxmlformats.org/drawingml/2006/main">
             <a:pPr algn="l">
+              <a:buNone/>
               <a:defRPr sz="2100" b="1">
                 <a:solidFill>
                   <a:srgbClr val="D6532F"/>
@@ -3574,6 +3456,7 @@
           <a:lstStyle xmlns:a="http://schemas.openxmlformats.org/drawingml/2006/main"/>
           <a:p xmlns:a="http://schemas.openxmlformats.org/drawingml/2006/main">
             <a:pPr algn="l">
+              <a:buNone/>
               <a:defRPr sz="1875" b="0">
                 <a:solidFill>
                   <a:srgbClr val="111111"/>
@@ -3624,6 +3507,7 @@
           <a:lstStyle xmlns:a="http://schemas.openxmlformats.org/drawingml/2006/main"/>
           <a:p xmlns:a="http://schemas.openxmlformats.org/drawingml/2006/main">
             <a:pPr algn="l">
+              <a:buNone/>
               <a:defRPr sz="1875" b="1">
                 <a:solidFill>
                   <a:srgbClr val="111111"/>
@@ -3703,6 +3587,7 @@
           <a:lstStyle xmlns:a="http://schemas.openxmlformats.org/drawingml/2006/main"/>
           <a:p xmlns:a="http://schemas.openxmlformats.org/drawingml/2006/main">
             <a:pPr algn="l">
+              <a:buNone/>
               <a:defRPr sz="3600" b="1">
                 <a:solidFill>
                   <a:srgbClr val="111111"/>
@@ -3753,6 +3638,7 @@
           <a:lstStyle xmlns:a="http://schemas.openxmlformats.org/drawingml/2006/main"/>
           <a:p xmlns:a="http://schemas.openxmlformats.org/drawingml/2006/main">
             <a:pPr algn="l">
+              <a:buNone/>
               <a:defRPr sz="1650" b="0">
                 <a:solidFill>
                   <a:srgbClr val="565D67"/>
@@ -3803,6 +3689,7 @@
           <a:lstStyle xmlns:a="http://schemas.openxmlformats.org/drawingml/2006/main"/>
           <a:p xmlns:a="http://schemas.openxmlformats.org/drawingml/2006/main">
             <a:pPr algn="r">
+              <a:buNone/>
               <a:defRPr sz="1200" b="0">
                 <a:solidFill>
                   <a:srgbClr val="565D67"/>
@@ -3884,6 +3771,7 @@
           <a:lstStyle xmlns:a="http://schemas.openxmlformats.org/drawingml/2006/main"/>
           <a:p xmlns:a="http://schemas.openxmlformats.org/drawingml/2006/main">
             <a:pPr algn="l">
+              <a:buNone/>
               <a:defRPr sz="4350" b="1">
                 <a:solidFill>
                   <a:srgbClr val="3D8DFF"/>
@@ -3934,6 +3822,7 @@
           <a:lstStyle xmlns:a="http://schemas.openxmlformats.org/drawingml/2006/main"/>
           <a:p xmlns:a="http://schemas.openxmlformats.org/drawingml/2006/main">
             <a:pPr algn="l">
+              <a:buNone/>
               <a:defRPr sz="1650" b="0">
                 <a:solidFill>
                   <a:srgbClr val="111111"/>
@@ -4015,6 +3904,7 @@
           <a:lstStyle xmlns:a="http://schemas.openxmlformats.org/drawingml/2006/main"/>
           <a:p xmlns:a="http://schemas.openxmlformats.org/drawingml/2006/main">
             <a:pPr algn="l">
+              <a:buNone/>
               <a:defRPr sz="4350" b="1">
                 <a:solidFill>
                   <a:srgbClr val="3D8DFF"/>
@@ -4065,6 +3955,7 @@
           <a:lstStyle xmlns:a="http://schemas.openxmlformats.org/drawingml/2006/main"/>
           <a:p xmlns:a="http://schemas.openxmlformats.org/drawingml/2006/main">
             <a:pPr algn="l">
+              <a:buNone/>
               <a:defRPr sz="1650" b="0">
                 <a:solidFill>
                   <a:srgbClr val="111111"/>
@@ -4146,6 +4037,7 @@
           <a:lstStyle xmlns:a="http://schemas.openxmlformats.org/drawingml/2006/main"/>
           <a:p xmlns:a="http://schemas.openxmlformats.org/drawingml/2006/main">
             <a:pPr algn="l">
+              <a:buNone/>
               <a:defRPr sz="4350" b="1">
                 <a:solidFill>
                   <a:srgbClr val="D6532F"/>
@@ -4196,6 +4088,7 @@
           <a:lstStyle xmlns:a="http://schemas.openxmlformats.org/drawingml/2006/main"/>
           <a:p xmlns:a="http://schemas.openxmlformats.org/drawingml/2006/main">
             <a:pPr algn="l">
+              <a:buNone/>
               <a:defRPr sz="1650" b="0">
                 <a:solidFill>
                   <a:srgbClr val="111111"/>
@@ -4277,6 +4170,7 @@
           <a:lstStyle xmlns:a="http://schemas.openxmlformats.org/drawingml/2006/main"/>
           <a:p xmlns:a="http://schemas.openxmlformats.org/drawingml/2006/main">
             <a:pPr algn="l">
+              <a:buNone/>
               <a:defRPr sz="4350" b="1">
                 <a:solidFill>
                   <a:srgbClr val="D6532F"/>
@@ -4327,6 +4221,7 @@
           <a:lstStyle xmlns:a="http://schemas.openxmlformats.org/drawingml/2006/main"/>
           <a:p xmlns:a="http://schemas.openxmlformats.org/drawingml/2006/main">
             <a:pPr algn="l">
+              <a:buNone/>
               <a:defRPr sz="1650" b="0">
                 <a:solidFill>
                   <a:srgbClr val="111111"/>
@@ -4406,6 +4301,7 @@
           <a:lstStyle xmlns:a="http://schemas.openxmlformats.org/drawingml/2006/main"/>
           <a:p xmlns:a="http://schemas.openxmlformats.org/drawingml/2006/main">
             <a:pPr algn="l">
+              <a:buNone/>
               <a:defRPr sz="3600" b="1">
                 <a:solidFill>
                   <a:srgbClr val="111111"/>
@@ -4456,6 +4352,7 @@
           <a:lstStyle xmlns:a="http://schemas.openxmlformats.org/drawingml/2006/main"/>
           <a:p xmlns:a="http://schemas.openxmlformats.org/drawingml/2006/main">
             <a:pPr algn="r">
+              <a:buNone/>
               <a:defRPr sz="1200" b="0">
                 <a:solidFill>
                   <a:srgbClr val="565D67"/>
@@ -4475,7 +4372,7 @@
       </p:sp>
       <p:cxnSp>
         <p:nvCxnSpPr>
-          <p:cNvPr id="22" name=""/>
+          <p:cNvPr id="28" name=""/>
           <p:cNvCxnSpPr/>
           <p:nvPr/>
         </p:nvCxnSpPr>
@@ -4559,6 +4456,7 @@
           <a:lstStyle xmlns:a="http://schemas.openxmlformats.org/drawingml/2006/main"/>
           <a:p xmlns:a="http://schemas.openxmlformats.org/drawingml/2006/main">
             <a:pPr algn="l">
+              <a:buNone/>
               <a:defRPr sz="1800" b="1">
                 <a:solidFill>
                   <a:srgbClr val="565D67"/>
@@ -4609,6 +4507,7 @@
           <a:lstStyle xmlns:a="http://schemas.openxmlformats.org/drawingml/2006/main"/>
           <a:p xmlns:a="http://schemas.openxmlformats.org/drawingml/2006/main">
             <a:pPr algn="l">
+              <a:buNone/>
               <a:defRPr sz="2250" b="1">
                 <a:solidFill>
                   <a:srgbClr val="3D8DFF"/>
@@ -4659,6 +4558,7 @@
           <a:lstStyle xmlns:a="http://schemas.openxmlformats.org/drawingml/2006/main"/>
           <a:p xmlns:a="http://schemas.openxmlformats.org/drawingml/2006/main">
             <a:pPr algn="l">
+              <a:buNone/>
               <a:defRPr sz="1650" b="0">
                 <a:solidFill>
                   <a:srgbClr val="111111"/>
@@ -4676,6 +4576,7 @@
           </a:p>
           <a:p xmlns:a="http://schemas.openxmlformats.org/drawingml/2006/main">
             <a:pPr algn="l">
+              <a:buNone/>
               <a:defRPr sz="1650" b="0">
                 <a:solidFill>
                   <a:srgbClr val="111111"/>
@@ -4757,6 +4658,7 @@
           <a:lstStyle xmlns:a="http://schemas.openxmlformats.org/drawingml/2006/main"/>
           <a:p xmlns:a="http://schemas.openxmlformats.org/drawingml/2006/main">
             <a:pPr algn="l">
+              <a:buNone/>
               <a:defRPr sz="1800" b="1">
                 <a:solidFill>
                   <a:srgbClr val="565D67"/>
@@ -4807,6 +4709,7 @@
           <a:lstStyle xmlns:a="http://schemas.openxmlformats.org/drawingml/2006/main"/>
           <a:p xmlns:a="http://schemas.openxmlformats.org/drawingml/2006/main">
             <a:pPr algn="l">
+              <a:buNone/>
               <a:defRPr sz="2250" b="1">
                 <a:solidFill>
                   <a:srgbClr val="3D8DFF"/>
@@ -4857,6 +4760,7 @@
           <a:lstStyle xmlns:a="http://schemas.openxmlformats.org/drawingml/2006/main"/>
           <a:p xmlns:a="http://schemas.openxmlformats.org/drawingml/2006/main">
             <a:pPr algn="l">
+              <a:buNone/>
               <a:defRPr sz="1650" b="0">
                 <a:solidFill>
                   <a:srgbClr val="111111"/>
@@ -4874,6 +4778,7 @@
           </a:p>
           <a:p xmlns:a="http://schemas.openxmlformats.org/drawingml/2006/main">
             <a:pPr algn="l">
+              <a:buNone/>
               <a:defRPr sz="1650" b="0">
                 <a:solidFill>
                   <a:srgbClr val="111111"/>
@@ -4955,6 +4860,7 @@
           <a:lstStyle xmlns:a="http://schemas.openxmlformats.org/drawingml/2006/main"/>
           <a:p xmlns:a="http://schemas.openxmlformats.org/drawingml/2006/main">
             <a:pPr algn="l">
+              <a:buNone/>
               <a:defRPr sz="1800" b="1">
                 <a:solidFill>
                   <a:srgbClr val="565D67"/>
@@ -5005,6 +4911,7 @@
           <a:lstStyle xmlns:a="http://schemas.openxmlformats.org/drawingml/2006/main"/>
           <a:p xmlns:a="http://schemas.openxmlformats.org/drawingml/2006/main">
             <a:pPr algn="l">
+              <a:buNone/>
               <a:defRPr sz="2250" b="1">
                 <a:solidFill>
                   <a:srgbClr val="3D8DFF"/>
@@ -5055,6 +4962,7 @@
           <a:lstStyle xmlns:a="http://schemas.openxmlformats.org/drawingml/2006/main"/>
           <a:p xmlns:a="http://schemas.openxmlformats.org/drawingml/2006/main">
             <a:pPr algn="l">
+              <a:buNone/>
               <a:defRPr sz="1650" b="0">
                 <a:solidFill>
                   <a:srgbClr val="111111"/>
@@ -5072,6 +4980,7 @@
           </a:p>
           <a:p xmlns:a="http://schemas.openxmlformats.org/drawingml/2006/main">
             <a:pPr algn="l">
+              <a:buNone/>
               <a:defRPr sz="1650" b="0">
                 <a:solidFill>
                   <a:srgbClr val="111111"/>
@@ -5153,6 +5062,7 @@
           <a:lstStyle xmlns:a="http://schemas.openxmlformats.org/drawingml/2006/main"/>
           <a:p xmlns:a="http://schemas.openxmlformats.org/drawingml/2006/main">
             <a:pPr algn="l">
+              <a:buNone/>
               <a:defRPr sz="1800" b="1">
                 <a:solidFill>
                   <a:srgbClr val="565D67"/>
@@ -5203,6 +5113,7 @@
           <a:lstStyle xmlns:a="http://schemas.openxmlformats.org/drawingml/2006/main"/>
           <a:p xmlns:a="http://schemas.openxmlformats.org/drawingml/2006/main">
             <a:pPr algn="l">
+              <a:buNone/>
               <a:defRPr sz="2250" b="1">
                 <a:solidFill>
                   <a:srgbClr val="D6532F"/>
@@ -5253,6 +5164,7 @@
           <a:lstStyle xmlns:a="http://schemas.openxmlformats.org/drawingml/2006/main"/>
           <a:p xmlns:a="http://schemas.openxmlformats.org/drawingml/2006/main">
             <a:pPr algn="l">
+              <a:buNone/>
               <a:defRPr sz="1650" b="0">
                 <a:solidFill>
                   <a:srgbClr val="111111"/>
@@ -5270,6 +5182,7 @@
           </a:p>
           <a:p xmlns:a="http://schemas.openxmlformats.org/drawingml/2006/main">
             <a:pPr algn="l">
+              <a:buNone/>
               <a:defRPr sz="1650" b="0">
                 <a:solidFill>
                   <a:srgbClr val="111111"/>
@@ -5349,6 +5262,7 @@
           <a:lstStyle xmlns:a="http://schemas.openxmlformats.org/drawingml/2006/main"/>
           <a:p xmlns:a="http://schemas.openxmlformats.org/drawingml/2006/main">
             <a:pPr algn="l">
+              <a:buNone/>
               <a:defRPr sz="3600" b="1">
                 <a:solidFill>
                   <a:srgbClr val="111111"/>
@@ -5399,6 +5313,7 @@
           <a:lstStyle xmlns:a="http://schemas.openxmlformats.org/drawingml/2006/main"/>
           <a:p xmlns:a="http://schemas.openxmlformats.org/drawingml/2006/main">
             <a:pPr algn="l">
+              <a:buNone/>
               <a:defRPr sz="1650" b="0">
                 <a:solidFill>
                   <a:srgbClr val="565D67"/>
@@ -5449,6 +5364,7 @@
           <a:lstStyle xmlns:a="http://schemas.openxmlformats.org/drawingml/2006/main"/>
           <a:p xmlns:a="http://schemas.openxmlformats.org/drawingml/2006/main">
             <a:pPr algn="r">
+              <a:buNone/>
               <a:defRPr sz="1200" b="0">
                 <a:solidFill>
                   <a:srgbClr val="565D67"/>
@@ -5468,7 +5384,7 @@
       </p:sp>
       <p:cxnSp>
         <p:nvCxnSpPr>
-          <p:cNvPr id="32" name=""/>
+          <p:cNvPr id="46" name=""/>
           <p:cNvCxnSpPr/>
           <p:nvPr/>
         </p:nvCxnSpPr>
@@ -5490,7 +5406,7 @@
       </p:cxnSp>
       <p:cxnSp>
         <p:nvCxnSpPr>
-          <p:cNvPr id="33" name=""/>
+          <p:cNvPr id="47" name=""/>
           <p:cNvCxnSpPr/>
           <p:nvPr/>
         </p:nvCxnSpPr>
@@ -5512,7 +5428,7 @@
       </p:cxnSp>
       <p:cxnSp>
         <p:nvCxnSpPr>
-          <p:cNvPr id="34" name=""/>
+          <p:cNvPr id="48" name=""/>
           <p:cNvCxnSpPr/>
           <p:nvPr/>
         </p:nvCxnSpPr>
@@ -5534,7 +5450,7 @@
       </p:cxnSp>
       <p:cxnSp>
         <p:nvCxnSpPr>
-          <p:cNvPr id="35" name=""/>
+          <p:cNvPr id="49" name=""/>
           <p:cNvCxnSpPr/>
           <p:nvPr/>
         </p:nvCxnSpPr>
@@ -5618,6 +5534,7 @@
           <a:lstStyle xmlns:a="http://schemas.openxmlformats.org/drawingml/2006/main"/>
           <a:p xmlns:a="http://schemas.openxmlformats.org/drawingml/2006/main">
             <a:pPr algn="l">
+              <a:buNone/>
               <a:defRPr sz="1950" b="1">
                 <a:solidFill>
                   <a:srgbClr val="3D8DFF"/>
@@ -5668,6 +5585,7 @@
           <a:lstStyle xmlns:a="http://schemas.openxmlformats.org/drawingml/2006/main"/>
           <a:p xmlns:a="http://schemas.openxmlformats.org/drawingml/2006/main">
             <a:pPr algn="l">
+              <a:buNone/>
               <a:defRPr sz="1800" b="1">
                 <a:solidFill>
                   <a:srgbClr val="111111"/>
@@ -5718,6 +5636,7 @@
           <a:lstStyle xmlns:a="http://schemas.openxmlformats.org/drawingml/2006/main"/>
           <a:p xmlns:a="http://schemas.openxmlformats.org/drawingml/2006/main">
             <a:pPr algn="l">
+              <a:buNone/>
               <a:defRPr sz="1500" b="0">
                 <a:solidFill>
                   <a:srgbClr val="565D67"/>
@@ -5799,6 +5718,7 @@
           <a:lstStyle xmlns:a="http://schemas.openxmlformats.org/drawingml/2006/main"/>
           <a:p xmlns:a="http://schemas.openxmlformats.org/drawingml/2006/main">
             <a:pPr algn="l">
+              <a:buNone/>
               <a:defRPr sz="1950" b="1">
                 <a:solidFill>
                   <a:srgbClr val="3D8DFF"/>
@@ -5849,6 +5769,7 @@
           <a:lstStyle xmlns:a="http://schemas.openxmlformats.org/drawingml/2006/main"/>
           <a:p xmlns:a="http://schemas.openxmlformats.org/drawingml/2006/main">
             <a:pPr algn="l">
+              <a:buNone/>
               <a:defRPr sz="1800" b="1">
                 <a:solidFill>
                   <a:srgbClr val="111111"/>
@@ -5899,6 +5820,7 @@
           <a:lstStyle xmlns:a="http://schemas.openxmlformats.org/drawingml/2006/main"/>
           <a:p xmlns:a="http://schemas.openxmlformats.org/drawingml/2006/main">
             <a:pPr algn="l">
+              <a:buNone/>
               <a:defRPr sz="1500" b="0">
                 <a:solidFill>
                   <a:srgbClr val="565D67"/>
@@ -5980,6 +5902,7 @@
           <a:lstStyle xmlns:a="http://schemas.openxmlformats.org/drawingml/2006/main"/>
           <a:p xmlns:a="http://schemas.openxmlformats.org/drawingml/2006/main">
             <a:pPr algn="l">
+              <a:buNone/>
               <a:defRPr sz="1950" b="1">
                 <a:solidFill>
                   <a:srgbClr val="3D8DFF"/>
@@ -6030,6 +5953,7 @@
           <a:lstStyle xmlns:a="http://schemas.openxmlformats.org/drawingml/2006/main"/>
           <a:p xmlns:a="http://schemas.openxmlformats.org/drawingml/2006/main">
             <a:pPr algn="l">
+              <a:buNone/>
               <a:defRPr sz="1800" b="1">
                 <a:solidFill>
                   <a:srgbClr val="111111"/>
@@ -6080,6 +6004,7 @@
           <a:lstStyle xmlns:a="http://schemas.openxmlformats.org/drawingml/2006/main"/>
           <a:p xmlns:a="http://schemas.openxmlformats.org/drawingml/2006/main">
             <a:pPr algn="l">
+              <a:buNone/>
               <a:defRPr sz="1500" b="0">
                 <a:solidFill>
                   <a:srgbClr val="565D67"/>
@@ -6161,6 +6086,7 @@
           <a:lstStyle xmlns:a="http://schemas.openxmlformats.org/drawingml/2006/main"/>
           <a:p xmlns:a="http://schemas.openxmlformats.org/drawingml/2006/main">
             <a:pPr algn="l">
+              <a:buNone/>
               <a:defRPr sz="1950" b="1">
                 <a:solidFill>
                   <a:srgbClr val="3D8DFF"/>
@@ -6211,6 +6137,7 @@
           <a:lstStyle xmlns:a="http://schemas.openxmlformats.org/drawingml/2006/main"/>
           <a:p xmlns:a="http://schemas.openxmlformats.org/drawingml/2006/main">
             <a:pPr algn="l">
+              <a:buNone/>
               <a:defRPr sz="1800" b="1">
                 <a:solidFill>
                   <a:srgbClr val="111111"/>
@@ -6261,6 +6188,7 @@
           <a:lstStyle xmlns:a="http://schemas.openxmlformats.org/drawingml/2006/main"/>
           <a:p xmlns:a="http://schemas.openxmlformats.org/drawingml/2006/main">
             <a:pPr algn="l">
+              <a:buNone/>
               <a:defRPr sz="1500" b="0">
                 <a:solidFill>
                   <a:srgbClr val="565D67"/>
@@ -6342,6 +6270,7 @@
           <a:lstStyle xmlns:a="http://schemas.openxmlformats.org/drawingml/2006/main"/>
           <a:p xmlns:a="http://schemas.openxmlformats.org/drawingml/2006/main">
             <a:pPr algn="l">
+              <a:buNone/>
               <a:defRPr sz="1950" b="1">
                 <a:solidFill>
                   <a:srgbClr val="D6532F"/>
@@ -6392,6 +6321,7 @@
           <a:lstStyle xmlns:a="http://schemas.openxmlformats.org/drawingml/2006/main"/>
           <a:p xmlns:a="http://schemas.openxmlformats.org/drawingml/2006/main">
             <a:pPr algn="l">
+              <a:buNone/>
               <a:defRPr sz="1800" b="1">
                 <a:solidFill>
                   <a:srgbClr val="111111"/>
@@ -6442,6 +6372,7 @@
           <a:lstStyle xmlns:a="http://schemas.openxmlformats.org/drawingml/2006/main"/>
           <a:p xmlns:a="http://schemas.openxmlformats.org/drawingml/2006/main">
             <a:pPr algn="l">
+              <a:buNone/>
               <a:defRPr sz="1500" b="0">
                 <a:solidFill>
                   <a:srgbClr val="565D67"/>
@@ -6492,6 +6423,7 @@
           <a:lstStyle xmlns:a="http://schemas.openxmlformats.org/drawingml/2006/main"/>
           <a:p xmlns:a="http://schemas.openxmlformats.org/drawingml/2006/main">
             <a:pPr algn="l">
+              <a:buNone/>
               <a:defRPr sz="2175" b="1">
                 <a:solidFill>
                   <a:srgbClr val="111111"/>
@@ -6554,23 +6486,24 @@
         </p:nvSpPr>
         <p:spPr>
           <a:xfrm xmlns:a="http://schemas.openxmlformats.org/drawingml/2006/main">
-            <a:off x="400050" y="323850"/>
-            <a:ext cx="11096625" cy="685800"/>
-          </a:xfrm>
-          <a:prstGeom xmlns:a="http://schemas.openxmlformats.org/drawingml/2006/main" prst="rect">
-            <a:avLst/>
-          </a:prstGeom>
-          <a:noFill xmlns:a="http://schemas.openxmlformats.org/drawingml/2006/main"/>
-          <a:ln xmlns:a="http://schemas.openxmlformats.org/drawingml/2006/main" w="0">
-            <a:noFill/>
-            <a:prstDash val="solid"/>
-          </a:ln>
-        </p:spPr>
-        <p:txBody>
-          <a:bodyPr xmlns:a="http://schemas.openxmlformats.org/drawingml/2006/main" anchor="t"/>
-          <a:lstStyle xmlns:a="http://schemas.openxmlformats.org/drawingml/2006/main"/>
-          <a:p xmlns:a="http://schemas.openxmlformats.org/drawingml/2006/main">
-            <a:pPr algn="l">
+            <a:off x="495300" y="428625"/>
+            <a:ext cx="11049000" cy="552450"/>
+          </a:xfrm>
+          <a:prstGeom xmlns:a="http://schemas.openxmlformats.org/drawingml/2006/main" prst="rect">
+            <a:avLst/>
+          </a:prstGeom>
+          <a:noFill xmlns:a="http://schemas.openxmlformats.org/drawingml/2006/main"/>
+          <a:ln xmlns:a="http://schemas.openxmlformats.org/drawingml/2006/main" w="0">
+            <a:noFill/>
+            <a:prstDash val="solid"/>
+          </a:ln>
+        </p:spPr>
+        <p:txBody>
+          <a:bodyPr xmlns:a="http://schemas.openxmlformats.org/drawingml/2006/main" anchor="t"/>
+          <a:lstStyle xmlns:a="http://schemas.openxmlformats.org/drawingml/2006/main"/>
+          <a:p xmlns:a="http://schemas.openxmlformats.org/drawingml/2006/main">
+            <a:pPr algn="l">
+              <a:buNone/>
               <a:defRPr sz="3600" b="1">
                 <a:solidFill>
                   <a:srgbClr val="111111"/>
@@ -6583,7 +6516,7 @@
                   <a:srgbClr val="111111"/>
                 </a:solidFill>
               </a:rPr>
-              <a:t>Search mode returns constrained, inspectable candidates</a:t>
+              <a:t>A real search returns constrained, inspectable evidence</a:t>
             </a:r>
           </a:p>
         </p:txBody>
@@ -6604,36 +6537,37 @@
         </p:nvSpPr>
         <p:spPr>
           <a:xfrm xmlns:a="http://schemas.openxmlformats.org/drawingml/2006/main">
-            <a:off x="419100" y="1028700"/>
-            <a:ext cx="10668000" cy="457200"/>
-          </a:xfrm>
-          <a:prstGeom xmlns:a="http://schemas.openxmlformats.org/drawingml/2006/main" prst="rect">
-            <a:avLst/>
-          </a:prstGeom>
-          <a:noFill xmlns:a="http://schemas.openxmlformats.org/drawingml/2006/main"/>
-          <a:ln xmlns:a="http://schemas.openxmlformats.org/drawingml/2006/main" w="0">
-            <a:noFill/>
-            <a:prstDash val="solid"/>
-          </a:ln>
-        </p:spPr>
-        <p:txBody>
-          <a:bodyPr xmlns:a="http://schemas.openxmlformats.org/drawingml/2006/main" anchor="t"/>
-          <a:lstStyle xmlns:a="http://schemas.openxmlformats.org/drawingml/2006/main"/>
-          <a:p xmlns:a="http://schemas.openxmlformats.org/drawingml/2006/main">
-            <a:pPr algn="l">
-              <a:defRPr sz="1650" b="0">
-                <a:solidFill>
-                  <a:srgbClr val="565D67"/>
-                </a:solidFill>
-              </a:defRPr>
-            </a:pPr>
-            <a:r>
-              <a:rPr sz="1650" b="0">
-                <a:solidFill>
-                  <a:srgbClr val="565D67"/>
-                </a:solidFill>
-              </a:rPr>
-              <a:t>The top five results satisfy the requested US constraint; the search sentence is not misclassified.</a:t>
+            <a:off x="514350" y="6115050"/>
+            <a:ext cx="10287000" cy="323850"/>
+          </a:xfrm>
+          <a:prstGeom xmlns:a="http://schemas.openxmlformats.org/drawingml/2006/main" prst="rect">
+            <a:avLst/>
+          </a:prstGeom>
+          <a:noFill xmlns:a="http://schemas.openxmlformats.org/drawingml/2006/main"/>
+          <a:ln xmlns:a="http://schemas.openxmlformats.org/drawingml/2006/main" w="0">
+            <a:noFill/>
+            <a:prstDash val="solid"/>
+          </a:ln>
+        </p:spPr>
+        <p:txBody>
+          <a:bodyPr xmlns:a="http://schemas.openxmlformats.org/drawingml/2006/main" anchor="t"/>
+          <a:lstStyle xmlns:a="http://schemas.openxmlformats.org/drawingml/2006/main"/>
+          <a:p xmlns:a="http://schemas.openxmlformats.org/drawingml/2006/main">
+            <a:pPr algn="l">
+              <a:buNone/>
+              <a:defRPr sz="1350" b="1">
+                <a:solidFill>
+                  <a:srgbClr val="111111"/>
+                </a:solidFill>
+              </a:defRPr>
+            </a:pPr>
+            <a:r>
+              <a:rPr sz="1350" b="1">
+                <a:solidFill>
+                  <a:srgbClr val="111111"/>
+                </a:solidFill>
+              </a:rPr>
+              <a:t>6 audit queries -&gt; 36 results -&gt; 0 hard-constraint violations -&gt; 0 duplicate company-title pairs</a:t>
             </a:r>
           </a:p>
         </p:txBody>
@@ -6671,6 +6605,7 @@
           <a:lstStyle xmlns:a="http://schemas.openxmlformats.org/drawingml/2006/main"/>
           <a:p xmlns:a="http://schemas.openxmlformats.org/drawingml/2006/main">
             <a:pPr algn="r">
+              <a:buNone/>
               <a:defRPr sz="1200" b="0">
                 <a:solidFill>
                   <a:srgbClr val="565D67"/>
@@ -6688,1917 +6623,33 @@
           </a:p>
         </p:txBody>
       </p:sp>
-      <p:sp>
-        <p:nvSpPr>
-          <p:cNvPr id="4" name="">
-            <a:extLst xmlns:a="http://schemas.openxmlformats.org/drawingml/2006/main">
-              <a:ext uri="{FF2B5EF4-FFF2-40B4-BE49-F238E27FC236}">
-                <a16:creationId xmlns:a16="http://schemas.microsoft.com/office/drawing/2014/main" id="{70BBC0E9-56F5-4F15-B41E-8C907B63B461}"/>
-              </a:ext>
-            </a:extLst>
-          </p:cNvPr>
-          <p:cNvSpPr>
-            <a:spLocks xmlns:a="http://schemas.openxmlformats.org/drawingml/2006/main" noGrp="1"/>
-          </p:cNvSpPr>
-          <p:nvPr/>
-        </p:nvSpPr>
-        <p:spPr>
-          <a:xfrm xmlns:a="http://schemas.openxmlformats.org/drawingml/2006/main">
-            <a:off x="419100" y="1581150"/>
-            <a:ext cx="1238250" cy="304800"/>
-          </a:xfrm>
-          <a:prstGeom xmlns:a="http://schemas.openxmlformats.org/drawingml/2006/main" prst="rect">
-            <a:avLst/>
-          </a:prstGeom>
-          <a:noFill xmlns:a="http://schemas.openxmlformats.org/drawingml/2006/main"/>
-          <a:ln xmlns:a="http://schemas.openxmlformats.org/drawingml/2006/main" w="0">
-            <a:noFill/>
-            <a:prstDash val="solid"/>
-          </a:ln>
-        </p:spPr>
-        <p:txBody>
-          <a:bodyPr xmlns:a="http://schemas.openxmlformats.org/drawingml/2006/main" anchor="t"/>
-          <a:lstStyle xmlns:a="http://schemas.openxmlformats.org/drawingml/2006/main"/>
-          <a:p xmlns:a="http://schemas.openxmlformats.org/drawingml/2006/main">
-            <a:pPr algn="l">
-              <a:defRPr sz="1650" b="1">
-                <a:solidFill>
-                  <a:srgbClr val="3D8DFF"/>
-                </a:solidFill>
-              </a:defRPr>
-            </a:pPr>
-            <a:r>
-              <a:rPr sz="1650" b="1">
-                <a:solidFill>
-                  <a:srgbClr val="3D8DFF"/>
-                </a:solidFill>
-              </a:rPr>
-              <a:t>INPUT</a:t>
-            </a:r>
-          </a:p>
-        </p:txBody>
-      </p:sp>
-      <p:sp>
-        <p:nvSpPr>
-          <p:cNvPr id="5" name="">
-            <a:extLst xmlns:a="http://schemas.openxmlformats.org/drawingml/2006/main">
-              <a:ext uri="{FF2B5EF4-FFF2-40B4-BE49-F238E27FC236}">
-                <a16:creationId xmlns:a16="http://schemas.microsoft.com/office/drawing/2014/main" id="{AC43585A-18D7-4F8E-BB7A-BC463BDA6477}"/>
-              </a:ext>
-            </a:extLst>
-          </p:cNvPr>
-          <p:cNvSpPr>
-            <a:spLocks xmlns:a="http://schemas.openxmlformats.org/drawingml/2006/main" noGrp="1"/>
-          </p:cNvSpPr>
-          <p:nvPr/>
-        </p:nvSpPr>
-        <p:spPr>
-          <a:xfrm xmlns:a="http://schemas.openxmlformats.org/drawingml/2006/main">
-            <a:off x="1581150" y="1524000"/>
-            <a:ext cx="9906000" cy="590550"/>
-          </a:xfrm>
-          <a:prstGeom xmlns:a="http://schemas.openxmlformats.org/drawingml/2006/main" prst="rect">
-            <a:avLst/>
-          </a:prstGeom>
-          <a:noFill xmlns:a="http://schemas.openxmlformats.org/drawingml/2006/main"/>
-          <a:ln xmlns:a="http://schemas.openxmlformats.org/drawingml/2006/main" w="0">
-            <a:noFill/>
-            <a:prstDash val="solid"/>
-          </a:ln>
-        </p:spPr>
-        <p:txBody>
-          <a:bodyPr xmlns:a="http://schemas.openxmlformats.org/drawingml/2006/main" anchor="t"/>
-          <a:lstStyle xmlns:a="http://schemas.openxmlformats.org/drawingml/2006/main"/>
-          <a:p xmlns:a="http://schemas.openxmlformats.org/drawingml/2006/main">
-            <a:pPr algn="l">
-              <a:defRPr sz="1575" b="0">
-                <a:solidFill>
-                  <a:srgbClr val="111111"/>
-                </a:solidFill>
-              </a:defRPr>
-            </a:pPr>
-            <a:r>
-              <a:rPr sz="1575" b="0">
-                <a:solidFill>
-                  <a:srgbClr val="111111"/>
-                </a:solidFill>
-              </a:rPr>
-              <a:t>Find entry-level US data analyst, business analyst, or BI roles with SQL, Python, Excel, Tableau, or Power BI. Remote roles are acceptable.</a:t>
-            </a:r>
-          </a:p>
-        </p:txBody>
-      </p:sp>
-      <p:sp>
-        <p:nvSpPr>
-          <p:cNvPr id="6" name="">
-            <a:extLst xmlns:a="http://schemas.openxmlformats.org/drawingml/2006/main">
-              <a:ext uri="{FF2B5EF4-FFF2-40B4-BE49-F238E27FC236}">
-                <a16:creationId xmlns:a16="http://schemas.microsoft.com/office/drawing/2014/main" id="{6469EE34-7DAE-40AC-8AEB-B5B39D6E8BFF}"/>
-              </a:ext>
-            </a:extLst>
-          </p:cNvPr>
-          <p:cNvSpPr>
-            <a:spLocks xmlns:a="http://schemas.openxmlformats.org/drawingml/2006/main" noGrp="1"/>
-          </p:cNvSpPr>
-          <p:nvPr/>
-        </p:nvSpPr>
-        <p:spPr>
-          <a:xfrm xmlns:a="http://schemas.openxmlformats.org/drawingml/2006/main">
-            <a:off x="419100" y="2343150"/>
-            <a:ext cx="666750" cy="457200"/>
-          </a:xfrm>
-          <a:prstGeom xmlns:a="http://schemas.openxmlformats.org/drawingml/2006/main" prst="rect">
-            <a:avLst/>
-          </a:prstGeom>
-          <a:solidFill xmlns:a="http://schemas.openxmlformats.org/drawingml/2006/main">
-            <a:srgbClr val="EDEDED"/>
-          </a:solidFill>
-          <a:ln xmlns:a="http://schemas.openxmlformats.org/drawingml/2006/main" w="9525">
-            <a:solidFill>
-              <a:srgbClr val="FFFFFF"/>
-            </a:solidFill>
-            <a:prstDash val="solid"/>
-          </a:ln>
-        </p:spPr>
-      </p:sp>
-      <p:sp>
-        <p:nvSpPr>
-          <p:cNvPr id="7" name="">
-            <a:extLst xmlns:a="http://schemas.openxmlformats.org/drawingml/2006/main">
-              <a:ext uri="{FF2B5EF4-FFF2-40B4-BE49-F238E27FC236}">
-                <a16:creationId xmlns:a16="http://schemas.microsoft.com/office/drawing/2014/main" id="{243C6886-3491-486E-B3A2-8FA048D32CF0}"/>
-              </a:ext>
-            </a:extLst>
-          </p:cNvPr>
-          <p:cNvSpPr>
-            <a:spLocks xmlns:a="http://schemas.openxmlformats.org/drawingml/2006/main" noGrp="1"/>
-          </p:cNvSpPr>
-          <p:nvPr/>
-        </p:nvSpPr>
-        <p:spPr>
-          <a:xfrm xmlns:a="http://schemas.openxmlformats.org/drawingml/2006/main">
-            <a:off x="476250" y="2466975"/>
-            <a:ext cx="552450" cy="228600"/>
-          </a:xfrm>
-          <a:prstGeom xmlns:a="http://schemas.openxmlformats.org/drawingml/2006/main" prst="rect">
-            <a:avLst/>
-          </a:prstGeom>
-          <a:noFill xmlns:a="http://schemas.openxmlformats.org/drawingml/2006/main"/>
-          <a:ln xmlns:a="http://schemas.openxmlformats.org/drawingml/2006/main" w="0">
-            <a:noFill/>
-            <a:prstDash val="solid"/>
-          </a:ln>
-        </p:spPr>
-        <p:txBody>
-          <a:bodyPr xmlns:a="http://schemas.openxmlformats.org/drawingml/2006/main" anchor="t"/>
-          <a:lstStyle xmlns:a="http://schemas.openxmlformats.org/drawingml/2006/main"/>
-          <a:p xmlns:a="http://schemas.openxmlformats.org/drawingml/2006/main">
-            <a:pPr algn="l">
-              <a:defRPr sz="1050" b="1">
-                <a:solidFill>
-                  <a:srgbClr val="111111"/>
-                </a:solidFill>
-              </a:defRPr>
-            </a:pPr>
-            <a:r>
-              <a:rPr sz="1050" b="1">
-                <a:solidFill>
-                  <a:srgbClr val="111111"/>
-                </a:solidFill>
-              </a:rPr>
-              <a:t>RANK</a:t>
-            </a:r>
-          </a:p>
-        </p:txBody>
-      </p:sp>
-      <p:sp>
-        <p:nvSpPr>
-          <p:cNvPr id="8" name="">
-            <a:extLst xmlns:a="http://schemas.openxmlformats.org/drawingml/2006/main">
-              <a:ext uri="{FF2B5EF4-FFF2-40B4-BE49-F238E27FC236}">
-                <a16:creationId xmlns:a16="http://schemas.microsoft.com/office/drawing/2014/main" id="{FAF2676A-4324-479A-A336-481EBC203AE9}"/>
-              </a:ext>
-            </a:extLst>
-          </p:cNvPr>
-          <p:cNvSpPr>
-            <a:spLocks xmlns:a="http://schemas.openxmlformats.org/drawingml/2006/main" noGrp="1"/>
-          </p:cNvSpPr>
-          <p:nvPr/>
-        </p:nvSpPr>
-        <p:spPr>
-          <a:xfrm xmlns:a="http://schemas.openxmlformats.org/drawingml/2006/main">
-            <a:off x="1085850" y="2343150"/>
-            <a:ext cx="3619500" cy="457200"/>
-          </a:xfrm>
-          <a:prstGeom xmlns:a="http://schemas.openxmlformats.org/drawingml/2006/main" prst="rect">
-            <a:avLst/>
-          </a:prstGeom>
-          <a:solidFill xmlns:a="http://schemas.openxmlformats.org/drawingml/2006/main">
-            <a:srgbClr val="EDEDED"/>
-          </a:solidFill>
-          <a:ln xmlns:a="http://schemas.openxmlformats.org/drawingml/2006/main" w="9525">
-            <a:solidFill>
-              <a:srgbClr val="FFFFFF"/>
-            </a:solidFill>
-            <a:prstDash val="solid"/>
-          </a:ln>
-        </p:spPr>
-      </p:sp>
-      <p:sp>
-        <p:nvSpPr>
-          <p:cNvPr id="9" name="">
-            <a:extLst xmlns:a="http://schemas.openxmlformats.org/drawingml/2006/main">
-              <a:ext uri="{FF2B5EF4-FFF2-40B4-BE49-F238E27FC236}">
-                <a16:creationId xmlns:a16="http://schemas.microsoft.com/office/drawing/2014/main" id="{98DC3B87-A190-4B33-B813-4282F48AB384}"/>
-              </a:ext>
-            </a:extLst>
-          </p:cNvPr>
-          <p:cNvSpPr>
-            <a:spLocks xmlns:a="http://schemas.openxmlformats.org/drawingml/2006/main" noGrp="1"/>
-          </p:cNvSpPr>
-          <p:nvPr/>
-        </p:nvSpPr>
-        <p:spPr>
-          <a:xfrm xmlns:a="http://schemas.openxmlformats.org/drawingml/2006/main">
-            <a:off x="1143000" y="2466975"/>
-            <a:ext cx="3505200" cy="228600"/>
-          </a:xfrm>
-          <a:prstGeom xmlns:a="http://schemas.openxmlformats.org/drawingml/2006/main" prst="rect">
-            <a:avLst/>
-          </a:prstGeom>
-          <a:noFill xmlns:a="http://schemas.openxmlformats.org/drawingml/2006/main"/>
-          <a:ln xmlns:a="http://schemas.openxmlformats.org/drawingml/2006/main" w="0">
-            <a:noFill/>
-            <a:prstDash val="solid"/>
-          </a:ln>
-        </p:spPr>
-        <p:txBody>
-          <a:bodyPr xmlns:a="http://schemas.openxmlformats.org/drawingml/2006/main" anchor="t"/>
-          <a:lstStyle xmlns:a="http://schemas.openxmlformats.org/drawingml/2006/main"/>
-          <a:p xmlns:a="http://schemas.openxmlformats.org/drawingml/2006/main">
-            <a:pPr algn="l">
-              <a:defRPr sz="1200" b="1">
-                <a:solidFill>
-                  <a:srgbClr val="111111"/>
-                </a:solidFill>
-              </a:defRPr>
-            </a:pPr>
-            <a:r>
-              <a:rPr sz="1200" b="1">
-                <a:solidFill>
-                  <a:srgbClr val="111111"/>
-                </a:solidFill>
-              </a:rPr>
-              <a:t>POSTING</a:t>
-            </a:r>
-          </a:p>
-        </p:txBody>
-      </p:sp>
-      <p:sp>
-        <p:nvSpPr>
-          <p:cNvPr id="10" name="">
-            <a:extLst xmlns:a="http://schemas.openxmlformats.org/drawingml/2006/main">
-              <a:ext uri="{FF2B5EF4-FFF2-40B4-BE49-F238E27FC236}">
-                <a16:creationId xmlns:a16="http://schemas.microsoft.com/office/drawing/2014/main" id="{61E47D26-1CD6-40B9-A9DE-697FDFE250F6}"/>
-              </a:ext>
-            </a:extLst>
-          </p:cNvPr>
-          <p:cNvSpPr>
-            <a:spLocks xmlns:a="http://schemas.openxmlformats.org/drawingml/2006/main" noGrp="1"/>
-          </p:cNvSpPr>
-          <p:nvPr/>
-        </p:nvSpPr>
-        <p:spPr>
-          <a:xfrm xmlns:a="http://schemas.openxmlformats.org/drawingml/2006/main">
-            <a:off x="4705350" y="2343150"/>
-            <a:ext cx="3714750" cy="457200"/>
-          </a:xfrm>
-          <a:prstGeom xmlns:a="http://schemas.openxmlformats.org/drawingml/2006/main" prst="rect">
-            <a:avLst/>
-          </a:prstGeom>
-          <a:solidFill xmlns:a="http://schemas.openxmlformats.org/drawingml/2006/main">
-            <a:srgbClr val="EDEDED"/>
-          </a:solidFill>
-          <a:ln xmlns:a="http://schemas.openxmlformats.org/drawingml/2006/main" w="9525">
-            <a:solidFill>
-              <a:srgbClr val="FFFFFF"/>
-            </a:solidFill>
-            <a:prstDash val="solid"/>
-          </a:ln>
-        </p:spPr>
-      </p:sp>
-      <p:sp>
-        <p:nvSpPr>
-          <p:cNvPr id="11" name="">
-            <a:extLst xmlns:a="http://schemas.openxmlformats.org/drawingml/2006/main">
-              <a:ext uri="{FF2B5EF4-FFF2-40B4-BE49-F238E27FC236}">
-                <a16:creationId xmlns:a16="http://schemas.microsoft.com/office/drawing/2014/main" id="{C0F610CA-0571-4068-AD3A-F53251103708}"/>
-              </a:ext>
-            </a:extLst>
-          </p:cNvPr>
-          <p:cNvSpPr>
-            <a:spLocks xmlns:a="http://schemas.openxmlformats.org/drawingml/2006/main" noGrp="1"/>
-          </p:cNvSpPr>
-          <p:nvPr/>
-        </p:nvSpPr>
-        <p:spPr>
-          <a:xfrm xmlns:a="http://schemas.openxmlformats.org/drawingml/2006/main">
-            <a:off x="4762500" y="2466975"/>
-            <a:ext cx="3600450" cy="228600"/>
-          </a:xfrm>
-          <a:prstGeom xmlns:a="http://schemas.openxmlformats.org/drawingml/2006/main" prst="rect">
-            <a:avLst/>
-          </a:prstGeom>
-          <a:noFill xmlns:a="http://schemas.openxmlformats.org/drawingml/2006/main"/>
-          <a:ln xmlns:a="http://schemas.openxmlformats.org/drawingml/2006/main" w="0">
-            <a:noFill/>
-            <a:prstDash val="solid"/>
-          </a:ln>
-        </p:spPr>
-        <p:txBody>
-          <a:bodyPr xmlns:a="http://schemas.openxmlformats.org/drawingml/2006/main" anchor="t"/>
-          <a:lstStyle xmlns:a="http://schemas.openxmlformats.org/drawingml/2006/main"/>
-          <a:p xmlns:a="http://schemas.openxmlformats.org/drawingml/2006/main">
-            <a:pPr algn="l">
-              <a:defRPr sz="1200" b="1">
-                <a:solidFill>
-                  <a:srgbClr val="111111"/>
-                </a:solidFill>
-              </a:defRPr>
-            </a:pPr>
-            <a:r>
-              <a:rPr sz="1200" b="1">
-                <a:solidFill>
-                  <a:srgbClr val="111111"/>
-                </a:solidFill>
-              </a:rPr>
-              <a:t>COMPANY / LOCATION</a:t>
-            </a:r>
-          </a:p>
-        </p:txBody>
-      </p:sp>
-      <p:sp>
-        <p:nvSpPr>
-          <p:cNvPr id="12" name="">
-            <a:extLst xmlns:a="http://schemas.openxmlformats.org/drawingml/2006/main">
-              <a:ext uri="{FF2B5EF4-FFF2-40B4-BE49-F238E27FC236}">
-                <a16:creationId xmlns:a16="http://schemas.microsoft.com/office/drawing/2014/main" id="{FE98E561-B445-4781-9F71-9997A769E350}"/>
-              </a:ext>
-            </a:extLst>
-          </p:cNvPr>
-          <p:cNvSpPr>
-            <a:spLocks xmlns:a="http://schemas.openxmlformats.org/drawingml/2006/main" noGrp="1"/>
-          </p:cNvSpPr>
-          <p:nvPr/>
-        </p:nvSpPr>
-        <p:spPr>
-          <a:xfrm xmlns:a="http://schemas.openxmlformats.org/drawingml/2006/main">
-            <a:off x="8420100" y="2343150"/>
-            <a:ext cx="1428750" cy="457200"/>
-          </a:xfrm>
-          <a:prstGeom xmlns:a="http://schemas.openxmlformats.org/drawingml/2006/main" prst="rect">
-            <a:avLst/>
-          </a:prstGeom>
-          <a:solidFill xmlns:a="http://schemas.openxmlformats.org/drawingml/2006/main">
-            <a:srgbClr val="EDEDED"/>
-          </a:solidFill>
-          <a:ln xmlns:a="http://schemas.openxmlformats.org/drawingml/2006/main" w="9525">
-            <a:solidFill>
-              <a:srgbClr val="FFFFFF"/>
-            </a:solidFill>
-            <a:prstDash val="solid"/>
-          </a:ln>
-        </p:spPr>
-      </p:sp>
-      <p:sp>
-        <p:nvSpPr>
-          <p:cNvPr id="13" name="">
-            <a:extLst xmlns:a="http://schemas.openxmlformats.org/drawingml/2006/main">
-              <a:ext uri="{FF2B5EF4-FFF2-40B4-BE49-F238E27FC236}">
-                <a16:creationId xmlns:a16="http://schemas.microsoft.com/office/drawing/2014/main" id="{5BA5A32E-3180-4F7B-9390-62C3D6099B16}"/>
-              </a:ext>
-            </a:extLst>
-          </p:cNvPr>
-          <p:cNvSpPr>
-            <a:spLocks xmlns:a="http://schemas.openxmlformats.org/drawingml/2006/main" noGrp="1"/>
-          </p:cNvSpPr>
-          <p:nvPr/>
-        </p:nvSpPr>
-        <p:spPr>
-          <a:xfrm xmlns:a="http://schemas.openxmlformats.org/drawingml/2006/main">
-            <a:off x="8477250" y="2466975"/>
-            <a:ext cx="1314450" cy="228600"/>
-          </a:xfrm>
-          <a:prstGeom xmlns:a="http://schemas.openxmlformats.org/drawingml/2006/main" prst="rect">
-            <a:avLst/>
-          </a:prstGeom>
-          <a:noFill xmlns:a="http://schemas.openxmlformats.org/drawingml/2006/main"/>
-          <a:ln xmlns:a="http://schemas.openxmlformats.org/drawingml/2006/main" w="0">
-            <a:noFill/>
-            <a:prstDash val="solid"/>
-          </a:ln>
-        </p:spPr>
-        <p:txBody>
-          <a:bodyPr xmlns:a="http://schemas.openxmlformats.org/drawingml/2006/main" anchor="t"/>
-          <a:lstStyle xmlns:a="http://schemas.openxmlformats.org/drawingml/2006/main"/>
-          <a:p xmlns:a="http://schemas.openxmlformats.org/drawingml/2006/main">
-            <a:pPr algn="l">
-              <a:defRPr sz="1200" b="1">
-                <a:solidFill>
-                  <a:srgbClr val="111111"/>
-                </a:solidFill>
-              </a:defRPr>
-            </a:pPr>
-            <a:r>
-              <a:rPr sz="1200" b="1">
-                <a:solidFill>
-                  <a:srgbClr val="111111"/>
-                </a:solidFill>
-              </a:rPr>
-              <a:t>FIT</a:t>
-            </a:r>
-          </a:p>
-        </p:txBody>
-      </p:sp>
-      <p:sp>
-        <p:nvSpPr>
-          <p:cNvPr id="14" name="">
-            <a:extLst xmlns:a="http://schemas.openxmlformats.org/drawingml/2006/main">
-              <a:ext uri="{FF2B5EF4-FFF2-40B4-BE49-F238E27FC236}">
-                <a16:creationId xmlns:a16="http://schemas.microsoft.com/office/drawing/2014/main" id="{557ADC12-66D4-4043-99C0-B6826E62FB7C}"/>
-              </a:ext>
-            </a:extLst>
-          </p:cNvPr>
-          <p:cNvSpPr>
-            <a:spLocks xmlns:a="http://schemas.openxmlformats.org/drawingml/2006/main" noGrp="1"/>
-          </p:cNvSpPr>
-          <p:nvPr/>
-        </p:nvSpPr>
-        <p:spPr>
-          <a:xfrm xmlns:a="http://schemas.openxmlformats.org/drawingml/2006/main">
-            <a:off x="9848850" y="2343150"/>
-            <a:ext cx="952500" cy="457200"/>
-          </a:xfrm>
-          <a:prstGeom xmlns:a="http://schemas.openxmlformats.org/drawingml/2006/main" prst="rect">
-            <a:avLst/>
-          </a:prstGeom>
-          <a:solidFill xmlns:a="http://schemas.openxmlformats.org/drawingml/2006/main">
-            <a:srgbClr val="EDEDED"/>
-          </a:solidFill>
-          <a:ln xmlns:a="http://schemas.openxmlformats.org/drawingml/2006/main" w="9525">
-            <a:solidFill>
-              <a:srgbClr val="FFFFFF"/>
-            </a:solidFill>
-            <a:prstDash val="solid"/>
-          </a:ln>
-        </p:spPr>
-      </p:sp>
-      <p:sp>
-        <p:nvSpPr>
-          <p:cNvPr id="15" name="">
-            <a:extLst xmlns:a="http://schemas.openxmlformats.org/drawingml/2006/main">
-              <a:ext uri="{FF2B5EF4-FFF2-40B4-BE49-F238E27FC236}">
-                <a16:creationId xmlns:a16="http://schemas.microsoft.com/office/drawing/2014/main" id="{3C50F3F3-B032-46A0-8DF3-92E91C6806B4}"/>
-              </a:ext>
-            </a:extLst>
-          </p:cNvPr>
-          <p:cNvSpPr>
-            <a:spLocks xmlns:a="http://schemas.openxmlformats.org/drawingml/2006/main" noGrp="1"/>
-          </p:cNvSpPr>
-          <p:nvPr/>
-        </p:nvSpPr>
-        <p:spPr>
-          <a:xfrm xmlns:a="http://schemas.openxmlformats.org/drawingml/2006/main">
-            <a:off x="9906000" y="2466975"/>
-            <a:ext cx="838200" cy="228600"/>
-          </a:xfrm>
-          <a:prstGeom xmlns:a="http://schemas.openxmlformats.org/drawingml/2006/main" prst="rect">
-            <a:avLst/>
-          </a:prstGeom>
-          <a:noFill xmlns:a="http://schemas.openxmlformats.org/drawingml/2006/main"/>
-          <a:ln xmlns:a="http://schemas.openxmlformats.org/drawingml/2006/main" w="0">
-            <a:noFill/>
-            <a:prstDash val="solid"/>
-          </a:ln>
-        </p:spPr>
-        <p:txBody>
-          <a:bodyPr xmlns:a="http://schemas.openxmlformats.org/drawingml/2006/main" anchor="t"/>
-          <a:lstStyle xmlns:a="http://schemas.openxmlformats.org/drawingml/2006/main"/>
-          <a:p xmlns:a="http://schemas.openxmlformats.org/drawingml/2006/main">
-            <a:pPr algn="l">
-              <a:defRPr sz="1200" b="1">
-                <a:solidFill>
-                  <a:srgbClr val="111111"/>
-                </a:solidFill>
-              </a:defRPr>
-            </a:pPr>
-            <a:r>
-              <a:rPr sz="1200" b="1">
-                <a:solidFill>
-                  <a:srgbClr val="111111"/>
-                </a:solidFill>
-              </a:rPr>
-              <a:t>SCORE</a:t>
-            </a:r>
-          </a:p>
-        </p:txBody>
-      </p:sp>
-      <p:sp>
-        <p:nvSpPr>
-          <p:cNvPr id="16" name="">
-            <a:extLst xmlns:a="http://schemas.openxmlformats.org/drawingml/2006/main">
-              <a:ext uri="{FF2B5EF4-FFF2-40B4-BE49-F238E27FC236}">
-                <a16:creationId xmlns:a16="http://schemas.microsoft.com/office/drawing/2014/main" id="{6647ECF4-4EEE-4A22-8FDF-8D8E50168EC8}"/>
-              </a:ext>
-            </a:extLst>
-          </p:cNvPr>
-          <p:cNvSpPr>
-            <a:spLocks xmlns:a="http://schemas.openxmlformats.org/drawingml/2006/main" noGrp="1"/>
-          </p:cNvSpPr>
-          <p:nvPr/>
-        </p:nvSpPr>
-        <p:spPr>
-          <a:xfrm xmlns:a="http://schemas.openxmlformats.org/drawingml/2006/main">
-            <a:off x="419100" y="2800350"/>
-            <a:ext cx="666750" cy="723900"/>
-          </a:xfrm>
-          <a:prstGeom xmlns:a="http://schemas.openxmlformats.org/drawingml/2006/main" prst="rect">
-            <a:avLst/>
-          </a:prstGeom>
-          <a:solidFill xmlns:a="http://schemas.openxmlformats.org/drawingml/2006/main">
-            <a:srgbClr val="FFFFFF"/>
-          </a:solidFill>
-          <a:ln xmlns:a="http://schemas.openxmlformats.org/drawingml/2006/main" w="9525">
-            <a:solidFill>
-              <a:srgbClr val="B8BCC4"/>
-            </a:solidFill>
-            <a:prstDash val="solid"/>
-          </a:ln>
-        </p:spPr>
-      </p:sp>
-      <p:sp>
-        <p:nvSpPr>
-          <p:cNvPr id="17" name="">
-            <a:extLst xmlns:a="http://schemas.openxmlformats.org/drawingml/2006/main">
-              <a:ext uri="{FF2B5EF4-FFF2-40B4-BE49-F238E27FC236}">
-                <a16:creationId xmlns:a16="http://schemas.microsoft.com/office/drawing/2014/main" id="{A0BDF1E4-BE9B-4072-ACAA-B28C99F3503A}"/>
-              </a:ext>
-            </a:extLst>
-          </p:cNvPr>
-          <p:cNvSpPr>
-            <a:spLocks xmlns:a="http://schemas.openxmlformats.org/drawingml/2006/main" noGrp="1"/>
-          </p:cNvSpPr>
-          <p:nvPr/>
-        </p:nvSpPr>
-        <p:spPr>
-          <a:xfrm xmlns:a="http://schemas.openxmlformats.org/drawingml/2006/main">
-            <a:off x="495300" y="2914650"/>
-            <a:ext cx="514350" cy="514350"/>
-          </a:xfrm>
-          <a:prstGeom xmlns:a="http://schemas.openxmlformats.org/drawingml/2006/main" prst="rect">
-            <a:avLst/>
-          </a:prstGeom>
-          <a:noFill xmlns:a="http://schemas.openxmlformats.org/drawingml/2006/main"/>
-          <a:ln xmlns:a="http://schemas.openxmlformats.org/drawingml/2006/main" w="0">
-            <a:noFill/>
-            <a:prstDash val="solid"/>
-          </a:ln>
-        </p:spPr>
-        <p:txBody>
-          <a:bodyPr xmlns:a="http://schemas.openxmlformats.org/drawingml/2006/main" anchor="t"/>
-          <a:lstStyle xmlns:a="http://schemas.openxmlformats.org/drawingml/2006/main"/>
-          <a:p xmlns:a="http://schemas.openxmlformats.org/drawingml/2006/main">
-            <a:pPr algn="l">
-              <a:defRPr sz="1350" b="0">
-                <a:solidFill>
-                  <a:srgbClr val="111111"/>
-                </a:solidFill>
-              </a:defRPr>
-            </a:pPr>
-            <a:r>
-              <a:rPr sz="1350" b="0">
-                <a:solidFill>
-                  <a:srgbClr val="111111"/>
-                </a:solidFill>
-              </a:rPr>
-              <a:t>1</a:t>
-            </a:r>
-          </a:p>
-        </p:txBody>
-      </p:sp>
-      <p:sp>
-        <p:nvSpPr>
-          <p:cNvPr id="18" name="">
-            <a:extLst xmlns:a="http://schemas.openxmlformats.org/drawingml/2006/main">
-              <a:ext uri="{FF2B5EF4-FFF2-40B4-BE49-F238E27FC236}">
-                <a16:creationId xmlns:a16="http://schemas.microsoft.com/office/drawing/2014/main" id="{604843EC-BEA8-4CFB-9F70-35D2F3CDF9FA}"/>
-              </a:ext>
-            </a:extLst>
-          </p:cNvPr>
-          <p:cNvSpPr>
-            <a:spLocks xmlns:a="http://schemas.openxmlformats.org/drawingml/2006/main" noGrp="1"/>
-          </p:cNvSpPr>
-          <p:nvPr/>
-        </p:nvSpPr>
-        <p:spPr>
-          <a:xfrm xmlns:a="http://schemas.openxmlformats.org/drawingml/2006/main">
-            <a:off x="1085850" y="2800350"/>
-            <a:ext cx="3619500" cy="723900"/>
-          </a:xfrm>
-          <a:prstGeom xmlns:a="http://schemas.openxmlformats.org/drawingml/2006/main" prst="rect">
-            <a:avLst/>
-          </a:prstGeom>
-          <a:solidFill xmlns:a="http://schemas.openxmlformats.org/drawingml/2006/main">
-            <a:srgbClr val="FFFFFF"/>
-          </a:solidFill>
-          <a:ln xmlns:a="http://schemas.openxmlformats.org/drawingml/2006/main" w="9525">
-            <a:solidFill>
-              <a:srgbClr val="B8BCC4"/>
-            </a:solidFill>
-            <a:prstDash val="solid"/>
-          </a:ln>
-        </p:spPr>
-      </p:sp>
-      <p:sp>
-        <p:nvSpPr>
-          <p:cNvPr id="19" name="">
-            <a:extLst xmlns:a="http://schemas.openxmlformats.org/drawingml/2006/main">
-              <a:ext uri="{FF2B5EF4-FFF2-40B4-BE49-F238E27FC236}">
-                <a16:creationId xmlns:a16="http://schemas.microsoft.com/office/drawing/2014/main" id="{6807CF48-9B8B-496D-90FF-D9EFB81E3F69}"/>
-              </a:ext>
-            </a:extLst>
-          </p:cNvPr>
-          <p:cNvSpPr>
-            <a:spLocks xmlns:a="http://schemas.openxmlformats.org/drawingml/2006/main" noGrp="1"/>
-          </p:cNvSpPr>
-          <p:nvPr/>
-        </p:nvSpPr>
-        <p:spPr>
-          <a:xfrm xmlns:a="http://schemas.openxmlformats.org/drawingml/2006/main">
-            <a:off x="1162050" y="2914650"/>
-            <a:ext cx="3467100" cy="514350"/>
-          </a:xfrm>
-          <a:prstGeom xmlns:a="http://schemas.openxmlformats.org/drawingml/2006/main" prst="rect">
-            <a:avLst/>
-          </a:prstGeom>
-          <a:noFill xmlns:a="http://schemas.openxmlformats.org/drawingml/2006/main"/>
-          <a:ln xmlns:a="http://schemas.openxmlformats.org/drawingml/2006/main" w="0">
-            <a:noFill/>
-            <a:prstDash val="solid"/>
-          </a:ln>
-        </p:spPr>
-        <p:txBody>
-          <a:bodyPr xmlns:a="http://schemas.openxmlformats.org/drawingml/2006/main" anchor="t"/>
-          <a:lstStyle xmlns:a="http://schemas.openxmlformats.org/drawingml/2006/main"/>
-          <a:p xmlns:a="http://schemas.openxmlformats.org/drawingml/2006/main">
-            <a:pPr algn="l">
-              <a:defRPr sz="1425" b="0">
-                <a:solidFill>
-                  <a:srgbClr val="111111"/>
-                </a:solidFill>
-              </a:defRPr>
-            </a:pPr>
-            <a:r>
-              <a:rPr sz="1425" b="0">
-                <a:solidFill>
-                  <a:srgbClr val="111111"/>
-                </a:solidFill>
-              </a:rPr>
-              <a:t>Data Analyst</a:t>
-            </a:r>
-          </a:p>
-        </p:txBody>
-      </p:sp>
-      <p:sp>
-        <p:nvSpPr>
-          <p:cNvPr id="20" name="">
-            <a:extLst xmlns:a="http://schemas.openxmlformats.org/drawingml/2006/main">
-              <a:ext uri="{FF2B5EF4-FFF2-40B4-BE49-F238E27FC236}">
-                <a16:creationId xmlns:a16="http://schemas.microsoft.com/office/drawing/2014/main" id="{BCD2A4E3-ECAD-4D4E-94D2-7023F02FB89E}"/>
-              </a:ext>
-            </a:extLst>
-          </p:cNvPr>
-          <p:cNvSpPr>
-            <a:spLocks xmlns:a="http://schemas.openxmlformats.org/drawingml/2006/main" noGrp="1"/>
-          </p:cNvSpPr>
-          <p:nvPr/>
-        </p:nvSpPr>
-        <p:spPr>
-          <a:xfrm xmlns:a="http://schemas.openxmlformats.org/drawingml/2006/main">
-            <a:off x="4705350" y="2800350"/>
-            <a:ext cx="3714750" cy="723900"/>
-          </a:xfrm>
-          <a:prstGeom xmlns:a="http://schemas.openxmlformats.org/drawingml/2006/main" prst="rect">
-            <a:avLst/>
-          </a:prstGeom>
-          <a:solidFill xmlns:a="http://schemas.openxmlformats.org/drawingml/2006/main">
-            <a:srgbClr val="FFFFFF"/>
-          </a:solidFill>
-          <a:ln xmlns:a="http://schemas.openxmlformats.org/drawingml/2006/main" w="9525">
-            <a:solidFill>
-              <a:srgbClr val="B8BCC4"/>
-            </a:solidFill>
-            <a:prstDash val="solid"/>
-          </a:ln>
-        </p:spPr>
-      </p:sp>
-      <p:sp>
-        <p:nvSpPr>
-          <p:cNvPr id="21" name="">
-            <a:extLst xmlns:a="http://schemas.openxmlformats.org/drawingml/2006/main">
-              <a:ext uri="{FF2B5EF4-FFF2-40B4-BE49-F238E27FC236}">
-                <a16:creationId xmlns:a16="http://schemas.microsoft.com/office/drawing/2014/main" id="{76AFB412-57AD-4BEE-895F-DC9D91CB610B}"/>
-              </a:ext>
-            </a:extLst>
-          </p:cNvPr>
-          <p:cNvSpPr>
-            <a:spLocks xmlns:a="http://schemas.openxmlformats.org/drawingml/2006/main" noGrp="1"/>
-          </p:cNvSpPr>
-          <p:nvPr/>
-        </p:nvSpPr>
-        <p:spPr>
-          <a:xfrm xmlns:a="http://schemas.openxmlformats.org/drawingml/2006/main">
-            <a:off x="4781550" y="2914650"/>
-            <a:ext cx="3562350" cy="514350"/>
-          </a:xfrm>
-          <a:prstGeom xmlns:a="http://schemas.openxmlformats.org/drawingml/2006/main" prst="rect">
-            <a:avLst/>
-          </a:prstGeom>
-          <a:noFill xmlns:a="http://schemas.openxmlformats.org/drawingml/2006/main"/>
-          <a:ln xmlns:a="http://schemas.openxmlformats.org/drawingml/2006/main" w="0">
-            <a:noFill/>
-            <a:prstDash val="solid"/>
-          </a:ln>
-        </p:spPr>
-        <p:txBody>
-          <a:bodyPr xmlns:a="http://schemas.openxmlformats.org/drawingml/2006/main" anchor="t"/>
-          <a:lstStyle xmlns:a="http://schemas.openxmlformats.org/drawingml/2006/main"/>
-          <a:p xmlns:a="http://schemas.openxmlformats.org/drawingml/2006/main">
-            <a:pPr algn="l">
-              <a:defRPr sz="1425" b="0">
-                <a:solidFill>
-                  <a:srgbClr val="111111"/>
-                </a:solidFill>
-              </a:defRPr>
-            </a:pPr>
-            <a:r>
-              <a:rPr sz="1425" b="0">
-                <a:solidFill>
-                  <a:srgbClr val="111111"/>
-                </a:solidFill>
-              </a:rPr>
-              <a:t>HireMatch</a:t>
-            </a:r>
-          </a:p>
-          <a:p xmlns:a="http://schemas.openxmlformats.org/drawingml/2006/main">
-            <a:pPr algn="l">
-              <a:defRPr sz="1425" b="0">
-                <a:solidFill>
-                  <a:srgbClr val="111111"/>
-                </a:solidFill>
-              </a:defRPr>
-            </a:pPr>
-            <a:r>
-              <a:rPr sz="1425" b="0">
-                <a:solidFill>
-                  <a:srgbClr val="111111"/>
-                </a:solidFill>
-              </a:rPr>
-              <a:t>Anywhere</a:t>
-            </a:r>
-          </a:p>
-        </p:txBody>
-      </p:sp>
-      <p:sp>
-        <p:nvSpPr>
-          <p:cNvPr id="22" name="">
-            <a:extLst xmlns:a="http://schemas.openxmlformats.org/drawingml/2006/main">
-              <a:ext uri="{FF2B5EF4-FFF2-40B4-BE49-F238E27FC236}">
-                <a16:creationId xmlns:a16="http://schemas.microsoft.com/office/drawing/2014/main" id="{6F845062-1972-4462-A6FA-46EBF0662B96}"/>
-              </a:ext>
-            </a:extLst>
-          </p:cNvPr>
-          <p:cNvSpPr>
-            <a:spLocks xmlns:a="http://schemas.openxmlformats.org/drawingml/2006/main" noGrp="1"/>
-          </p:cNvSpPr>
-          <p:nvPr/>
-        </p:nvSpPr>
-        <p:spPr>
-          <a:xfrm xmlns:a="http://schemas.openxmlformats.org/drawingml/2006/main">
-            <a:off x="8420100" y="2800350"/>
-            <a:ext cx="1428750" cy="723900"/>
-          </a:xfrm>
-          <a:prstGeom xmlns:a="http://schemas.openxmlformats.org/drawingml/2006/main" prst="rect">
-            <a:avLst/>
-          </a:prstGeom>
-          <a:solidFill xmlns:a="http://schemas.openxmlformats.org/drawingml/2006/main">
-            <a:srgbClr val="FFFFFF"/>
-          </a:solidFill>
-          <a:ln xmlns:a="http://schemas.openxmlformats.org/drawingml/2006/main" w="9525">
-            <a:solidFill>
-              <a:srgbClr val="B8BCC4"/>
-            </a:solidFill>
-            <a:prstDash val="solid"/>
-          </a:ln>
-        </p:spPr>
-      </p:sp>
-      <p:sp>
-        <p:nvSpPr>
-          <p:cNvPr id="23" name="">
-            <a:extLst xmlns:a="http://schemas.openxmlformats.org/drawingml/2006/main">
-              <a:ext uri="{FF2B5EF4-FFF2-40B4-BE49-F238E27FC236}">
-                <a16:creationId xmlns:a16="http://schemas.microsoft.com/office/drawing/2014/main" id="{904EC6EA-23C8-47DF-9BD4-7E1A8070B87C}"/>
-              </a:ext>
-            </a:extLst>
-          </p:cNvPr>
-          <p:cNvSpPr>
-            <a:spLocks xmlns:a="http://schemas.openxmlformats.org/drawingml/2006/main" noGrp="1"/>
-          </p:cNvSpPr>
-          <p:nvPr/>
-        </p:nvSpPr>
-        <p:spPr>
-          <a:xfrm xmlns:a="http://schemas.openxmlformats.org/drawingml/2006/main">
-            <a:off x="8496300" y="2914650"/>
-            <a:ext cx="1276350" cy="514350"/>
-          </a:xfrm>
-          <a:prstGeom xmlns:a="http://schemas.openxmlformats.org/drawingml/2006/main" prst="rect">
-            <a:avLst/>
-          </a:prstGeom>
-          <a:noFill xmlns:a="http://schemas.openxmlformats.org/drawingml/2006/main"/>
-          <a:ln xmlns:a="http://schemas.openxmlformats.org/drawingml/2006/main" w="0">
-            <a:noFill/>
-            <a:prstDash val="solid"/>
-          </a:ln>
-        </p:spPr>
-        <p:txBody>
-          <a:bodyPr xmlns:a="http://schemas.openxmlformats.org/drawingml/2006/main" anchor="t"/>
-          <a:lstStyle xmlns:a="http://schemas.openxmlformats.org/drawingml/2006/main"/>
-          <a:p xmlns:a="http://schemas.openxmlformats.org/drawingml/2006/main">
-            <a:pPr algn="l">
-              <a:defRPr sz="1425" b="1">
-                <a:solidFill>
-                  <a:srgbClr val="3D8DFF"/>
-                </a:solidFill>
-              </a:defRPr>
-            </a:pPr>
-            <a:r>
-              <a:rPr sz="1425" b="1">
-                <a:solidFill>
-                  <a:srgbClr val="3D8DFF"/>
-                </a:solidFill>
-              </a:rPr>
-              <a:t>high_fit</a:t>
-            </a:r>
-          </a:p>
-        </p:txBody>
-      </p:sp>
-      <p:sp>
-        <p:nvSpPr>
-          <p:cNvPr id="24" name="">
-            <a:extLst xmlns:a="http://schemas.openxmlformats.org/drawingml/2006/main">
-              <a:ext uri="{FF2B5EF4-FFF2-40B4-BE49-F238E27FC236}">
-                <a16:creationId xmlns:a16="http://schemas.microsoft.com/office/drawing/2014/main" id="{8C2B50AC-BBC9-4BE8-95F8-A555EE2FA11A}"/>
-              </a:ext>
-            </a:extLst>
-          </p:cNvPr>
-          <p:cNvSpPr>
-            <a:spLocks xmlns:a="http://schemas.openxmlformats.org/drawingml/2006/main" noGrp="1"/>
-          </p:cNvSpPr>
-          <p:nvPr/>
-        </p:nvSpPr>
-        <p:spPr>
-          <a:xfrm xmlns:a="http://schemas.openxmlformats.org/drawingml/2006/main">
-            <a:off x="9848850" y="2800350"/>
-            <a:ext cx="952500" cy="723900"/>
-          </a:xfrm>
-          <a:prstGeom xmlns:a="http://schemas.openxmlformats.org/drawingml/2006/main" prst="rect">
-            <a:avLst/>
-          </a:prstGeom>
-          <a:solidFill xmlns:a="http://schemas.openxmlformats.org/drawingml/2006/main">
-            <a:srgbClr val="FFFFFF"/>
-          </a:solidFill>
-          <a:ln xmlns:a="http://schemas.openxmlformats.org/drawingml/2006/main" w="9525">
-            <a:solidFill>
-              <a:srgbClr val="B8BCC4"/>
-            </a:solidFill>
-            <a:prstDash val="solid"/>
-          </a:ln>
-        </p:spPr>
-      </p:sp>
-      <p:sp>
-        <p:nvSpPr>
-          <p:cNvPr id="25" name="">
-            <a:extLst xmlns:a="http://schemas.openxmlformats.org/drawingml/2006/main">
-              <a:ext uri="{FF2B5EF4-FFF2-40B4-BE49-F238E27FC236}">
-                <a16:creationId xmlns:a16="http://schemas.microsoft.com/office/drawing/2014/main" id="{D3BE12CF-4B20-454F-84A2-9D5ECB827C4E}"/>
-              </a:ext>
-            </a:extLst>
-          </p:cNvPr>
-          <p:cNvSpPr>
-            <a:spLocks xmlns:a="http://schemas.openxmlformats.org/drawingml/2006/main" noGrp="1"/>
-          </p:cNvSpPr>
-          <p:nvPr/>
-        </p:nvSpPr>
-        <p:spPr>
-          <a:xfrm xmlns:a="http://schemas.openxmlformats.org/drawingml/2006/main">
-            <a:off x="9925050" y="2914650"/>
-            <a:ext cx="800100" cy="514350"/>
-          </a:xfrm>
-          <a:prstGeom xmlns:a="http://schemas.openxmlformats.org/drawingml/2006/main" prst="rect">
-            <a:avLst/>
-          </a:prstGeom>
-          <a:noFill xmlns:a="http://schemas.openxmlformats.org/drawingml/2006/main"/>
-          <a:ln xmlns:a="http://schemas.openxmlformats.org/drawingml/2006/main" w="0">
-            <a:noFill/>
-            <a:prstDash val="solid"/>
-          </a:ln>
-        </p:spPr>
-        <p:txBody>
-          <a:bodyPr xmlns:a="http://schemas.openxmlformats.org/drawingml/2006/main" anchor="t"/>
-          <a:lstStyle xmlns:a="http://schemas.openxmlformats.org/drawingml/2006/main"/>
-          <a:p xmlns:a="http://schemas.openxmlformats.org/drawingml/2006/main">
-            <a:pPr algn="l">
-              <a:defRPr sz="1350" b="0">
-                <a:solidFill>
-                  <a:srgbClr val="111111"/>
-                </a:solidFill>
-              </a:defRPr>
-            </a:pPr>
-            <a:r>
-              <a:rPr sz="1350" b="0">
-                <a:solidFill>
-                  <a:srgbClr val="111111"/>
-                </a:solidFill>
-              </a:rPr>
-              <a:t>9.854</a:t>
-            </a:r>
-          </a:p>
-        </p:txBody>
-      </p:sp>
-      <p:sp>
-        <p:nvSpPr>
-          <p:cNvPr id="26" name="">
-            <a:extLst xmlns:a="http://schemas.openxmlformats.org/drawingml/2006/main">
-              <a:ext uri="{FF2B5EF4-FFF2-40B4-BE49-F238E27FC236}">
-                <a16:creationId xmlns:a16="http://schemas.microsoft.com/office/drawing/2014/main" id="{7A232F57-D896-467A-94F9-5CA69BD5D484}"/>
-              </a:ext>
-            </a:extLst>
-          </p:cNvPr>
-          <p:cNvSpPr>
-            <a:spLocks xmlns:a="http://schemas.openxmlformats.org/drawingml/2006/main" noGrp="1"/>
-          </p:cNvSpPr>
-          <p:nvPr/>
-        </p:nvSpPr>
-        <p:spPr>
-          <a:xfrm xmlns:a="http://schemas.openxmlformats.org/drawingml/2006/main">
-            <a:off x="419100" y="3524250"/>
-            <a:ext cx="666750" cy="723900"/>
-          </a:xfrm>
-          <a:prstGeom xmlns:a="http://schemas.openxmlformats.org/drawingml/2006/main" prst="rect">
-            <a:avLst/>
-          </a:prstGeom>
-          <a:solidFill xmlns:a="http://schemas.openxmlformats.org/drawingml/2006/main">
-            <a:srgbClr val="FFFFFF"/>
-          </a:solidFill>
-          <a:ln xmlns:a="http://schemas.openxmlformats.org/drawingml/2006/main" w="9525">
-            <a:solidFill>
-              <a:srgbClr val="B8BCC4"/>
-            </a:solidFill>
-            <a:prstDash val="solid"/>
-          </a:ln>
-        </p:spPr>
-      </p:sp>
-      <p:sp>
-        <p:nvSpPr>
-          <p:cNvPr id="27" name="">
-            <a:extLst xmlns:a="http://schemas.openxmlformats.org/drawingml/2006/main">
-              <a:ext uri="{FF2B5EF4-FFF2-40B4-BE49-F238E27FC236}">
-                <a16:creationId xmlns:a16="http://schemas.microsoft.com/office/drawing/2014/main" id="{807B0B1D-9274-4A21-8735-89761C81C736}"/>
-              </a:ext>
-            </a:extLst>
-          </p:cNvPr>
-          <p:cNvSpPr>
-            <a:spLocks xmlns:a="http://schemas.openxmlformats.org/drawingml/2006/main" noGrp="1"/>
-          </p:cNvSpPr>
-          <p:nvPr/>
-        </p:nvSpPr>
-        <p:spPr>
-          <a:xfrm xmlns:a="http://schemas.openxmlformats.org/drawingml/2006/main">
-            <a:off x="495300" y="3638550"/>
-            <a:ext cx="514350" cy="514350"/>
-          </a:xfrm>
-          <a:prstGeom xmlns:a="http://schemas.openxmlformats.org/drawingml/2006/main" prst="rect">
-            <a:avLst/>
-          </a:prstGeom>
-          <a:noFill xmlns:a="http://schemas.openxmlformats.org/drawingml/2006/main"/>
-          <a:ln xmlns:a="http://schemas.openxmlformats.org/drawingml/2006/main" w="0">
-            <a:noFill/>
-            <a:prstDash val="solid"/>
-          </a:ln>
-        </p:spPr>
-        <p:txBody>
-          <a:bodyPr xmlns:a="http://schemas.openxmlformats.org/drawingml/2006/main" anchor="t"/>
-          <a:lstStyle xmlns:a="http://schemas.openxmlformats.org/drawingml/2006/main"/>
-          <a:p xmlns:a="http://schemas.openxmlformats.org/drawingml/2006/main">
-            <a:pPr algn="l">
-              <a:defRPr sz="1350" b="0">
-                <a:solidFill>
-                  <a:srgbClr val="111111"/>
-                </a:solidFill>
-              </a:defRPr>
-            </a:pPr>
-            <a:r>
-              <a:rPr sz="1350" b="0">
-                <a:solidFill>
-                  <a:srgbClr val="111111"/>
-                </a:solidFill>
-              </a:rPr>
-              <a:t>2</a:t>
-            </a:r>
-          </a:p>
-        </p:txBody>
-      </p:sp>
-      <p:sp>
-        <p:nvSpPr>
-          <p:cNvPr id="28" name="">
-            <a:extLst xmlns:a="http://schemas.openxmlformats.org/drawingml/2006/main">
-              <a:ext uri="{FF2B5EF4-FFF2-40B4-BE49-F238E27FC236}">
-                <a16:creationId xmlns:a16="http://schemas.microsoft.com/office/drawing/2014/main" id="{D8FDDADB-CED0-40B1-88FD-1D4FF9079B16}"/>
-              </a:ext>
-            </a:extLst>
-          </p:cNvPr>
-          <p:cNvSpPr>
-            <a:spLocks xmlns:a="http://schemas.openxmlformats.org/drawingml/2006/main" noGrp="1"/>
-          </p:cNvSpPr>
-          <p:nvPr/>
-        </p:nvSpPr>
-        <p:spPr>
-          <a:xfrm xmlns:a="http://schemas.openxmlformats.org/drawingml/2006/main">
-            <a:off x="1085850" y="3524250"/>
-            <a:ext cx="3619500" cy="723900"/>
-          </a:xfrm>
-          <a:prstGeom xmlns:a="http://schemas.openxmlformats.org/drawingml/2006/main" prst="rect">
-            <a:avLst/>
-          </a:prstGeom>
-          <a:solidFill xmlns:a="http://schemas.openxmlformats.org/drawingml/2006/main">
-            <a:srgbClr val="FFFFFF"/>
-          </a:solidFill>
-          <a:ln xmlns:a="http://schemas.openxmlformats.org/drawingml/2006/main" w="9525">
-            <a:solidFill>
-              <a:srgbClr val="B8BCC4"/>
-            </a:solidFill>
-            <a:prstDash val="solid"/>
-          </a:ln>
-        </p:spPr>
-      </p:sp>
-      <p:sp>
-        <p:nvSpPr>
-          <p:cNvPr id="29" name="">
-            <a:extLst xmlns:a="http://schemas.openxmlformats.org/drawingml/2006/main">
-              <a:ext uri="{FF2B5EF4-FFF2-40B4-BE49-F238E27FC236}">
-                <a16:creationId xmlns:a16="http://schemas.microsoft.com/office/drawing/2014/main" id="{DCF0DAE0-EE29-487E-A2DC-EE605CB1B01C}"/>
-              </a:ext>
-            </a:extLst>
-          </p:cNvPr>
-          <p:cNvSpPr>
-            <a:spLocks xmlns:a="http://schemas.openxmlformats.org/drawingml/2006/main" noGrp="1"/>
-          </p:cNvSpPr>
-          <p:nvPr/>
-        </p:nvSpPr>
-        <p:spPr>
-          <a:xfrm xmlns:a="http://schemas.openxmlformats.org/drawingml/2006/main">
-            <a:off x="1162050" y="3638550"/>
-            <a:ext cx="3467100" cy="514350"/>
-          </a:xfrm>
-          <a:prstGeom xmlns:a="http://schemas.openxmlformats.org/drawingml/2006/main" prst="rect">
-            <a:avLst/>
-          </a:prstGeom>
-          <a:noFill xmlns:a="http://schemas.openxmlformats.org/drawingml/2006/main"/>
-          <a:ln xmlns:a="http://schemas.openxmlformats.org/drawingml/2006/main" w="0">
-            <a:noFill/>
-            <a:prstDash val="solid"/>
-          </a:ln>
-        </p:spPr>
-        <p:txBody>
-          <a:bodyPr xmlns:a="http://schemas.openxmlformats.org/drawingml/2006/main" anchor="t"/>
-          <a:lstStyle xmlns:a="http://schemas.openxmlformats.org/drawingml/2006/main"/>
-          <a:p xmlns:a="http://schemas.openxmlformats.org/drawingml/2006/main">
-            <a:pPr algn="l">
-              <a:defRPr sz="1425" b="0">
-                <a:solidFill>
-                  <a:srgbClr val="111111"/>
-                </a:solidFill>
-              </a:defRPr>
-            </a:pPr>
-            <a:r>
-              <a:rPr sz="1425" b="0">
-                <a:solidFill>
-                  <a:srgbClr val="111111"/>
-                </a:solidFill>
-              </a:rPr>
-              <a:t>Data Analyst</a:t>
-            </a:r>
-          </a:p>
-        </p:txBody>
-      </p:sp>
-      <p:sp>
-        <p:nvSpPr>
-          <p:cNvPr id="30" name="">
-            <a:extLst xmlns:a="http://schemas.openxmlformats.org/drawingml/2006/main">
-              <a:ext uri="{FF2B5EF4-FFF2-40B4-BE49-F238E27FC236}">
-                <a16:creationId xmlns:a16="http://schemas.microsoft.com/office/drawing/2014/main" id="{3204C213-690D-4B71-9D3F-81E5A9820886}"/>
-              </a:ext>
-            </a:extLst>
-          </p:cNvPr>
-          <p:cNvSpPr>
-            <a:spLocks xmlns:a="http://schemas.openxmlformats.org/drawingml/2006/main" noGrp="1"/>
-          </p:cNvSpPr>
-          <p:nvPr/>
-        </p:nvSpPr>
-        <p:spPr>
-          <a:xfrm xmlns:a="http://schemas.openxmlformats.org/drawingml/2006/main">
-            <a:off x="4705350" y="3524250"/>
-            <a:ext cx="3714750" cy="723900"/>
-          </a:xfrm>
-          <a:prstGeom xmlns:a="http://schemas.openxmlformats.org/drawingml/2006/main" prst="rect">
-            <a:avLst/>
-          </a:prstGeom>
-          <a:solidFill xmlns:a="http://schemas.openxmlformats.org/drawingml/2006/main">
-            <a:srgbClr val="FFFFFF"/>
-          </a:solidFill>
-          <a:ln xmlns:a="http://schemas.openxmlformats.org/drawingml/2006/main" w="9525">
-            <a:solidFill>
-              <a:srgbClr val="B8BCC4"/>
-            </a:solidFill>
-            <a:prstDash val="solid"/>
-          </a:ln>
-        </p:spPr>
-      </p:sp>
-      <p:sp>
-        <p:nvSpPr>
-          <p:cNvPr id="31" name="">
-            <a:extLst xmlns:a="http://schemas.openxmlformats.org/drawingml/2006/main">
-              <a:ext uri="{FF2B5EF4-FFF2-40B4-BE49-F238E27FC236}">
-                <a16:creationId xmlns:a16="http://schemas.microsoft.com/office/drawing/2014/main" id="{8A4E02A8-80BD-4887-BD71-E27640C3184F}"/>
-              </a:ext>
-            </a:extLst>
-          </p:cNvPr>
-          <p:cNvSpPr>
-            <a:spLocks xmlns:a="http://schemas.openxmlformats.org/drawingml/2006/main" noGrp="1"/>
-          </p:cNvSpPr>
-          <p:nvPr/>
-        </p:nvSpPr>
-        <p:spPr>
-          <a:xfrm xmlns:a="http://schemas.openxmlformats.org/drawingml/2006/main">
-            <a:off x="4781550" y="3638550"/>
-            <a:ext cx="3562350" cy="514350"/>
-          </a:xfrm>
-          <a:prstGeom xmlns:a="http://schemas.openxmlformats.org/drawingml/2006/main" prst="rect">
-            <a:avLst/>
-          </a:prstGeom>
-          <a:noFill xmlns:a="http://schemas.openxmlformats.org/drawingml/2006/main"/>
-          <a:ln xmlns:a="http://schemas.openxmlformats.org/drawingml/2006/main" w="0">
-            <a:noFill/>
-            <a:prstDash val="solid"/>
-          </a:ln>
-        </p:spPr>
-        <p:txBody>
-          <a:bodyPr xmlns:a="http://schemas.openxmlformats.org/drawingml/2006/main" anchor="t"/>
-          <a:lstStyle xmlns:a="http://schemas.openxmlformats.org/drawingml/2006/main"/>
-          <a:p xmlns:a="http://schemas.openxmlformats.org/drawingml/2006/main">
-            <a:pPr algn="l">
-              <a:defRPr sz="1425" b="0">
-                <a:solidFill>
-                  <a:srgbClr val="111111"/>
-                </a:solidFill>
-              </a:defRPr>
-            </a:pPr>
-            <a:r>
-              <a:rPr sz="1425" b="0">
-                <a:solidFill>
-                  <a:srgbClr val="111111"/>
-                </a:solidFill>
-              </a:rPr>
-              <a:t>HMP Global</a:t>
-            </a:r>
-          </a:p>
-          <a:p xmlns:a="http://schemas.openxmlformats.org/drawingml/2006/main">
-            <a:pPr algn="l">
-              <a:defRPr sz="1425" b="0">
-                <a:solidFill>
-                  <a:srgbClr val="111111"/>
-                </a:solidFill>
-              </a:defRPr>
-            </a:pPr>
-            <a:r>
-              <a:rPr sz="1425" b="0">
-                <a:solidFill>
-                  <a:srgbClr val="111111"/>
-                </a:solidFill>
-              </a:rPr>
-              <a:t>Anywhere</a:t>
-            </a:r>
-          </a:p>
-        </p:txBody>
-      </p:sp>
-      <p:sp>
-        <p:nvSpPr>
-          <p:cNvPr id="32" name="">
-            <a:extLst xmlns:a="http://schemas.openxmlformats.org/drawingml/2006/main">
-              <a:ext uri="{FF2B5EF4-FFF2-40B4-BE49-F238E27FC236}">
-                <a16:creationId xmlns:a16="http://schemas.microsoft.com/office/drawing/2014/main" id="{8BCF0949-E03B-456B-B6B2-33758407D7D3}"/>
-              </a:ext>
-            </a:extLst>
-          </p:cNvPr>
-          <p:cNvSpPr>
-            <a:spLocks xmlns:a="http://schemas.openxmlformats.org/drawingml/2006/main" noGrp="1"/>
-          </p:cNvSpPr>
-          <p:nvPr/>
-        </p:nvSpPr>
-        <p:spPr>
-          <a:xfrm xmlns:a="http://schemas.openxmlformats.org/drawingml/2006/main">
-            <a:off x="8420100" y="3524250"/>
-            <a:ext cx="1428750" cy="723900"/>
-          </a:xfrm>
-          <a:prstGeom xmlns:a="http://schemas.openxmlformats.org/drawingml/2006/main" prst="rect">
-            <a:avLst/>
-          </a:prstGeom>
-          <a:solidFill xmlns:a="http://schemas.openxmlformats.org/drawingml/2006/main">
-            <a:srgbClr val="FFFFFF"/>
-          </a:solidFill>
-          <a:ln xmlns:a="http://schemas.openxmlformats.org/drawingml/2006/main" w="9525">
-            <a:solidFill>
-              <a:srgbClr val="B8BCC4"/>
-            </a:solidFill>
-            <a:prstDash val="solid"/>
-          </a:ln>
-        </p:spPr>
-      </p:sp>
-      <p:sp>
-        <p:nvSpPr>
-          <p:cNvPr id="33" name="">
-            <a:extLst xmlns:a="http://schemas.openxmlformats.org/drawingml/2006/main">
-              <a:ext uri="{FF2B5EF4-FFF2-40B4-BE49-F238E27FC236}">
-                <a16:creationId xmlns:a16="http://schemas.microsoft.com/office/drawing/2014/main" id="{40C14650-505B-444A-AF44-CB4022436DCB}"/>
-              </a:ext>
-            </a:extLst>
-          </p:cNvPr>
-          <p:cNvSpPr>
-            <a:spLocks xmlns:a="http://schemas.openxmlformats.org/drawingml/2006/main" noGrp="1"/>
-          </p:cNvSpPr>
-          <p:nvPr/>
-        </p:nvSpPr>
-        <p:spPr>
-          <a:xfrm xmlns:a="http://schemas.openxmlformats.org/drawingml/2006/main">
-            <a:off x="8496300" y="3638550"/>
-            <a:ext cx="1276350" cy="514350"/>
-          </a:xfrm>
-          <a:prstGeom xmlns:a="http://schemas.openxmlformats.org/drawingml/2006/main" prst="rect">
-            <a:avLst/>
-          </a:prstGeom>
-          <a:noFill xmlns:a="http://schemas.openxmlformats.org/drawingml/2006/main"/>
-          <a:ln xmlns:a="http://schemas.openxmlformats.org/drawingml/2006/main" w="0">
-            <a:noFill/>
-            <a:prstDash val="solid"/>
-          </a:ln>
-        </p:spPr>
-        <p:txBody>
-          <a:bodyPr xmlns:a="http://schemas.openxmlformats.org/drawingml/2006/main" anchor="t"/>
-          <a:lstStyle xmlns:a="http://schemas.openxmlformats.org/drawingml/2006/main"/>
-          <a:p xmlns:a="http://schemas.openxmlformats.org/drawingml/2006/main">
-            <a:pPr algn="l">
-              <a:defRPr sz="1425" b="1">
-                <a:solidFill>
-                  <a:srgbClr val="3D8DFF"/>
-                </a:solidFill>
-              </a:defRPr>
-            </a:pPr>
-            <a:r>
-              <a:rPr sz="1425" b="1">
-                <a:solidFill>
-                  <a:srgbClr val="3D8DFF"/>
-                </a:solidFill>
-              </a:rPr>
-              <a:t>high_fit</a:t>
-            </a:r>
-          </a:p>
-        </p:txBody>
-      </p:sp>
-      <p:sp>
-        <p:nvSpPr>
-          <p:cNvPr id="34" name="">
-            <a:extLst xmlns:a="http://schemas.openxmlformats.org/drawingml/2006/main">
-              <a:ext uri="{FF2B5EF4-FFF2-40B4-BE49-F238E27FC236}">
-                <a16:creationId xmlns:a16="http://schemas.microsoft.com/office/drawing/2014/main" id="{C1A92EBF-8690-4751-9A1A-44610043BE2E}"/>
-              </a:ext>
-            </a:extLst>
-          </p:cNvPr>
-          <p:cNvSpPr>
-            <a:spLocks xmlns:a="http://schemas.openxmlformats.org/drawingml/2006/main" noGrp="1"/>
-          </p:cNvSpPr>
-          <p:nvPr/>
-        </p:nvSpPr>
-        <p:spPr>
-          <a:xfrm xmlns:a="http://schemas.openxmlformats.org/drawingml/2006/main">
-            <a:off x="9848850" y="3524250"/>
-            <a:ext cx="952500" cy="723900"/>
-          </a:xfrm>
-          <a:prstGeom xmlns:a="http://schemas.openxmlformats.org/drawingml/2006/main" prst="rect">
-            <a:avLst/>
-          </a:prstGeom>
-          <a:solidFill xmlns:a="http://schemas.openxmlformats.org/drawingml/2006/main">
-            <a:srgbClr val="FFFFFF"/>
-          </a:solidFill>
-          <a:ln xmlns:a="http://schemas.openxmlformats.org/drawingml/2006/main" w="9525">
-            <a:solidFill>
-              <a:srgbClr val="B8BCC4"/>
-            </a:solidFill>
-            <a:prstDash val="solid"/>
-          </a:ln>
-        </p:spPr>
-      </p:sp>
-      <p:sp>
-        <p:nvSpPr>
-          <p:cNvPr id="35" name="">
-            <a:extLst xmlns:a="http://schemas.openxmlformats.org/drawingml/2006/main">
-              <a:ext uri="{FF2B5EF4-FFF2-40B4-BE49-F238E27FC236}">
-                <a16:creationId xmlns:a16="http://schemas.microsoft.com/office/drawing/2014/main" id="{1A865A71-1AF6-4DEC-BC4D-4C13D4892DEA}"/>
-              </a:ext>
-            </a:extLst>
-          </p:cNvPr>
-          <p:cNvSpPr>
-            <a:spLocks xmlns:a="http://schemas.openxmlformats.org/drawingml/2006/main" noGrp="1"/>
-          </p:cNvSpPr>
-          <p:nvPr/>
-        </p:nvSpPr>
-        <p:spPr>
-          <a:xfrm xmlns:a="http://schemas.openxmlformats.org/drawingml/2006/main">
-            <a:off x="9925050" y="3638550"/>
-            <a:ext cx="800100" cy="514350"/>
-          </a:xfrm>
-          <a:prstGeom xmlns:a="http://schemas.openxmlformats.org/drawingml/2006/main" prst="rect">
-            <a:avLst/>
-          </a:prstGeom>
-          <a:noFill xmlns:a="http://schemas.openxmlformats.org/drawingml/2006/main"/>
-          <a:ln xmlns:a="http://schemas.openxmlformats.org/drawingml/2006/main" w="0">
-            <a:noFill/>
-            <a:prstDash val="solid"/>
-          </a:ln>
-        </p:spPr>
-        <p:txBody>
-          <a:bodyPr xmlns:a="http://schemas.openxmlformats.org/drawingml/2006/main" anchor="t"/>
-          <a:lstStyle xmlns:a="http://schemas.openxmlformats.org/drawingml/2006/main"/>
-          <a:p xmlns:a="http://schemas.openxmlformats.org/drawingml/2006/main">
-            <a:pPr algn="l">
-              <a:defRPr sz="1350" b="0">
-                <a:solidFill>
-                  <a:srgbClr val="111111"/>
-                </a:solidFill>
-              </a:defRPr>
-            </a:pPr>
-            <a:r>
-              <a:rPr sz="1350" b="0">
-                <a:solidFill>
-                  <a:srgbClr val="111111"/>
-                </a:solidFill>
-              </a:rPr>
-              <a:t>8.555</a:t>
-            </a:r>
-          </a:p>
-        </p:txBody>
-      </p:sp>
-      <p:sp>
-        <p:nvSpPr>
-          <p:cNvPr id="36" name="">
-            <a:extLst xmlns:a="http://schemas.openxmlformats.org/drawingml/2006/main">
-              <a:ext uri="{FF2B5EF4-FFF2-40B4-BE49-F238E27FC236}">
-                <a16:creationId xmlns:a16="http://schemas.microsoft.com/office/drawing/2014/main" id="{68AFDD15-17FA-40D8-877E-C3A8CC16BCA8}"/>
-              </a:ext>
-            </a:extLst>
-          </p:cNvPr>
-          <p:cNvSpPr>
-            <a:spLocks xmlns:a="http://schemas.openxmlformats.org/drawingml/2006/main" noGrp="1"/>
-          </p:cNvSpPr>
-          <p:nvPr/>
-        </p:nvSpPr>
-        <p:spPr>
-          <a:xfrm xmlns:a="http://schemas.openxmlformats.org/drawingml/2006/main">
-            <a:off x="419100" y="4248150"/>
-            <a:ext cx="666750" cy="723900"/>
-          </a:xfrm>
-          <a:prstGeom xmlns:a="http://schemas.openxmlformats.org/drawingml/2006/main" prst="rect">
-            <a:avLst/>
-          </a:prstGeom>
-          <a:solidFill xmlns:a="http://schemas.openxmlformats.org/drawingml/2006/main">
-            <a:srgbClr val="FFFFFF"/>
-          </a:solidFill>
-          <a:ln xmlns:a="http://schemas.openxmlformats.org/drawingml/2006/main" w="9525">
-            <a:solidFill>
-              <a:srgbClr val="B8BCC4"/>
-            </a:solidFill>
-            <a:prstDash val="solid"/>
-          </a:ln>
-        </p:spPr>
-      </p:sp>
-      <p:sp>
-        <p:nvSpPr>
-          <p:cNvPr id="37" name="">
-            <a:extLst xmlns:a="http://schemas.openxmlformats.org/drawingml/2006/main">
-              <a:ext uri="{FF2B5EF4-FFF2-40B4-BE49-F238E27FC236}">
-                <a16:creationId xmlns:a16="http://schemas.microsoft.com/office/drawing/2014/main" id="{C056DDD1-CF79-405C-9828-9F974B3DD942}"/>
-              </a:ext>
-            </a:extLst>
-          </p:cNvPr>
-          <p:cNvSpPr>
-            <a:spLocks xmlns:a="http://schemas.openxmlformats.org/drawingml/2006/main" noGrp="1"/>
-          </p:cNvSpPr>
-          <p:nvPr/>
-        </p:nvSpPr>
-        <p:spPr>
-          <a:xfrm xmlns:a="http://schemas.openxmlformats.org/drawingml/2006/main">
-            <a:off x="495300" y="4362450"/>
-            <a:ext cx="514350" cy="514350"/>
-          </a:xfrm>
-          <a:prstGeom xmlns:a="http://schemas.openxmlformats.org/drawingml/2006/main" prst="rect">
-            <a:avLst/>
-          </a:prstGeom>
-          <a:noFill xmlns:a="http://schemas.openxmlformats.org/drawingml/2006/main"/>
-          <a:ln xmlns:a="http://schemas.openxmlformats.org/drawingml/2006/main" w="0">
-            <a:noFill/>
-            <a:prstDash val="solid"/>
-          </a:ln>
-        </p:spPr>
-        <p:txBody>
-          <a:bodyPr xmlns:a="http://schemas.openxmlformats.org/drawingml/2006/main" anchor="t"/>
-          <a:lstStyle xmlns:a="http://schemas.openxmlformats.org/drawingml/2006/main"/>
-          <a:p xmlns:a="http://schemas.openxmlformats.org/drawingml/2006/main">
-            <a:pPr algn="l">
-              <a:defRPr sz="1350" b="0">
-                <a:solidFill>
-                  <a:srgbClr val="111111"/>
-                </a:solidFill>
-              </a:defRPr>
-            </a:pPr>
-            <a:r>
-              <a:rPr sz="1350" b="0">
-                <a:solidFill>
-                  <a:srgbClr val="111111"/>
-                </a:solidFill>
-              </a:rPr>
-              <a:t>3</a:t>
-            </a:r>
-          </a:p>
-        </p:txBody>
-      </p:sp>
-      <p:sp>
-        <p:nvSpPr>
-          <p:cNvPr id="38" name="">
-            <a:extLst xmlns:a="http://schemas.openxmlformats.org/drawingml/2006/main">
-              <a:ext uri="{FF2B5EF4-FFF2-40B4-BE49-F238E27FC236}">
-                <a16:creationId xmlns:a16="http://schemas.microsoft.com/office/drawing/2014/main" id="{25D5E133-19D8-463D-870F-F43AB8181283}"/>
-              </a:ext>
-            </a:extLst>
-          </p:cNvPr>
-          <p:cNvSpPr>
-            <a:spLocks xmlns:a="http://schemas.openxmlformats.org/drawingml/2006/main" noGrp="1"/>
-          </p:cNvSpPr>
-          <p:nvPr/>
-        </p:nvSpPr>
-        <p:spPr>
-          <a:xfrm xmlns:a="http://schemas.openxmlformats.org/drawingml/2006/main">
-            <a:off x="1085850" y="4248150"/>
-            <a:ext cx="3619500" cy="723900"/>
-          </a:xfrm>
-          <a:prstGeom xmlns:a="http://schemas.openxmlformats.org/drawingml/2006/main" prst="rect">
-            <a:avLst/>
-          </a:prstGeom>
-          <a:solidFill xmlns:a="http://schemas.openxmlformats.org/drawingml/2006/main">
-            <a:srgbClr val="FFFFFF"/>
-          </a:solidFill>
-          <a:ln xmlns:a="http://schemas.openxmlformats.org/drawingml/2006/main" w="9525">
-            <a:solidFill>
-              <a:srgbClr val="B8BCC4"/>
-            </a:solidFill>
-            <a:prstDash val="solid"/>
-          </a:ln>
-        </p:spPr>
-      </p:sp>
-      <p:sp>
-        <p:nvSpPr>
-          <p:cNvPr id="39" name="">
-            <a:extLst xmlns:a="http://schemas.openxmlformats.org/drawingml/2006/main">
-              <a:ext uri="{FF2B5EF4-FFF2-40B4-BE49-F238E27FC236}">
-                <a16:creationId xmlns:a16="http://schemas.microsoft.com/office/drawing/2014/main" id="{141F444B-A218-47AA-923D-759C8BC9041F}"/>
-              </a:ext>
-            </a:extLst>
-          </p:cNvPr>
-          <p:cNvSpPr>
-            <a:spLocks xmlns:a="http://schemas.openxmlformats.org/drawingml/2006/main" noGrp="1"/>
-          </p:cNvSpPr>
-          <p:nvPr/>
-        </p:nvSpPr>
-        <p:spPr>
-          <a:xfrm xmlns:a="http://schemas.openxmlformats.org/drawingml/2006/main">
-            <a:off x="1162050" y="4362450"/>
-            <a:ext cx="3467100" cy="514350"/>
-          </a:xfrm>
-          <a:prstGeom xmlns:a="http://schemas.openxmlformats.org/drawingml/2006/main" prst="rect">
-            <a:avLst/>
-          </a:prstGeom>
-          <a:noFill xmlns:a="http://schemas.openxmlformats.org/drawingml/2006/main"/>
-          <a:ln xmlns:a="http://schemas.openxmlformats.org/drawingml/2006/main" w="0">
-            <a:noFill/>
-            <a:prstDash val="solid"/>
-          </a:ln>
-        </p:spPr>
-        <p:txBody>
-          <a:bodyPr xmlns:a="http://schemas.openxmlformats.org/drawingml/2006/main" anchor="t"/>
-          <a:lstStyle xmlns:a="http://schemas.openxmlformats.org/drawingml/2006/main"/>
-          <a:p xmlns:a="http://schemas.openxmlformats.org/drawingml/2006/main">
-            <a:pPr algn="l">
-              <a:defRPr sz="1425" b="0">
-                <a:solidFill>
-                  <a:srgbClr val="111111"/>
-                </a:solidFill>
-              </a:defRPr>
-            </a:pPr>
-            <a:r>
-              <a:rPr sz="1425" b="0">
-                <a:solidFill>
-                  <a:srgbClr val="111111"/>
-                </a:solidFill>
-              </a:rPr>
-              <a:t>Data Analyst (US REMOTE)</a:t>
-            </a:r>
-          </a:p>
-        </p:txBody>
-      </p:sp>
-      <p:sp>
-        <p:nvSpPr>
-          <p:cNvPr id="40" name="">
-            <a:extLst xmlns:a="http://schemas.openxmlformats.org/drawingml/2006/main">
-              <a:ext uri="{FF2B5EF4-FFF2-40B4-BE49-F238E27FC236}">
-                <a16:creationId xmlns:a16="http://schemas.microsoft.com/office/drawing/2014/main" id="{4AFA6669-70B3-48E1-BCC6-58F8E2AE0F50}"/>
-              </a:ext>
-            </a:extLst>
-          </p:cNvPr>
-          <p:cNvSpPr>
-            <a:spLocks xmlns:a="http://schemas.openxmlformats.org/drawingml/2006/main" noGrp="1"/>
-          </p:cNvSpPr>
-          <p:nvPr/>
-        </p:nvSpPr>
-        <p:spPr>
-          <a:xfrm xmlns:a="http://schemas.openxmlformats.org/drawingml/2006/main">
-            <a:off x="4705350" y="4248150"/>
-            <a:ext cx="3714750" cy="723900"/>
-          </a:xfrm>
-          <a:prstGeom xmlns:a="http://schemas.openxmlformats.org/drawingml/2006/main" prst="rect">
-            <a:avLst/>
-          </a:prstGeom>
-          <a:solidFill xmlns:a="http://schemas.openxmlformats.org/drawingml/2006/main">
-            <a:srgbClr val="FFFFFF"/>
-          </a:solidFill>
-          <a:ln xmlns:a="http://schemas.openxmlformats.org/drawingml/2006/main" w="9525">
-            <a:solidFill>
-              <a:srgbClr val="B8BCC4"/>
-            </a:solidFill>
-            <a:prstDash val="solid"/>
-          </a:ln>
-        </p:spPr>
-      </p:sp>
-      <p:sp>
-        <p:nvSpPr>
-          <p:cNvPr id="41" name="">
-            <a:extLst xmlns:a="http://schemas.openxmlformats.org/drawingml/2006/main">
-              <a:ext uri="{FF2B5EF4-FFF2-40B4-BE49-F238E27FC236}">
-                <a16:creationId xmlns:a16="http://schemas.microsoft.com/office/drawing/2014/main" id="{FBE31BED-660A-4987-ACCC-96906DEC71FF}"/>
-              </a:ext>
-            </a:extLst>
-          </p:cNvPr>
-          <p:cNvSpPr>
-            <a:spLocks xmlns:a="http://schemas.openxmlformats.org/drawingml/2006/main" noGrp="1"/>
-          </p:cNvSpPr>
-          <p:nvPr/>
-        </p:nvSpPr>
-        <p:spPr>
-          <a:xfrm xmlns:a="http://schemas.openxmlformats.org/drawingml/2006/main">
-            <a:off x="4781550" y="4362450"/>
-            <a:ext cx="3562350" cy="514350"/>
-          </a:xfrm>
-          <a:prstGeom xmlns:a="http://schemas.openxmlformats.org/drawingml/2006/main" prst="rect">
-            <a:avLst/>
-          </a:prstGeom>
-          <a:noFill xmlns:a="http://schemas.openxmlformats.org/drawingml/2006/main"/>
-          <a:ln xmlns:a="http://schemas.openxmlformats.org/drawingml/2006/main" w="0">
-            <a:noFill/>
-            <a:prstDash val="solid"/>
-          </a:ln>
-        </p:spPr>
-        <p:txBody>
-          <a:bodyPr xmlns:a="http://schemas.openxmlformats.org/drawingml/2006/main" anchor="t"/>
-          <a:lstStyle xmlns:a="http://schemas.openxmlformats.org/drawingml/2006/main"/>
-          <a:p xmlns:a="http://schemas.openxmlformats.org/drawingml/2006/main">
-            <a:pPr algn="l">
-              <a:defRPr sz="1425" b="0">
-                <a:solidFill>
-                  <a:srgbClr val="111111"/>
-                </a:solidFill>
-              </a:defRPr>
-            </a:pPr>
-            <a:r>
-              <a:rPr sz="1425" b="0">
-                <a:solidFill>
-                  <a:srgbClr val="111111"/>
-                </a:solidFill>
-              </a:rPr>
-              <a:t>LeanTaaS</a:t>
-            </a:r>
-          </a:p>
-          <a:p xmlns:a="http://schemas.openxmlformats.org/drawingml/2006/main">
-            <a:pPr algn="l">
-              <a:defRPr sz="1425" b="0">
-                <a:solidFill>
-                  <a:srgbClr val="111111"/>
-                </a:solidFill>
-              </a:defRPr>
-            </a:pPr>
-            <a:r>
-              <a:rPr sz="1425" b="0">
-                <a:solidFill>
-                  <a:srgbClr val="111111"/>
-                </a:solidFill>
-              </a:rPr>
-              <a:t>Anywhere</a:t>
-            </a:r>
-          </a:p>
-        </p:txBody>
-      </p:sp>
-      <p:sp>
-        <p:nvSpPr>
-          <p:cNvPr id="42" name="">
-            <a:extLst xmlns:a="http://schemas.openxmlformats.org/drawingml/2006/main">
-              <a:ext uri="{FF2B5EF4-FFF2-40B4-BE49-F238E27FC236}">
-                <a16:creationId xmlns:a16="http://schemas.microsoft.com/office/drawing/2014/main" id="{10D98F03-A5B0-4667-BA96-43A8FE9A31C3}"/>
-              </a:ext>
-            </a:extLst>
-          </p:cNvPr>
-          <p:cNvSpPr>
-            <a:spLocks xmlns:a="http://schemas.openxmlformats.org/drawingml/2006/main" noGrp="1"/>
-          </p:cNvSpPr>
-          <p:nvPr/>
-        </p:nvSpPr>
-        <p:spPr>
-          <a:xfrm xmlns:a="http://schemas.openxmlformats.org/drawingml/2006/main">
-            <a:off x="8420100" y="4248150"/>
-            <a:ext cx="1428750" cy="723900"/>
-          </a:xfrm>
-          <a:prstGeom xmlns:a="http://schemas.openxmlformats.org/drawingml/2006/main" prst="rect">
-            <a:avLst/>
-          </a:prstGeom>
-          <a:solidFill xmlns:a="http://schemas.openxmlformats.org/drawingml/2006/main">
-            <a:srgbClr val="FFFFFF"/>
-          </a:solidFill>
-          <a:ln xmlns:a="http://schemas.openxmlformats.org/drawingml/2006/main" w="9525">
-            <a:solidFill>
-              <a:srgbClr val="B8BCC4"/>
-            </a:solidFill>
-            <a:prstDash val="solid"/>
-          </a:ln>
-        </p:spPr>
-      </p:sp>
-      <p:sp>
-        <p:nvSpPr>
-          <p:cNvPr id="43" name="">
-            <a:extLst xmlns:a="http://schemas.openxmlformats.org/drawingml/2006/main">
-              <a:ext uri="{FF2B5EF4-FFF2-40B4-BE49-F238E27FC236}">
-                <a16:creationId xmlns:a16="http://schemas.microsoft.com/office/drawing/2014/main" id="{4D252523-184C-4E9B-B094-1A2800D5C6F4}"/>
-              </a:ext>
-            </a:extLst>
-          </p:cNvPr>
-          <p:cNvSpPr>
-            <a:spLocks xmlns:a="http://schemas.openxmlformats.org/drawingml/2006/main" noGrp="1"/>
-          </p:cNvSpPr>
-          <p:nvPr/>
-        </p:nvSpPr>
-        <p:spPr>
-          <a:xfrm xmlns:a="http://schemas.openxmlformats.org/drawingml/2006/main">
-            <a:off x="8496300" y="4362450"/>
-            <a:ext cx="1276350" cy="514350"/>
-          </a:xfrm>
-          <a:prstGeom xmlns:a="http://schemas.openxmlformats.org/drawingml/2006/main" prst="rect">
-            <a:avLst/>
-          </a:prstGeom>
-          <a:noFill xmlns:a="http://schemas.openxmlformats.org/drawingml/2006/main"/>
-          <a:ln xmlns:a="http://schemas.openxmlformats.org/drawingml/2006/main" w="0">
-            <a:noFill/>
-            <a:prstDash val="solid"/>
-          </a:ln>
-        </p:spPr>
-        <p:txBody>
-          <a:bodyPr xmlns:a="http://schemas.openxmlformats.org/drawingml/2006/main" anchor="t"/>
-          <a:lstStyle xmlns:a="http://schemas.openxmlformats.org/drawingml/2006/main"/>
-          <a:p xmlns:a="http://schemas.openxmlformats.org/drawingml/2006/main">
-            <a:pPr algn="l">
-              <a:defRPr sz="1425" b="1">
-                <a:solidFill>
-                  <a:srgbClr val="3D8DFF"/>
-                </a:solidFill>
-              </a:defRPr>
-            </a:pPr>
-            <a:r>
-              <a:rPr sz="1425" b="1">
-                <a:solidFill>
-                  <a:srgbClr val="3D8DFF"/>
-                </a:solidFill>
-              </a:rPr>
-              <a:t>high_fit</a:t>
-            </a:r>
-          </a:p>
-        </p:txBody>
-      </p:sp>
-      <p:sp>
-        <p:nvSpPr>
-          <p:cNvPr id="44" name="">
-            <a:extLst xmlns:a="http://schemas.openxmlformats.org/drawingml/2006/main">
-              <a:ext uri="{FF2B5EF4-FFF2-40B4-BE49-F238E27FC236}">
-                <a16:creationId xmlns:a16="http://schemas.microsoft.com/office/drawing/2014/main" id="{09624099-D56E-4B2A-8761-32A0C734F124}"/>
-              </a:ext>
-            </a:extLst>
-          </p:cNvPr>
-          <p:cNvSpPr>
-            <a:spLocks xmlns:a="http://schemas.openxmlformats.org/drawingml/2006/main" noGrp="1"/>
-          </p:cNvSpPr>
-          <p:nvPr/>
-        </p:nvSpPr>
-        <p:spPr>
-          <a:xfrm xmlns:a="http://schemas.openxmlformats.org/drawingml/2006/main">
-            <a:off x="9848850" y="4248150"/>
-            <a:ext cx="952500" cy="723900"/>
-          </a:xfrm>
-          <a:prstGeom xmlns:a="http://schemas.openxmlformats.org/drawingml/2006/main" prst="rect">
-            <a:avLst/>
-          </a:prstGeom>
-          <a:solidFill xmlns:a="http://schemas.openxmlformats.org/drawingml/2006/main">
-            <a:srgbClr val="FFFFFF"/>
-          </a:solidFill>
-          <a:ln xmlns:a="http://schemas.openxmlformats.org/drawingml/2006/main" w="9525">
-            <a:solidFill>
-              <a:srgbClr val="B8BCC4"/>
-            </a:solidFill>
-            <a:prstDash val="solid"/>
-          </a:ln>
-        </p:spPr>
-      </p:sp>
-      <p:sp>
-        <p:nvSpPr>
-          <p:cNvPr id="45" name="">
-            <a:extLst xmlns:a="http://schemas.openxmlformats.org/drawingml/2006/main">
-              <a:ext uri="{FF2B5EF4-FFF2-40B4-BE49-F238E27FC236}">
-                <a16:creationId xmlns:a16="http://schemas.microsoft.com/office/drawing/2014/main" id="{80CF33AD-EC44-42CB-B10F-164AB13FE586}"/>
-              </a:ext>
-            </a:extLst>
-          </p:cNvPr>
-          <p:cNvSpPr>
-            <a:spLocks xmlns:a="http://schemas.openxmlformats.org/drawingml/2006/main" noGrp="1"/>
-          </p:cNvSpPr>
-          <p:nvPr/>
-        </p:nvSpPr>
-        <p:spPr>
-          <a:xfrm xmlns:a="http://schemas.openxmlformats.org/drawingml/2006/main">
-            <a:off x="9925050" y="4362450"/>
-            <a:ext cx="800100" cy="514350"/>
-          </a:xfrm>
-          <a:prstGeom xmlns:a="http://schemas.openxmlformats.org/drawingml/2006/main" prst="rect">
-            <a:avLst/>
-          </a:prstGeom>
-          <a:noFill xmlns:a="http://schemas.openxmlformats.org/drawingml/2006/main"/>
-          <a:ln xmlns:a="http://schemas.openxmlformats.org/drawingml/2006/main" w="0">
-            <a:noFill/>
-            <a:prstDash val="solid"/>
-          </a:ln>
-        </p:spPr>
-        <p:txBody>
-          <a:bodyPr xmlns:a="http://schemas.openxmlformats.org/drawingml/2006/main" anchor="t"/>
-          <a:lstStyle xmlns:a="http://schemas.openxmlformats.org/drawingml/2006/main"/>
-          <a:p xmlns:a="http://schemas.openxmlformats.org/drawingml/2006/main">
-            <a:pPr algn="l">
-              <a:defRPr sz="1350" b="0">
-                <a:solidFill>
-                  <a:srgbClr val="111111"/>
-                </a:solidFill>
-              </a:defRPr>
-            </a:pPr>
-            <a:r>
-              <a:rPr sz="1350" b="0">
-                <a:solidFill>
-                  <a:srgbClr val="111111"/>
-                </a:solidFill>
-              </a:rPr>
-              <a:t>8.458</a:t>
-            </a:r>
-          </a:p>
-        </p:txBody>
-      </p:sp>
-      <p:sp>
-        <p:nvSpPr>
-          <p:cNvPr id="46" name="">
-            <a:extLst xmlns:a="http://schemas.openxmlformats.org/drawingml/2006/main">
-              <a:ext uri="{FF2B5EF4-FFF2-40B4-BE49-F238E27FC236}">
-                <a16:creationId xmlns:a16="http://schemas.microsoft.com/office/drawing/2014/main" id="{D49AC2B1-8A03-4856-93F9-53C595CC3A83}"/>
-              </a:ext>
-            </a:extLst>
-          </p:cNvPr>
-          <p:cNvSpPr>
-            <a:spLocks xmlns:a="http://schemas.openxmlformats.org/drawingml/2006/main" noGrp="1"/>
-          </p:cNvSpPr>
-          <p:nvPr/>
-        </p:nvSpPr>
-        <p:spPr>
-          <a:xfrm xmlns:a="http://schemas.openxmlformats.org/drawingml/2006/main">
-            <a:off x="419100" y="5219700"/>
-            <a:ext cx="10287000" cy="400050"/>
-          </a:xfrm>
-          <a:prstGeom xmlns:a="http://schemas.openxmlformats.org/drawingml/2006/main" prst="rect">
-            <a:avLst/>
-          </a:prstGeom>
-          <a:noFill xmlns:a="http://schemas.openxmlformats.org/drawingml/2006/main"/>
-          <a:ln xmlns:a="http://schemas.openxmlformats.org/drawingml/2006/main" w="0">
-            <a:noFill/>
-            <a:prstDash val="solid"/>
-          </a:ln>
-        </p:spPr>
-        <p:txBody>
-          <a:bodyPr xmlns:a="http://schemas.openxmlformats.org/drawingml/2006/main" anchor="t"/>
-          <a:lstStyle xmlns:a="http://schemas.openxmlformats.org/drawingml/2006/main"/>
-          <a:p xmlns:a="http://schemas.openxmlformats.org/drawingml/2006/main">
-            <a:pPr algn="l">
-              <a:defRPr sz="1875" b="1">
-                <a:solidFill>
-                  <a:srgbClr val="111111"/>
-                </a:solidFill>
-              </a:defRPr>
-            </a:pPr>
-            <a:r>
-              <a:rPr sz="1875" b="1">
-                <a:solidFill>
-                  <a:srgbClr val="111111"/>
-                </a:solidFill>
-              </a:rPr>
-              <a:t>Review six retrieved postings; the top five satisfy the US constraint.</a:t>
-            </a:r>
-          </a:p>
-        </p:txBody>
-      </p:sp>
-      <p:sp>
-        <p:nvSpPr>
-          <p:cNvPr id="47" name="">
-            <a:extLst xmlns:a="http://schemas.openxmlformats.org/drawingml/2006/main">
-              <a:ext uri="{FF2B5EF4-FFF2-40B4-BE49-F238E27FC236}">
-                <a16:creationId xmlns:a16="http://schemas.microsoft.com/office/drawing/2014/main" id="{A594B8D0-2022-4BDA-B9C1-81A57619922E}"/>
-              </a:ext>
-            </a:extLst>
-          </p:cNvPr>
-          <p:cNvSpPr>
-            <a:spLocks xmlns:a="http://schemas.openxmlformats.org/drawingml/2006/main" noGrp="1"/>
-          </p:cNvSpPr>
-          <p:nvPr/>
-        </p:nvSpPr>
-        <p:spPr>
-          <a:xfrm xmlns:a="http://schemas.openxmlformats.org/drawingml/2006/main">
-            <a:off x="419100" y="5734050"/>
-            <a:ext cx="10287000" cy="285750"/>
-          </a:xfrm>
-          <a:prstGeom xmlns:a="http://schemas.openxmlformats.org/drawingml/2006/main" prst="rect">
-            <a:avLst/>
-          </a:prstGeom>
-          <a:noFill xmlns:a="http://schemas.openxmlformats.org/drawingml/2006/main"/>
-          <a:ln xmlns:a="http://schemas.openxmlformats.org/drawingml/2006/main" w="0">
-            <a:noFill/>
-            <a:prstDash val="solid"/>
-          </a:ln>
-        </p:spPr>
-        <p:txBody>
-          <a:bodyPr xmlns:a="http://schemas.openxmlformats.org/drawingml/2006/main" anchor="t"/>
-          <a:lstStyle xmlns:a="http://schemas.openxmlformats.org/drawingml/2006/main"/>
-          <a:p xmlns:a="http://schemas.openxmlformats.org/drawingml/2006/main">
-            <a:pPr algn="l">
-              <a:defRPr sz="1500" b="0">
-                <a:solidFill>
-                  <a:srgbClr val="D6532F"/>
-                </a:solidFill>
-              </a:defRPr>
-            </a:pPr>
-            <a:r>
-              <a:rPr sz="1500" b="0">
-                <a:solidFill>
-                  <a:srgbClr val="D6532F"/>
-                </a:solidFill>
-              </a:rPr>
-              <a:t>Authorization: verify separately unless explicit source text is present.</a:t>
-            </a:r>
-          </a:p>
-        </p:txBody>
-      </p:sp>
+      <p:pic>
+        <p:nvPicPr>
+          <p:cNvPr id="53" name=""/>
+          <p:cNvPicPr>
+            <a:picLocks xmlns:a="http://schemas.openxmlformats.org/drawingml/2006/main" noChangeAspect="1"/>
+          </p:cNvPicPr>
+          <p:nvPr/>
+        </p:nvPicPr>
+        <p:blipFill>
+          <a:blip xmlns:r="http://schemas.openxmlformats.org/officeDocument/2006/relationships" xmlns:a="http://schemas.openxmlformats.org/drawingml/2006/main" r:embed="Ra8eb26cb17de460d"/>
+          <a:srcRect xmlns:a="http://schemas.openxmlformats.org/drawingml/2006/main" l="0" t="13772" r="0" b="13772"/>
+          <a:stretch xmlns:a="http://schemas.openxmlformats.org/drawingml/2006/main">
+            <a:fillRect l="0" t="0" r="0" b="0"/>
+          </a:stretch>
+        </p:blipFill>
+        <p:spPr>
+          <a:xfrm xmlns:a="http://schemas.openxmlformats.org/drawingml/2006/main">
+            <a:off x="419100" y="1285875"/>
+            <a:ext cx="11334750" cy="4619625"/>
+          </a:xfrm>
+          <a:prstGeom xmlns:a="http://schemas.openxmlformats.org/drawingml/2006/main" prst="roundRect">
+            <a:avLst>
+              <a:gd name="adj" fmla="val 1649"/>
+            </a:avLst>
+          </a:prstGeom>
+        </p:spPr>
+      </p:pic>
     </p:spTree>
     <p:extLst>
       <p:ext uri="{BB962C8B-B14F-4D97-AF65-F5344CB8AC3E}">
@@ -8644,23 +6695,24 @@
         </p:nvSpPr>
         <p:spPr>
           <a:xfrm xmlns:a="http://schemas.openxmlformats.org/drawingml/2006/main">
-            <a:off x="400050" y="323850"/>
-            <a:ext cx="11096625" cy="685800"/>
-          </a:xfrm>
-          <a:prstGeom xmlns:a="http://schemas.openxmlformats.org/drawingml/2006/main" prst="rect">
-            <a:avLst/>
-          </a:prstGeom>
-          <a:noFill xmlns:a="http://schemas.openxmlformats.org/drawingml/2006/main"/>
-          <a:ln xmlns:a="http://schemas.openxmlformats.org/drawingml/2006/main" w="0">
-            <a:noFill/>
-            <a:prstDash val="solid"/>
-          </a:ln>
-        </p:spPr>
-        <p:txBody>
-          <a:bodyPr xmlns:a="http://schemas.openxmlformats.org/drawingml/2006/main" anchor="t"/>
-          <a:lstStyle xmlns:a="http://schemas.openxmlformats.org/drawingml/2006/main"/>
-          <a:p xmlns:a="http://schemas.openxmlformats.org/drawingml/2006/main">
-            <a:pPr algn="l">
+            <a:off x="495300" y="428625"/>
+            <a:ext cx="11049000" cy="552450"/>
+          </a:xfrm>
+          <a:prstGeom xmlns:a="http://schemas.openxmlformats.org/drawingml/2006/main" prst="rect">
+            <a:avLst/>
+          </a:prstGeom>
+          <a:noFill xmlns:a="http://schemas.openxmlformats.org/drawingml/2006/main"/>
+          <a:ln xmlns:a="http://schemas.openxmlformats.org/drawingml/2006/main" w="0">
+            <a:noFill/>
+            <a:prstDash val="solid"/>
+          </a:ln>
+        </p:spPr>
+        <p:txBody>
+          <a:bodyPr xmlns:a="http://schemas.openxmlformats.org/drawingml/2006/main" anchor="t"/>
+          <a:lstStyle xmlns:a="http://schemas.openxmlformats.org/drawingml/2006/main"/>
+          <a:p xmlns:a="http://schemas.openxmlformats.org/drawingml/2006/main">
+            <a:pPr algn="l">
+              <a:buNone/>
               <a:defRPr sz="3600" b="1">
                 <a:solidFill>
                   <a:srgbClr val="111111"/>
@@ -8673,7 +6725,7 @@
                   <a:srgbClr val="111111"/>
                 </a:solidFill>
               </a:rPr>
-              <a:t>Edge cases change the action, not the safety boundary</a:t>
+              <a:t>High role fit never overrides an explicit restriction</a:t>
             </a:r>
           </a:p>
         </p:txBody>
@@ -8711,6 +6763,7 @@
           <a:lstStyle xmlns:a="http://schemas.openxmlformats.org/drawingml/2006/main"/>
           <a:p xmlns:a="http://schemas.openxmlformats.org/drawingml/2006/main">
             <a:pPr algn="r">
+              <a:buNone/>
               <a:defRPr sz="1200" b="0">
                 <a:solidFill>
                   <a:srgbClr val="565D67"/>
@@ -8728,694 +6781,84 @@
           </a:p>
         </p:txBody>
       </p:sp>
-      <p:cxnSp>
-        <p:nvCxnSpPr>
-          <p:cNvPr id="21" name=""/>
-          <p:cNvCxnSpPr/>
-          <p:nvPr/>
-        </p:nvCxnSpPr>
-        <p:spPr>
-          <a:xfrm xmlns:a="http://schemas.openxmlformats.org/drawingml/2006/main">
-            <a:off x="419100" y="1790700"/>
-            <a:ext cx="5143500" cy="0"/>
-          </a:xfrm>
-          <a:prstGeom xmlns:a="http://schemas.openxmlformats.org/drawingml/2006/main" prst="straightConnector1">
-            <a:avLst/>
-          </a:prstGeom>
-          <a:ln xmlns:a="http://schemas.openxmlformats.org/drawingml/2006/main" w="38100">
-            <a:solidFill>
-              <a:srgbClr val="3D8DFF"/>
-            </a:solidFill>
-            <a:prstDash val="solid"/>
-          </a:ln>
-        </p:spPr>
-      </p:cxnSp>
-      <p:sp>
-        <p:nvSpPr>
-          <p:cNvPr id="4" name="">
-            <a:extLst xmlns:a="http://schemas.openxmlformats.org/drawingml/2006/main">
-              <a:ext uri="{FF2B5EF4-FFF2-40B4-BE49-F238E27FC236}">
-                <a16:creationId xmlns:a16="http://schemas.microsoft.com/office/drawing/2014/main" id="{C886FC69-1F6F-43A6-B31F-23261E82CEF5}"/>
-              </a:ext>
-            </a:extLst>
-          </p:cNvPr>
-          <p:cNvSpPr>
-            <a:spLocks xmlns:a="http://schemas.openxmlformats.org/drawingml/2006/main" noGrp="1"/>
-          </p:cNvSpPr>
-          <p:nvPr/>
-        </p:nvSpPr>
-        <p:spPr>
-          <a:xfrm xmlns:a="http://schemas.openxmlformats.org/drawingml/2006/main">
-            <a:off x="419100" y="2019300"/>
-            <a:ext cx="5143500" cy="323850"/>
-          </a:xfrm>
-          <a:prstGeom xmlns:a="http://schemas.openxmlformats.org/drawingml/2006/main" prst="rect">
-            <a:avLst/>
-          </a:prstGeom>
-          <a:noFill xmlns:a="http://schemas.openxmlformats.org/drawingml/2006/main"/>
-          <a:ln xmlns:a="http://schemas.openxmlformats.org/drawingml/2006/main" w="0">
-            <a:noFill/>
-            <a:prstDash val="solid"/>
-          </a:ln>
-        </p:spPr>
-        <p:txBody>
-          <a:bodyPr xmlns:a="http://schemas.openxmlformats.org/drawingml/2006/main" anchor="t"/>
-          <a:lstStyle xmlns:a="http://schemas.openxmlformats.org/drawingml/2006/main"/>
-          <a:p xmlns:a="http://schemas.openxmlformats.org/drawingml/2006/main">
-            <a:pPr algn="l">
+      <p:sp>
+        <p:nvSpPr>
+          <p:cNvPr id="6" name="">
+            <a:extLst xmlns:a="http://schemas.openxmlformats.org/drawingml/2006/main">
+              <a:ext uri="{FF2B5EF4-FFF2-40B4-BE49-F238E27FC236}">
+                <a16:creationId xmlns:a16="http://schemas.microsoft.com/office/drawing/2014/main" id="{82285E05-5D02-43F5-BAA1-BA3237D03B50}"/>
+              </a:ext>
+            </a:extLst>
+          </p:cNvPr>
+          <p:cNvSpPr>
+            <a:spLocks xmlns:a="http://schemas.openxmlformats.org/drawingml/2006/main" noGrp="1"/>
+          </p:cNvSpPr>
+          <p:nvPr/>
+        </p:nvSpPr>
+        <p:spPr>
+          <a:xfrm xmlns:a="http://schemas.openxmlformats.org/drawingml/2006/main">
+            <a:off x="514350" y="6115050"/>
+            <a:ext cx="10477500" cy="342900"/>
+          </a:xfrm>
+          <a:prstGeom xmlns:a="http://schemas.openxmlformats.org/drawingml/2006/main" prst="rect">
+            <a:avLst/>
+          </a:prstGeom>
+          <a:noFill xmlns:a="http://schemas.openxmlformats.org/drawingml/2006/main"/>
+          <a:ln xmlns:a="http://schemas.openxmlformats.org/drawingml/2006/main" w="0">
+            <a:noFill/>
+            <a:prstDash val="solid"/>
+          </a:ln>
+        </p:spPr>
+        <p:txBody>
+          <a:bodyPr xmlns:a="http://schemas.openxmlformats.org/drawingml/2006/main" anchor="t"/>
+          <a:lstStyle xmlns:a="http://schemas.openxmlformats.org/drawingml/2006/main"/>
+          <a:p xmlns:a="http://schemas.openxmlformats.org/drawingml/2006/main">
+            <a:pPr algn="l">
+              <a:buNone/>
               <a:defRPr sz="1650" b="1">
                 <a:solidFill>
-                  <a:srgbClr val="565D67"/>
+                  <a:srgbClr val="111111"/>
                 </a:solidFill>
               </a:defRPr>
             </a:pPr>
             <a:r>
               <a:rPr sz="1650" b="1">
                 <a:solidFill>
-                  <a:srgbClr val="565D67"/>
-                </a:solidFill>
-              </a:rPr>
-              <a:t>ENTRY LEVEL ANALYTICS SEARCH</a:t>
-            </a:r>
-          </a:p>
-        </p:txBody>
-      </p:sp>
-      <p:sp>
-        <p:nvSpPr>
-          <p:cNvPr id="5" name="">
-            <a:extLst xmlns:a="http://schemas.openxmlformats.org/drawingml/2006/main">
-              <a:ext uri="{FF2B5EF4-FFF2-40B4-BE49-F238E27FC236}">
-                <a16:creationId xmlns:a16="http://schemas.microsoft.com/office/drawing/2014/main" id="{A9BFF07E-9A81-454F-B4A6-2EEA78164C9F}"/>
-              </a:ext>
-            </a:extLst>
-          </p:cNvPr>
-          <p:cNvSpPr>
-            <a:spLocks xmlns:a="http://schemas.openxmlformats.org/drawingml/2006/main" noGrp="1"/>
-          </p:cNvSpPr>
-          <p:nvPr/>
-        </p:nvSpPr>
-        <p:spPr>
-          <a:xfrm xmlns:a="http://schemas.openxmlformats.org/drawingml/2006/main">
-            <a:off x="419100" y="2514600"/>
-            <a:ext cx="1809750" cy="400050"/>
-          </a:xfrm>
-          <a:prstGeom xmlns:a="http://schemas.openxmlformats.org/drawingml/2006/main" prst="rect">
-            <a:avLst/>
-          </a:prstGeom>
-          <a:noFill xmlns:a="http://schemas.openxmlformats.org/drawingml/2006/main"/>
-          <a:ln xmlns:a="http://schemas.openxmlformats.org/drawingml/2006/main" w="0">
-            <a:noFill/>
-            <a:prstDash val="solid"/>
-          </a:ln>
-        </p:spPr>
-        <p:txBody>
-          <a:bodyPr xmlns:a="http://schemas.openxmlformats.org/drawingml/2006/main" anchor="t"/>
-          <a:lstStyle xmlns:a="http://schemas.openxmlformats.org/drawingml/2006/main"/>
-          <a:p xmlns:a="http://schemas.openxmlformats.org/drawingml/2006/main">
-            <a:pPr algn="l">
-              <a:defRPr sz="2325" b="1">
-                <a:solidFill>
-                  <a:srgbClr val="3D8DFF"/>
-                </a:solidFill>
-              </a:defRPr>
-            </a:pPr>
-            <a:r>
-              <a:rPr sz="2325" b="1">
-                <a:solidFill>
-                  <a:srgbClr val="3D8DFF"/>
-                </a:solidFill>
-              </a:rPr>
-              <a:t>search results</a:t>
-            </a:r>
-          </a:p>
-        </p:txBody>
-      </p:sp>
-      <p:sp>
-        <p:nvSpPr>
-          <p:cNvPr id="6" name="">
-            <a:extLst xmlns:a="http://schemas.openxmlformats.org/drawingml/2006/main">
-              <a:ext uri="{FF2B5EF4-FFF2-40B4-BE49-F238E27FC236}">
-                <a16:creationId xmlns:a16="http://schemas.microsoft.com/office/drawing/2014/main" id="{82285E05-5D02-43F5-BAA1-BA3237D03B50}"/>
-              </a:ext>
-            </a:extLst>
-          </p:cNvPr>
-          <p:cNvSpPr>
-            <a:spLocks xmlns:a="http://schemas.openxmlformats.org/drawingml/2006/main" noGrp="1"/>
-          </p:cNvSpPr>
-          <p:nvPr/>
-        </p:nvSpPr>
-        <p:spPr>
-          <a:xfrm xmlns:a="http://schemas.openxmlformats.org/drawingml/2006/main">
-            <a:off x="2228850" y="2438400"/>
-            <a:ext cx="3333750" cy="666750"/>
-          </a:xfrm>
-          <a:prstGeom xmlns:a="http://schemas.openxmlformats.org/drawingml/2006/main" prst="rect">
-            <a:avLst/>
-          </a:prstGeom>
-          <a:noFill xmlns:a="http://schemas.openxmlformats.org/drawingml/2006/main"/>
-          <a:ln xmlns:a="http://schemas.openxmlformats.org/drawingml/2006/main" w="0">
-            <a:noFill/>
-            <a:prstDash val="solid"/>
-          </a:ln>
-        </p:spPr>
-        <p:txBody>
-          <a:bodyPr xmlns:a="http://schemas.openxmlformats.org/drawingml/2006/main" anchor="t"/>
-          <a:lstStyle xmlns:a="http://schemas.openxmlformats.org/drawingml/2006/main"/>
-          <a:p xmlns:a="http://schemas.openxmlformats.org/drawingml/2006/main">
-            <a:pPr algn="l">
-              <a:defRPr sz="1650" b="0">
-                <a:solidFill>
-                  <a:srgbClr val="111111"/>
-                </a:solidFill>
-              </a:defRPr>
-            </a:pPr>
-            <a:r>
-              <a:rPr sz="1650" b="0">
-                <a:solidFill>
-                  <a:srgbClr val="111111"/>
-                </a:solidFill>
-              </a:rPr>
-              <a:t>Find US analytics opportunities for advisor review</a:t>
-            </a:r>
-          </a:p>
-        </p:txBody>
-      </p:sp>
-      <p:cxnSp>
-        <p:nvCxnSpPr>
-          <p:cNvPr id="25" name=""/>
-          <p:cNvCxnSpPr/>
-          <p:nvPr/>
-        </p:nvCxnSpPr>
-        <p:spPr>
-          <a:xfrm xmlns:a="http://schemas.openxmlformats.org/drawingml/2006/main">
-            <a:off x="6248400" y="1790700"/>
-            <a:ext cx="5143500" cy="0"/>
-          </a:xfrm>
-          <a:prstGeom xmlns:a="http://schemas.openxmlformats.org/drawingml/2006/main" prst="straightConnector1">
-            <a:avLst/>
-          </a:prstGeom>
-          <a:ln xmlns:a="http://schemas.openxmlformats.org/drawingml/2006/main" w="38100">
-            <a:solidFill>
-              <a:srgbClr val="3D8DFF"/>
-            </a:solidFill>
-            <a:prstDash val="solid"/>
-          </a:ln>
-        </p:spPr>
-      </p:cxnSp>
-      <p:sp>
-        <p:nvSpPr>
-          <p:cNvPr id="8" name="">
-            <a:extLst xmlns:a="http://schemas.openxmlformats.org/drawingml/2006/main">
-              <a:ext uri="{FF2B5EF4-FFF2-40B4-BE49-F238E27FC236}">
-                <a16:creationId xmlns:a16="http://schemas.microsoft.com/office/drawing/2014/main" id="{D330DCFA-1BE4-4A88-8E56-F22CDE4FD1BD}"/>
-              </a:ext>
-            </a:extLst>
-          </p:cNvPr>
-          <p:cNvSpPr>
-            <a:spLocks xmlns:a="http://schemas.openxmlformats.org/drawingml/2006/main" noGrp="1"/>
-          </p:cNvSpPr>
-          <p:nvPr/>
-        </p:nvSpPr>
-        <p:spPr>
-          <a:xfrm xmlns:a="http://schemas.openxmlformats.org/drawingml/2006/main">
-            <a:off x="6248400" y="2019300"/>
-            <a:ext cx="5143500" cy="323850"/>
-          </a:xfrm>
-          <a:prstGeom xmlns:a="http://schemas.openxmlformats.org/drawingml/2006/main" prst="rect">
-            <a:avLst/>
-          </a:prstGeom>
-          <a:noFill xmlns:a="http://schemas.openxmlformats.org/drawingml/2006/main"/>
-          <a:ln xmlns:a="http://schemas.openxmlformats.org/drawingml/2006/main" w="0">
-            <a:noFill/>
-            <a:prstDash val="solid"/>
-          </a:ln>
-        </p:spPr>
-        <p:txBody>
-          <a:bodyPr xmlns:a="http://schemas.openxmlformats.org/drawingml/2006/main" anchor="t"/>
-          <a:lstStyle xmlns:a="http://schemas.openxmlformats.org/drawingml/2006/main"/>
-          <a:p xmlns:a="http://schemas.openxmlformats.org/drawingml/2006/main">
-            <a:pPr algn="l">
-              <a:defRPr sz="1650" b="1">
-                <a:solidFill>
-                  <a:srgbClr val="565D67"/>
-                </a:solidFill>
-              </a:defRPr>
-            </a:pPr>
-            <a:r>
-              <a:rPr sz="1650" b="1">
-                <a:solidFill>
-                  <a:srgbClr val="565D67"/>
-                </a:solidFill>
-              </a:rPr>
-              <a:t>SENIOR ENGINEERING POSTING</a:t>
-            </a:r>
-          </a:p>
-        </p:txBody>
-      </p:sp>
-      <p:sp>
-        <p:nvSpPr>
-          <p:cNvPr id="9" name="">
-            <a:extLst xmlns:a="http://schemas.openxmlformats.org/drawingml/2006/main">
-              <a:ext uri="{FF2B5EF4-FFF2-40B4-BE49-F238E27FC236}">
-                <a16:creationId xmlns:a16="http://schemas.microsoft.com/office/drawing/2014/main" id="{EDBFC8C0-AB14-4A22-AFDE-20DD55175E43}"/>
-              </a:ext>
-            </a:extLst>
-          </p:cNvPr>
-          <p:cNvSpPr>
-            <a:spLocks xmlns:a="http://schemas.openxmlformats.org/drawingml/2006/main" noGrp="1"/>
-          </p:cNvSpPr>
-          <p:nvPr/>
-        </p:nvSpPr>
-        <p:spPr>
-          <a:xfrm xmlns:a="http://schemas.openxmlformats.org/drawingml/2006/main">
-            <a:off x="6248400" y="2514600"/>
-            <a:ext cx="1809750" cy="400050"/>
-          </a:xfrm>
-          <a:prstGeom xmlns:a="http://schemas.openxmlformats.org/drawingml/2006/main" prst="rect">
-            <a:avLst/>
-          </a:prstGeom>
-          <a:noFill xmlns:a="http://schemas.openxmlformats.org/drawingml/2006/main"/>
-          <a:ln xmlns:a="http://schemas.openxmlformats.org/drawingml/2006/main" w="0">
-            <a:noFill/>
-            <a:prstDash val="solid"/>
-          </a:ln>
-        </p:spPr>
-        <p:txBody>
-          <a:bodyPr xmlns:a="http://schemas.openxmlformats.org/drawingml/2006/main" anchor="t"/>
-          <a:lstStyle xmlns:a="http://schemas.openxmlformats.org/drawingml/2006/main"/>
-          <a:p xmlns:a="http://schemas.openxmlformats.org/drawingml/2006/main">
-            <a:pPr algn="l">
-              <a:defRPr sz="2325" b="1">
-                <a:solidFill>
-                  <a:srgbClr val="3D8DFF"/>
-                </a:solidFill>
-              </a:defRPr>
-            </a:pPr>
-            <a:r>
-              <a:rPr sz="2325" b="1">
-                <a:solidFill>
-                  <a:srgbClr val="3D8DFF"/>
-                </a:solidFill>
-              </a:rPr>
-              <a:t>low_fit</a:t>
-            </a:r>
-          </a:p>
-        </p:txBody>
-      </p:sp>
-      <p:sp>
-        <p:nvSpPr>
-          <p:cNvPr id="10" name="">
-            <a:extLst xmlns:a="http://schemas.openxmlformats.org/drawingml/2006/main">
-              <a:ext uri="{FF2B5EF4-FFF2-40B4-BE49-F238E27FC236}">
-                <a16:creationId xmlns:a16="http://schemas.microsoft.com/office/drawing/2014/main" id="{27C9B55D-BACC-4691-8529-4431E22E85CF}"/>
-              </a:ext>
-            </a:extLst>
-          </p:cNvPr>
-          <p:cNvSpPr>
-            <a:spLocks xmlns:a="http://schemas.openxmlformats.org/drawingml/2006/main" noGrp="1"/>
-          </p:cNvSpPr>
-          <p:nvPr/>
-        </p:nvSpPr>
-        <p:spPr>
-          <a:xfrm xmlns:a="http://schemas.openxmlformats.org/drawingml/2006/main">
-            <a:off x="8058150" y="2438400"/>
-            <a:ext cx="3333750" cy="666750"/>
-          </a:xfrm>
-          <a:prstGeom xmlns:a="http://schemas.openxmlformats.org/drawingml/2006/main" prst="rect">
-            <a:avLst/>
-          </a:prstGeom>
-          <a:noFill xmlns:a="http://schemas.openxmlformats.org/drawingml/2006/main"/>
-          <a:ln xmlns:a="http://schemas.openxmlformats.org/drawingml/2006/main" w="0">
-            <a:noFill/>
-            <a:prstDash val="solid"/>
-          </a:ln>
-        </p:spPr>
-        <p:txBody>
-          <a:bodyPr xmlns:a="http://schemas.openxmlformats.org/drawingml/2006/main" anchor="t"/>
-          <a:lstStyle xmlns:a="http://schemas.openxmlformats.org/drawingml/2006/main"/>
-          <a:p xmlns:a="http://schemas.openxmlformats.org/drawingml/2006/main">
-            <a:pPr algn="l">
-              <a:defRPr sz="1650" b="0">
-                <a:solidFill>
-                  <a:srgbClr val="111111"/>
-                </a:solidFill>
-              </a:defRPr>
-            </a:pPr>
-            <a:r>
-              <a:rPr sz="1650" b="0">
-                <a:solidFill>
-                  <a:srgbClr val="111111"/>
-                </a:solidFill>
-              </a:rPr>
-              <a:t>Hold a role that is too senior and engineering-heavy</a:t>
-            </a:r>
-          </a:p>
-        </p:txBody>
-      </p:sp>
-      <p:cxnSp>
-        <p:nvCxnSpPr>
-          <p:cNvPr id="29" name=""/>
-          <p:cNvCxnSpPr/>
-          <p:nvPr/>
-        </p:nvCxnSpPr>
-        <p:spPr>
-          <a:xfrm xmlns:a="http://schemas.openxmlformats.org/drawingml/2006/main">
-            <a:off x="419100" y="3943350"/>
-            <a:ext cx="5143500" cy="0"/>
-          </a:xfrm>
-          <a:prstGeom xmlns:a="http://schemas.openxmlformats.org/drawingml/2006/main" prst="straightConnector1">
-            <a:avLst/>
-          </a:prstGeom>
-          <a:ln xmlns:a="http://schemas.openxmlformats.org/drawingml/2006/main" w="38100">
-            <a:solidFill>
-              <a:srgbClr val="D6532F"/>
-            </a:solidFill>
-            <a:prstDash val="solid"/>
-          </a:ln>
-        </p:spPr>
-      </p:cxnSp>
-      <p:sp>
-        <p:nvSpPr>
-          <p:cNvPr id="12" name="">
-            <a:extLst xmlns:a="http://schemas.openxmlformats.org/drawingml/2006/main">
-              <a:ext uri="{FF2B5EF4-FFF2-40B4-BE49-F238E27FC236}">
-                <a16:creationId xmlns:a16="http://schemas.microsoft.com/office/drawing/2014/main" id="{7DA17F34-50BD-47F0-A301-15150CE990BA}"/>
-              </a:ext>
-            </a:extLst>
-          </p:cNvPr>
-          <p:cNvSpPr>
-            <a:spLocks xmlns:a="http://schemas.openxmlformats.org/drawingml/2006/main" noGrp="1"/>
-          </p:cNvSpPr>
-          <p:nvPr/>
-        </p:nvSpPr>
-        <p:spPr>
-          <a:xfrm xmlns:a="http://schemas.openxmlformats.org/drawingml/2006/main">
-            <a:off x="419100" y="4171950"/>
-            <a:ext cx="5143500" cy="323850"/>
-          </a:xfrm>
-          <a:prstGeom xmlns:a="http://schemas.openxmlformats.org/drawingml/2006/main" prst="rect">
-            <a:avLst/>
-          </a:prstGeom>
-          <a:noFill xmlns:a="http://schemas.openxmlformats.org/drawingml/2006/main"/>
-          <a:ln xmlns:a="http://schemas.openxmlformats.org/drawingml/2006/main" w="0">
-            <a:noFill/>
-            <a:prstDash val="solid"/>
-          </a:ln>
-        </p:spPr>
-        <p:txBody>
-          <a:bodyPr xmlns:a="http://schemas.openxmlformats.org/drawingml/2006/main" anchor="t"/>
-          <a:lstStyle xmlns:a="http://schemas.openxmlformats.org/drawingml/2006/main"/>
-          <a:p xmlns:a="http://schemas.openxmlformats.org/drawingml/2006/main">
-            <a:pPr algn="l">
-              <a:defRPr sz="1650" b="1">
-                <a:solidFill>
-                  <a:srgbClr val="565D67"/>
-                </a:solidFill>
-              </a:defRPr>
-            </a:pPr>
-            <a:r>
-              <a:rPr sz="1650" b="1">
-                <a:solidFill>
-                  <a:srgbClr val="565D67"/>
-                </a:solidFill>
-              </a:rPr>
-              <a:t>AUTHORIZATION RESTRICTION POSTING</a:t>
-            </a:r>
-          </a:p>
-        </p:txBody>
-      </p:sp>
-      <p:sp>
-        <p:nvSpPr>
-          <p:cNvPr id="13" name="">
-            <a:extLst xmlns:a="http://schemas.openxmlformats.org/drawingml/2006/main">
-              <a:ext uri="{FF2B5EF4-FFF2-40B4-BE49-F238E27FC236}">
-                <a16:creationId xmlns:a16="http://schemas.microsoft.com/office/drawing/2014/main" id="{3A4CBED6-5FB8-44E0-8669-C9D26778F3FD}"/>
-              </a:ext>
-            </a:extLst>
-          </p:cNvPr>
-          <p:cNvSpPr>
-            <a:spLocks xmlns:a="http://schemas.openxmlformats.org/drawingml/2006/main" noGrp="1"/>
-          </p:cNvSpPr>
-          <p:nvPr/>
-        </p:nvSpPr>
-        <p:spPr>
-          <a:xfrm xmlns:a="http://schemas.openxmlformats.org/drawingml/2006/main">
-            <a:off x="419100" y="4667250"/>
-            <a:ext cx="1809750" cy="400050"/>
-          </a:xfrm>
-          <a:prstGeom xmlns:a="http://schemas.openxmlformats.org/drawingml/2006/main" prst="rect">
-            <a:avLst/>
-          </a:prstGeom>
-          <a:noFill xmlns:a="http://schemas.openxmlformats.org/drawingml/2006/main"/>
-          <a:ln xmlns:a="http://schemas.openxmlformats.org/drawingml/2006/main" w="0">
-            <a:noFill/>
-            <a:prstDash val="solid"/>
-          </a:ln>
-        </p:spPr>
-        <p:txBody>
-          <a:bodyPr xmlns:a="http://schemas.openxmlformats.org/drawingml/2006/main" anchor="t"/>
-          <a:lstStyle xmlns:a="http://schemas.openxmlformats.org/drawingml/2006/main"/>
-          <a:p xmlns:a="http://schemas.openxmlformats.org/drawingml/2006/main">
-            <a:pPr algn="l">
-              <a:defRPr sz="2325" b="1">
-                <a:solidFill>
-                  <a:srgbClr val="D6532F"/>
-                </a:solidFill>
-              </a:defRPr>
-            </a:pPr>
-            <a:r>
-              <a:rPr sz="2325" b="1">
-                <a:solidFill>
-                  <a:srgbClr val="D6532F"/>
-                </a:solidFill>
-              </a:rPr>
-              <a:t>high_fit</a:t>
-            </a:r>
-          </a:p>
-        </p:txBody>
-      </p:sp>
-      <p:sp>
-        <p:nvSpPr>
-          <p:cNvPr id="14" name="">
-            <a:extLst xmlns:a="http://schemas.openxmlformats.org/drawingml/2006/main">
-              <a:ext uri="{FF2B5EF4-FFF2-40B4-BE49-F238E27FC236}">
-                <a16:creationId xmlns:a16="http://schemas.microsoft.com/office/drawing/2014/main" id="{9F83745D-93F8-48EF-A8E2-DE6BE6B058EA}"/>
-              </a:ext>
-            </a:extLst>
-          </p:cNvPr>
-          <p:cNvSpPr>
-            <a:spLocks xmlns:a="http://schemas.openxmlformats.org/drawingml/2006/main" noGrp="1"/>
-          </p:cNvSpPr>
-          <p:nvPr/>
-        </p:nvSpPr>
-        <p:spPr>
-          <a:xfrm xmlns:a="http://schemas.openxmlformats.org/drawingml/2006/main">
-            <a:off x="2228850" y="4591050"/>
-            <a:ext cx="3333750" cy="666750"/>
-          </a:xfrm>
-          <a:prstGeom xmlns:a="http://schemas.openxmlformats.org/drawingml/2006/main" prst="rect">
-            <a:avLst/>
-          </a:prstGeom>
-          <a:noFill xmlns:a="http://schemas.openxmlformats.org/drawingml/2006/main"/>
-          <a:ln xmlns:a="http://schemas.openxmlformats.org/drawingml/2006/main" w="0">
-            <a:noFill/>
-            <a:prstDash val="solid"/>
-          </a:ln>
-        </p:spPr>
-        <p:txBody>
-          <a:bodyPr xmlns:a="http://schemas.openxmlformats.org/drawingml/2006/main" anchor="t"/>
-          <a:lstStyle xmlns:a="http://schemas.openxmlformats.org/drawingml/2006/main"/>
-          <a:p xmlns:a="http://schemas.openxmlformats.org/drawingml/2006/main">
-            <a:pPr algn="l">
-              <a:defRPr sz="1650" b="0">
-                <a:solidFill>
-                  <a:srgbClr val="111111"/>
-                </a:solidFill>
-              </a:defRPr>
-            </a:pPr>
-            <a:r>
-              <a:rPr sz="1650" b="0">
-                <a:solidFill>
-                  <a:srgbClr val="111111"/>
-                </a:solidFill>
-              </a:rPr>
-              <a:t>High role fit, but No OPT/CPT forces Hold</a:t>
-            </a:r>
-          </a:p>
-        </p:txBody>
-      </p:sp>
-      <p:cxnSp>
-        <p:nvCxnSpPr>
-          <p:cNvPr id="33" name=""/>
-          <p:cNvCxnSpPr/>
-          <p:nvPr/>
-        </p:nvCxnSpPr>
-        <p:spPr>
-          <a:xfrm xmlns:a="http://schemas.openxmlformats.org/drawingml/2006/main">
-            <a:off x="6248400" y="3943350"/>
-            <a:ext cx="5143500" cy="0"/>
-          </a:xfrm>
-          <a:prstGeom xmlns:a="http://schemas.openxmlformats.org/drawingml/2006/main" prst="straightConnector1">
-            <a:avLst/>
-          </a:prstGeom>
-          <a:ln xmlns:a="http://schemas.openxmlformats.org/drawingml/2006/main" w="38100">
-            <a:solidFill>
-              <a:srgbClr val="3D8DFF"/>
-            </a:solidFill>
-            <a:prstDash val="solid"/>
-          </a:ln>
-        </p:spPr>
-      </p:cxnSp>
-      <p:sp>
-        <p:nvSpPr>
-          <p:cNvPr id="16" name="">
-            <a:extLst xmlns:a="http://schemas.openxmlformats.org/drawingml/2006/main">
-              <a:ext uri="{FF2B5EF4-FFF2-40B4-BE49-F238E27FC236}">
-                <a16:creationId xmlns:a16="http://schemas.microsoft.com/office/drawing/2014/main" id="{1D2C620E-441A-4968-9067-2B2F859244C1}"/>
-              </a:ext>
-            </a:extLst>
-          </p:cNvPr>
-          <p:cNvSpPr>
-            <a:spLocks xmlns:a="http://schemas.openxmlformats.org/drawingml/2006/main" noGrp="1"/>
-          </p:cNvSpPr>
-          <p:nvPr/>
-        </p:nvSpPr>
-        <p:spPr>
-          <a:xfrm xmlns:a="http://schemas.openxmlformats.org/drawingml/2006/main">
-            <a:off x="6248400" y="4171950"/>
-            <a:ext cx="5143500" cy="323850"/>
-          </a:xfrm>
-          <a:prstGeom xmlns:a="http://schemas.openxmlformats.org/drawingml/2006/main" prst="rect">
-            <a:avLst/>
-          </a:prstGeom>
-          <a:noFill xmlns:a="http://schemas.openxmlformats.org/drawingml/2006/main"/>
-          <a:ln xmlns:a="http://schemas.openxmlformats.org/drawingml/2006/main" w="0">
-            <a:noFill/>
-            <a:prstDash val="solid"/>
-          </a:ln>
-        </p:spPr>
-        <p:txBody>
-          <a:bodyPr xmlns:a="http://schemas.openxmlformats.org/drawingml/2006/main" anchor="t"/>
-          <a:lstStyle xmlns:a="http://schemas.openxmlformats.org/drawingml/2006/main"/>
-          <a:p xmlns:a="http://schemas.openxmlformats.org/drawingml/2006/main">
-            <a:pPr algn="l">
-              <a:defRPr sz="1650" b="1">
-                <a:solidFill>
-                  <a:srgbClr val="565D67"/>
-                </a:solidFill>
-              </a:defRPr>
-            </a:pPr>
-            <a:r>
-              <a:rPr sz="1650" b="1">
-                <a:solidFill>
-                  <a:srgbClr val="565D67"/>
-                </a:solidFill>
-              </a:rPr>
-              <a:t>THIN METADATA POSTING</a:t>
-            </a:r>
-          </a:p>
-        </p:txBody>
-      </p:sp>
-      <p:sp>
-        <p:nvSpPr>
-          <p:cNvPr id="17" name="">
-            <a:extLst xmlns:a="http://schemas.openxmlformats.org/drawingml/2006/main">
-              <a:ext uri="{FF2B5EF4-FFF2-40B4-BE49-F238E27FC236}">
-                <a16:creationId xmlns:a16="http://schemas.microsoft.com/office/drawing/2014/main" id="{ECD85F6F-E224-46DA-B279-F68921D67F99}"/>
-              </a:ext>
-            </a:extLst>
-          </p:cNvPr>
-          <p:cNvSpPr>
-            <a:spLocks xmlns:a="http://schemas.openxmlformats.org/drawingml/2006/main" noGrp="1"/>
-          </p:cNvSpPr>
-          <p:nvPr/>
-        </p:nvSpPr>
-        <p:spPr>
-          <a:xfrm xmlns:a="http://schemas.openxmlformats.org/drawingml/2006/main">
-            <a:off x="6248400" y="4667250"/>
-            <a:ext cx="1809750" cy="400050"/>
-          </a:xfrm>
-          <a:prstGeom xmlns:a="http://schemas.openxmlformats.org/drawingml/2006/main" prst="rect">
-            <a:avLst/>
-          </a:prstGeom>
-          <a:noFill xmlns:a="http://schemas.openxmlformats.org/drawingml/2006/main"/>
-          <a:ln xmlns:a="http://schemas.openxmlformats.org/drawingml/2006/main" w="0">
-            <a:noFill/>
-            <a:prstDash val="solid"/>
-          </a:ln>
-        </p:spPr>
-        <p:txBody>
-          <a:bodyPr xmlns:a="http://schemas.openxmlformats.org/drawingml/2006/main" anchor="t"/>
-          <a:lstStyle xmlns:a="http://schemas.openxmlformats.org/drawingml/2006/main"/>
-          <a:p xmlns:a="http://schemas.openxmlformats.org/drawingml/2006/main">
-            <a:pPr algn="l">
-              <a:defRPr sz="2325" b="1">
-                <a:solidFill>
-                  <a:srgbClr val="3D8DFF"/>
-                </a:solidFill>
-              </a:defRPr>
-            </a:pPr>
-            <a:r>
-              <a:rPr sz="2325" b="1">
-                <a:solidFill>
-                  <a:srgbClr val="3D8DFF"/>
-                </a:solidFill>
-              </a:rPr>
-              <a:t>unclear</a:t>
-            </a:r>
-          </a:p>
-        </p:txBody>
-      </p:sp>
-      <p:sp>
-        <p:nvSpPr>
-          <p:cNvPr id="18" name="">
-            <a:extLst xmlns:a="http://schemas.openxmlformats.org/drawingml/2006/main">
-              <a:ext uri="{FF2B5EF4-FFF2-40B4-BE49-F238E27FC236}">
-                <a16:creationId xmlns:a16="http://schemas.microsoft.com/office/drawing/2014/main" id="{425C51FE-0528-4C48-A1C7-27C1697F87AA}"/>
-              </a:ext>
-            </a:extLst>
-          </p:cNvPr>
-          <p:cNvSpPr>
-            <a:spLocks xmlns:a="http://schemas.openxmlformats.org/drawingml/2006/main" noGrp="1"/>
-          </p:cNvSpPr>
-          <p:nvPr/>
-        </p:nvSpPr>
-        <p:spPr>
-          <a:xfrm xmlns:a="http://schemas.openxmlformats.org/drawingml/2006/main">
-            <a:off x="8058150" y="4591050"/>
-            <a:ext cx="3333750" cy="666750"/>
-          </a:xfrm>
-          <a:prstGeom xmlns:a="http://schemas.openxmlformats.org/drawingml/2006/main" prst="rect">
-            <a:avLst/>
-          </a:prstGeom>
-          <a:noFill xmlns:a="http://schemas.openxmlformats.org/drawingml/2006/main"/>
-          <a:ln xmlns:a="http://schemas.openxmlformats.org/drawingml/2006/main" w="0">
-            <a:noFill/>
-            <a:prstDash val="solid"/>
-          </a:ln>
-        </p:spPr>
-        <p:txBody>
-          <a:bodyPr xmlns:a="http://schemas.openxmlformats.org/drawingml/2006/main" anchor="t"/>
-          <a:lstStyle xmlns:a="http://schemas.openxmlformats.org/drawingml/2006/main"/>
-          <a:p xmlns:a="http://schemas.openxmlformats.org/drawingml/2006/main">
-            <a:pPr algn="l">
-              <a:defRPr sz="1650" b="0">
-                <a:solidFill>
-                  <a:srgbClr val="111111"/>
-                </a:solidFill>
-              </a:defRPr>
-            </a:pPr>
-            <a:r>
-              <a:rPr sz="1650" b="0">
-                <a:solidFill>
-                  <a:srgbClr val="111111"/>
-                </a:solidFill>
-              </a:rPr>
-              <a:t>Missing fields override medium_fit to unclear</a:t>
-            </a:r>
-          </a:p>
-        </p:txBody>
-      </p:sp>
+                  <a:srgbClr val="111111"/>
+                </a:solidFill>
+              </a:rPr>
+              <a:t>No OPT/CPT -&gt; HOLD. Missing core fields -&gt; UNCLEAR + REVIEW.</a:t>
+            </a:r>
+          </a:p>
+        </p:txBody>
+      </p:sp>
+      <p:pic>
+        <p:nvPicPr>
+          <p:cNvPr id="24" name=""/>
+          <p:cNvPicPr>
+            <a:picLocks xmlns:a="http://schemas.openxmlformats.org/drawingml/2006/main" noChangeAspect="1"/>
+          </p:cNvPicPr>
+          <p:nvPr/>
+        </p:nvPicPr>
+        <p:blipFill>
+          <a:blip xmlns:r="http://schemas.openxmlformats.org/officeDocument/2006/relationships" xmlns:a="http://schemas.openxmlformats.org/drawingml/2006/main" r:embed="R1b0bc76286884537"/>
+          <a:srcRect xmlns:a="http://schemas.openxmlformats.org/drawingml/2006/main" l="0" t="13833" r="0" b="13833"/>
+          <a:stretch xmlns:a="http://schemas.openxmlformats.org/drawingml/2006/main">
+            <a:fillRect l="0" t="0" r="0" b="0"/>
+          </a:stretch>
+        </p:blipFill>
+        <p:spPr>
+          <a:xfrm xmlns:a="http://schemas.openxmlformats.org/drawingml/2006/main">
+            <a:off x="419100" y="1285875"/>
+            <a:ext cx="11353800" cy="4619625"/>
+          </a:xfrm>
+          <a:prstGeom xmlns:a="http://schemas.openxmlformats.org/drawingml/2006/main" prst="roundRect">
+            <a:avLst>
+              <a:gd name="adj" fmla="val 1649"/>
+            </a:avLst>
+          </a:prstGeom>
+        </p:spPr>
+      </p:pic>
     </p:spTree>
     <p:extLst>
       <p:ext uri="{BB962C8B-B14F-4D97-AF65-F5344CB8AC3E}">
@@ -9478,6 +6921,7 @@
           <a:lstStyle xmlns:a="http://schemas.openxmlformats.org/drawingml/2006/main"/>
           <a:p xmlns:a="http://schemas.openxmlformats.org/drawingml/2006/main">
             <a:pPr algn="l">
+              <a:buNone/>
               <a:defRPr sz="3600" b="1">
                 <a:solidFill>
                   <a:srgbClr val="111111"/>
@@ -9528,6 +6972,7 @@
           <a:lstStyle xmlns:a="http://schemas.openxmlformats.org/drawingml/2006/main"/>
           <a:p xmlns:a="http://schemas.openxmlformats.org/drawingml/2006/main">
             <a:pPr algn="r">
+              <a:buNone/>
               <a:defRPr sz="1200" b="0">
                 <a:solidFill>
                   <a:srgbClr val="565D67"/>
@@ -9547,7 +6992,7 @@
       </p:sp>
       <p:graphicFrame>
         <p:nvGraphicFramePr>
-          <p:cNvPr id="16" name="Chart"/>
+          <p:cNvPr id="18" name="Chart"/>
           <p:cNvGraphicFramePr/>
           <p:nvPr/>
         </p:nvGraphicFramePr>
@@ -9557,7 +7002,7 @@
         </p:xfrm>
         <a:graphic xmlns:a="http://schemas.openxmlformats.org/drawingml/2006/main">
           <a:graphicData uri="http://schemas.openxmlformats.org/drawingml/2006/chart">
-            <c:chart xmlns:r="http://schemas.openxmlformats.org/officeDocument/2006/relationships" xmlns:c="http://schemas.openxmlformats.org/drawingml/2006/chart" r:id="R8cfdfec96331477e"/>
+            <c:chart xmlns:r="http://schemas.openxmlformats.org/officeDocument/2006/relationships" xmlns:c="http://schemas.openxmlformats.org/drawingml/2006/chart" r:id="R1f413d81d2344820"/>
           </a:graphicData>
         </a:graphic>
       </p:graphicFrame>
@@ -9625,6 +7070,7 @@
           <a:lstStyle xmlns:a="http://schemas.openxmlformats.org/drawingml/2006/main"/>
           <a:p xmlns:a="http://schemas.openxmlformats.org/drawingml/2006/main">
             <a:pPr algn="l">
+              <a:buNone/>
               <a:defRPr sz="3150" b="1">
                 <a:solidFill>
                   <a:srgbClr val="3D8DFF"/>
@@ -9675,6 +7121,7 @@
           <a:lstStyle xmlns:a="http://schemas.openxmlformats.org/drawingml/2006/main"/>
           <a:p xmlns:a="http://schemas.openxmlformats.org/drawingml/2006/main">
             <a:pPr algn="l">
+              <a:buNone/>
               <a:defRPr sz="1650" b="0">
                 <a:solidFill>
                   <a:srgbClr val="111111"/>
@@ -9756,6 +7203,7 @@
           <a:lstStyle xmlns:a="http://schemas.openxmlformats.org/drawingml/2006/main"/>
           <a:p xmlns:a="http://schemas.openxmlformats.org/drawingml/2006/main">
             <a:pPr algn="l">
+              <a:buNone/>
               <a:defRPr sz="3150" b="1">
                 <a:solidFill>
                   <a:srgbClr val="3D8DFF"/>
@@ -9806,6 +7254,7 @@
           <a:lstStyle xmlns:a="http://schemas.openxmlformats.org/drawingml/2006/main"/>
           <a:p xmlns:a="http://schemas.openxmlformats.org/drawingml/2006/main">
             <a:pPr algn="l">
+              <a:buNone/>
               <a:defRPr sz="1650" b="0">
                 <a:solidFill>
                   <a:srgbClr val="111111"/>
@@ -9887,6 +7336,7 @@
           <a:lstStyle xmlns:a="http://schemas.openxmlformats.org/drawingml/2006/main"/>
           <a:p xmlns:a="http://schemas.openxmlformats.org/drawingml/2006/main">
             <a:pPr algn="l">
+              <a:buNone/>
               <a:defRPr sz="3150" b="1">
                 <a:solidFill>
                   <a:srgbClr val="D6532F"/>
@@ -9937,6 +7387,7 @@
           <a:lstStyle xmlns:a="http://schemas.openxmlformats.org/drawingml/2006/main"/>
           <a:p xmlns:a="http://schemas.openxmlformats.org/drawingml/2006/main">
             <a:pPr algn="l">
+              <a:buNone/>
               <a:defRPr sz="1650" b="0">
                 <a:solidFill>
                   <a:srgbClr val="111111"/>
@@ -9987,6 +7438,7 @@
           <a:lstStyle xmlns:a="http://schemas.openxmlformats.org/drawingml/2006/main"/>
           <a:p xmlns:a="http://schemas.openxmlformats.org/drawingml/2006/main">
             <a:pPr algn="l">
+              <a:buNone/>
               <a:defRPr sz="1500" b="1">
                 <a:solidFill>
                   <a:srgbClr val="111111"/>
@@ -10066,6 +7518,7 @@
           <a:lstStyle xmlns:a="http://schemas.openxmlformats.org/drawingml/2006/main"/>
           <a:p xmlns:a="http://schemas.openxmlformats.org/drawingml/2006/main">
             <a:pPr algn="l">
+              <a:buNone/>
               <a:defRPr sz="3600" b="1">
                 <a:solidFill>
                   <a:srgbClr val="111111"/>
@@ -10116,6 +7569,7 @@
           <a:lstStyle xmlns:a="http://schemas.openxmlformats.org/drawingml/2006/main"/>
           <a:p xmlns:a="http://schemas.openxmlformats.org/drawingml/2006/main">
             <a:pPr algn="r">
+              <a:buNone/>
               <a:defRPr sz="1200" b="0">
                 <a:solidFill>
                   <a:srgbClr val="565D67"/>
@@ -10166,6 +7620,7 @@
           <a:lstStyle xmlns:a="http://schemas.openxmlformats.org/drawingml/2006/main"/>
           <a:p xmlns:a="http://schemas.openxmlformats.org/drawingml/2006/main">
             <a:pPr algn="l">
+              <a:buNone/>
               <a:defRPr sz="1650" b="1">
                 <a:solidFill>
                   <a:srgbClr val="3D8DFF"/>
@@ -10216,6 +7671,7 @@
           <a:lstStyle xmlns:a="http://schemas.openxmlformats.org/drawingml/2006/main"/>
           <a:p xmlns:a="http://schemas.openxmlformats.org/drawingml/2006/main">
             <a:pPr algn="l">
+              <a:buNone/>
               <a:defRPr sz="1650" b="0">
                 <a:solidFill>
                   <a:srgbClr val="111111"/>
@@ -10297,6 +7753,7 @@
           <a:lstStyle xmlns:a="http://schemas.openxmlformats.org/drawingml/2006/main"/>
           <a:p xmlns:a="http://schemas.openxmlformats.org/drawingml/2006/main">
             <a:pPr algn="r">
+              <a:buNone/>
               <a:defRPr sz="1650" b="1">
                 <a:solidFill>
                   <a:srgbClr val="111111"/>
@@ -10347,6 +7804,7 @@
           <a:lstStyle xmlns:a="http://schemas.openxmlformats.org/drawingml/2006/main"/>
           <a:p xmlns:a="http://schemas.openxmlformats.org/drawingml/2006/main">
             <a:pPr algn="l">
+              <a:buNone/>
               <a:defRPr sz="1650" b="0">
                 <a:solidFill>
                   <a:srgbClr val="111111"/>
@@ -10428,6 +7886,7 @@
           <a:lstStyle xmlns:a="http://schemas.openxmlformats.org/drawingml/2006/main"/>
           <a:p xmlns:a="http://schemas.openxmlformats.org/drawingml/2006/main">
             <a:pPr algn="r">
+              <a:buNone/>
               <a:defRPr sz="1650" b="1">
                 <a:solidFill>
                   <a:srgbClr val="111111"/>
@@ -10478,6 +7937,7 @@
           <a:lstStyle xmlns:a="http://schemas.openxmlformats.org/drawingml/2006/main"/>
           <a:p xmlns:a="http://schemas.openxmlformats.org/drawingml/2006/main">
             <a:pPr algn="l">
+              <a:buNone/>
               <a:defRPr sz="1650" b="0">
                 <a:solidFill>
                   <a:srgbClr val="111111"/>
@@ -10559,6 +8019,7 @@
           <a:lstStyle xmlns:a="http://schemas.openxmlformats.org/drawingml/2006/main"/>
           <a:p xmlns:a="http://schemas.openxmlformats.org/drawingml/2006/main">
             <a:pPr algn="r">
+              <a:buNone/>
               <a:defRPr sz="1650" b="1">
                 <a:solidFill>
                   <a:srgbClr val="111111"/>
@@ -10609,14 +8070,15 @@
           <a:lstStyle xmlns:a="http://schemas.openxmlformats.org/drawingml/2006/main"/>
           <a:p xmlns:a="http://schemas.openxmlformats.org/drawingml/2006/main">
             <a:pPr algn="l">
-              <a:defRPr sz="1650" b="0">
-                <a:solidFill>
-                  <a:srgbClr val="111111"/>
-                </a:solidFill>
-              </a:defRPr>
-            </a:pPr>
-            <a:r>
-              <a:rPr sz="1650" b="0">
+              <a:buNone/>
+              <a:defRPr sz="1500" b="0">
+                <a:solidFill>
+                  <a:srgbClr val="111111"/>
+                </a:solidFill>
+              </a:defRPr>
+            </a:pPr>
+            <a:r>
+              <a:rPr sz="1500" b="0">
                 <a:solidFill>
                   <a:srgbClr val="111111"/>
                 </a:solidFill>
@@ -10690,6 +8152,7 @@
           <a:lstStyle xmlns:a="http://schemas.openxmlformats.org/drawingml/2006/main"/>
           <a:p xmlns:a="http://schemas.openxmlformats.org/drawingml/2006/main">
             <a:pPr algn="r">
+              <a:buNone/>
               <a:defRPr sz="1650" b="1">
                 <a:solidFill>
                   <a:srgbClr val="111111"/>
@@ -10709,7 +8172,7 @@
       </p:sp>
       <p:cxnSp>
         <p:nvCxnSpPr>
-          <p:cNvPr id="35" name=""/>
+          <p:cNvPr id="67" name=""/>
           <p:cNvCxnSpPr/>
           <p:nvPr/>
         </p:nvCxnSpPr>
@@ -10762,6 +8225,7 @@
           <a:lstStyle xmlns:a="http://schemas.openxmlformats.org/drawingml/2006/main"/>
           <a:p xmlns:a="http://schemas.openxmlformats.org/drawingml/2006/main">
             <a:pPr algn="l">
+              <a:buNone/>
               <a:defRPr sz="1650" b="1">
                 <a:solidFill>
                   <a:srgbClr val="3D8DFF"/>
@@ -10812,6 +8276,7 @@
           <a:lstStyle xmlns:a="http://schemas.openxmlformats.org/drawingml/2006/main"/>
           <a:p xmlns:a="http://schemas.openxmlformats.org/drawingml/2006/main">
             <a:pPr algn="l">
+              <a:buNone/>
               <a:defRPr sz="2250" b="1">
                 <a:solidFill>
                   <a:srgbClr val="111111"/>
@@ -10862,6 +8327,7 @@
           <a:lstStyle xmlns:a="http://schemas.openxmlformats.org/drawingml/2006/main"/>
           <a:p xmlns:a="http://schemas.openxmlformats.org/drawingml/2006/main">
             <a:pPr algn="l">
+              <a:buNone/>
               <a:defRPr sz="1725" b="0">
                 <a:solidFill>
                   <a:srgbClr val="565D67"/>
@@ -10879,6 +8345,7 @@
           </a:p>
           <a:p xmlns:a="http://schemas.openxmlformats.org/drawingml/2006/main">
             <a:pPr algn="l">
+              <a:buNone/>
               <a:defRPr sz="1725" b="0">
                 <a:solidFill>
                   <a:srgbClr val="565D67"/>
@@ -10896,6 +8363,7 @@
           </a:p>
           <a:p xmlns:a="http://schemas.openxmlformats.org/drawingml/2006/main">
             <a:pPr algn="l">
+              <a:buNone/>
               <a:defRPr sz="1725" b="0">
                 <a:solidFill>
                   <a:srgbClr val="565D67"/>
@@ -10913,6 +8381,7 @@
           </a:p>
           <a:p xmlns:a="http://schemas.openxmlformats.org/drawingml/2006/main">
             <a:pPr algn="l">
+              <a:buNone/>
               <a:defRPr sz="1725" b="0">
                 <a:solidFill>
                   <a:srgbClr val="565D67"/>

</xml_diff>